<commit_message>
docs: update final MEMOIVE presentation
</commit_message>
<xml_diff>
--- a/docs/presentation/MEMOIVE-Presentation.pptx
+++ b/docs/presentation/MEMOIVE-Presentation.pptx
@@ -2,26 +2,26 @@
 <file path=ppt/presentation.xml><?xml version="1.0" encoding="utf-8"?>
 <p:presentation xmlns:p="http://schemas.openxmlformats.org/presentationml/2006/main">
   <p:sldMasterIdLst>
-    <p:sldMasterId xmlns:r="http://schemas.openxmlformats.org/officeDocument/2006/relationships" id="2147483648" r:id="R853691cbd4af4d44"/>
+    <p:sldMasterId xmlns:r="http://schemas.openxmlformats.org/officeDocument/2006/relationships" id="2147483648" r:id="R63389ff20b7d4eed"/>
   </p:sldMasterIdLst>
   <p:notesMasterIdLst>
-    <p:notesMasterId xmlns:r="http://schemas.openxmlformats.org/officeDocument/2006/relationships" r:id="R32fa908d408f4bc9"/>
+    <p:notesMasterId xmlns:r="http://schemas.openxmlformats.org/officeDocument/2006/relationships" r:id="Rb497f1323ac941dc"/>
   </p:notesMasterIdLst>
   <p:sldIdLst>
-    <p:sldId xmlns:r="http://schemas.openxmlformats.org/officeDocument/2006/relationships" id="256" r:id="R4c237f2d9ac04a7c"/>
-    <p:sldId xmlns:r="http://schemas.openxmlformats.org/officeDocument/2006/relationships" id="257" r:id="R4ea614e8291647e3"/>
-    <p:sldId xmlns:r="http://schemas.openxmlformats.org/officeDocument/2006/relationships" id="258" r:id="Rcac125ff0d8b4faa"/>
-    <p:sldId xmlns:r="http://schemas.openxmlformats.org/officeDocument/2006/relationships" id="259" r:id="Rd7fa796374df4692"/>
-    <p:sldId xmlns:r="http://schemas.openxmlformats.org/officeDocument/2006/relationships" id="260" r:id="R48ac85d05d754184"/>
-    <p:sldId xmlns:r="http://schemas.openxmlformats.org/officeDocument/2006/relationships" id="261" r:id="R403a719b2c6748b0"/>
-    <p:sldId xmlns:r="http://schemas.openxmlformats.org/officeDocument/2006/relationships" id="262" r:id="R7784b55f52314ada"/>
-    <p:sldId xmlns:r="http://schemas.openxmlformats.org/officeDocument/2006/relationships" id="263" r:id="R2829f3ebaa6b4f9c"/>
-    <p:sldId xmlns:r="http://schemas.openxmlformats.org/officeDocument/2006/relationships" id="264" r:id="R6ab3d53fac314fc6"/>
-    <p:sldId xmlns:r="http://schemas.openxmlformats.org/officeDocument/2006/relationships" id="265" r:id="R6da1475ba7d14186"/>
-    <p:sldId xmlns:r="http://schemas.openxmlformats.org/officeDocument/2006/relationships" id="266" r:id="R5807f4239d864dea"/>
-    <p:sldId xmlns:r="http://schemas.openxmlformats.org/officeDocument/2006/relationships" id="267" r:id="R4192a8182848496c"/>
-    <p:sldId xmlns:r="http://schemas.openxmlformats.org/officeDocument/2006/relationships" id="268" r:id="Rc29bfedfdc4e4a60"/>
-    <p:sldId xmlns:r="http://schemas.openxmlformats.org/officeDocument/2006/relationships" id="269" r:id="Rb738c833bd974ea2"/>
+    <p:sldId xmlns:r="http://schemas.openxmlformats.org/officeDocument/2006/relationships" id="256" r:id="R1739812baeb64f79"/>
+    <p:sldId xmlns:r="http://schemas.openxmlformats.org/officeDocument/2006/relationships" id="257" r:id="R6fbbc29ce7904e98"/>
+    <p:sldId xmlns:r="http://schemas.openxmlformats.org/officeDocument/2006/relationships" id="258" r:id="R0c7cba70407243af"/>
+    <p:sldId xmlns:r="http://schemas.openxmlformats.org/officeDocument/2006/relationships" id="259" r:id="R91735f8c03cb44c9"/>
+    <p:sldId xmlns:r="http://schemas.openxmlformats.org/officeDocument/2006/relationships" id="260" r:id="Rffe5c07723364782"/>
+    <p:sldId xmlns:r="http://schemas.openxmlformats.org/officeDocument/2006/relationships" id="261" r:id="R30324338e4d341b7"/>
+    <p:sldId xmlns:r="http://schemas.openxmlformats.org/officeDocument/2006/relationships" id="262" r:id="R804a309e3c97409e"/>
+    <p:sldId xmlns:r="http://schemas.openxmlformats.org/officeDocument/2006/relationships" id="263" r:id="Rcdf0f5579d3a493e"/>
+    <p:sldId xmlns:r="http://schemas.openxmlformats.org/officeDocument/2006/relationships" id="264" r:id="R5136b9a09f634f70"/>
+    <p:sldId xmlns:r="http://schemas.openxmlformats.org/officeDocument/2006/relationships" id="265" r:id="R5d1a575e057844b7"/>
+    <p:sldId xmlns:r="http://schemas.openxmlformats.org/officeDocument/2006/relationships" id="266" r:id="R870ab957b1ec4876"/>
+    <p:sldId xmlns:r="http://schemas.openxmlformats.org/officeDocument/2006/relationships" id="267" r:id="R4b9d3561e23c4b63"/>
+    <p:sldId xmlns:r="http://schemas.openxmlformats.org/officeDocument/2006/relationships" id="268" r:id="R7187c620ce2542d2"/>
+    <p:sldId xmlns:r="http://schemas.openxmlformats.org/officeDocument/2006/relationships" id="269" r:id="Raeac6acf29b14569"/>
   </p:sldIdLst>
   <p:sldSz cx="12192000" cy="6858000"/>
   <p:notesSz cx="6858000" cy="9144000"/>
@@ -935,7 +935,7 @@
           </a:p>
           <a:p xmlns:a="http://schemas.openxmlformats.org/drawingml/2006/main">
             <a:r>
-              <a:t>메모이브는 memoive.vercel.app에서 확인할 수 있습니다. 지금까지는 제가 반복해서 쓸 수 있는 흐름을 만들고 운영 화면에서 확인했습니다. 다음 단계에서는 다른 사람에게도 정리 시간이 줄고 생각의 확장이 이어지는지 행동과 시간으로 검증하겠습니다. 감사합니다.</a:t>
+              <a:t>메모이브는 memoive.vercel.app에서 확인할 수 있습니다. 다음 단계에서는 먼저 3명을 관찰하고 5명 시험으로 막히는 위치와 시간 단축을 확인하겠습니다. 여러 사용자가 쓰는 단계에 도달하면 계정 로그인과 사용자별 기록 권한을 구현하고, 반복 사용이 확인되면 검색 필터와 결과물 버전 관리를 개선하겠습니다. 검증 결과에 따라 필요한 기능부터 구현하겠습니다. 감사합니다.</a:t>
             </a:r>
           </a:p>
           <a:p xmlns:a="http://schemas.openxmlformats.org/drawingml/2006/main">
@@ -1783,7 +1783,7 @@
   </p:cSld>
   <p:clrMap bg1="lt1" tx1="dk1" bg2="lt2" tx2="dk2" accent1="accent1" accent2="accent2" accent3="accent3" accent4="accent4" accent5="accent5" accent6="accent6" hlink="hlink" folHlink="folHlink"/>
   <p:sldLayoutIdLst>
-    <p:sldLayoutId xmlns:r="http://schemas.openxmlformats.org/officeDocument/2006/relationships" id="2147483649" r:id="R593f9560da4540b9"/>
+    <p:sldLayoutId xmlns:r="http://schemas.openxmlformats.org/officeDocument/2006/relationships" id="2147483649" r:id="Red940412a11a41a4"/>
   </p:sldLayoutIdLst>
   <p:txStyles>
     <p:titleStyle>
@@ -2334,7 +2334,7 @@
           <p:cNvPr id="9" name="">
             <a:extLst xmlns:a="http://schemas.openxmlformats.org/drawingml/2006/main">
               <a:ext uri="{FF2B5EF4-FFF2-40B4-BE49-F238E27FC236}">
-                <a16:creationId xmlns:a16="http://schemas.microsoft.com/office/drawing/2014/main" id="{37CD7423-B97B-4AD0-85FA-A745126BFFA4}"/>
+                <a16:creationId xmlns:a16="http://schemas.microsoft.com/office/drawing/2014/main" id="{E30A8B98-532C-4E10-A8E4-C4239BBB3436}"/>
               </a:ext>
             </a:extLst>
           </p:cNvPr>
@@ -2391,7 +2391,7 @@
           <p:cNvPr id="2" name="">
             <a:extLst xmlns:a="http://schemas.openxmlformats.org/drawingml/2006/main">
               <a:ext uri="{FF2B5EF4-FFF2-40B4-BE49-F238E27FC236}">
-                <a16:creationId xmlns:a16="http://schemas.microsoft.com/office/drawing/2014/main" id="{8469375B-DD6A-44A5-8107-F393CFC68E29}"/>
+                <a16:creationId xmlns:a16="http://schemas.microsoft.com/office/drawing/2014/main" id="{F8AD504B-8E3B-4222-9985-CDE3310167DA}"/>
               </a:ext>
             </a:extLst>
           </p:cNvPr>
@@ -2448,7 +2448,7 @@
           <p:cNvPr id="3" name="">
             <a:extLst xmlns:a="http://schemas.openxmlformats.org/drawingml/2006/main">
               <a:ext uri="{FF2B5EF4-FFF2-40B4-BE49-F238E27FC236}">
-                <a16:creationId xmlns:a16="http://schemas.microsoft.com/office/drawing/2014/main" id="{328CB4A4-CADD-43B0-AD29-E72ACDA4CB10}"/>
+                <a16:creationId xmlns:a16="http://schemas.microsoft.com/office/drawing/2014/main" id="{727D0573-4949-4544-8260-B53885A23628}"/>
               </a:ext>
             </a:extLst>
           </p:cNvPr>
@@ -2505,7 +2505,7 @@
           <p:cNvPr id="4" name="">
             <a:extLst xmlns:a="http://schemas.openxmlformats.org/drawingml/2006/main">
               <a:ext uri="{FF2B5EF4-FFF2-40B4-BE49-F238E27FC236}">
-                <a16:creationId xmlns:a16="http://schemas.microsoft.com/office/drawing/2014/main" id="{53EA3D75-EDA4-4DF5-8722-DA070879DCDE}"/>
+                <a16:creationId xmlns:a16="http://schemas.microsoft.com/office/drawing/2014/main" id="{6DA83F83-52C8-4A51-9FBA-402F5784B3B4}"/>
               </a:ext>
             </a:extLst>
           </p:cNvPr>
@@ -2562,7 +2562,7 @@
           <p:cNvPr id="5" name="">
             <a:extLst xmlns:a="http://schemas.openxmlformats.org/drawingml/2006/main">
               <a:ext uri="{FF2B5EF4-FFF2-40B4-BE49-F238E27FC236}">
-                <a16:creationId xmlns:a16="http://schemas.microsoft.com/office/drawing/2014/main" id="{8FA62D5A-6BA0-4579-B0AE-A9EE60060172}"/>
+                <a16:creationId xmlns:a16="http://schemas.microsoft.com/office/drawing/2014/main" id="{53E7D1E3-5324-46A0-8B61-A194B0966D70}"/>
               </a:ext>
             </a:extLst>
           </p:cNvPr>
@@ -2642,7 +2642,7 @@
           <p:cNvPr id="6" name="">
             <a:extLst xmlns:a="http://schemas.openxmlformats.org/drawingml/2006/main">
               <a:ext uri="{FF2B5EF4-FFF2-40B4-BE49-F238E27FC236}">
-                <a16:creationId xmlns:a16="http://schemas.microsoft.com/office/drawing/2014/main" id="{A8DCFACF-2D6C-4F56-9714-10AD198AB399}"/>
+                <a16:creationId xmlns:a16="http://schemas.microsoft.com/office/drawing/2014/main" id="{AADB7CA3-BCB2-475C-AD97-D23828F5301B}"/>
               </a:ext>
             </a:extLst>
           </p:cNvPr>
@@ -2672,7 +2672,7 @@
           <p:cNvPr id="7" name="">
             <a:extLst xmlns:a="http://schemas.openxmlformats.org/drawingml/2006/main">
               <a:ext uri="{FF2B5EF4-FFF2-40B4-BE49-F238E27FC236}">
-                <a16:creationId xmlns:a16="http://schemas.microsoft.com/office/drawing/2014/main" id="{3572FA69-AAC4-40BD-BF0F-510BFFE49BA3}"/>
+                <a16:creationId xmlns:a16="http://schemas.microsoft.com/office/drawing/2014/main" id="{CC35385D-6F54-44F2-B2A2-02778FD8C605}"/>
               </a:ext>
             </a:extLst>
           </p:cNvPr>
@@ -2719,7 +2719,7 @@
                 <a:ea typeface="Noto Sans KR"/>
                 <a:cs typeface="Noto Sans KR"/>
               </a:rPr>
-              <a:t>문제 정의 / 구현 / 검증 / 배운 점</a:t>
+              <a:t>문제 정의 / 구현 결과 / 다음 계획 / 배운 점</a:t>
             </a:r>
           </a:p>
         </p:txBody>
@@ -2729,7 +2729,7 @@
           <p:cNvPr id="8" name="">
             <a:extLst xmlns:a="http://schemas.openxmlformats.org/drawingml/2006/main">
               <a:ext uri="{FF2B5EF4-FFF2-40B4-BE49-F238E27FC236}">
-                <a16:creationId xmlns:a16="http://schemas.microsoft.com/office/drawing/2014/main" id="{AAE35A6D-88A4-4537-8F1F-9A2BF0B1342F}"/>
+                <a16:creationId xmlns:a16="http://schemas.microsoft.com/office/drawing/2014/main" id="{9D26C232-9378-45F7-8E13-D8C1EE586A12}"/>
               </a:ext>
             </a:extLst>
           </p:cNvPr>
@@ -2784,7 +2784,7 @@
     </p:spTree>
     <p:extLst>
       <p:ext uri="{BB962C8B-B14F-4D97-AF65-F5344CB8AC3E}">
-        <p14:creationId xmlns:p14="http://schemas.microsoft.com/office/powerpoint/2010/main" val="2113822836"/>
+        <p14:creationId xmlns:p14="http://schemas.microsoft.com/office/powerpoint/2010/main" val="990642439"/>
       </p:ext>
     </p:extLst>
   </p:cSld>
@@ -2815,7 +2815,7 @@
           <p:cNvPr id="22" name="">
             <a:extLst xmlns:a="http://schemas.openxmlformats.org/drawingml/2006/main">
               <a:ext uri="{FF2B5EF4-FFF2-40B4-BE49-F238E27FC236}">
-                <a16:creationId xmlns:a16="http://schemas.microsoft.com/office/drawing/2014/main" id="{4F5754EE-13F0-4E9C-94A6-E8600103B37B}"/>
+                <a16:creationId xmlns:a16="http://schemas.microsoft.com/office/drawing/2014/main" id="{8491E527-47DD-4872-888F-88F6E6EC2EB5}"/>
               </a:ext>
             </a:extLst>
           </p:cNvPr>
@@ -2845,7 +2845,7 @@
           <p:cNvPr id="2" name="">
             <a:extLst xmlns:a="http://schemas.openxmlformats.org/drawingml/2006/main">
               <a:ext uri="{FF2B5EF4-FFF2-40B4-BE49-F238E27FC236}">
-                <a16:creationId xmlns:a16="http://schemas.microsoft.com/office/drawing/2014/main" id="{6AEDF336-536F-4805-A0A9-7F4583A5D306}"/>
+                <a16:creationId xmlns:a16="http://schemas.microsoft.com/office/drawing/2014/main" id="{C16C7589-8BBA-4BB8-B909-9F7122EAB3D3}"/>
               </a:ext>
             </a:extLst>
           </p:cNvPr>
@@ -2902,7 +2902,7 @@
           <p:cNvPr id="3" name="">
             <a:extLst xmlns:a="http://schemas.openxmlformats.org/drawingml/2006/main">
               <a:ext uri="{FF2B5EF4-FFF2-40B4-BE49-F238E27FC236}">
-                <a16:creationId xmlns:a16="http://schemas.microsoft.com/office/drawing/2014/main" id="{5DA1E510-4D7E-44D6-A6CF-E161C3092E4B}"/>
+                <a16:creationId xmlns:a16="http://schemas.microsoft.com/office/drawing/2014/main" id="{FEB7C680-79C1-4C29-82B3-87CAA8536C8B}"/>
               </a:ext>
             </a:extLst>
           </p:cNvPr>
@@ -2932,7 +2932,7 @@
           <p:cNvPr id="4" name="">
             <a:extLst xmlns:a="http://schemas.openxmlformats.org/drawingml/2006/main">
               <a:ext uri="{FF2B5EF4-FFF2-40B4-BE49-F238E27FC236}">
-                <a16:creationId xmlns:a16="http://schemas.microsoft.com/office/drawing/2014/main" id="{9724C595-AA70-488A-BD0B-B8DE29E102A5}"/>
+                <a16:creationId xmlns:a16="http://schemas.microsoft.com/office/drawing/2014/main" id="{A858A319-11F4-413F-86AA-71CF3DEA6F63}"/>
               </a:ext>
             </a:extLst>
           </p:cNvPr>
@@ -2989,7 +2989,7 @@
           <p:cNvPr id="5" name="">
             <a:extLst xmlns:a="http://schemas.openxmlformats.org/drawingml/2006/main">
               <a:ext uri="{FF2B5EF4-FFF2-40B4-BE49-F238E27FC236}">
-                <a16:creationId xmlns:a16="http://schemas.microsoft.com/office/drawing/2014/main" id="{54C748AF-D114-4375-8EF3-F8B681FC488B}"/>
+                <a16:creationId xmlns:a16="http://schemas.microsoft.com/office/drawing/2014/main" id="{BFE459AB-9EDE-416F-BB49-50285036E1A1}"/>
               </a:ext>
             </a:extLst>
           </p:cNvPr>
@@ -3019,7 +3019,7 @@
           <p:cNvPr id="6" name="">
             <a:extLst xmlns:a="http://schemas.openxmlformats.org/drawingml/2006/main">
               <a:ext uri="{FF2B5EF4-FFF2-40B4-BE49-F238E27FC236}">
-                <a16:creationId xmlns:a16="http://schemas.microsoft.com/office/drawing/2014/main" id="{EDB286DA-431B-4919-AF3B-FD749B6AE6B0}"/>
+                <a16:creationId xmlns:a16="http://schemas.microsoft.com/office/drawing/2014/main" id="{8EE6BF0A-B664-417A-8985-C19C952633EC}"/>
               </a:ext>
             </a:extLst>
           </p:cNvPr>
@@ -3076,7 +3076,7 @@
           <p:cNvPr id="7" name="">
             <a:extLst xmlns:a="http://schemas.openxmlformats.org/drawingml/2006/main">
               <a:ext uri="{FF2B5EF4-FFF2-40B4-BE49-F238E27FC236}">
-                <a16:creationId xmlns:a16="http://schemas.microsoft.com/office/drawing/2014/main" id="{4E8BBF8E-6F08-4E74-8137-F85283CB10B1}"/>
+                <a16:creationId xmlns:a16="http://schemas.microsoft.com/office/drawing/2014/main" id="{F59E74FB-1A8D-4F6C-B32F-6AB061591AB6}"/>
               </a:ext>
             </a:extLst>
           </p:cNvPr>
@@ -3133,7 +3133,7 @@
           <p:cNvPr id="8" name="">
             <a:extLst xmlns:a="http://schemas.openxmlformats.org/drawingml/2006/main">
               <a:ext uri="{FF2B5EF4-FFF2-40B4-BE49-F238E27FC236}">
-                <a16:creationId xmlns:a16="http://schemas.microsoft.com/office/drawing/2014/main" id="{544412DB-07E0-4C58-B527-045731BBE960}"/>
+                <a16:creationId xmlns:a16="http://schemas.microsoft.com/office/drawing/2014/main" id="{BC4F7032-714D-4E56-AF6C-2466B7542BC3}"/>
               </a:ext>
             </a:extLst>
           </p:cNvPr>
@@ -3190,7 +3190,7 @@
           <p:cNvPr id="9" name="">
             <a:extLst xmlns:a="http://schemas.openxmlformats.org/drawingml/2006/main">
               <a:ext uri="{FF2B5EF4-FFF2-40B4-BE49-F238E27FC236}">
-                <a16:creationId xmlns:a16="http://schemas.microsoft.com/office/drawing/2014/main" id="{4E26AFCB-F821-43AA-A1E3-45B4FA634434}"/>
+                <a16:creationId xmlns:a16="http://schemas.microsoft.com/office/drawing/2014/main" id="{5491F373-979C-42BA-854C-CB93644BF15A}"/>
               </a:ext>
             </a:extLst>
           </p:cNvPr>
@@ -3222,7 +3222,7 @@
           <p:cNvPr id="10" name="">
             <a:extLst xmlns:a="http://schemas.openxmlformats.org/drawingml/2006/main">
               <a:ext uri="{FF2B5EF4-FFF2-40B4-BE49-F238E27FC236}">
-                <a16:creationId xmlns:a16="http://schemas.microsoft.com/office/drawing/2014/main" id="{FBA13C12-C440-4AF2-B60D-1BBA000C5522}"/>
+                <a16:creationId xmlns:a16="http://schemas.microsoft.com/office/drawing/2014/main" id="{717B23FD-D0CE-4597-8AB6-D164AAD5999F}"/>
               </a:ext>
             </a:extLst>
           </p:cNvPr>
@@ -3279,7 +3279,7 @@
           <p:cNvPr id="11" name="">
             <a:extLst xmlns:a="http://schemas.openxmlformats.org/drawingml/2006/main">
               <a:ext uri="{FF2B5EF4-FFF2-40B4-BE49-F238E27FC236}">
-                <a16:creationId xmlns:a16="http://schemas.microsoft.com/office/drawing/2014/main" id="{368A91B5-12FC-4DF4-84AA-811E77B1B97C}"/>
+                <a16:creationId xmlns:a16="http://schemas.microsoft.com/office/drawing/2014/main" id="{8ABE7ECD-259F-4386-8102-63B00E79B29E}"/>
               </a:ext>
             </a:extLst>
           </p:cNvPr>
@@ -3336,7 +3336,7 @@
           <p:cNvPr id="12" name="">
             <a:extLst xmlns:a="http://schemas.openxmlformats.org/drawingml/2006/main">
               <a:ext uri="{FF2B5EF4-FFF2-40B4-BE49-F238E27FC236}">
-                <a16:creationId xmlns:a16="http://schemas.microsoft.com/office/drawing/2014/main" id="{74223590-EDDE-4F41-A7A3-AC90C4199134}"/>
+                <a16:creationId xmlns:a16="http://schemas.microsoft.com/office/drawing/2014/main" id="{7E072BF7-35D7-484F-A0A0-0DDA00FE3B6E}"/>
               </a:ext>
             </a:extLst>
           </p:cNvPr>
@@ -3393,7 +3393,7 @@
           <p:cNvPr id="13" name="">
             <a:extLst xmlns:a="http://schemas.openxmlformats.org/drawingml/2006/main">
               <a:ext uri="{FF2B5EF4-FFF2-40B4-BE49-F238E27FC236}">
-                <a16:creationId xmlns:a16="http://schemas.microsoft.com/office/drawing/2014/main" id="{9E73F1F4-9EA0-4A89-967D-E7C2D1567398}"/>
+                <a16:creationId xmlns:a16="http://schemas.microsoft.com/office/drawing/2014/main" id="{DF475A30-5B4C-46B0-B102-361C9DAD63FA}"/>
               </a:ext>
             </a:extLst>
           </p:cNvPr>
@@ -3425,7 +3425,7 @@
           <p:cNvPr id="14" name="">
             <a:extLst xmlns:a="http://schemas.openxmlformats.org/drawingml/2006/main">
               <a:ext uri="{FF2B5EF4-FFF2-40B4-BE49-F238E27FC236}">
-                <a16:creationId xmlns:a16="http://schemas.microsoft.com/office/drawing/2014/main" id="{92583625-CDE2-4D0E-A927-0779AE7D1A17}"/>
+                <a16:creationId xmlns:a16="http://schemas.microsoft.com/office/drawing/2014/main" id="{02673EFE-9888-4CCC-973F-D98BC19FF844}"/>
               </a:ext>
             </a:extLst>
           </p:cNvPr>
@@ -3482,7 +3482,7 @@
           <p:cNvPr id="15" name="">
             <a:extLst xmlns:a="http://schemas.openxmlformats.org/drawingml/2006/main">
               <a:ext uri="{FF2B5EF4-FFF2-40B4-BE49-F238E27FC236}">
-                <a16:creationId xmlns:a16="http://schemas.microsoft.com/office/drawing/2014/main" id="{1A0766D9-E8FB-467A-B55F-7CBB6569C38A}"/>
+                <a16:creationId xmlns:a16="http://schemas.microsoft.com/office/drawing/2014/main" id="{E38DAAC5-0D37-470E-A0B6-2F7A3D1DA7D4}"/>
               </a:ext>
             </a:extLst>
           </p:cNvPr>
@@ -3539,7 +3539,7 @@
           <p:cNvPr id="16" name="">
             <a:extLst xmlns:a="http://schemas.openxmlformats.org/drawingml/2006/main">
               <a:ext uri="{FF2B5EF4-FFF2-40B4-BE49-F238E27FC236}">
-                <a16:creationId xmlns:a16="http://schemas.microsoft.com/office/drawing/2014/main" id="{300DF6F1-3A42-48A7-ABA2-794FCF675C41}"/>
+                <a16:creationId xmlns:a16="http://schemas.microsoft.com/office/drawing/2014/main" id="{DCFBA9B6-6397-4642-A5C2-C22755D1C26C}"/>
               </a:ext>
             </a:extLst>
           </p:cNvPr>
@@ -3596,7 +3596,7 @@
           <p:cNvPr id="17" name="">
             <a:extLst xmlns:a="http://schemas.openxmlformats.org/drawingml/2006/main">
               <a:ext uri="{FF2B5EF4-FFF2-40B4-BE49-F238E27FC236}">
-                <a16:creationId xmlns:a16="http://schemas.microsoft.com/office/drawing/2014/main" id="{DE495059-4C7F-445F-9F6F-A9FE5A326003}"/>
+                <a16:creationId xmlns:a16="http://schemas.microsoft.com/office/drawing/2014/main" id="{18FC7B87-5DEB-4544-9C65-9953FF951BF4}"/>
               </a:ext>
             </a:extLst>
           </p:cNvPr>
@@ -3628,7 +3628,7 @@
           <p:cNvPr id="18" name="">
             <a:extLst xmlns:a="http://schemas.openxmlformats.org/drawingml/2006/main">
               <a:ext uri="{FF2B5EF4-FFF2-40B4-BE49-F238E27FC236}">
-                <a16:creationId xmlns:a16="http://schemas.microsoft.com/office/drawing/2014/main" id="{42CAB999-5DE9-46F8-89DB-B72B59283200}"/>
+                <a16:creationId xmlns:a16="http://schemas.microsoft.com/office/drawing/2014/main" id="{4E2CFE37-D44E-4EE8-9C56-DEEEF7EBDDA3}"/>
               </a:ext>
             </a:extLst>
           </p:cNvPr>
@@ -3685,7 +3685,7 @@
           <p:cNvPr id="19" name="">
             <a:extLst xmlns:a="http://schemas.openxmlformats.org/drawingml/2006/main">
               <a:ext uri="{FF2B5EF4-FFF2-40B4-BE49-F238E27FC236}">
-                <a16:creationId xmlns:a16="http://schemas.microsoft.com/office/drawing/2014/main" id="{FB872C91-A965-432C-BC4A-6CEFB8D06083}"/>
+                <a16:creationId xmlns:a16="http://schemas.microsoft.com/office/drawing/2014/main" id="{19F8EDAC-D542-4DD7-AF00-874869DC2CF6}"/>
               </a:ext>
             </a:extLst>
           </p:cNvPr>
@@ -3742,7 +3742,7 @@
           <p:cNvPr id="20" name="">
             <a:extLst xmlns:a="http://schemas.openxmlformats.org/drawingml/2006/main">
               <a:ext uri="{FF2B5EF4-FFF2-40B4-BE49-F238E27FC236}">
-                <a16:creationId xmlns:a16="http://schemas.microsoft.com/office/drawing/2014/main" id="{4D5B90AB-609C-4C44-88FD-7B27147EC990}"/>
+                <a16:creationId xmlns:a16="http://schemas.microsoft.com/office/drawing/2014/main" id="{0C365874-C70E-4345-9DF9-DBFE6B8730FF}"/>
               </a:ext>
             </a:extLst>
           </p:cNvPr>
@@ -3799,7 +3799,7 @@
           <p:cNvPr id="21" name="">
             <a:extLst xmlns:a="http://schemas.openxmlformats.org/drawingml/2006/main">
               <a:ext uri="{FF2B5EF4-FFF2-40B4-BE49-F238E27FC236}">
-                <a16:creationId xmlns:a16="http://schemas.microsoft.com/office/drawing/2014/main" id="{8A9AC995-1BDF-4A62-9AF7-52546FCA4E4A}"/>
+                <a16:creationId xmlns:a16="http://schemas.microsoft.com/office/drawing/2014/main" id="{79684C62-2FE7-4F59-8DBD-72B096091CF7}"/>
               </a:ext>
             </a:extLst>
           </p:cNvPr>
@@ -3854,7 +3854,7 @@
     </p:spTree>
     <p:extLst>
       <p:ext uri="{BB962C8B-B14F-4D97-AF65-F5344CB8AC3E}">
-        <p14:creationId xmlns:p14="http://schemas.microsoft.com/office/powerpoint/2010/main" val="1462927586"/>
+        <p14:creationId xmlns:p14="http://schemas.microsoft.com/office/powerpoint/2010/main" val="1180608110"/>
       </p:ext>
     </p:extLst>
   </p:cSld>
@@ -3885,7 +3885,7 @@
           <p:cNvPr id="21" name="">
             <a:extLst xmlns:a="http://schemas.openxmlformats.org/drawingml/2006/main">
               <a:ext uri="{FF2B5EF4-FFF2-40B4-BE49-F238E27FC236}">
-                <a16:creationId xmlns:a16="http://schemas.microsoft.com/office/drawing/2014/main" id="{69511549-FF96-41D4-AE45-C46D27D80859}"/>
+                <a16:creationId xmlns:a16="http://schemas.microsoft.com/office/drawing/2014/main" id="{0395ED75-C40E-476E-861F-5B61BAB86735}"/>
               </a:ext>
             </a:extLst>
           </p:cNvPr>
@@ -3915,7 +3915,7 @@
           <p:cNvPr id="2" name="">
             <a:extLst xmlns:a="http://schemas.openxmlformats.org/drawingml/2006/main">
               <a:ext uri="{FF2B5EF4-FFF2-40B4-BE49-F238E27FC236}">
-                <a16:creationId xmlns:a16="http://schemas.microsoft.com/office/drawing/2014/main" id="{8C1CCE94-A674-4D2C-9902-9BF66E127B32}"/>
+                <a16:creationId xmlns:a16="http://schemas.microsoft.com/office/drawing/2014/main" id="{2C6C43F2-234A-4195-A0F7-7A7E21DA64FE}"/>
               </a:ext>
             </a:extLst>
           </p:cNvPr>
@@ -3972,7 +3972,7 @@
           <p:cNvPr id="3" name="">
             <a:extLst xmlns:a="http://schemas.openxmlformats.org/drawingml/2006/main">
               <a:ext uri="{FF2B5EF4-FFF2-40B4-BE49-F238E27FC236}">
-                <a16:creationId xmlns:a16="http://schemas.microsoft.com/office/drawing/2014/main" id="{299BB8F1-646D-447A-B46D-47BD763837B2}"/>
+                <a16:creationId xmlns:a16="http://schemas.microsoft.com/office/drawing/2014/main" id="{07A81E01-E916-4F19-B2DB-A9269DD7C2E9}"/>
               </a:ext>
             </a:extLst>
           </p:cNvPr>
@@ -4002,7 +4002,7 @@
           <p:cNvPr id="4" name="">
             <a:extLst xmlns:a="http://schemas.openxmlformats.org/drawingml/2006/main">
               <a:ext uri="{FF2B5EF4-FFF2-40B4-BE49-F238E27FC236}">
-                <a16:creationId xmlns:a16="http://schemas.microsoft.com/office/drawing/2014/main" id="{CE3F504C-7310-46B8-8041-BF8CDCBD4F29}"/>
+                <a16:creationId xmlns:a16="http://schemas.microsoft.com/office/drawing/2014/main" id="{14EEE9A4-587F-4285-816C-E9E72ADECFC7}"/>
               </a:ext>
             </a:extLst>
           </p:cNvPr>
@@ -4059,7 +4059,7 @@
           <p:cNvPr id="5" name="">
             <a:extLst xmlns:a="http://schemas.openxmlformats.org/drawingml/2006/main">
               <a:ext uri="{FF2B5EF4-FFF2-40B4-BE49-F238E27FC236}">
-                <a16:creationId xmlns:a16="http://schemas.microsoft.com/office/drawing/2014/main" id="{C732B73E-4BF6-4C75-ACD2-786F88AC3C56}"/>
+                <a16:creationId xmlns:a16="http://schemas.microsoft.com/office/drawing/2014/main" id="{937CE83C-EC58-4DC2-81B5-28D4AE4CD21B}"/>
               </a:ext>
             </a:extLst>
           </p:cNvPr>
@@ -4116,7 +4116,7 @@
           <p:cNvPr id="6" name="">
             <a:extLst xmlns:a="http://schemas.openxmlformats.org/drawingml/2006/main">
               <a:ext uri="{FF2B5EF4-FFF2-40B4-BE49-F238E27FC236}">
-                <a16:creationId xmlns:a16="http://schemas.microsoft.com/office/drawing/2014/main" id="{BD552F6F-07B6-427F-AB93-32718E5961F2}"/>
+                <a16:creationId xmlns:a16="http://schemas.microsoft.com/office/drawing/2014/main" id="{70F553C5-E0BE-4D99-865E-16AF8A55CFF6}"/>
               </a:ext>
             </a:extLst>
           </p:cNvPr>
@@ -4173,7 +4173,7 @@
           <p:cNvPr id="7" name="">
             <a:extLst xmlns:a="http://schemas.openxmlformats.org/drawingml/2006/main">
               <a:ext uri="{FF2B5EF4-FFF2-40B4-BE49-F238E27FC236}">
-                <a16:creationId xmlns:a16="http://schemas.microsoft.com/office/drawing/2014/main" id="{1F6C487B-D8ED-4F6E-AA2F-8C7894BF5E31}"/>
+                <a16:creationId xmlns:a16="http://schemas.microsoft.com/office/drawing/2014/main" id="{3D767B04-2F74-4D2B-A535-7EDA945B5844}"/>
               </a:ext>
             </a:extLst>
           </p:cNvPr>
@@ -4230,7 +4230,7 @@
           <p:cNvPr id="8" name="">
             <a:extLst xmlns:a="http://schemas.openxmlformats.org/drawingml/2006/main">
               <a:ext uri="{FF2B5EF4-FFF2-40B4-BE49-F238E27FC236}">
-                <a16:creationId xmlns:a16="http://schemas.microsoft.com/office/drawing/2014/main" id="{13D2B74D-9226-4A99-8C6C-FA3638B99805}"/>
+                <a16:creationId xmlns:a16="http://schemas.microsoft.com/office/drawing/2014/main" id="{01CF3C6A-0BBB-4D7F-AC6E-3FC14A026F9C}"/>
               </a:ext>
             </a:extLst>
           </p:cNvPr>
@@ -4260,7 +4260,7 @@
           <p:cNvPr id="9" name="">
             <a:extLst xmlns:a="http://schemas.openxmlformats.org/drawingml/2006/main">
               <a:ext uri="{FF2B5EF4-FFF2-40B4-BE49-F238E27FC236}">
-                <a16:creationId xmlns:a16="http://schemas.microsoft.com/office/drawing/2014/main" id="{F19D2E4F-C21F-4E99-ABD1-4E421A8F5123}"/>
+                <a16:creationId xmlns:a16="http://schemas.microsoft.com/office/drawing/2014/main" id="{4F686899-A1F6-434B-A8C2-E014434DE095}"/>
               </a:ext>
             </a:extLst>
           </p:cNvPr>
@@ -4317,7 +4317,7 @@
           <p:cNvPr id="10" name="">
             <a:extLst xmlns:a="http://schemas.openxmlformats.org/drawingml/2006/main">
               <a:ext uri="{FF2B5EF4-FFF2-40B4-BE49-F238E27FC236}">
-                <a16:creationId xmlns:a16="http://schemas.microsoft.com/office/drawing/2014/main" id="{B7012AEB-5FE2-4E64-9407-4B6822780DB8}"/>
+                <a16:creationId xmlns:a16="http://schemas.microsoft.com/office/drawing/2014/main" id="{ABACDF65-87B9-4A4F-874F-C6D3FFDCFE3C}"/>
               </a:ext>
             </a:extLst>
           </p:cNvPr>
@@ -4374,7 +4374,7 @@
           <p:cNvPr id="11" name="">
             <a:extLst xmlns:a="http://schemas.openxmlformats.org/drawingml/2006/main">
               <a:ext uri="{FF2B5EF4-FFF2-40B4-BE49-F238E27FC236}">
-                <a16:creationId xmlns:a16="http://schemas.microsoft.com/office/drawing/2014/main" id="{C788E4C4-95A6-4B27-A179-A5969BE5E4E4}"/>
+                <a16:creationId xmlns:a16="http://schemas.microsoft.com/office/drawing/2014/main" id="{41E78910-60AC-4EE1-B27B-99E5718383F7}"/>
               </a:ext>
             </a:extLst>
           </p:cNvPr>
@@ -4431,7 +4431,7 @@
           <p:cNvPr id="12" name="">
             <a:extLst xmlns:a="http://schemas.openxmlformats.org/drawingml/2006/main">
               <a:ext uri="{FF2B5EF4-FFF2-40B4-BE49-F238E27FC236}">
-                <a16:creationId xmlns:a16="http://schemas.microsoft.com/office/drawing/2014/main" id="{AF58CA87-F2B3-4BDE-B743-B3A90BFDDEE5}"/>
+                <a16:creationId xmlns:a16="http://schemas.microsoft.com/office/drawing/2014/main" id="{8CA6DC50-4ABB-4AF5-8963-A39ADDB75E3D}"/>
               </a:ext>
             </a:extLst>
           </p:cNvPr>
@@ -4461,7 +4461,7 @@
           <p:cNvPr id="13" name="">
             <a:extLst xmlns:a="http://schemas.openxmlformats.org/drawingml/2006/main">
               <a:ext uri="{FF2B5EF4-FFF2-40B4-BE49-F238E27FC236}">
-                <a16:creationId xmlns:a16="http://schemas.microsoft.com/office/drawing/2014/main" id="{04C98844-05DB-41D5-B5E4-64D3CF8DAA96}"/>
+                <a16:creationId xmlns:a16="http://schemas.microsoft.com/office/drawing/2014/main" id="{F2853B5B-6EC8-4FB1-968F-6CB337856212}"/>
               </a:ext>
             </a:extLst>
           </p:cNvPr>
@@ -4518,7 +4518,7 @@
           <p:cNvPr id="14" name="">
             <a:extLst xmlns:a="http://schemas.openxmlformats.org/drawingml/2006/main">
               <a:ext uri="{FF2B5EF4-FFF2-40B4-BE49-F238E27FC236}">
-                <a16:creationId xmlns:a16="http://schemas.microsoft.com/office/drawing/2014/main" id="{C2099B16-392F-4243-94D4-7C1E5D822688}"/>
+                <a16:creationId xmlns:a16="http://schemas.microsoft.com/office/drawing/2014/main" id="{9A292D65-907C-4F85-A3D8-C19969AC683B}"/>
               </a:ext>
             </a:extLst>
           </p:cNvPr>
@@ -4575,7 +4575,7 @@
           <p:cNvPr id="15" name="">
             <a:extLst xmlns:a="http://schemas.openxmlformats.org/drawingml/2006/main">
               <a:ext uri="{FF2B5EF4-FFF2-40B4-BE49-F238E27FC236}">
-                <a16:creationId xmlns:a16="http://schemas.microsoft.com/office/drawing/2014/main" id="{D75CBEF7-BDA8-4F7B-AFAB-6928FB6BC455}"/>
+                <a16:creationId xmlns:a16="http://schemas.microsoft.com/office/drawing/2014/main" id="{8DF8D7C7-B095-442C-AEAE-338479644FB0}"/>
               </a:ext>
             </a:extLst>
           </p:cNvPr>
@@ -4632,7 +4632,7 @@
           <p:cNvPr id="16" name="">
             <a:extLst xmlns:a="http://schemas.openxmlformats.org/drawingml/2006/main">
               <a:ext uri="{FF2B5EF4-FFF2-40B4-BE49-F238E27FC236}">
-                <a16:creationId xmlns:a16="http://schemas.microsoft.com/office/drawing/2014/main" id="{21266675-8D24-4949-9592-04E6C199ECE0}"/>
+                <a16:creationId xmlns:a16="http://schemas.microsoft.com/office/drawing/2014/main" id="{0D057AC4-4C42-4F9A-A06F-D3B06178BD38}"/>
               </a:ext>
             </a:extLst>
           </p:cNvPr>
@@ -4662,7 +4662,7 @@
           <p:cNvPr id="17" name="">
             <a:extLst xmlns:a="http://schemas.openxmlformats.org/drawingml/2006/main">
               <a:ext uri="{FF2B5EF4-FFF2-40B4-BE49-F238E27FC236}">
-                <a16:creationId xmlns:a16="http://schemas.microsoft.com/office/drawing/2014/main" id="{15460030-6F7E-4AFE-A0D0-2B7C0C3E7E0A}"/>
+                <a16:creationId xmlns:a16="http://schemas.microsoft.com/office/drawing/2014/main" id="{C3D32F45-186D-4DF8-97D8-0F41168724E1}"/>
               </a:ext>
             </a:extLst>
           </p:cNvPr>
@@ -4719,7 +4719,7 @@
           <p:cNvPr id="18" name="">
             <a:extLst xmlns:a="http://schemas.openxmlformats.org/drawingml/2006/main">
               <a:ext uri="{FF2B5EF4-FFF2-40B4-BE49-F238E27FC236}">
-                <a16:creationId xmlns:a16="http://schemas.microsoft.com/office/drawing/2014/main" id="{7F04B56B-8248-4234-BD04-5C6958D146E9}"/>
+                <a16:creationId xmlns:a16="http://schemas.microsoft.com/office/drawing/2014/main" id="{37384C16-F666-4F24-9639-FF8A5D954E82}"/>
               </a:ext>
             </a:extLst>
           </p:cNvPr>
@@ -4776,7 +4776,7 @@
           <p:cNvPr id="19" name="">
             <a:extLst xmlns:a="http://schemas.openxmlformats.org/drawingml/2006/main">
               <a:ext uri="{FF2B5EF4-FFF2-40B4-BE49-F238E27FC236}">
-                <a16:creationId xmlns:a16="http://schemas.microsoft.com/office/drawing/2014/main" id="{905CBECB-E0CD-40EB-BD9F-874176515358}"/>
+                <a16:creationId xmlns:a16="http://schemas.microsoft.com/office/drawing/2014/main" id="{B356BF4E-86B2-4AAE-85C3-D50E821863EC}"/>
               </a:ext>
             </a:extLst>
           </p:cNvPr>
@@ -4833,7 +4833,7 @@
           <p:cNvPr id="20" name="">
             <a:extLst xmlns:a="http://schemas.openxmlformats.org/drawingml/2006/main">
               <a:ext uri="{FF2B5EF4-FFF2-40B4-BE49-F238E27FC236}">
-                <a16:creationId xmlns:a16="http://schemas.microsoft.com/office/drawing/2014/main" id="{5DFAA060-DDBE-4EA9-80A7-B107CD954459}"/>
+                <a16:creationId xmlns:a16="http://schemas.microsoft.com/office/drawing/2014/main" id="{159FB153-8474-4901-820C-32CC7013D838}"/>
               </a:ext>
             </a:extLst>
           </p:cNvPr>
@@ -4888,7 +4888,7 @@
     </p:spTree>
     <p:extLst>
       <p:ext uri="{BB962C8B-B14F-4D97-AF65-F5344CB8AC3E}">
-        <p14:creationId xmlns:p14="http://schemas.microsoft.com/office/powerpoint/2010/main" val="1366235685"/>
+        <p14:creationId xmlns:p14="http://schemas.microsoft.com/office/powerpoint/2010/main" val="1039531399"/>
       </p:ext>
     </p:extLst>
   </p:cSld>
@@ -4919,7 +4919,7 @@
           <p:cNvPr id="21" name="">
             <a:extLst xmlns:a="http://schemas.openxmlformats.org/drawingml/2006/main">
               <a:ext uri="{FF2B5EF4-FFF2-40B4-BE49-F238E27FC236}">
-                <a16:creationId xmlns:a16="http://schemas.microsoft.com/office/drawing/2014/main" id="{00C3FEB2-B95B-4C90-9D1A-59C15D994E31}"/>
+                <a16:creationId xmlns:a16="http://schemas.microsoft.com/office/drawing/2014/main" id="{93B30118-89CE-457E-95AF-DB2C9C0B0714}"/>
               </a:ext>
             </a:extLst>
           </p:cNvPr>
@@ -4949,7 +4949,7 @@
           <p:cNvPr id="2" name="">
             <a:extLst xmlns:a="http://schemas.openxmlformats.org/drawingml/2006/main">
               <a:ext uri="{FF2B5EF4-FFF2-40B4-BE49-F238E27FC236}">
-                <a16:creationId xmlns:a16="http://schemas.microsoft.com/office/drawing/2014/main" id="{04EE2F0C-9A62-4EFD-AE91-52143D583E30}"/>
+                <a16:creationId xmlns:a16="http://schemas.microsoft.com/office/drawing/2014/main" id="{701FDF30-B5B6-4773-95C4-D38400206646}"/>
               </a:ext>
             </a:extLst>
           </p:cNvPr>
@@ -5006,7 +5006,7 @@
           <p:cNvPr id="3" name="">
             <a:extLst xmlns:a="http://schemas.openxmlformats.org/drawingml/2006/main">
               <a:ext uri="{FF2B5EF4-FFF2-40B4-BE49-F238E27FC236}">
-                <a16:creationId xmlns:a16="http://schemas.microsoft.com/office/drawing/2014/main" id="{F17C2872-595F-4BAB-8D3A-A0996124D0D2}"/>
+                <a16:creationId xmlns:a16="http://schemas.microsoft.com/office/drawing/2014/main" id="{9731ED50-B118-49AA-9A33-338148952CEF}"/>
               </a:ext>
             </a:extLst>
           </p:cNvPr>
@@ -5036,7 +5036,7 @@
           <p:cNvPr id="4" name="">
             <a:extLst xmlns:a="http://schemas.openxmlformats.org/drawingml/2006/main">
               <a:ext uri="{FF2B5EF4-FFF2-40B4-BE49-F238E27FC236}">
-                <a16:creationId xmlns:a16="http://schemas.microsoft.com/office/drawing/2014/main" id="{BC0A16EC-FAA0-43E1-BB5C-04C337F7AF3C}"/>
+                <a16:creationId xmlns:a16="http://schemas.microsoft.com/office/drawing/2014/main" id="{02EC0114-B656-43B3-A04C-BCBB018EB107}"/>
               </a:ext>
             </a:extLst>
           </p:cNvPr>
@@ -5093,7 +5093,7 @@
           <p:cNvPr id="5" name="">
             <a:extLst xmlns:a="http://schemas.openxmlformats.org/drawingml/2006/main">
               <a:ext uri="{FF2B5EF4-FFF2-40B4-BE49-F238E27FC236}">
-                <a16:creationId xmlns:a16="http://schemas.microsoft.com/office/drawing/2014/main" id="{54ED7CC2-70DF-4339-A2D8-F63BBF8F5E93}"/>
+                <a16:creationId xmlns:a16="http://schemas.microsoft.com/office/drawing/2014/main" id="{00C110BD-525C-4F18-A2D9-F7A074824586}"/>
               </a:ext>
             </a:extLst>
           </p:cNvPr>
@@ -5125,7 +5125,7 @@
           <p:cNvPr id="6" name="">
             <a:extLst xmlns:a="http://schemas.openxmlformats.org/drawingml/2006/main">
               <a:ext uri="{FF2B5EF4-FFF2-40B4-BE49-F238E27FC236}">
-                <a16:creationId xmlns:a16="http://schemas.microsoft.com/office/drawing/2014/main" id="{1846EA46-ADDB-4F24-964E-D8523C6EBF44}"/>
+                <a16:creationId xmlns:a16="http://schemas.microsoft.com/office/drawing/2014/main" id="{4BD3C4E8-D838-4ADB-ADB3-70FA74BC4091}"/>
               </a:ext>
             </a:extLst>
           </p:cNvPr>
@@ -5182,7 +5182,7 @@
           <p:cNvPr id="7" name="">
             <a:extLst xmlns:a="http://schemas.openxmlformats.org/drawingml/2006/main">
               <a:ext uri="{FF2B5EF4-FFF2-40B4-BE49-F238E27FC236}">
-                <a16:creationId xmlns:a16="http://schemas.microsoft.com/office/drawing/2014/main" id="{1DBAEE03-C14B-4298-9ABE-41675E5425D3}"/>
+                <a16:creationId xmlns:a16="http://schemas.microsoft.com/office/drawing/2014/main" id="{5BDFB574-F739-4D2D-9EFF-62A7AF116644}"/>
               </a:ext>
             </a:extLst>
           </p:cNvPr>
@@ -5262,7 +5262,7 @@
           <p:cNvPr id="8" name="">
             <a:extLst xmlns:a="http://schemas.openxmlformats.org/drawingml/2006/main">
               <a:ext uri="{FF2B5EF4-FFF2-40B4-BE49-F238E27FC236}">
-                <a16:creationId xmlns:a16="http://schemas.microsoft.com/office/drawing/2014/main" id="{62CBD877-AF43-45D6-90B3-2EC21EA7D9E9}"/>
+                <a16:creationId xmlns:a16="http://schemas.microsoft.com/office/drawing/2014/main" id="{FD4F4B41-A211-4FF8-A9D7-094AFED8B41C}"/>
               </a:ext>
             </a:extLst>
           </p:cNvPr>
@@ -5342,7 +5342,7 @@
           <p:cNvPr id="9" name="">
             <a:extLst xmlns:a="http://schemas.openxmlformats.org/drawingml/2006/main">
               <a:ext uri="{FF2B5EF4-FFF2-40B4-BE49-F238E27FC236}">
-                <a16:creationId xmlns:a16="http://schemas.microsoft.com/office/drawing/2014/main" id="{4E468BAF-D373-472B-8143-346B95149FBA}"/>
+                <a16:creationId xmlns:a16="http://schemas.microsoft.com/office/drawing/2014/main" id="{7A97AAB2-A0E4-49B8-9069-8F02E233D0A8}"/>
               </a:ext>
             </a:extLst>
           </p:cNvPr>
@@ -5372,7 +5372,7 @@
           <p:cNvPr id="10" name="">
             <a:extLst xmlns:a="http://schemas.openxmlformats.org/drawingml/2006/main">
               <a:ext uri="{FF2B5EF4-FFF2-40B4-BE49-F238E27FC236}">
-                <a16:creationId xmlns:a16="http://schemas.microsoft.com/office/drawing/2014/main" id="{A97FD560-4692-4591-9E30-E8246E272D3F}"/>
+                <a16:creationId xmlns:a16="http://schemas.microsoft.com/office/drawing/2014/main" id="{5646C22A-A951-485E-AAA7-06D74A5C0056}"/>
               </a:ext>
             </a:extLst>
           </p:cNvPr>
@@ -5429,7 +5429,7 @@
           <p:cNvPr id="11" name="">
             <a:extLst xmlns:a="http://schemas.openxmlformats.org/drawingml/2006/main">
               <a:ext uri="{FF2B5EF4-FFF2-40B4-BE49-F238E27FC236}">
-                <a16:creationId xmlns:a16="http://schemas.microsoft.com/office/drawing/2014/main" id="{9BA6CE0F-46A6-4A42-9A6D-DF47AC64AEA2}"/>
+                <a16:creationId xmlns:a16="http://schemas.microsoft.com/office/drawing/2014/main" id="{CC5C84B8-7EE4-4692-82D3-14055F5EF926}"/>
               </a:ext>
             </a:extLst>
           </p:cNvPr>
@@ -5486,7 +5486,7 @@
           <p:cNvPr id="12" name="">
             <a:extLst xmlns:a="http://schemas.openxmlformats.org/drawingml/2006/main">
               <a:ext uri="{FF2B5EF4-FFF2-40B4-BE49-F238E27FC236}">
-                <a16:creationId xmlns:a16="http://schemas.microsoft.com/office/drawing/2014/main" id="{F99CB7D7-5C75-4460-A315-53407E54579B}"/>
+                <a16:creationId xmlns:a16="http://schemas.microsoft.com/office/drawing/2014/main" id="{0C2FB5EC-7DA2-4FF6-AF89-890E14E8C9BE}"/>
               </a:ext>
             </a:extLst>
           </p:cNvPr>
@@ -5543,7 +5543,7 @@
           <p:cNvPr id="13" name="">
             <a:extLst xmlns:a="http://schemas.openxmlformats.org/drawingml/2006/main">
               <a:ext uri="{FF2B5EF4-FFF2-40B4-BE49-F238E27FC236}">
-                <a16:creationId xmlns:a16="http://schemas.microsoft.com/office/drawing/2014/main" id="{C4311C54-F7C0-4CED-B1E2-E734E8FA2CE3}"/>
+                <a16:creationId xmlns:a16="http://schemas.microsoft.com/office/drawing/2014/main" id="{907D0C83-34E4-4939-A661-9C721CF23B3A}"/>
               </a:ext>
             </a:extLst>
           </p:cNvPr>
@@ -5623,7 +5623,7 @@
           <p:cNvPr id="14" name="">
             <a:extLst xmlns:a="http://schemas.openxmlformats.org/drawingml/2006/main">
               <a:ext uri="{FF2B5EF4-FFF2-40B4-BE49-F238E27FC236}">
-                <a16:creationId xmlns:a16="http://schemas.microsoft.com/office/drawing/2014/main" id="{047AEF86-1D6B-437D-8CCA-23CD1364EEEB}"/>
+                <a16:creationId xmlns:a16="http://schemas.microsoft.com/office/drawing/2014/main" id="{482F47EF-9B87-4124-9ED0-6CFE2F68290A}"/>
               </a:ext>
             </a:extLst>
           </p:cNvPr>
@@ -5680,7 +5680,7 @@
           <p:cNvPr id="15" name="">
             <a:extLst xmlns:a="http://schemas.openxmlformats.org/drawingml/2006/main">
               <a:ext uri="{FF2B5EF4-FFF2-40B4-BE49-F238E27FC236}">
-                <a16:creationId xmlns:a16="http://schemas.microsoft.com/office/drawing/2014/main" id="{7F41BB0D-BC6D-4F31-B41E-BF3678524080}"/>
+                <a16:creationId xmlns:a16="http://schemas.microsoft.com/office/drawing/2014/main" id="{6933FDCA-CB80-49C4-B458-5F4C1DC3B92A}"/>
               </a:ext>
             </a:extLst>
           </p:cNvPr>
@@ -5712,7 +5712,7 @@
           <p:cNvPr id="16" name="">
             <a:extLst xmlns:a="http://schemas.openxmlformats.org/drawingml/2006/main">
               <a:ext uri="{FF2B5EF4-FFF2-40B4-BE49-F238E27FC236}">
-                <a16:creationId xmlns:a16="http://schemas.microsoft.com/office/drawing/2014/main" id="{C49EEE70-E858-4A79-A08A-1813A4AFF1ED}"/>
+                <a16:creationId xmlns:a16="http://schemas.microsoft.com/office/drawing/2014/main" id="{15986DA8-2CFE-4FC9-9D85-7656265C77D8}"/>
               </a:ext>
             </a:extLst>
           </p:cNvPr>
@@ -5769,7 +5769,7 @@
           <p:cNvPr id="17" name="">
             <a:extLst xmlns:a="http://schemas.openxmlformats.org/drawingml/2006/main">
               <a:ext uri="{FF2B5EF4-FFF2-40B4-BE49-F238E27FC236}">
-                <a16:creationId xmlns:a16="http://schemas.microsoft.com/office/drawing/2014/main" id="{C9E9F853-10F8-424C-8E8A-9FDFA38DF06E}"/>
+                <a16:creationId xmlns:a16="http://schemas.microsoft.com/office/drawing/2014/main" id="{358B2A26-1668-49A6-9F5C-3AE11CAB4205}"/>
               </a:ext>
             </a:extLst>
           </p:cNvPr>
@@ -5849,7 +5849,7 @@
           <p:cNvPr id="18" name="">
             <a:extLst xmlns:a="http://schemas.openxmlformats.org/drawingml/2006/main">
               <a:ext uri="{FF2B5EF4-FFF2-40B4-BE49-F238E27FC236}">
-                <a16:creationId xmlns:a16="http://schemas.microsoft.com/office/drawing/2014/main" id="{DF523624-FAC5-4C54-9FB3-DCB8F74CCE28}"/>
+                <a16:creationId xmlns:a16="http://schemas.microsoft.com/office/drawing/2014/main" id="{38FE4C0C-1393-4295-94BB-0AB0B4EE2820}"/>
               </a:ext>
             </a:extLst>
           </p:cNvPr>
@@ -5929,7 +5929,7 @@
           <p:cNvPr id="19" name="">
             <a:extLst xmlns:a="http://schemas.openxmlformats.org/drawingml/2006/main">
               <a:ext uri="{FF2B5EF4-FFF2-40B4-BE49-F238E27FC236}">
-                <a16:creationId xmlns:a16="http://schemas.microsoft.com/office/drawing/2014/main" id="{D4749141-7DC7-41A0-8CA0-AB44ADFC501D}"/>
+                <a16:creationId xmlns:a16="http://schemas.microsoft.com/office/drawing/2014/main" id="{F2467CEF-5655-43C6-8E23-2ECA3AA684E4}"/>
               </a:ext>
             </a:extLst>
           </p:cNvPr>
@@ -5986,7 +5986,7 @@
           <p:cNvPr id="20" name="">
             <a:extLst xmlns:a="http://schemas.openxmlformats.org/drawingml/2006/main">
               <a:ext uri="{FF2B5EF4-FFF2-40B4-BE49-F238E27FC236}">
-                <a16:creationId xmlns:a16="http://schemas.microsoft.com/office/drawing/2014/main" id="{A2F4F2A2-CC61-47F3-85B9-0E5122E62F66}"/>
+                <a16:creationId xmlns:a16="http://schemas.microsoft.com/office/drawing/2014/main" id="{4C08B5B3-6DF9-4FFA-8925-F56A6F4C0C32}"/>
               </a:ext>
             </a:extLst>
           </p:cNvPr>
@@ -6041,7 +6041,7 @@
     </p:spTree>
     <p:extLst>
       <p:ext uri="{BB962C8B-B14F-4D97-AF65-F5344CB8AC3E}">
-        <p14:creationId xmlns:p14="http://schemas.microsoft.com/office/powerpoint/2010/main" val="1574786998"/>
+        <p14:creationId xmlns:p14="http://schemas.microsoft.com/office/powerpoint/2010/main" val="1860346409"/>
       </p:ext>
     </p:extLst>
   </p:cSld>
@@ -6072,7 +6072,7 @@
           <p:cNvPr id="15" name="">
             <a:extLst xmlns:a="http://schemas.openxmlformats.org/drawingml/2006/main">
               <a:ext uri="{FF2B5EF4-FFF2-40B4-BE49-F238E27FC236}">
-                <a16:creationId xmlns:a16="http://schemas.microsoft.com/office/drawing/2014/main" id="{7274914E-ED6C-4E11-9C93-063742D5EA2F}"/>
+                <a16:creationId xmlns:a16="http://schemas.microsoft.com/office/drawing/2014/main" id="{0E8F5009-5A16-4957-BF5C-B9FD9E3BF0FF}"/>
               </a:ext>
             </a:extLst>
           </p:cNvPr>
@@ -6102,7 +6102,7 @@
           <p:cNvPr id="2" name="">
             <a:extLst xmlns:a="http://schemas.openxmlformats.org/drawingml/2006/main">
               <a:ext uri="{FF2B5EF4-FFF2-40B4-BE49-F238E27FC236}">
-                <a16:creationId xmlns:a16="http://schemas.microsoft.com/office/drawing/2014/main" id="{70A92C08-7B53-430B-BA22-CF6849B95FCB}"/>
+                <a16:creationId xmlns:a16="http://schemas.microsoft.com/office/drawing/2014/main" id="{3317EA2D-5A85-4DC3-93ED-9DAB6AFD286C}"/>
               </a:ext>
             </a:extLst>
           </p:cNvPr>
@@ -6159,7 +6159,7 @@
           <p:cNvPr id="3" name="">
             <a:extLst xmlns:a="http://schemas.openxmlformats.org/drawingml/2006/main">
               <a:ext uri="{FF2B5EF4-FFF2-40B4-BE49-F238E27FC236}">
-                <a16:creationId xmlns:a16="http://schemas.microsoft.com/office/drawing/2014/main" id="{DEC913C2-BA6B-4D87-A626-A0E5DEFE9D1B}"/>
+                <a16:creationId xmlns:a16="http://schemas.microsoft.com/office/drawing/2014/main" id="{309C84BA-9695-4420-BDB1-C24953542178}"/>
               </a:ext>
             </a:extLst>
           </p:cNvPr>
@@ -6189,7 +6189,7 @@
           <p:cNvPr id="4" name="">
             <a:extLst xmlns:a="http://schemas.openxmlformats.org/drawingml/2006/main">
               <a:ext uri="{FF2B5EF4-FFF2-40B4-BE49-F238E27FC236}">
-                <a16:creationId xmlns:a16="http://schemas.microsoft.com/office/drawing/2014/main" id="{3FF1B9BD-B7D5-436A-AC55-D3A776079310}"/>
+                <a16:creationId xmlns:a16="http://schemas.microsoft.com/office/drawing/2014/main" id="{42A006F3-DA56-4606-AC11-52B38034BE70}"/>
               </a:ext>
             </a:extLst>
           </p:cNvPr>
@@ -6246,7 +6246,7 @@
           <p:cNvPr id="5" name="">
             <a:extLst xmlns:a="http://schemas.openxmlformats.org/drawingml/2006/main">
               <a:ext uri="{FF2B5EF4-FFF2-40B4-BE49-F238E27FC236}">
-                <a16:creationId xmlns:a16="http://schemas.microsoft.com/office/drawing/2014/main" id="{2869261C-2A26-443D-986D-B7774BFE31A8}"/>
+                <a16:creationId xmlns:a16="http://schemas.microsoft.com/office/drawing/2014/main" id="{26C989E3-7ED9-4E99-9A2F-1F475315D1D3}"/>
               </a:ext>
             </a:extLst>
           </p:cNvPr>
@@ -6303,7 +6303,7 @@
           <p:cNvPr id="6" name="">
             <a:extLst xmlns:a="http://schemas.openxmlformats.org/drawingml/2006/main">
               <a:ext uri="{FF2B5EF4-FFF2-40B4-BE49-F238E27FC236}">
-                <a16:creationId xmlns:a16="http://schemas.microsoft.com/office/drawing/2014/main" id="{67F5C303-9F97-4D0B-AE13-93A9BCF6A1F9}"/>
+                <a16:creationId xmlns:a16="http://schemas.microsoft.com/office/drawing/2014/main" id="{12271541-4D43-4752-9963-A0231C4290E6}"/>
               </a:ext>
             </a:extLst>
           </p:cNvPr>
@@ -6360,7 +6360,7 @@
           <p:cNvPr id="7" name="">
             <a:extLst xmlns:a="http://schemas.openxmlformats.org/drawingml/2006/main">
               <a:ext uri="{FF2B5EF4-FFF2-40B4-BE49-F238E27FC236}">
-                <a16:creationId xmlns:a16="http://schemas.microsoft.com/office/drawing/2014/main" id="{27D04017-29B9-4B95-AC7F-A45E6A39274B}"/>
+                <a16:creationId xmlns:a16="http://schemas.microsoft.com/office/drawing/2014/main" id="{8587A9A3-9E2C-4149-ACE7-F1CA7FE44DF5}"/>
               </a:ext>
             </a:extLst>
           </p:cNvPr>
@@ -6390,7 +6390,7 @@
           <p:cNvPr id="8" name="">
             <a:extLst xmlns:a="http://schemas.openxmlformats.org/drawingml/2006/main">
               <a:ext uri="{FF2B5EF4-FFF2-40B4-BE49-F238E27FC236}">
-                <a16:creationId xmlns:a16="http://schemas.microsoft.com/office/drawing/2014/main" id="{BD2AC132-34C6-4F07-8A00-AB69F2C7BFA0}"/>
+                <a16:creationId xmlns:a16="http://schemas.microsoft.com/office/drawing/2014/main" id="{06E0E123-5A28-4869-AFD5-07A0DDBCB142}"/>
               </a:ext>
             </a:extLst>
           </p:cNvPr>
@@ -6447,7 +6447,7 @@
           <p:cNvPr id="9" name="">
             <a:extLst xmlns:a="http://schemas.openxmlformats.org/drawingml/2006/main">
               <a:ext uri="{FF2B5EF4-FFF2-40B4-BE49-F238E27FC236}">
-                <a16:creationId xmlns:a16="http://schemas.microsoft.com/office/drawing/2014/main" id="{1B002F43-15F1-4A8C-87F2-C111DDC4A7CA}"/>
+                <a16:creationId xmlns:a16="http://schemas.microsoft.com/office/drawing/2014/main" id="{C9584CBC-DA4E-41CD-99D1-F56D5D424615}"/>
               </a:ext>
             </a:extLst>
           </p:cNvPr>
@@ -6504,7 +6504,7 @@
           <p:cNvPr id="10" name="">
             <a:extLst xmlns:a="http://schemas.openxmlformats.org/drawingml/2006/main">
               <a:ext uri="{FF2B5EF4-FFF2-40B4-BE49-F238E27FC236}">
-                <a16:creationId xmlns:a16="http://schemas.microsoft.com/office/drawing/2014/main" id="{A67AD5B1-C5E2-42D3-98C3-5CDEBEE0A7C0}"/>
+                <a16:creationId xmlns:a16="http://schemas.microsoft.com/office/drawing/2014/main" id="{6E4F8F82-752D-453A-85EE-A6B8E8CF2898}"/>
               </a:ext>
             </a:extLst>
           </p:cNvPr>
@@ -6534,7 +6534,7 @@
           <p:cNvPr id="11" name="">
             <a:extLst xmlns:a="http://schemas.openxmlformats.org/drawingml/2006/main">
               <a:ext uri="{FF2B5EF4-FFF2-40B4-BE49-F238E27FC236}">
-                <a16:creationId xmlns:a16="http://schemas.microsoft.com/office/drawing/2014/main" id="{99F27D09-345A-4897-8AD3-59333622ED64}"/>
+                <a16:creationId xmlns:a16="http://schemas.microsoft.com/office/drawing/2014/main" id="{26911DE6-0C2C-4830-99BC-631A6AD5A41A}"/>
               </a:ext>
             </a:extLst>
           </p:cNvPr>
@@ -6591,7 +6591,7 @@
           <p:cNvPr id="12" name="">
             <a:extLst xmlns:a="http://schemas.openxmlformats.org/drawingml/2006/main">
               <a:ext uri="{FF2B5EF4-FFF2-40B4-BE49-F238E27FC236}">
-                <a16:creationId xmlns:a16="http://schemas.microsoft.com/office/drawing/2014/main" id="{F459A9B3-3CD3-440B-BCEC-BA8E80FFAA93}"/>
+                <a16:creationId xmlns:a16="http://schemas.microsoft.com/office/drawing/2014/main" id="{0DB03915-0A27-4EED-A0C7-160336D66933}"/>
               </a:ext>
             </a:extLst>
           </p:cNvPr>
@@ -6648,7 +6648,7 @@
           <p:cNvPr id="13" name="">
             <a:extLst xmlns:a="http://schemas.openxmlformats.org/drawingml/2006/main">
               <a:ext uri="{FF2B5EF4-FFF2-40B4-BE49-F238E27FC236}">
-                <a16:creationId xmlns:a16="http://schemas.microsoft.com/office/drawing/2014/main" id="{0772D696-3B01-4F69-8CE5-081F689C03B2}"/>
+                <a16:creationId xmlns:a16="http://schemas.microsoft.com/office/drawing/2014/main" id="{FD90B609-437D-48F8-8862-9700DC598E51}"/>
               </a:ext>
             </a:extLst>
           </p:cNvPr>
@@ -6678,7 +6678,7 @@
           <p:cNvPr id="14" name="">
             <a:extLst xmlns:a="http://schemas.openxmlformats.org/drawingml/2006/main">
               <a:ext uri="{FF2B5EF4-FFF2-40B4-BE49-F238E27FC236}">
-                <a16:creationId xmlns:a16="http://schemas.microsoft.com/office/drawing/2014/main" id="{DC6BFD57-E507-4455-98F7-E3C18951C7AB}"/>
+                <a16:creationId xmlns:a16="http://schemas.microsoft.com/office/drawing/2014/main" id="{45245DC4-E45F-48E6-9080-7361A0392CC5}"/>
               </a:ext>
             </a:extLst>
           </p:cNvPr>
@@ -6733,7 +6733,7 @@
     </p:spTree>
     <p:extLst>
       <p:ext uri="{BB962C8B-B14F-4D97-AF65-F5344CB8AC3E}">
-        <p14:creationId xmlns:p14="http://schemas.microsoft.com/office/powerpoint/2010/main" val="921013620"/>
+        <p14:creationId xmlns:p14="http://schemas.microsoft.com/office/powerpoint/2010/main" val="560443876"/>
       </p:ext>
     </p:extLst>
   </p:cSld>
@@ -6761,10 +6761,10 @@
       </p:grpSpPr>
       <p:sp>
         <p:nvSpPr>
-          <p:cNvPr id="13" name="">
-            <a:extLst xmlns:a="http://schemas.openxmlformats.org/drawingml/2006/main">
-              <a:ext uri="{FF2B5EF4-FFF2-40B4-BE49-F238E27FC236}">
-                <a16:creationId xmlns:a16="http://schemas.microsoft.com/office/drawing/2014/main" id="{A9AC8631-305C-4B33-9D88-2A2ECC726B72}"/>
+          <p:cNvPr id="18" name="">
+            <a:extLst xmlns:a="http://schemas.openxmlformats.org/drawingml/2006/main">
+              <a:ext uri="{FF2B5EF4-FFF2-40B4-BE49-F238E27FC236}">
+                <a16:creationId xmlns:a16="http://schemas.microsoft.com/office/drawing/2014/main" id="{7E5A0BF4-9DC1-4B03-9B46-C22D99F90658}"/>
               </a:ext>
             </a:extLst>
           </p:cNvPr>
@@ -6794,7 +6794,7 @@
           <p:cNvPr id="2" name="">
             <a:extLst xmlns:a="http://schemas.openxmlformats.org/drawingml/2006/main">
               <a:ext uri="{FF2B5EF4-FFF2-40B4-BE49-F238E27FC236}">
-                <a16:creationId xmlns:a16="http://schemas.microsoft.com/office/drawing/2014/main" id="{CB5D7761-4A59-4220-AAC0-4E68F5D359CB}"/>
+                <a16:creationId xmlns:a16="http://schemas.microsoft.com/office/drawing/2014/main" id="{69C1ADF2-05F8-489E-973F-5B459A56D93B}"/>
               </a:ext>
             </a:extLst>
           </p:cNvPr>
@@ -6841,7 +6841,7 @@
                 <a:ea typeface="Noto Sans KR"/>
                 <a:cs typeface="Noto Sans KR"/>
               </a:rPr>
-              <a:t>배포와 다음 검증</a:t>
+              <a:t>배포와 다음 구현 계획</a:t>
             </a:r>
           </a:p>
         </p:txBody>
@@ -6851,7 +6851,7 @@
           <p:cNvPr id="3" name="">
             <a:extLst xmlns:a="http://schemas.openxmlformats.org/drawingml/2006/main">
               <a:ext uri="{FF2B5EF4-FFF2-40B4-BE49-F238E27FC236}">
-                <a16:creationId xmlns:a16="http://schemas.microsoft.com/office/drawing/2014/main" id="{DC8DD914-9D06-4E7E-B428-F1304F0A2B0D}"/>
+                <a16:creationId xmlns:a16="http://schemas.microsoft.com/office/drawing/2014/main" id="{AC44D693-C347-4748-B6B6-3411F05EADF5}"/>
               </a:ext>
             </a:extLst>
           </p:cNvPr>
@@ -6881,7 +6881,7 @@
           <p:cNvPr id="4" name="">
             <a:extLst xmlns:a="http://schemas.openxmlformats.org/drawingml/2006/main">
               <a:ext uri="{FF2B5EF4-FFF2-40B4-BE49-F238E27FC236}">
-                <a16:creationId xmlns:a16="http://schemas.microsoft.com/office/drawing/2014/main" id="{4F03EE54-4986-40CB-AE41-B892824C6573}"/>
+                <a16:creationId xmlns:a16="http://schemas.microsoft.com/office/drawing/2014/main" id="{2076E79C-1279-48AE-8E10-F86F21D472E1}"/>
               </a:ext>
             </a:extLst>
           </p:cNvPr>
@@ -6938,7 +6938,7 @@
           <p:cNvPr id="5" name="">
             <a:extLst xmlns:a="http://schemas.openxmlformats.org/drawingml/2006/main">
               <a:ext uri="{FF2B5EF4-FFF2-40B4-BE49-F238E27FC236}">
-                <a16:creationId xmlns:a16="http://schemas.microsoft.com/office/drawing/2014/main" id="{E47DC82E-FAAB-4C24-9F4A-84E9D8191F01}"/>
+                <a16:creationId xmlns:a16="http://schemas.microsoft.com/office/drawing/2014/main" id="{B57B200F-8BA7-4C3E-AB37-5C8DD8963379}"/>
               </a:ext>
             </a:extLst>
           </p:cNvPr>
@@ -6995,7 +6995,7 @@
           <p:cNvPr id="6" name="">
             <a:extLst xmlns:a="http://schemas.openxmlformats.org/drawingml/2006/main">
               <a:ext uri="{FF2B5EF4-FFF2-40B4-BE49-F238E27FC236}">
-                <a16:creationId xmlns:a16="http://schemas.microsoft.com/office/drawing/2014/main" id="{7E5076EA-FC37-4575-8917-D3AAE9CAFF8F}"/>
+                <a16:creationId xmlns:a16="http://schemas.microsoft.com/office/drawing/2014/main" id="{DC1109BD-204D-4687-9F42-78001271D375}"/>
               </a:ext>
             </a:extLst>
           </p:cNvPr>
@@ -7052,7 +7052,7 @@
           <p:cNvPr id="7" name="">
             <a:extLst xmlns:a="http://schemas.openxmlformats.org/drawingml/2006/main">
               <a:ext uri="{FF2B5EF4-FFF2-40B4-BE49-F238E27FC236}">
-                <a16:creationId xmlns:a16="http://schemas.microsoft.com/office/drawing/2014/main" id="{5958118B-7ECC-44F4-B343-983429AD934E}"/>
+                <a16:creationId xmlns:a16="http://schemas.microsoft.com/office/drawing/2014/main" id="{38F255F3-3A40-4309-B84F-CD5E94F1EC98}"/>
               </a:ext>
             </a:extLst>
           </p:cNvPr>
@@ -7109,7 +7109,7 @@
           <p:cNvPr id="8" name="">
             <a:extLst xmlns:a="http://schemas.openxmlformats.org/drawingml/2006/main">
               <a:ext uri="{FF2B5EF4-FFF2-40B4-BE49-F238E27FC236}">
-                <a16:creationId xmlns:a16="http://schemas.microsoft.com/office/drawing/2014/main" id="{AC33DE70-4F52-4D9F-8748-9BB26F41543A}"/>
+                <a16:creationId xmlns:a16="http://schemas.microsoft.com/office/drawing/2014/main" id="{376D2C89-7F50-467E-A8B3-C5E7002B8365}"/>
               </a:ext>
             </a:extLst>
           </p:cNvPr>
@@ -7166,18 +7166,18 @@
           <p:cNvPr id="9" name="">
             <a:extLst xmlns:a="http://schemas.openxmlformats.org/drawingml/2006/main">
               <a:ext uri="{FF2B5EF4-FFF2-40B4-BE49-F238E27FC236}">
-                <a16:creationId xmlns:a16="http://schemas.microsoft.com/office/drawing/2014/main" id="{83E04C3D-934D-4D42-91D1-E8EB7EBB4204}"/>
-              </a:ext>
-            </a:extLst>
-          </p:cNvPr>
-          <p:cNvSpPr>
-            <a:spLocks xmlns:a="http://schemas.openxmlformats.org/drawingml/2006/main" noGrp="1"/>
-          </p:cNvSpPr>
-          <p:nvPr/>
-        </p:nvSpPr>
-        <p:spPr>
-          <a:xfrm xmlns:a="http://schemas.openxmlformats.org/drawingml/2006/main">
-            <a:off x="685800" y="3724275"/>
+                <a16:creationId xmlns:a16="http://schemas.microsoft.com/office/drawing/2014/main" id="{08266346-4534-4DDF-9225-0B5436629553}"/>
+              </a:ext>
+            </a:extLst>
+          </p:cNvPr>
+          <p:cNvSpPr>
+            <a:spLocks xmlns:a="http://schemas.openxmlformats.org/drawingml/2006/main" noGrp="1"/>
+          </p:cNvSpPr>
+          <p:nvPr/>
+        </p:nvSpPr>
+        <p:spPr>
+          <a:xfrm xmlns:a="http://schemas.openxmlformats.org/drawingml/2006/main">
+            <a:off x="685800" y="3476625"/>
             <a:ext cx="10668000" cy="0"/>
           </a:xfrm>
           <a:prstGeom xmlns:a="http://schemas.openxmlformats.org/drawingml/2006/main" prst="line">
@@ -7196,19 +7196,19 @@
           <p:cNvPr id="10" name="">
             <a:extLst xmlns:a="http://schemas.openxmlformats.org/drawingml/2006/main">
               <a:ext uri="{FF2B5EF4-FFF2-40B4-BE49-F238E27FC236}">
-                <a16:creationId xmlns:a16="http://schemas.microsoft.com/office/drawing/2014/main" id="{E36353AE-FADC-49CF-9126-4198857127DC}"/>
-              </a:ext>
-            </a:extLst>
-          </p:cNvPr>
-          <p:cNvSpPr>
-            <a:spLocks xmlns:a="http://schemas.openxmlformats.org/drawingml/2006/main" noGrp="1"/>
-          </p:cNvSpPr>
-          <p:nvPr/>
-        </p:nvSpPr>
-        <p:spPr>
-          <a:xfrm xmlns:a="http://schemas.openxmlformats.org/drawingml/2006/main">
-            <a:off x="685800" y="4095750"/>
-            <a:ext cx="1809750" cy="381000"/>
+                <a16:creationId xmlns:a16="http://schemas.microsoft.com/office/drawing/2014/main" id="{092BA08B-458B-4C20-A169-C871BE597885}"/>
+              </a:ext>
+            </a:extLst>
+          </p:cNvPr>
+          <p:cNvSpPr>
+            <a:spLocks xmlns:a="http://schemas.openxmlformats.org/drawingml/2006/main" noGrp="1"/>
+          </p:cNvSpPr>
+          <p:nvPr/>
+        </p:nvSpPr>
+        <p:spPr>
+          <a:xfrm xmlns:a="http://schemas.openxmlformats.org/drawingml/2006/main">
+            <a:off x="685800" y="3800475"/>
+            <a:ext cx="2000250" cy="381000"/>
           </a:xfrm>
           <a:prstGeom xmlns:a="http://schemas.openxmlformats.org/drawingml/2006/main" prst="rect">
             <a:avLst/>
@@ -7243,7 +7243,7 @@
                 <a:ea typeface="Noto Sans KR"/>
                 <a:cs typeface="Noto Sans KR"/>
               </a:rPr>
-              <a:t>다음 검증</a:t>
+              <a:t>다음 구현 계획</a:t>
             </a:r>
           </a:p>
         </p:txBody>
@@ -7253,36 +7253,93 @@
           <p:cNvPr id="11" name="">
             <a:extLst xmlns:a="http://schemas.openxmlformats.org/drawingml/2006/main">
               <a:ext uri="{FF2B5EF4-FFF2-40B4-BE49-F238E27FC236}">
-                <a16:creationId xmlns:a16="http://schemas.microsoft.com/office/drawing/2014/main" id="{CC7297F7-3A95-4FF8-8FAA-785F716808F3}"/>
-              </a:ext>
-            </a:extLst>
-          </p:cNvPr>
-          <p:cNvSpPr>
-            <a:spLocks xmlns:a="http://schemas.openxmlformats.org/drawingml/2006/main" noGrp="1"/>
-          </p:cNvSpPr>
-          <p:nvPr/>
-        </p:nvSpPr>
-        <p:spPr>
-          <a:xfrm xmlns:a="http://schemas.openxmlformats.org/drawingml/2006/main">
-            <a:off x="2762250" y="4019550"/>
-            <a:ext cx="8286750" cy="1047750"/>
-          </a:xfrm>
-          <a:prstGeom xmlns:a="http://schemas.openxmlformats.org/drawingml/2006/main" prst="rect">
-            <a:avLst/>
-          </a:prstGeom>
-          <a:noFill xmlns:a="http://schemas.openxmlformats.org/drawingml/2006/main"/>
-          <a:ln xmlns:a="http://schemas.openxmlformats.org/drawingml/2006/main" w="0">
-            <a:noFill/>
-          </a:ln>
-        </p:spPr>
-        <p:txBody>
-          <a:bodyPr xmlns:a="http://schemas.openxmlformats.org/drawingml/2006/main">
-            <a:noAutofit/>
-          </a:bodyPr>
-          <a:lstStyle xmlns:a="http://schemas.openxmlformats.org/drawingml/2006/main"/>
-          <a:p xmlns:a="http://schemas.openxmlformats.org/drawingml/2006/main">
-            <a:pPr algn="l">
-              <a:defRPr sz="2325" b="1">
+                <a16:creationId xmlns:a16="http://schemas.microsoft.com/office/drawing/2014/main" id="{0B371E5D-6C86-4AEB-8CCB-1BD66E6F8099}"/>
+              </a:ext>
+            </a:extLst>
+          </p:cNvPr>
+          <p:cNvSpPr>
+            <a:spLocks xmlns:a="http://schemas.openxmlformats.org/drawingml/2006/main" noGrp="1"/>
+          </p:cNvSpPr>
+          <p:nvPr/>
+        </p:nvSpPr>
+        <p:spPr>
+          <a:xfrm xmlns:a="http://schemas.openxmlformats.org/drawingml/2006/main">
+            <a:off x="2838450" y="3810000"/>
+            <a:ext cx="523875" cy="342900"/>
+          </a:xfrm>
+          <a:prstGeom xmlns:a="http://schemas.openxmlformats.org/drawingml/2006/main" prst="rect">
+            <a:avLst/>
+          </a:prstGeom>
+          <a:noFill xmlns:a="http://schemas.openxmlformats.org/drawingml/2006/main"/>
+          <a:ln xmlns:a="http://schemas.openxmlformats.org/drawingml/2006/main" w="0">
+            <a:noFill/>
+          </a:ln>
+        </p:spPr>
+        <p:txBody>
+          <a:bodyPr xmlns:a="http://schemas.openxmlformats.org/drawingml/2006/main">
+            <a:noAutofit/>
+          </a:bodyPr>
+          <a:lstStyle xmlns:a="http://schemas.openxmlformats.org/drawingml/2006/main"/>
+          <a:p xmlns:a="http://schemas.openxmlformats.org/drawingml/2006/main">
+            <a:pPr algn="l">
+              <a:defRPr sz="1575" b="1">
+                <a:solidFill>
+                  <a:srgbClr val="865C46"/>
+                </a:solidFill>
+                <a:latin typeface="Noto Sans KR"/>
+                <a:ea typeface="Noto Sans KR"/>
+                <a:cs typeface="Noto Sans KR"/>
+              </a:defRPr>
+            </a:pPr>
+            <a:r>
+              <a:rPr sz="1575" b="1">
+                <a:solidFill>
+                  <a:srgbClr val="865C46"/>
+                </a:solidFill>
+                <a:latin typeface="Noto Sans KR"/>
+                <a:ea typeface="Noto Sans KR"/>
+                <a:cs typeface="Noto Sans KR"/>
+              </a:rPr>
+              <a:t>01</a:t>
+            </a:r>
+          </a:p>
+        </p:txBody>
+      </p:sp>
+      <p:sp>
+        <p:nvSpPr>
+          <p:cNvPr id="12" name="">
+            <a:extLst xmlns:a="http://schemas.openxmlformats.org/drawingml/2006/main">
+              <a:ext uri="{FF2B5EF4-FFF2-40B4-BE49-F238E27FC236}">
+                <a16:creationId xmlns:a16="http://schemas.microsoft.com/office/drawing/2014/main" id="{AFD71A96-A9FF-482D-899C-1BF2E951FEF1}"/>
+              </a:ext>
+            </a:extLst>
+          </p:cNvPr>
+          <p:cNvSpPr>
+            <a:spLocks xmlns:a="http://schemas.openxmlformats.org/drawingml/2006/main" noGrp="1"/>
+          </p:cNvSpPr>
+          <p:nvPr/>
+        </p:nvSpPr>
+        <p:spPr>
+          <a:xfrm xmlns:a="http://schemas.openxmlformats.org/drawingml/2006/main">
+            <a:off x="3429000" y="3781425"/>
+            <a:ext cx="7810500" cy="400050"/>
+          </a:xfrm>
+          <a:prstGeom xmlns:a="http://schemas.openxmlformats.org/drawingml/2006/main" prst="rect">
+            <a:avLst/>
+          </a:prstGeom>
+          <a:noFill xmlns:a="http://schemas.openxmlformats.org/drawingml/2006/main"/>
+          <a:ln xmlns:a="http://schemas.openxmlformats.org/drawingml/2006/main" w="0">
+            <a:noFill/>
+          </a:ln>
+        </p:spPr>
+        <p:txBody>
+          <a:bodyPr xmlns:a="http://schemas.openxmlformats.org/drawingml/2006/main">
+            <a:noAutofit/>
+          </a:bodyPr>
+          <a:lstStyle xmlns:a="http://schemas.openxmlformats.org/drawingml/2006/main"/>
+          <a:p xmlns:a="http://schemas.openxmlformats.org/drawingml/2006/main">
+            <a:pPr algn="l">
+              <a:defRPr sz="1875" b="1">
                 <a:solidFill>
                   <a:srgbClr val="F7F2EA"/>
                 </a:solidFill>
@@ -7292,7 +7349,7 @@
               </a:defRPr>
             </a:pPr>
             <a:r>
-              <a:rPr sz="2325" b="1">
+              <a:rPr sz="1875" b="1">
                 <a:solidFill>
                   <a:srgbClr val="F7F2EA"/>
                 </a:solidFill>
@@ -7300,12 +7357,103 @@
                 <a:ea typeface="Noto Sans KR"/>
                 <a:cs typeface="Noto Sans KR"/>
               </a:rPr>
-              <a:t>3명에게 막힌 지점을 찾고, 5명 시험에서</a:t>
-            </a:r>
-          </a:p>
-          <a:p xmlns:a="http://schemas.openxmlformats.org/drawingml/2006/main">
-            <a:pPr algn="l">
-              <a:defRPr sz="2325" b="1">
+              <a:t>3명 관찰과 5명 시험으로 막히는 위치와 시간 단축을 확인</a:t>
+            </a:r>
+          </a:p>
+        </p:txBody>
+      </p:sp>
+      <p:sp>
+        <p:nvSpPr>
+          <p:cNvPr id="13" name="">
+            <a:extLst xmlns:a="http://schemas.openxmlformats.org/drawingml/2006/main">
+              <a:ext uri="{FF2B5EF4-FFF2-40B4-BE49-F238E27FC236}">
+                <a16:creationId xmlns:a16="http://schemas.microsoft.com/office/drawing/2014/main" id="{B9AB395D-0E1A-4037-9FFD-4960804D5BC0}"/>
+              </a:ext>
+            </a:extLst>
+          </p:cNvPr>
+          <p:cNvSpPr>
+            <a:spLocks xmlns:a="http://schemas.openxmlformats.org/drawingml/2006/main" noGrp="1"/>
+          </p:cNvSpPr>
+          <p:nvPr/>
+        </p:nvSpPr>
+        <p:spPr>
+          <a:xfrm xmlns:a="http://schemas.openxmlformats.org/drawingml/2006/main">
+            <a:off x="2838450" y="4457700"/>
+            <a:ext cx="523875" cy="342900"/>
+          </a:xfrm>
+          <a:prstGeom xmlns:a="http://schemas.openxmlformats.org/drawingml/2006/main" prst="rect">
+            <a:avLst/>
+          </a:prstGeom>
+          <a:noFill xmlns:a="http://schemas.openxmlformats.org/drawingml/2006/main"/>
+          <a:ln xmlns:a="http://schemas.openxmlformats.org/drawingml/2006/main" w="0">
+            <a:noFill/>
+          </a:ln>
+        </p:spPr>
+        <p:txBody>
+          <a:bodyPr xmlns:a="http://schemas.openxmlformats.org/drawingml/2006/main">
+            <a:noAutofit/>
+          </a:bodyPr>
+          <a:lstStyle xmlns:a="http://schemas.openxmlformats.org/drawingml/2006/main"/>
+          <a:p xmlns:a="http://schemas.openxmlformats.org/drawingml/2006/main">
+            <a:pPr algn="l">
+              <a:defRPr sz="1575" b="1">
+                <a:solidFill>
+                  <a:srgbClr val="865C46"/>
+                </a:solidFill>
+                <a:latin typeface="Noto Sans KR"/>
+                <a:ea typeface="Noto Sans KR"/>
+                <a:cs typeface="Noto Sans KR"/>
+              </a:defRPr>
+            </a:pPr>
+            <a:r>
+              <a:rPr sz="1575" b="1">
+                <a:solidFill>
+                  <a:srgbClr val="865C46"/>
+                </a:solidFill>
+                <a:latin typeface="Noto Sans KR"/>
+                <a:ea typeface="Noto Sans KR"/>
+                <a:cs typeface="Noto Sans KR"/>
+              </a:rPr>
+              <a:t>02</a:t>
+            </a:r>
+          </a:p>
+        </p:txBody>
+      </p:sp>
+      <p:sp>
+        <p:nvSpPr>
+          <p:cNvPr id="14" name="">
+            <a:extLst xmlns:a="http://schemas.openxmlformats.org/drawingml/2006/main">
+              <a:ext uri="{FF2B5EF4-FFF2-40B4-BE49-F238E27FC236}">
+                <a16:creationId xmlns:a16="http://schemas.microsoft.com/office/drawing/2014/main" id="{A7EB0065-F287-4ED0-B6D7-D3E8555FB980}"/>
+              </a:ext>
+            </a:extLst>
+          </p:cNvPr>
+          <p:cNvSpPr>
+            <a:spLocks xmlns:a="http://schemas.openxmlformats.org/drawingml/2006/main" noGrp="1"/>
+          </p:cNvSpPr>
+          <p:nvPr/>
+        </p:nvSpPr>
+        <p:spPr>
+          <a:xfrm xmlns:a="http://schemas.openxmlformats.org/drawingml/2006/main">
+            <a:off x="3429000" y="4429125"/>
+            <a:ext cx="7810500" cy="400050"/>
+          </a:xfrm>
+          <a:prstGeom xmlns:a="http://schemas.openxmlformats.org/drawingml/2006/main" prst="rect">
+            <a:avLst/>
+          </a:prstGeom>
+          <a:noFill xmlns:a="http://schemas.openxmlformats.org/drawingml/2006/main"/>
+          <a:ln xmlns:a="http://schemas.openxmlformats.org/drawingml/2006/main" w="0">
+            <a:noFill/>
+          </a:ln>
+        </p:spPr>
+        <p:txBody>
+          <a:bodyPr xmlns:a="http://schemas.openxmlformats.org/drawingml/2006/main">
+            <a:noAutofit/>
+          </a:bodyPr>
+          <a:lstStyle xmlns:a="http://schemas.openxmlformats.org/drawingml/2006/main"/>
+          <a:p xmlns:a="http://schemas.openxmlformats.org/drawingml/2006/main">
+            <a:pPr algn="l">
+              <a:defRPr sz="1875" b="1">
                 <a:solidFill>
                   <a:srgbClr val="F7F2EA"/>
                 </a:solidFill>
@@ -7315,7 +7463,7 @@
               </a:defRPr>
             </a:pPr>
             <a:r>
-              <a:rPr sz="2325" b="1">
+              <a:rPr sz="1875" b="1">
                 <a:solidFill>
                   <a:srgbClr val="F7F2EA"/>
                 </a:solidFill>
@@ -7323,28 +7471,142 @@
                 <a:ea typeface="Noto Sans KR"/>
                 <a:cs typeface="Noto Sans KR"/>
               </a:rPr>
-              <a:t>정리 시간과 생각의 확장이 재현되는지 확인</a:t>
-            </a:r>
-          </a:p>
-        </p:txBody>
-      </p:sp>
-      <p:sp>
-        <p:nvSpPr>
-          <p:cNvPr id="12" name="">
-            <a:extLst xmlns:a="http://schemas.openxmlformats.org/drawingml/2006/main">
-              <a:ext uri="{FF2B5EF4-FFF2-40B4-BE49-F238E27FC236}">
-                <a16:creationId xmlns:a16="http://schemas.microsoft.com/office/drawing/2014/main" id="{D76164BE-B507-4179-A9D7-5FC0315E9AB2}"/>
-              </a:ext>
-            </a:extLst>
-          </p:cNvPr>
-          <p:cNvSpPr>
-            <a:spLocks xmlns:a="http://schemas.openxmlformats.org/drawingml/2006/main" noGrp="1"/>
-          </p:cNvSpPr>
-          <p:nvPr/>
-        </p:nvSpPr>
-        <p:spPr>
-          <a:xfrm xmlns:a="http://schemas.openxmlformats.org/drawingml/2006/main">
-            <a:off x="685800" y="5810250"/>
+              <a:t>여러 사용자가 쓰는 단계에서 계정 로그인과 사용자별 기록 권한 구현</a:t>
+            </a:r>
+          </a:p>
+        </p:txBody>
+      </p:sp>
+      <p:sp>
+        <p:nvSpPr>
+          <p:cNvPr id="15" name="">
+            <a:extLst xmlns:a="http://schemas.openxmlformats.org/drawingml/2006/main">
+              <a:ext uri="{FF2B5EF4-FFF2-40B4-BE49-F238E27FC236}">
+                <a16:creationId xmlns:a16="http://schemas.microsoft.com/office/drawing/2014/main" id="{A5D3229B-A237-459D-A718-622F4BB75A49}"/>
+              </a:ext>
+            </a:extLst>
+          </p:cNvPr>
+          <p:cNvSpPr>
+            <a:spLocks xmlns:a="http://schemas.openxmlformats.org/drawingml/2006/main" noGrp="1"/>
+          </p:cNvSpPr>
+          <p:nvPr/>
+        </p:nvSpPr>
+        <p:spPr>
+          <a:xfrm xmlns:a="http://schemas.openxmlformats.org/drawingml/2006/main">
+            <a:off x="2838450" y="5105400"/>
+            <a:ext cx="523875" cy="342900"/>
+          </a:xfrm>
+          <a:prstGeom xmlns:a="http://schemas.openxmlformats.org/drawingml/2006/main" prst="rect">
+            <a:avLst/>
+          </a:prstGeom>
+          <a:noFill xmlns:a="http://schemas.openxmlformats.org/drawingml/2006/main"/>
+          <a:ln xmlns:a="http://schemas.openxmlformats.org/drawingml/2006/main" w="0">
+            <a:noFill/>
+          </a:ln>
+        </p:spPr>
+        <p:txBody>
+          <a:bodyPr xmlns:a="http://schemas.openxmlformats.org/drawingml/2006/main">
+            <a:noAutofit/>
+          </a:bodyPr>
+          <a:lstStyle xmlns:a="http://schemas.openxmlformats.org/drawingml/2006/main"/>
+          <a:p xmlns:a="http://schemas.openxmlformats.org/drawingml/2006/main">
+            <a:pPr algn="l">
+              <a:defRPr sz="1575" b="1">
+                <a:solidFill>
+                  <a:srgbClr val="865C46"/>
+                </a:solidFill>
+                <a:latin typeface="Noto Sans KR"/>
+                <a:ea typeface="Noto Sans KR"/>
+                <a:cs typeface="Noto Sans KR"/>
+              </a:defRPr>
+            </a:pPr>
+            <a:r>
+              <a:rPr sz="1575" b="1">
+                <a:solidFill>
+                  <a:srgbClr val="865C46"/>
+                </a:solidFill>
+                <a:latin typeface="Noto Sans KR"/>
+                <a:ea typeface="Noto Sans KR"/>
+                <a:cs typeface="Noto Sans KR"/>
+              </a:rPr>
+              <a:t>03</a:t>
+            </a:r>
+          </a:p>
+        </p:txBody>
+      </p:sp>
+      <p:sp>
+        <p:nvSpPr>
+          <p:cNvPr id="16" name="">
+            <a:extLst xmlns:a="http://schemas.openxmlformats.org/drawingml/2006/main">
+              <a:ext uri="{FF2B5EF4-FFF2-40B4-BE49-F238E27FC236}">
+                <a16:creationId xmlns:a16="http://schemas.microsoft.com/office/drawing/2014/main" id="{AB1EC055-43D2-4035-9351-DF340169FD17}"/>
+              </a:ext>
+            </a:extLst>
+          </p:cNvPr>
+          <p:cNvSpPr>
+            <a:spLocks xmlns:a="http://schemas.openxmlformats.org/drawingml/2006/main" noGrp="1"/>
+          </p:cNvSpPr>
+          <p:nvPr/>
+        </p:nvSpPr>
+        <p:spPr>
+          <a:xfrm xmlns:a="http://schemas.openxmlformats.org/drawingml/2006/main">
+            <a:off x="3429000" y="5076825"/>
+            <a:ext cx="7810500" cy="400050"/>
+          </a:xfrm>
+          <a:prstGeom xmlns:a="http://schemas.openxmlformats.org/drawingml/2006/main" prst="rect">
+            <a:avLst/>
+          </a:prstGeom>
+          <a:noFill xmlns:a="http://schemas.openxmlformats.org/drawingml/2006/main"/>
+          <a:ln xmlns:a="http://schemas.openxmlformats.org/drawingml/2006/main" w="0">
+            <a:noFill/>
+          </a:ln>
+        </p:spPr>
+        <p:txBody>
+          <a:bodyPr xmlns:a="http://schemas.openxmlformats.org/drawingml/2006/main">
+            <a:noAutofit/>
+          </a:bodyPr>
+          <a:lstStyle xmlns:a="http://schemas.openxmlformats.org/drawingml/2006/main"/>
+          <a:p xmlns:a="http://schemas.openxmlformats.org/drawingml/2006/main">
+            <a:pPr algn="l">
+              <a:defRPr sz="1875" b="1">
+                <a:solidFill>
+                  <a:srgbClr val="F7F2EA"/>
+                </a:solidFill>
+                <a:latin typeface="Noto Sans KR"/>
+                <a:ea typeface="Noto Sans KR"/>
+                <a:cs typeface="Noto Sans KR"/>
+              </a:defRPr>
+            </a:pPr>
+            <a:r>
+              <a:rPr sz="1875" b="1">
+                <a:solidFill>
+                  <a:srgbClr val="F7F2EA"/>
+                </a:solidFill>
+                <a:latin typeface="Noto Sans KR"/>
+                <a:ea typeface="Noto Sans KR"/>
+                <a:cs typeface="Noto Sans KR"/>
+              </a:rPr>
+              <a:t>반복 사용이 확인되면 검색 필터와 결과물 버전 관리 개선</a:t>
+            </a:r>
+          </a:p>
+        </p:txBody>
+      </p:sp>
+      <p:sp>
+        <p:nvSpPr>
+          <p:cNvPr id="17" name="">
+            <a:extLst xmlns:a="http://schemas.openxmlformats.org/drawingml/2006/main">
+              <a:ext uri="{FF2B5EF4-FFF2-40B4-BE49-F238E27FC236}">
+                <a16:creationId xmlns:a16="http://schemas.microsoft.com/office/drawing/2014/main" id="{55906AF3-856A-4A47-B98B-340DD49C1CBC}"/>
+              </a:ext>
+            </a:extLst>
+          </p:cNvPr>
+          <p:cNvSpPr>
+            <a:spLocks xmlns:a="http://schemas.openxmlformats.org/drawingml/2006/main" noGrp="1"/>
+          </p:cNvSpPr>
+          <p:nvPr/>
+        </p:nvSpPr>
+        <p:spPr>
+          <a:xfrm xmlns:a="http://schemas.openxmlformats.org/drawingml/2006/main">
+            <a:off x="685800" y="5905500"/>
             <a:ext cx="10668000" cy="333375"/>
           </a:xfrm>
           <a:prstGeom xmlns:a="http://schemas.openxmlformats.org/drawingml/2006/main" prst="rect">
@@ -7380,7 +7642,7 @@
                 <a:ea typeface="Noto Sans KR"/>
                 <a:cs typeface="Noto Sans KR"/>
               </a:rPr>
-              <a:t>저장한 맥락을 다시 쓰는 경험이 다른 사용자에게도 도움이 되는지 확인하겠습니다</a:t>
+              <a:t>검증 결과를 확인한 뒤 필요한 기능부터 구현하겠습니다</a:t>
             </a:r>
           </a:p>
         </p:txBody>
@@ -7388,7 +7650,7 @@
     </p:spTree>
     <p:extLst>
       <p:ext uri="{BB962C8B-B14F-4D97-AF65-F5344CB8AC3E}">
-        <p14:creationId xmlns:p14="http://schemas.microsoft.com/office/powerpoint/2010/main" val="686948999"/>
+        <p14:creationId xmlns:p14="http://schemas.microsoft.com/office/powerpoint/2010/main" val="622870741"/>
       </p:ext>
     </p:extLst>
   </p:cSld>
@@ -7419,7 +7681,7 @@
           <p:cNvPr id="19" name="">
             <a:extLst xmlns:a="http://schemas.openxmlformats.org/drawingml/2006/main">
               <a:ext uri="{FF2B5EF4-FFF2-40B4-BE49-F238E27FC236}">
-                <a16:creationId xmlns:a16="http://schemas.microsoft.com/office/drawing/2014/main" id="{323DC78D-1F62-412C-BE4C-D330E6F24666}"/>
+                <a16:creationId xmlns:a16="http://schemas.microsoft.com/office/drawing/2014/main" id="{0D809E80-7F4B-4A9B-9C28-5865EBBB4796}"/>
               </a:ext>
             </a:extLst>
           </p:cNvPr>
@@ -7449,7 +7711,7 @@
           <p:cNvPr id="2" name="">
             <a:extLst xmlns:a="http://schemas.openxmlformats.org/drawingml/2006/main">
               <a:ext uri="{FF2B5EF4-FFF2-40B4-BE49-F238E27FC236}">
-                <a16:creationId xmlns:a16="http://schemas.microsoft.com/office/drawing/2014/main" id="{59FECA49-A710-485B-A5BC-B4312182C3AE}"/>
+                <a16:creationId xmlns:a16="http://schemas.microsoft.com/office/drawing/2014/main" id="{76517AC6-201A-4D9A-9AA1-8EA2BCB86660}"/>
               </a:ext>
             </a:extLst>
           </p:cNvPr>
@@ -7506,7 +7768,7 @@
           <p:cNvPr id="3" name="">
             <a:extLst xmlns:a="http://schemas.openxmlformats.org/drawingml/2006/main">
               <a:ext uri="{FF2B5EF4-FFF2-40B4-BE49-F238E27FC236}">
-                <a16:creationId xmlns:a16="http://schemas.microsoft.com/office/drawing/2014/main" id="{7ADBE61B-3291-4EF1-8FB6-E9833FAB6FC8}"/>
+                <a16:creationId xmlns:a16="http://schemas.microsoft.com/office/drawing/2014/main" id="{60FF1A6D-AE90-4522-A5A3-FCF996261809}"/>
               </a:ext>
             </a:extLst>
           </p:cNvPr>
@@ -7536,7 +7798,7 @@
           <p:cNvPr id="4" name="">
             <a:extLst xmlns:a="http://schemas.openxmlformats.org/drawingml/2006/main">
               <a:ext uri="{FF2B5EF4-FFF2-40B4-BE49-F238E27FC236}">
-                <a16:creationId xmlns:a16="http://schemas.microsoft.com/office/drawing/2014/main" id="{2EFA10E0-7197-4ED5-8498-0EDCE096A055}"/>
+                <a16:creationId xmlns:a16="http://schemas.microsoft.com/office/drawing/2014/main" id="{1E25333D-3CD6-4F00-99EF-5364605BF191}"/>
               </a:ext>
             </a:extLst>
           </p:cNvPr>
@@ -7593,7 +7855,7 @@
           <p:cNvPr id="5" name="">
             <a:extLst xmlns:a="http://schemas.openxmlformats.org/drawingml/2006/main">
               <a:ext uri="{FF2B5EF4-FFF2-40B4-BE49-F238E27FC236}">
-                <a16:creationId xmlns:a16="http://schemas.microsoft.com/office/drawing/2014/main" id="{3D007CDE-6061-4092-ADC1-9C4EF2EBAE18}"/>
+                <a16:creationId xmlns:a16="http://schemas.microsoft.com/office/drawing/2014/main" id="{80EFDD51-9818-4778-B290-8219CEB081B7}"/>
               </a:ext>
             </a:extLst>
           </p:cNvPr>
@@ -7650,7 +7912,7 @@
           <p:cNvPr id="6" name="">
             <a:extLst xmlns:a="http://schemas.openxmlformats.org/drawingml/2006/main">
               <a:ext uri="{FF2B5EF4-FFF2-40B4-BE49-F238E27FC236}">
-                <a16:creationId xmlns:a16="http://schemas.microsoft.com/office/drawing/2014/main" id="{D271B616-071F-458E-BC9A-871AEB873F25}"/>
+                <a16:creationId xmlns:a16="http://schemas.microsoft.com/office/drawing/2014/main" id="{C5681EAB-1E9A-4569-8B1E-1A68850D40F2}"/>
               </a:ext>
             </a:extLst>
           </p:cNvPr>
@@ -7730,7 +7992,7 @@
           <p:cNvPr id="7" name="">
             <a:extLst xmlns:a="http://schemas.openxmlformats.org/drawingml/2006/main">
               <a:ext uri="{FF2B5EF4-FFF2-40B4-BE49-F238E27FC236}">
-                <a16:creationId xmlns:a16="http://schemas.microsoft.com/office/drawing/2014/main" id="{664353D3-FA5E-43C3-A482-01CA08821EFE}"/>
+                <a16:creationId xmlns:a16="http://schemas.microsoft.com/office/drawing/2014/main" id="{BE56AC31-8223-4DE0-B173-48C39FCB1FF8}"/>
               </a:ext>
             </a:extLst>
           </p:cNvPr>
@@ -7787,7 +8049,7 @@
           <p:cNvPr id="8" name="">
             <a:extLst xmlns:a="http://schemas.openxmlformats.org/drawingml/2006/main">
               <a:ext uri="{FF2B5EF4-FFF2-40B4-BE49-F238E27FC236}">
-                <a16:creationId xmlns:a16="http://schemas.microsoft.com/office/drawing/2014/main" id="{AEFF87DE-571D-4BE8-A3ED-2E2A0E160B9F}"/>
+                <a16:creationId xmlns:a16="http://schemas.microsoft.com/office/drawing/2014/main" id="{DE91129E-9046-460E-9D15-771742A51737}"/>
               </a:ext>
             </a:extLst>
           </p:cNvPr>
@@ -7867,7 +8129,7 @@
           <p:cNvPr id="9" name="">
             <a:extLst xmlns:a="http://schemas.openxmlformats.org/drawingml/2006/main">
               <a:ext uri="{FF2B5EF4-FFF2-40B4-BE49-F238E27FC236}">
-                <a16:creationId xmlns:a16="http://schemas.microsoft.com/office/drawing/2014/main" id="{B7D9E5F4-F99A-48ED-AD5E-EE58E055D35A}"/>
+                <a16:creationId xmlns:a16="http://schemas.microsoft.com/office/drawing/2014/main" id="{4C91B3F4-BFC5-4579-8D4D-8A4368886A22}"/>
               </a:ext>
             </a:extLst>
           </p:cNvPr>
@@ -7924,7 +8186,7 @@
           <p:cNvPr id="10" name="">
             <a:extLst xmlns:a="http://schemas.openxmlformats.org/drawingml/2006/main">
               <a:ext uri="{FF2B5EF4-FFF2-40B4-BE49-F238E27FC236}">
-                <a16:creationId xmlns:a16="http://schemas.microsoft.com/office/drawing/2014/main" id="{C8CE2233-A940-442E-AB15-EA326E649477}"/>
+                <a16:creationId xmlns:a16="http://schemas.microsoft.com/office/drawing/2014/main" id="{876DED59-8F44-4D12-BFB8-3F54E58F6371}"/>
               </a:ext>
             </a:extLst>
           </p:cNvPr>
@@ -8027,7 +8289,7 @@
           <p:cNvPr id="11" name="">
             <a:extLst xmlns:a="http://schemas.openxmlformats.org/drawingml/2006/main">
               <a:ext uri="{FF2B5EF4-FFF2-40B4-BE49-F238E27FC236}">
-                <a16:creationId xmlns:a16="http://schemas.microsoft.com/office/drawing/2014/main" id="{CFB81EF7-5A15-4759-B2C7-1A93FB4220B2}"/>
+                <a16:creationId xmlns:a16="http://schemas.microsoft.com/office/drawing/2014/main" id="{F08FF74B-C0DA-43BF-B18B-69A52B789BF2}"/>
               </a:ext>
             </a:extLst>
           </p:cNvPr>
@@ -8084,7 +8346,7 @@
           <p:cNvPr id="12" name="">
             <a:extLst xmlns:a="http://schemas.openxmlformats.org/drawingml/2006/main">
               <a:ext uri="{FF2B5EF4-FFF2-40B4-BE49-F238E27FC236}">
-                <a16:creationId xmlns:a16="http://schemas.microsoft.com/office/drawing/2014/main" id="{5A5345A3-09A9-43C5-87CA-9D33CECC4DD6}"/>
+                <a16:creationId xmlns:a16="http://schemas.microsoft.com/office/drawing/2014/main" id="{07E2AEBE-9DE1-4D87-B338-2EF35ACEB959}"/>
               </a:ext>
             </a:extLst>
           </p:cNvPr>
@@ -8187,7 +8449,7 @@
           <p:cNvPr id="13" name="">
             <a:extLst xmlns:a="http://schemas.openxmlformats.org/drawingml/2006/main">
               <a:ext uri="{FF2B5EF4-FFF2-40B4-BE49-F238E27FC236}">
-                <a16:creationId xmlns:a16="http://schemas.microsoft.com/office/drawing/2014/main" id="{08072128-5241-4765-8200-6193A90FFF7B}"/>
+                <a16:creationId xmlns:a16="http://schemas.microsoft.com/office/drawing/2014/main" id="{5A0F4B83-8E4A-425D-925E-B32B02CF25CB}"/>
               </a:ext>
             </a:extLst>
           </p:cNvPr>
@@ -8244,7 +8506,7 @@
           <p:cNvPr id="14" name="">
             <a:extLst xmlns:a="http://schemas.openxmlformats.org/drawingml/2006/main">
               <a:ext uri="{FF2B5EF4-FFF2-40B4-BE49-F238E27FC236}">
-                <a16:creationId xmlns:a16="http://schemas.microsoft.com/office/drawing/2014/main" id="{9F979232-139D-4300-B314-436C7C1A3D7C}"/>
+                <a16:creationId xmlns:a16="http://schemas.microsoft.com/office/drawing/2014/main" id="{1D6FC5DF-D4CE-4F00-89C4-7B7CAF6BCB57}"/>
               </a:ext>
             </a:extLst>
           </p:cNvPr>
@@ -8301,7 +8563,7 @@
           <p:cNvPr id="15" name="">
             <a:extLst xmlns:a="http://schemas.openxmlformats.org/drawingml/2006/main">
               <a:ext uri="{FF2B5EF4-FFF2-40B4-BE49-F238E27FC236}">
-                <a16:creationId xmlns:a16="http://schemas.microsoft.com/office/drawing/2014/main" id="{5D0131B7-09A1-46B5-BCA4-B3030540EBF0}"/>
+                <a16:creationId xmlns:a16="http://schemas.microsoft.com/office/drawing/2014/main" id="{8E8FE15D-E32C-405E-9023-A9259F88A469}"/>
               </a:ext>
             </a:extLst>
           </p:cNvPr>
@@ -8358,7 +8620,7 @@
           <p:cNvPr id="16" name="">
             <a:extLst xmlns:a="http://schemas.openxmlformats.org/drawingml/2006/main">
               <a:ext uri="{FF2B5EF4-FFF2-40B4-BE49-F238E27FC236}">
-                <a16:creationId xmlns:a16="http://schemas.microsoft.com/office/drawing/2014/main" id="{564204B0-6FFC-468B-A9C0-7916998EA89D}"/>
+                <a16:creationId xmlns:a16="http://schemas.microsoft.com/office/drawing/2014/main" id="{2502DF1B-AA10-4663-8519-B9796973A113}"/>
               </a:ext>
             </a:extLst>
           </p:cNvPr>
@@ -8388,7 +8650,7 @@
           <p:cNvPr id="17" name="">
             <a:extLst xmlns:a="http://schemas.openxmlformats.org/drawingml/2006/main">
               <a:ext uri="{FF2B5EF4-FFF2-40B4-BE49-F238E27FC236}">
-                <a16:creationId xmlns:a16="http://schemas.microsoft.com/office/drawing/2014/main" id="{891D9AF2-A6D5-469E-9A6B-F1109C5A21CF}"/>
+                <a16:creationId xmlns:a16="http://schemas.microsoft.com/office/drawing/2014/main" id="{64FC5DD0-E4B7-47D7-A69F-A5B55E9BE235}"/>
               </a:ext>
             </a:extLst>
           </p:cNvPr>
@@ -8445,7 +8707,7 @@
           <p:cNvPr id="18" name="">
             <a:extLst xmlns:a="http://schemas.openxmlformats.org/drawingml/2006/main">
               <a:ext uri="{FF2B5EF4-FFF2-40B4-BE49-F238E27FC236}">
-                <a16:creationId xmlns:a16="http://schemas.microsoft.com/office/drawing/2014/main" id="{BCEEE817-C04D-4A99-BA83-E5C99F6A64DD}"/>
+                <a16:creationId xmlns:a16="http://schemas.microsoft.com/office/drawing/2014/main" id="{EAC6106A-70DE-4CB6-87F8-D0D65F3FA019}"/>
               </a:ext>
             </a:extLst>
           </p:cNvPr>
@@ -8523,7 +8785,7 @@
     </p:spTree>
     <p:extLst>
       <p:ext uri="{BB962C8B-B14F-4D97-AF65-F5344CB8AC3E}">
-        <p14:creationId xmlns:p14="http://schemas.microsoft.com/office/powerpoint/2010/main" val="1013457757"/>
+        <p14:creationId xmlns:p14="http://schemas.microsoft.com/office/powerpoint/2010/main" val="1834696863"/>
       </p:ext>
     </p:extLst>
   </p:cSld>
@@ -8554,7 +8816,7 @@
           <p:cNvPr id="19" name="">
             <a:extLst xmlns:a="http://schemas.openxmlformats.org/drawingml/2006/main">
               <a:ext uri="{FF2B5EF4-FFF2-40B4-BE49-F238E27FC236}">
-                <a16:creationId xmlns:a16="http://schemas.microsoft.com/office/drawing/2014/main" id="{EDC1E92A-CE0D-4BC4-8AFE-A1289A959F99}"/>
+                <a16:creationId xmlns:a16="http://schemas.microsoft.com/office/drawing/2014/main" id="{DF0F2D52-B5C1-460D-8050-584B2939BCE9}"/>
               </a:ext>
             </a:extLst>
           </p:cNvPr>
@@ -8584,7 +8846,7 @@
           <p:cNvPr id="2" name="">
             <a:extLst xmlns:a="http://schemas.openxmlformats.org/drawingml/2006/main">
               <a:ext uri="{FF2B5EF4-FFF2-40B4-BE49-F238E27FC236}">
-                <a16:creationId xmlns:a16="http://schemas.microsoft.com/office/drawing/2014/main" id="{9CB40D5C-5603-4ABE-9546-9B0EE45EF7E4}"/>
+                <a16:creationId xmlns:a16="http://schemas.microsoft.com/office/drawing/2014/main" id="{9F9B99EB-0490-4122-B67B-CFE66C5B87B0}"/>
               </a:ext>
             </a:extLst>
           </p:cNvPr>
@@ -8641,7 +8903,7 @@
           <p:cNvPr id="3" name="">
             <a:extLst xmlns:a="http://schemas.openxmlformats.org/drawingml/2006/main">
               <a:ext uri="{FF2B5EF4-FFF2-40B4-BE49-F238E27FC236}">
-                <a16:creationId xmlns:a16="http://schemas.microsoft.com/office/drawing/2014/main" id="{8F54F162-E2CD-4D41-97B2-48579EDFD205}"/>
+                <a16:creationId xmlns:a16="http://schemas.microsoft.com/office/drawing/2014/main" id="{FFA6EA54-2D3D-44EE-AEA4-64DC643C9E0F}"/>
               </a:ext>
             </a:extLst>
           </p:cNvPr>
@@ -8671,7 +8933,7 @@
           <p:cNvPr id="4" name="">
             <a:extLst xmlns:a="http://schemas.openxmlformats.org/drawingml/2006/main">
               <a:ext uri="{FF2B5EF4-FFF2-40B4-BE49-F238E27FC236}">
-                <a16:creationId xmlns:a16="http://schemas.microsoft.com/office/drawing/2014/main" id="{3754EE50-D5B7-49BB-8A93-36324397E611}"/>
+                <a16:creationId xmlns:a16="http://schemas.microsoft.com/office/drawing/2014/main" id="{E0484149-FA7B-4A7E-A964-DF788392EDBD}"/>
               </a:ext>
             </a:extLst>
           </p:cNvPr>
@@ -8728,7 +8990,7 @@
           <p:cNvPr id="5" name="">
             <a:extLst xmlns:a="http://schemas.openxmlformats.org/drawingml/2006/main">
               <a:ext uri="{FF2B5EF4-FFF2-40B4-BE49-F238E27FC236}">
-                <a16:creationId xmlns:a16="http://schemas.microsoft.com/office/drawing/2014/main" id="{84EE2D07-9C57-4A40-AAAA-EAF03DA26E5F}"/>
+                <a16:creationId xmlns:a16="http://schemas.microsoft.com/office/drawing/2014/main" id="{E4D7FA79-8EF2-480B-B3A2-5F4C18CC03A1}"/>
               </a:ext>
             </a:extLst>
           </p:cNvPr>
@@ -8785,7 +9047,7 @@
           <p:cNvPr id="6" name="">
             <a:extLst xmlns:a="http://schemas.openxmlformats.org/drawingml/2006/main">
               <a:ext uri="{FF2B5EF4-FFF2-40B4-BE49-F238E27FC236}">
-                <a16:creationId xmlns:a16="http://schemas.microsoft.com/office/drawing/2014/main" id="{B8978A5D-DE6D-4108-ADE3-4CF8285EE407}"/>
+                <a16:creationId xmlns:a16="http://schemas.microsoft.com/office/drawing/2014/main" id="{6CCEB68B-912A-4714-8A00-801D3179A5F7}"/>
               </a:ext>
             </a:extLst>
           </p:cNvPr>
@@ -8842,7 +9104,7 @@
           <p:cNvPr id="7" name="">
             <a:extLst xmlns:a="http://schemas.openxmlformats.org/drawingml/2006/main">
               <a:ext uri="{FF2B5EF4-FFF2-40B4-BE49-F238E27FC236}">
-                <a16:creationId xmlns:a16="http://schemas.microsoft.com/office/drawing/2014/main" id="{C9DD8FA0-8E5B-4A42-BE0C-4AC4F06A7B2C}"/>
+                <a16:creationId xmlns:a16="http://schemas.microsoft.com/office/drawing/2014/main" id="{D8E78EA0-9C1A-4B3E-BC30-CB30EAAAE552}"/>
               </a:ext>
             </a:extLst>
           </p:cNvPr>
@@ -8922,7 +9184,7 @@
           <p:cNvPr id="8" name="">
             <a:extLst xmlns:a="http://schemas.openxmlformats.org/drawingml/2006/main">
               <a:ext uri="{FF2B5EF4-FFF2-40B4-BE49-F238E27FC236}">
-                <a16:creationId xmlns:a16="http://schemas.microsoft.com/office/drawing/2014/main" id="{42EAF475-50F3-40BB-8B41-3833C9A5AC41}"/>
+                <a16:creationId xmlns:a16="http://schemas.microsoft.com/office/drawing/2014/main" id="{7051A078-7F98-4A60-B7D7-6A4DDAE70CA7}"/>
               </a:ext>
             </a:extLst>
           </p:cNvPr>
@@ -8952,7 +9214,7 @@
           <p:cNvPr id="9" name="">
             <a:extLst xmlns:a="http://schemas.openxmlformats.org/drawingml/2006/main">
               <a:ext uri="{FF2B5EF4-FFF2-40B4-BE49-F238E27FC236}">
-                <a16:creationId xmlns:a16="http://schemas.microsoft.com/office/drawing/2014/main" id="{E4077367-3CF8-4A46-8FCE-1116FBA8CC9F}"/>
+                <a16:creationId xmlns:a16="http://schemas.microsoft.com/office/drawing/2014/main" id="{2E0299BB-00B5-4712-A3CE-2CBA94B65AEB}"/>
               </a:ext>
             </a:extLst>
           </p:cNvPr>
@@ -9009,7 +9271,7 @@
           <p:cNvPr id="10" name="">
             <a:extLst xmlns:a="http://schemas.openxmlformats.org/drawingml/2006/main">
               <a:ext uri="{FF2B5EF4-FFF2-40B4-BE49-F238E27FC236}">
-                <a16:creationId xmlns:a16="http://schemas.microsoft.com/office/drawing/2014/main" id="{3CB4FA00-DFDC-4BC5-BD00-DF2903E2BEBF}"/>
+                <a16:creationId xmlns:a16="http://schemas.microsoft.com/office/drawing/2014/main" id="{F67807EA-0857-4D6D-A005-510778772E54}"/>
               </a:ext>
             </a:extLst>
           </p:cNvPr>
@@ -9066,7 +9328,7 @@
           <p:cNvPr id="11" name="">
             <a:extLst xmlns:a="http://schemas.openxmlformats.org/drawingml/2006/main">
               <a:ext uri="{FF2B5EF4-FFF2-40B4-BE49-F238E27FC236}">
-                <a16:creationId xmlns:a16="http://schemas.microsoft.com/office/drawing/2014/main" id="{12AE1535-6C9F-400E-84B8-461B6254B8CD}"/>
+                <a16:creationId xmlns:a16="http://schemas.microsoft.com/office/drawing/2014/main" id="{2D65D83E-3E23-433A-A53C-5B8B874F6EEB}"/>
               </a:ext>
             </a:extLst>
           </p:cNvPr>
@@ -9146,7 +9408,7 @@
           <p:cNvPr id="12" name="">
             <a:extLst xmlns:a="http://schemas.openxmlformats.org/drawingml/2006/main">
               <a:ext uri="{FF2B5EF4-FFF2-40B4-BE49-F238E27FC236}">
-                <a16:creationId xmlns:a16="http://schemas.microsoft.com/office/drawing/2014/main" id="{185AF6B5-469A-41F0-AB09-C866AB6359BB}"/>
+                <a16:creationId xmlns:a16="http://schemas.microsoft.com/office/drawing/2014/main" id="{E46766D3-FE94-4B0B-9A57-7D2964264BD5}"/>
               </a:ext>
             </a:extLst>
           </p:cNvPr>
@@ -9176,7 +9438,7 @@
           <p:cNvPr id="13" name="">
             <a:extLst xmlns:a="http://schemas.openxmlformats.org/drawingml/2006/main">
               <a:ext uri="{FF2B5EF4-FFF2-40B4-BE49-F238E27FC236}">
-                <a16:creationId xmlns:a16="http://schemas.microsoft.com/office/drawing/2014/main" id="{EDDEDA41-782C-4CBA-B74E-8D89B6C5B93C}"/>
+                <a16:creationId xmlns:a16="http://schemas.microsoft.com/office/drawing/2014/main" id="{36022420-C516-4005-AC58-27D1613A6ABE}"/>
               </a:ext>
             </a:extLst>
           </p:cNvPr>
@@ -9233,7 +9495,7 @@
           <p:cNvPr id="14" name="">
             <a:extLst xmlns:a="http://schemas.openxmlformats.org/drawingml/2006/main">
               <a:ext uri="{FF2B5EF4-FFF2-40B4-BE49-F238E27FC236}">
-                <a16:creationId xmlns:a16="http://schemas.microsoft.com/office/drawing/2014/main" id="{BBE8195D-8AA0-462D-8AB3-AF933655674E}"/>
+                <a16:creationId xmlns:a16="http://schemas.microsoft.com/office/drawing/2014/main" id="{E761C80C-C06C-4A1D-A09B-FD4DDB7C3429}"/>
               </a:ext>
             </a:extLst>
           </p:cNvPr>
@@ -9290,7 +9552,7 @@
           <p:cNvPr id="15" name="">
             <a:extLst xmlns:a="http://schemas.openxmlformats.org/drawingml/2006/main">
               <a:ext uri="{FF2B5EF4-FFF2-40B4-BE49-F238E27FC236}">
-                <a16:creationId xmlns:a16="http://schemas.microsoft.com/office/drawing/2014/main" id="{DBA98273-D14D-432C-95EC-7D903A1AB518}"/>
+                <a16:creationId xmlns:a16="http://schemas.microsoft.com/office/drawing/2014/main" id="{F4ABB504-149D-4430-91F0-AD7699BEDF54}"/>
               </a:ext>
             </a:extLst>
           </p:cNvPr>
@@ -9370,7 +9632,7 @@
           <p:cNvPr id="16" name="">
             <a:extLst xmlns:a="http://schemas.openxmlformats.org/drawingml/2006/main">
               <a:ext uri="{FF2B5EF4-FFF2-40B4-BE49-F238E27FC236}">
-                <a16:creationId xmlns:a16="http://schemas.microsoft.com/office/drawing/2014/main" id="{3A43EBF4-B71D-436E-B303-E7D6DA252614}"/>
+                <a16:creationId xmlns:a16="http://schemas.microsoft.com/office/drawing/2014/main" id="{D32EAAAF-3D51-440E-82D9-450A699AE041}"/>
               </a:ext>
             </a:extLst>
           </p:cNvPr>
@@ -9427,7 +9689,7 @@
           <p:cNvPr id="17" name="">
             <a:extLst xmlns:a="http://schemas.openxmlformats.org/drawingml/2006/main">
               <a:ext uri="{FF2B5EF4-FFF2-40B4-BE49-F238E27FC236}">
-                <a16:creationId xmlns:a16="http://schemas.microsoft.com/office/drawing/2014/main" id="{069DBFD2-491F-4C63-BACD-2FB48B53FEE4}"/>
+                <a16:creationId xmlns:a16="http://schemas.microsoft.com/office/drawing/2014/main" id="{2746FDCD-35A6-43F2-A831-6C95656D4B05}"/>
               </a:ext>
             </a:extLst>
           </p:cNvPr>
@@ -9484,7 +9746,7 @@
           <p:cNvPr id="18" name="">
             <a:extLst xmlns:a="http://schemas.openxmlformats.org/drawingml/2006/main">
               <a:ext uri="{FF2B5EF4-FFF2-40B4-BE49-F238E27FC236}">
-                <a16:creationId xmlns:a16="http://schemas.microsoft.com/office/drawing/2014/main" id="{8F54E190-2E14-4C81-9FCE-8757D421E0EF}"/>
+                <a16:creationId xmlns:a16="http://schemas.microsoft.com/office/drawing/2014/main" id="{2BB1AD69-1121-4AB7-B0D5-8089F09071C3}"/>
               </a:ext>
             </a:extLst>
           </p:cNvPr>
@@ -9539,7 +9801,7 @@
     </p:spTree>
     <p:extLst>
       <p:ext uri="{BB962C8B-B14F-4D97-AF65-F5344CB8AC3E}">
-        <p14:creationId xmlns:p14="http://schemas.microsoft.com/office/powerpoint/2010/main" val="898003431"/>
+        <p14:creationId xmlns:p14="http://schemas.microsoft.com/office/powerpoint/2010/main" val="1467454721"/>
       </p:ext>
     </p:extLst>
   </p:cSld>
@@ -9570,7 +9832,7 @@
           <p:cNvPr id="18" name="">
             <a:extLst xmlns:a="http://schemas.openxmlformats.org/drawingml/2006/main">
               <a:ext uri="{FF2B5EF4-FFF2-40B4-BE49-F238E27FC236}">
-                <a16:creationId xmlns:a16="http://schemas.microsoft.com/office/drawing/2014/main" id="{61EB2A08-789A-4CD8-887E-E292E49C371A}"/>
+                <a16:creationId xmlns:a16="http://schemas.microsoft.com/office/drawing/2014/main" id="{C23E73B6-DF69-4ED3-BE87-427B3A3E9642}"/>
               </a:ext>
             </a:extLst>
           </p:cNvPr>
@@ -9600,7 +9862,7 @@
           <p:cNvPr id="2" name="">
             <a:extLst xmlns:a="http://schemas.openxmlformats.org/drawingml/2006/main">
               <a:ext uri="{FF2B5EF4-FFF2-40B4-BE49-F238E27FC236}">
-                <a16:creationId xmlns:a16="http://schemas.microsoft.com/office/drawing/2014/main" id="{FBAF1A0F-1F2D-45A7-B02D-ABFAB7824645}"/>
+                <a16:creationId xmlns:a16="http://schemas.microsoft.com/office/drawing/2014/main" id="{FA2579AB-85F9-4594-9636-C0572C57AB8F}"/>
               </a:ext>
             </a:extLst>
           </p:cNvPr>
@@ -9657,7 +9919,7 @@
           <p:cNvPr id="3" name="">
             <a:extLst xmlns:a="http://schemas.openxmlformats.org/drawingml/2006/main">
               <a:ext uri="{FF2B5EF4-FFF2-40B4-BE49-F238E27FC236}">
-                <a16:creationId xmlns:a16="http://schemas.microsoft.com/office/drawing/2014/main" id="{4D467329-523F-422B-8705-F95930D9CB72}"/>
+                <a16:creationId xmlns:a16="http://schemas.microsoft.com/office/drawing/2014/main" id="{A9EF6490-5A73-47F5-972C-B65153D72012}"/>
               </a:ext>
             </a:extLst>
           </p:cNvPr>
@@ -9687,7 +9949,7 @@
           <p:cNvPr id="4" name="">
             <a:extLst xmlns:a="http://schemas.openxmlformats.org/drawingml/2006/main">
               <a:ext uri="{FF2B5EF4-FFF2-40B4-BE49-F238E27FC236}">
-                <a16:creationId xmlns:a16="http://schemas.microsoft.com/office/drawing/2014/main" id="{A4FE1588-DA51-4416-A9FD-BDE376776CD6}"/>
+                <a16:creationId xmlns:a16="http://schemas.microsoft.com/office/drawing/2014/main" id="{A04800F3-0980-4933-ACF8-4D03E07CB000}"/>
               </a:ext>
             </a:extLst>
           </p:cNvPr>
@@ -9744,7 +10006,7 @@
           <p:cNvPr id="5" name="">
             <a:extLst xmlns:a="http://schemas.openxmlformats.org/drawingml/2006/main">
               <a:ext uri="{FF2B5EF4-FFF2-40B4-BE49-F238E27FC236}">
-                <a16:creationId xmlns:a16="http://schemas.microsoft.com/office/drawing/2014/main" id="{4AC01B0C-6316-4971-BDB2-FDDA58B1CEE4}"/>
+                <a16:creationId xmlns:a16="http://schemas.microsoft.com/office/drawing/2014/main" id="{5A4B0EEA-B0BA-4CD6-B8FF-8AFA18455707}"/>
               </a:ext>
             </a:extLst>
           </p:cNvPr>
@@ -9774,7 +10036,7 @@
           <p:cNvPr id="6" name="">
             <a:extLst xmlns:a="http://schemas.openxmlformats.org/drawingml/2006/main">
               <a:ext uri="{FF2B5EF4-FFF2-40B4-BE49-F238E27FC236}">
-                <a16:creationId xmlns:a16="http://schemas.microsoft.com/office/drawing/2014/main" id="{66B9F1B1-7CB1-43C6-8D14-8DD6F04005DF}"/>
+                <a16:creationId xmlns:a16="http://schemas.microsoft.com/office/drawing/2014/main" id="{705A9AD0-ABDA-4B9C-BA93-2DC0F5C85646}"/>
               </a:ext>
             </a:extLst>
           </p:cNvPr>
@@ -9831,7 +10093,7 @@
           <p:cNvPr id="7" name="">
             <a:extLst xmlns:a="http://schemas.openxmlformats.org/drawingml/2006/main">
               <a:ext uri="{FF2B5EF4-FFF2-40B4-BE49-F238E27FC236}">
-                <a16:creationId xmlns:a16="http://schemas.microsoft.com/office/drawing/2014/main" id="{0F92698D-D858-45D6-82E5-87D3C890D5F3}"/>
+                <a16:creationId xmlns:a16="http://schemas.microsoft.com/office/drawing/2014/main" id="{B3D048D9-D541-4797-8D25-E32862B7C11A}"/>
               </a:ext>
             </a:extLst>
           </p:cNvPr>
@@ -9911,7 +10173,7 @@
           <p:cNvPr id="8" name="">
             <a:extLst xmlns:a="http://schemas.openxmlformats.org/drawingml/2006/main">
               <a:ext uri="{FF2B5EF4-FFF2-40B4-BE49-F238E27FC236}">
-                <a16:creationId xmlns:a16="http://schemas.microsoft.com/office/drawing/2014/main" id="{B114325A-5411-4C31-8653-27FB089B9E05}"/>
+                <a16:creationId xmlns:a16="http://schemas.microsoft.com/office/drawing/2014/main" id="{76BB8D93-08AC-47FA-8F5F-25F3275A2662}"/>
               </a:ext>
             </a:extLst>
           </p:cNvPr>
@@ -9941,7 +10203,7 @@
           <p:cNvPr id="9" name="">
             <a:extLst xmlns:a="http://schemas.openxmlformats.org/drawingml/2006/main">
               <a:ext uri="{FF2B5EF4-FFF2-40B4-BE49-F238E27FC236}">
-                <a16:creationId xmlns:a16="http://schemas.microsoft.com/office/drawing/2014/main" id="{685E7358-FCFE-4B0C-B07B-4A9C2FCD5F90}"/>
+                <a16:creationId xmlns:a16="http://schemas.microsoft.com/office/drawing/2014/main" id="{DC32D34A-6858-455F-B516-522616877EC4}"/>
               </a:ext>
             </a:extLst>
           </p:cNvPr>
@@ -9998,7 +10260,7 @@
           <p:cNvPr id="10" name="">
             <a:extLst xmlns:a="http://schemas.openxmlformats.org/drawingml/2006/main">
               <a:ext uri="{FF2B5EF4-FFF2-40B4-BE49-F238E27FC236}">
-                <a16:creationId xmlns:a16="http://schemas.microsoft.com/office/drawing/2014/main" id="{E6CE245C-51CA-4986-B09C-4F8DB2908E2F}"/>
+                <a16:creationId xmlns:a16="http://schemas.microsoft.com/office/drawing/2014/main" id="{AF0DD99D-A94A-42FA-9E93-31D847BED536}"/>
               </a:ext>
             </a:extLst>
           </p:cNvPr>
@@ -10078,7 +10340,7 @@
           <p:cNvPr id="11" name="">
             <a:extLst xmlns:a="http://schemas.openxmlformats.org/drawingml/2006/main">
               <a:ext uri="{FF2B5EF4-FFF2-40B4-BE49-F238E27FC236}">
-                <a16:creationId xmlns:a16="http://schemas.microsoft.com/office/drawing/2014/main" id="{B69F4D15-CF52-4784-A08C-9D8DFDAA062E}"/>
+                <a16:creationId xmlns:a16="http://schemas.microsoft.com/office/drawing/2014/main" id="{D208321C-8DD1-4501-9698-D9234531827C}"/>
               </a:ext>
             </a:extLst>
           </p:cNvPr>
@@ -10108,7 +10370,7 @@
           <p:cNvPr id="12" name="">
             <a:extLst xmlns:a="http://schemas.openxmlformats.org/drawingml/2006/main">
               <a:ext uri="{FF2B5EF4-FFF2-40B4-BE49-F238E27FC236}">
-                <a16:creationId xmlns:a16="http://schemas.microsoft.com/office/drawing/2014/main" id="{6FE62ACB-7599-42A5-9050-2F517E6B9571}"/>
+                <a16:creationId xmlns:a16="http://schemas.microsoft.com/office/drawing/2014/main" id="{52C023AC-6DAC-4BFA-8368-E8967EA8E863}"/>
               </a:ext>
             </a:extLst>
           </p:cNvPr>
@@ -10165,7 +10427,7 @@
           <p:cNvPr id="13" name="">
             <a:extLst xmlns:a="http://schemas.openxmlformats.org/drawingml/2006/main">
               <a:ext uri="{FF2B5EF4-FFF2-40B4-BE49-F238E27FC236}">
-                <a16:creationId xmlns:a16="http://schemas.microsoft.com/office/drawing/2014/main" id="{9A600869-8F3A-4A62-9287-01165A439B46}"/>
+                <a16:creationId xmlns:a16="http://schemas.microsoft.com/office/drawing/2014/main" id="{A223634C-E262-4277-AD4D-309B7B53FABC}"/>
               </a:ext>
             </a:extLst>
           </p:cNvPr>
@@ -10245,7 +10507,7 @@
           <p:cNvPr id="14" name="">
             <a:extLst xmlns:a="http://schemas.openxmlformats.org/drawingml/2006/main">
               <a:ext uri="{FF2B5EF4-FFF2-40B4-BE49-F238E27FC236}">
-                <a16:creationId xmlns:a16="http://schemas.microsoft.com/office/drawing/2014/main" id="{9DF74343-4A0B-4C82-BAAA-5B5E4C23F091}"/>
+                <a16:creationId xmlns:a16="http://schemas.microsoft.com/office/drawing/2014/main" id="{1E53219A-F79E-428D-8607-1471A1702EE4}"/>
               </a:ext>
             </a:extLst>
           </p:cNvPr>
@@ -10275,7 +10537,7 @@
           <p:cNvPr id="15" name="">
             <a:extLst xmlns:a="http://schemas.openxmlformats.org/drawingml/2006/main">
               <a:ext uri="{FF2B5EF4-FFF2-40B4-BE49-F238E27FC236}">
-                <a16:creationId xmlns:a16="http://schemas.microsoft.com/office/drawing/2014/main" id="{A39F6F41-B4BA-4F81-AF4A-1BBDB4D79556}"/>
+                <a16:creationId xmlns:a16="http://schemas.microsoft.com/office/drawing/2014/main" id="{BFCC9ABE-B741-45E0-A88B-FB7D88AA70BE}"/>
               </a:ext>
             </a:extLst>
           </p:cNvPr>
@@ -10332,7 +10594,7 @@
           <p:cNvPr id="16" name="">
             <a:extLst xmlns:a="http://schemas.openxmlformats.org/drawingml/2006/main">
               <a:ext uri="{FF2B5EF4-FFF2-40B4-BE49-F238E27FC236}">
-                <a16:creationId xmlns:a16="http://schemas.microsoft.com/office/drawing/2014/main" id="{6AD9FD49-2B6F-4437-B8C6-AE17381C7F69}"/>
+                <a16:creationId xmlns:a16="http://schemas.microsoft.com/office/drawing/2014/main" id="{630076FB-EE1F-419E-8B5D-8169F537D399}"/>
               </a:ext>
             </a:extLst>
           </p:cNvPr>
@@ -10412,7 +10674,7 @@
           <p:cNvPr id="17" name="">
             <a:extLst xmlns:a="http://schemas.openxmlformats.org/drawingml/2006/main">
               <a:ext uri="{FF2B5EF4-FFF2-40B4-BE49-F238E27FC236}">
-                <a16:creationId xmlns:a16="http://schemas.microsoft.com/office/drawing/2014/main" id="{A8833B53-EAB4-46C7-AD2C-8E0FF864F205}"/>
+                <a16:creationId xmlns:a16="http://schemas.microsoft.com/office/drawing/2014/main" id="{095BBFAA-4D24-485F-A321-F4CD817081A4}"/>
               </a:ext>
             </a:extLst>
           </p:cNvPr>
@@ -10467,7 +10729,7 @@
     </p:spTree>
     <p:extLst>
       <p:ext uri="{BB962C8B-B14F-4D97-AF65-F5344CB8AC3E}">
-        <p14:creationId xmlns:p14="http://schemas.microsoft.com/office/powerpoint/2010/main" val="942446179"/>
+        <p14:creationId xmlns:p14="http://schemas.microsoft.com/office/powerpoint/2010/main" val="2019158915"/>
       </p:ext>
     </p:extLst>
   </p:cSld>
@@ -10498,7 +10760,7 @@
           <p:cNvPr id="30" name="">
             <a:extLst xmlns:a="http://schemas.openxmlformats.org/drawingml/2006/main">
               <a:ext uri="{FF2B5EF4-FFF2-40B4-BE49-F238E27FC236}">
-                <a16:creationId xmlns:a16="http://schemas.microsoft.com/office/drawing/2014/main" id="{001B4A75-301D-4F89-93D3-66693CF87F76}"/>
+                <a16:creationId xmlns:a16="http://schemas.microsoft.com/office/drawing/2014/main" id="{66891B42-12F1-48DB-8764-8740054E6471}"/>
               </a:ext>
             </a:extLst>
           </p:cNvPr>
@@ -10528,7 +10790,7 @@
           <p:cNvPr id="2" name="">
             <a:extLst xmlns:a="http://schemas.openxmlformats.org/drawingml/2006/main">
               <a:ext uri="{FF2B5EF4-FFF2-40B4-BE49-F238E27FC236}">
-                <a16:creationId xmlns:a16="http://schemas.microsoft.com/office/drawing/2014/main" id="{00F26CE0-85C5-4EF4-A069-DAF71DBEF62F}"/>
+                <a16:creationId xmlns:a16="http://schemas.microsoft.com/office/drawing/2014/main" id="{78ECB73E-BF0A-4637-9D8F-FDBDC20F3507}"/>
               </a:ext>
             </a:extLst>
           </p:cNvPr>
@@ -10585,7 +10847,7 @@
           <p:cNvPr id="3" name="">
             <a:extLst xmlns:a="http://schemas.openxmlformats.org/drawingml/2006/main">
               <a:ext uri="{FF2B5EF4-FFF2-40B4-BE49-F238E27FC236}">
-                <a16:creationId xmlns:a16="http://schemas.microsoft.com/office/drawing/2014/main" id="{6BC7DE7D-11F5-41F1-829D-BA8B54A52B82}"/>
+                <a16:creationId xmlns:a16="http://schemas.microsoft.com/office/drawing/2014/main" id="{B0A9F970-5490-4ECC-8098-86CF96300582}"/>
               </a:ext>
             </a:extLst>
           </p:cNvPr>
@@ -10615,7 +10877,7 @@
           <p:cNvPr id="4" name="">
             <a:extLst xmlns:a="http://schemas.openxmlformats.org/drawingml/2006/main">
               <a:ext uri="{FF2B5EF4-FFF2-40B4-BE49-F238E27FC236}">
-                <a16:creationId xmlns:a16="http://schemas.microsoft.com/office/drawing/2014/main" id="{1F7FA61D-CB29-4F3A-B89A-7EEE2A9893E1}"/>
+                <a16:creationId xmlns:a16="http://schemas.microsoft.com/office/drawing/2014/main" id="{617BC351-568E-4BB6-9B9F-169F439C9B78}"/>
               </a:ext>
             </a:extLst>
           </p:cNvPr>
@@ -10672,7 +10934,7 @@
           <p:cNvPr id="5" name="">
             <a:extLst xmlns:a="http://schemas.openxmlformats.org/drawingml/2006/main">
               <a:ext uri="{FF2B5EF4-FFF2-40B4-BE49-F238E27FC236}">
-                <a16:creationId xmlns:a16="http://schemas.microsoft.com/office/drawing/2014/main" id="{CFFEC3EA-4A5A-4D41-A666-D88E25F48416}"/>
+                <a16:creationId xmlns:a16="http://schemas.microsoft.com/office/drawing/2014/main" id="{21CB5D8A-8EE4-4657-8EC9-1CAF499AA0EF}"/>
               </a:ext>
             </a:extLst>
           </p:cNvPr>
@@ -10704,7 +10966,7 @@
           <p:cNvPr id="6" name="">
             <a:extLst xmlns:a="http://schemas.openxmlformats.org/drawingml/2006/main">
               <a:ext uri="{FF2B5EF4-FFF2-40B4-BE49-F238E27FC236}">
-                <a16:creationId xmlns:a16="http://schemas.microsoft.com/office/drawing/2014/main" id="{217F3091-B039-4ECC-B2F2-C5C8CCFF9945}"/>
+                <a16:creationId xmlns:a16="http://schemas.microsoft.com/office/drawing/2014/main" id="{93223D4D-474C-4A68-A647-E0D05512F939}"/>
               </a:ext>
             </a:extLst>
           </p:cNvPr>
@@ -10761,7 +11023,7 @@
           <p:cNvPr id="7" name="">
             <a:extLst xmlns:a="http://schemas.openxmlformats.org/drawingml/2006/main">
               <a:ext uri="{FF2B5EF4-FFF2-40B4-BE49-F238E27FC236}">
-                <a16:creationId xmlns:a16="http://schemas.microsoft.com/office/drawing/2014/main" id="{C79EBD88-20D2-46A8-AB51-48CF00E3A57F}"/>
+                <a16:creationId xmlns:a16="http://schemas.microsoft.com/office/drawing/2014/main" id="{062C5E53-32E8-40D8-A854-5C22DF59AC3E}"/>
               </a:ext>
             </a:extLst>
           </p:cNvPr>
@@ -10818,7 +11080,7 @@
           <p:cNvPr id="8" name="">
             <a:extLst xmlns:a="http://schemas.openxmlformats.org/drawingml/2006/main">
               <a:ext uri="{FF2B5EF4-FFF2-40B4-BE49-F238E27FC236}">
-                <a16:creationId xmlns:a16="http://schemas.microsoft.com/office/drawing/2014/main" id="{AB8E0DC1-898F-4F54-8C03-13BB42E1369E}"/>
+                <a16:creationId xmlns:a16="http://schemas.microsoft.com/office/drawing/2014/main" id="{F32A100D-2BF1-4654-8CF6-76C0C442E53F}"/>
               </a:ext>
             </a:extLst>
           </p:cNvPr>
@@ -10898,7 +11160,7 @@
           <p:cNvPr id="9" name="">
             <a:extLst xmlns:a="http://schemas.openxmlformats.org/drawingml/2006/main">
               <a:ext uri="{FF2B5EF4-FFF2-40B4-BE49-F238E27FC236}">
-                <a16:creationId xmlns:a16="http://schemas.microsoft.com/office/drawing/2014/main" id="{53AAF0FC-C67A-4C76-B851-F2D7C1412A06}"/>
+                <a16:creationId xmlns:a16="http://schemas.microsoft.com/office/drawing/2014/main" id="{F15A5305-B942-4865-9F26-CA400E92E0EB}"/>
               </a:ext>
             </a:extLst>
           </p:cNvPr>
@@ -10955,7 +11217,7 @@
           <p:cNvPr id="10" name="">
             <a:extLst xmlns:a="http://schemas.openxmlformats.org/drawingml/2006/main">
               <a:ext uri="{FF2B5EF4-FFF2-40B4-BE49-F238E27FC236}">
-                <a16:creationId xmlns:a16="http://schemas.microsoft.com/office/drawing/2014/main" id="{71DBCA38-08D6-4672-9167-9864EAB98F0C}"/>
+                <a16:creationId xmlns:a16="http://schemas.microsoft.com/office/drawing/2014/main" id="{17C8FC9A-BFC7-4562-BB82-327EDF1A98FE}"/>
               </a:ext>
             </a:extLst>
           </p:cNvPr>
@@ -10987,7 +11249,7 @@
           <p:cNvPr id="11" name="">
             <a:extLst xmlns:a="http://schemas.openxmlformats.org/drawingml/2006/main">
               <a:ext uri="{FF2B5EF4-FFF2-40B4-BE49-F238E27FC236}">
-                <a16:creationId xmlns:a16="http://schemas.microsoft.com/office/drawing/2014/main" id="{ECAA039D-AF22-403D-AE6B-340E31F9A1B1}"/>
+                <a16:creationId xmlns:a16="http://schemas.microsoft.com/office/drawing/2014/main" id="{D2540578-3DBB-44AF-8E5D-1BA1DB5F35C8}"/>
               </a:ext>
             </a:extLst>
           </p:cNvPr>
@@ -11044,7 +11306,7 @@
           <p:cNvPr id="12" name="">
             <a:extLst xmlns:a="http://schemas.openxmlformats.org/drawingml/2006/main">
               <a:ext uri="{FF2B5EF4-FFF2-40B4-BE49-F238E27FC236}">
-                <a16:creationId xmlns:a16="http://schemas.microsoft.com/office/drawing/2014/main" id="{8A2F7A83-1105-4944-9D26-15B77D91AC9E}"/>
+                <a16:creationId xmlns:a16="http://schemas.microsoft.com/office/drawing/2014/main" id="{1B08F686-3556-4318-81F0-8C59946FDB6E}"/>
               </a:ext>
             </a:extLst>
           </p:cNvPr>
@@ -11101,7 +11363,7 @@
           <p:cNvPr id="13" name="">
             <a:extLst xmlns:a="http://schemas.openxmlformats.org/drawingml/2006/main">
               <a:ext uri="{FF2B5EF4-FFF2-40B4-BE49-F238E27FC236}">
-                <a16:creationId xmlns:a16="http://schemas.microsoft.com/office/drawing/2014/main" id="{84E3B9F8-0061-4BC6-A7A9-491A3DD9734A}"/>
+                <a16:creationId xmlns:a16="http://schemas.microsoft.com/office/drawing/2014/main" id="{49380B68-480F-4D14-8321-27546C3C3A90}"/>
               </a:ext>
             </a:extLst>
           </p:cNvPr>
@@ -11181,7 +11443,7 @@
           <p:cNvPr id="14" name="">
             <a:extLst xmlns:a="http://schemas.openxmlformats.org/drawingml/2006/main">
               <a:ext uri="{FF2B5EF4-FFF2-40B4-BE49-F238E27FC236}">
-                <a16:creationId xmlns:a16="http://schemas.microsoft.com/office/drawing/2014/main" id="{DD537413-42FD-468C-915E-612BE7BCFF67}"/>
+                <a16:creationId xmlns:a16="http://schemas.microsoft.com/office/drawing/2014/main" id="{2C1A5386-2474-46B1-8717-842458C4B96C}"/>
               </a:ext>
             </a:extLst>
           </p:cNvPr>
@@ -11238,7 +11500,7 @@
           <p:cNvPr id="15" name="">
             <a:extLst xmlns:a="http://schemas.openxmlformats.org/drawingml/2006/main">
               <a:ext uri="{FF2B5EF4-FFF2-40B4-BE49-F238E27FC236}">
-                <a16:creationId xmlns:a16="http://schemas.microsoft.com/office/drawing/2014/main" id="{CF4E0442-2B7B-4D87-9D3D-900A2A633CB6}"/>
+                <a16:creationId xmlns:a16="http://schemas.microsoft.com/office/drawing/2014/main" id="{0512B442-9EA7-4786-9A49-349A14F291D9}"/>
               </a:ext>
             </a:extLst>
           </p:cNvPr>
@@ -11270,7 +11532,7 @@
           <p:cNvPr id="16" name="">
             <a:extLst xmlns:a="http://schemas.openxmlformats.org/drawingml/2006/main">
               <a:ext uri="{FF2B5EF4-FFF2-40B4-BE49-F238E27FC236}">
-                <a16:creationId xmlns:a16="http://schemas.microsoft.com/office/drawing/2014/main" id="{D6B87A2C-CCD8-43CE-B190-EE0F6F4BA9A1}"/>
+                <a16:creationId xmlns:a16="http://schemas.microsoft.com/office/drawing/2014/main" id="{E486A962-AC9F-4711-BDEB-3C1AA1CF4E7B}"/>
               </a:ext>
             </a:extLst>
           </p:cNvPr>
@@ -11327,7 +11589,7 @@
           <p:cNvPr id="17" name="">
             <a:extLst xmlns:a="http://schemas.openxmlformats.org/drawingml/2006/main">
               <a:ext uri="{FF2B5EF4-FFF2-40B4-BE49-F238E27FC236}">
-                <a16:creationId xmlns:a16="http://schemas.microsoft.com/office/drawing/2014/main" id="{69FB45C9-FAFE-422E-88AD-462C51DFEC01}"/>
+                <a16:creationId xmlns:a16="http://schemas.microsoft.com/office/drawing/2014/main" id="{B359265B-DDF2-44FC-80BF-F3442C00101F}"/>
               </a:ext>
             </a:extLst>
           </p:cNvPr>
@@ -11384,7 +11646,7 @@
           <p:cNvPr id="18" name="">
             <a:extLst xmlns:a="http://schemas.openxmlformats.org/drawingml/2006/main">
               <a:ext uri="{FF2B5EF4-FFF2-40B4-BE49-F238E27FC236}">
-                <a16:creationId xmlns:a16="http://schemas.microsoft.com/office/drawing/2014/main" id="{CAA54260-86DB-467C-96F5-1DBB45CFBC85}"/>
+                <a16:creationId xmlns:a16="http://schemas.microsoft.com/office/drawing/2014/main" id="{14BAEA36-5D9B-4600-B134-ABEE2841A6AC}"/>
               </a:ext>
             </a:extLst>
           </p:cNvPr>
@@ -11464,7 +11726,7 @@
           <p:cNvPr id="19" name="">
             <a:extLst xmlns:a="http://schemas.openxmlformats.org/drawingml/2006/main">
               <a:ext uri="{FF2B5EF4-FFF2-40B4-BE49-F238E27FC236}">
-                <a16:creationId xmlns:a16="http://schemas.microsoft.com/office/drawing/2014/main" id="{DD376FDE-97EC-4A3C-BF06-0CBD3C7D5F1B}"/>
+                <a16:creationId xmlns:a16="http://schemas.microsoft.com/office/drawing/2014/main" id="{83374031-8083-4F14-82DC-BB4FF4903F2F}"/>
               </a:ext>
             </a:extLst>
           </p:cNvPr>
@@ -11521,7 +11783,7 @@
           <p:cNvPr id="20" name="">
             <a:extLst xmlns:a="http://schemas.openxmlformats.org/drawingml/2006/main">
               <a:ext uri="{FF2B5EF4-FFF2-40B4-BE49-F238E27FC236}">
-                <a16:creationId xmlns:a16="http://schemas.microsoft.com/office/drawing/2014/main" id="{5062E0BB-DAD2-425D-A065-A9EA8946E5C0}"/>
+                <a16:creationId xmlns:a16="http://schemas.microsoft.com/office/drawing/2014/main" id="{FE965F7D-B000-4196-AED1-3FC2D8520262}"/>
               </a:ext>
             </a:extLst>
           </p:cNvPr>
@@ -11553,7 +11815,7 @@
           <p:cNvPr id="21" name="">
             <a:extLst xmlns:a="http://schemas.openxmlformats.org/drawingml/2006/main">
               <a:ext uri="{FF2B5EF4-FFF2-40B4-BE49-F238E27FC236}">
-                <a16:creationId xmlns:a16="http://schemas.microsoft.com/office/drawing/2014/main" id="{FB431843-C587-444F-BF44-4BF7E1D705C8}"/>
+                <a16:creationId xmlns:a16="http://schemas.microsoft.com/office/drawing/2014/main" id="{9D73BFFC-DBB4-4B8A-83B4-787600E8D1DC}"/>
               </a:ext>
             </a:extLst>
           </p:cNvPr>
@@ -11610,7 +11872,7 @@
           <p:cNvPr id="22" name="">
             <a:extLst xmlns:a="http://schemas.openxmlformats.org/drawingml/2006/main">
               <a:ext uri="{FF2B5EF4-FFF2-40B4-BE49-F238E27FC236}">
-                <a16:creationId xmlns:a16="http://schemas.microsoft.com/office/drawing/2014/main" id="{9FC1F125-4C03-4C2A-93EC-C19F5EE7DC1E}"/>
+                <a16:creationId xmlns:a16="http://schemas.microsoft.com/office/drawing/2014/main" id="{D0AA117B-5338-4A98-A184-4A9A7040A398}"/>
               </a:ext>
             </a:extLst>
           </p:cNvPr>
@@ -11667,7 +11929,7 @@
           <p:cNvPr id="23" name="">
             <a:extLst xmlns:a="http://schemas.openxmlformats.org/drawingml/2006/main">
               <a:ext uri="{FF2B5EF4-FFF2-40B4-BE49-F238E27FC236}">
-                <a16:creationId xmlns:a16="http://schemas.microsoft.com/office/drawing/2014/main" id="{205E74E1-EAD7-42F6-88EA-C715998B3019}"/>
+                <a16:creationId xmlns:a16="http://schemas.microsoft.com/office/drawing/2014/main" id="{1604AF88-D7A5-49E2-B899-E4027606F773}"/>
               </a:ext>
             </a:extLst>
           </p:cNvPr>
@@ -11747,7 +12009,7 @@
           <p:cNvPr id="24" name="">
             <a:extLst xmlns:a="http://schemas.openxmlformats.org/drawingml/2006/main">
               <a:ext uri="{FF2B5EF4-FFF2-40B4-BE49-F238E27FC236}">
-                <a16:creationId xmlns:a16="http://schemas.microsoft.com/office/drawing/2014/main" id="{F163496D-5C03-4BB1-839A-1DC59B56F85E}"/>
+                <a16:creationId xmlns:a16="http://schemas.microsoft.com/office/drawing/2014/main" id="{C1863AF7-882D-416E-B844-6819DE958DAF}"/>
               </a:ext>
             </a:extLst>
           </p:cNvPr>
@@ -11804,7 +12066,7 @@
           <p:cNvPr id="25" name="">
             <a:extLst xmlns:a="http://schemas.openxmlformats.org/drawingml/2006/main">
               <a:ext uri="{FF2B5EF4-FFF2-40B4-BE49-F238E27FC236}">
-                <a16:creationId xmlns:a16="http://schemas.microsoft.com/office/drawing/2014/main" id="{6EABA65E-2933-4B0F-B2A2-7B565005750D}"/>
+                <a16:creationId xmlns:a16="http://schemas.microsoft.com/office/drawing/2014/main" id="{C7D241A1-AAF9-453D-9149-A18A9C286B31}"/>
               </a:ext>
             </a:extLst>
           </p:cNvPr>
@@ -11834,7 +12096,7 @@
           <p:cNvPr id="26" name="">
             <a:extLst xmlns:a="http://schemas.openxmlformats.org/drawingml/2006/main">
               <a:ext uri="{FF2B5EF4-FFF2-40B4-BE49-F238E27FC236}">
-                <a16:creationId xmlns:a16="http://schemas.microsoft.com/office/drawing/2014/main" id="{4BBE15CE-965B-4499-8CD8-3BD9AFAD757A}"/>
+                <a16:creationId xmlns:a16="http://schemas.microsoft.com/office/drawing/2014/main" id="{2FB4F76B-2096-4B37-9FB7-AC7801DE2CB0}"/>
               </a:ext>
             </a:extLst>
           </p:cNvPr>
@@ -11891,7 +12153,7 @@
           <p:cNvPr id="27" name="">
             <a:extLst xmlns:a="http://schemas.openxmlformats.org/drawingml/2006/main">
               <a:ext uri="{FF2B5EF4-FFF2-40B4-BE49-F238E27FC236}">
-                <a16:creationId xmlns:a16="http://schemas.microsoft.com/office/drawing/2014/main" id="{882052C6-E54A-4DA1-960D-1A7EF3FA4E3C}"/>
+                <a16:creationId xmlns:a16="http://schemas.microsoft.com/office/drawing/2014/main" id="{7B16C8DF-13D0-4619-9D58-E9F7A3D2D22F}"/>
               </a:ext>
             </a:extLst>
           </p:cNvPr>
@@ -11948,7 +12210,7 @@
           <p:cNvPr id="28" name="">
             <a:extLst xmlns:a="http://schemas.openxmlformats.org/drawingml/2006/main">
               <a:ext uri="{FF2B5EF4-FFF2-40B4-BE49-F238E27FC236}">
-                <a16:creationId xmlns:a16="http://schemas.microsoft.com/office/drawing/2014/main" id="{1898DB74-16D5-4E80-B9BC-071D670CCE14}"/>
+                <a16:creationId xmlns:a16="http://schemas.microsoft.com/office/drawing/2014/main" id="{E2941882-ECB4-49A6-B45E-5CD0A0409804}"/>
               </a:ext>
             </a:extLst>
           </p:cNvPr>
@@ -12028,7 +12290,7 @@
           <p:cNvPr id="29" name="">
             <a:extLst xmlns:a="http://schemas.openxmlformats.org/drawingml/2006/main">
               <a:ext uri="{FF2B5EF4-FFF2-40B4-BE49-F238E27FC236}">
-                <a16:creationId xmlns:a16="http://schemas.microsoft.com/office/drawing/2014/main" id="{5E1BE5DD-0DB9-48A2-A26C-459153C14FDE}"/>
+                <a16:creationId xmlns:a16="http://schemas.microsoft.com/office/drawing/2014/main" id="{90DAF911-51FA-441B-BFBD-C4C639330040}"/>
               </a:ext>
             </a:extLst>
           </p:cNvPr>
@@ -12083,7 +12345,7 @@
     </p:spTree>
     <p:extLst>
       <p:ext uri="{BB962C8B-B14F-4D97-AF65-F5344CB8AC3E}">
-        <p14:creationId xmlns:p14="http://schemas.microsoft.com/office/powerpoint/2010/main" val="1280103811"/>
+        <p14:creationId xmlns:p14="http://schemas.microsoft.com/office/powerpoint/2010/main" val="971713325"/>
       </p:ext>
     </p:extLst>
   </p:cSld>
@@ -12114,7 +12376,7 @@
           <p:cNvPr id="12" name="">
             <a:extLst xmlns:a="http://schemas.openxmlformats.org/drawingml/2006/main">
               <a:ext uri="{FF2B5EF4-FFF2-40B4-BE49-F238E27FC236}">
-                <a16:creationId xmlns:a16="http://schemas.microsoft.com/office/drawing/2014/main" id="{19639C42-72D4-419D-8FE1-83A487428E26}"/>
+                <a16:creationId xmlns:a16="http://schemas.microsoft.com/office/drawing/2014/main" id="{43E4F63B-DB51-4CC3-93E4-12BA1537F8B8}"/>
               </a:ext>
             </a:extLst>
           </p:cNvPr>
@@ -12144,7 +12406,7 @@
           <p:cNvPr id="2" name="">
             <a:extLst xmlns:a="http://schemas.openxmlformats.org/drawingml/2006/main">
               <a:ext uri="{FF2B5EF4-FFF2-40B4-BE49-F238E27FC236}">
-                <a16:creationId xmlns:a16="http://schemas.microsoft.com/office/drawing/2014/main" id="{B8FDA68D-023C-4E4E-9334-E729EDF47A3C}"/>
+                <a16:creationId xmlns:a16="http://schemas.microsoft.com/office/drawing/2014/main" id="{190B5F92-1593-4348-BCD7-715CAC727CF5}"/>
               </a:ext>
             </a:extLst>
           </p:cNvPr>
@@ -12201,7 +12463,7 @@
           <p:cNvPr id="3" name="">
             <a:extLst xmlns:a="http://schemas.openxmlformats.org/drawingml/2006/main">
               <a:ext uri="{FF2B5EF4-FFF2-40B4-BE49-F238E27FC236}">
-                <a16:creationId xmlns:a16="http://schemas.microsoft.com/office/drawing/2014/main" id="{89F64D38-2DF0-489C-BE7C-CDF81AD9FB17}"/>
+                <a16:creationId xmlns:a16="http://schemas.microsoft.com/office/drawing/2014/main" id="{ABA9FC49-0BB4-4433-8EA6-DF84109B0863}"/>
               </a:ext>
             </a:extLst>
           </p:cNvPr>
@@ -12231,7 +12493,7 @@
           <p:cNvPr id="4" name="">
             <a:extLst xmlns:a="http://schemas.openxmlformats.org/drawingml/2006/main">
               <a:ext uri="{FF2B5EF4-FFF2-40B4-BE49-F238E27FC236}">
-                <a16:creationId xmlns:a16="http://schemas.microsoft.com/office/drawing/2014/main" id="{4E07301B-F973-4C47-B182-ECF68F43E1A1}"/>
+                <a16:creationId xmlns:a16="http://schemas.microsoft.com/office/drawing/2014/main" id="{8E098CEE-3FE0-4FF0-B063-72C5BB3D586E}"/>
               </a:ext>
             </a:extLst>
           </p:cNvPr>
@@ -12288,7 +12550,7 @@
           <p:cNvPr id="5" name="">
             <a:extLst xmlns:a="http://schemas.openxmlformats.org/drawingml/2006/main">
               <a:ext uri="{FF2B5EF4-FFF2-40B4-BE49-F238E27FC236}">
-                <a16:creationId xmlns:a16="http://schemas.microsoft.com/office/drawing/2014/main" id="{839E3EC9-CAE0-4ADD-9BE4-5092A2FC730F}"/>
+                <a16:creationId xmlns:a16="http://schemas.microsoft.com/office/drawing/2014/main" id="{9206223B-66D4-4258-9364-F25F76FBCBD6}"/>
               </a:ext>
             </a:extLst>
           </p:cNvPr>
@@ -12320,7 +12582,7 @@
           <p:cNvPr id="6" name="">
             <a:extLst xmlns:a="http://schemas.openxmlformats.org/drawingml/2006/main">
               <a:ext uri="{FF2B5EF4-FFF2-40B4-BE49-F238E27FC236}">
-                <a16:creationId xmlns:a16="http://schemas.microsoft.com/office/drawing/2014/main" id="{4F8A0C5E-AD9E-4F51-A49A-2C708203C9AF}"/>
+                <a16:creationId xmlns:a16="http://schemas.microsoft.com/office/drawing/2014/main" id="{FB95A79A-2F30-4901-A40E-B90E37A9FB9B}"/>
               </a:ext>
             </a:extLst>
           </p:cNvPr>
@@ -12356,7 +12618,7 @@
           <p:nvPr/>
         </p:nvPicPr>
         <p:blipFill>
-          <a:blip xmlns:r="http://schemas.openxmlformats.org/officeDocument/2006/relationships" xmlns:a="http://schemas.openxmlformats.org/drawingml/2006/main" r:embed="R6db41761156b483c"/>
+          <a:blip xmlns:r="http://schemas.openxmlformats.org/officeDocument/2006/relationships" xmlns:a="http://schemas.openxmlformats.org/drawingml/2006/main" r:embed="R95ea58d4dc5847f8"/>
           <a:stretch xmlns:a="http://schemas.openxmlformats.org/drawingml/2006/main"/>
         </p:blipFill>
         <p:spPr>
@@ -12378,7 +12640,7 @@
           <p:nvPr/>
         </p:nvPicPr>
         <p:blipFill>
-          <a:blip xmlns:r="http://schemas.openxmlformats.org/officeDocument/2006/relationships" xmlns:a="http://schemas.openxmlformats.org/drawingml/2006/main" r:embed="R15cdb659feea47fa"/>
+          <a:blip xmlns:r="http://schemas.openxmlformats.org/officeDocument/2006/relationships" xmlns:a="http://schemas.openxmlformats.org/drawingml/2006/main" r:embed="Rfe3fcd4557bc45ff"/>
           <a:stretch xmlns:a="http://schemas.openxmlformats.org/drawingml/2006/main"/>
         </p:blipFill>
         <p:spPr>
@@ -12396,7 +12658,7 @@
           <p:cNvPr id="9" name="">
             <a:extLst xmlns:a="http://schemas.openxmlformats.org/drawingml/2006/main">
               <a:ext uri="{FF2B5EF4-FFF2-40B4-BE49-F238E27FC236}">
-                <a16:creationId xmlns:a16="http://schemas.microsoft.com/office/drawing/2014/main" id="{BFECA6C8-BCEA-44C4-B50F-0DD22053F3CE}"/>
+                <a16:creationId xmlns:a16="http://schemas.microsoft.com/office/drawing/2014/main" id="{333696A9-FDE6-4E6F-A924-EE4378D2D937}"/>
               </a:ext>
             </a:extLst>
           </p:cNvPr>
@@ -12453,7 +12715,7 @@
           <p:cNvPr id="10" name="">
             <a:extLst xmlns:a="http://schemas.openxmlformats.org/drawingml/2006/main">
               <a:ext uri="{FF2B5EF4-FFF2-40B4-BE49-F238E27FC236}">
-                <a16:creationId xmlns:a16="http://schemas.microsoft.com/office/drawing/2014/main" id="{DC9C879B-AC04-4EE6-9649-491A4701042A}"/>
+                <a16:creationId xmlns:a16="http://schemas.microsoft.com/office/drawing/2014/main" id="{451BFDF0-8FCE-44FF-B817-D9D2F5A071CD}"/>
               </a:ext>
             </a:extLst>
           </p:cNvPr>
@@ -12510,7 +12772,7 @@
           <p:cNvPr id="11" name="">
             <a:extLst xmlns:a="http://schemas.openxmlformats.org/drawingml/2006/main">
               <a:ext uri="{FF2B5EF4-FFF2-40B4-BE49-F238E27FC236}">
-                <a16:creationId xmlns:a16="http://schemas.microsoft.com/office/drawing/2014/main" id="{892DDC5E-C76F-444C-A694-46681D5E4DAF}"/>
+                <a16:creationId xmlns:a16="http://schemas.microsoft.com/office/drawing/2014/main" id="{FAEBFA0E-6CD3-4428-A053-EE11944CEA29}"/>
               </a:ext>
             </a:extLst>
           </p:cNvPr>
@@ -12565,7 +12827,7 @@
     </p:spTree>
     <p:extLst>
       <p:ext uri="{BB962C8B-B14F-4D97-AF65-F5344CB8AC3E}">
-        <p14:creationId xmlns:p14="http://schemas.microsoft.com/office/powerpoint/2010/main" val="1587914580"/>
+        <p14:creationId xmlns:p14="http://schemas.microsoft.com/office/powerpoint/2010/main" val="45472646"/>
       </p:ext>
     </p:extLst>
   </p:cSld>
@@ -12596,7 +12858,7 @@
           <p:cNvPr id="12" name="">
             <a:extLst xmlns:a="http://schemas.openxmlformats.org/drawingml/2006/main">
               <a:ext uri="{FF2B5EF4-FFF2-40B4-BE49-F238E27FC236}">
-                <a16:creationId xmlns:a16="http://schemas.microsoft.com/office/drawing/2014/main" id="{9CB06ADB-8102-4BCC-B8ED-34197440D39D}"/>
+                <a16:creationId xmlns:a16="http://schemas.microsoft.com/office/drawing/2014/main" id="{03B6999E-DA3E-491F-9521-6B25ED8D4970}"/>
               </a:ext>
             </a:extLst>
           </p:cNvPr>
@@ -12626,7 +12888,7 @@
           <p:cNvPr id="2" name="">
             <a:extLst xmlns:a="http://schemas.openxmlformats.org/drawingml/2006/main">
               <a:ext uri="{FF2B5EF4-FFF2-40B4-BE49-F238E27FC236}">
-                <a16:creationId xmlns:a16="http://schemas.microsoft.com/office/drawing/2014/main" id="{3E6611C2-EDB1-4110-BEC0-635C429670DC}"/>
+                <a16:creationId xmlns:a16="http://schemas.microsoft.com/office/drawing/2014/main" id="{C97E380B-246E-47BA-81B5-34B4F176F593}"/>
               </a:ext>
             </a:extLst>
           </p:cNvPr>
@@ -12683,7 +12945,7 @@
           <p:cNvPr id="3" name="">
             <a:extLst xmlns:a="http://schemas.openxmlformats.org/drawingml/2006/main">
               <a:ext uri="{FF2B5EF4-FFF2-40B4-BE49-F238E27FC236}">
-                <a16:creationId xmlns:a16="http://schemas.microsoft.com/office/drawing/2014/main" id="{DF00F761-A906-4558-92E3-B3AE454F6541}"/>
+                <a16:creationId xmlns:a16="http://schemas.microsoft.com/office/drawing/2014/main" id="{AB679FD2-5313-4263-A106-82C68A4F9109}"/>
               </a:ext>
             </a:extLst>
           </p:cNvPr>
@@ -12713,7 +12975,7 @@
           <p:cNvPr id="4" name="">
             <a:extLst xmlns:a="http://schemas.openxmlformats.org/drawingml/2006/main">
               <a:ext uri="{FF2B5EF4-FFF2-40B4-BE49-F238E27FC236}">
-                <a16:creationId xmlns:a16="http://schemas.microsoft.com/office/drawing/2014/main" id="{4649CDC5-98EE-4A23-93CB-7D0A3AB21D66}"/>
+                <a16:creationId xmlns:a16="http://schemas.microsoft.com/office/drawing/2014/main" id="{FFE17D1A-0134-4203-BA21-ADBFA40FCFF3}"/>
               </a:ext>
             </a:extLst>
           </p:cNvPr>
@@ -12770,7 +13032,7 @@
           <p:cNvPr id="5" name="">
             <a:extLst xmlns:a="http://schemas.openxmlformats.org/drawingml/2006/main">
               <a:ext uri="{FF2B5EF4-FFF2-40B4-BE49-F238E27FC236}">
-                <a16:creationId xmlns:a16="http://schemas.microsoft.com/office/drawing/2014/main" id="{687354B7-A73B-4C1C-9246-773DFE8C204A}"/>
+                <a16:creationId xmlns:a16="http://schemas.microsoft.com/office/drawing/2014/main" id="{C9E85DB1-785C-4761-85D0-98F459776989}"/>
               </a:ext>
             </a:extLst>
           </p:cNvPr>
@@ -12802,7 +13064,7 @@
           <p:cNvPr id="6" name="">
             <a:extLst xmlns:a="http://schemas.openxmlformats.org/drawingml/2006/main">
               <a:ext uri="{FF2B5EF4-FFF2-40B4-BE49-F238E27FC236}">
-                <a16:creationId xmlns:a16="http://schemas.microsoft.com/office/drawing/2014/main" id="{F39983EB-D322-4DA7-B23F-CBF3167956A3}"/>
+                <a16:creationId xmlns:a16="http://schemas.microsoft.com/office/drawing/2014/main" id="{739953FA-3722-4874-8EDF-6AA2CCA118D1}"/>
               </a:ext>
             </a:extLst>
           </p:cNvPr>
@@ -12838,7 +13100,7 @@
           <p:nvPr/>
         </p:nvPicPr>
         <p:blipFill>
-          <a:blip xmlns:r="http://schemas.openxmlformats.org/officeDocument/2006/relationships" xmlns:a="http://schemas.openxmlformats.org/drawingml/2006/main" r:embed="R810f4bb7a0704488"/>
+          <a:blip xmlns:r="http://schemas.openxmlformats.org/officeDocument/2006/relationships" xmlns:a="http://schemas.openxmlformats.org/drawingml/2006/main" r:embed="R6f8ec24e12bd4157"/>
           <a:stretch xmlns:a="http://schemas.openxmlformats.org/drawingml/2006/main"/>
         </p:blipFill>
         <p:spPr>
@@ -12860,7 +13122,7 @@
           <p:nvPr/>
         </p:nvPicPr>
         <p:blipFill>
-          <a:blip xmlns:r="http://schemas.openxmlformats.org/officeDocument/2006/relationships" xmlns:a="http://schemas.openxmlformats.org/drawingml/2006/main" r:embed="Rba753095b95f4834"/>
+          <a:blip xmlns:r="http://schemas.openxmlformats.org/officeDocument/2006/relationships" xmlns:a="http://schemas.openxmlformats.org/drawingml/2006/main" r:embed="Rc23c450f4c3f4615"/>
           <a:stretch xmlns:a="http://schemas.openxmlformats.org/drawingml/2006/main"/>
         </p:blipFill>
         <p:spPr>
@@ -12878,7 +13140,7 @@
           <p:cNvPr id="9" name="">
             <a:extLst xmlns:a="http://schemas.openxmlformats.org/drawingml/2006/main">
               <a:ext uri="{FF2B5EF4-FFF2-40B4-BE49-F238E27FC236}">
-                <a16:creationId xmlns:a16="http://schemas.microsoft.com/office/drawing/2014/main" id="{6D5E7B8E-C27D-4193-A4F2-88451432C213}"/>
+                <a16:creationId xmlns:a16="http://schemas.microsoft.com/office/drawing/2014/main" id="{96BCF356-D273-412A-8BBD-07C9B59D0594}"/>
               </a:ext>
             </a:extLst>
           </p:cNvPr>
@@ -12935,7 +13197,7 @@
           <p:cNvPr id="10" name="">
             <a:extLst xmlns:a="http://schemas.openxmlformats.org/drawingml/2006/main">
               <a:ext uri="{FF2B5EF4-FFF2-40B4-BE49-F238E27FC236}">
-                <a16:creationId xmlns:a16="http://schemas.microsoft.com/office/drawing/2014/main" id="{C2C029E7-F4DE-4C7D-9DFD-EBFEEDCA8D19}"/>
+                <a16:creationId xmlns:a16="http://schemas.microsoft.com/office/drawing/2014/main" id="{6023DDA6-D760-4B66-B62F-B5464092CF94}"/>
               </a:ext>
             </a:extLst>
           </p:cNvPr>
@@ -12992,7 +13254,7 @@
           <p:cNvPr id="11" name="">
             <a:extLst xmlns:a="http://schemas.openxmlformats.org/drawingml/2006/main">
               <a:ext uri="{FF2B5EF4-FFF2-40B4-BE49-F238E27FC236}">
-                <a16:creationId xmlns:a16="http://schemas.microsoft.com/office/drawing/2014/main" id="{ED027C14-586B-4014-BD71-5BC27A3F2CB5}"/>
+                <a16:creationId xmlns:a16="http://schemas.microsoft.com/office/drawing/2014/main" id="{EF1CC71A-C229-41DB-BBAF-1E38061ABAE3}"/>
               </a:ext>
             </a:extLst>
           </p:cNvPr>
@@ -13047,7 +13309,7 @@
     </p:spTree>
     <p:extLst>
       <p:ext uri="{BB962C8B-B14F-4D97-AF65-F5344CB8AC3E}">
-        <p14:creationId xmlns:p14="http://schemas.microsoft.com/office/powerpoint/2010/main" val="898328654"/>
+        <p14:creationId xmlns:p14="http://schemas.microsoft.com/office/powerpoint/2010/main" val="1740811960"/>
       </p:ext>
     </p:extLst>
   </p:cSld>
@@ -13078,7 +13340,7 @@
           <p:cNvPr id="12" name="">
             <a:extLst xmlns:a="http://schemas.openxmlformats.org/drawingml/2006/main">
               <a:ext uri="{FF2B5EF4-FFF2-40B4-BE49-F238E27FC236}">
-                <a16:creationId xmlns:a16="http://schemas.microsoft.com/office/drawing/2014/main" id="{C8024367-3954-4EC2-ABA9-F5B5BBFC2FA9}"/>
+                <a16:creationId xmlns:a16="http://schemas.microsoft.com/office/drawing/2014/main" id="{BC114E8C-8101-44ED-A64D-B8481ED4C48A}"/>
               </a:ext>
             </a:extLst>
           </p:cNvPr>
@@ -13108,7 +13370,7 @@
           <p:cNvPr id="2" name="">
             <a:extLst xmlns:a="http://schemas.openxmlformats.org/drawingml/2006/main">
               <a:ext uri="{FF2B5EF4-FFF2-40B4-BE49-F238E27FC236}">
-                <a16:creationId xmlns:a16="http://schemas.microsoft.com/office/drawing/2014/main" id="{DCC543FC-D7DE-46AA-9092-DD4E35A75E2B}"/>
+                <a16:creationId xmlns:a16="http://schemas.microsoft.com/office/drawing/2014/main" id="{72DB6781-C24F-49CB-9087-C3A8C4F77A2E}"/>
               </a:ext>
             </a:extLst>
           </p:cNvPr>
@@ -13165,7 +13427,7 @@
           <p:cNvPr id="3" name="">
             <a:extLst xmlns:a="http://schemas.openxmlformats.org/drawingml/2006/main">
               <a:ext uri="{FF2B5EF4-FFF2-40B4-BE49-F238E27FC236}">
-                <a16:creationId xmlns:a16="http://schemas.microsoft.com/office/drawing/2014/main" id="{0EBE2943-D19C-42CD-83FA-164ABEE3406D}"/>
+                <a16:creationId xmlns:a16="http://schemas.microsoft.com/office/drawing/2014/main" id="{257043BD-FC96-47C7-AA8F-E8AB27570460}"/>
               </a:ext>
             </a:extLst>
           </p:cNvPr>
@@ -13195,7 +13457,7 @@
           <p:cNvPr id="4" name="">
             <a:extLst xmlns:a="http://schemas.openxmlformats.org/drawingml/2006/main">
               <a:ext uri="{FF2B5EF4-FFF2-40B4-BE49-F238E27FC236}">
-                <a16:creationId xmlns:a16="http://schemas.microsoft.com/office/drawing/2014/main" id="{39BFE846-E41A-468E-9776-6CFBC7109082}"/>
+                <a16:creationId xmlns:a16="http://schemas.microsoft.com/office/drawing/2014/main" id="{A6413FE1-E63A-4875-9C89-F8D5435E9C84}"/>
               </a:ext>
             </a:extLst>
           </p:cNvPr>
@@ -13252,7 +13514,7 @@
           <p:cNvPr id="5" name="">
             <a:extLst xmlns:a="http://schemas.openxmlformats.org/drawingml/2006/main">
               <a:ext uri="{FF2B5EF4-FFF2-40B4-BE49-F238E27FC236}">
-                <a16:creationId xmlns:a16="http://schemas.microsoft.com/office/drawing/2014/main" id="{C386D17B-C6EF-42F2-840A-3642773D09D7}"/>
+                <a16:creationId xmlns:a16="http://schemas.microsoft.com/office/drawing/2014/main" id="{E143FF19-D41E-432F-BDD0-8F87C2D3E94F}"/>
               </a:ext>
             </a:extLst>
           </p:cNvPr>
@@ -13284,7 +13546,7 @@
           <p:cNvPr id="6" name="">
             <a:extLst xmlns:a="http://schemas.openxmlformats.org/drawingml/2006/main">
               <a:ext uri="{FF2B5EF4-FFF2-40B4-BE49-F238E27FC236}">
-                <a16:creationId xmlns:a16="http://schemas.microsoft.com/office/drawing/2014/main" id="{15487AD4-A7C0-42EC-A76A-9A380C0B8CC4}"/>
+                <a16:creationId xmlns:a16="http://schemas.microsoft.com/office/drawing/2014/main" id="{A6E97CA5-A9F0-434C-A830-9090C6543549}"/>
               </a:ext>
             </a:extLst>
           </p:cNvPr>
@@ -13320,7 +13582,7 @@
           <p:nvPr/>
         </p:nvPicPr>
         <p:blipFill>
-          <a:blip xmlns:r="http://schemas.openxmlformats.org/officeDocument/2006/relationships" xmlns:a="http://schemas.openxmlformats.org/drawingml/2006/main" r:embed="R0cdf53d7dcf443ed"/>
+          <a:blip xmlns:r="http://schemas.openxmlformats.org/officeDocument/2006/relationships" xmlns:a="http://schemas.openxmlformats.org/drawingml/2006/main" r:embed="Rf04cffc3e0504d48"/>
           <a:stretch xmlns:a="http://schemas.openxmlformats.org/drawingml/2006/main"/>
         </p:blipFill>
         <p:spPr>
@@ -13342,7 +13604,7 @@
           <p:nvPr/>
         </p:nvPicPr>
         <p:blipFill>
-          <a:blip xmlns:r="http://schemas.openxmlformats.org/officeDocument/2006/relationships" xmlns:a="http://schemas.openxmlformats.org/drawingml/2006/main" r:embed="R2a8cc023249a4fac"/>
+          <a:blip xmlns:r="http://schemas.openxmlformats.org/officeDocument/2006/relationships" xmlns:a="http://schemas.openxmlformats.org/drawingml/2006/main" r:embed="Re232f79b6c1746a2"/>
           <a:stretch xmlns:a="http://schemas.openxmlformats.org/drawingml/2006/main"/>
         </p:blipFill>
         <p:spPr>
@@ -13360,7 +13622,7 @@
           <p:cNvPr id="9" name="">
             <a:extLst xmlns:a="http://schemas.openxmlformats.org/drawingml/2006/main">
               <a:ext uri="{FF2B5EF4-FFF2-40B4-BE49-F238E27FC236}">
-                <a16:creationId xmlns:a16="http://schemas.microsoft.com/office/drawing/2014/main" id="{C00C635E-376E-4698-980D-DCB591B4CCE3}"/>
+                <a16:creationId xmlns:a16="http://schemas.microsoft.com/office/drawing/2014/main" id="{2B62F258-BD70-4C80-A810-397EF4A28483}"/>
               </a:ext>
             </a:extLst>
           </p:cNvPr>
@@ -13417,7 +13679,7 @@
           <p:cNvPr id="10" name="">
             <a:extLst xmlns:a="http://schemas.openxmlformats.org/drawingml/2006/main">
               <a:ext uri="{FF2B5EF4-FFF2-40B4-BE49-F238E27FC236}">
-                <a16:creationId xmlns:a16="http://schemas.microsoft.com/office/drawing/2014/main" id="{96BA35E0-6FDA-4A0C-A4C6-1E08D0B4E1C4}"/>
+                <a16:creationId xmlns:a16="http://schemas.microsoft.com/office/drawing/2014/main" id="{951AA9B9-CD49-4589-890D-E089A3074958}"/>
               </a:ext>
             </a:extLst>
           </p:cNvPr>
@@ -13474,7 +13736,7 @@
           <p:cNvPr id="11" name="">
             <a:extLst xmlns:a="http://schemas.openxmlformats.org/drawingml/2006/main">
               <a:ext uri="{FF2B5EF4-FFF2-40B4-BE49-F238E27FC236}">
-                <a16:creationId xmlns:a16="http://schemas.microsoft.com/office/drawing/2014/main" id="{39CC9FDD-C4C1-4573-BCA3-54CD4ADB76F8}"/>
+                <a16:creationId xmlns:a16="http://schemas.microsoft.com/office/drawing/2014/main" id="{35C3CD68-B5BC-4724-A60F-46DA886E3FB8}"/>
               </a:ext>
             </a:extLst>
           </p:cNvPr>
@@ -13529,7 +13791,7 @@
     </p:spTree>
     <p:extLst>
       <p:ext uri="{BB962C8B-B14F-4D97-AF65-F5344CB8AC3E}">
-        <p14:creationId xmlns:p14="http://schemas.microsoft.com/office/powerpoint/2010/main" val="869784241"/>
+        <p14:creationId xmlns:p14="http://schemas.microsoft.com/office/powerpoint/2010/main" val="1315261781"/>
       </p:ext>
     </p:extLst>
   </p:cSld>
@@ -13560,7 +13822,7 @@
           <p:cNvPr id="27" name="">
             <a:extLst xmlns:a="http://schemas.openxmlformats.org/drawingml/2006/main">
               <a:ext uri="{FF2B5EF4-FFF2-40B4-BE49-F238E27FC236}">
-                <a16:creationId xmlns:a16="http://schemas.microsoft.com/office/drawing/2014/main" id="{CCC285D4-BE89-44CD-B208-16D9E5431240}"/>
+                <a16:creationId xmlns:a16="http://schemas.microsoft.com/office/drawing/2014/main" id="{66620607-C16B-4F49-83AC-AD06F4ADEDF5}"/>
               </a:ext>
             </a:extLst>
           </p:cNvPr>
@@ -13590,7 +13852,7 @@
           <p:cNvPr id="2" name="">
             <a:extLst xmlns:a="http://schemas.openxmlformats.org/drawingml/2006/main">
               <a:ext uri="{FF2B5EF4-FFF2-40B4-BE49-F238E27FC236}">
-                <a16:creationId xmlns:a16="http://schemas.microsoft.com/office/drawing/2014/main" id="{5A27CCCA-86C7-465B-B1F3-6A1716FE2E8A}"/>
+                <a16:creationId xmlns:a16="http://schemas.microsoft.com/office/drawing/2014/main" id="{8A339FC0-4078-456A-87BC-8D001F25EE23}"/>
               </a:ext>
             </a:extLst>
           </p:cNvPr>
@@ -13647,7 +13909,7 @@
           <p:cNvPr id="3" name="">
             <a:extLst xmlns:a="http://schemas.openxmlformats.org/drawingml/2006/main">
               <a:ext uri="{FF2B5EF4-FFF2-40B4-BE49-F238E27FC236}">
-                <a16:creationId xmlns:a16="http://schemas.microsoft.com/office/drawing/2014/main" id="{E46A93BB-6B22-4BBD-AA47-F52C85883617}"/>
+                <a16:creationId xmlns:a16="http://schemas.microsoft.com/office/drawing/2014/main" id="{AAE1ADD2-A7F9-4090-A5C9-7D1A27D52BD4}"/>
               </a:ext>
             </a:extLst>
           </p:cNvPr>
@@ -13677,7 +13939,7 @@
           <p:cNvPr id="4" name="">
             <a:extLst xmlns:a="http://schemas.openxmlformats.org/drawingml/2006/main">
               <a:ext uri="{FF2B5EF4-FFF2-40B4-BE49-F238E27FC236}">
-                <a16:creationId xmlns:a16="http://schemas.microsoft.com/office/drawing/2014/main" id="{47044750-16D1-47C0-8F9C-2E8607CA14E4}"/>
+                <a16:creationId xmlns:a16="http://schemas.microsoft.com/office/drawing/2014/main" id="{90F7CD2E-A540-4707-AD50-B707010A9BC7}"/>
               </a:ext>
             </a:extLst>
           </p:cNvPr>
@@ -13734,7 +13996,7 @@
           <p:cNvPr id="5" name="">
             <a:extLst xmlns:a="http://schemas.openxmlformats.org/drawingml/2006/main">
               <a:ext uri="{FF2B5EF4-FFF2-40B4-BE49-F238E27FC236}">
-                <a16:creationId xmlns:a16="http://schemas.microsoft.com/office/drawing/2014/main" id="{5A56D8E7-4021-4EEE-8C0F-A98FC11BAD72}"/>
+                <a16:creationId xmlns:a16="http://schemas.microsoft.com/office/drawing/2014/main" id="{34F8B9FD-B94E-4D7E-8029-9040312E6B4B}"/>
               </a:ext>
             </a:extLst>
           </p:cNvPr>
@@ -13766,7 +14028,7 @@
           <p:cNvPr id="6" name="">
             <a:extLst xmlns:a="http://schemas.openxmlformats.org/drawingml/2006/main">
               <a:ext uri="{FF2B5EF4-FFF2-40B4-BE49-F238E27FC236}">
-                <a16:creationId xmlns:a16="http://schemas.microsoft.com/office/drawing/2014/main" id="{28A04DA3-F972-471C-A71E-57D70FB116AB}"/>
+                <a16:creationId xmlns:a16="http://schemas.microsoft.com/office/drawing/2014/main" id="{0F6630C8-ED14-4541-8908-216D45A97F0B}"/>
               </a:ext>
             </a:extLst>
           </p:cNvPr>
@@ -13823,7 +14085,7 @@
           <p:cNvPr id="7" name="">
             <a:extLst xmlns:a="http://schemas.openxmlformats.org/drawingml/2006/main">
               <a:ext uri="{FF2B5EF4-FFF2-40B4-BE49-F238E27FC236}">
-                <a16:creationId xmlns:a16="http://schemas.microsoft.com/office/drawing/2014/main" id="{195B956A-F889-4BC8-8FAD-FDB61721FEAA}"/>
+                <a16:creationId xmlns:a16="http://schemas.microsoft.com/office/drawing/2014/main" id="{EB864EDB-4485-4992-A782-CF4B80258B47}"/>
               </a:ext>
             </a:extLst>
           </p:cNvPr>
@@ -13880,7 +14142,7 @@
           <p:cNvPr id="8" name="">
             <a:extLst xmlns:a="http://schemas.openxmlformats.org/drawingml/2006/main">
               <a:ext uri="{FF2B5EF4-FFF2-40B4-BE49-F238E27FC236}">
-                <a16:creationId xmlns:a16="http://schemas.microsoft.com/office/drawing/2014/main" id="{D51BBF5F-3D39-45FE-A6AA-30B2D1B1B2FD}"/>
+                <a16:creationId xmlns:a16="http://schemas.microsoft.com/office/drawing/2014/main" id="{9E3494F2-5924-4BD5-AD9E-03951DF27760}"/>
               </a:ext>
             </a:extLst>
           </p:cNvPr>
@@ -13960,7 +14222,7 @@
           <p:cNvPr id="9" name="">
             <a:extLst xmlns:a="http://schemas.openxmlformats.org/drawingml/2006/main">
               <a:ext uri="{FF2B5EF4-FFF2-40B4-BE49-F238E27FC236}">
-                <a16:creationId xmlns:a16="http://schemas.microsoft.com/office/drawing/2014/main" id="{1F3E1DF0-7F22-4ADD-8EF4-C92E2B82F800}"/>
+                <a16:creationId xmlns:a16="http://schemas.microsoft.com/office/drawing/2014/main" id="{4ADF35E7-2CDD-4402-8FED-4F61A6B83E65}"/>
               </a:ext>
             </a:extLst>
           </p:cNvPr>
@@ -13992,7 +14254,7 @@
           <p:cNvPr id="10" name="">
             <a:extLst xmlns:a="http://schemas.openxmlformats.org/drawingml/2006/main">
               <a:ext uri="{FF2B5EF4-FFF2-40B4-BE49-F238E27FC236}">
-                <a16:creationId xmlns:a16="http://schemas.microsoft.com/office/drawing/2014/main" id="{7E0BEE9D-8058-4979-97C1-6DDF482824FF}"/>
+                <a16:creationId xmlns:a16="http://schemas.microsoft.com/office/drawing/2014/main" id="{570CB376-955E-43C1-8496-924E16FA7B67}"/>
               </a:ext>
             </a:extLst>
           </p:cNvPr>
@@ -14049,7 +14311,7 @@
           <p:cNvPr id="11" name="">
             <a:extLst xmlns:a="http://schemas.openxmlformats.org/drawingml/2006/main">
               <a:ext uri="{FF2B5EF4-FFF2-40B4-BE49-F238E27FC236}">
-                <a16:creationId xmlns:a16="http://schemas.microsoft.com/office/drawing/2014/main" id="{5C00443C-3DDB-4AF0-9870-9C38B8A1C9BE}"/>
+                <a16:creationId xmlns:a16="http://schemas.microsoft.com/office/drawing/2014/main" id="{A612C935-46EA-470F-B19D-67AF21FFFDF2}"/>
               </a:ext>
             </a:extLst>
           </p:cNvPr>
@@ -14106,7 +14368,7 @@
           <p:cNvPr id="12" name="">
             <a:extLst xmlns:a="http://schemas.openxmlformats.org/drawingml/2006/main">
               <a:ext uri="{FF2B5EF4-FFF2-40B4-BE49-F238E27FC236}">
-                <a16:creationId xmlns:a16="http://schemas.microsoft.com/office/drawing/2014/main" id="{ED55EF5F-306D-490E-BED3-590C03261ABF}"/>
+                <a16:creationId xmlns:a16="http://schemas.microsoft.com/office/drawing/2014/main" id="{5DA930FC-D04C-4246-86E5-FBCDD446A9A8}"/>
               </a:ext>
             </a:extLst>
           </p:cNvPr>
@@ -14186,7 +14448,7 @@
           <p:cNvPr id="13" name="">
             <a:extLst xmlns:a="http://schemas.openxmlformats.org/drawingml/2006/main">
               <a:ext uri="{FF2B5EF4-FFF2-40B4-BE49-F238E27FC236}">
-                <a16:creationId xmlns:a16="http://schemas.microsoft.com/office/drawing/2014/main" id="{0FD6663E-4C55-4087-8762-B18DEC2F54F3}"/>
+                <a16:creationId xmlns:a16="http://schemas.microsoft.com/office/drawing/2014/main" id="{E369BDB6-5DB5-40C7-904F-1D2C77283963}"/>
               </a:ext>
             </a:extLst>
           </p:cNvPr>
@@ -14218,7 +14480,7 @@
           <p:cNvPr id="14" name="">
             <a:extLst xmlns:a="http://schemas.openxmlformats.org/drawingml/2006/main">
               <a:ext uri="{FF2B5EF4-FFF2-40B4-BE49-F238E27FC236}">
-                <a16:creationId xmlns:a16="http://schemas.microsoft.com/office/drawing/2014/main" id="{B8D9A99B-4059-45FC-95E4-422939EAFD5E}"/>
+                <a16:creationId xmlns:a16="http://schemas.microsoft.com/office/drawing/2014/main" id="{F05FC300-37F1-4B36-A04F-0D94257830EF}"/>
               </a:ext>
             </a:extLst>
           </p:cNvPr>
@@ -14275,7 +14537,7 @@
           <p:cNvPr id="15" name="">
             <a:extLst xmlns:a="http://schemas.openxmlformats.org/drawingml/2006/main">
               <a:ext uri="{FF2B5EF4-FFF2-40B4-BE49-F238E27FC236}">
-                <a16:creationId xmlns:a16="http://schemas.microsoft.com/office/drawing/2014/main" id="{90275CD0-7700-4E56-AE50-A0702EDF8869}"/>
+                <a16:creationId xmlns:a16="http://schemas.microsoft.com/office/drawing/2014/main" id="{C2898703-D961-4C3F-AEB0-0B712906F12F}"/>
               </a:ext>
             </a:extLst>
           </p:cNvPr>
@@ -14332,7 +14594,7 @@
           <p:cNvPr id="16" name="">
             <a:extLst xmlns:a="http://schemas.openxmlformats.org/drawingml/2006/main">
               <a:ext uri="{FF2B5EF4-FFF2-40B4-BE49-F238E27FC236}">
-                <a16:creationId xmlns:a16="http://schemas.microsoft.com/office/drawing/2014/main" id="{5D5A6DD5-80BF-433F-B853-9AC42876F45F}"/>
+                <a16:creationId xmlns:a16="http://schemas.microsoft.com/office/drawing/2014/main" id="{7ED8CA61-D862-45A6-B189-904A3A02326E}"/>
               </a:ext>
             </a:extLst>
           </p:cNvPr>
@@ -14412,7 +14674,7 @@
           <p:cNvPr id="17" name="">
             <a:extLst xmlns:a="http://schemas.openxmlformats.org/drawingml/2006/main">
               <a:ext uri="{FF2B5EF4-FFF2-40B4-BE49-F238E27FC236}">
-                <a16:creationId xmlns:a16="http://schemas.microsoft.com/office/drawing/2014/main" id="{FD1A89A9-56A5-4A3D-950C-A195C13A0976}"/>
+                <a16:creationId xmlns:a16="http://schemas.microsoft.com/office/drawing/2014/main" id="{03EF750B-D497-4643-A4C8-7C1601626BF2}"/>
               </a:ext>
             </a:extLst>
           </p:cNvPr>
@@ -14444,7 +14706,7 @@
           <p:cNvPr id="18" name="">
             <a:extLst xmlns:a="http://schemas.openxmlformats.org/drawingml/2006/main">
               <a:ext uri="{FF2B5EF4-FFF2-40B4-BE49-F238E27FC236}">
-                <a16:creationId xmlns:a16="http://schemas.microsoft.com/office/drawing/2014/main" id="{DCD8676D-CC27-4E38-8EC6-89C94734E507}"/>
+                <a16:creationId xmlns:a16="http://schemas.microsoft.com/office/drawing/2014/main" id="{01D8DA9D-5248-4972-9484-BC08961176E5}"/>
               </a:ext>
             </a:extLst>
           </p:cNvPr>
@@ -14501,7 +14763,7 @@
           <p:cNvPr id="19" name="">
             <a:extLst xmlns:a="http://schemas.openxmlformats.org/drawingml/2006/main">
               <a:ext uri="{FF2B5EF4-FFF2-40B4-BE49-F238E27FC236}">
-                <a16:creationId xmlns:a16="http://schemas.microsoft.com/office/drawing/2014/main" id="{B68E4BCE-8405-4895-B4F0-EA4A3C7F4216}"/>
+                <a16:creationId xmlns:a16="http://schemas.microsoft.com/office/drawing/2014/main" id="{4FE5EEDC-AFF4-444B-A246-AD1BF5EA7200}"/>
               </a:ext>
             </a:extLst>
           </p:cNvPr>
@@ -14558,7 +14820,7 @@
           <p:cNvPr id="20" name="">
             <a:extLst xmlns:a="http://schemas.openxmlformats.org/drawingml/2006/main">
               <a:ext uri="{FF2B5EF4-FFF2-40B4-BE49-F238E27FC236}">
-                <a16:creationId xmlns:a16="http://schemas.microsoft.com/office/drawing/2014/main" id="{B381E92A-D8E0-4F0D-BB16-856032BAA336}"/>
+                <a16:creationId xmlns:a16="http://schemas.microsoft.com/office/drawing/2014/main" id="{D9EA0EBA-46EA-4BD4-97A9-2157B9435683}"/>
               </a:ext>
             </a:extLst>
           </p:cNvPr>
@@ -14638,7 +14900,7 @@
           <p:cNvPr id="21" name="">
             <a:extLst xmlns:a="http://schemas.openxmlformats.org/drawingml/2006/main">
               <a:ext uri="{FF2B5EF4-FFF2-40B4-BE49-F238E27FC236}">
-                <a16:creationId xmlns:a16="http://schemas.microsoft.com/office/drawing/2014/main" id="{4C87A0D0-CEEC-4051-96E5-3D4432CF962D}"/>
+                <a16:creationId xmlns:a16="http://schemas.microsoft.com/office/drawing/2014/main" id="{2FDD2A37-AB97-4CAC-816C-F62C96E35B0C}"/>
               </a:ext>
             </a:extLst>
           </p:cNvPr>
@@ -14695,7 +14957,7 @@
           <p:cNvPr id="22" name="">
             <a:extLst xmlns:a="http://schemas.openxmlformats.org/drawingml/2006/main">
               <a:ext uri="{FF2B5EF4-FFF2-40B4-BE49-F238E27FC236}">
-                <a16:creationId xmlns:a16="http://schemas.microsoft.com/office/drawing/2014/main" id="{9619E60A-EC20-4A97-8D2A-9B0B97475F39}"/>
+                <a16:creationId xmlns:a16="http://schemas.microsoft.com/office/drawing/2014/main" id="{BC4009C3-0A07-4029-8396-2BA8FCE6501C}"/>
               </a:ext>
             </a:extLst>
           </p:cNvPr>
@@ -14752,7 +15014,7 @@
           <p:cNvPr id="23" name="">
             <a:extLst xmlns:a="http://schemas.openxmlformats.org/drawingml/2006/main">
               <a:ext uri="{FF2B5EF4-FFF2-40B4-BE49-F238E27FC236}">
-                <a16:creationId xmlns:a16="http://schemas.microsoft.com/office/drawing/2014/main" id="{A6D99B69-898A-4313-A73D-F833FCC85E09}"/>
+                <a16:creationId xmlns:a16="http://schemas.microsoft.com/office/drawing/2014/main" id="{6BD5B5BF-5A90-4C46-A437-D7D94060AEC2}"/>
               </a:ext>
             </a:extLst>
           </p:cNvPr>
@@ -14809,7 +15071,7 @@
           <p:cNvPr id="24" name="">
             <a:extLst xmlns:a="http://schemas.openxmlformats.org/drawingml/2006/main">
               <a:ext uri="{FF2B5EF4-FFF2-40B4-BE49-F238E27FC236}">
-                <a16:creationId xmlns:a16="http://schemas.microsoft.com/office/drawing/2014/main" id="{C859FE63-69B0-4B3C-9DB9-2CA98CB28A0F}"/>
+                <a16:creationId xmlns:a16="http://schemas.microsoft.com/office/drawing/2014/main" id="{1627FAE8-6934-48E5-94AE-F772DCCA403B}"/>
               </a:ext>
             </a:extLst>
           </p:cNvPr>
@@ -14866,7 +15128,7 @@
           <p:cNvPr id="25" name="">
             <a:extLst xmlns:a="http://schemas.openxmlformats.org/drawingml/2006/main">
               <a:ext uri="{FF2B5EF4-FFF2-40B4-BE49-F238E27FC236}">
-                <a16:creationId xmlns:a16="http://schemas.microsoft.com/office/drawing/2014/main" id="{5AADF754-2CE1-494A-A988-003AE41F8E94}"/>
+                <a16:creationId xmlns:a16="http://schemas.microsoft.com/office/drawing/2014/main" id="{2EF215B9-8A57-4A60-80AE-701B6D9036EF}"/>
               </a:ext>
             </a:extLst>
           </p:cNvPr>
@@ -14923,7 +15185,7 @@
           <p:cNvPr id="26" name="">
             <a:extLst xmlns:a="http://schemas.openxmlformats.org/drawingml/2006/main">
               <a:ext uri="{FF2B5EF4-FFF2-40B4-BE49-F238E27FC236}">
-                <a16:creationId xmlns:a16="http://schemas.microsoft.com/office/drawing/2014/main" id="{1A15AE8C-5931-4A30-B2EC-79F77FFB6964}"/>
+                <a16:creationId xmlns:a16="http://schemas.microsoft.com/office/drawing/2014/main" id="{0D7C30DA-802D-4833-A661-2E01416ACFA4}"/>
               </a:ext>
             </a:extLst>
           </p:cNvPr>
@@ -14978,7 +15240,7 @@
     </p:spTree>
     <p:extLst>
       <p:ext uri="{BB962C8B-B14F-4D97-AF65-F5344CB8AC3E}">
-        <p14:creationId xmlns:p14="http://schemas.microsoft.com/office/powerpoint/2010/main" val="360402470"/>
+        <p14:creationId xmlns:p14="http://schemas.microsoft.com/office/powerpoint/2010/main" val="1067670571"/>
       </p:ext>
     </p:extLst>
   </p:cSld>

</xml_diff>

<commit_message>
docs: update final MEMOIVE presentation (#9)
</commit_message>
<xml_diff>
--- a/docs/presentation/MEMOIVE-Presentation.pptx
+++ b/docs/presentation/MEMOIVE-Presentation.pptx
@@ -2,26 +2,26 @@
 <file path=ppt/presentation.xml><?xml version="1.0" encoding="utf-8"?>
 <p:presentation xmlns:p="http://schemas.openxmlformats.org/presentationml/2006/main">
   <p:sldMasterIdLst>
-    <p:sldMasterId xmlns:r="http://schemas.openxmlformats.org/officeDocument/2006/relationships" id="2147483648" r:id="R853691cbd4af4d44"/>
+    <p:sldMasterId xmlns:r="http://schemas.openxmlformats.org/officeDocument/2006/relationships" id="2147483648" r:id="R63389ff20b7d4eed"/>
   </p:sldMasterIdLst>
   <p:notesMasterIdLst>
-    <p:notesMasterId xmlns:r="http://schemas.openxmlformats.org/officeDocument/2006/relationships" r:id="R32fa908d408f4bc9"/>
+    <p:notesMasterId xmlns:r="http://schemas.openxmlformats.org/officeDocument/2006/relationships" r:id="Rb497f1323ac941dc"/>
   </p:notesMasterIdLst>
   <p:sldIdLst>
-    <p:sldId xmlns:r="http://schemas.openxmlformats.org/officeDocument/2006/relationships" id="256" r:id="R4c237f2d9ac04a7c"/>
-    <p:sldId xmlns:r="http://schemas.openxmlformats.org/officeDocument/2006/relationships" id="257" r:id="R4ea614e8291647e3"/>
-    <p:sldId xmlns:r="http://schemas.openxmlformats.org/officeDocument/2006/relationships" id="258" r:id="Rcac125ff0d8b4faa"/>
-    <p:sldId xmlns:r="http://schemas.openxmlformats.org/officeDocument/2006/relationships" id="259" r:id="Rd7fa796374df4692"/>
-    <p:sldId xmlns:r="http://schemas.openxmlformats.org/officeDocument/2006/relationships" id="260" r:id="R48ac85d05d754184"/>
-    <p:sldId xmlns:r="http://schemas.openxmlformats.org/officeDocument/2006/relationships" id="261" r:id="R403a719b2c6748b0"/>
-    <p:sldId xmlns:r="http://schemas.openxmlformats.org/officeDocument/2006/relationships" id="262" r:id="R7784b55f52314ada"/>
-    <p:sldId xmlns:r="http://schemas.openxmlformats.org/officeDocument/2006/relationships" id="263" r:id="R2829f3ebaa6b4f9c"/>
-    <p:sldId xmlns:r="http://schemas.openxmlformats.org/officeDocument/2006/relationships" id="264" r:id="R6ab3d53fac314fc6"/>
-    <p:sldId xmlns:r="http://schemas.openxmlformats.org/officeDocument/2006/relationships" id="265" r:id="R6da1475ba7d14186"/>
-    <p:sldId xmlns:r="http://schemas.openxmlformats.org/officeDocument/2006/relationships" id="266" r:id="R5807f4239d864dea"/>
-    <p:sldId xmlns:r="http://schemas.openxmlformats.org/officeDocument/2006/relationships" id="267" r:id="R4192a8182848496c"/>
-    <p:sldId xmlns:r="http://schemas.openxmlformats.org/officeDocument/2006/relationships" id="268" r:id="Rc29bfedfdc4e4a60"/>
-    <p:sldId xmlns:r="http://schemas.openxmlformats.org/officeDocument/2006/relationships" id="269" r:id="Rb738c833bd974ea2"/>
+    <p:sldId xmlns:r="http://schemas.openxmlformats.org/officeDocument/2006/relationships" id="256" r:id="R1739812baeb64f79"/>
+    <p:sldId xmlns:r="http://schemas.openxmlformats.org/officeDocument/2006/relationships" id="257" r:id="R6fbbc29ce7904e98"/>
+    <p:sldId xmlns:r="http://schemas.openxmlformats.org/officeDocument/2006/relationships" id="258" r:id="R0c7cba70407243af"/>
+    <p:sldId xmlns:r="http://schemas.openxmlformats.org/officeDocument/2006/relationships" id="259" r:id="R91735f8c03cb44c9"/>
+    <p:sldId xmlns:r="http://schemas.openxmlformats.org/officeDocument/2006/relationships" id="260" r:id="Rffe5c07723364782"/>
+    <p:sldId xmlns:r="http://schemas.openxmlformats.org/officeDocument/2006/relationships" id="261" r:id="R30324338e4d341b7"/>
+    <p:sldId xmlns:r="http://schemas.openxmlformats.org/officeDocument/2006/relationships" id="262" r:id="R804a309e3c97409e"/>
+    <p:sldId xmlns:r="http://schemas.openxmlformats.org/officeDocument/2006/relationships" id="263" r:id="Rcdf0f5579d3a493e"/>
+    <p:sldId xmlns:r="http://schemas.openxmlformats.org/officeDocument/2006/relationships" id="264" r:id="R5136b9a09f634f70"/>
+    <p:sldId xmlns:r="http://schemas.openxmlformats.org/officeDocument/2006/relationships" id="265" r:id="R5d1a575e057844b7"/>
+    <p:sldId xmlns:r="http://schemas.openxmlformats.org/officeDocument/2006/relationships" id="266" r:id="R870ab957b1ec4876"/>
+    <p:sldId xmlns:r="http://schemas.openxmlformats.org/officeDocument/2006/relationships" id="267" r:id="R4b9d3561e23c4b63"/>
+    <p:sldId xmlns:r="http://schemas.openxmlformats.org/officeDocument/2006/relationships" id="268" r:id="R7187c620ce2542d2"/>
+    <p:sldId xmlns:r="http://schemas.openxmlformats.org/officeDocument/2006/relationships" id="269" r:id="Raeac6acf29b14569"/>
   </p:sldIdLst>
   <p:sldSz cx="12192000" cy="6858000"/>
   <p:notesSz cx="6858000" cy="9144000"/>
@@ -935,7 +935,7 @@
           </a:p>
           <a:p xmlns:a="http://schemas.openxmlformats.org/drawingml/2006/main">
             <a:r>
-              <a:t>메모이브는 memoive.vercel.app에서 확인할 수 있습니다. 지금까지는 제가 반복해서 쓸 수 있는 흐름을 만들고 운영 화면에서 확인했습니다. 다음 단계에서는 다른 사람에게도 정리 시간이 줄고 생각의 확장이 이어지는지 행동과 시간으로 검증하겠습니다. 감사합니다.</a:t>
+              <a:t>메모이브는 memoive.vercel.app에서 확인할 수 있습니다. 다음 단계에서는 먼저 3명을 관찰하고 5명 시험으로 막히는 위치와 시간 단축을 확인하겠습니다. 여러 사용자가 쓰는 단계에 도달하면 계정 로그인과 사용자별 기록 권한을 구현하고, 반복 사용이 확인되면 검색 필터와 결과물 버전 관리를 개선하겠습니다. 검증 결과에 따라 필요한 기능부터 구현하겠습니다. 감사합니다.</a:t>
             </a:r>
           </a:p>
           <a:p xmlns:a="http://schemas.openxmlformats.org/drawingml/2006/main">
@@ -1783,7 +1783,7 @@
   </p:cSld>
   <p:clrMap bg1="lt1" tx1="dk1" bg2="lt2" tx2="dk2" accent1="accent1" accent2="accent2" accent3="accent3" accent4="accent4" accent5="accent5" accent6="accent6" hlink="hlink" folHlink="folHlink"/>
   <p:sldLayoutIdLst>
-    <p:sldLayoutId xmlns:r="http://schemas.openxmlformats.org/officeDocument/2006/relationships" id="2147483649" r:id="R593f9560da4540b9"/>
+    <p:sldLayoutId xmlns:r="http://schemas.openxmlformats.org/officeDocument/2006/relationships" id="2147483649" r:id="Red940412a11a41a4"/>
   </p:sldLayoutIdLst>
   <p:txStyles>
     <p:titleStyle>
@@ -2334,7 +2334,7 @@
           <p:cNvPr id="9" name="">
             <a:extLst xmlns:a="http://schemas.openxmlformats.org/drawingml/2006/main">
               <a:ext uri="{FF2B5EF4-FFF2-40B4-BE49-F238E27FC236}">
-                <a16:creationId xmlns:a16="http://schemas.microsoft.com/office/drawing/2014/main" id="{37CD7423-B97B-4AD0-85FA-A745126BFFA4}"/>
+                <a16:creationId xmlns:a16="http://schemas.microsoft.com/office/drawing/2014/main" id="{E30A8B98-532C-4E10-A8E4-C4239BBB3436}"/>
               </a:ext>
             </a:extLst>
           </p:cNvPr>
@@ -2391,7 +2391,7 @@
           <p:cNvPr id="2" name="">
             <a:extLst xmlns:a="http://schemas.openxmlformats.org/drawingml/2006/main">
               <a:ext uri="{FF2B5EF4-FFF2-40B4-BE49-F238E27FC236}">
-                <a16:creationId xmlns:a16="http://schemas.microsoft.com/office/drawing/2014/main" id="{8469375B-DD6A-44A5-8107-F393CFC68E29}"/>
+                <a16:creationId xmlns:a16="http://schemas.microsoft.com/office/drawing/2014/main" id="{F8AD504B-8E3B-4222-9985-CDE3310167DA}"/>
               </a:ext>
             </a:extLst>
           </p:cNvPr>
@@ -2448,7 +2448,7 @@
           <p:cNvPr id="3" name="">
             <a:extLst xmlns:a="http://schemas.openxmlformats.org/drawingml/2006/main">
               <a:ext uri="{FF2B5EF4-FFF2-40B4-BE49-F238E27FC236}">
-                <a16:creationId xmlns:a16="http://schemas.microsoft.com/office/drawing/2014/main" id="{328CB4A4-CADD-43B0-AD29-E72ACDA4CB10}"/>
+                <a16:creationId xmlns:a16="http://schemas.microsoft.com/office/drawing/2014/main" id="{727D0573-4949-4544-8260-B53885A23628}"/>
               </a:ext>
             </a:extLst>
           </p:cNvPr>
@@ -2505,7 +2505,7 @@
           <p:cNvPr id="4" name="">
             <a:extLst xmlns:a="http://schemas.openxmlformats.org/drawingml/2006/main">
               <a:ext uri="{FF2B5EF4-FFF2-40B4-BE49-F238E27FC236}">
-                <a16:creationId xmlns:a16="http://schemas.microsoft.com/office/drawing/2014/main" id="{53EA3D75-EDA4-4DF5-8722-DA070879DCDE}"/>
+                <a16:creationId xmlns:a16="http://schemas.microsoft.com/office/drawing/2014/main" id="{6DA83F83-52C8-4A51-9FBA-402F5784B3B4}"/>
               </a:ext>
             </a:extLst>
           </p:cNvPr>
@@ -2562,7 +2562,7 @@
           <p:cNvPr id="5" name="">
             <a:extLst xmlns:a="http://schemas.openxmlformats.org/drawingml/2006/main">
               <a:ext uri="{FF2B5EF4-FFF2-40B4-BE49-F238E27FC236}">
-                <a16:creationId xmlns:a16="http://schemas.microsoft.com/office/drawing/2014/main" id="{8FA62D5A-6BA0-4579-B0AE-A9EE60060172}"/>
+                <a16:creationId xmlns:a16="http://schemas.microsoft.com/office/drawing/2014/main" id="{53E7D1E3-5324-46A0-8B61-A194B0966D70}"/>
               </a:ext>
             </a:extLst>
           </p:cNvPr>
@@ -2642,7 +2642,7 @@
           <p:cNvPr id="6" name="">
             <a:extLst xmlns:a="http://schemas.openxmlformats.org/drawingml/2006/main">
               <a:ext uri="{FF2B5EF4-FFF2-40B4-BE49-F238E27FC236}">
-                <a16:creationId xmlns:a16="http://schemas.microsoft.com/office/drawing/2014/main" id="{A8DCFACF-2D6C-4F56-9714-10AD198AB399}"/>
+                <a16:creationId xmlns:a16="http://schemas.microsoft.com/office/drawing/2014/main" id="{AADB7CA3-BCB2-475C-AD97-D23828F5301B}"/>
               </a:ext>
             </a:extLst>
           </p:cNvPr>
@@ -2672,7 +2672,7 @@
           <p:cNvPr id="7" name="">
             <a:extLst xmlns:a="http://schemas.openxmlformats.org/drawingml/2006/main">
               <a:ext uri="{FF2B5EF4-FFF2-40B4-BE49-F238E27FC236}">
-                <a16:creationId xmlns:a16="http://schemas.microsoft.com/office/drawing/2014/main" id="{3572FA69-AAC4-40BD-BF0F-510BFFE49BA3}"/>
+                <a16:creationId xmlns:a16="http://schemas.microsoft.com/office/drawing/2014/main" id="{CC35385D-6F54-44F2-B2A2-02778FD8C605}"/>
               </a:ext>
             </a:extLst>
           </p:cNvPr>
@@ -2719,7 +2719,7 @@
                 <a:ea typeface="Noto Sans KR"/>
                 <a:cs typeface="Noto Sans KR"/>
               </a:rPr>
-              <a:t>문제 정의 / 구현 / 검증 / 배운 점</a:t>
+              <a:t>문제 정의 / 구현 결과 / 다음 계획 / 배운 점</a:t>
             </a:r>
           </a:p>
         </p:txBody>
@@ -2729,7 +2729,7 @@
           <p:cNvPr id="8" name="">
             <a:extLst xmlns:a="http://schemas.openxmlformats.org/drawingml/2006/main">
               <a:ext uri="{FF2B5EF4-FFF2-40B4-BE49-F238E27FC236}">
-                <a16:creationId xmlns:a16="http://schemas.microsoft.com/office/drawing/2014/main" id="{AAE35A6D-88A4-4537-8F1F-9A2BF0B1342F}"/>
+                <a16:creationId xmlns:a16="http://schemas.microsoft.com/office/drawing/2014/main" id="{9D26C232-9378-45F7-8E13-D8C1EE586A12}"/>
               </a:ext>
             </a:extLst>
           </p:cNvPr>
@@ -2784,7 +2784,7 @@
     </p:spTree>
     <p:extLst>
       <p:ext uri="{BB962C8B-B14F-4D97-AF65-F5344CB8AC3E}">
-        <p14:creationId xmlns:p14="http://schemas.microsoft.com/office/powerpoint/2010/main" val="2113822836"/>
+        <p14:creationId xmlns:p14="http://schemas.microsoft.com/office/powerpoint/2010/main" val="990642439"/>
       </p:ext>
     </p:extLst>
   </p:cSld>
@@ -2815,7 +2815,7 @@
           <p:cNvPr id="22" name="">
             <a:extLst xmlns:a="http://schemas.openxmlformats.org/drawingml/2006/main">
               <a:ext uri="{FF2B5EF4-FFF2-40B4-BE49-F238E27FC236}">
-                <a16:creationId xmlns:a16="http://schemas.microsoft.com/office/drawing/2014/main" id="{4F5754EE-13F0-4E9C-94A6-E8600103B37B}"/>
+                <a16:creationId xmlns:a16="http://schemas.microsoft.com/office/drawing/2014/main" id="{8491E527-47DD-4872-888F-88F6E6EC2EB5}"/>
               </a:ext>
             </a:extLst>
           </p:cNvPr>
@@ -2845,7 +2845,7 @@
           <p:cNvPr id="2" name="">
             <a:extLst xmlns:a="http://schemas.openxmlformats.org/drawingml/2006/main">
               <a:ext uri="{FF2B5EF4-FFF2-40B4-BE49-F238E27FC236}">
-                <a16:creationId xmlns:a16="http://schemas.microsoft.com/office/drawing/2014/main" id="{6AEDF336-536F-4805-A0A9-7F4583A5D306}"/>
+                <a16:creationId xmlns:a16="http://schemas.microsoft.com/office/drawing/2014/main" id="{C16C7589-8BBA-4BB8-B909-9F7122EAB3D3}"/>
               </a:ext>
             </a:extLst>
           </p:cNvPr>
@@ -2902,7 +2902,7 @@
           <p:cNvPr id="3" name="">
             <a:extLst xmlns:a="http://schemas.openxmlformats.org/drawingml/2006/main">
               <a:ext uri="{FF2B5EF4-FFF2-40B4-BE49-F238E27FC236}">
-                <a16:creationId xmlns:a16="http://schemas.microsoft.com/office/drawing/2014/main" id="{5DA1E510-4D7E-44D6-A6CF-E161C3092E4B}"/>
+                <a16:creationId xmlns:a16="http://schemas.microsoft.com/office/drawing/2014/main" id="{FEB7C680-79C1-4C29-82B3-87CAA8536C8B}"/>
               </a:ext>
             </a:extLst>
           </p:cNvPr>
@@ -2932,7 +2932,7 @@
           <p:cNvPr id="4" name="">
             <a:extLst xmlns:a="http://schemas.openxmlformats.org/drawingml/2006/main">
               <a:ext uri="{FF2B5EF4-FFF2-40B4-BE49-F238E27FC236}">
-                <a16:creationId xmlns:a16="http://schemas.microsoft.com/office/drawing/2014/main" id="{9724C595-AA70-488A-BD0B-B8DE29E102A5}"/>
+                <a16:creationId xmlns:a16="http://schemas.microsoft.com/office/drawing/2014/main" id="{A858A319-11F4-413F-86AA-71CF3DEA6F63}"/>
               </a:ext>
             </a:extLst>
           </p:cNvPr>
@@ -2989,7 +2989,7 @@
           <p:cNvPr id="5" name="">
             <a:extLst xmlns:a="http://schemas.openxmlformats.org/drawingml/2006/main">
               <a:ext uri="{FF2B5EF4-FFF2-40B4-BE49-F238E27FC236}">
-                <a16:creationId xmlns:a16="http://schemas.microsoft.com/office/drawing/2014/main" id="{54C748AF-D114-4375-8EF3-F8B681FC488B}"/>
+                <a16:creationId xmlns:a16="http://schemas.microsoft.com/office/drawing/2014/main" id="{BFE459AB-9EDE-416F-BB49-50285036E1A1}"/>
               </a:ext>
             </a:extLst>
           </p:cNvPr>
@@ -3019,7 +3019,7 @@
           <p:cNvPr id="6" name="">
             <a:extLst xmlns:a="http://schemas.openxmlformats.org/drawingml/2006/main">
               <a:ext uri="{FF2B5EF4-FFF2-40B4-BE49-F238E27FC236}">
-                <a16:creationId xmlns:a16="http://schemas.microsoft.com/office/drawing/2014/main" id="{EDB286DA-431B-4919-AF3B-FD749B6AE6B0}"/>
+                <a16:creationId xmlns:a16="http://schemas.microsoft.com/office/drawing/2014/main" id="{8EE6BF0A-B664-417A-8985-C19C952633EC}"/>
               </a:ext>
             </a:extLst>
           </p:cNvPr>
@@ -3076,7 +3076,7 @@
           <p:cNvPr id="7" name="">
             <a:extLst xmlns:a="http://schemas.openxmlformats.org/drawingml/2006/main">
               <a:ext uri="{FF2B5EF4-FFF2-40B4-BE49-F238E27FC236}">
-                <a16:creationId xmlns:a16="http://schemas.microsoft.com/office/drawing/2014/main" id="{4E8BBF8E-6F08-4E74-8137-F85283CB10B1}"/>
+                <a16:creationId xmlns:a16="http://schemas.microsoft.com/office/drawing/2014/main" id="{F59E74FB-1A8D-4F6C-B32F-6AB061591AB6}"/>
               </a:ext>
             </a:extLst>
           </p:cNvPr>
@@ -3133,7 +3133,7 @@
           <p:cNvPr id="8" name="">
             <a:extLst xmlns:a="http://schemas.openxmlformats.org/drawingml/2006/main">
               <a:ext uri="{FF2B5EF4-FFF2-40B4-BE49-F238E27FC236}">
-                <a16:creationId xmlns:a16="http://schemas.microsoft.com/office/drawing/2014/main" id="{544412DB-07E0-4C58-B527-045731BBE960}"/>
+                <a16:creationId xmlns:a16="http://schemas.microsoft.com/office/drawing/2014/main" id="{BC4F7032-714D-4E56-AF6C-2466B7542BC3}"/>
               </a:ext>
             </a:extLst>
           </p:cNvPr>
@@ -3190,7 +3190,7 @@
           <p:cNvPr id="9" name="">
             <a:extLst xmlns:a="http://schemas.openxmlformats.org/drawingml/2006/main">
               <a:ext uri="{FF2B5EF4-FFF2-40B4-BE49-F238E27FC236}">
-                <a16:creationId xmlns:a16="http://schemas.microsoft.com/office/drawing/2014/main" id="{4E26AFCB-F821-43AA-A1E3-45B4FA634434}"/>
+                <a16:creationId xmlns:a16="http://schemas.microsoft.com/office/drawing/2014/main" id="{5491F373-979C-42BA-854C-CB93644BF15A}"/>
               </a:ext>
             </a:extLst>
           </p:cNvPr>
@@ -3222,7 +3222,7 @@
           <p:cNvPr id="10" name="">
             <a:extLst xmlns:a="http://schemas.openxmlformats.org/drawingml/2006/main">
               <a:ext uri="{FF2B5EF4-FFF2-40B4-BE49-F238E27FC236}">
-                <a16:creationId xmlns:a16="http://schemas.microsoft.com/office/drawing/2014/main" id="{FBA13C12-C440-4AF2-B60D-1BBA000C5522}"/>
+                <a16:creationId xmlns:a16="http://schemas.microsoft.com/office/drawing/2014/main" id="{717B23FD-D0CE-4597-8AB6-D164AAD5999F}"/>
               </a:ext>
             </a:extLst>
           </p:cNvPr>
@@ -3279,7 +3279,7 @@
           <p:cNvPr id="11" name="">
             <a:extLst xmlns:a="http://schemas.openxmlformats.org/drawingml/2006/main">
               <a:ext uri="{FF2B5EF4-FFF2-40B4-BE49-F238E27FC236}">
-                <a16:creationId xmlns:a16="http://schemas.microsoft.com/office/drawing/2014/main" id="{368A91B5-12FC-4DF4-84AA-811E77B1B97C}"/>
+                <a16:creationId xmlns:a16="http://schemas.microsoft.com/office/drawing/2014/main" id="{8ABE7ECD-259F-4386-8102-63B00E79B29E}"/>
               </a:ext>
             </a:extLst>
           </p:cNvPr>
@@ -3336,7 +3336,7 @@
           <p:cNvPr id="12" name="">
             <a:extLst xmlns:a="http://schemas.openxmlformats.org/drawingml/2006/main">
               <a:ext uri="{FF2B5EF4-FFF2-40B4-BE49-F238E27FC236}">
-                <a16:creationId xmlns:a16="http://schemas.microsoft.com/office/drawing/2014/main" id="{74223590-EDDE-4F41-A7A3-AC90C4199134}"/>
+                <a16:creationId xmlns:a16="http://schemas.microsoft.com/office/drawing/2014/main" id="{7E072BF7-35D7-484F-A0A0-0DDA00FE3B6E}"/>
               </a:ext>
             </a:extLst>
           </p:cNvPr>
@@ -3393,7 +3393,7 @@
           <p:cNvPr id="13" name="">
             <a:extLst xmlns:a="http://schemas.openxmlformats.org/drawingml/2006/main">
               <a:ext uri="{FF2B5EF4-FFF2-40B4-BE49-F238E27FC236}">
-                <a16:creationId xmlns:a16="http://schemas.microsoft.com/office/drawing/2014/main" id="{9E73F1F4-9EA0-4A89-967D-E7C2D1567398}"/>
+                <a16:creationId xmlns:a16="http://schemas.microsoft.com/office/drawing/2014/main" id="{DF475A30-5B4C-46B0-B102-361C9DAD63FA}"/>
               </a:ext>
             </a:extLst>
           </p:cNvPr>
@@ -3425,7 +3425,7 @@
           <p:cNvPr id="14" name="">
             <a:extLst xmlns:a="http://schemas.openxmlformats.org/drawingml/2006/main">
               <a:ext uri="{FF2B5EF4-FFF2-40B4-BE49-F238E27FC236}">
-                <a16:creationId xmlns:a16="http://schemas.microsoft.com/office/drawing/2014/main" id="{92583625-CDE2-4D0E-A927-0779AE7D1A17}"/>
+                <a16:creationId xmlns:a16="http://schemas.microsoft.com/office/drawing/2014/main" id="{02673EFE-9888-4CCC-973F-D98BC19FF844}"/>
               </a:ext>
             </a:extLst>
           </p:cNvPr>
@@ -3482,7 +3482,7 @@
           <p:cNvPr id="15" name="">
             <a:extLst xmlns:a="http://schemas.openxmlformats.org/drawingml/2006/main">
               <a:ext uri="{FF2B5EF4-FFF2-40B4-BE49-F238E27FC236}">
-                <a16:creationId xmlns:a16="http://schemas.microsoft.com/office/drawing/2014/main" id="{1A0766D9-E8FB-467A-B55F-7CBB6569C38A}"/>
+                <a16:creationId xmlns:a16="http://schemas.microsoft.com/office/drawing/2014/main" id="{E38DAAC5-0D37-470E-A0B6-2F7A3D1DA7D4}"/>
               </a:ext>
             </a:extLst>
           </p:cNvPr>
@@ -3539,7 +3539,7 @@
           <p:cNvPr id="16" name="">
             <a:extLst xmlns:a="http://schemas.openxmlformats.org/drawingml/2006/main">
               <a:ext uri="{FF2B5EF4-FFF2-40B4-BE49-F238E27FC236}">
-                <a16:creationId xmlns:a16="http://schemas.microsoft.com/office/drawing/2014/main" id="{300DF6F1-3A42-48A7-ABA2-794FCF675C41}"/>
+                <a16:creationId xmlns:a16="http://schemas.microsoft.com/office/drawing/2014/main" id="{DCFBA9B6-6397-4642-A5C2-C22755D1C26C}"/>
               </a:ext>
             </a:extLst>
           </p:cNvPr>
@@ -3596,7 +3596,7 @@
           <p:cNvPr id="17" name="">
             <a:extLst xmlns:a="http://schemas.openxmlformats.org/drawingml/2006/main">
               <a:ext uri="{FF2B5EF4-FFF2-40B4-BE49-F238E27FC236}">
-                <a16:creationId xmlns:a16="http://schemas.microsoft.com/office/drawing/2014/main" id="{DE495059-4C7F-445F-9F6F-A9FE5A326003}"/>
+                <a16:creationId xmlns:a16="http://schemas.microsoft.com/office/drawing/2014/main" id="{18FC7B87-5DEB-4544-9C65-9953FF951BF4}"/>
               </a:ext>
             </a:extLst>
           </p:cNvPr>
@@ -3628,7 +3628,7 @@
           <p:cNvPr id="18" name="">
             <a:extLst xmlns:a="http://schemas.openxmlformats.org/drawingml/2006/main">
               <a:ext uri="{FF2B5EF4-FFF2-40B4-BE49-F238E27FC236}">
-                <a16:creationId xmlns:a16="http://schemas.microsoft.com/office/drawing/2014/main" id="{42CAB999-5DE9-46F8-89DB-B72B59283200}"/>
+                <a16:creationId xmlns:a16="http://schemas.microsoft.com/office/drawing/2014/main" id="{4E2CFE37-D44E-4EE8-9C56-DEEEF7EBDDA3}"/>
               </a:ext>
             </a:extLst>
           </p:cNvPr>
@@ -3685,7 +3685,7 @@
           <p:cNvPr id="19" name="">
             <a:extLst xmlns:a="http://schemas.openxmlformats.org/drawingml/2006/main">
               <a:ext uri="{FF2B5EF4-FFF2-40B4-BE49-F238E27FC236}">
-                <a16:creationId xmlns:a16="http://schemas.microsoft.com/office/drawing/2014/main" id="{FB872C91-A965-432C-BC4A-6CEFB8D06083}"/>
+                <a16:creationId xmlns:a16="http://schemas.microsoft.com/office/drawing/2014/main" id="{19F8EDAC-D542-4DD7-AF00-874869DC2CF6}"/>
               </a:ext>
             </a:extLst>
           </p:cNvPr>
@@ -3742,7 +3742,7 @@
           <p:cNvPr id="20" name="">
             <a:extLst xmlns:a="http://schemas.openxmlformats.org/drawingml/2006/main">
               <a:ext uri="{FF2B5EF4-FFF2-40B4-BE49-F238E27FC236}">
-                <a16:creationId xmlns:a16="http://schemas.microsoft.com/office/drawing/2014/main" id="{4D5B90AB-609C-4C44-88FD-7B27147EC990}"/>
+                <a16:creationId xmlns:a16="http://schemas.microsoft.com/office/drawing/2014/main" id="{0C365874-C70E-4345-9DF9-DBFE6B8730FF}"/>
               </a:ext>
             </a:extLst>
           </p:cNvPr>
@@ -3799,7 +3799,7 @@
           <p:cNvPr id="21" name="">
             <a:extLst xmlns:a="http://schemas.openxmlformats.org/drawingml/2006/main">
               <a:ext uri="{FF2B5EF4-FFF2-40B4-BE49-F238E27FC236}">
-                <a16:creationId xmlns:a16="http://schemas.microsoft.com/office/drawing/2014/main" id="{8A9AC995-1BDF-4A62-9AF7-52546FCA4E4A}"/>
+                <a16:creationId xmlns:a16="http://schemas.microsoft.com/office/drawing/2014/main" id="{79684C62-2FE7-4F59-8DBD-72B096091CF7}"/>
               </a:ext>
             </a:extLst>
           </p:cNvPr>
@@ -3854,7 +3854,7 @@
     </p:spTree>
     <p:extLst>
       <p:ext uri="{BB962C8B-B14F-4D97-AF65-F5344CB8AC3E}">
-        <p14:creationId xmlns:p14="http://schemas.microsoft.com/office/powerpoint/2010/main" val="1462927586"/>
+        <p14:creationId xmlns:p14="http://schemas.microsoft.com/office/powerpoint/2010/main" val="1180608110"/>
       </p:ext>
     </p:extLst>
   </p:cSld>
@@ -3885,7 +3885,7 @@
           <p:cNvPr id="21" name="">
             <a:extLst xmlns:a="http://schemas.openxmlformats.org/drawingml/2006/main">
               <a:ext uri="{FF2B5EF4-FFF2-40B4-BE49-F238E27FC236}">
-                <a16:creationId xmlns:a16="http://schemas.microsoft.com/office/drawing/2014/main" id="{69511549-FF96-41D4-AE45-C46D27D80859}"/>
+                <a16:creationId xmlns:a16="http://schemas.microsoft.com/office/drawing/2014/main" id="{0395ED75-C40E-476E-861F-5B61BAB86735}"/>
               </a:ext>
             </a:extLst>
           </p:cNvPr>
@@ -3915,7 +3915,7 @@
           <p:cNvPr id="2" name="">
             <a:extLst xmlns:a="http://schemas.openxmlformats.org/drawingml/2006/main">
               <a:ext uri="{FF2B5EF4-FFF2-40B4-BE49-F238E27FC236}">
-                <a16:creationId xmlns:a16="http://schemas.microsoft.com/office/drawing/2014/main" id="{8C1CCE94-A674-4D2C-9902-9BF66E127B32}"/>
+                <a16:creationId xmlns:a16="http://schemas.microsoft.com/office/drawing/2014/main" id="{2C6C43F2-234A-4195-A0F7-7A7E21DA64FE}"/>
               </a:ext>
             </a:extLst>
           </p:cNvPr>
@@ -3972,7 +3972,7 @@
           <p:cNvPr id="3" name="">
             <a:extLst xmlns:a="http://schemas.openxmlformats.org/drawingml/2006/main">
               <a:ext uri="{FF2B5EF4-FFF2-40B4-BE49-F238E27FC236}">
-                <a16:creationId xmlns:a16="http://schemas.microsoft.com/office/drawing/2014/main" id="{299BB8F1-646D-447A-B46D-47BD763837B2}"/>
+                <a16:creationId xmlns:a16="http://schemas.microsoft.com/office/drawing/2014/main" id="{07A81E01-E916-4F19-B2DB-A9269DD7C2E9}"/>
               </a:ext>
             </a:extLst>
           </p:cNvPr>
@@ -4002,7 +4002,7 @@
           <p:cNvPr id="4" name="">
             <a:extLst xmlns:a="http://schemas.openxmlformats.org/drawingml/2006/main">
               <a:ext uri="{FF2B5EF4-FFF2-40B4-BE49-F238E27FC236}">
-                <a16:creationId xmlns:a16="http://schemas.microsoft.com/office/drawing/2014/main" id="{CE3F504C-7310-46B8-8041-BF8CDCBD4F29}"/>
+                <a16:creationId xmlns:a16="http://schemas.microsoft.com/office/drawing/2014/main" id="{14EEE9A4-587F-4285-816C-E9E72ADECFC7}"/>
               </a:ext>
             </a:extLst>
           </p:cNvPr>
@@ -4059,7 +4059,7 @@
           <p:cNvPr id="5" name="">
             <a:extLst xmlns:a="http://schemas.openxmlformats.org/drawingml/2006/main">
               <a:ext uri="{FF2B5EF4-FFF2-40B4-BE49-F238E27FC236}">
-                <a16:creationId xmlns:a16="http://schemas.microsoft.com/office/drawing/2014/main" id="{C732B73E-4BF6-4C75-ACD2-786F88AC3C56}"/>
+                <a16:creationId xmlns:a16="http://schemas.microsoft.com/office/drawing/2014/main" id="{937CE83C-EC58-4DC2-81B5-28D4AE4CD21B}"/>
               </a:ext>
             </a:extLst>
           </p:cNvPr>
@@ -4116,7 +4116,7 @@
           <p:cNvPr id="6" name="">
             <a:extLst xmlns:a="http://schemas.openxmlformats.org/drawingml/2006/main">
               <a:ext uri="{FF2B5EF4-FFF2-40B4-BE49-F238E27FC236}">
-                <a16:creationId xmlns:a16="http://schemas.microsoft.com/office/drawing/2014/main" id="{BD552F6F-07B6-427F-AB93-32718E5961F2}"/>
+                <a16:creationId xmlns:a16="http://schemas.microsoft.com/office/drawing/2014/main" id="{70F553C5-E0BE-4D99-865E-16AF8A55CFF6}"/>
               </a:ext>
             </a:extLst>
           </p:cNvPr>
@@ -4173,7 +4173,7 @@
           <p:cNvPr id="7" name="">
             <a:extLst xmlns:a="http://schemas.openxmlformats.org/drawingml/2006/main">
               <a:ext uri="{FF2B5EF4-FFF2-40B4-BE49-F238E27FC236}">
-                <a16:creationId xmlns:a16="http://schemas.microsoft.com/office/drawing/2014/main" id="{1F6C487B-D8ED-4F6E-AA2F-8C7894BF5E31}"/>
+                <a16:creationId xmlns:a16="http://schemas.microsoft.com/office/drawing/2014/main" id="{3D767B04-2F74-4D2B-A535-7EDA945B5844}"/>
               </a:ext>
             </a:extLst>
           </p:cNvPr>
@@ -4230,7 +4230,7 @@
           <p:cNvPr id="8" name="">
             <a:extLst xmlns:a="http://schemas.openxmlformats.org/drawingml/2006/main">
               <a:ext uri="{FF2B5EF4-FFF2-40B4-BE49-F238E27FC236}">
-                <a16:creationId xmlns:a16="http://schemas.microsoft.com/office/drawing/2014/main" id="{13D2B74D-9226-4A99-8C6C-FA3638B99805}"/>
+                <a16:creationId xmlns:a16="http://schemas.microsoft.com/office/drawing/2014/main" id="{01CF3C6A-0BBB-4D7F-AC6E-3FC14A026F9C}"/>
               </a:ext>
             </a:extLst>
           </p:cNvPr>
@@ -4260,7 +4260,7 @@
           <p:cNvPr id="9" name="">
             <a:extLst xmlns:a="http://schemas.openxmlformats.org/drawingml/2006/main">
               <a:ext uri="{FF2B5EF4-FFF2-40B4-BE49-F238E27FC236}">
-                <a16:creationId xmlns:a16="http://schemas.microsoft.com/office/drawing/2014/main" id="{F19D2E4F-C21F-4E99-ABD1-4E421A8F5123}"/>
+                <a16:creationId xmlns:a16="http://schemas.microsoft.com/office/drawing/2014/main" id="{4F686899-A1F6-434B-A8C2-E014434DE095}"/>
               </a:ext>
             </a:extLst>
           </p:cNvPr>
@@ -4317,7 +4317,7 @@
           <p:cNvPr id="10" name="">
             <a:extLst xmlns:a="http://schemas.openxmlformats.org/drawingml/2006/main">
               <a:ext uri="{FF2B5EF4-FFF2-40B4-BE49-F238E27FC236}">
-                <a16:creationId xmlns:a16="http://schemas.microsoft.com/office/drawing/2014/main" id="{B7012AEB-5FE2-4E64-9407-4B6822780DB8}"/>
+                <a16:creationId xmlns:a16="http://schemas.microsoft.com/office/drawing/2014/main" id="{ABACDF65-87B9-4A4F-874F-C6D3FFDCFE3C}"/>
               </a:ext>
             </a:extLst>
           </p:cNvPr>
@@ -4374,7 +4374,7 @@
           <p:cNvPr id="11" name="">
             <a:extLst xmlns:a="http://schemas.openxmlformats.org/drawingml/2006/main">
               <a:ext uri="{FF2B5EF4-FFF2-40B4-BE49-F238E27FC236}">
-                <a16:creationId xmlns:a16="http://schemas.microsoft.com/office/drawing/2014/main" id="{C788E4C4-95A6-4B27-A179-A5969BE5E4E4}"/>
+                <a16:creationId xmlns:a16="http://schemas.microsoft.com/office/drawing/2014/main" id="{41E78910-60AC-4EE1-B27B-99E5718383F7}"/>
               </a:ext>
             </a:extLst>
           </p:cNvPr>
@@ -4431,7 +4431,7 @@
           <p:cNvPr id="12" name="">
             <a:extLst xmlns:a="http://schemas.openxmlformats.org/drawingml/2006/main">
               <a:ext uri="{FF2B5EF4-FFF2-40B4-BE49-F238E27FC236}">
-                <a16:creationId xmlns:a16="http://schemas.microsoft.com/office/drawing/2014/main" id="{AF58CA87-F2B3-4BDE-B743-B3A90BFDDEE5}"/>
+                <a16:creationId xmlns:a16="http://schemas.microsoft.com/office/drawing/2014/main" id="{8CA6DC50-4ABB-4AF5-8963-A39ADDB75E3D}"/>
               </a:ext>
             </a:extLst>
           </p:cNvPr>
@@ -4461,7 +4461,7 @@
           <p:cNvPr id="13" name="">
             <a:extLst xmlns:a="http://schemas.openxmlformats.org/drawingml/2006/main">
               <a:ext uri="{FF2B5EF4-FFF2-40B4-BE49-F238E27FC236}">
-                <a16:creationId xmlns:a16="http://schemas.microsoft.com/office/drawing/2014/main" id="{04C98844-05DB-41D5-B5E4-64D3CF8DAA96}"/>
+                <a16:creationId xmlns:a16="http://schemas.microsoft.com/office/drawing/2014/main" id="{F2853B5B-6EC8-4FB1-968F-6CB337856212}"/>
               </a:ext>
             </a:extLst>
           </p:cNvPr>
@@ -4518,7 +4518,7 @@
           <p:cNvPr id="14" name="">
             <a:extLst xmlns:a="http://schemas.openxmlformats.org/drawingml/2006/main">
               <a:ext uri="{FF2B5EF4-FFF2-40B4-BE49-F238E27FC236}">
-                <a16:creationId xmlns:a16="http://schemas.microsoft.com/office/drawing/2014/main" id="{C2099B16-392F-4243-94D4-7C1E5D822688}"/>
+                <a16:creationId xmlns:a16="http://schemas.microsoft.com/office/drawing/2014/main" id="{9A292D65-907C-4F85-A3D8-C19969AC683B}"/>
               </a:ext>
             </a:extLst>
           </p:cNvPr>
@@ -4575,7 +4575,7 @@
           <p:cNvPr id="15" name="">
             <a:extLst xmlns:a="http://schemas.openxmlformats.org/drawingml/2006/main">
               <a:ext uri="{FF2B5EF4-FFF2-40B4-BE49-F238E27FC236}">
-                <a16:creationId xmlns:a16="http://schemas.microsoft.com/office/drawing/2014/main" id="{D75CBEF7-BDA8-4F7B-AFAB-6928FB6BC455}"/>
+                <a16:creationId xmlns:a16="http://schemas.microsoft.com/office/drawing/2014/main" id="{8DF8D7C7-B095-442C-AEAE-338479644FB0}"/>
               </a:ext>
             </a:extLst>
           </p:cNvPr>
@@ -4632,7 +4632,7 @@
           <p:cNvPr id="16" name="">
             <a:extLst xmlns:a="http://schemas.openxmlformats.org/drawingml/2006/main">
               <a:ext uri="{FF2B5EF4-FFF2-40B4-BE49-F238E27FC236}">
-                <a16:creationId xmlns:a16="http://schemas.microsoft.com/office/drawing/2014/main" id="{21266675-8D24-4949-9592-04E6C199ECE0}"/>
+                <a16:creationId xmlns:a16="http://schemas.microsoft.com/office/drawing/2014/main" id="{0D057AC4-4C42-4F9A-A06F-D3B06178BD38}"/>
               </a:ext>
             </a:extLst>
           </p:cNvPr>
@@ -4662,7 +4662,7 @@
           <p:cNvPr id="17" name="">
             <a:extLst xmlns:a="http://schemas.openxmlformats.org/drawingml/2006/main">
               <a:ext uri="{FF2B5EF4-FFF2-40B4-BE49-F238E27FC236}">
-                <a16:creationId xmlns:a16="http://schemas.microsoft.com/office/drawing/2014/main" id="{15460030-6F7E-4AFE-A0D0-2B7C0C3E7E0A}"/>
+                <a16:creationId xmlns:a16="http://schemas.microsoft.com/office/drawing/2014/main" id="{C3D32F45-186D-4DF8-97D8-0F41168724E1}"/>
               </a:ext>
             </a:extLst>
           </p:cNvPr>
@@ -4719,7 +4719,7 @@
           <p:cNvPr id="18" name="">
             <a:extLst xmlns:a="http://schemas.openxmlformats.org/drawingml/2006/main">
               <a:ext uri="{FF2B5EF4-FFF2-40B4-BE49-F238E27FC236}">
-                <a16:creationId xmlns:a16="http://schemas.microsoft.com/office/drawing/2014/main" id="{7F04B56B-8248-4234-BD04-5C6958D146E9}"/>
+                <a16:creationId xmlns:a16="http://schemas.microsoft.com/office/drawing/2014/main" id="{37384C16-F666-4F24-9639-FF8A5D954E82}"/>
               </a:ext>
             </a:extLst>
           </p:cNvPr>
@@ -4776,7 +4776,7 @@
           <p:cNvPr id="19" name="">
             <a:extLst xmlns:a="http://schemas.openxmlformats.org/drawingml/2006/main">
               <a:ext uri="{FF2B5EF4-FFF2-40B4-BE49-F238E27FC236}">
-                <a16:creationId xmlns:a16="http://schemas.microsoft.com/office/drawing/2014/main" id="{905CBECB-E0CD-40EB-BD9F-874176515358}"/>
+                <a16:creationId xmlns:a16="http://schemas.microsoft.com/office/drawing/2014/main" id="{B356BF4E-86B2-4AAE-85C3-D50E821863EC}"/>
               </a:ext>
             </a:extLst>
           </p:cNvPr>
@@ -4833,7 +4833,7 @@
           <p:cNvPr id="20" name="">
             <a:extLst xmlns:a="http://schemas.openxmlformats.org/drawingml/2006/main">
               <a:ext uri="{FF2B5EF4-FFF2-40B4-BE49-F238E27FC236}">
-                <a16:creationId xmlns:a16="http://schemas.microsoft.com/office/drawing/2014/main" id="{5DFAA060-DDBE-4EA9-80A7-B107CD954459}"/>
+                <a16:creationId xmlns:a16="http://schemas.microsoft.com/office/drawing/2014/main" id="{159FB153-8474-4901-820C-32CC7013D838}"/>
               </a:ext>
             </a:extLst>
           </p:cNvPr>
@@ -4888,7 +4888,7 @@
     </p:spTree>
     <p:extLst>
       <p:ext uri="{BB962C8B-B14F-4D97-AF65-F5344CB8AC3E}">
-        <p14:creationId xmlns:p14="http://schemas.microsoft.com/office/powerpoint/2010/main" val="1366235685"/>
+        <p14:creationId xmlns:p14="http://schemas.microsoft.com/office/powerpoint/2010/main" val="1039531399"/>
       </p:ext>
     </p:extLst>
   </p:cSld>
@@ -4919,7 +4919,7 @@
           <p:cNvPr id="21" name="">
             <a:extLst xmlns:a="http://schemas.openxmlformats.org/drawingml/2006/main">
               <a:ext uri="{FF2B5EF4-FFF2-40B4-BE49-F238E27FC236}">
-                <a16:creationId xmlns:a16="http://schemas.microsoft.com/office/drawing/2014/main" id="{00C3FEB2-B95B-4C90-9D1A-59C15D994E31}"/>
+                <a16:creationId xmlns:a16="http://schemas.microsoft.com/office/drawing/2014/main" id="{93B30118-89CE-457E-95AF-DB2C9C0B0714}"/>
               </a:ext>
             </a:extLst>
           </p:cNvPr>
@@ -4949,7 +4949,7 @@
           <p:cNvPr id="2" name="">
             <a:extLst xmlns:a="http://schemas.openxmlformats.org/drawingml/2006/main">
               <a:ext uri="{FF2B5EF4-FFF2-40B4-BE49-F238E27FC236}">
-                <a16:creationId xmlns:a16="http://schemas.microsoft.com/office/drawing/2014/main" id="{04EE2F0C-9A62-4EFD-AE91-52143D583E30}"/>
+                <a16:creationId xmlns:a16="http://schemas.microsoft.com/office/drawing/2014/main" id="{701FDF30-B5B6-4773-95C4-D38400206646}"/>
               </a:ext>
             </a:extLst>
           </p:cNvPr>
@@ -5006,7 +5006,7 @@
           <p:cNvPr id="3" name="">
             <a:extLst xmlns:a="http://schemas.openxmlformats.org/drawingml/2006/main">
               <a:ext uri="{FF2B5EF4-FFF2-40B4-BE49-F238E27FC236}">
-                <a16:creationId xmlns:a16="http://schemas.microsoft.com/office/drawing/2014/main" id="{F17C2872-595F-4BAB-8D3A-A0996124D0D2}"/>
+                <a16:creationId xmlns:a16="http://schemas.microsoft.com/office/drawing/2014/main" id="{9731ED50-B118-49AA-9A33-338148952CEF}"/>
               </a:ext>
             </a:extLst>
           </p:cNvPr>
@@ -5036,7 +5036,7 @@
           <p:cNvPr id="4" name="">
             <a:extLst xmlns:a="http://schemas.openxmlformats.org/drawingml/2006/main">
               <a:ext uri="{FF2B5EF4-FFF2-40B4-BE49-F238E27FC236}">
-                <a16:creationId xmlns:a16="http://schemas.microsoft.com/office/drawing/2014/main" id="{BC0A16EC-FAA0-43E1-BB5C-04C337F7AF3C}"/>
+                <a16:creationId xmlns:a16="http://schemas.microsoft.com/office/drawing/2014/main" id="{02EC0114-B656-43B3-A04C-BCBB018EB107}"/>
               </a:ext>
             </a:extLst>
           </p:cNvPr>
@@ -5093,7 +5093,7 @@
           <p:cNvPr id="5" name="">
             <a:extLst xmlns:a="http://schemas.openxmlformats.org/drawingml/2006/main">
               <a:ext uri="{FF2B5EF4-FFF2-40B4-BE49-F238E27FC236}">
-                <a16:creationId xmlns:a16="http://schemas.microsoft.com/office/drawing/2014/main" id="{54ED7CC2-70DF-4339-A2D8-F63BBF8F5E93}"/>
+                <a16:creationId xmlns:a16="http://schemas.microsoft.com/office/drawing/2014/main" id="{00C110BD-525C-4F18-A2D9-F7A074824586}"/>
               </a:ext>
             </a:extLst>
           </p:cNvPr>
@@ -5125,7 +5125,7 @@
           <p:cNvPr id="6" name="">
             <a:extLst xmlns:a="http://schemas.openxmlformats.org/drawingml/2006/main">
               <a:ext uri="{FF2B5EF4-FFF2-40B4-BE49-F238E27FC236}">
-                <a16:creationId xmlns:a16="http://schemas.microsoft.com/office/drawing/2014/main" id="{1846EA46-ADDB-4F24-964E-D8523C6EBF44}"/>
+                <a16:creationId xmlns:a16="http://schemas.microsoft.com/office/drawing/2014/main" id="{4BD3C4E8-D838-4ADB-ADB3-70FA74BC4091}"/>
               </a:ext>
             </a:extLst>
           </p:cNvPr>
@@ -5182,7 +5182,7 @@
           <p:cNvPr id="7" name="">
             <a:extLst xmlns:a="http://schemas.openxmlformats.org/drawingml/2006/main">
               <a:ext uri="{FF2B5EF4-FFF2-40B4-BE49-F238E27FC236}">
-                <a16:creationId xmlns:a16="http://schemas.microsoft.com/office/drawing/2014/main" id="{1DBAEE03-C14B-4298-9ABE-41675E5425D3}"/>
+                <a16:creationId xmlns:a16="http://schemas.microsoft.com/office/drawing/2014/main" id="{5BDFB574-F739-4D2D-9EFF-62A7AF116644}"/>
               </a:ext>
             </a:extLst>
           </p:cNvPr>
@@ -5262,7 +5262,7 @@
           <p:cNvPr id="8" name="">
             <a:extLst xmlns:a="http://schemas.openxmlformats.org/drawingml/2006/main">
               <a:ext uri="{FF2B5EF4-FFF2-40B4-BE49-F238E27FC236}">
-                <a16:creationId xmlns:a16="http://schemas.microsoft.com/office/drawing/2014/main" id="{62CBD877-AF43-45D6-90B3-2EC21EA7D9E9}"/>
+                <a16:creationId xmlns:a16="http://schemas.microsoft.com/office/drawing/2014/main" id="{FD4F4B41-A211-4FF8-A9D7-094AFED8B41C}"/>
               </a:ext>
             </a:extLst>
           </p:cNvPr>
@@ -5342,7 +5342,7 @@
           <p:cNvPr id="9" name="">
             <a:extLst xmlns:a="http://schemas.openxmlformats.org/drawingml/2006/main">
               <a:ext uri="{FF2B5EF4-FFF2-40B4-BE49-F238E27FC236}">
-                <a16:creationId xmlns:a16="http://schemas.microsoft.com/office/drawing/2014/main" id="{4E468BAF-D373-472B-8143-346B95149FBA}"/>
+                <a16:creationId xmlns:a16="http://schemas.microsoft.com/office/drawing/2014/main" id="{7A97AAB2-A0E4-49B8-9069-8F02E233D0A8}"/>
               </a:ext>
             </a:extLst>
           </p:cNvPr>
@@ -5372,7 +5372,7 @@
           <p:cNvPr id="10" name="">
             <a:extLst xmlns:a="http://schemas.openxmlformats.org/drawingml/2006/main">
               <a:ext uri="{FF2B5EF4-FFF2-40B4-BE49-F238E27FC236}">
-                <a16:creationId xmlns:a16="http://schemas.microsoft.com/office/drawing/2014/main" id="{A97FD560-4692-4591-9E30-E8246E272D3F}"/>
+                <a16:creationId xmlns:a16="http://schemas.microsoft.com/office/drawing/2014/main" id="{5646C22A-A951-485E-AAA7-06D74A5C0056}"/>
               </a:ext>
             </a:extLst>
           </p:cNvPr>
@@ -5429,7 +5429,7 @@
           <p:cNvPr id="11" name="">
             <a:extLst xmlns:a="http://schemas.openxmlformats.org/drawingml/2006/main">
               <a:ext uri="{FF2B5EF4-FFF2-40B4-BE49-F238E27FC236}">
-                <a16:creationId xmlns:a16="http://schemas.microsoft.com/office/drawing/2014/main" id="{9BA6CE0F-46A6-4A42-9A6D-DF47AC64AEA2}"/>
+                <a16:creationId xmlns:a16="http://schemas.microsoft.com/office/drawing/2014/main" id="{CC5C84B8-7EE4-4692-82D3-14055F5EF926}"/>
               </a:ext>
             </a:extLst>
           </p:cNvPr>
@@ -5486,7 +5486,7 @@
           <p:cNvPr id="12" name="">
             <a:extLst xmlns:a="http://schemas.openxmlformats.org/drawingml/2006/main">
               <a:ext uri="{FF2B5EF4-FFF2-40B4-BE49-F238E27FC236}">
-                <a16:creationId xmlns:a16="http://schemas.microsoft.com/office/drawing/2014/main" id="{F99CB7D7-5C75-4460-A315-53407E54579B}"/>
+                <a16:creationId xmlns:a16="http://schemas.microsoft.com/office/drawing/2014/main" id="{0C2FB5EC-7DA2-4FF6-AF89-890E14E8C9BE}"/>
               </a:ext>
             </a:extLst>
           </p:cNvPr>
@@ -5543,7 +5543,7 @@
           <p:cNvPr id="13" name="">
             <a:extLst xmlns:a="http://schemas.openxmlformats.org/drawingml/2006/main">
               <a:ext uri="{FF2B5EF4-FFF2-40B4-BE49-F238E27FC236}">
-                <a16:creationId xmlns:a16="http://schemas.microsoft.com/office/drawing/2014/main" id="{C4311C54-F7C0-4CED-B1E2-E734E8FA2CE3}"/>
+                <a16:creationId xmlns:a16="http://schemas.microsoft.com/office/drawing/2014/main" id="{907D0C83-34E4-4939-A661-9C721CF23B3A}"/>
               </a:ext>
             </a:extLst>
           </p:cNvPr>
@@ -5623,7 +5623,7 @@
           <p:cNvPr id="14" name="">
             <a:extLst xmlns:a="http://schemas.openxmlformats.org/drawingml/2006/main">
               <a:ext uri="{FF2B5EF4-FFF2-40B4-BE49-F238E27FC236}">
-                <a16:creationId xmlns:a16="http://schemas.microsoft.com/office/drawing/2014/main" id="{047AEF86-1D6B-437D-8CCA-23CD1364EEEB}"/>
+                <a16:creationId xmlns:a16="http://schemas.microsoft.com/office/drawing/2014/main" id="{482F47EF-9B87-4124-9ED0-6CFE2F68290A}"/>
               </a:ext>
             </a:extLst>
           </p:cNvPr>
@@ -5680,7 +5680,7 @@
           <p:cNvPr id="15" name="">
             <a:extLst xmlns:a="http://schemas.openxmlformats.org/drawingml/2006/main">
               <a:ext uri="{FF2B5EF4-FFF2-40B4-BE49-F238E27FC236}">
-                <a16:creationId xmlns:a16="http://schemas.microsoft.com/office/drawing/2014/main" id="{7F41BB0D-BC6D-4F31-B41E-BF3678524080}"/>
+                <a16:creationId xmlns:a16="http://schemas.microsoft.com/office/drawing/2014/main" id="{6933FDCA-CB80-49C4-B458-5F4C1DC3B92A}"/>
               </a:ext>
             </a:extLst>
           </p:cNvPr>
@@ -5712,7 +5712,7 @@
           <p:cNvPr id="16" name="">
             <a:extLst xmlns:a="http://schemas.openxmlformats.org/drawingml/2006/main">
               <a:ext uri="{FF2B5EF4-FFF2-40B4-BE49-F238E27FC236}">
-                <a16:creationId xmlns:a16="http://schemas.microsoft.com/office/drawing/2014/main" id="{C49EEE70-E858-4A79-A08A-1813A4AFF1ED}"/>
+                <a16:creationId xmlns:a16="http://schemas.microsoft.com/office/drawing/2014/main" id="{15986DA8-2CFE-4FC9-9D85-7656265C77D8}"/>
               </a:ext>
             </a:extLst>
           </p:cNvPr>
@@ -5769,7 +5769,7 @@
           <p:cNvPr id="17" name="">
             <a:extLst xmlns:a="http://schemas.openxmlformats.org/drawingml/2006/main">
               <a:ext uri="{FF2B5EF4-FFF2-40B4-BE49-F238E27FC236}">
-                <a16:creationId xmlns:a16="http://schemas.microsoft.com/office/drawing/2014/main" id="{C9E9F853-10F8-424C-8E8A-9FDFA38DF06E}"/>
+                <a16:creationId xmlns:a16="http://schemas.microsoft.com/office/drawing/2014/main" id="{358B2A26-1668-49A6-9F5C-3AE11CAB4205}"/>
               </a:ext>
             </a:extLst>
           </p:cNvPr>
@@ -5849,7 +5849,7 @@
           <p:cNvPr id="18" name="">
             <a:extLst xmlns:a="http://schemas.openxmlformats.org/drawingml/2006/main">
               <a:ext uri="{FF2B5EF4-FFF2-40B4-BE49-F238E27FC236}">
-                <a16:creationId xmlns:a16="http://schemas.microsoft.com/office/drawing/2014/main" id="{DF523624-FAC5-4C54-9FB3-DCB8F74CCE28}"/>
+                <a16:creationId xmlns:a16="http://schemas.microsoft.com/office/drawing/2014/main" id="{38FE4C0C-1393-4295-94BB-0AB0B4EE2820}"/>
               </a:ext>
             </a:extLst>
           </p:cNvPr>
@@ -5929,7 +5929,7 @@
           <p:cNvPr id="19" name="">
             <a:extLst xmlns:a="http://schemas.openxmlformats.org/drawingml/2006/main">
               <a:ext uri="{FF2B5EF4-FFF2-40B4-BE49-F238E27FC236}">
-                <a16:creationId xmlns:a16="http://schemas.microsoft.com/office/drawing/2014/main" id="{D4749141-7DC7-41A0-8CA0-AB44ADFC501D}"/>
+                <a16:creationId xmlns:a16="http://schemas.microsoft.com/office/drawing/2014/main" id="{F2467CEF-5655-43C6-8E23-2ECA3AA684E4}"/>
               </a:ext>
             </a:extLst>
           </p:cNvPr>
@@ -5986,7 +5986,7 @@
           <p:cNvPr id="20" name="">
             <a:extLst xmlns:a="http://schemas.openxmlformats.org/drawingml/2006/main">
               <a:ext uri="{FF2B5EF4-FFF2-40B4-BE49-F238E27FC236}">
-                <a16:creationId xmlns:a16="http://schemas.microsoft.com/office/drawing/2014/main" id="{A2F4F2A2-CC61-47F3-85B9-0E5122E62F66}"/>
+                <a16:creationId xmlns:a16="http://schemas.microsoft.com/office/drawing/2014/main" id="{4C08B5B3-6DF9-4FFA-8925-F56A6F4C0C32}"/>
               </a:ext>
             </a:extLst>
           </p:cNvPr>
@@ -6041,7 +6041,7 @@
     </p:spTree>
     <p:extLst>
       <p:ext uri="{BB962C8B-B14F-4D97-AF65-F5344CB8AC3E}">
-        <p14:creationId xmlns:p14="http://schemas.microsoft.com/office/powerpoint/2010/main" val="1574786998"/>
+        <p14:creationId xmlns:p14="http://schemas.microsoft.com/office/powerpoint/2010/main" val="1860346409"/>
       </p:ext>
     </p:extLst>
   </p:cSld>
@@ -6072,7 +6072,7 @@
           <p:cNvPr id="15" name="">
             <a:extLst xmlns:a="http://schemas.openxmlformats.org/drawingml/2006/main">
               <a:ext uri="{FF2B5EF4-FFF2-40B4-BE49-F238E27FC236}">
-                <a16:creationId xmlns:a16="http://schemas.microsoft.com/office/drawing/2014/main" id="{7274914E-ED6C-4E11-9C93-063742D5EA2F}"/>
+                <a16:creationId xmlns:a16="http://schemas.microsoft.com/office/drawing/2014/main" id="{0E8F5009-5A16-4957-BF5C-B9FD9E3BF0FF}"/>
               </a:ext>
             </a:extLst>
           </p:cNvPr>
@@ -6102,7 +6102,7 @@
           <p:cNvPr id="2" name="">
             <a:extLst xmlns:a="http://schemas.openxmlformats.org/drawingml/2006/main">
               <a:ext uri="{FF2B5EF4-FFF2-40B4-BE49-F238E27FC236}">
-                <a16:creationId xmlns:a16="http://schemas.microsoft.com/office/drawing/2014/main" id="{70A92C08-7B53-430B-BA22-CF6849B95FCB}"/>
+                <a16:creationId xmlns:a16="http://schemas.microsoft.com/office/drawing/2014/main" id="{3317EA2D-5A85-4DC3-93ED-9DAB6AFD286C}"/>
               </a:ext>
             </a:extLst>
           </p:cNvPr>
@@ -6159,7 +6159,7 @@
           <p:cNvPr id="3" name="">
             <a:extLst xmlns:a="http://schemas.openxmlformats.org/drawingml/2006/main">
               <a:ext uri="{FF2B5EF4-FFF2-40B4-BE49-F238E27FC236}">
-                <a16:creationId xmlns:a16="http://schemas.microsoft.com/office/drawing/2014/main" id="{DEC913C2-BA6B-4D87-A626-A0E5DEFE9D1B}"/>
+                <a16:creationId xmlns:a16="http://schemas.microsoft.com/office/drawing/2014/main" id="{309C84BA-9695-4420-BDB1-C24953542178}"/>
               </a:ext>
             </a:extLst>
           </p:cNvPr>
@@ -6189,7 +6189,7 @@
           <p:cNvPr id="4" name="">
             <a:extLst xmlns:a="http://schemas.openxmlformats.org/drawingml/2006/main">
               <a:ext uri="{FF2B5EF4-FFF2-40B4-BE49-F238E27FC236}">
-                <a16:creationId xmlns:a16="http://schemas.microsoft.com/office/drawing/2014/main" id="{3FF1B9BD-B7D5-436A-AC55-D3A776079310}"/>
+                <a16:creationId xmlns:a16="http://schemas.microsoft.com/office/drawing/2014/main" id="{42A006F3-DA56-4606-AC11-52B38034BE70}"/>
               </a:ext>
             </a:extLst>
           </p:cNvPr>
@@ -6246,7 +6246,7 @@
           <p:cNvPr id="5" name="">
             <a:extLst xmlns:a="http://schemas.openxmlformats.org/drawingml/2006/main">
               <a:ext uri="{FF2B5EF4-FFF2-40B4-BE49-F238E27FC236}">
-                <a16:creationId xmlns:a16="http://schemas.microsoft.com/office/drawing/2014/main" id="{2869261C-2A26-443D-986D-B7774BFE31A8}"/>
+                <a16:creationId xmlns:a16="http://schemas.microsoft.com/office/drawing/2014/main" id="{26C989E3-7ED9-4E99-9A2F-1F475315D1D3}"/>
               </a:ext>
             </a:extLst>
           </p:cNvPr>
@@ -6303,7 +6303,7 @@
           <p:cNvPr id="6" name="">
             <a:extLst xmlns:a="http://schemas.openxmlformats.org/drawingml/2006/main">
               <a:ext uri="{FF2B5EF4-FFF2-40B4-BE49-F238E27FC236}">
-                <a16:creationId xmlns:a16="http://schemas.microsoft.com/office/drawing/2014/main" id="{67F5C303-9F97-4D0B-AE13-93A9BCF6A1F9}"/>
+                <a16:creationId xmlns:a16="http://schemas.microsoft.com/office/drawing/2014/main" id="{12271541-4D43-4752-9963-A0231C4290E6}"/>
               </a:ext>
             </a:extLst>
           </p:cNvPr>
@@ -6360,7 +6360,7 @@
           <p:cNvPr id="7" name="">
             <a:extLst xmlns:a="http://schemas.openxmlformats.org/drawingml/2006/main">
               <a:ext uri="{FF2B5EF4-FFF2-40B4-BE49-F238E27FC236}">
-                <a16:creationId xmlns:a16="http://schemas.microsoft.com/office/drawing/2014/main" id="{27D04017-29B9-4B95-AC7F-A45E6A39274B}"/>
+                <a16:creationId xmlns:a16="http://schemas.microsoft.com/office/drawing/2014/main" id="{8587A9A3-9E2C-4149-ACE7-F1CA7FE44DF5}"/>
               </a:ext>
             </a:extLst>
           </p:cNvPr>
@@ -6390,7 +6390,7 @@
           <p:cNvPr id="8" name="">
             <a:extLst xmlns:a="http://schemas.openxmlformats.org/drawingml/2006/main">
               <a:ext uri="{FF2B5EF4-FFF2-40B4-BE49-F238E27FC236}">
-                <a16:creationId xmlns:a16="http://schemas.microsoft.com/office/drawing/2014/main" id="{BD2AC132-34C6-4F07-8A00-AB69F2C7BFA0}"/>
+                <a16:creationId xmlns:a16="http://schemas.microsoft.com/office/drawing/2014/main" id="{06E0E123-5A28-4869-AFD5-07A0DDBCB142}"/>
               </a:ext>
             </a:extLst>
           </p:cNvPr>
@@ -6447,7 +6447,7 @@
           <p:cNvPr id="9" name="">
             <a:extLst xmlns:a="http://schemas.openxmlformats.org/drawingml/2006/main">
               <a:ext uri="{FF2B5EF4-FFF2-40B4-BE49-F238E27FC236}">
-                <a16:creationId xmlns:a16="http://schemas.microsoft.com/office/drawing/2014/main" id="{1B002F43-15F1-4A8C-87F2-C111DDC4A7CA}"/>
+                <a16:creationId xmlns:a16="http://schemas.microsoft.com/office/drawing/2014/main" id="{C9584CBC-DA4E-41CD-99D1-F56D5D424615}"/>
               </a:ext>
             </a:extLst>
           </p:cNvPr>
@@ -6504,7 +6504,7 @@
           <p:cNvPr id="10" name="">
             <a:extLst xmlns:a="http://schemas.openxmlformats.org/drawingml/2006/main">
               <a:ext uri="{FF2B5EF4-FFF2-40B4-BE49-F238E27FC236}">
-                <a16:creationId xmlns:a16="http://schemas.microsoft.com/office/drawing/2014/main" id="{A67AD5B1-C5E2-42D3-98C3-5CDEBEE0A7C0}"/>
+                <a16:creationId xmlns:a16="http://schemas.microsoft.com/office/drawing/2014/main" id="{6E4F8F82-752D-453A-85EE-A6B8E8CF2898}"/>
               </a:ext>
             </a:extLst>
           </p:cNvPr>
@@ -6534,7 +6534,7 @@
           <p:cNvPr id="11" name="">
             <a:extLst xmlns:a="http://schemas.openxmlformats.org/drawingml/2006/main">
               <a:ext uri="{FF2B5EF4-FFF2-40B4-BE49-F238E27FC236}">
-                <a16:creationId xmlns:a16="http://schemas.microsoft.com/office/drawing/2014/main" id="{99F27D09-345A-4897-8AD3-59333622ED64}"/>
+                <a16:creationId xmlns:a16="http://schemas.microsoft.com/office/drawing/2014/main" id="{26911DE6-0C2C-4830-99BC-631A6AD5A41A}"/>
               </a:ext>
             </a:extLst>
           </p:cNvPr>
@@ -6591,7 +6591,7 @@
           <p:cNvPr id="12" name="">
             <a:extLst xmlns:a="http://schemas.openxmlformats.org/drawingml/2006/main">
               <a:ext uri="{FF2B5EF4-FFF2-40B4-BE49-F238E27FC236}">
-                <a16:creationId xmlns:a16="http://schemas.microsoft.com/office/drawing/2014/main" id="{F459A9B3-3CD3-440B-BCEC-BA8E80FFAA93}"/>
+                <a16:creationId xmlns:a16="http://schemas.microsoft.com/office/drawing/2014/main" id="{0DB03915-0A27-4EED-A0C7-160336D66933}"/>
               </a:ext>
             </a:extLst>
           </p:cNvPr>
@@ -6648,7 +6648,7 @@
           <p:cNvPr id="13" name="">
             <a:extLst xmlns:a="http://schemas.openxmlformats.org/drawingml/2006/main">
               <a:ext uri="{FF2B5EF4-FFF2-40B4-BE49-F238E27FC236}">
-                <a16:creationId xmlns:a16="http://schemas.microsoft.com/office/drawing/2014/main" id="{0772D696-3B01-4F69-8CE5-081F689C03B2}"/>
+                <a16:creationId xmlns:a16="http://schemas.microsoft.com/office/drawing/2014/main" id="{FD90B609-437D-48F8-8862-9700DC598E51}"/>
               </a:ext>
             </a:extLst>
           </p:cNvPr>
@@ -6678,7 +6678,7 @@
           <p:cNvPr id="14" name="">
             <a:extLst xmlns:a="http://schemas.openxmlformats.org/drawingml/2006/main">
               <a:ext uri="{FF2B5EF4-FFF2-40B4-BE49-F238E27FC236}">
-                <a16:creationId xmlns:a16="http://schemas.microsoft.com/office/drawing/2014/main" id="{DC6BFD57-E507-4455-98F7-E3C18951C7AB}"/>
+                <a16:creationId xmlns:a16="http://schemas.microsoft.com/office/drawing/2014/main" id="{45245DC4-E45F-48E6-9080-7361A0392CC5}"/>
               </a:ext>
             </a:extLst>
           </p:cNvPr>
@@ -6733,7 +6733,7 @@
     </p:spTree>
     <p:extLst>
       <p:ext uri="{BB962C8B-B14F-4D97-AF65-F5344CB8AC3E}">
-        <p14:creationId xmlns:p14="http://schemas.microsoft.com/office/powerpoint/2010/main" val="921013620"/>
+        <p14:creationId xmlns:p14="http://schemas.microsoft.com/office/powerpoint/2010/main" val="560443876"/>
       </p:ext>
     </p:extLst>
   </p:cSld>
@@ -6761,10 +6761,10 @@
       </p:grpSpPr>
       <p:sp>
         <p:nvSpPr>
-          <p:cNvPr id="13" name="">
-            <a:extLst xmlns:a="http://schemas.openxmlformats.org/drawingml/2006/main">
-              <a:ext uri="{FF2B5EF4-FFF2-40B4-BE49-F238E27FC236}">
-                <a16:creationId xmlns:a16="http://schemas.microsoft.com/office/drawing/2014/main" id="{A9AC8631-305C-4B33-9D88-2A2ECC726B72}"/>
+          <p:cNvPr id="18" name="">
+            <a:extLst xmlns:a="http://schemas.openxmlformats.org/drawingml/2006/main">
+              <a:ext uri="{FF2B5EF4-FFF2-40B4-BE49-F238E27FC236}">
+                <a16:creationId xmlns:a16="http://schemas.microsoft.com/office/drawing/2014/main" id="{7E5A0BF4-9DC1-4B03-9B46-C22D99F90658}"/>
               </a:ext>
             </a:extLst>
           </p:cNvPr>
@@ -6794,7 +6794,7 @@
           <p:cNvPr id="2" name="">
             <a:extLst xmlns:a="http://schemas.openxmlformats.org/drawingml/2006/main">
               <a:ext uri="{FF2B5EF4-FFF2-40B4-BE49-F238E27FC236}">
-                <a16:creationId xmlns:a16="http://schemas.microsoft.com/office/drawing/2014/main" id="{CB5D7761-4A59-4220-AAC0-4E68F5D359CB}"/>
+                <a16:creationId xmlns:a16="http://schemas.microsoft.com/office/drawing/2014/main" id="{69C1ADF2-05F8-489E-973F-5B459A56D93B}"/>
               </a:ext>
             </a:extLst>
           </p:cNvPr>
@@ -6841,7 +6841,7 @@
                 <a:ea typeface="Noto Sans KR"/>
                 <a:cs typeface="Noto Sans KR"/>
               </a:rPr>
-              <a:t>배포와 다음 검증</a:t>
+              <a:t>배포와 다음 구현 계획</a:t>
             </a:r>
           </a:p>
         </p:txBody>
@@ -6851,7 +6851,7 @@
           <p:cNvPr id="3" name="">
             <a:extLst xmlns:a="http://schemas.openxmlformats.org/drawingml/2006/main">
               <a:ext uri="{FF2B5EF4-FFF2-40B4-BE49-F238E27FC236}">
-                <a16:creationId xmlns:a16="http://schemas.microsoft.com/office/drawing/2014/main" id="{DC8DD914-9D06-4E7E-B428-F1304F0A2B0D}"/>
+                <a16:creationId xmlns:a16="http://schemas.microsoft.com/office/drawing/2014/main" id="{AC44D693-C347-4748-B6B6-3411F05EADF5}"/>
               </a:ext>
             </a:extLst>
           </p:cNvPr>
@@ -6881,7 +6881,7 @@
           <p:cNvPr id="4" name="">
             <a:extLst xmlns:a="http://schemas.openxmlformats.org/drawingml/2006/main">
               <a:ext uri="{FF2B5EF4-FFF2-40B4-BE49-F238E27FC236}">
-                <a16:creationId xmlns:a16="http://schemas.microsoft.com/office/drawing/2014/main" id="{4F03EE54-4986-40CB-AE41-B892824C6573}"/>
+                <a16:creationId xmlns:a16="http://schemas.microsoft.com/office/drawing/2014/main" id="{2076E79C-1279-48AE-8E10-F86F21D472E1}"/>
               </a:ext>
             </a:extLst>
           </p:cNvPr>
@@ -6938,7 +6938,7 @@
           <p:cNvPr id="5" name="">
             <a:extLst xmlns:a="http://schemas.openxmlformats.org/drawingml/2006/main">
               <a:ext uri="{FF2B5EF4-FFF2-40B4-BE49-F238E27FC236}">
-                <a16:creationId xmlns:a16="http://schemas.microsoft.com/office/drawing/2014/main" id="{E47DC82E-FAAB-4C24-9F4A-84E9D8191F01}"/>
+                <a16:creationId xmlns:a16="http://schemas.microsoft.com/office/drawing/2014/main" id="{B57B200F-8BA7-4C3E-AB37-5C8DD8963379}"/>
               </a:ext>
             </a:extLst>
           </p:cNvPr>
@@ -6995,7 +6995,7 @@
           <p:cNvPr id="6" name="">
             <a:extLst xmlns:a="http://schemas.openxmlformats.org/drawingml/2006/main">
               <a:ext uri="{FF2B5EF4-FFF2-40B4-BE49-F238E27FC236}">
-                <a16:creationId xmlns:a16="http://schemas.microsoft.com/office/drawing/2014/main" id="{7E5076EA-FC37-4575-8917-D3AAE9CAFF8F}"/>
+                <a16:creationId xmlns:a16="http://schemas.microsoft.com/office/drawing/2014/main" id="{DC1109BD-204D-4687-9F42-78001271D375}"/>
               </a:ext>
             </a:extLst>
           </p:cNvPr>
@@ -7052,7 +7052,7 @@
           <p:cNvPr id="7" name="">
             <a:extLst xmlns:a="http://schemas.openxmlformats.org/drawingml/2006/main">
               <a:ext uri="{FF2B5EF4-FFF2-40B4-BE49-F238E27FC236}">
-                <a16:creationId xmlns:a16="http://schemas.microsoft.com/office/drawing/2014/main" id="{5958118B-7ECC-44F4-B343-983429AD934E}"/>
+                <a16:creationId xmlns:a16="http://schemas.microsoft.com/office/drawing/2014/main" id="{38F255F3-3A40-4309-B84F-CD5E94F1EC98}"/>
               </a:ext>
             </a:extLst>
           </p:cNvPr>
@@ -7109,7 +7109,7 @@
           <p:cNvPr id="8" name="">
             <a:extLst xmlns:a="http://schemas.openxmlformats.org/drawingml/2006/main">
               <a:ext uri="{FF2B5EF4-FFF2-40B4-BE49-F238E27FC236}">
-                <a16:creationId xmlns:a16="http://schemas.microsoft.com/office/drawing/2014/main" id="{AC33DE70-4F52-4D9F-8748-9BB26F41543A}"/>
+                <a16:creationId xmlns:a16="http://schemas.microsoft.com/office/drawing/2014/main" id="{376D2C89-7F50-467E-A8B3-C5E7002B8365}"/>
               </a:ext>
             </a:extLst>
           </p:cNvPr>
@@ -7166,18 +7166,18 @@
           <p:cNvPr id="9" name="">
             <a:extLst xmlns:a="http://schemas.openxmlformats.org/drawingml/2006/main">
               <a:ext uri="{FF2B5EF4-FFF2-40B4-BE49-F238E27FC236}">
-                <a16:creationId xmlns:a16="http://schemas.microsoft.com/office/drawing/2014/main" id="{83E04C3D-934D-4D42-91D1-E8EB7EBB4204}"/>
-              </a:ext>
-            </a:extLst>
-          </p:cNvPr>
-          <p:cNvSpPr>
-            <a:spLocks xmlns:a="http://schemas.openxmlformats.org/drawingml/2006/main" noGrp="1"/>
-          </p:cNvSpPr>
-          <p:nvPr/>
-        </p:nvSpPr>
-        <p:spPr>
-          <a:xfrm xmlns:a="http://schemas.openxmlformats.org/drawingml/2006/main">
-            <a:off x="685800" y="3724275"/>
+                <a16:creationId xmlns:a16="http://schemas.microsoft.com/office/drawing/2014/main" id="{08266346-4534-4DDF-9225-0B5436629553}"/>
+              </a:ext>
+            </a:extLst>
+          </p:cNvPr>
+          <p:cNvSpPr>
+            <a:spLocks xmlns:a="http://schemas.openxmlformats.org/drawingml/2006/main" noGrp="1"/>
+          </p:cNvSpPr>
+          <p:nvPr/>
+        </p:nvSpPr>
+        <p:spPr>
+          <a:xfrm xmlns:a="http://schemas.openxmlformats.org/drawingml/2006/main">
+            <a:off x="685800" y="3476625"/>
             <a:ext cx="10668000" cy="0"/>
           </a:xfrm>
           <a:prstGeom xmlns:a="http://schemas.openxmlformats.org/drawingml/2006/main" prst="line">
@@ -7196,19 +7196,19 @@
           <p:cNvPr id="10" name="">
             <a:extLst xmlns:a="http://schemas.openxmlformats.org/drawingml/2006/main">
               <a:ext uri="{FF2B5EF4-FFF2-40B4-BE49-F238E27FC236}">
-                <a16:creationId xmlns:a16="http://schemas.microsoft.com/office/drawing/2014/main" id="{E36353AE-FADC-49CF-9126-4198857127DC}"/>
-              </a:ext>
-            </a:extLst>
-          </p:cNvPr>
-          <p:cNvSpPr>
-            <a:spLocks xmlns:a="http://schemas.openxmlformats.org/drawingml/2006/main" noGrp="1"/>
-          </p:cNvSpPr>
-          <p:nvPr/>
-        </p:nvSpPr>
-        <p:spPr>
-          <a:xfrm xmlns:a="http://schemas.openxmlformats.org/drawingml/2006/main">
-            <a:off x="685800" y="4095750"/>
-            <a:ext cx="1809750" cy="381000"/>
+                <a16:creationId xmlns:a16="http://schemas.microsoft.com/office/drawing/2014/main" id="{092BA08B-458B-4C20-A169-C871BE597885}"/>
+              </a:ext>
+            </a:extLst>
+          </p:cNvPr>
+          <p:cNvSpPr>
+            <a:spLocks xmlns:a="http://schemas.openxmlformats.org/drawingml/2006/main" noGrp="1"/>
+          </p:cNvSpPr>
+          <p:nvPr/>
+        </p:nvSpPr>
+        <p:spPr>
+          <a:xfrm xmlns:a="http://schemas.openxmlformats.org/drawingml/2006/main">
+            <a:off x="685800" y="3800475"/>
+            <a:ext cx="2000250" cy="381000"/>
           </a:xfrm>
           <a:prstGeom xmlns:a="http://schemas.openxmlformats.org/drawingml/2006/main" prst="rect">
             <a:avLst/>
@@ -7243,7 +7243,7 @@
                 <a:ea typeface="Noto Sans KR"/>
                 <a:cs typeface="Noto Sans KR"/>
               </a:rPr>
-              <a:t>다음 검증</a:t>
+              <a:t>다음 구현 계획</a:t>
             </a:r>
           </a:p>
         </p:txBody>
@@ -7253,36 +7253,93 @@
           <p:cNvPr id="11" name="">
             <a:extLst xmlns:a="http://schemas.openxmlformats.org/drawingml/2006/main">
               <a:ext uri="{FF2B5EF4-FFF2-40B4-BE49-F238E27FC236}">
-                <a16:creationId xmlns:a16="http://schemas.microsoft.com/office/drawing/2014/main" id="{CC7297F7-3A95-4FF8-8FAA-785F716808F3}"/>
-              </a:ext>
-            </a:extLst>
-          </p:cNvPr>
-          <p:cNvSpPr>
-            <a:spLocks xmlns:a="http://schemas.openxmlformats.org/drawingml/2006/main" noGrp="1"/>
-          </p:cNvSpPr>
-          <p:nvPr/>
-        </p:nvSpPr>
-        <p:spPr>
-          <a:xfrm xmlns:a="http://schemas.openxmlformats.org/drawingml/2006/main">
-            <a:off x="2762250" y="4019550"/>
-            <a:ext cx="8286750" cy="1047750"/>
-          </a:xfrm>
-          <a:prstGeom xmlns:a="http://schemas.openxmlformats.org/drawingml/2006/main" prst="rect">
-            <a:avLst/>
-          </a:prstGeom>
-          <a:noFill xmlns:a="http://schemas.openxmlformats.org/drawingml/2006/main"/>
-          <a:ln xmlns:a="http://schemas.openxmlformats.org/drawingml/2006/main" w="0">
-            <a:noFill/>
-          </a:ln>
-        </p:spPr>
-        <p:txBody>
-          <a:bodyPr xmlns:a="http://schemas.openxmlformats.org/drawingml/2006/main">
-            <a:noAutofit/>
-          </a:bodyPr>
-          <a:lstStyle xmlns:a="http://schemas.openxmlformats.org/drawingml/2006/main"/>
-          <a:p xmlns:a="http://schemas.openxmlformats.org/drawingml/2006/main">
-            <a:pPr algn="l">
-              <a:defRPr sz="2325" b="1">
+                <a16:creationId xmlns:a16="http://schemas.microsoft.com/office/drawing/2014/main" id="{0B371E5D-6C86-4AEB-8CCB-1BD66E6F8099}"/>
+              </a:ext>
+            </a:extLst>
+          </p:cNvPr>
+          <p:cNvSpPr>
+            <a:spLocks xmlns:a="http://schemas.openxmlformats.org/drawingml/2006/main" noGrp="1"/>
+          </p:cNvSpPr>
+          <p:nvPr/>
+        </p:nvSpPr>
+        <p:spPr>
+          <a:xfrm xmlns:a="http://schemas.openxmlformats.org/drawingml/2006/main">
+            <a:off x="2838450" y="3810000"/>
+            <a:ext cx="523875" cy="342900"/>
+          </a:xfrm>
+          <a:prstGeom xmlns:a="http://schemas.openxmlformats.org/drawingml/2006/main" prst="rect">
+            <a:avLst/>
+          </a:prstGeom>
+          <a:noFill xmlns:a="http://schemas.openxmlformats.org/drawingml/2006/main"/>
+          <a:ln xmlns:a="http://schemas.openxmlformats.org/drawingml/2006/main" w="0">
+            <a:noFill/>
+          </a:ln>
+        </p:spPr>
+        <p:txBody>
+          <a:bodyPr xmlns:a="http://schemas.openxmlformats.org/drawingml/2006/main">
+            <a:noAutofit/>
+          </a:bodyPr>
+          <a:lstStyle xmlns:a="http://schemas.openxmlformats.org/drawingml/2006/main"/>
+          <a:p xmlns:a="http://schemas.openxmlformats.org/drawingml/2006/main">
+            <a:pPr algn="l">
+              <a:defRPr sz="1575" b="1">
+                <a:solidFill>
+                  <a:srgbClr val="865C46"/>
+                </a:solidFill>
+                <a:latin typeface="Noto Sans KR"/>
+                <a:ea typeface="Noto Sans KR"/>
+                <a:cs typeface="Noto Sans KR"/>
+              </a:defRPr>
+            </a:pPr>
+            <a:r>
+              <a:rPr sz="1575" b="1">
+                <a:solidFill>
+                  <a:srgbClr val="865C46"/>
+                </a:solidFill>
+                <a:latin typeface="Noto Sans KR"/>
+                <a:ea typeface="Noto Sans KR"/>
+                <a:cs typeface="Noto Sans KR"/>
+              </a:rPr>
+              <a:t>01</a:t>
+            </a:r>
+          </a:p>
+        </p:txBody>
+      </p:sp>
+      <p:sp>
+        <p:nvSpPr>
+          <p:cNvPr id="12" name="">
+            <a:extLst xmlns:a="http://schemas.openxmlformats.org/drawingml/2006/main">
+              <a:ext uri="{FF2B5EF4-FFF2-40B4-BE49-F238E27FC236}">
+                <a16:creationId xmlns:a16="http://schemas.microsoft.com/office/drawing/2014/main" id="{AFD71A96-A9FF-482D-899C-1BF2E951FEF1}"/>
+              </a:ext>
+            </a:extLst>
+          </p:cNvPr>
+          <p:cNvSpPr>
+            <a:spLocks xmlns:a="http://schemas.openxmlformats.org/drawingml/2006/main" noGrp="1"/>
+          </p:cNvSpPr>
+          <p:nvPr/>
+        </p:nvSpPr>
+        <p:spPr>
+          <a:xfrm xmlns:a="http://schemas.openxmlformats.org/drawingml/2006/main">
+            <a:off x="3429000" y="3781425"/>
+            <a:ext cx="7810500" cy="400050"/>
+          </a:xfrm>
+          <a:prstGeom xmlns:a="http://schemas.openxmlformats.org/drawingml/2006/main" prst="rect">
+            <a:avLst/>
+          </a:prstGeom>
+          <a:noFill xmlns:a="http://schemas.openxmlformats.org/drawingml/2006/main"/>
+          <a:ln xmlns:a="http://schemas.openxmlformats.org/drawingml/2006/main" w="0">
+            <a:noFill/>
+          </a:ln>
+        </p:spPr>
+        <p:txBody>
+          <a:bodyPr xmlns:a="http://schemas.openxmlformats.org/drawingml/2006/main">
+            <a:noAutofit/>
+          </a:bodyPr>
+          <a:lstStyle xmlns:a="http://schemas.openxmlformats.org/drawingml/2006/main"/>
+          <a:p xmlns:a="http://schemas.openxmlformats.org/drawingml/2006/main">
+            <a:pPr algn="l">
+              <a:defRPr sz="1875" b="1">
                 <a:solidFill>
                   <a:srgbClr val="F7F2EA"/>
                 </a:solidFill>
@@ -7292,7 +7349,7 @@
               </a:defRPr>
             </a:pPr>
             <a:r>
-              <a:rPr sz="2325" b="1">
+              <a:rPr sz="1875" b="1">
                 <a:solidFill>
                   <a:srgbClr val="F7F2EA"/>
                 </a:solidFill>
@@ -7300,12 +7357,103 @@
                 <a:ea typeface="Noto Sans KR"/>
                 <a:cs typeface="Noto Sans KR"/>
               </a:rPr>
-              <a:t>3명에게 막힌 지점을 찾고, 5명 시험에서</a:t>
-            </a:r>
-          </a:p>
-          <a:p xmlns:a="http://schemas.openxmlformats.org/drawingml/2006/main">
-            <a:pPr algn="l">
-              <a:defRPr sz="2325" b="1">
+              <a:t>3명 관찰과 5명 시험으로 막히는 위치와 시간 단축을 확인</a:t>
+            </a:r>
+          </a:p>
+        </p:txBody>
+      </p:sp>
+      <p:sp>
+        <p:nvSpPr>
+          <p:cNvPr id="13" name="">
+            <a:extLst xmlns:a="http://schemas.openxmlformats.org/drawingml/2006/main">
+              <a:ext uri="{FF2B5EF4-FFF2-40B4-BE49-F238E27FC236}">
+                <a16:creationId xmlns:a16="http://schemas.microsoft.com/office/drawing/2014/main" id="{B9AB395D-0E1A-4037-9FFD-4960804D5BC0}"/>
+              </a:ext>
+            </a:extLst>
+          </p:cNvPr>
+          <p:cNvSpPr>
+            <a:spLocks xmlns:a="http://schemas.openxmlformats.org/drawingml/2006/main" noGrp="1"/>
+          </p:cNvSpPr>
+          <p:nvPr/>
+        </p:nvSpPr>
+        <p:spPr>
+          <a:xfrm xmlns:a="http://schemas.openxmlformats.org/drawingml/2006/main">
+            <a:off x="2838450" y="4457700"/>
+            <a:ext cx="523875" cy="342900"/>
+          </a:xfrm>
+          <a:prstGeom xmlns:a="http://schemas.openxmlformats.org/drawingml/2006/main" prst="rect">
+            <a:avLst/>
+          </a:prstGeom>
+          <a:noFill xmlns:a="http://schemas.openxmlformats.org/drawingml/2006/main"/>
+          <a:ln xmlns:a="http://schemas.openxmlformats.org/drawingml/2006/main" w="0">
+            <a:noFill/>
+          </a:ln>
+        </p:spPr>
+        <p:txBody>
+          <a:bodyPr xmlns:a="http://schemas.openxmlformats.org/drawingml/2006/main">
+            <a:noAutofit/>
+          </a:bodyPr>
+          <a:lstStyle xmlns:a="http://schemas.openxmlformats.org/drawingml/2006/main"/>
+          <a:p xmlns:a="http://schemas.openxmlformats.org/drawingml/2006/main">
+            <a:pPr algn="l">
+              <a:defRPr sz="1575" b="1">
+                <a:solidFill>
+                  <a:srgbClr val="865C46"/>
+                </a:solidFill>
+                <a:latin typeface="Noto Sans KR"/>
+                <a:ea typeface="Noto Sans KR"/>
+                <a:cs typeface="Noto Sans KR"/>
+              </a:defRPr>
+            </a:pPr>
+            <a:r>
+              <a:rPr sz="1575" b="1">
+                <a:solidFill>
+                  <a:srgbClr val="865C46"/>
+                </a:solidFill>
+                <a:latin typeface="Noto Sans KR"/>
+                <a:ea typeface="Noto Sans KR"/>
+                <a:cs typeface="Noto Sans KR"/>
+              </a:rPr>
+              <a:t>02</a:t>
+            </a:r>
+          </a:p>
+        </p:txBody>
+      </p:sp>
+      <p:sp>
+        <p:nvSpPr>
+          <p:cNvPr id="14" name="">
+            <a:extLst xmlns:a="http://schemas.openxmlformats.org/drawingml/2006/main">
+              <a:ext uri="{FF2B5EF4-FFF2-40B4-BE49-F238E27FC236}">
+                <a16:creationId xmlns:a16="http://schemas.microsoft.com/office/drawing/2014/main" id="{A7EB0065-F287-4ED0-B6D7-D3E8555FB980}"/>
+              </a:ext>
+            </a:extLst>
+          </p:cNvPr>
+          <p:cNvSpPr>
+            <a:spLocks xmlns:a="http://schemas.openxmlformats.org/drawingml/2006/main" noGrp="1"/>
+          </p:cNvSpPr>
+          <p:nvPr/>
+        </p:nvSpPr>
+        <p:spPr>
+          <a:xfrm xmlns:a="http://schemas.openxmlformats.org/drawingml/2006/main">
+            <a:off x="3429000" y="4429125"/>
+            <a:ext cx="7810500" cy="400050"/>
+          </a:xfrm>
+          <a:prstGeom xmlns:a="http://schemas.openxmlformats.org/drawingml/2006/main" prst="rect">
+            <a:avLst/>
+          </a:prstGeom>
+          <a:noFill xmlns:a="http://schemas.openxmlformats.org/drawingml/2006/main"/>
+          <a:ln xmlns:a="http://schemas.openxmlformats.org/drawingml/2006/main" w="0">
+            <a:noFill/>
+          </a:ln>
+        </p:spPr>
+        <p:txBody>
+          <a:bodyPr xmlns:a="http://schemas.openxmlformats.org/drawingml/2006/main">
+            <a:noAutofit/>
+          </a:bodyPr>
+          <a:lstStyle xmlns:a="http://schemas.openxmlformats.org/drawingml/2006/main"/>
+          <a:p xmlns:a="http://schemas.openxmlformats.org/drawingml/2006/main">
+            <a:pPr algn="l">
+              <a:defRPr sz="1875" b="1">
                 <a:solidFill>
                   <a:srgbClr val="F7F2EA"/>
                 </a:solidFill>
@@ -7315,7 +7463,7 @@
               </a:defRPr>
             </a:pPr>
             <a:r>
-              <a:rPr sz="2325" b="1">
+              <a:rPr sz="1875" b="1">
                 <a:solidFill>
                   <a:srgbClr val="F7F2EA"/>
                 </a:solidFill>
@@ -7323,28 +7471,142 @@
                 <a:ea typeface="Noto Sans KR"/>
                 <a:cs typeface="Noto Sans KR"/>
               </a:rPr>
-              <a:t>정리 시간과 생각의 확장이 재현되는지 확인</a:t>
-            </a:r>
-          </a:p>
-        </p:txBody>
-      </p:sp>
-      <p:sp>
-        <p:nvSpPr>
-          <p:cNvPr id="12" name="">
-            <a:extLst xmlns:a="http://schemas.openxmlformats.org/drawingml/2006/main">
-              <a:ext uri="{FF2B5EF4-FFF2-40B4-BE49-F238E27FC236}">
-                <a16:creationId xmlns:a16="http://schemas.microsoft.com/office/drawing/2014/main" id="{D76164BE-B507-4179-A9D7-5FC0315E9AB2}"/>
-              </a:ext>
-            </a:extLst>
-          </p:cNvPr>
-          <p:cNvSpPr>
-            <a:spLocks xmlns:a="http://schemas.openxmlformats.org/drawingml/2006/main" noGrp="1"/>
-          </p:cNvSpPr>
-          <p:nvPr/>
-        </p:nvSpPr>
-        <p:spPr>
-          <a:xfrm xmlns:a="http://schemas.openxmlformats.org/drawingml/2006/main">
-            <a:off x="685800" y="5810250"/>
+              <a:t>여러 사용자가 쓰는 단계에서 계정 로그인과 사용자별 기록 권한 구현</a:t>
+            </a:r>
+          </a:p>
+        </p:txBody>
+      </p:sp>
+      <p:sp>
+        <p:nvSpPr>
+          <p:cNvPr id="15" name="">
+            <a:extLst xmlns:a="http://schemas.openxmlformats.org/drawingml/2006/main">
+              <a:ext uri="{FF2B5EF4-FFF2-40B4-BE49-F238E27FC236}">
+                <a16:creationId xmlns:a16="http://schemas.microsoft.com/office/drawing/2014/main" id="{A5D3229B-A237-459D-A718-622F4BB75A49}"/>
+              </a:ext>
+            </a:extLst>
+          </p:cNvPr>
+          <p:cNvSpPr>
+            <a:spLocks xmlns:a="http://schemas.openxmlformats.org/drawingml/2006/main" noGrp="1"/>
+          </p:cNvSpPr>
+          <p:nvPr/>
+        </p:nvSpPr>
+        <p:spPr>
+          <a:xfrm xmlns:a="http://schemas.openxmlformats.org/drawingml/2006/main">
+            <a:off x="2838450" y="5105400"/>
+            <a:ext cx="523875" cy="342900"/>
+          </a:xfrm>
+          <a:prstGeom xmlns:a="http://schemas.openxmlformats.org/drawingml/2006/main" prst="rect">
+            <a:avLst/>
+          </a:prstGeom>
+          <a:noFill xmlns:a="http://schemas.openxmlformats.org/drawingml/2006/main"/>
+          <a:ln xmlns:a="http://schemas.openxmlformats.org/drawingml/2006/main" w="0">
+            <a:noFill/>
+          </a:ln>
+        </p:spPr>
+        <p:txBody>
+          <a:bodyPr xmlns:a="http://schemas.openxmlformats.org/drawingml/2006/main">
+            <a:noAutofit/>
+          </a:bodyPr>
+          <a:lstStyle xmlns:a="http://schemas.openxmlformats.org/drawingml/2006/main"/>
+          <a:p xmlns:a="http://schemas.openxmlformats.org/drawingml/2006/main">
+            <a:pPr algn="l">
+              <a:defRPr sz="1575" b="1">
+                <a:solidFill>
+                  <a:srgbClr val="865C46"/>
+                </a:solidFill>
+                <a:latin typeface="Noto Sans KR"/>
+                <a:ea typeface="Noto Sans KR"/>
+                <a:cs typeface="Noto Sans KR"/>
+              </a:defRPr>
+            </a:pPr>
+            <a:r>
+              <a:rPr sz="1575" b="1">
+                <a:solidFill>
+                  <a:srgbClr val="865C46"/>
+                </a:solidFill>
+                <a:latin typeface="Noto Sans KR"/>
+                <a:ea typeface="Noto Sans KR"/>
+                <a:cs typeface="Noto Sans KR"/>
+              </a:rPr>
+              <a:t>03</a:t>
+            </a:r>
+          </a:p>
+        </p:txBody>
+      </p:sp>
+      <p:sp>
+        <p:nvSpPr>
+          <p:cNvPr id="16" name="">
+            <a:extLst xmlns:a="http://schemas.openxmlformats.org/drawingml/2006/main">
+              <a:ext uri="{FF2B5EF4-FFF2-40B4-BE49-F238E27FC236}">
+                <a16:creationId xmlns:a16="http://schemas.microsoft.com/office/drawing/2014/main" id="{AB1EC055-43D2-4035-9351-DF340169FD17}"/>
+              </a:ext>
+            </a:extLst>
+          </p:cNvPr>
+          <p:cNvSpPr>
+            <a:spLocks xmlns:a="http://schemas.openxmlformats.org/drawingml/2006/main" noGrp="1"/>
+          </p:cNvSpPr>
+          <p:nvPr/>
+        </p:nvSpPr>
+        <p:spPr>
+          <a:xfrm xmlns:a="http://schemas.openxmlformats.org/drawingml/2006/main">
+            <a:off x="3429000" y="5076825"/>
+            <a:ext cx="7810500" cy="400050"/>
+          </a:xfrm>
+          <a:prstGeom xmlns:a="http://schemas.openxmlformats.org/drawingml/2006/main" prst="rect">
+            <a:avLst/>
+          </a:prstGeom>
+          <a:noFill xmlns:a="http://schemas.openxmlformats.org/drawingml/2006/main"/>
+          <a:ln xmlns:a="http://schemas.openxmlformats.org/drawingml/2006/main" w="0">
+            <a:noFill/>
+          </a:ln>
+        </p:spPr>
+        <p:txBody>
+          <a:bodyPr xmlns:a="http://schemas.openxmlformats.org/drawingml/2006/main">
+            <a:noAutofit/>
+          </a:bodyPr>
+          <a:lstStyle xmlns:a="http://schemas.openxmlformats.org/drawingml/2006/main"/>
+          <a:p xmlns:a="http://schemas.openxmlformats.org/drawingml/2006/main">
+            <a:pPr algn="l">
+              <a:defRPr sz="1875" b="1">
+                <a:solidFill>
+                  <a:srgbClr val="F7F2EA"/>
+                </a:solidFill>
+                <a:latin typeface="Noto Sans KR"/>
+                <a:ea typeface="Noto Sans KR"/>
+                <a:cs typeface="Noto Sans KR"/>
+              </a:defRPr>
+            </a:pPr>
+            <a:r>
+              <a:rPr sz="1875" b="1">
+                <a:solidFill>
+                  <a:srgbClr val="F7F2EA"/>
+                </a:solidFill>
+                <a:latin typeface="Noto Sans KR"/>
+                <a:ea typeface="Noto Sans KR"/>
+                <a:cs typeface="Noto Sans KR"/>
+              </a:rPr>
+              <a:t>반복 사용이 확인되면 검색 필터와 결과물 버전 관리 개선</a:t>
+            </a:r>
+          </a:p>
+        </p:txBody>
+      </p:sp>
+      <p:sp>
+        <p:nvSpPr>
+          <p:cNvPr id="17" name="">
+            <a:extLst xmlns:a="http://schemas.openxmlformats.org/drawingml/2006/main">
+              <a:ext uri="{FF2B5EF4-FFF2-40B4-BE49-F238E27FC236}">
+                <a16:creationId xmlns:a16="http://schemas.microsoft.com/office/drawing/2014/main" id="{55906AF3-856A-4A47-B98B-340DD49C1CBC}"/>
+              </a:ext>
+            </a:extLst>
+          </p:cNvPr>
+          <p:cNvSpPr>
+            <a:spLocks xmlns:a="http://schemas.openxmlformats.org/drawingml/2006/main" noGrp="1"/>
+          </p:cNvSpPr>
+          <p:nvPr/>
+        </p:nvSpPr>
+        <p:spPr>
+          <a:xfrm xmlns:a="http://schemas.openxmlformats.org/drawingml/2006/main">
+            <a:off x="685800" y="5905500"/>
             <a:ext cx="10668000" cy="333375"/>
           </a:xfrm>
           <a:prstGeom xmlns:a="http://schemas.openxmlformats.org/drawingml/2006/main" prst="rect">
@@ -7380,7 +7642,7 @@
                 <a:ea typeface="Noto Sans KR"/>
                 <a:cs typeface="Noto Sans KR"/>
               </a:rPr>
-              <a:t>저장한 맥락을 다시 쓰는 경험이 다른 사용자에게도 도움이 되는지 확인하겠습니다</a:t>
+              <a:t>검증 결과를 확인한 뒤 필요한 기능부터 구현하겠습니다</a:t>
             </a:r>
           </a:p>
         </p:txBody>
@@ -7388,7 +7650,7 @@
     </p:spTree>
     <p:extLst>
       <p:ext uri="{BB962C8B-B14F-4D97-AF65-F5344CB8AC3E}">
-        <p14:creationId xmlns:p14="http://schemas.microsoft.com/office/powerpoint/2010/main" val="686948999"/>
+        <p14:creationId xmlns:p14="http://schemas.microsoft.com/office/powerpoint/2010/main" val="622870741"/>
       </p:ext>
     </p:extLst>
   </p:cSld>
@@ -7419,7 +7681,7 @@
           <p:cNvPr id="19" name="">
             <a:extLst xmlns:a="http://schemas.openxmlformats.org/drawingml/2006/main">
               <a:ext uri="{FF2B5EF4-FFF2-40B4-BE49-F238E27FC236}">
-                <a16:creationId xmlns:a16="http://schemas.microsoft.com/office/drawing/2014/main" id="{323DC78D-1F62-412C-BE4C-D330E6F24666}"/>
+                <a16:creationId xmlns:a16="http://schemas.microsoft.com/office/drawing/2014/main" id="{0D809E80-7F4B-4A9B-9C28-5865EBBB4796}"/>
               </a:ext>
             </a:extLst>
           </p:cNvPr>
@@ -7449,7 +7711,7 @@
           <p:cNvPr id="2" name="">
             <a:extLst xmlns:a="http://schemas.openxmlformats.org/drawingml/2006/main">
               <a:ext uri="{FF2B5EF4-FFF2-40B4-BE49-F238E27FC236}">
-                <a16:creationId xmlns:a16="http://schemas.microsoft.com/office/drawing/2014/main" id="{59FECA49-A710-485B-A5BC-B4312182C3AE}"/>
+                <a16:creationId xmlns:a16="http://schemas.microsoft.com/office/drawing/2014/main" id="{76517AC6-201A-4D9A-9AA1-8EA2BCB86660}"/>
               </a:ext>
             </a:extLst>
           </p:cNvPr>
@@ -7506,7 +7768,7 @@
           <p:cNvPr id="3" name="">
             <a:extLst xmlns:a="http://schemas.openxmlformats.org/drawingml/2006/main">
               <a:ext uri="{FF2B5EF4-FFF2-40B4-BE49-F238E27FC236}">
-                <a16:creationId xmlns:a16="http://schemas.microsoft.com/office/drawing/2014/main" id="{7ADBE61B-3291-4EF1-8FB6-E9833FAB6FC8}"/>
+                <a16:creationId xmlns:a16="http://schemas.microsoft.com/office/drawing/2014/main" id="{60FF1A6D-AE90-4522-A5A3-FCF996261809}"/>
               </a:ext>
             </a:extLst>
           </p:cNvPr>
@@ -7536,7 +7798,7 @@
           <p:cNvPr id="4" name="">
             <a:extLst xmlns:a="http://schemas.openxmlformats.org/drawingml/2006/main">
               <a:ext uri="{FF2B5EF4-FFF2-40B4-BE49-F238E27FC236}">
-                <a16:creationId xmlns:a16="http://schemas.microsoft.com/office/drawing/2014/main" id="{2EFA10E0-7197-4ED5-8498-0EDCE096A055}"/>
+                <a16:creationId xmlns:a16="http://schemas.microsoft.com/office/drawing/2014/main" id="{1E25333D-3CD6-4F00-99EF-5364605BF191}"/>
               </a:ext>
             </a:extLst>
           </p:cNvPr>
@@ -7593,7 +7855,7 @@
           <p:cNvPr id="5" name="">
             <a:extLst xmlns:a="http://schemas.openxmlformats.org/drawingml/2006/main">
               <a:ext uri="{FF2B5EF4-FFF2-40B4-BE49-F238E27FC236}">
-                <a16:creationId xmlns:a16="http://schemas.microsoft.com/office/drawing/2014/main" id="{3D007CDE-6061-4092-ADC1-9C4EF2EBAE18}"/>
+                <a16:creationId xmlns:a16="http://schemas.microsoft.com/office/drawing/2014/main" id="{80EFDD51-9818-4778-B290-8219CEB081B7}"/>
               </a:ext>
             </a:extLst>
           </p:cNvPr>
@@ -7650,7 +7912,7 @@
           <p:cNvPr id="6" name="">
             <a:extLst xmlns:a="http://schemas.openxmlformats.org/drawingml/2006/main">
               <a:ext uri="{FF2B5EF4-FFF2-40B4-BE49-F238E27FC236}">
-                <a16:creationId xmlns:a16="http://schemas.microsoft.com/office/drawing/2014/main" id="{D271B616-071F-458E-BC9A-871AEB873F25}"/>
+                <a16:creationId xmlns:a16="http://schemas.microsoft.com/office/drawing/2014/main" id="{C5681EAB-1E9A-4569-8B1E-1A68850D40F2}"/>
               </a:ext>
             </a:extLst>
           </p:cNvPr>
@@ -7730,7 +7992,7 @@
           <p:cNvPr id="7" name="">
             <a:extLst xmlns:a="http://schemas.openxmlformats.org/drawingml/2006/main">
               <a:ext uri="{FF2B5EF4-FFF2-40B4-BE49-F238E27FC236}">
-                <a16:creationId xmlns:a16="http://schemas.microsoft.com/office/drawing/2014/main" id="{664353D3-FA5E-43C3-A482-01CA08821EFE}"/>
+                <a16:creationId xmlns:a16="http://schemas.microsoft.com/office/drawing/2014/main" id="{BE56AC31-8223-4DE0-B173-48C39FCB1FF8}"/>
               </a:ext>
             </a:extLst>
           </p:cNvPr>
@@ -7787,7 +8049,7 @@
           <p:cNvPr id="8" name="">
             <a:extLst xmlns:a="http://schemas.openxmlformats.org/drawingml/2006/main">
               <a:ext uri="{FF2B5EF4-FFF2-40B4-BE49-F238E27FC236}">
-                <a16:creationId xmlns:a16="http://schemas.microsoft.com/office/drawing/2014/main" id="{AEFF87DE-571D-4BE8-A3ED-2E2A0E160B9F}"/>
+                <a16:creationId xmlns:a16="http://schemas.microsoft.com/office/drawing/2014/main" id="{DE91129E-9046-460E-9D15-771742A51737}"/>
               </a:ext>
             </a:extLst>
           </p:cNvPr>
@@ -7867,7 +8129,7 @@
           <p:cNvPr id="9" name="">
             <a:extLst xmlns:a="http://schemas.openxmlformats.org/drawingml/2006/main">
               <a:ext uri="{FF2B5EF4-FFF2-40B4-BE49-F238E27FC236}">
-                <a16:creationId xmlns:a16="http://schemas.microsoft.com/office/drawing/2014/main" id="{B7D9E5F4-F99A-48ED-AD5E-EE58E055D35A}"/>
+                <a16:creationId xmlns:a16="http://schemas.microsoft.com/office/drawing/2014/main" id="{4C91B3F4-BFC5-4579-8D4D-8A4368886A22}"/>
               </a:ext>
             </a:extLst>
           </p:cNvPr>
@@ -7924,7 +8186,7 @@
           <p:cNvPr id="10" name="">
             <a:extLst xmlns:a="http://schemas.openxmlformats.org/drawingml/2006/main">
               <a:ext uri="{FF2B5EF4-FFF2-40B4-BE49-F238E27FC236}">
-                <a16:creationId xmlns:a16="http://schemas.microsoft.com/office/drawing/2014/main" id="{C8CE2233-A940-442E-AB15-EA326E649477}"/>
+                <a16:creationId xmlns:a16="http://schemas.microsoft.com/office/drawing/2014/main" id="{876DED59-8F44-4D12-BFB8-3F54E58F6371}"/>
               </a:ext>
             </a:extLst>
           </p:cNvPr>
@@ -8027,7 +8289,7 @@
           <p:cNvPr id="11" name="">
             <a:extLst xmlns:a="http://schemas.openxmlformats.org/drawingml/2006/main">
               <a:ext uri="{FF2B5EF4-FFF2-40B4-BE49-F238E27FC236}">
-                <a16:creationId xmlns:a16="http://schemas.microsoft.com/office/drawing/2014/main" id="{CFB81EF7-5A15-4759-B2C7-1A93FB4220B2}"/>
+                <a16:creationId xmlns:a16="http://schemas.microsoft.com/office/drawing/2014/main" id="{F08FF74B-C0DA-43BF-B18B-69A52B789BF2}"/>
               </a:ext>
             </a:extLst>
           </p:cNvPr>
@@ -8084,7 +8346,7 @@
           <p:cNvPr id="12" name="">
             <a:extLst xmlns:a="http://schemas.openxmlformats.org/drawingml/2006/main">
               <a:ext uri="{FF2B5EF4-FFF2-40B4-BE49-F238E27FC236}">
-                <a16:creationId xmlns:a16="http://schemas.microsoft.com/office/drawing/2014/main" id="{5A5345A3-09A9-43C5-87CA-9D33CECC4DD6}"/>
+                <a16:creationId xmlns:a16="http://schemas.microsoft.com/office/drawing/2014/main" id="{07E2AEBE-9DE1-4D87-B338-2EF35ACEB959}"/>
               </a:ext>
             </a:extLst>
           </p:cNvPr>
@@ -8187,7 +8449,7 @@
           <p:cNvPr id="13" name="">
             <a:extLst xmlns:a="http://schemas.openxmlformats.org/drawingml/2006/main">
               <a:ext uri="{FF2B5EF4-FFF2-40B4-BE49-F238E27FC236}">
-                <a16:creationId xmlns:a16="http://schemas.microsoft.com/office/drawing/2014/main" id="{08072128-5241-4765-8200-6193A90FFF7B}"/>
+                <a16:creationId xmlns:a16="http://schemas.microsoft.com/office/drawing/2014/main" id="{5A0F4B83-8E4A-425D-925E-B32B02CF25CB}"/>
               </a:ext>
             </a:extLst>
           </p:cNvPr>
@@ -8244,7 +8506,7 @@
           <p:cNvPr id="14" name="">
             <a:extLst xmlns:a="http://schemas.openxmlformats.org/drawingml/2006/main">
               <a:ext uri="{FF2B5EF4-FFF2-40B4-BE49-F238E27FC236}">
-                <a16:creationId xmlns:a16="http://schemas.microsoft.com/office/drawing/2014/main" id="{9F979232-139D-4300-B314-436C7C1A3D7C}"/>
+                <a16:creationId xmlns:a16="http://schemas.microsoft.com/office/drawing/2014/main" id="{1D6FC5DF-D4CE-4F00-89C4-7B7CAF6BCB57}"/>
               </a:ext>
             </a:extLst>
           </p:cNvPr>
@@ -8301,7 +8563,7 @@
           <p:cNvPr id="15" name="">
             <a:extLst xmlns:a="http://schemas.openxmlformats.org/drawingml/2006/main">
               <a:ext uri="{FF2B5EF4-FFF2-40B4-BE49-F238E27FC236}">
-                <a16:creationId xmlns:a16="http://schemas.microsoft.com/office/drawing/2014/main" id="{5D0131B7-09A1-46B5-BCA4-B3030540EBF0}"/>
+                <a16:creationId xmlns:a16="http://schemas.microsoft.com/office/drawing/2014/main" id="{8E8FE15D-E32C-405E-9023-A9259F88A469}"/>
               </a:ext>
             </a:extLst>
           </p:cNvPr>
@@ -8358,7 +8620,7 @@
           <p:cNvPr id="16" name="">
             <a:extLst xmlns:a="http://schemas.openxmlformats.org/drawingml/2006/main">
               <a:ext uri="{FF2B5EF4-FFF2-40B4-BE49-F238E27FC236}">
-                <a16:creationId xmlns:a16="http://schemas.microsoft.com/office/drawing/2014/main" id="{564204B0-6FFC-468B-A9C0-7916998EA89D}"/>
+                <a16:creationId xmlns:a16="http://schemas.microsoft.com/office/drawing/2014/main" id="{2502DF1B-AA10-4663-8519-B9796973A113}"/>
               </a:ext>
             </a:extLst>
           </p:cNvPr>
@@ -8388,7 +8650,7 @@
           <p:cNvPr id="17" name="">
             <a:extLst xmlns:a="http://schemas.openxmlformats.org/drawingml/2006/main">
               <a:ext uri="{FF2B5EF4-FFF2-40B4-BE49-F238E27FC236}">
-                <a16:creationId xmlns:a16="http://schemas.microsoft.com/office/drawing/2014/main" id="{891D9AF2-A6D5-469E-9A6B-F1109C5A21CF}"/>
+                <a16:creationId xmlns:a16="http://schemas.microsoft.com/office/drawing/2014/main" id="{64FC5DD0-E4B7-47D7-A69F-A5B55E9BE235}"/>
               </a:ext>
             </a:extLst>
           </p:cNvPr>
@@ -8445,7 +8707,7 @@
           <p:cNvPr id="18" name="">
             <a:extLst xmlns:a="http://schemas.openxmlformats.org/drawingml/2006/main">
               <a:ext uri="{FF2B5EF4-FFF2-40B4-BE49-F238E27FC236}">
-                <a16:creationId xmlns:a16="http://schemas.microsoft.com/office/drawing/2014/main" id="{BCEEE817-C04D-4A99-BA83-E5C99F6A64DD}"/>
+                <a16:creationId xmlns:a16="http://schemas.microsoft.com/office/drawing/2014/main" id="{EAC6106A-70DE-4CB6-87F8-D0D65F3FA019}"/>
               </a:ext>
             </a:extLst>
           </p:cNvPr>
@@ -8523,7 +8785,7 @@
     </p:spTree>
     <p:extLst>
       <p:ext uri="{BB962C8B-B14F-4D97-AF65-F5344CB8AC3E}">
-        <p14:creationId xmlns:p14="http://schemas.microsoft.com/office/powerpoint/2010/main" val="1013457757"/>
+        <p14:creationId xmlns:p14="http://schemas.microsoft.com/office/powerpoint/2010/main" val="1834696863"/>
       </p:ext>
     </p:extLst>
   </p:cSld>
@@ -8554,7 +8816,7 @@
           <p:cNvPr id="19" name="">
             <a:extLst xmlns:a="http://schemas.openxmlformats.org/drawingml/2006/main">
               <a:ext uri="{FF2B5EF4-FFF2-40B4-BE49-F238E27FC236}">
-                <a16:creationId xmlns:a16="http://schemas.microsoft.com/office/drawing/2014/main" id="{EDC1E92A-CE0D-4BC4-8AFE-A1289A959F99}"/>
+                <a16:creationId xmlns:a16="http://schemas.microsoft.com/office/drawing/2014/main" id="{DF0F2D52-B5C1-460D-8050-584B2939BCE9}"/>
               </a:ext>
             </a:extLst>
           </p:cNvPr>
@@ -8584,7 +8846,7 @@
           <p:cNvPr id="2" name="">
             <a:extLst xmlns:a="http://schemas.openxmlformats.org/drawingml/2006/main">
               <a:ext uri="{FF2B5EF4-FFF2-40B4-BE49-F238E27FC236}">
-                <a16:creationId xmlns:a16="http://schemas.microsoft.com/office/drawing/2014/main" id="{9CB40D5C-5603-4ABE-9546-9B0EE45EF7E4}"/>
+                <a16:creationId xmlns:a16="http://schemas.microsoft.com/office/drawing/2014/main" id="{9F9B99EB-0490-4122-B67B-CFE66C5B87B0}"/>
               </a:ext>
             </a:extLst>
           </p:cNvPr>
@@ -8641,7 +8903,7 @@
           <p:cNvPr id="3" name="">
             <a:extLst xmlns:a="http://schemas.openxmlformats.org/drawingml/2006/main">
               <a:ext uri="{FF2B5EF4-FFF2-40B4-BE49-F238E27FC236}">
-                <a16:creationId xmlns:a16="http://schemas.microsoft.com/office/drawing/2014/main" id="{8F54F162-E2CD-4D41-97B2-48579EDFD205}"/>
+                <a16:creationId xmlns:a16="http://schemas.microsoft.com/office/drawing/2014/main" id="{FFA6EA54-2D3D-44EE-AEA4-64DC643C9E0F}"/>
               </a:ext>
             </a:extLst>
           </p:cNvPr>
@@ -8671,7 +8933,7 @@
           <p:cNvPr id="4" name="">
             <a:extLst xmlns:a="http://schemas.openxmlformats.org/drawingml/2006/main">
               <a:ext uri="{FF2B5EF4-FFF2-40B4-BE49-F238E27FC236}">
-                <a16:creationId xmlns:a16="http://schemas.microsoft.com/office/drawing/2014/main" id="{3754EE50-D5B7-49BB-8A93-36324397E611}"/>
+                <a16:creationId xmlns:a16="http://schemas.microsoft.com/office/drawing/2014/main" id="{E0484149-FA7B-4A7E-A964-DF788392EDBD}"/>
               </a:ext>
             </a:extLst>
           </p:cNvPr>
@@ -8728,7 +8990,7 @@
           <p:cNvPr id="5" name="">
             <a:extLst xmlns:a="http://schemas.openxmlformats.org/drawingml/2006/main">
               <a:ext uri="{FF2B5EF4-FFF2-40B4-BE49-F238E27FC236}">
-                <a16:creationId xmlns:a16="http://schemas.microsoft.com/office/drawing/2014/main" id="{84EE2D07-9C57-4A40-AAAA-EAF03DA26E5F}"/>
+                <a16:creationId xmlns:a16="http://schemas.microsoft.com/office/drawing/2014/main" id="{E4D7FA79-8EF2-480B-B3A2-5F4C18CC03A1}"/>
               </a:ext>
             </a:extLst>
           </p:cNvPr>
@@ -8785,7 +9047,7 @@
           <p:cNvPr id="6" name="">
             <a:extLst xmlns:a="http://schemas.openxmlformats.org/drawingml/2006/main">
               <a:ext uri="{FF2B5EF4-FFF2-40B4-BE49-F238E27FC236}">
-                <a16:creationId xmlns:a16="http://schemas.microsoft.com/office/drawing/2014/main" id="{B8978A5D-DE6D-4108-ADE3-4CF8285EE407}"/>
+                <a16:creationId xmlns:a16="http://schemas.microsoft.com/office/drawing/2014/main" id="{6CCEB68B-912A-4714-8A00-801D3179A5F7}"/>
               </a:ext>
             </a:extLst>
           </p:cNvPr>
@@ -8842,7 +9104,7 @@
           <p:cNvPr id="7" name="">
             <a:extLst xmlns:a="http://schemas.openxmlformats.org/drawingml/2006/main">
               <a:ext uri="{FF2B5EF4-FFF2-40B4-BE49-F238E27FC236}">
-                <a16:creationId xmlns:a16="http://schemas.microsoft.com/office/drawing/2014/main" id="{C9DD8FA0-8E5B-4A42-BE0C-4AC4F06A7B2C}"/>
+                <a16:creationId xmlns:a16="http://schemas.microsoft.com/office/drawing/2014/main" id="{D8E78EA0-9C1A-4B3E-BC30-CB30EAAAE552}"/>
               </a:ext>
             </a:extLst>
           </p:cNvPr>
@@ -8922,7 +9184,7 @@
           <p:cNvPr id="8" name="">
             <a:extLst xmlns:a="http://schemas.openxmlformats.org/drawingml/2006/main">
               <a:ext uri="{FF2B5EF4-FFF2-40B4-BE49-F238E27FC236}">
-                <a16:creationId xmlns:a16="http://schemas.microsoft.com/office/drawing/2014/main" id="{42EAF475-50F3-40BB-8B41-3833C9A5AC41}"/>
+                <a16:creationId xmlns:a16="http://schemas.microsoft.com/office/drawing/2014/main" id="{7051A078-7F98-4A60-B7D7-6A4DDAE70CA7}"/>
               </a:ext>
             </a:extLst>
           </p:cNvPr>
@@ -8952,7 +9214,7 @@
           <p:cNvPr id="9" name="">
             <a:extLst xmlns:a="http://schemas.openxmlformats.org/drawingml/2006/main">
               <a:ext uri="{FF2B5EF4-FFF2-40B4-BE49-F238E27FC236}">
-                <a16:creationId xmlns:a16="http://schemas.microsoft.com/office/drawing/2014/main" id="{E4077367-3CF8-4A46-8FCE-1116FBA8CC9F}"/>
+                <a16:creationId xmlns:a16="http://schemas.microsoft.com/office/drawing/2014/main" id="{2E0299BB-00B5-4712-A3CE-2CBA94B65AEB}"/>
               </a:ext>
             </a:extLst>
           </p:cNvPr>
@@ -9009,7 +9271,7 @@
           <p:cNvPr id="10" name="">
             <a:extLst xmlns:a="http://schemas.openxmlformats.org/drawingml/2006/main">
               <a:ext uri="{FF2B5EF4-FFF2-40B4-BE49-F238E27FC236}">
-                <a16:creationId xmlns:a16="http://schemas.microsoft.com/office/drawing/2014/main" id="{3CB4FA00-DFDC-4BC5-BD00-DF2903E2BEBF}"/>
+                <a16:creationId xmlns:a16="http://schemas.microsoft.com/office/drawing/2014/main" id="{F67807EA-0857-4D6D-A005-510778772E54}"/>
               </a:ext>
             </a:extLst>
           </p:cNvPr>
@@ -9066,7 +9328,7 @@
           <p:cNvPr id="11" name="">
             <a:extLst xmlns:a="http://schemas.openxmlformats.org/drawingml/2006/main">
               <a:ext uri="{FF2B5EF4-FFF2-40B4-BE49-F238E27FC236}">
-                <a16:creationId xmlns:a16="http://schemas.microsoft.com/office/drawing/2014/main" id="{12AE1535-6C9F-400E-84B8-461B6254B8CD}"/>
+                <a16:creationId xmlns:a16="http://schemas.microsoft.com/office/drawing/2014/main" id="{2D65D83E-3E23-433A-A53C-5B8B874F6EEB}"/>
               </a:ext>
             </a:extLst>
           </p:cNvPr>
@@ -9146,7 +9408,7 @@
           <p:cNvPr id="12" name="">
             <a:extLst xmlns:a="http://schemas.openxmlformats.org/drawingml/2006/main">
               <a:ext uri="{FF2B5EF4-FFF2-40B4-BE49-F238E27FC236}">
-                <a16:creationId xmlns:a16="http://schemas.microsoft.com/office/drawing/2014/main" id="{185AF6B5-469A-41F0-AB09-C866AB6359BB}"/>
+                <a16:creationId xmlns:a16="http://schemas.microsoft.com/office/drawing/2014/main" id="{E46766D3-FE94-4B0B-9A57-7D2964264BD5}"/>
               </a:ext>
             </a:extLst>
           </p:cNvPr>
@@ -9176,7 +9438,7 @@
           <p:cNvPr id="13" name="">
             <a:extLst xmlns:a="http://schemas.openxmlformats.org/drawingml/2006/main">
               <a:ext uri="{FF2B5EF4-FFF2-40B4-BE49-F238E27FC236}">
-                <a16:creationId xmlns:a16="http://schemas.microsoft.com/office/drawing/2014/main" id="{EDDEDA41-782C-4CBA-B74E-8D89B6C5B93C}"/>
+                <a16:creationId xmlns:a16="http://schemas.microsoft.com/office/drawing/2014/main" id="{36022420-C516-4005-AC58-27D1613A6ABE}"/>
               </a:ext>
             </a:extLst>
           </p:cNvPr>
@@ -9233,7 +9495,7 @@
           <p:cNvPr id="14" name="">
             <a:extLst xmlns:a="http://schemas.openxmlformats.org/drawingml/2006/main">
               <a:ext uri="{FF2B5EF4-FFF2-40B4-BE49-F238E27FC236}">
-                <a16:creationId xmlns:a16="http://schemas.microsoft.com/office/drawing/2014/main" id="{BBE8195D-8AA0-462D-8AB3-AF933655674E}"/>
+                <a16:creationId xmlns:a16="http://schemas.microsoft.com/office/drawing/2014/main" id="{E761C80C-C06C-4A1D-A09B-FD4DDB7C3429}"/>
               </a:ext>
             </a:extLst>
           </p:cNvPr>
@@ -9290,7 +9552,7 @@
           <p:cNvPr id="15" name="">
             <a:extLst xmlns:a="http://schemas.openxmlformats.org/drawingml/2006/main">
               <a:ext uri="{FF2B5EF4-FFF2-40B4-BE49-F238E27FC236}">
-                <a16:creationId xmlns:a16="http://schemas.microsoft.com/office/drawing/2014/main" id="{DBA98273-D14D-432C-95EC-7D903A1AB518}"/>
+                <a16:creationId xmlns:a16="http://schemas.microsoft.com/office/drawing/2014/main" id="{F4ABB504-149D-4430-91F0-AD7699BEDF54}"/>
               </a:ext>
             </a:extLst>
           </p:cNvPr>
@@ -9370,7 +9632,7 @@
           <p:cNvPr id="16" name="">
             <a:extLst xmlns:a="http://schemas.openxmlformats.org/drawingml/2006/main">
               <a:ext uri="{FF2B5EF4-FFF2-40B4-BE49-F238E27FC236}">
-                <a16:creationId xmlns:a16="http://schemas.microsoft.com/office/drawing/2014/main" id="{3A43EBF4-B71D-436E-B303-E7D6DA252614}"/>
+                <a16:creationId xmlns:a16="http://schemas.microsoft.com/office/drawing/2014/main" id="{D32EAAAF-3D51-440E-82D9-450A699AE041}"/>
               </a:ext>
             </a:extLst>
           </p:cNvPr>
@@ -9427,7 +9689,7 @@
           <p:cNvPr id="17" name="">
             <a:extLst xmlns:a="http://schemas.openxmlformats.org/drawingml/2006/main">
               <a:ext uri="{FF2B5EF4-FFF2-40B4-BE49-F238E27FC236}">
-                <a16:creationId xmlns:a16="http://schemas.microsoft.com/office/drawing/2014/main" id="{069DBFD2-491F-4C63-BACD-2FB48B53FEE4}"/>
+                <a16:creationId xmlns:a16="http://schemas.microsoft.com/office/drawing/2014/main" id="{2746FDCD-35A6-43F2-A831-6C95656D4B05}"/>
               </a:ext>
             </a:extLst>
           </p:cNvPr>
@@ -9484,7 +9746,7 @@
           <p:cNvPr id="18" name="">
             <a:extLst xmlns:a="http://schemas.openxmlformats.org/drawingml/2006/main">
               <a:ext uri="{FF2B5EF4-FFF2-40B4-BE49-F238E27FC236}">
-                <a16:creationId xmlns:a16="http://schemas.microsoft.com/office/drawing/2014/main" id="{8F54E190-2E14-4C81-9FCE-8757D421E0EF}"/>
+                <a16:creationId xmlns:a16="http://schemas.microsoft.com/office/drawing/2014/main" id="{2BB1AD69-1121-4AB7-B0D5-8089F09071C3}"/>
               </a:ext>
             </a:extLst>
           </p:cNvPr>
@@ -9539,7 +9801,7 @@
     </p:spTree>
     <p:extLst>
       <p:ext uri="{BB962C8B-B14F-4D97-AF65-F5344CB8AC3E}">
-        <p14:creationId xmlns:p14="http://schemas.microsoft.com/office/powerpoint/2010/main" val="898003431"/>
+        <p14:creationId xmlns:p14="http://schemas.microsoft.com/office/powerpoint/2010/main" val="1467454721"/>
       </p:ext>
     </p:extLst>
   </p:cSld>
@@ -9570,7 +9832,7 @@
           <p:cNvPr id="18" name="">
             <a:extLst xmlns:a="http://schemas.openxmlformats.org/drawingml/2006/main">
               <a:ext uri="{FF2B5EF4-FFF2-40B4-BE49-F238E27FC236}">
-                <a16:creationId xmlns:a16="http://schemas.microsoft.com/office/drawing/2014/main" id="{61EB2A08-789A-4CD8-887E-E292E49C371A}"/>
+                <a16:creationId xmlns:a16="http://schemas.microsoft.com/office/drawing/2014/main" id="{C23E73B6-DF69-4ED3-BE87-427B3A3E9642}"/>
               </a:ext>
             </a:extLst>
           </p:cNvPr>
@@ -9600,7 +9862,7 @@
           <p:cNvPr id="2" name="">
             <a:extLst xmlns:a="http://schemas.openxmlformats.org/drawingml/2006/main">
               <a:ext uri="{FF2B5EF4-FFF2-40B4-BE49-F238E27FC236}">
-                <a16:creationId xmlns:a16="http://schemas.microsoft.com/office/drawing/2014/main" id="{FBAF1A0F-1F2D-45A7-B02D-ABFAB7824645}"/>
+                <a16:creationId xmlns:a16="http://schemas.microsoft.com/office/drawing/2014/main" id="{FA2579AB-85F9-4594-9636-C0572C57AB8F}"/>
               </a:ext>
             </a:extLst>
           </p:cNvPr>
@@ -9657,7 +9919,7 @@
           <p:cNvPr id="3" name="">
             <a:extLst xmlns:a="http://schemas.openxmlformats.org/drawingml/2006/main">
               <a:ext uri="{FF2B5EF4-FFF2-40B4-BE49-F238E27FC236}">
-                <a16:creationId xmlns:a16="http://schemas.microsoft.com/office/drawing/2014/main" id="{4D467329-523F-422B-8705-F95930D9CB72}"/>
+                <a16:creationId xmlns:a16="http://schemas.microsoft.com/office/drawing/2014/main" id="{A9EF6490-5A73-47F5-972C-B65153D72012}"/>
               </a:ext>
             </a:extLst>
           </p:cNvPr>
@@ -9687,7 +9949,7 @@
           <p:cNvPr id="4" name="">
             <a:extLst xmlns:a="http://schemas.openxmlformats.org/drawingml/2006/main">
               <a:ext uri="{FF2B5EF4-FFF2-40B4-BE49-F238E27FC236}">
-                <a16:creationId xmlns:a16="http://schemas.microsoft.com/office/drawing/2014/main" id="{A4FE1588-DA51-4416-A9FD-BDE376776CD6}"/>
+                <a16:creationId xmlns:a16="http://schemas.microsoft.com/office/drawing/2014/main" id="{A04800F3-0980-4933-ACF8-4D03E07CB000}"/>
               </a:ext>
             </a:extLst>
           </p:cNvPr>
@@ -9744,7 +10006,7 @@
           <p:cNvPr id="5" name="">
             <a:extLst xmlns:a="http://schemas.openxmlformats.org/drawingml/2006/main">
               <a:ext uri="{FF2B5EF4-FFF2-40B4-BE49-F238E27FC236}">
-                <a16:creationId xmlns:a16="http://schemas.microsoft.com/office/drawing/2014/main" id="{4AC01B0C-6316-4971-BDB2-FDDA58B1CEE4}"/>
+                <a16:creationId xmlns:a16="http://schemas.microsoft.com/office/drawing/2014/main" id="{5A4B0EEA-B0BA-4CD6-B8FF-8AFA18455707}"/>
               </a:ext>
             </a:extLst>
           </p:cNvPr>
@@ -9774,7 +10036,7 @@
           <p:cNvPr id="6" name="">
             <a:extLst xmlns:a="http://schemas.openxmlformats.org/drawingml/2006/main">
               <a:ext uri="{FF2B5EF4-FFF2-40B4-BE49-F238E27FC236}">
-                <a16:creationId xmlns:a16="http://schemas.microsoft.com/office/drawing/2014/main" id="{66B9F1B1-7CB1-43C6-8D14-8DD6F04005DF}"/>
+                <a16:creationId xmlns:a16="http://schemas.microsoft.com/office/drawing/2014/main" id="{705A9AD0-ABDA-4B9C-BA93-2DC0F5C85646}"/>
               </a:ext>
             </a:extLst>
           </p:cNvPr>
@@ -9831,7 +10093,7 @@
           <p:cNvPr id="7" name="">
             <a:extLst xmlns:a="http://schemas.openxmlformats.org/drawingml/2006/main">
               <a:ext uri="{FF2B5EF4-FFF2-40B4-BE49-F238E27FC236}">
-                <a16:creationId xmlns:a16="http://schemas.microsoft.com/office/drawing/2014/main" id="{0F92698D-D858-45D6-82E5-87D3C890D5F3}"/>
+                <a16:creationId xmlns:a16="http://schemas.microsoft.com/office/drawing/2014/main" id="{B3D048D9-D541-4797-8D25-E32862B7C11A}"/>
               </a:ext>
             </a:extLst>
           </p:cNvPr>
@@ -9911,7 +10173,7 @@
           <p:cNvPr id="8" name="">
             <a:extLst xmlns:a="http://schemas.openxmlformats.org/drawingml/2006/main">
               <a:ext uri="{FF2B5EF4-FFF2-40B4-BE49-F238E27FC236}">
-                <a16:creationId xmlns:a16="http://schemas.microsoft.com/office/drawing/2014/main" id="{B114325A-5411-4C31-8653-27FB089B9E05}"/>
+                <a16:creationId xmlns:a16="http://schemas.microsoft.com/office/drawing/2014/main" id="{76BB8D93-08AC-47FA-8F5F-25F3275A2662}"/>
               </a:ext>
             </a:extLst>
           </p:cNvPr>
@@ -9941,7 +10203,7 @@
           <p:cNvPr id="9" name="">
             <a:extLst xmlns:a="http://schemas.openxmlformats.org/drawingml/2006/main">
               <a:ext uri="{FF2B5EF4-FFF2-40B4-BE49-F238E27FC236}">
-                <a16:creationId xmlns:a16="http://schemas.microsoft.com/office/drawing/2014/main" id="{685E7358-FCFE-4B0C-B07B-4A9C2FCD5F90}"/>
+                <a16:creationId xmlns:a16="http://schemas.microsoft.com/office/drawing/2014/main" id="{DC32D34A-6858-455F-B516-522616877EC4}"/>
               </a:ext>
             </a:extLst>
           </p:cNvPr>
@@ -9998,7 +10260,7 @@
           <p:cNvPr id="10" name="">
             <a:extLst xmlns:a="http://schemas.openxmlformats.org/drawingml/2006/main">
               <a:ext uri="{FF2B5EF4-FFF2-40B4-BE49-F238E27FC236}">
-                <a16:creationId xmlns:a16="http://schemas.microsoft.com/office/drawing/2014/main" id="{E6CE245C-51CA-4986-B09C-4F8DB2908E2F}"/>
+                <a16:creationId xmlns:a16="http://schemas.microsoft.com/office/drawing/2014/main" id="{AF0DD99D-A94A-42FA-9E93-31D847BED536}"/>
               </a:ext>
             </a:extLst>
           </p:cNvPr>
@@ -10078,7 +10340,7 @@
           <p:cNvPr id="11" name="">
             <a:extLst xmlns:a="http://schemas.openxmlformats.org/drawingml/2006/main">
               <a:ext uri="{FF2B5EF4-FFF2-40B4-BE49-F238E27FC236}">
-                <a16:creationId xmlns:a16="http://schemas.microsoft.com/office/drawing/2014/main" id="{B69F4D15-CF52-4784-A08C-9D8DFDAA062E}"/>
+                <a16:creationId xmlns:a16="http://schemas.microsoft.com/office/drawing/2014/main" id="{D208321C-8DD1-4501-9698-D9234531827C}"/>
               </a:ext>
             </a:extLst>
           </p:cNvPr>
@@ -10108,7 +10370,7 @@
           <p:cNvPr id="12" name="">
             <a:extLst xmlns:a="http://schemas.openxmlformats.org/drawingml/2006/main">
               <a:ext uri="{FF2B5EF4-FFF2-40B4-BE49-F238E27FC236}">
-                <a16:creationId xmlns:a16="http://schemas.microsoft.com/office/drawing/2014/main" id="{6FE62ACB-7599-42A5-9050-2F517E6B9571}"/>
+                <a16:creationId xmlns:a16="http://schemas.microsoft.com/office/drawing/2014/main" id="{52C023AC-6DAC-4BFA-8368-E8967EA8E863}"/>
               </a:ext>
             </a:extLst>
           </p:cNvPr>
@@ -10165,7 +10427,7 @@
           <p:cNvPr id="13" name="">
             <a:extLst xmlns:a="http://schemas.openxmlformats.org/drawingml/2006/main">
               <a:ext uri="{FF2B5EF4-FFF2-40B4-BE49-F238E27FC236}">
-                <a16:creationId xmlns:a16="http://schemas.microsoft.com/office/drawing/2014/main" id="{9A600869-8F3A-4A62-9287-01165A439B46}"/>
+                <a16:creationId xmlns:a16="http://schemas.microsoft.com/office/drawing/2014/main" id="{A223634C-E262-4277-AD4D-309B7B53FABC}"/>
               </a:ext>
             </a:extLst>
           </p:cNvPr>
@@ -10245,7 +10507,7 @@
           <p:cNvPr id="14" name="">
             <a:extLst xmlns:a="http://schemas.openxmlformats.org/drawingml/2006/main">
               <a:ext uri="{FF2B5EF4-FFF2-40B4-BE49-F238E27FC236}">
-                <a16:creationId xmlns:a16="http://schemas.microsoft.com/office/drawing/2014/main" id="{9DF74343-4A0B-4C82-BAAA-5B5E4C23F091}"/>
+                <a16:creationId xmlns:a16="http://schemas.microsoft.com/office/drawing/2014/main" id="{1E53219A-F79E-428D-8607-1471A1702EE4}"/>
               </a:ext>
             </a:extLst>
           </p:cNvPr>
@@ -10275,7 +10537,7 @@
           <p:cNvPr id="15" name="">
             <a:extLst xmlns:a="http://schemas.openxmlformats.org/drawingml/2006/main">
               <a:ext uri="{FF2B5EF4-FFF2-40B4-BE49-F238E27FC236}">
-                <a16:creationId xmlns:a16="http://schemas.microsoft.com/office/drawing/2014/main" id="{A39F6F41-B4BA-4F81-AF4A-1BBDB4D79556}"/>
+                <a16:creationId xmlns:a16="http://schemas.microsoft.com/office/drawing/2014/main" id="{BFCC9ABE-B741-45E0-A88B-FB7D88AA70BE}"/>
               </a:ext>
             </a:extLst>
           </p:cNvPr>
@@ -10332,7 +10594,7 @@
           <p:cNvPr id="16" name="">
             <a:extLst xmlns:a="http://schemas.openxmlformats.org/drawingml/2006/main">
               <a:ext uri="{FF2B5EF4-FFF2-40B4-BE49-F238E27FC236}">
-                <a16:creationId xmlns:a16="http://schemas.microsoft.com/office/drawing/2014/main" id="{6AD9FD49-2B6F-4437-B8C6-AE17381C7F69}"/>
+                <a16:creationId xmlns:a16="http://schemas.microsoft.com/office/drawing/2014/main" id="{630076FB-EE1F-419E-8B5D-8169F537D399}"/>
               </a:ext>
             </a:extLst>
           </p:cNvPr>
@@ -10412,7 +10674,7 @@
           <p:cNvPr id="17" name="">
             <a:extLst xmlns:a="http://schemas.openxmlformats.org/drawingml/2006/main">
               <a:ext uri="{FF2B5EF4-FFF2-40B4-BE49-F238E27FC236}">
-                <a16:creationId xmlns:a16="http://schemas.microsoft.com/office/drawing/2014/main" id="{A8833B53-EAB4-46C7-AD2C-8E0FF864F205}"/>
+                <a16:creationId xmlns:a16="http://schemas.microsoft.com/office/drawing/2014/main" id="{095BBFAA-4D24-485F-A321-F4CD817081A4}"/>
               </a:ext>
             </a:extLst>
           </p:cNvPr>
@@ -10467,7 +10729,7 @@
     </p:spTree>
     <p:extLst>
       <p:ext uri="{BB962C8B-B14F-4D97-AF65-F5344CB8AC3E}">
-        <p14:creationId xmlns:p14="http://schemas.microsoft.com/office/powerpoint/2010/main" val="942446179"/>
+        <p14:creationId xmlns:p14="http://schemas.microsoft.com/office/powerpoint/2010/main" val="2019158915"/>
       </p:ext>
     </p:extLst>
   </p:cSld>
@@ -10498,7 +10760,7 @@
           <p:cNvPr id="30" name="">
             <a:extLst xmlns:a="http://schemas.openxmlformats.org/drawingml/2006/main">
               <a:ext uri="{FF2B5EF4-FFF2-40B4-BE49-F238E27FC236}">
-                <a16:creationId xmlns:a16="http://schemas.microsoft.com/office/drawing/2014/main" id="{001B4A75-301D-4F89-93D3-66693CF87F76}"/>
+                <a16:creationId xmlns:a16="http://schemas.microsoft.com/office/drawing/2014/main" id="{66891B42-12F1-48DB-8764-8740054E6471}"/>
               </a:ext>
             </a:extLst>
           </p:cNvPr>
@@ -10528,7 +10790,7 @@
           <p:cNvPr id="2" name="">
             <a:extLst xmlns:a="http://schemas.openxmlformats.org/drawingml/2006/main">
               <a:ext uri="{FF2B5EF4-FFF2-40B4-BE49-F238E27FC236}">
-                <a16:creationId xmlns:a16="http://schemas.microsoft.com/office/drawing/2014/main" id="{00F26CE0-85C5-4EF4-A069-DAF71DBEF62F}"/>
+                <a16:creationId xmlns:a16="http://schemas.microsoft.com/office/drawing/2014/main" id="{78ECB73E-BF0A-4637-9D8F-FDBDC20F3507}"/>
               </a:ext>
             </a:extLst>
           </p:cNvPr>
@@ -10585,7 +10847,7 @@
           <p:cNvPr id="3" name="">
             <a:extLst xmlns:a="http://schemas.openxmlformats.org/drawingml/2006/main">
               <a:ext uri="{FF2B5EF4-FFF2-40B4-BE49-F238E27FC236}">
-                <a16:creationId xmlns:a16="http://schemas.microsoft.com/office/drawing/2014/main" id="{6BC7DE7D-11F5-41F1-829D-BA8B54A52B82}"/>
+                <a16:creationId xmlns:a16="http://schemas.microsoft.com/office/drawing/2014/main" id="{B0A9F970-5490-4ECC-8098-86CF96300582}"/>
               </a:ext>
             </a:extLst>
           </p:cNvPr>
@@ -10615,7 +10877,7 @@
           <p:cNvPr id="4" name="">
             <a:extLst xmlns:a="http://schemas.openxmlformats.org/drawingml/2006/main">
               <a:ext uri="{FF2B5EF4-FFF2-40B4-BE49-F238E27FC236}">
-                <a16:creationId xmlns:a16="http://schemas.microsoft.com/office/drawing/2014/main" id="{1F7FA61D-CB29-4F3A-B89A-7EEE2A9893E1}"/>
+                <a16:creationId xmlns:a16="http://schemas.microsoft.com/office/drawing/2014/main" id="{617BC351-568E-4BB6-9B9F-169F439C9B78}"/>
               </a:ext>
             </a:extLst>
           </p:cNvPr>
@@ -10672,7 +10934,7 @@
           <p:cNvPr id="5" name="">
             <a:extLst xmlns:a="http://schemas.openxmlformats.org/drawingml/2006/main">
               <a:ext uri="{FF2B5EF4-FFF2-40B4-BE49-F238E27FC236}">
-                <a16:creationId xmlns:a16="http://schemas.microsoft.com/office/drawing/2014/main" id="{CFFEC3EA-4A5A-4D41-A666-D88E25F48416}"/>
+                <a16:creationId xmlns:a16="http://schemas.microsoft.com/office/drawing/2014/main" id="{21CB5D8A-8EE4-4657-8EC9-1CAF499AA0EF}"/>
               </a:ext>
             </a:extLst>
           </p:cNvPr>
@@ -10704,7 +10966,7 @@
           <p:cNvPr id="6" name="">
             <a:extLst xmlns:a="http://schemas.openxmlformats.org/drawingml/2006/main">
               <a:ext uri="{FF2B5EF4-FFF2-40B4-BE49-F238E27FC236}">
-                <a16:creationId xmlns:a16="http://schemas.microsoft.com/office/drawing/2014/main" id="{217F3091-B039-4ECC-B2F2-C5C8CCFF9945}"/>
+                <a16:creationId xmlns:a16="http://schemas.microsoft.com/office/drawing/2014/main" id="{93223D4D-474C-4A68-A647-E0D05512F939}"/>
               </a:ext>
             </a:extLst>
           </p:cNvPr>
@@ -10761,7 +11023,7 @@
           <p:cNvPr id="7" name="">
             <a:extLst xmlns:a="http://schemas.openxmlformats.org/drawingml/2006/main">
               <a:ext uri="{FF2B5EF4-FFF2-40B4-BE49-F238E27FC236}">
-                <a16:creationId xmlns:a16="http://schemas.microsoft.com/office/drawing/2014/main" id="{C79EBD88-20D2-46A8-AB51-48CF00E3A57F}"/>
+                <a16:creationId xmlns:a16="http://schemas.microsoft.com/office/drawing/2014/main" id="{062C5E53-32E8-40D8-A854-5C22DF59AC3E}"/>
               </a:ext>
             </a:extLst>
           </p:cNvPr>
@@ -10818,7 +11080,7 @@
           <p:cNvPr id="8" name="">
             <a:extLst xmlns:a="http://schemas.openxmlformats.org/drawingml/2006/main">
               <a:ext uri="{FF2B5EF4-FFF2-40B4-BE49-F238E27FC236}">
-                <a16:creationId xmlns:a16="http://schemas.microsoft.com/office/drawing/2014/main" id="{AB8E0DC1-898F-4F54-8C03-13BB42E1369E}"/>
+                <a16:creationId xmlns:a16="http://schemas.microsoft.com/office/drawing/2014/main" id="{F32A100D-2BF1-4654-8CF6-76C0C442E53F}"/>
               </a:ext>
             </a:extLst>
           </p:cNvPr>
@@ -10898,7 +11160,7 @@
           <p:cNvPr id="9" name="">
             <a:extLst xmlns:a="http://schemas.openxmlformats.org/drawingml/2006/main">
               <a:ext uri="{FF2B5EF4-FFF2-40B4-BE49-F238E27FC236}">
-                <a16:creationId xmlns:a16="http://schemas.microsoft.com/office/drawing/2014/main" id="{53AAF0FC-C67A-4C76-B851-F2D7C1412A06}"/>
+                <a16:creationId xmlns:a16="http://schemas.microsoft.com/office/drawing/2014/main" id="{F15A5305-B942-4865-9F26-CA400E92E0EB}"/>
               </a:ext>
             </a:extLst>
           </p:cNvPr>
@@ -10955,7 +11217,7 @@
           <p:cNvPr id="10" name="">
             <a:extLst xmlns:a="http://schemas.openxmlformats.org/drawingml/2006/main">
               <a:ext uri="{FF2B5EF4-FFF2-40B4-BE49-F238E27FC236}">
-                <a16:creationId xmlns:a16="http://schemas.microsoft.com/office/drawing/2014/main" id="{71DBCA38-08D6-4672-9167-9864EAB98F0C}"/>
+                <a16:creationId xmlns:a16="http://schemas.microsoft.com/office/drawing/2014/main" id="{17C8FC9A-BFC7-4562-BB82-327EDF1A98FE}"/>
               </a:ext>
             </a:extLst>
           </p:cNvPr>
@@ -10987,7 +11249,7 @@
           <p:cNvPr id="11" name="">
             <a:extLst xmlns:a="http://schemas.openxmlformats.org/drawingml/2006/main">
               <a:ext uri="{FF2B5EF4-FFF2-40B4-BE49-F238E27FC236}">
-                <a16:creationId xmlns:a16="http://schemas.microsoft.com/office/drawing/2014/main" id="{ECAA039D-AF22-403D-AE6B-340E31F9A1B1}"/>
+                <a16:creationId xmlns:a16="http://schemas.microsoft.com/office/drawing/2014/main" id="{D2540578-3DBB-44AF-8E5D-1BA1DB5F35C8}"/>
               </a:ext>
             </a:extLst>
           </p:cNvPr>
@@ -11044,7 +11306,7 @@
           <p:cNvPr id="12" name="">
             <a:extLst xmlns:a="http://schemas.openxmlformats.org/drawingml/2006/main">
               <a:ext uri="{FF2B5EF4-FFF2-40B4-BE49-F238E27FC236}">
-                <a16:creationId xmlns:a16="http://schemas.microsoft.com/office/drawing/2014/main" id="{8A2F7A83-1105-4944-9D26-15B77D91AC9E}"/>
+                <a16:creationId xmlns:a16="http://schemas.microsoft.com/office/drawing/2014/main" id="{1B08F686-3556-4318-81F0-8C59946FDB6E}"/>
               </a:ext>
             </a:extLst>
           </p:cNvPr>
@@ -11101,7 +11363,7 @@
           <p:cNvPr id="13" name="">
             <a:extLst xmlns:a="http://schemas.openxmlformats.org/drawingml/2006/main">
               <a:ext uri="{FF2B5EF4-FFF2-40B4-BE49-F238E27FC236}">
-                <a16:creationId xmlns:a16="http://schemas.microsoft.com/office/drawing/2014/main" id="{84E3B9F8-0061-4BC6-A7A9-491A3DD9734A}"/>
+                <a16:creationId xmlns:a16="http://schemas.microsoft.com/office/drawing/2014/main" id="{49380B68-480F-4D14-8321-27546C3C3A90}"/>
               </a:ext>
             </a:extLst>
           </p:cNvPr>
@@ -11181,7 +11443,7 @@
           <p:cNvPr id="14" name="">
             <a:extLst xmlns:a="http://schemas.openxmlformats.org/drawingml/2006/main">
               <a:ext uri="{FF2B5EF4-FFF2-40B4-BE49-F238E27FC236}">
-                <a16:creationId xmlns:a16="http://schemas.microsoft.com/office/drawing/2014/main" id="{DD537413-42FD-468C-915E-612BE7BCFF67}"/>
+                <a16:creationId xmlns:a16="http://schemas.microsoft.com/office/drawing/2014/main" id="{2C1A5386-2474-46B1-8717-842458C4B96C}"/>
               </a:ext>
             </a:extLst>
           </p:cNvPr>
@@ -11238,7 +11500,7 @@
           <p:cNvPr id="15" name="">
             <a:extLst xmlns:a="http://schemas.openxmlformats.org/drawingml/2006/main">
               <a:ext uri="{FF2B5EF4-FFF2-40B4-BE49-F238E27FC236}">
-                <a16:creationId xmlns:a16="http://schemas.microsoft.com/office/drawing/2014/main" id="{CF4E0442-2B7B-4D87-9D3D-900A2A633CB6}"/>
+                <a16:creationId xmlns:a16="http://schemas.microsoft.com/office/drawing/2014/main" id="{0512B442-9EA7-4786-9A49-349A14F291D9}"/>
               </a:ext>
             </a:extLst>
           </p:cNvPr>
@@ -11270,7 +11532,7 @@
           <p:cNvPr id="16" name="">
             <a:extLst xmlns:a="http://schemas.openxmlformats.org/drawingml/2006/main">
               <a:ext uri="{FF2B5EF4-FFF2-40B4-BE49-F238E27FC236}">
-                <a16:creationId xmlns:a16="http://schemas.microsoft.com/office/drawing/2014/main" id="{D6B87A2C-CCD8-43CE-B190-EE0F6F4BA9A1}"/>
+                <a16:creationId xmlns:a16="http://schemas.microsoft.com/office/drawing/2014/main" id="{E486A962-AC9F-4711-BDEB-3C1AA1CF4E7B}"/>
               </a:ext>
             </a:extLst>
           </p:cNvPr>
@@ -11327,7 +11589,7 @@
           <p:cNvPr id="17" name="">
             <a:extLst xmlns:a="http://schemas.openxmlformats.org/drawingml/2006/main">
               <a:ext uri="{FF2B5EF4-FFF2-40B4-BE49-F238E27FC236}">
-                <a16:creationId xmlns:a16="http://schemas.microsoft.com/office/drawing/2014/main" id="{69FB45C9-FAFE-422E-88AD-462C51DFEC01}"/>
+                <a16:creationId xmlns:a16="http://schemas.microsoft.com/office/drawing/2014/main" id="{B359265B-DDF2-44FC-80BF-F3442C00101F}"/>
               </a:ext>
             </a:extLst>
           </p:cNvPr>
@@ -11384,7 +11646,7 @@
           <p:cNvPr id="18" name="">
             <a:extLst xmlns:a="http://schemas.openxmlformats.org/drawingml/2006/main">
               <a:ext uri="{FF2B5EF4-FFF2-40B4-BE49-F238E27FC236}">
-                <a16:creationId xmlns:a16="http://schemas.microsoft.com/office/drawing/2014/main" id="{CAA54260-86DB-467C-96F5-1DBB45CFBC85}"/>
+                <a16:creationId xmlns:a16="http://schemas.microsoft.com/office/drawing/2014/main" id="{14BAEA36-5D9B-4600-B134-ABEE2841A6AC}"/>
               </a:ext>
             </a:extLst>
           </p:cNvPr>
@@ -11464,7 +11726,7 @@
           <p:cNvPr id="19" name="">
             <a:extLst xmlns:a="http://schemas.openxmlformats.org/drawingml/2006/main">
               <a:ext uri="{FF2B5EF4-FFF2-40B4-BE49-F238E27FC236}">
-                <a16:creationId xmlns:a16="http://schemas.microsoft.com/office/drawing/2014/main" id="{DD376FDE-97EC-4A3C-BF06-0CBD3C7D5F1B}"/>
+                <a16:creationId xmlns:a16="http://schemas.microsoft.com/office/drawing/2014/main" id="{83374031-8083-4F14-82DC-BB4FF4903F2F}"/>
               </a:ext>
             </a:extLst>
           </p:cNvPr>
@@ -11521,7 +11783,7 @@
           <p:cNvPr id="20" name="">
             <a:extLst xmlns:a="http://schemas.openxmlformats.org/drawingml/2006/main">
               <a:ext uri="{FF2B5EF4-FFF2-40B4-BE49-F238E27FC236}">
-                <a16:creationId xmlns:a16="http://schemas.microsoft.com/office/drawing/2014/main" id="{5062E0BB-DAD2-425D-A065-A9EA8946E5C0}"/>
+                <a16:creationId xmlns:a16="http://schemas.microsoft.com/office/drawing/2014/main" id="{FE965F7D-B000-4196-AED1-3FC2D8520262}"/>
               </a:ext>
             </a:extLst>
           </p:cNvPr>
@@ -11553,7 +11815,7 @@
           <p:cNvPr id="21" name="">
             <a:extLst xmlns:a="http://schemas.openxmlformats.org/drawingml/2006/main">
               <a:ext uri="{FF2B5EF4-FFF2-40B4-BE49-F238E27FC236}">
-                <a16:creationId xmlns:a16="http://schemas.microsoft.com/office/drawing/2014/main" id="{FB431843-C587-444F-BF44-4BF7E1D705C8}"/>
+                <a16:creationId xmlns:a16="http://schemas.microsoft.com/office/drawing/2014/main" id="{9D73BFFC-DBB4-4B8A-83B4-787600E8D1DC}"/>
               </a:ext>
             </a:extLst>
           </p:cNvPr>
@@ -11610,7 +11872,7 @@
           <p:cNvPr id="22" name="">
             <a:extLst xmlns:a="http://schemas.openxmlformats.org/drawingml/2006/main">
               <a:ext uri="{FF2B5EF4-FFF2-40B4-BE49-F238E27FC236}">
-                <a16:creationId xmlns:a16="http://schemas.microsoft.com/office/drawing/2014/main" id="{9FC1F125-4C03-4C2A-93EC-C19F5EE7DC1E}"/>
+                <a16:creationId xmlns:a16="http://schemas.microsoft.com/office/drawing/2014/main" id="{D0AA117B-5338-4A98-A184-4A9A7040A398}"/>
               </a:ext>
             </a:extLst>
           </p:cNvPr>
@@ -11667,7 +11929,7 @@
           <p:cNvPr id="23" name="">
             <a:extLst xmlns:a="http://schemas.openxmlformats.org/drawingml/2006/main">
               <a:ext uri="{FF2B5EF4-FFF2-40B4-BE49-F238E27FC236}">
-                <a16:creationId xmlns:a16="http://schemas.microsoft.com/office/drawing/2014/main" id="{205E74E1-EAD7-42F6-88EA-C715998B3019}"/>
+                <a16:creationId xmlns:a16="http://schemas.microsoft.com/office/drawing/2014/main" id="{1604AF88-D7A5-49E2-B899-E4027606F773}"/>
               </a:ext>
             </a:extLst>
           </p:cNvPr>
@@ -11747,7 +12009,7 @@
           <p:cNvPr id="24" name="">
             <a:extLst xmlns:a="http://schemas.openxmlformats.org/drawingml/2006/main">
               <a:ext uri="{FF2B5EF4-FFF2-40B4-BE49-F238E27FC236}">
-                <a16:creationId xmlns:a16="http://schemas.microsoft.com/office/drawing/2014/main" id="{F163496D-5C03-4BB1-839A-1DC59B56F85E}"/>
+                <a16:creationId xmlns:a16="http://schemas.microsoft.com/office/drawing/2014/main" id="{C1863AF7-882D-416E-B844-6819DE958DAF}"/>
               </a:ext>
             </a:extLst>
           </p:cNvPr>
@@ -11804,7 +12066,7 @@
           <p:cNvPr id="25" name="">
             <a:extLst xmlns:a="http://schemas.openxmlformats.org/drawingml/2006/main">
               <a:ext uri="{FF2B5EF4-FFF2-40B4-BE49-F238E27FC236}">
-                <a16:creationId xmlns:a16="http://schemas.microsoft.com/office/drawing/2014/main" id="{6EABA65E-2933-4B0F-B2A2-7B565005750D}"/>
+                <a16:creationId xmlns:a16="http://schemas.microsoft.com/office/drawing/2014/main" id="{C7D241A1-AAF9-453D-9149-A18A9C286B31}"/>
               </a:ext>
             </a:extLst>
           </p:cNvPr>
@@ -11834,7 +12096,7 @@
           <p:cNvPr id="26" name="">
             <a:extLst xmlns:a="http://schemas.openxmlformats.org/drawingml/2006/main">
               <a:ext uri="{FF2B5EF4-FFF2-40B4-BE49-F238E27FC236}">
-                <a16:creationId xmlns:a16="http://schemas.microsoft.com/office/drawing/2014/main" id="{4BBE15CE-965B-4499-8CD8-3BD9AFAD757A}"/>
+                <a16:creationId xmlns:a16="http://schemas.microsoft.com/office/drawing/2014/main" id="{2FB4F76B-2096-4B37-9FB7-AC7801DE2CB0}"/>
               </a:ext>
             </a:extLst>
           </p:cNvPr>
@@ -11891,7 +12153,7 @@
           <p:cNvPr id="27" name="">
             <a:extLst xmlns:a="http://schemas.openxmlformats.org/drawingml/2006/main">
               <a:ext uri="{FF2B5EF4-FFF2-40B4-BE49-F238E27FC236}">
-                <a16:creationId xmlns:a16="http://schemas.microsoft.com/office/drawing/2014/main" id="{882052C6-E54A-4DA1-960D-1A7EF3FA4E3C}"/>
+                <a16:creationId xmlns:a16="http://schemas.microsoft.com/office/drawing/2014/main" id="{7B16C8DF-13D0-4619-9D58-E9F7A3D2D22F}"/>
               </a:ext>
             </a:extLst>
           </p:cNvPr>
@@ -11948,7 +12210,7 @@
           <p:cNvPr id="28" name="">
             <a:extLst xmlns:a="http://schemas.openxmlformats.org/drawingml/2006/main">
               <a:ext uri="{FF2B5EF4-FFF2-40B4-BE49-F238E27FC236}">
-                <a16:creationId xmlns:a16="http://schemas.microsoft.com/office/drawing/2014/main" id="{1898DB74-16D5-4E80-B9BC-071D670CCE14}"/>
+                <a16:creationId xmlns:a16="http://schemas.microsoft.com/office/drawing/2014/main" id="{E2941882-ECB4-49A6-B45E-5CD0A0409804}"/>
               </a:ext>
             </a:extLst>
           </p:cNvPr>
@@ -12028,7 +12290,7 @@
           <p:cNvPr id="29" name="">
             <a:extLst xmlns:a="http://schemas.openxmlformats.org/drawingml/2006/main">
               <a:ext uri="{FF2B5EF4-FFF2-40B4-BE49-F238E27FC236}">
-                <a16:creationId xmlns:a16="http://schemas.microsoft.com/office/drawing/2014/main" id="{5E1BE5DD-0DB9-48A2-A26C-459153C14FDE}"/>
+                <a16:creationId xmlns:a16="http://schemas.microsoft.com/office/drawing/2014/main" id="{90DAF911-51FA-441B-BFBD-C4C639330040}"/>
               </a:ext>
             </a:extLst>
           </p:cNvPr>
@@ -12083,7 +12345,7 @@
     </p:spTree>
     <p:extLst>
       <p:ext uri="{BB962C8B-B14F-4D97-AF65-F5344CB8AC3E}">
-        <p14:creationId xmlns:p14="http://schemas.microsoft.com/office/powerpoint/2010/main" val="1280103811"/>
+        <p14:creationId xmlns:p14="http://schemas.microsoft.com/office/powerpoint/2010/main" val="971713325"/>
       </p:ext>
     </p:extLst>
   </p:cSld>
@@ -12114,7 +12376,7 @@
           <p:cNvPr id="12" name="">
             <a:extLst xmlns:a="http://schemas.openxmlformats.org/drawingml/2006/main">
               <a:ext uri="{FF2B5EF4-FFF2-40B4-BE49-F238E27FC236}">
-                <a16:creationId xmlns:a16="http://schemas.microsoft.com/office/drawing/2014/main" id="{19639C42-72D4-419D-8FE1-83A487428E26}"/>
+                <a16:creationId xmlns:a16="http://schemas.microsoft.com/office/drawing/2014/main" id="{43E4F63B-DB51-4CC3-93E4-12BA1537F8B8}"/>
               </a:ext>
             </a:extLst>
           </p:cNvPr>
@@ -12144,7 +12406,7 @@
           <p:cNvPr id="2" name="">
             <a:extLst xmlns:a="http://schemas.openxmlformats.org/drawingml/2006/main">
               <a:ext uri="{FF2B5EF4-FFF2-40B4-BE49-F238E27FC236}">
-                <a16:creationId xmlns:a16="http://schemas.microsoft.com/office/drawing/2014/main" id="{B8FDA68D-023C-4E4E-9334-E729EDF47A3C}"/>
+                <a16:creationId xmlns:a16="http://schemas.microsoft.com/office/drawing/2014/main" id="{190B5F92-1593-4348-BCD7-715CAC727CF5}"/>
               </a:ext>
             </a:extLst>
           </p:cNvPr>
@@ -12201,7 +12463,7 @@
           <p:cNvPr id="3" name="">
             <a:extLst xmlns:a="http://schemas.openxmlformats.org/drawingml/2006/main">
               <a:ext uri="{FF2B5EF4-FFF2-40B4-BE49-F238E27FC236}">
-                <a16:creationId xmlns:a16="http://schemas.microsoft.com/office/drawing/2014/main" id="{89F64D38-2DF0-489C-BE7C-CDF81AD9FB17}"/>
+                <a16:creationId xmlns:a16="http://schemas.microsoft.com/office/drawing/2014/main" id="{ABA9FC49-0BB4-4433-8EA6-DF84109B0863}"/>
               </a:ext>
             </a:extLst>
           </p:cNvPr>
@@ -12231,7 +12493,7 @@
           <p:cNvPr id="4" name="">
             <a:extLst xmlns:a="http://schemas.openxmlformats.org/drawingml/2006/main">
               <a:ext uri="{FF2B5EF4-FFF2-40B4-BE49-F238E27FC236}">
-                <a16:creationId xmlns:a16="http://schemas.microsoft.com/office/drawing/2014/main" id="{4E07301B-F973-4C47-B182-ECF68F43E1A1}"/>
+                <a16:creationId xmlns:a16="http://schemas.microsoft.com/office/drawing/2014/main" id="{8E098CEE-3FE0-4FF0-B063-72C5BB3D586E}"/>
               </a:ext>
             </a:extLst>
           </p:cNvPr>
@@ -12288,7 +12550,7 @@
           <p:cNvPr id="5" name="">
             <a:extLst xmlns:a="http://schemas.openxmlformats.org/drawingml/2006/main">
               <a:ext uri="{FF2B5EF4-FFF2-40B4-BE49-F238E27FC236}">
-                <a16:creationId xmlns:a16="http://schemas.microsoft.com/office/drawing/2014/main" id="{839E3EC9-CAE0-4ADD-9BE4-5092A2FC730F}"/>
+                <a16:creationId xmlns:a16="http://schemas.microsoft.com/office/drawing/2014/main" id="{9206223B-66D4-4258-9364-F25F76FBCBD6}"/>
               </a:ext>
             </a:extLst>
           </p:cNvPr>
@@ -12320,7 +12582,7 @@
           <p:cNvPr id="6" name="">
             <a:extLst xmlns:a="http://schemas.openxmlformats.org/drawingml/2006/main">
               <a:ext uri="{FF2B5EF4-FFF2-40B4-BE49-F238E27FC236}">
-                <a16:creationId xmlns:a16="http://schemas.microsoft.com/office/drawing/2014/main" id="{4F8A0C5E-AD9E-4F51-A49A-2C708203C9AF}"/>
+                <a16:creationId xmlns:a16="http://schemas.microsoft.com/office/drawing/2014/main" id="{FB95A79A-2F30-4901-A40E-B90E37A9FB9B}"/>
               </a:ext>
             </a:extLst>
           </p:cNvPr>
@@ -12356,7 +12618,7 @@
           <p:nvPr/>
         </p:nvPicPr>
         <p:blipFill>
-          <a:blip xmlns:r="http://schemas.openxmlformats.org/officeDocument/2006/relationships" xmlns:a="http://schemas.openxmlformats.org/drawingml/2006/main" r:embed="R6db41761156b483c"/>
+          <a:blip xmlns:r="http://schemas.openxmlformats.org/officeDocument/2006/relationships" xmlns:a="http://schemas.openxmlformats.org/drawingml/2006/main" r:embed="R95ea58d4dc5847f8"/>
           <a:stretch xmlns:a="http://schemas.openxmlformats.org/drawingml/2006/main"/>
         </p:blipFill>
         <p:spPr>
@@ -12378,7 +12640,7 @@
           <p:nvPr/>
         </p:nvPicPr>
         <p:blipFill>
-          <a:blip xmlns:r="http://schemas.openxmlformats.org/officeDocument/2006/relationships" xmlns:a="http://schemas.openxmlformats.org/drawingml/2006/main" r:embed="R15cdb659feea47fa"/>
+          <a:blip xmlns:r="http://schemas.openxmlformats.org/officeDocument/2006/relationships" xmlns:a="http://schemas.openxmlformats.org/drawingml/2006/main" r:embed="Rfe3fcd4557bc45ff"/>
           <a:stretch xmlns:a="http://schemas.openxmlformats.org/drawingml/2006/main"/>
         </p:blipFill>
         <p:spPr>
@@ -12396,7 +12658,7 @@
           <p:cNvPr id="9" name="">
             <a:extLst xmlns:a="http://schemas.openxmlformats.org/drawingml/2006/main">
               <a:ext uri="{FF2B5EF4-FFF2-40B4-BE49-F238E27FC236}">
-                <a16:creationId xmlns:a16="http://schemas.microsoft.com/office/drawing/2014/main" id="{BFECA6C8-BCEA-44C4-B50F-0DD22053F3CE}"/>
+                <a16:creationId xmlns:a16="http://schemas.microsoft.com/office/drawing/2014/main" id="{333696A9-FDE6-4E6F-A924-EE4378D2D937}"/>
               </a:ext>
             </a:extLst>
           </p:cNvPr>
@@ -12453,7 +12715,7 @@
           <p:cNvPr id="10" name="">
             <a:extLst xmlns:a="http://schemas.openxmlformats.org/drawingml/2006/main">
               <a:ext uri="{FF2B5EF4-FFF2-40B4-BE49-F238E27FC236}">
-                <a16:creationId xmlns:a16="http://schemas.microsoft.com/office/drawing/2014/main" id="{DC9C879B-AC04-4EE6-9649-491A4701042A}"/>
+                <a16:creationId xmlns:a16="http://schemas.microsoft.com/office/drawing/2014/main" id="{451BFDF0-8FCE-44FF-B817-D9D2F5A071CD}"/>
               </a:ext>
             </a:extLst>
           </p:cNvPr>
@@ -12510,7 +12772,7 @@
           <p:cNvPr id="11" name="">
             <a:extLst xmlns:a="http://schemas.openxmlformats.org/drawingml/2006/main">
               <a:ext uri="{FF2B5EF4-FFF2-40B4-BE49-F238E27FC236}">
-                <a16:creationId xmlns:a16="http://schemas.microsoft.com/office/drawing/2014/main" id="{892DDC5E-C76F-444C-A694-46681D5E4DAF}"/>
+                <a16:creationId xmlns:a16="http://schemas.microsoft.com/office/drawing/2014/main" id="{FAEBFA0E-6CD3-4428-A053-EE11944CEA29}"/>
               </a:ext>
             </a:extLst>
           </p:cNvPr>
@@ -12565,7 +12827,7 @@
     </p:spTree>
     <p:extLst>
       <p:ext uri="{BB962C8B-B14F-4D97-AF65-F5344CB8AC3E}">
-        <p14:creationId xmlns:p14="http://schemas.microsoft.com/office/powerpoint/2010/main" val="1587914580"/>
+        <p14:creationId xmlns:p14="http://schemas.microsoft.com/office/powerpoint/2010/main" val="45472646"/>
       </p:ext>
     </p:extLst>
   </p:cSld>
@@ -12596,7 +12858,7 @@
           <p:cNvPr id="12" name="">
             <a:extLst xmlns:a="http://schemas.openxmlformats.org/drawingml/2006/main">
               <a:ext uri="{FF2B5EF4-FFF2-40B4-BE49-F238E27FC236}">
-                <a16:creationId xmlns:a16="http://schemas.microsoft.com/office/drawing/2014/main" id="{9CB06ADB-8102-4BCC-B8ED-34197440D39D}"/>
+                <a16:creationId xmlns:a16="http://schemas.microsoft.com/office/drawing/2014/main" id="{03B6999E-DA3E-491F-9521-6B25ED8D4970}"/>
               </a:ext>
             </a:extLst>
           </p:cNvPr>
@@ -12626,7 +12888,7 @@
           <p:cNvPr id="2" name="">
             <a:extLst xmlns:a="http://schemas.openxmlformats.org/drawingml/2006/main">
               <a:ext uri="{FF2B5EF4-FFF2-40B4-BE49-F238E27FC236}">
-                <a16:creationId xmlns:a16="http://schemas.microsoft.com/office/drawing/2014/main" id="{3E6611C2-EDB1-4110-BEC0-635C429670DC}"/>
+                <a16:creationId xmlns:a16="http://schemas.microsoft.com/office/drawing/2014/main" id="{C97E380B-246E-47BA-81B5-34B4F176F593}"/>
               </a:ext>
             </a:extLst>
           </p:cNvPr>
@@ -12683,7 +12945,7 @@
           <p:cNvPr id="3" name="">
             <a:extLst xmlns:a="http://schemas.openxmlformats.org/drawingml/2006/main">
               <a:ext uri="{FF2B5EF4-FFF2-40B4-BE49-F238E27FC236}">
-                <a16:creationId xmlns:a16="http://schemas.microsoft.com/office/drawing/2014/main" id="{DF00F761-A906-4558-92E3-B3AE454F6541}"/>
+                <a16:creationId xmlns:a16="http://schemas.microsoft.com/office/drawing/2014/main" id="{AB679FD2-5313-4263-A106-82C68A4F9109}"/>
               </a:ext>
             </a:extLst>
           </p:cNvPr>
@@ -12713,7 +12975,7 @@
           <p:cNvPr id="4" name="">
             <a:extLst xmlns:a="http://schemas.openxmlformats.org/drawingml/2006/main">
               <a:ext uri="{FF2B5EF4-FFF2-40B4-BE49-F238E27FC236}">
-                <a16:creationId xmlns:a16="http://schemas.microsoft.com/office/drawing/2014/main" id="{4649CDC5-98EE-4A23-93CB-7D0A3AB21D66}"/>
+                <a16:creationId xmlns:a16="http://schemas.microsoft.com/office/drawing/2014/main" id="{FFE17D1A-0134-4203-BA21-ADBFA40FCFF3}"/>
               </a:ext>
             </a:extLst>
           </p:cNvPr>
@@ -12770,7 +13032,7 @@
           <p:cNvPr id="5" name="">
             <a:extLst xmlns:a="http://schemas.openxmlformats.org/drawingml/2006/main">
               <a:ext uri="{FF2B5EF4-FFF2-40B4-BE49-F238E27FC236}">
-                <a16:creationId xmlns:a16="http://schemas.microsoft.com/office/drawing/2014/main" id="{687354B7-A73B-4C1C-9246-773DFE8C204A}"/>
+                <a16:creationId xmlns:a16="http://schemas.microsoft.com/office/drawing/2014/main" id="{C9E85DB1-785C-4761-85D0-98F459776989}"/>
               </a:ext>
             </a:extLst>
           </p:cNvPr>
@@ -12802,7 +13064,7 @@
           <p:cNvPr id="6" name="">
             <a:extLst xmlns:a="http://schemas.openxmlformats.org/drawingml/2006/main">
               <a:ext uri="{FF2B5EF4-FFF2-40B4-BE49-F238E27FC236}">
-                <a16:creationId xmlns:a16="http://schemas.microsoft.com/office/drawing/2014/main" id="{F39983EB-D322-4DA7-B23F-CBF3167956A3}"/>
+                <a16:creationId xmlns:a16="http://schemas.microsoft.com/office/drawing/2014/main" id="{739953FA-3722-4874-8EDF-6AA2CCA118D1}"/>
               </a:ext>
             </a:extLst>
           </p:cNvPr>
@@ -12838,7 +13100,7 @@
           <p:nvPr/>
         </p:nvPicPr>
         <p:blipFill>
-          <a:blip xmlns:r="http://schemas.openxmlformats.org/officeDocument/2006/relationships" xmlns:a="http://schemas.openxmlformats.org/drawingml/2006/main" r:embed="R810f4bb7a0704488"/>
+          <a:blip xmlns:r="http://schemas.openxmlformats.org/officeDocument/2006/relationships" xmlns:a="http://schemas.openxmlformats.org/drawingml/2006/main" r:embed="R6f8ec24e12bd4157"/>
           <a:stretch xmlns:a="http://schemas.openxmlformats.org/drawingml/2006/main"/>
         </p:blipFill>
         <p:spPr>
@@ -12860,7 +13122,7 @@
           <p:nvPr/>
         </p:nvPicPr>
         <p:blipFill>
-          <a:blip xmlns:r="http://schemas.openxmlformats.org/officeDocument/2006/relationships" xmlns:a="http://schemas.openxmlformats.org/drawingml/2006/main" r:embed="Rba753095b95f4834"/>
+          <a:blip xmlns:r="http://schemas.openxmlformats.org/officeDocument/2006/relationships" xmlns:a="http://schemas.openxmlformats.org/drawingml/2006/main" r:embed="Rc23c450f4c3f4615"/>
           <a:stretch xmlns:a="http://schemas.openxmlformats.org/drawingml/2006/main"/>
         </p:blipFill>
         <p:spPr>
@@ -12878,7 +13140,7 @@
           <p:cNvPr id="9" name="">
             <a:extLst xmlns:a="http://schemas.openxmlformats.org/drawingml/2006/main">
               <a:ext uri="{FF2B5EF4-FFF2-40B4-BE49-F238E27FC236}">
-                <a16:creationId xmlns:a16="http://schemas.microsoft.com/office/drawing/2014/main" id="{6D5E7B8E-C27D-4193-A4F2-88451432C213}"/>
+                <a16:creationId xmlns:a16="http://schemas.microsoft.com/office/drawing/2014/main" id="{96BCF356-D273-412A-8BBD-07C9B59D0594}"/>
               </a:ext>
             </a:extLst>
           </p:cNvPr>
@@ -12935,7 +13197,7 @@
           <p:cNvPr id="10" name="">
             <a:extLst xmlns:a="http://schemas.openxmlformats.org/drawingml/2006/main">
               <a:ext uri="{FF2B5EF4-FFF2-40B4-BE49-F238E27FC236}">
-                <a16:creationId xmlns:a16="http://schemas.microsoft.com/office/drawing/2014/main" id="{C2C029E7-F4DE-4C7D-9DFD-EBFEEDCA8D19}"/>
+                <a16:creationId xmlns:a16="http://schemas.microsoft.com/office/drawing/2014/main" id="{6023DDA6-D760-4B66-B62F-B5464092CF94}"/>
               </a:ext>
             </a:extLst>
           </p:cNvPr>
@@ -12992,7 +13254,7 @@
           <p:cNvPr id="11" name="">
             <a:extLst xmlns:a="http://schemas.openxmlformats.org/drawingml/2006/main">
               <a:ext uri="{FF2B5EF4-FFF2-40B4-BE49-F238E27FC236}">
-                <a16:creationId xmlns:a16="http://schemas.microsoft.com/office/drawing/2014/main" id="{ED027C14-586B-4014-BD71-5BC27A3F2CB5}"/>
+                <a16:creationId xmlns:a16="http://schemas.microsoft.com/office/drawing/2014/main" id="{EF1CC71A-C229-41DB-BBAF-1E38061ABAE3}"/>
               </a:ext>
             </a:extLst>
           </p:cNvPr>
@@ -13047,7 +13309,7 @@
     </p:spTree>
     <p:extLst>
       <p:ext uri="{BB962C8B-B14F-4D97-AF65-F5344CB8AC3E}">
-        <p14:creationId xmlns:p14="http://schemas.microsoft.com/office/powerpoint/2010/main" val="898328654"/>
+        <p14:creationId xmlns:p14="http://schemas.microsoft.com/office/powerpoint/2010/main" val="1740811960"/>
       </p:ext>
     </p:extLst>
   </p:cSld>
@@ -13078,7 +13340,7 @@
           <p:cNvPr id="12" name="">
             <a:extLst xmlns:a="http://schemas.openxmlformats.org/drawingml/2006/main">
               <a:ext uri="{FF2B5EF4-FFF2-40B4-BE49-F238E27FC236}">
-                <a16:creationId xmlns:a16="http://schemas.microsoft.com/office/drawing/2014/main" id="{C8024367-3954-4EC2-ABA9-F5B5BBFC2FA9}"/>
+                <a16:creationId xmlns:a16="http://schemas.microsoft.com/office/drawing/2014/main" id="{BC114E8C-8101-44ED-A64D-B8481ED4C48A}"/>
               </a:ext>
             </a:extLst>
           </p:cNvPr>
@@ -13108,7 +13370,7 @@
           <p:cNvPr id="2" name="">
             <a:extLst xmlns:a="http://schemas.openxmlformats.org/drawingml/2006/main">
               <a:ext uri="{FF2B5EF4-FFF2-40B4-BE49-F238E27FC236}">
-                <a16:creationId xmlns:a16="http://schemas.microsoft.com/office/drawing/2014/main" id="{DCC543FC-D7DE-46AA-9092-DD4E35A75E2B}"/>
+                <a16:creationId xmlns:a16="http://schemas.microsoft.com/office/drawing/2014/main" id="{72DB6781-C24F-49CB-9087-C3A8C4F77A2E}"/>
               </a:ext>
             </a:extLst>
           </p:cNvPr>
@@ -13165,7 +13427,7 @@
           <p:cNvPr id="3" name="">
             <a:extLst xmlns:a="http://schemas.openxmlformats.org/drawingml/2006/main">
               <a:ext uri="{FF2B5EF4-FFF2-40B4-BE49-F238E27FC236}">
-                <a16:creationId xmlns:a16="http://schemas.microsoft.com/office/drawing/2014/main" id="{0EBE2943-D19C-42CD-83FA-164ABEE3406D}"/>
+                <a16:creationId xmlns:a16="http://schemas.microsoft.com/office/drawing/2014/main" id="{257043BD-FC96-47C7-AA8F-E8AB27570460}"/>
               </a:ext>
             </a:extLst>
           </p:cNvPr>
@@ -13195,7 +13457,7 @@
           <p:cNvPr id="4" name="">
             <a:extLst xmlns:a="http://schemas.openxmlformats.org/drawingml/2006/main">
               <a:ext uri="{FF2B5EF4-FFF2-40B4-BE49-F238E27FC236}">
-                <a16:creationId xmlns:a16="http://schemas.microsoft.com/office/drawing/2014/main" id="{39BFE846-E41A-468E-9776-6CFBC7109082}"/>
+                <a16:creationId xmlns:a16="http://schemas.microsoft.com/office/drawing/2014/main" id="{A6413FE1-E63A-4875-9C89-F8D5435E9C84}"/>
               </a:ext>
             </a:extLst>
           </p:cNvPr>
@@ -13252,7 +13514,7 @@
           <p:cNvPr id="5" name="">
             <a:extLst xmlns:a="http://schemas.openxmlformats.org/drawingml/2006/main">
               <a:ext uri="{FF2B5EF4-FFF2-40B4-BE49-F238E27FC236}">
-                <a16:creationId xmlns:a16="http://schemas.microsoft.com/office/drawing/2014/main" id="{C386D17B-C6EF-42F2-840A-3642773D09D7}"/>
+                <a16:creationId xmlns:a16="http://schemas.microsoft.com/office/drawing/2014/main" id="{E143FF19-D41E-432F-BDD0-8F87C2D3E94F}"/>
               </a:ext>
             </a:extLst>
           </p:cNvPr>
@@ -13284,7 +13546,7 @@
           <p:cNvPr id="6" name="">
             <a:extLst xmlns:a="http://schemas.openxmlformats.org/drawingml/2006/main">
               <a:ext uri="{FF2B5EF4-FFF2-40B4-BE49-F238E27FC236}">
-                <a16:creationId xmlns:a16="http://schemas.microsoft.com/office/drawing/2014/main" id="{15487AD4-A7C0-42EC-A76A-9A380C0B8CC4}"/>
+                <a16:creationId xmlns:a16="http://schemas.microsoft.com/office/drawing/2014/main" id="{A6E97CA5-A9F0-434C-A830-9090C6543549}"/>
               </a:ext>
             </a:extLst>
           </p:cNvPr>
@@ -13320,7 +13582,7 @@
           <p:nvPr/>
         </p:nvPicPr>
         <p:blipFill>
-          <a:blip xmlns:r="http://schemas.openxmlformats.org/officeDocument/2006/relationships" xmlns:a="http://schemas.openxmlformats.org/drawingml/2006/main" r:embed="R0cdf53d7dcf443ed"/>
+          <a:blip xmlns:r="http://schemas.openxmlformats.org/officeDocument/2006/relationships" xmlns:a="http://schemas.openxmlformats.org/drawingml/2006/main" r:embed="Rf04cffc3e0504d48"/>
           <a:stretch xmlns:a="http://schemas.openxmlformats.org/drawingml/2006/main"/>
         </p:blipFill>
         <p:spPr>
@@ -13342,7 +13604,7 @@
           <p:nvPr/>
         </p:nvPicPr>
         <p:blipFill>
-          <a:blip xmlns:r="http://schemas.openxmlformats.org/officeDocument/2006/relationships" xmlns:a="http://schemas.openxmlformats.org/drawingml/2006/main" r:embed="R2a8cc023249a4fac"/>
+          <a:blip xmlns:r="http://schemas.openxmlformats.org/officeDocument/2006/relationships" xmlns:a="http://schemas.openxmlformats.org/drawingml/2006/main" r:embed="Re232f79b6c1746a2"/>
           <a:stretch xmlns:a="http://schemas.openxmlformats.org/drawingml/2006/main"/>
         </p:blipFill>
         <p:spPr>
@@ -13360,7 +13622,7 @@
           <p:cNvPr id="9" name="">
             <a:extLst xmlns:a="http://schemas.openxmlformats.org/drawingml/2006/main">
               <a:ext uri="{FF2B5EF4-FFF2-40B4-BE49-F238E27FC236}">
-                <a16:creationId xmlns:a16="http://schemas.microsoft.com/office/drawing/2014/main" id="{C00C635E-376E-4698-980D-DCB591B4CCE3}"/>
+                <a16:creationId xmlns:a16="http://schemas.microsoft.com/office/drawing/2014/main" id="{2B62F258-BD70-4C80-A810-397EF4A28483}"/>
               </a:ext>
             </a:extLst>
           </p:cNvPr>
@@ -13417,7 +13679,7 @@
           <p:cNvPr id="10" name="">
             <a:extLst xmlns:a="http://schemas.openxmlformats.org/drawingml/2006/main">
               <a:ext uri="{FF2B5EF4-FFF2-40B4-BE49-F238E27FC236}">
-                <a16:creationId xmlns:a16="http://schemas.microsoft.com/office/drawing/2014/main" id="{96BA35E0-6FDA-4A0C-A4C6-1E08D0B4E1C4}"/>
+                <a16:creationId xmlns:a16="http://schemas.microsoft.com/office/drawing/2014/main" id="{951AA9B9-CD49-4589-890D-E089A3074958}"/>
               </a:ext>
             </a:extLst>
           </p:cNvPr>
@@ -13474,7 +13736,7 @@
           <p:cNvPr id="11" name="">
             <a:extLst xmlns:a="http://schemas.openxmlformats.org/drawingml/2006/main">
               <a:ext uri="{FF2B5EF4-FFF2-40B4-BE49-F238E27FC236}">
-                <a16:creationId xmlns:a16="http://schemas.microsoft.com/office/drawing/2014/main" id="{39CC9FDD-C4C1-4573-BCA3-54CD4ADB76F8}"/>
+                <a16:creationId xmlns:a16="http://schemas.microsoft.com/office/drawing/2014/main" id="{35C3CD68-B5BC-4724-A60F-46DA886E3FB8}"/>
               </a:ext>
             </a:extLst>
           </p:cNvPr>
@@ -13529,7 +13791,7 @@
     </p:spTree>
     <p:extLst>
       <p:ext uri="{BB962C8B-B14F-4D97-AF65-F5344CB8AC3E}">
-        <p14:creationId xmlns:p14="http://schemas.microsoft.com/office/powerpoint/2010/main" val="869784241"/>
+        <p14:creationId xmlns:p14="http://schemas.microsoft.com/office/powerpoint/2010/main" val="1315261781"/>
       </p:ext>
     </p:extLst>
   </p:cSld>
@@ -13560,7 +13822,7 @@
           <p:cNvPr id="27" name="">
             <a:extLst xmlns:a="http://schemas.openxmlformats.org/drawingml/2006/main">
               <a:ext uri="{FF2B5EF4-FFF2-40B4-BE49-F238E27FC236}">
-                <a16:creationId xmlns:a16="http://schemas.microsoft.com/office/drawing/2014/main" id="{CCC285D4-BE89-44CD-B208-16D9E5431240}"/>
+                <a16:creationId xmlns:a16="http://schemas.microsoft.com/office/drawing/2014/main" id="{66620607-C16B-4F49-83AC-AD06F4ADEDF5}"/>
               </a:ext>
             </a:extLst>
           </p:cNvPr>
@@ -13590,7 +13852,7 @@
           <p:cNvPr id="2" name="">
             <a:extLst xmlns:a="http://schemas.openxmlformats.org/drawingml/2006/main">
               <a:ext uri="{FF2B5EF4-FFF2-40B4-BE49-F238E27FC236}">
-                <a16:creationId xmlns:a16="http://schemas.microsoft.com/office/drawing/2014/main" id="{5A27CCCA-86C7-465B-B1F3-6A1716FE2E8A}"/>
+                <a16:creationId xmlns:a16="http://schemas.microsoft.com/office/drawing/2014/main" id="{8A339FC0-4078-456A-87BC-8D001F25EE23}"/>
               </a:ext>
             </a:extLst>
           </p:cNvPr>
@@ -13647,7 +13909,7 @@
           <p:cNvPr id="3" name="">
             <a:extLst xmlns:a="http://schemas.openxmlformats.org/drawingml/2006/main">
               <a:ext uri="{FF2B5EF4-FFF2-40B4-BE49-F238E27FC236}">
-                <a16:creationId xmlns:a16="http://schemas.microsoft.com/office/drawing/2014/main" id="{E46A93BB-6B22-4BBD-AA47-F52C85883617}"/>
+                <a16:creationId xmlns:a16="http://schemas.microsoft.com/office/drawing/2014/main" id="{AAE1ADD2-A7F9-4090-A5C9-7D1A27D52BD4}"/>
               </a:ext>
             </a:extLst>
           </p:cNvPr>
@@ -13677,7 +13939,7 @@
           <p:cNvPr id="4" name="">
             <a:extLst xmlns:a="http://schemas.openxmlformats.org/drawingml/2006/main">
               <a:ext uri="{FF2B5EF4-FFF2-40B4-BE49-F238E27FC236}">
-                <a16:creationId xmlns:a16="http://schemas.microsoft.com/office/drawing/2014/main" id="{47044750-16D1-47C0-8F9C-2E8607CA14E4}"/>
+                <a16:creationId xmlns:a16="http://schemas.microsoft.com/office/drawing/2014/main" id="{90F7CD2E-A540-4707-AD50-B707010A9BC7}"/>
               </a:ext>
             </a:extLst>
           </p:cNvPr>
@@ -13734,7 +13996,7 @@
           <p:cNvPr id="5" name="">
             <a:extLst xmlns:a="http://schemas.openxmlformats.org/drawingml/2006/main">
               <a:ext uri="{FF2B5EF4-FFF2-40B4-BE49-F238E27FC236}">
-                <a16:creationId xmlns:a16="http://schemas.microsoft.com/office/drawing/2014/main" id="{5A56D8E7-4021-4EEE-8C0F-A98FC11BAD72}"/>
+                <a16:creationId xmlns:a16="http://schemas.microsoft.com/office/drawing/2014/main" id="{34F8B9FD-B94E-4D7E-8029-9040312E6B4B}"/>
               </a:ext>
             </a:extLst>
           </p:cNvPr>
@@ -13766,7 +14028,7 @@
           <p:cNvPr id="6" name="">
             <a:extLst xmlns:a="http://schemas.openxmlformats.org/drawingml/2006/main">
               <a:ext uri="{FF2B5EF4-FFF2-40B4-BE49-F238E27FC236}">
-                <a16:creationId xmlns:a16="http://schemas.microsoft.com/office/drawing/2014/main" id="{28A04DA3-F972-471C-A71E-57D70FB116AB}"/>
+                <a16:creationId xmlns:a16="http://schemas.microsoft.com/office/drawing/2014/main" id="{0F6630C8-ED14-4541-8908-216D45A97F0B}"/>
               </a:ext>
             </a:extLst>
           </p:cNvPr>
@@ -13823,7 +14085,7 @@
           <p:cNvPr id="7" name="">
             <a:extLst xmlns:a="http://schemas.openxmlformats.org/drawingml/2006/main">
               <a:ext uri="{FF2B5EF4-FFF2-40B4-BE49-F238E27FC236}">
-                <a16:creationId xmlns:a16="http://schemas.microsoft.com/office/drawing/2014/main" id="{195B956A-F889-4BC8-8FAD-FDB61721FEAA}"/>
+                <a16:creationId xmlns:a16="http://schemas.microsoft.com/office/drawing/2014/main" id="{EB864EDB-4485-4992-A782-CF4B80258B47}"/>
               </a:ext>
             </a:extLst>
           </p:cNvPr>
@@ -13880,7 +14142,7 @@
           <p:cNvPr id="8" name="">
             <a:extLst xmlns:a="http://schemas.openxmlformats.org/drawingml/2006/main">
               <a:ext uri="{FF2B5EF4-FFF2-40B4-BE49-F238E27FC236}">
-                <a16:creationId xmlns:a16="http://schemas.microsoft.com/office/drawing/2014/main" id="{D51BBF5F-3D39-45FE-A6AA-30B2D1B1B2FD}"/>
+                <a16:creationId xmlns:a16="http://schemas.microsoft.com/office/drawing/2014/main" id="{9E3494F2-5924-4BD5-AD9E-03951DF27760}"/>
               </a:ext>
             </a:extLst>
           </p:cNvPr>
@@ -13960,7 +14222,7 @@
           <p:cNvPr id="9" name="">
             <a:extLst xmlns:a="http://schemas.openxmlformats.org/drawingml/2006/main">
               <a:ext uri="{FF2B5EF4-FFF2-40B4-BE49-F238E27FC236}">
-                <a16:creationId xmlns:a16="http://schemas.microsoft.com/office/drawing/2014/main" id="{1F3E1DF0-7F22-4ADD-8EF4-C92E2B82F800}"/>
+                <a16:creationId xmlns:a16="http://schemas.microsoft.com/office/drawing/2014/main" id="{4ADF35E7-2CDD-4402-8FED-4F61A6B83E65}"/>
               </a:ext>
             </a:extLst>
           </p:cNvPr>
@@ -13992,7 +14254,7 @@
           <p:cNvPr id="10" name="">
             <a:extLst xmlns:a="http://schemas.openxmlformats.org/drawingml/2006/main">
               <a:ext uri="{FF2B5EF4-FFF2-40B4-BE49-F238E27FC236}">
-                <a16:creationId xmlns:a16="http://schemas.microsoft.com/office/drawing/2014/main" id="{7E0BEE9D-8058-4979-97C1-6DDF482824FF}"/>
+                <a16:creationId xmlns:a16="http://schemas.microsoft.com/office/drawing/2014/main" id="{570CB376-955E-43C1-8496-924E16FA7B67}"/>
               </a:ext>
             </a:extLst>
           </p:cNvPr>
@@ -14049,7 +14311,7 @@
           <p:cNvPr id="11" name="">
             <a:extLst xmlns:a="http://schemas.openxmlformats.org/drawingml/2006/main">
               <a:ext uri="{FF2B5EF4-FFF2-40B4-BE49-F238E27FC236}">
-                <a16:creationId xmlns:a16="http://schemas.microsoft.com/office/drawing/2014/main" id="{5C00443C-3DDB-4AF0-9870-9C38B8A1C9BE}"/>
+                <a16:creationId xmlns:a16="http://schemas.microsoft.com/office/drawing/2014/main" id="{A612C935-46EA-470F-B19D-67AF21FFFDF2}"/>
               </a:ext>
             </a:extLst>
           </p:cNvPr>
@@ -14106,7 +14368,7 @@
           <p:cNvPr id="12" name="">
             <a:extLst xmlns:a="http://schemas.openxmlformats.org/drawingml/2006/main">
               <a:ext uri="{FF2B5EF4-FFF2-40B4-BE49-F238E27FC236}">
-                <a16:creationId xmlns:a16="http://schemas.microsoft.com/office/drawing/2014/main" id="{ED55EF5F-306D-490E-BED3-590C03261ABF}"/>
+                <a16:creationId xmlns:a16="http://schemas.microsoft.com/office/drawing/2014/main" id="{5DA930FC-D04C-4246-86E5-FBCDD446A9A8}"/>
               </a:ext>
             </a:extLst>
           </p:cNvPr>
@@ -14186,7 +14448,7 @@
           <p:cNvPr id="13" name="">
             <a:extLst xmlns:a="http://schemas.openxmlformats.org/drawingml/2006/main">
               <a:ext uri="{FF2B5EF4-FFF2-40B4-BE49-F238E27FC236}">
-                <a16:creationId xmlns:a16="http://schemas.microsoft.com/office/drawing/2014/main" id="{0FD6663E-4C55-4087-8762-B18DEC2F54F3}"/>
+                <a16:creationId xmlns:a16="http://schemas.microsoft.com/office/drawing/2014/main" id="{E369BDB6-5DB5-40C7-904F-1D2C77283963}"/>
               </a:ext>
             </a:extLst>
           </p:cNvPr>
@@ -14218,7 +14480,7 @@
           <p:cNvPr id="14" name="">
             <a:extLst xmlns:a="http://schemas.openxmlformats.org/drawingml/2006/main">
               <a:ext uri="{FF2B5EF4-FFF2-40B4-BE49-F238E27FC236}">
-                <a16:creationId xmlns:a16="http://schemas.microsoft.com/office/drawing/2014/main" id="{B8D9A99B-4059-45FC-95E4-422939EAFD5E}"/>
+                <a16:creationId xmlns:a16="http://schemas.microsoft.com/office/drawing/2014/main" id="{F05FC300-37F1-4B36-A04F-0D94257830EF}"/>
               </a:ext>
             </a:extLst>
           </p:cNvPr>
@@ -14275,7 +14537,7 @@
           <p:cNvPr id="15" name="">
             <a:extLst xmlns:a="http://schemas.openxmlformats.org/drawingml/2006/main">
               <a:ext uri="{FF2B5EF4-FFF2-40B4-BE49-F238E27FC236}">
-                <a16:creationId xmlns:a16="http://schemas.microsoft.com/office/drawing/2014/main" id="{90275CD0-7700-4E56-AE50-A0702EDF8869}"/>
+                <a16:creationId xmlns:a16="http://schemas.microsoft.com/office/drawing/2014/main" id="{C2898703-D961-4C3F-AEB0-0B712906F12F}"/>
               </a:ext>
             </a:extLst>
           </p:cNvPr>
@@ -14332,7 +14594,7 @@
           <p:cNvPr id="16" name="">
             <a:extLst xmlns:a="http://schemas.openxmlformats.org/drawingml/2006/main">
               <a:ext uri="{FF2B5EF4-FFF2-40B4-BE49-F238E27FC236}">
-                <a16:creationId xmlns:a16="http://schemas.microsoft.com/office/drawing/2014/main" id="{5D5A6DD5-80BF-433F-B853-9AC42876F45F}"/>
+                <a16:creationId xmlns:a16="http://schemas.microsoft.com/office/drawing/2014/main" id="{7ED8CA61-D862-45A6-B189-904A3A02326E}"/>
               </a:ext>
             </a:extLst>
           </p:cNvPr>
@@ -14412,7 +14674,7 @@
           <p:cNvPr id="17" name="">
             <a:extLst xmlns:a="http://schemas.openxmlformats.org/drawingml/2006/main">
               <a:ext uri="{FF2B5EF4-FFF2-40B4-BE49-F238E27FC236}">
-                <a16:creationId xmlns:a16="http://schemas.microsoft.com/office/drawing/2014/main" id="{FD1A89A9-56A5-4A3D-950C-A195C13A0976}"/>
+                <a16:creationId xmlns:a16="http://schemas.microsoft.com/office/drawing/2014/main" id="{03EF750B-D497-4643-A4C8-7C1601626BF2}"/>
               </a:ext>
             </a:extLst>
           </p:cNvPr>
@@ -14444,7 +14706,7 @@
           <p:cNvPr id="18" name="">
             <a:extLst xmlns:a="http://schemas.openxmlformats.org/drawingml/2006/main">
               <a:ext uri="{FF2B5EF4-FFF2-40B4-BE49-F238E27FC236}">
-                <a16:creationId xmlns:a16="http://schemas.microsoft.com/office/drawing/2014/main" id="{DCD8676D-CC27-4E38-8EC6-89C94734E507}"/>
+                <a16:creationId xmlns:a16="http://schemas.microsoft.com/office/drawing/2014/main" id="{01D8DA9D-5248-4972-9484-BC08961176E5}"/>
               </a:ext>
             </a:extLst>
           </p:cNvPr>
@@ -14501,7 +14763,7 @@
           <p:cNvPr id="19" name="">
             <a:extLst xmlns:a="http://schemas.openxmlformats.org/drawingml/2006/main">
               <a:ext uri="{FF2B5EF4-FFF2-40B4-BE49-F238E27FC236}">
-                <a16:creationId xmlns:a16="http://schemas.microsoft.com/office/drawing/2014/main" id="{B68E4BCE-8405-4895-B4F0-EA4A3C7F4216}"/>
+                <a16:creationId xmlns:a16="http://schemas.microsoft.com/office/drawing/2014/main" id="{4FE5EEDC-AFF4-444B-A246-AD1BF5EA7200}"/>
               </a:ext>
             </a:extLst>
           </p:cNvPr>
@@ -14558,7 +14820,7 @@
           <p:cNvPr id="20" name="">
             <a:extLst xmlns:a="http://schemas.openxmlformats.org/drawingml/2006/main">
               <a:ext uri="{FF2B5EF4-FFF2-40B4-BE49-F238E27FC236}">
-                <a16:creationId xmlns:a16="http://schemas.microsoft.com/office/drawing/2014/main" id="{B381E92A-D8E0-4F0D-BB16-856032BAA336}"/>
+                <a16:creationId xmlns:a16="http://schemas.microsoft.com/office/drawing/2014/main" id="{D9EA0EBA-46EA-4BD4-97A9-2157B9435683}"/>
               </a:ext>
             </a:extLst>
           </p:cNvPr>
@@ -14638,7 +14900,7 @@
           <p:cNvPr id="21" name="">
             <a:extLst xmlns:a="http://schemas.openxmlformats.org/drawingml/2006/main">
               <a:ext uri="{FF2B5EF4-FFF2-40B4-BE49-F238E27FC236}">
-                <a16:creationId xmlns:a16="http://schemas.microsoft.com/office/drawing/2014/main" id="{4C87A0D0-CEEC-4051-96E5-3D4432CF962D}"/>
+                <a16:creationId xmlns:a16="http://schemas.microsoft.com/office/drawing/2014/main" id="{2FDD2A37-AB97-4CAC-816C-F62C96E35B0C}"/>
               </a:ext>
             </a:extLst>
           </p:cNvPr>
@@ -14695,7 +14957,7 @@
           <p:cNvPr id="22" name="">
             <a:extLst xmlns:a="http://schemas.openxmlformats.org/drawingml/2006/main">
               <a:ext uri="{FF2B5EF4-FFF2-40B4-BE49-F238E27FC236}">
-                <a16:creationId xmlns:a16="http://schemas.microsoft.com/office/drawing/2014/main" id="{9619E60A-EC20-4A97-8D2A-9B0B97475F39}"/>
+                <a16:creationId xmlns:a16="http://schemas.microsoft.com/office/drawing/2014/main" id="{BC4009C3-0A07-4029-8396-2BA8FCE6501C}"/>
               </a:ext>
             </a:extLst>
           </p:cNvPr>
@@ -14752,7 +15014,7 @@
           <p:cNvPr id="23" name="">
             <a:extLst xmlns:a="http://schemas.openxmlformats.org/drawingml/2006/main">
               <a:ext uri="{FF2B5EF4-FFF2-40B4-BE49-F238E27FC236}">
-                <a16:creationId xmlns:a16="http://schemas.microsoft.com/office/drawing/2014/main" id="{A6D99B69-898A-4313-A73D-F833FCC85E09}"/>
+                <a16:creationId xmlns:a16="http://schemas.microsoft.com/office/drawing/2014/main" id="{6BD5B5BF-5A90-4C46-A437-D7D94060AEC2}"/>
               </a:ext>
             </a:extLst>
           </p:cNvPr>
@@ -14809,7 +15071,7 @@
           <p:cNvPr id="24" name="">
             <a:extLst xmlns:a="http://schemas.openxmlformats.org/drawingml/2006/main">
               <a:ext uri="{FF2B5EF4-FFF2-40B4-BE49-F238E27FC236}">
-                <a16:creationId xmlns:a16="http://schemas.microsoft.com/office/drawing/2014/main" id="{C859FE63-69B0-4B3C-9DB9-2CA98CB28A0F}"/>
+                <a16:creationId xmlns:a16="http://schemas.microsoft.com/office/drawing/2014/main" id="{1627FAE8-6934-48E5-94AE-F772DCCA403B}"/>
               </a:ext>
             </a:extLst>
           </p:cNvPr>
@@ -14866,7 +15128,7 @@
           <p:cNvPr id="25" name="">
             <a:extLst xmlns:a="http://schemas.openxmlformats.org/drawingml/2006/main">
               <a:ext uri="{FF2B5EF4-FFF2-40B4-BE49-F238E27FC236}">
-                <a16:creationId xmlns:a16="http://schemas.microsoft.com/office/drawing/2014/main" id="{5AADF754-2CE1-494A-A988-003AE41F8E94}"/>
+                <a16:creationId xmlns:a16="http://schemas.microsoft.com/office/drawing/2014/main" id="{2EF215B9-8A57-4A60-80AE-701B6D9036EF}"/>
               </a:ext>
             </a:extLst>
           </p:cNvPr>
@@ -14923,7 +15185,7 @@
           <p:cNvPr id="26" name="">
             <a:extLst xmlns:a="http://schemas.openxmlformats.org/drawingml/2006/main">
               <a:ext uri="{FF2B5EF4-FFF2-40B4-BE49-F238E27FC236}">
-                <a16:creationId xmlns:a16="http://schemas.microsoft.com/office/drawing/2014/main" id="{1A15AE8C-5931-4A30-B2EC-79F77FFB6964}"/>
+                <a16:creationId xmlns:a16="http://schemas.microsoft.com/office/drawing/2014/main" id="{0D7C30DA-802D-4833-A661-2E01416ACFA4}"/>
               </a:ext>
             </a:extLst>
           </p:cNvPr>
@@ -14978,7 +15240,7 @@
     </p:spTree>
     <p:extLst>
       <p:ext uri="{BB962C8B-B14F-4D97-AF65-F5344CB8AC3E}">
-        <p14:creationId xmlns:p14="http://schemas.microsoft.com/office/powerpoint/2010/main" val="360402470"/>
+        <p14:creationId xmlns:p14="http://schemas.microsoft.com/office/powerpoint/2010/main" val="1067670571"/>
       </p:ext>
     </p:extLst>
   </p:cSld>

</xml_diff>

<commit_message>
docs: refine final presentation plan
</commit_message>
<xml_diff>
--- a/docs/presentation/MEMOIVE-Presentation.pptx
+++ b/docs/presentation/MEMOIVE-Presentation.pptx
@@ -2,26 +2,26 @@
 <file path=ppt/presentation.xml><?xml version="1.0" encoding="utf-8"?>
 <p:presentation xmlns:p="http://schemas.openxmlformats.org/presentationml/2006/main">
   <p:sldMasterIdLst>
-    <p:sldMasterId xmlns:r="http://schemas.openxmlformats.org/officeDocument/2006/relationships" id="2147483648" r:id="R63389ff20b7d4eed"/>
+    <p:sldMasterId xmlns:r="http://schemas.openxmlformats.org/officeDocument/2006/relationships" id="2147483648" r:id="R1a60270e200f46ab"/>
   </p:sldMasterIdLst>
   <p:notesMasterIdLst>
-    <p:notesMasterId xmlns:r="http://schemas.openxmlformats.org/officeDocument/2006/relationships" r:id="Rb497f1323ac941dc"/>
+    <p:notesMasterId xmlns:r="http://schemas.openxmlformats.org/officeDocument/2006/relationships" r:id="R2d6d1e16300b4194"/>
   </p:notesMasterIdLst>
   <p:sldIdLst>
-    <p:sldId xmlns:r="http://schemas.openxmlformats.org/officeDocument/2006/relationships" id="256" r:id="R1739812baeb64f79"/>
-    <p:sldId xmlns:r="http://schemas.openxmlformats.org/officeDocument/2006/relationships" id="257" r:id="R6fbbc29ce7904e98"/>
-    <p:sldId xmlns:r="http://schemas.openxmlformats.org/officeDocument/2006/relationships" id="258" r:id="R0c7cba70407243af"/>
-    <p:sldId xmlns:r="http://schemas.openxmlformats.org/officeDocument/2006/relationships" id="259" r:id="R91735f8c03cb44c9"/>
-    <p:sldId xmlns:r="http://schemas.openxmlformats.org/officeDocument/2006/relationships" id="260" r:id="Rffe5c07723364782"/>
-    <p:sldId xmlns:r="http://schemas.openxmlformats.org/officeDocument/2006/relationships" id="261" r:id="R30324338e4d341b7"/>
-    <p:sldId xmlns:r="http://schemas.openxmlformats.org/officeDocument/2006/relationships" id="262" r:id="R804a309e3c97409e"/>
-    <p:sldId xmlns:r="http://schemas.openxmlformats.org/officeDocument/2006/relationships" id="263" r:id="Rcdf0f5579d3a493e"/>
-    <p:sldId xmlns:r="http://schemas.openxmlformats.org/officeDocument/2006/relationships" id="264" r:id="R5136b9a09f634f70"/>
-    <p:sldId xmlns:r="http://schemas.openxmlformats.org/officeDocument/2006/relationships" id="265" r:id="R5d1a575e057844b7"/>
-    <p:sldId xmlns:r="http://schemas.openxmlformats.org/officeDocument/2006/relationships" id="266" r:id="R870ab957b1ec4876"/>
-    <p:sldId xmlns:r="http://schemas.openxmlformats.org/officeDocument/2006/relationships" id="267" r:id="R4b9d3561e23c4b63"/>
-    <p:sldId xmlns:r="http://schemas.openxmlformats.org/officeDocument/2006/relationships" id="268" r:id="R7187c620ce2542d2"/>
-    <p:sldId xmlns:r="http://schemas.openxmlformats.org/officeDocument/2006/relationships" id="269" r:id="Raeac6acf29b14569"/>
+    <p:sldId xmlns:r="http://schemas.openxmlformats.org/officeDocument/2006/relationships" id="256" r:id="R0a738db1ca9b483f"/>
+    <p:sldId xmlns:r="http://schemas.openxmlformats.org/officeDocument/2006/relationships" id="257" r:id="R069f10033e1944a8"/>
+    <p:sldId xmlns:r="http://schemas.openxmlformats.org/officeDocument/2006/relationships" id="258" r:id="R1dd8a136fc114d6a"/>
+    <p:sldId xmlns:r="http://schemas.openxmlformats.org/officeDocument/2006/relationships" id="259" r:id="Raf8442e921a643be"/>
+    <p:sldId xmlns:r="http://schemas.openxmlformats.org/officeDocument/2006/relationships" id="260" r:id="Rf257e9cae60a48d8"/>
+    <p:sldId xmlns:r="http://schemas.openxmlformats.org/officeDocument/2006/relationships" id="261" r:id="R86202cd60a874593"/>
+    <p:sldId xmlns:r="http://schemas.openxmlformats.org/officeDocument/2006/relationships" id="262" r:id="R9bb53f23bc194338"/>
+    <p:sldId xmlns:r="http://schemas.openxmlformats.org/officeDocument/2006/relationships" id="263" r:id="Rd67e6dd9b8a74713"/>
+    <p:sldId xmlns:r="http://schemas.openxmlformats.org/officeDocument/2006/relationships" id="264" r:id="R32f3e467ee5b4a33"/>
+    <p:sldId xmlns:r="http://schemas.openxmlformats.org/officeDocument/2006/relationships" id="265" r:id="Ra548dd90f7a54d25"/>
+    <p:sldId xmlns:r="http://schemas.openxmlformats.org/officeDocument/2006/relationships" id="266" r:id="R98cdc3cd49eb47c1"/>
+    <p:sldId xmlns:r="http://schemas.openxmlformats.org/officeDocument/2006/relationships" id="267" r:id="R283830d15b5c40be"/>
+    <p:sldId xmlns:r="http://schemas.openxmlformats.org/officeDocument/2006/relationships" id="268" r:id="R6e7e07575f29464b"/>
+    <p:sldId xmlns:r="http://schemas.openxmlformats.org/officeDocument/2006/relationships" id="269" r:id="R45b695db13b04bff"/>
   </p:sldIdLst>
   <p:sldSz cx="12192000" cy="6858000"/>
   <p:notesSz cx="6858000" cy="9144000"/>
@@ -935,7 +935,7 @@
           </a:p>
           <a:p xmlns:a="http://schemas.openxmlformats.org/drawingml/2006/main">
             <a:r>
-              <a:t>메모이브는 memoive.vercel.app에서 확인할 수 있습니다. 다음 단계에서는 먼저 3명을 관찰하고 5명 시험으로 막히는 위치와 시간 단축을 확인하겠습니다. 여러 사용자가 쓰는 단계에 도달하면 계정 로그인과 사용자별 기록 권한을 구현하고, 반복 사용이 확인되면 검색 필터와 결과물 버전 관리를 개선하겠습니다. 검증 결과에 따라 필요한 기능부터 구현하겠습니다. 감사합니다.</a:t>
+              <a:t>메모이브는 memoive.vercel.app에서 확인할 수 있습니다. 다음 단계의 첫 번째 초점은 시간 단축입니다. 자료를 정리하고 결과물로 만드는 데 걸리는 시간이 실제로 줄어드는지 확인하겠습니다. 지금은 제가 혼자 쓰는 서비스이므로, 두 번째는 다양한 사람이 사용할 수 있는 범용 서비스로 확장하는 것입니다. 반복 사용이 확인되면 검색 필터와 결과물 버전 관리도 개선하겠습니다. 감사합니다.</a:t>
             </a:r>
           </a:p>
           <a:p xmlns:a="http://schemas.openxmlformats.org/drawingml/2006/main">
@@ -1783,7 +1783,7 @@
   </p:cSld>
   <p:clrMap bg1="lt1" tx1="dk1" bg2="lt2" tx2="dk2" accent1="accent1" accent2="accent2" accent3="accent3" accent4="accent4" accent5="accent5" accent6="accent6" hlink="hlink" folHlink="folHlink"/>
   <p:sldLayoutIdLst>
-    <p:sldLayoutId xmlns:r="http://schemas.openxmlformats.org/officeDocument/2006/relationships" id="2147483649" r:id="Red940412a11a41a4"/>
+    <p:sldLayoutId xmlns:r="http://schemas.openxmlformats.org/officeDocument/2006/relationships" id="2147483649" r:id="R7de44020cc874305"/>
   </p:sldLayoutIdLst>
   <p:txStyles>
     <p:titleStyle>
@@ -2334,7 +2334,7 @@
           <p:cNvPr id="9" name="">
             <a:extLst xmlns:a="http://schemas.openxmlformats.org/drawingml/2006/main">
               <a:ext uri="{FF2B5EF4-FFF2-40B4-BE49-F238E27FC236}">
-                <a16:creationId xmlns:a16="http://schemas.microsoft.com/office/drawing/2014/main" id="{E30A8B98-532C-4E10-A8E4-C4239BBB3436}"/>
+                <a16:creationId xmlns:a16="http://schemas.microsoft.com/office/drawing/2014/main" id="{BA47CF77-DD35-45CC-8A5B-996D2707CB49}"/>
               </a:ext>
             </a:extLst>
           </p:cNvPr>
@@ -2391,7 +2391,7 @@
           <p:cNvPr id="2" name="">
             <a:extLst xmlns:a="http://schemas.openxmlformats.org/drawingml/2006/main">
               <a:ext uri="{FF2B5EF4-FFF2-40B4-BE49-F238E27FC236}">
-                <a16:creationId xmlns:a16="http://schemas.microsoft.com/office/drawing/2014/main" id="{F8AD504B-8E3B-4222-9985-CDE3310167DA}"/>
+                <a16:creationId xmlns:a16="http://schemas.microsoft.com/office/drawing/2014/main" id="{F0A7A424-5A8E-4ADA-B071-31E9DE023B5F}"/>
               </a:ext>
             </a:extLst>
           </p:cNvPr>
@@ -2448,7 +2448,7 @@
           <p:cNvPr id="3" name="">
             <a:extLst xmlns:a="http://schemas.openxmlformats.org/drawingml/2006/main">
               <a:ext uri="{FF2B5EF4-FFF2-40B4-BE49-F238E27FC236}">
-                <a16:creationId xmlns:a16="http://schemas.microsoft.com/office/drawing/2014/main" id="{727D0573-4949-4544-8260-B53885A23628}"/>
+                <a16:creationId xmlns:a16="http://schemas.microsoft.com/office/drawing/2014/main" id="{C6F2C2F2-E52A-4898-9F74-452AE3660013}"/>
               </a:ext>
             </a:extLst>
           </p:cNvPr>
@@ -2505,7 +2505,7 @@
           <p:cNvPr id="4" name="">
             <a:extLst xmlns:a="http://schemas.openxmlformats.org/drawingml/2006/main">
               <a:ext uri="{FF2B5EF4-FFF2-40B4-BE49-F238E27FC236}">
-                <a16:creationId xmlns:a16="http://schemas.microsoft.com/office/drawing/2014/main" id="{6DA83F83-52C8-4A51-9FBA-402F5784B3B4}"/>
+                <a16:creationId xmlns:a16="http://schemas.microsoft.com/office/drawing/2014/main" id="{6AD68458-581E-4CC4-8A7B-EC3A45F8F87B}"/>
               </a:ext>
             </a:extLst>
           </p:cNvPr>
@@ -2562,7 +2562,7 @@
           <p:cNvPr id="5" name="">
             <a:extLst xmlns:a="http://schemas.openxmlformats.org/drawingml/2006/main">
               <a:ext uri="{FF2B5EF4-FFF2-40B4-BE49-F238E27FC236}">
-                <a16:creationId xmlns:a16="http://schemas.microsoft.com/office/drawing/2014/main" id="{53E7D1E3-5324-46A0-8B61-A194B0966D70}"/>
+                <a16:creationId xmlns:a16="http://schemas.microsoft.com/office/drawing/2014/main" id="{36FCF40C-3444-4861-B380-2291F9C59D82}"/>
               </a:ext>
             </a:extLst>
           </p:cNvPr>
@@ -2642,7 +2642,7 @@
           <p:cNvPr id="6" name="">
             <a:extLst xmlns:a="http://schemas.openxmlformats.org/drawingml/2006/main">
               <a:ext uri="{FF2B5EF4-FFF2-40B4-BE49-F238E27FC236}">
-                <a16:creationId xmlns:a16="http://schemas.microsoft.com/office/drawing/2014/main" id="{AADB7CA3-BCB2-475C-AD97-D23828F5301B}"/>
+                <a16:creationId xmlns:a16="http://schemas.microsoft.com/office/drawing/2014/main" id="{818E2DB3-D02A-4D5A-A692-183499EBFA70}"/>
               </a:ext>
             </a:extLst>
           </p:cNvPr>
@@ -2672,7 +2672,7 @@
           <p:cNvPr id="7" name="">
             <a:extLst xmlns:a="http://schemas.openxmlformats.org/drawingml/2006/main">
               <a:ext uri="{FF2B5EF4-FFF2-40B4-BE49-F238E27FC236}">
-                <a16:creationId xmlns:a16="http://schemas.microsoft.com/office/drawing/2014/main" id="{CC35385D-6F54-44F2-B2A2-02778FD8C605}"/>
+                <a16:creationId xmlns:a16="http://schemas.microsoft.com/office/drawing/2014/main" id="{6B3784B3-5303-4820-8B0A-0C067E818EF7}"/>
               </a:ext>
             </a:extLst>
           </p:cNvPr>
@@ -2729,7 +2729,7 @@
           <p:cNvPr id="8" name="">
             <a:extLst xmlns:a="http://schemas.openxmlformats.org/drawingml/2006/main">
               <a:ext uri="{FF2B5EF4-FFF2-40B4-BE49-F238E27FC236}">
-                <a16:creationId xmlns:a16="http://schemas.microsoft.com/office/drawing/2014/main" id="{9D26C232-9378-45F7-8E13-D8C1EE586A12}"/>
+                <a16:creationId xmlns:a16="http://schemas.microsoft.com/office/drawing/2014/main" id="{59F4E7E8-FA01-4FCE-8285-516398B6BA07}"/>
               </a:ext>
             </a:extLst>
           </p:cNvPr>
@@ -2784,7 +2784,7 @@
     </p:spTree>
     <p:extLst>
       <p:ext uri="{BB962C8B-B14F-4D97-AF65-F5344CB8AC3E}">
-        <p14:creationId xmlns:p14="http://schemas.microsoft.com/office/powerpoint/2010/main" val="990642439"/>
+        <p14:creationId xmlns:p14="http://schemas.microsoft.com/office/powerpoint/2010/main" val="1096804224"/>
       </p:ext>
     </p:extLst>
   </p:cSld>
@@ -2815,7 +2815,7 @@
           <p:cNvPr id="22" name="">
             <a:extLst xmlns:a="http://schemas.openxmlformats.org/drawingml/2006/main">
               <a:ext uri="{FF2B5EF4-FFF2-40B4-BE49-F238E27FC236}">
-                <a16:creationId xmlns:a16="http://schemas.microsoft.com/office/drawing/2014/main" id="{8491E527-47DD-4872-888F-88F6E6EC2EB5}"/>
+                <a16:creationId xmlns:a16="http://schemas.microsoft.com/office/drawing/2014/main" id="{99117364-111C-451F-99D6-30F79B1E135E}"/>
               </a:ext>
             </a:extLst>
           </p:cNvPr>
@@ -2845,7 +2845,7 @@
           <p:cNvPr id="2" name="">
             <a:extLst xmlns:a="http://schemas.openxmlformats.org/drawingml/2006/main">
               <a:ext uri="{FF2B5EF4-FFF2-40B4-BE49-F238E27FC236}">
-                <a16:creationId xmlns:a16="http://schemas.microsoft.com/office/drawing/2014/main" id="{C16C7589-8BBA-4BB8-B909-9F7122EAB3D3}"/>
+                <a16:creationId xmlns:a16="http://schemas.microsoft.com/office/drawing/2014/main" id="{ACBF4D66-EEF5-4EAF-AFED-C997B835820F}"/>
               </a:ext>
             </a:extLst>
           </p:cNvPr>
@@ -2902,7 +2902,7 @@
           <p:cNvPr id="3" name="">
             <a:extLst xmlns:a="http://schemas.openxmlformats.org/drawingml/2006/main">
               <a:ext uri="{FF2B5EF4-FFF2-40B4-BE49-F238E27FC236}">
-                <a16:creationId xmlns:a16="http://schemas.microsoft.com/office/drawing/2014/main" id="{FEB7C680-79C1-4C29-82B3-87CAA8536C8B}"/>
+                <a16:creationId xmlns:a16="http://schemas.microsoft.com/office/drawing/2014/main" id="{1840ED12-5FB5-4BA9-A21C-7CC773824348}"/>
               </a:ext>
             </a:extLst>
           </p:cNvPr>
@@ -2932,7 +2932,7 @@
           <p:cNvPr id="4" name="">
             <a:extLst xmlns:a="http://schemas.openxmlformats.org/drawingml/2006/main">
               <a:ext uri="{FF2B5EF4-FFF2-40B4-BE49-F238E27FC236}">
-                <a16:creationId xmlns:a16="http://schemas.microsoft.com/office/drawing/2014/main" id="{A858A319-11F4-413F-86AA-71CF3DEA6F63}"/>
+                <a16:creationId xmlns:a16="http://schemas.microsoft.com/office/drawing/2014/main" id="{6677304B-778C-4422-BE08-44687CBA3582}"/>
               </a:ext>
             </a:extLst>
           </p:cNvPr>
@@ -2989,7 +2989,7 @@
           <p:cNvPr id="5" name="">
             <a:extLst xmlns:a="http://schemas.openxmlformats.org/drawingml/2006/main">
               <a:ext uri="{FF2B5EF4-FFF2-40B4-BE49-F238E27FC236}">
-                <a16:creationId xmlns:a16="http://schemas.microsoft.com/office/drawing/2014/main" id="{BFE459AB-9EDE-416F-BB49-50285036E1A1}"/>
+                <a16:creationId xmlns:a16="http://schemas.microsoft.com/office/drawing/2014/main" id="{1F65DD82-7864-4B20-BB84-CEBCF3831393}"/>
               </a:ext>
             </a:extLst>
           </p:cNvPr>
@@ -3019,7 +3019,7 @@
           <p:cNvPr id="6" name="">
             <a:extLst xmlns:a="http://schemas.openxmlformats.org/drawingml/2006/main">
               <a:ext uri="{FF2B5EF4-FFF2-40B4-BE49-F238E27FC236}">
-                <a16:creationId xmlns:a16="http://schemas.microsoft.com/office/drawing/2014/main" id="{8EE6BF0A-B664-417A-8985-C19C952633EC}"/>
+                <a16:creationId xmlns:a16="http://schemas.microsoft.com/office/drawing/2014/main" id="{C61F2986-F81B-4946-969B-3D9F1E9AA767}"/>
               </a:ext>
             </a:extLst>
           </p:cNvPr>
@@ -3076,7 +3076,7 @@
           <p:cNvPr id="7" name="">
             <a:extLst xmlns:a="http://schemas.openxmlformats.org/drawingml/2006/main">
               <a:ext uri="{FF2B5EF4-FFF2-40B4-BE49-F238E27FC236}">
-                <a16:creationId xmlns:a16="http://schemas.microsoft.com/office/drawing/2014/main" id="{F59E74FB-1A8D-4F6C-B32F-6AB061591AB6}"/>
+                <a16:creationId xmlns:a16="http://schemas.microsoft.com/office/drawing/2014/main" id="{6EEB67F9-010D-4040-A029-FB7DFB32C8C4}"/>
               </a:ext>
             </a:extLst>
           </p:cNvPr>
@@ -3133,7 +3133,7 @@
           <p:cNvPr id="8" name="">
             <a:extLst xmlns:a="http://schemas.openxmlformats.org/drawingml/2006/main">
               <a:ext uri="{FF2B5EF4-FFF2-40B4-BE49-F238E27FC236}">
-                <a16:creationId xmlns:a16="http://schemas.microsoft.com/office/drawing/2014/main" id="{BC4F7032-714D-4E56-AF6C-2466B7542BC3}"/>
+                <a16:creationId xmlns:a16="http://schemas.microsoft.com/office/drawing/2014/main" id="{19617924-D352-4BEC-A923-2D3FE1B283C9}"/>
               </a:ext>
             </a:extLst>
           </p:cNvPr>
@@ -3190,7 +3190,7 @@
           <p:cNvPr id="9" name="">
             <a:extLst xmlns:a="http://schemas.openxmlformats.org/drawingml/2006/main">
               <a:ext uri="{FF2B5EF4-FFF2-40B4-BE49-F238E27FC236}">
-                <a16:creationId xmlns:a16="http://schemas.microsoft.com/office/drawing/2014/main" id="{5491F373-979C-42BA-854C-CB93644BF15A}"/>
+                <a16:creationId xmlns:a16="http://schemas.microsoft.com/office/drawing/2014/main" id="{EB3A59A6-1072-4C6A-AC53-095DFFB19BB9}"/>
               </a:ext>
             </a:extLst>
           </p:cNvPr>
@@ -3222,7 +3222,7 @@
           <p:cNvPr id="10" name="">
             <a:extLst xmlns:a="http://schemas.openxmlformats.org/drawingml/2006/main">
               <a:ext uri="{FF2B5EF4-FFF2-40B4-BE49-F238E27FC236}">
-                <a16:creationId xmlns:a16="http://schemas.microsoft.com/office/drawing/2014/main" id="{717B23FD-D0CE-4597-8AB6-D164AAD5999F}"/>
+                <a16:creationId xmlns:a16="http://schemas.microsoft.com/office/drawing/2014/main" id="{79E73B54-F5BB-4D3D-8E90-8EEA4181997F}"/>
               </a:ext>
             </a:extLst>
           </p:cNvPr>
@@ -3279,7 +3279,7 @@
           <p:cNvPr id="11" name="">
             <a:extLst xmlns:a="http://schemas.openxmlformats.org/drawingml/2006/main">
               <a:ext uri="{FF2B5EF4-FFF2-40B4-BE49-F238E27FC236}">
-                <a16:creationId xmlns:a16="http://schemas.microsoft.com/office/drawing/2014/main" id="{8ABE7ECD-259F-4386-8102-63B00E79B29E}"/>
+                <a16:creationId xmlns:a16="http://schemas.microsoft.com/office/drawing/2014/main" id="{F9C678DD-1584-4919-AA37-59FBCA1585CC}"/>
               </a:ext>
             </a:extLst>
           </p:cNvPr>
@@ -3336,7 +3336,7 @@
           <p:cNvPr id="12" name="">
             <a:extLst xmlns:a="http://schemas.openxmlformats.org/drawingml/2006/main">
               <a:ext uri="{FF2B5EF4-FFF2-40B4-BE49-F238E27FC236}">
-                <a16:creationId xmlns:a16="http://schemas.microsoft.com/office/drawing/2014/main" id="{7E072BF7-35D7-484F-A0A0-0DDA00FE3B6E}"/>
+                <a16:creationId xmlns:a16="http://schemas.microsoft.com/office/drawing/2014/main" id="{CB674C74-7E3D-4A6C-910A-DD3AF20DD4DC}"/>
               </a:ext>
             </a:extLst>
           </p:cNvPr>
@@ -3393,7 +3393,7 @@
           <p:cNvPr id="13" name="">
             <a:extLst xmlns:a="http://schemas.openxmlformats.org/drawingml/2006/main">
               <a:ext uri="{FF2B5EF4-FFF2-40B4-BE49-F238E27FC236}">
-                <a16:creationId xmlns:a16="http://schemas.microsoft.com/office/drawing/2014/main" id="{DF475A30-5B4C-46B0-B102-361C9DAD63FA}"/>
+                <a16:creationId xmlns:a16="http://schemas.microsoft.com/office/drawing/2014/main" id="{6BE5B791-8610-489F-B26E-9FE936D9E4EA}"/>
               </a:ext>
             </a:extLst>
           </p:cNvPr>
@@ -3425,7 +3425,7 @@
           <p:cNvPr id="14" name="">
             <a:extLst xmlns:a="http://schemas.openxmlformats.org/drawingml/2006/main">
               <a:ext uri="{FF2B5EF4-FFF2-40B4-BE49-F238E27FC236}">
-                <a16:creationId xmlns:a16="http://schemas.microsoft.com/office/drawing/2014/main" id="{02673EFE-9888-4CCC-973F-D98BC19FF844}"/>
+                <a16:creationId xmlns:a16="http://schemas.microsoft.com/office/drawing/2014/main" id="{2105434F-76C4-4C97-9AF7-6DBD08BCBAAD}"/>
               </a:ext>
             </a:extLst>
           </p:cNvPr>
@@ -3482,7 +3482,7 @@
           <p:cNvPr id="15" name="">
             <a:extLst xmlns:a="http://schemas.openxmlformats.org/drawingml/2006/main">
               <a:ext uri="{FF2B5EF4-FFF2-40B4-BE49-F238E27FC236}">
-                <a16:creationId xmlns:a16="http://schemas.microsoft.com/office/drawing/2014/main" id="{E38DAAC5-0D37-470E-A0B6-2F7A3D1DA7D4}"/>
+                <a16:creationId xmlns:a16="http://schemas.microsoft.com/office/drawing/2014/main" id="{EF941CC3-7861-4F1A-BA9D-277D89454C23}"/>
               </a:ext>
             </a:extLst>
           </p:cNvPr>
@@ -3539,7 +3539,7 @@
           <p:cNvPr id="16" name="">
             <a:extLst xmlns:a="http://schemas.openxmlformats.org/drawingml/2006/main">
               <a:ext uri="{FF2B5EF4-FFF2-40B4-BE49-F238E27FC236}">
-                <a16:creationId xmlns:a16="http://schemas.microsoft.com/office/drawing/2014/main" id="{DCFBA9B6-6397-4642-A5C2-C22755D1C26C}"/>
+                <a16:creationId xmlns:a16="http://schemas.microsoft.com/office/drawing/2014/main" id="{A48D0C0B-5794-4A22-AC5D-13C6F717E195}"/>
               </a:ext>
             </a:extLst>
           </p:cNvPr>
@@ -3596,7 +3596,7 @@
           <p:cNvPr id="17" name="">
             <a:extLst xmlns:a="http://schemas.openxmlformats.org/drawingml/2006/main">
               <a:ext uri="{FF2B5EF4-FFF2-40B4-BE49-F238E27FC236}">
-                <a16:creationId xmlns:a16="http://schemas.microsoft.com/office/drawing/2014/main" id="{18FC7B87-5DEB-4544-9C65-9953FF951BF4}"/>
+                <a16:creationId xmlns:a16="http://schemas.microsoft.com/office/drawing/2014/main" id="{824A5395-1776-4A08-A355-1294C34EE8BF}"/>
               </a:ext>
             </a:extLst>
           </p:cNvPr>
@@ -3628,7 +3628,7 @@
           <p:cNvPr id="18" name="">
             <a:extLst xmlns:a="http://schemas.openxmlformats.org/drawingml/2006/main">
               <a:ext uri="{FF2B5EF4-FFF2-40B4-BE49-F238E27FC236}">
-                <a16:creationId xmlns:a16="http://schemas.microsoft.com/office/drawing/2014/main" id="{4E2CFE37-D44E-4EE8-9C56-DEEEF7EBDDA3}"/>
+                <a16:creationId xmlns:a16="http://schemas.microsoft.com/office/drawing/2014/main" id="{E9AE2D57-B3CC-4CEA-BD6A-6A00FE900C9D}"/>
               </a:ext>
             </a:extLst>
           </p:cNvPr>
@@ -3685,7 +3685,7 @@
           <p:cNvPr id="19" name="">
             <a:extLst xmlns:a="http://schemas.openxmlformats.org/drawingml/2006/main">
               <a:ext uri="{FF2B5EF4-FFF2-40B4-BE49-F238E27FC236}">
-                <a16:creationId xmlns:a16="http://schemas.microsoft.com/office/drawing/2014/main" id="{19F8EDAC-D542-4DD7-AF00-874869DC2CF6}"/>
+                <a16:creationId xmlns:a16="http://schemas.microsoft.com/office/drawing/2014/main" id="{965EB956-4594-46CB-989F-C06BE864753A}"/>
               </a:ext>
             </a:extLst>
           </p:cNvPr>
@@ -3742,7 +3742,7 @@
           <p:cNvPr id="20" name="">
             <a:extLst xmlns:a="http://schemas.openxmlformats.org/drawingml/2006/main">
               <a:ext uri="{FF2B5EF4-FFF2-40B4-BE49-F238E27FC236}">
-                <a16:creationId xmlns:a16="http://schemas.microsoft.com/office/drawing/2014/main" id="{0C365874-C70E-4345-9DF9-DBFE6B8730FF}"/>
+                <a16:creationId xmlns:a16="http://schemas.microsoft.com/office/drawing/2014/main" id="{E7E5F287-750B-417E-82E9-014A6C29286A}"/>
               </a:ext>
             </a:extLst>
           </p:cNvPr>
@@ -3799,7 +3799,7 @@
           <p:cNvPr id="21" name="">
             <a:extLst xmlns:a="http://schemas.openxmlformats.org/drawingml/2006/main">
               <a:ext uri="{FF2B5EF4-FFF2-40B4-BE49-F238E27FC236}">
-                <a16:creationId xmlns:a16="http://schemas.microsoft.com/office/drawing/2014/main" id="{79684C62-2FE7-4F59-8DBD-72B096091CF7}"/>
+                <a16:creationId xmlns:a16="http://schemas.microsoft.com/office/drawing/2014/main" id="{B9C9B35C-4E36-4652-91A9-B89FEF5F2A93}"/>
               </a:ext>
             </a:extLst>
           </p:cNvPr>
@@ -3854,7 +3854,7 @@
     </p:spTree>
     <p:extLst>
       <p:ext uri="{BB962C8B-B14F-4D97-AF65-F5344CB8AC3E}">
-        <p14:creationId xmlns:p14="http://schemas.microsoft.com/office/powerpoint/2010/main" val="1180608110"/>
+        <p14:creationId xmlns:p14="http://schemas.microsoft.com/office/powerpoint/2010/main" val="1836227365"/>
       </p:ext>
     </p:extLst>
   </p:cSld>
@@ -3885,7 +3885,7 @@
           <p:cNvPr id="21" name="">
             <a:extLst xmlns:a="http://schemas.openxmlformats.org/drawingml/2006/main">
               <a:ext uri="{FF2B5EF4-FFF2-40B4-BE49-F238E27FC236}">
-                <a16:creationId xmlns:a16="http://schemas.microsoft.com/office/drawing/2014/main" id="{0395ED75-C40E-476E-861F-5B61BAB86735}"/>
+                <a16:creationId xmlns:a16="http://schemas.microsoft.com/office/drawing/2014/main" id="{5B72C287-F3CB-4EDC-8021-EACEB2C66745}"/>
               </a:ext>
             </a:extLst>
           </p:cNvPr>
@@ -3915,7 +3915,7 @@
           <p:cNvPr id="2" name="">
             <a:extLst xmlns:a="http://schemas.openxmlformats.org/drawingml/2006/main">
               <a:ext uri="{FF2B5EF4-FFF2-40B4-BE49-F238E27FC236}">
-                <a16:creationId xmlns:a16="http://schemas.microsoft.com/office/drawing/2014/main" id="{2C6C43F2-234A-4195-A0F7-7A7E21DA64FE}"/>
+                <a16:creationId xmlns:a16="http://schemas.microsoft.com/office/drawing/2014/main" id="{917060AE-BFCD-41F5-ACA2-4B6A1407E961}"/>
               </a:ext>
             </a:extLst>
           </p:cNvPr>
@@ -3972,7 +3972,7 @@
           <p:cNvPr id="3" name="">
             <a:extLst xmlns:a="http://schemas.openxmlformats.org/drawingml/2006/main">
               <a:ext uri="{FF2B5EF4-FFF2-40B4-BE49-F238E27FC236}">
-                <a16:creationId xmlns:a16="http://schemas.microsoft.com/office/drawing/2014/main" id="{07A81E01-E916-4F19-B2DB-A9269DD7C2E9}"/>
+                <a16:creationId xmlns:a16="http://schemas.microsoft.com/office/drawing/2014/main" id="{82DECDB4-D767-4823-94DF-71DC665F5F79}"/>
               </a:ext>
             </a:extLst>
           </p:cNvPr>
@@ -4002,7 +4002,7 @@
           <p:cNvPr id="4" name="">
             <a:extLst xmlns:a="http://schemas.openxmlformats.org/drawingml/2006/main">
               <a:ext uri="{FF2B5EF4-FFF2-40B4-BE49-F238E27FC236}">
-                <a16:creationId xmlns:a16="http://schemas.microsoft.com/office/drawing/2014/main" id="{14EEE9A4-587F-4285-816C-E9E72ADECFC7}"/>
+                <a16:creationId xmlns:a16="http://schemas.microsoft.com/office/drawing/2014/main" id="{67B154E6-DA4F-42F5-9DD0-6515031A126B}"/>
               </a:ext>
             </a:extLst>
           </p:cNvPr>
@@ -4059,7 +4059,7 @@
           <p:cNvPr id="5" name="">
             <a:extLst xmlns:a="http://schemas.openxmlformats.org/drawingml/2006/main">
               <a:ext uri="{FF2B5EF4-FFF2-40B4-BE49-F238E27FC236}">
-                <a16:creationId xmlns:a16="http://schemas.microsoft.com/office/drawing/2014/main" id="{937CE83C-EC58-4DC2-81B5-28D4AE4CD21B}"/>
+                <a16:creationId xmlns:a16="http://schemas.microsoft.com/office/drawing/2014/main" id="{6AA338CB-1AA0-4E0A-80BD-BBFFD2FED974}"/>
               </a:ext>
             </a:extLst>
           </p:cNvPr>
@@ -4116,7 +4116,7 @@
           <p:cNvPr id="6" name="">
             <a:extLst xmlns:a="http://schemas.openxmlformats.org/drawingml/2006/main">
               <a:ext uri="{FF2B5EF4-FFF2-40B4-BE49-F238E27FC236}">
-                <a16:creationId xmlns:a16="http://schemas.microsoft.com/office/drawing/2014/main" id="{70F553C5-E0BE-4D99-865E-16AF8A55CFF6}"/>
+                <a16:creationId xmlns:a16="http://schemas.microsoft.com/office/drawing/2014/main" id="{EF94D952-9EB6-4207-9546-925BAC94DC4A}"/>
               </a:ext>
             </a:extLst>
           </p:cNvPr>
@@ -4173,7 +4173,7 @@
           <p:cNvPr id="7" name="">
             <a:extLst xmlns:a="http://schemas.openxmlformats.org/drawingml/2006/main">
               <a:ext uri="{FF2B5EF4-FFF2-40B4-BE49-F238E27FC236}">
-                <a16:creationId xmlns:a16="http://schemas.microsoft.com/office/drawing/2014/main" id="{3D767B04-2F74-4D2B-A535-7EDA945B5844}"/>
+                <a16:creationId xmlns:a16="http://schemas.microsoft.com/office/drawing/2014/main" id="{BC528BD6-99C4-4729-8676-9637C0B127CF}"/>
               </a:ext>
             </a:extLst>
           </p:cNvPr>
@@ -4230,7 +4230,7 @@
           <p:cNvPr id="8" name="">
             <a:extLst xmlns:a="http://schemas.openxmlformats.org/drawingml/2006/main">
               <a:ext uri="{FF2B5EF4-FFF2-40B4-BE49-F238E27FC236}">
-                <a16:creationId xmlns:a16="http://schemas.microsoft.com/office/drawing/2014/main" id="{01CF3C6A-0BBB-4D7F-AC6E-3FC14A026F9C}"/>
+                <a16:creationId xmlns:a16="http://schemas.microsoft.com/office/drawing/2014/main" id="{CE7FBFC5-8D43-42CD-B129-C86E302DDB8E}"/>
               </a:ext>
             </a:extLst>
           </p:cNvPr>
@@ -4260,7 +4260,7 @@
           <p:cNvPr id="9" name="">
             <a:extLst xmlns:a="http://schemas.openxmlformats.org/drawingml/2006/main">
               <a:ext uri="{FF2B5EF4-FFF2-40B4-BE49-F238E27FC236}">
-                <a16:creationId xmlns:a16="http://schemas.microsoft.com/office/drawing/2014/main" id="{4F686899-A1F6-434B-A8C2-E014434DE095}"/>
+                <a16:creationId xmlns:a16="http://schemas.microsoft.com/office/drawing/2014/main" id="{8BD18F68-8E35-4382-8BA0-8327D1EFF029}"/>
               </a:ext>
             </a:extLst>
           </p:cNvPr>
@@ -4317,7 +4317,7 @@
           <p:cNvPr id="10" name="">
             <a:extLst xmlns:a="http://schemas.openxmlformats.org/drawingml/2006/main">
               <a:ext uri="{FF2B5EF4-FFF2-40B4-BE49-F238E27FC236}">
-                <a16:creationId xmlns:a16="http://schemas.microsoft.com/office/drawing/2014/main" id="{ABACDF65-87B9-4A4F-874F-C6D3FFDCFE3C}"/>
+                <a16:creationId xmlns:a16="http://schemas.microsoft.com/office/drawing/2014/main" id="{F3247C53-0EC3-4357-829A-F47A33F80E71}"/>
               </a:ext>
             </a:extLst>
           </p:cNvPr>
@@ -4374,7 +4374,7 @@
           <p:cNvPr id="11" name="">
             <a:extLst xmlns:a="http://schemas.openxmlformats.org/drawingml/2006/main">
               <a:ext uri="{FF2B5EF4-FFF2-40B4-BE49-F238E27FC236}">
-                <a16:creationId xmlns:a16="http://schemas.microsoft.com/office/drawing/2014/main" id="{41E78910-60AC-4EE1-B27B-99E5718383F7}"/>
+                <a16:creationId xmlns:a16="http://schemas.microsoft.com/office/drawing/2014/main" id="{E3ED147B-1366-49BB-9DBD-12D096DA409D}"/>
               </a:ext>
             </a:extLst>
           </p:cNvPr>
@@ -4431,7 +4431,7 @@
           <p:cNvPr id="12" name="">
             <a:extLst xmlns:a="http://schemas.openxmlformats.org/drawingml/2006/main">
               <a:ext uri="{FF2B5EF4-FFF2-40B4-BE49-F238E27FC236}">
-                <a16:creationId xmlns:a16="http://schemas.microsoft.com/office/drawing/2014/main" id="{8CA6DC50-4ABB-4AF5-8963-A39ADDB75E3D}"/>
+                <a16:creationId xmlns:a16="http://schemas.microsoft.com/office/drawing/2014/main" id="{6C221BFF-83F2-4FD1-B41F-83FAE171B570}"/>
               </a:ext>
             </a:extLst>
           </p:cNvPr>
@@ -4461,7 +4461,7 @@
           <p:cNvPr id="13" name="">
             <a:extLst xmlns:a="http://schemas.openxmlformats.org/drawingml/2006/main">
               <a:ext uri="{FF2B5EF4-FFF2-40B4-BE49-F238E27FC236}">
-                <a16:creationId xmlns:a16="http://schemas.microsoft.com/office/drawing/2014/main" id="{F2853B5B-6EC8-4FB1-968F-6CB337856212}"/>
+                <a16:creationId xmlns:a16="http://schemas.microsoft.com/office/drawing/2014/main" id="{E806BF57-5F79-4A83-A8C7-21478AA601D8}"/>
               </a:ext>
             </a:extLst>
           </p:cNvPr>
@@ -4518,7 +4518,7 @@
           <p:cNvPr id="14" name="">
             <a:extLst xmlns:a="http://schemas.openxmlformats.org/drawingml/2006/main">
               <a:ext uri="{FF2B5EF4-FFF2-40B4-BE49-F238E27FC236}">
-                <a16:creationId xmlns:a16="http://schemas.microsoft.com/office/drawing/2014/main" id="{9A292D65-907C-4F85-A3D8-C19969AC683B}"/>
+                <a16:creationId xmlns:a16="http://schemas.microsoft.com/office/drawing/2014/main" id="{18999AAD-3C9F-406F-AD29-9B97BD39247F}"/>
               </a:ext>
             </a:extLst>
           </p:cNvPr>
@@ -4575,7 +4575,7 @@
           <p:cNvPr id="15" name="">
             <a:extLst xmlns:a="http://schemas.openxmlformats.org/drawingml/2006/main">
               <a:ext uri="{FF2B5EF4-FFF2-40B4-BE49-F238E27FC236}">
-                <a16:creationId xmlns:a16="http://schemas.microsoft.com/office/drawing/2014/main" id="{8DF8D7C7-B095-442C-AEAE-338479644FB0}"/>
+                <a16:creationId xmlns:a16="http://schemas.microsoft.com/office/drawing/2014/main" id="{73E78BD2-E47D-4664-8AD2-7925E71E0ABE}"/>
               </a:ext>
             </a:extLst>
           </p:cNvPr>
@@ -4632,7 +4632,7 @@
           <p:cNvPr id="16" name="">
             <a:extLst xmlns:a="http://schemas.openxmlformats.org/drawingml/2006/main">
               <a:ext uri="{FF2B5EF4-FFF2-40B4-BE49-F238E27FC236}">
-                <a16:creationId xmlns:a16="http://schemas.microsoft.com/office/drawing/2014/main" id="{0D057AC4-4C42-4F9A-A06F-D3B06178BD38}"/>
+                <a16:creationId xmlns:a16="http://schemas.microsoft.com/office/drawing/2014/main" id="{AF5FEE80-56AA-47F8-A29A-5E8201B26017}"/>
               </a:ext>
             </a:extLst>
           </p:cNvPr>
@@ -4662,7 +4662,7 @@
           <p:cNvPr id="17" name="">
             <a:extLst xmlns:a="http://schemas.openxmlformats.org/drawingml/2006/main">
               <a:ext uri="{FF2B5EF4-FFF2-40B4-BE49-F238E27FC236}">
-                <a16:creationId xmlns:a16="http://schemas.microsoft.com/office/drawing/2014/main" id="{C3D32F45-186D-4DF8-97D8-0F41168724E1}"/>
+                <a16:creationId xmlns:a16="http://schemas.microsoft.com/office/drawing/2014/main" id="{9691673B-E6F8-40E0-B2F3-F94D340CD1E0}"/>
               </a:ext>
             </a:extLst>
           </p:cNvPr>
@@ -4719,7 +4719,7 @@
           <p:cNvPr id="18" name="">
             <a:extLst xmlns:a="http://schemas.openxmlformats.org/drawingml/2006/main">
               <a:ext uri="{FF2B5EF4-FFF2-40B4-BE49-F238E27FC236}">
-                <a16:creationId xmlns:a16="http://schemas.microsoft.com/office/drawing/2014/main" id="{37384C16-F666-4F24-9639-FF8A5D954E82}"/>
+                <a16:creationId xmlns:a16="http://schemas.microsoft.com/office/drawing/2014/main" id="{3C9EB00F-6DEF-4F0D-999A-B831D087286C}"/>
               </a:ext>
             </a:extLst>
           </p:cNvPr>
@@ -4776,7 +4776,7 @@
           <p:cNvPr id="19" name="">
             <a:extLst xmlns:a="http://schemas.openxmlformats.org/drawingml/2006/main">
               <a:ext uri="{FF2B5EF4-FFF2-40B4-BE49-F238E27FC236}">
-                <a16:creationId xmlns:a16="http://schemas.microsoft.com/office/drawing/2014/main" id="{B356BF4E-86B2-4AAE-85C3-D50E821863EC}"/>
+                <a16:creationId xmlns:a16="http://schemas.microsoft.com/office/drawing/2014/main" id="{C08EEC7B-E7AB-4061-B9D1-A294C5358067}"/>
               </a:ext>
             </a:extLst>
           </p:cNvPr>
@@ -4833,7 +4833,7 @@
           <p:cNvPr id="20" name="">
             <a:extLst xmlns:a="http://schemas.openxmlformats.org/drawingml/2006/main">
               <a:ext uri="{FF2B5EF4-FFF2-40B4-BE49-F238E27FC236}">
-                <a16:creationId xmlns:a16="http://schemas.microsoft.com/office/drawing/2014/main" id="{159FB153-8474-4901-820C-32CC7013D838}"/>
+                <a16:creationId xmlns:a16="http://schemas.microsoft.com/office/drawing/2014/main" id="{9753F51E-7E4F-40FE-B73F-D9BCCE19E78A}"/>
               </a:ext>
             </a:extLst>
           </p:cNvPr>
@@ -4888,7 +4888,7 @@
     </p:spTree>
     <p:extLst>
       <p:ext uri="{BB962C8B-B14F-4D97-AF65-F5344CB8AC3E}">
-        <p14:creationId xmlns:p14="http://schemas.microsoft.com/office/powerpoint/2010/main" val="1039531399"/>
+        <p14:creationId xmlns:p14="http://schemas.microsoft.com/office/powerpoint/2010/main" val="2034378284"/>
       </p:ext>
     </p:extLst>
   </p:cSld>
@@ -4919,7 +4919,7 @@
           <p:cNvPr id="21" name="">
             <a:extLst xmlns:a="http://schemas.openxmlformats.org/drawingml/2006/main">
               <a:ext uri="{FF2B5EF4-FFF2-40B4-BE49-F238E27FC236}">
-                <a16:creationId xmlns:a16="http://schemas.microsoft.com/office/drawing/2014/main" id="{93B30118-89CE-457E-95AF-DB2C9C0B0714}"/>
+                <a16:creationId xmlns:a16="http://schemas.microsoft.com/office/drawing/2014/main" id="{AF3313A8-37A5-444B-8FF1-C4486E0528D3}"/>
               </a:ext>
             </a:extLst>
           </p:cNvPr>
@@ -4949,7 +4949,7 @@
           <p:cNvPr id="2" name="">
             <a:extLst xmlns:a="http://schemas.openxmlformats.org/drawingml/2006/main">
               <a:ext uri="{FF2B5EF4-FFF2-40B4-BE49-F238E27FC236}">
-                <a16:creationId xmlns:a16="http://schemas.microsoft.com/office/drawing/2014/main" id="{701FDF30-B5B6-4773-95C4-D38400206646}"/>
+                <a16:creationId xmlns:a16="http://schemas.microsoft.com/office/drawing/2014/main" id="{AA291B3B-6EEE-421A-A7B5-27E0831F5FC4}"/>
               </a:ext>
             </a:extLst>
           </p:cNvPr>
@@ -5006,7 +5006,7 @@
           <p:cNvPr id="3" name="">
             <a:extLst xmlns:a="http://schemas.openxmlformats.org/drawingml/2006/main">
               <a:ext uri="{FF2B5EF4-FFF2-40B4-BE49-F238E27FC236}">
-                <a16:creationId xmlns:a16="http://schemas.microsoft.com/office/drawing/2014/main" id="{9731ED50-B118-49AA-9A33-338148952CEF}"/>
+                <a16:creationId xmlns:a16="http://schemas.microsoft.com/office/drawing/2014/main" id="{304C9ABD-06F3-4AF3-A50E-A877CD0CE24B}"/>
               </a:ext>
             </a:extLst>
           </p:cNvPr>
@@ -5036,7 +5036,7 @@
           <p:cNvPr id="4" name="">
             <a:extLst xmlns:a="http://schemas.openxmlformats.org/drawingml/2006/main">
               <a:ext uri="{FF2B5EF4-FFF2-40B4-BE49-F238E27FC236}">
-                <a16:creationId xmlns:a16="http://schemas.microsoft.com/office/drawing/2014/main" id="{02EC0114-B656-43B3-A04C-BCBB018EB107}"/>
+                <a16:creationId xmlns:a16="http://schemas.microsoft.com/office/drawing/2014/main" id="{CB4542AD-2D9C-4E3A-ADD6-4B3EEF967494}"/>
               </a:ext>
             </a:extLst>
           </p:cNvPr>
@@ -5093,7 +5093,7 @@
           <p:cNvPr id="5" name="">
             <a:extLst xmlns:a="http://schemas.openxmlformats.org/drawingml/2006/main">
               <a:ext uri="{FF2B5EF4-FFF2-40B4-BE49-F238E27FC236}">
-                <a16:creationId xmlns:a16="http://schemas.microsoft.com/office/drawing/2014/main" id="{00C110BD-525C-4F18-A2D9-F7A074824586}"/>
+                <a16:creationId xmlns:a16="http://schemas.microsoft.com/office/drawing/2014/main" id="{F293ED72-7404-476B-968B-024F3669BA0A}"/>
               </a:ext>
             </a:extLst>
           </p:cNvPr>
@@ -5125,7 +5125,7 @@
           <p:cNvPr id="6" name="">
             <a:extLst xmlns:a="http://schemas.openxmlformats.org/drawingml/2006/main">
               <a:ext uri="{FF2B5EF4-FFF2-40B4-BE49-F238E27FC236}">
-                <a16:creationId xmlns:a16="http://schemas.microsoft.com/office/drawing/2014/main" id="{4BD3C4E8-D838-4ADB-ADB3-70FA74BC4091}"/>
+                <a16:creationId xmlns:a16="http://schemas.microsoft.com/office/drawing/2014/main" id="{E7FB83FF-9632-48FB-8E41-BDE9394A1C98}"/>
               </a:ext>
             </a:extLst>
           </p:cNvPr>
@@ -5182,7 +5182,7 @@
           <p:cNvPr id="7" name="">
             <a:extLst xmlns:a="http://schemas.openxmlformats.org/drawingml/2006/main">
               <a:ext uri="{FF2B5EF4-FFF2-40B4-BE49-F238E27FC236}">
-                <a16:creationId xmlns:a16="http://schemas.microsoft.com/office/drawing/2014/main" id="{5BDFB574-F739-4D2D-9EFF-62A7AF116644}"/>
+                <a16:creationId xmlns:a16="http://schemas.microsoft.com/office/drawing/2014/main" id="{2B08E7A1-FB5E-41C7-9D96-A92E84DA0A26}"/>
               </a:ext>
             </a:extLst>
           </p:cNvPr>
@@ -5262,7 +5262,7 @@
           <p:cNvPr id="8" name="">
             <a:extLst xmlns:a="http://schemas.openxmlformats.org/drawingml/2006/main">
               <a:ext uri="{FF2B5EF4-FFF2-40B4-BE49-F238E27FC236}">
-                <a16:creationId xmlns:a16="http://schemas.microsoft.com/office/drawing/2014/main" id="{FD4F4B41-A211-4FF8-A9D7-094AFED8B41C}"/>
+                <a16:creationId xmlns:a16="http://schemas.microsoft.com/office/drawing/2014/main" id="{88C276D1-105C-408B-A44A-7B8DEE855050}"/>
               </a:ext>
             </a:extLst>
           </p:cNvPr>
@@ -5342,7 +5342,7 @@
           <p:cNvPr id="9" name="">
             <a:extLst xmlns:a="http://schemas.openxmlformats.org/drawingml/2006/main">
               <a:ext uri="{FF2B5EF4-FFF2-40B4-BE49-F238E27FC236}">
-                <a16:creationId xmlns:a16="http://schemas.microsoft.com/office/drawing/2014/main" id="{7A97AAB2-A0E4-49B8-9069-8F02E233D0A8}"/>
+                <a16:creationId xmlns:a16="http://schemas.microsoft.com/office/drawing/2014/main" id="{9C26DBE4-F7B8-4E7F-8B56-26C74DEF54AE}"/>
               </a:ext>
             </a:extLst>
           </p:cNvPr>
@@ -5372,7 +5372,7 @@
           <p:cNvPr id="10" name="">
             <a:extLst xmlns:a="http://schemas.openxmlformats.org/drawingml/2006/main">
               <a:ext uri="{FF2B5EF4-FFF2-40B4-BE49-F238E27FC236}">
-                <a16:creationId xmlns:a16="http://schemas.microsoft.com/office/drawing/2014/main" id="{5646C22A-A951-485E-AAA7-06D74A5C0056}"/>
+                <a16:creationId xmlns:a16="http://schemas.microsoft.com/office/drawing/2014/main" id="{72AEEBAA-47DE-4F3E-9CCF-7CBAD2F973B9}"/>
               </a:ext>
             </a:extLst>
           </p:cNvPr>
@@ -5429,7 +5429,7 @@
           <p:cNvPr id="11" name="">
             <a:extLst xmlns:a="http://schemas.openxmlformats.org/drawingml/2006/main">
               <a:ext uri="{FF2B5EF4-FFF2-40B4-BE49-F238E27FC236}">
-                <a16:creationId xmlns:a16="http://schemas.microsoft.com/office/drawing/2014/main" id="{CC5C84B8-7EE4-4692-82D3-14055F5EF926}"/>
+                <a16:creationId xmlns:a16="http://schemas.microsoft.com/office/drawing/2014/main" id="{EE5F40FD-3768-426D-ABF8-8FA607EAF94D}"/>
               </a:ext>
             </a:extLst>
           </p:cNvPr>
@@ -5486,7 +5486,7 @@
           <p:cNvPr id="12" name="">
             <a:extLst xmlns:a="http://schemas.openxmlformats.org/drawingml/2006/main">
               <a:ext uri="{FF2B5EF4-FFF2-40B4-BE49-F238E27FC236}">
-                <a16:creationId xmlns:a16="http://schemas.microsoft.com/office/drawing/2014/main" id="{0C2FB5EC-7DA2-4FF6-AF89-890E14E8C9BE}"/>
+                <a16:creationId xmlns:a16="http://schemas.microsoft.com/office/drawing/2014/main" id="{9A4DE62A-8112-489A-9E1F-EBBAF91F4548}"/>
               </a:ext>
             </a:extLst>
           </p:cNvPr>
@@ -5543,7 +5543,7 @@
           <p:cNvPr id="13" name="">
             <a:extLst xmlns:a="http://schemas.openxmlformats.org/drawingml/2006/main">
               <a:ext uri="{FF2B5EF4-FFF2-40B4-BE49-F238E27FC236}">
-                <a16:creationId xmlns:a16="http://schemas.microsoft.com/office/drawing/2014/main" id="{907D0C83-34E4-4939-A661-9C721CF23B3A}"/>
+                <a16:creationId xmlns:a16="http://schemas.microsoft.com/office/drawing/2014/main" id="{C7E6E399-B7B1-4098-B063-0EDDF56BF784}"/>
               </a:ext>
             </a:extLst>
           </p:cNvPr>
@@ -5623,7 +5623,7 @@
           <p:cNvPr id="14" name="">
             <a:extLst xmlns:a="http://schemas.openxmlformats.org/drawingml/2006/main">
               <a:ext uri="{FF2B5EF4-FFF2-40B4-BE49-F238E27FC236}">
-                <a16:creationId xmlns:a16="http://schemas.microsoft.com/office/drawing/2014/main" id="{482F47EF-9B87-4124-9ED0-6CFE2F68290A}"/>
+                <a16:creationId xmlns:a16="http://schemas.microsoft.com/office/drawing/2014/main" id="{53A06009-01D6-4541-B95C-E46A4995B18F}"/>
               </a:ext>
             </a:extLst>
           </p:cNvPr>
@@ -5680,7 +5680,7 @@
           <p:cNvPr id="15" name="">
             <a:extLst xmlns:a="http://schemas.openxmlformats.org/drawingml/2006/main">
               <a:ext uri="{FF2B5EF4-FFF2-40B4-BE49-F238E27FC236}">
-                <a16:creationId xmlns:a16="http://schemas.microsoft.com/office/drawing/2014/main" id="{6933FDCA-CB80-49C4-B458-5F4C1DC3B92A}"/>
+                <a16:creationId xmlns:a16="http://schemas.microsoft.com/office/drawing/2014/main" id="{3E63DF0A-7188-48A4-A9C5-4D8155EF2AEE}"/>
               </a:ext>
             </a:extLst>
           </p:cNvPr>
@@ -5712,7 +5712,7 @@
           <p:cNvPr id="16" name="">
             <a:extLst xmlns:a="http://schemas.openxmlformats.org/drawingml/2006/main">
               <a:ext uri="{FF2B5EF4-FFF2-40B4-BE49-F238E27FC236}">
-                <a16:creationId xmlns:a16="http://schemas.microsoft.com/office/drawing/2014/main" id="{15986DA8-2CFE-4FC9-9D85-7656265C77D8}"/>
+                <a16:creationId xmlns:a16="http://schemas.microsoft.com/office/drawing/2014/main" id="{C5C054BD-17BB-4FB2-A682-EA71C894CBE9}"/>
               </a:ext>
             </a:extLst>
           </p:cNvPr>
@@ -5769,7 +5769,7 @@
           <p:cNvPr id="17" name="">
             <a:extLst xmlns:a="http://schemas.openxmlformats.org/drawingml/2006/main">
               <a:ext uri="{FF2B5EF4-FFF2-40B4-BE49-F238E27FC236}">
-                <a16:creationId xmlns:a16="http://schemas.microsoft.com/office/drawing/2014/main" id="{358B2A26-1668-49A6-9F5C-3AE11CAB4205}"/>
+                <a16:creationId xmlns:a16="http://schemas.microsoft.com/office/drawing/2014/main" id="{DE26B6B4-7271-4797-9260-024F819C0592}"/>
               </a:ext>
             </a:extLst>
           </p:cNvPr>
@@ -5849,7 +5849,7 @@
           <p:cNvPr id="18" name="">
             <a:extLst xmlns:a="http://schemas.openxmlformats.org/drawingml/2006/main">
               <a:ext uri="{FF2B5EF4-FFF2-40B4-BE49-F238E27FC236}">
-                <a16:creationId xmlns:a16="http://schemas.microsoft.com/office/drawing/2014/main" id="{38FE4C0C-1393-4295-94BB-0AB0B4EE2820}"/>
+                <a16:creationId xmlns:a16="http://schemas.microsoft.com/office/drawing/2014/main" id="{E405314F-1037-4653-9215-08EEF7D6E970}"/>
               </a:ext>
             </a:extLst>
           </p:cNvPr>
@@ -5929,7 +5929,7 @@
           <p:cNvPr id="19" name="">
             <a:extLst xmlns:a="http://schemas.openxmlformats.org/drawingml/2006/main">
               <a:ext uri="{FF2B5EF4-FFF2-40B4-BE49-F238E27FC236}">
-                <a16:creationId xmlns:a16="http://schemas.microsoft.com/office/drawing/2014/main" id="{F2467CEF-5655-43C6-8E23-2ECA3AA684E4}"/>
+                <a16:creationId xmlns:a16="http://schemas.microsoft.com/office/drawing/2014/main" id="{42377FD6-46FC-4E3B-839E-8553C04508F0}"/>
               </a:ext>
             </a:extLst>
           </p:cNvPr>
@@ -5986,7 +5986,7 @@
           <p:cNvPr id="20" name="">
             <a:extLst xmlns:a="http://schemas.openxmlformats.org/drawingml/2006/main">
               <a:ext uri="{FF2B5EF4-FFF2-40B4-BE49-F238E27FC236}">
-                <a16:creationId xmlns:a16="http://schemas.microsoft.com/office/drawing/2014/main" id="{4C08B5B3-6DF9-4FFA-8925-F56A6F4C0C32}"/>
+                <a16:creationId xmlns:a16="http://schemas.microsoft.com/office/drawing/2014/main" id="{BA04CAED-2671-4189-A9E8-3DBC64656046}"/>
               </a:ext>
             </a:extLst>
           </p:cNvPr>
@@ -6041,7 +6041,7 @@
     </p:spTree>
     <p:extLst>
       <p:ext uri="{BB962C8B-B14F-4D97-AF65-F5344CB8AC3E}">
-        <p14:creationId xmlns:p14="http://schemas.microsoft.com/office/powerpoint/2010/main" val="1860346409"/>
+        <p14:creationId xmlns:p14="http://schemas.microsoft.com/office/powerpoint/2010/main" val="1357732233"/>
       </p:ext>
     </p:extLst>
   </p:cSld>
@@ -6072,7 +6072,7 @@
           <p:cNvPr id="15" name="">
             <a:extLst xmlns:a="http://schemas.openxmlformats.org/drawingml/2006/main">
               <a:ext uri="{FF2B5EF4-FFF2-40B4-BE49-F238E27FC236}">
-                <a16:creationId xmlns:a16="http://schemas.microsoft.com/office/drawing/2014/main" id="{0E8F5009-5A16-4957-BF5C-B9FD9E3BF0FF}"/>
+                <a16:creationId xmlns:a16="http://schemas.microsoft.com/office/drawing/2014/main" id="{C4F0ACEF-6D21-4BE2-B024-4B0AE48DBFD5}"/>
               </a:ext>
             </a:extLst>
           </p:cNvPr>
@@ -6102,7 +6102,7 @@
           <p:cNvPr id="2" name="">
             <a:extLst xmlns:a="http://schemas.openxmlformats.org/drawingml/2006/main">
               <a:ext uri="{FF2B5EF4-FFF2-40B4-BE49-F238E27FC236}">
-                <a16:creationId xmlns:a16="http://schemas.microsoft.com/office/drawing/2014/main" id="{3317EA2D-5A85-4DC3-93ED-9DAB6AFD286C}"/>
+                <a16:creationId xmlns:a16="http://schemas.microsoft.com/office/drawing/2014/main" id="{C11A3BA0-E43A-430B-9C1A-8193C36F9721}"/>
               </a:ext>
             </a:extLst>
           </p:cNvPr>
@@ -6159,7 +6159,7 @@
           <p:cNvPr id="3" name="">
             <a:extLst xmlns:a="http://schemas.openxmlformats.org/drawingml/2006/main">
               <a:ext uri="{FF2B5EF4-FFF2-40B4-BE49-F238E27FC236}">
-                <a16:creationId xmlns:a16="http://schemas.microsoft.com/office/drawing/2014/main" id="{309C84BA-9695-4420-BDB1-C24953542178}"/>
+                <a16:creationId xmlns:a16="http://schemas.microsoft.com/office/drawing/2014/main" id="{F0F8BBF3-A8F9-41D8-B4C8-234920051A92}"/>
               </a:ext>
             </a:extLst>
           </p:cNvPr>
@@ -6189,7 +6189,7 @@
           <p:cNvPr id="4" name="">
             <a:extLst xmlns:a="http://schemas.openxmlformats.org/drawingml/2006/main">
               <a:ext uri="{FF2B5EF4-FFF2-40B4-BE49-F238E27FC236}">
-                <a16:creationId xmlns:a16="http://schemas.microsoft.com/office/drawing/2014/main" id="{42A006F3-DA56-4606-AC11-52B38034BE70}"/>
+                <a16:creationId xmlns:a16="http://schemas.microsoft.com/office/drawing/2014/main" id="{66A3DF12-C679-4A88-BB28-D7603F76F89B}"/>
               </a:ext>
             </a:extLst>
           </p:cNvPr>
@@ -6246,7 +6246,7 @@
           <p:cNvPr id="5" name="">
             <a:extLst xmlns:a="http://schemas.openxmlformats.org/drawingml/2006/main">
               <a:ext uri="{FF2B5EF4-FFF2-40B4-BE49-F238E27FC236}">
-                <a16:creationId xmlns:a16="http://schemas.microsoft.com/office/drawing/2014/main" id="{26C989E3-7ED9-4E99-9A2F-1F475315D1D3}"/>
+                <a16:creationId xmlns:a16="http://schemas.microsoft.com/office/drawing/2014/main" id="{F44BC889-51D9-425B-BA25-988BDD38A310}"/>
               </a:ext>
             </a:extLst>
           </p:cNvPr>
@@ -6303,7 +6303,7 @@
           <p:cNvPr id="6" name="">
             <a:extLst xmlns:a="http://schemas.openxmlformats.org/drawingml/2006/main">
               <a:ext uri="{FF2B5EF4-FFF2-40B4-BE49-F238E27FC236}">
-                <a16:creationId xmlns:a16="http://schemas.microsoft.com/office/drawing/2014/main" id="{12271541-4D43-4752-9963-A0231C4290E6}"/>
+                <a16:creationId xmlns:a16="http://schemas.microsoft.com/office/drawing/2014/main" id="{8410A549-A2F5-4F13-98FE-46D3FF1B6DB5}"/>
               </a:ext>
             </a:extLst>
           </p:cNvPr>
@@ -6360,7 +6360,7 @@
           <p:cNvPr id="7" name="">
             <a:extLst xmlns:a="http://schemas.openxmlformats.org/drawingml/2006/main">
               <a:ext uri="{FF2B5EF4-FFF2-40B4-BE49-F238E27FC236}">
-                <a16:creationId xmlns:a16="http://schemas.microsoft.com/office/drawing/2014/main" id="{8587A9A3-9E2C-4149-ACE7-F1CA7FE44DF5}"/>
+                <a16:creationId xmlns:a16="http://schemas.microsoft.com/office/drawing/2014/main" id="{F2A01730-BACB-461D-9403-8B7D45DCB2BB}"/>
               </a:ext>
             </a:extLst>
           </p:cNvPr>
@@ -6390,7 +6390,7 @@
           <p:cNvPr id="8" name="">
             <a:extLst xmlns:a="http://schemas.openxmlformats.org/drawingml/2006/main">
               <a:ext uri="{FF2B5EF4-FFF2-40B4-BE49-F238E27FC236}">
-                <a16:creationId xmlns:a16="http://schemas.microsoft.com/office/drawing/2014/main" id="{06E0E123-5A28-4869-AFD5-07A0DDBCB142}"/>
+                <a16:creationId xmlns:a16="http://schemas.microsoft.com/office/drawing/2014/main" id="{F6A3DD55-DA96-43FF-ACF4-A34869663424}"/>
               </a:ext>
             </a:extLst>
           </p:cNvPr>
@@ -6447,7 +6447,7 @@
           <p:cNvPr id="9" name="">
             <a:extLst xmlns:a="http://schemas.openxmlformats.org/drawingml/2006/main">
               <a:ext uri="{FF2B5EF4-FFF2-40B4-BE49-F238E27FC236}">
-                <a16:creationId xmlns:a16="http://schemas.microsoft.com/office/drawing/2014/main" id="{C9584CBC-DA4E-41CD-99D1-F56D5D424615}"/>
+                <a16:creationId xmlns:a16="http://schemas.microsoft.com/office/drawing/2014/main" id="{7173481D-B406-4BDF-BAF3-02700B5F92EE}"/>
               </a:ext>
             </a:extLst>
           </p:cNvPr>
@@ -6504,7 +6504,7 @@
           <p:cNvPr id="10" name="">
             <a:extLst xmlns:a="http://schemas.openxmlformats.org/drawingml/2006/main">
               <a:ext uri="{FF2B5EF4-FFF2-40B4-BE49-F238E27FC236}">
-                <a16:creationId xmlns:a16="http://schemas.microsoft.com/office/drawing/2014/main" id="{6E4F8F82-752D-453A-85EE-A6B8E8CF2898}"/>
+                <a16:creationId xmlns:a16="http://schemas.microsoft.com/office/drawing/2014/main" id="{D20EB127-8223-4C05-849F-D35DBB068FF1}"/>
               </a:ext>
             </a:extLst>
           </p:cNvPr>
@@ -6534,7 +6534,7 @@
           <p:cNvPr id="11" name="">
             <a:extLst xmlns:a="http://schemas.openxmlformats.org/drawingml/2006/main">
               <a:ext uri="{FF2B5EF4-FFF2-40B4-BE49-F238E27FC236}">
-                <a16:creationId xmlns:a16="http://schemas.microsoft.com/office/drawing/2014/main" id="{26911DE6-0C2C-4830-99BC-631A6AD5A41A}"/>
+                <a16:creationId xmlns:a16="http://schemas.microsoft.com/office/drawing/2014/main" id="{F4038418-9FE4-48E6-8A1D-5D15E1703B69}"/>
               </a:ext>
             </a:extLst>
           </p:cNvPr>
@@ -6591,7 +6591,7 @@
           <p:cNvPr id="12" name="">
             <a:extLst xmlns:a="http://schemas.openxmlformats.org/drawingml/2006/main">
               <a:ext uri="{FF2B5EF4-FFF2-40B4-BE49-F238E27FC236}">
-                <a16:creationId xmlns:a16="http://schemas.microsoft.com/office/drawing/2014/main" id="{0DB03915-0A27-4EED-A0C7-160336D66933}"/>
+                <a16:creationId xmlns:a16="http://schemas.microsoft.com/office/drawing/2014/main" id="{D70DE86A-2558-42DE-9307-77FC80D6B7CE}"/>
               </a:ext>
             </a:extLst>
           </p:cNvPr>
@@ -6648,7 +6648,7 @@
           <p:cNvPr id="13" name="">
             <a:extLst xmlns:a="http://schemas.openxmlformats.org/drawingml/2006/main">
               <a:ext uri="{FF2B5EF4-FFF2-40B4-BE49-F238E27FC236}">
-                <a16:creationId xmlns:a16="http://schemas.microsoft.com/office/drawing/2014/main" id="{FD90B609-437D-48F8-8862-9700DC598E51}"/>
+                <a16:creationId xmlns:a16="http://schemas.microsoft.com/office/drawing/2014/main" id="{D616B5CD-31B7-40F3-A077-1B48785D509B}"/>
               </a:ext>
             </a:extLst>
           </p:cNvPr>
@@ -6678,7 +6678,7 @@
           <p:cNvPr id="14" name="">
             <a:extLst xmlns:a="http://schemas.openxmlformats.org/drawingml/2006/main">
               <a:ext uri="{FF2B5EF4-FFF2-40B4-BE49-F238E27FC236}">
-                <a16:creationId xmlns:a16="http://schemas.microsoft.com/office/drawing/2014/main" id="{45245DC4-E45F-48E6-9080-7361A0392CC5}"/>
+                <a16:creationId xmlns:a16="http://schemas.microsoft.com/office/drawing/2014/main" id="{0E9C092A-E26C-4EA7-8B6B-F3E4BC15FCC4}"/>
               </a:ext>
             </a:extLst>
           </p:cNvPr>
@@ -6733,7 +6733,7 @@
     </p:spTree>
     <p:extLst>
       <p:ext uri="{BB962C8B-B14F-4D97-AF65-F5344CB8AC3E}">
-        <p14:creationId xmlns:p14="http://schemas.microsoft.com/office/powerpoint/2010/main" val="560443876"/>
+        <p14:creationId xmlns:p14="http://schemas.microsoft.com/office/powerpoint/2010/main" val="246688590"/>
       </p:ext>
     </p:extLst>
   </p:cSld>
@@ -6764,7 +6764,7 @@
           <p:cNvPr id="18" name="">
             <a:extLst xmlns:a="http://schemas.openxmlformats.org/drawingml/2006/main">
               <a:ext uri="{FF2B5EF4-FFF2-40B4-BE49-F238E27FC236}">
-                <a16:creationId xmlns:a16="http://schemas.microsoft.com/office/drawing/2014/main" id="{7E5A0BF4-9DC1-4B03-9B46-C22D99F90658}"/>
+                <a16:creationId xmlns:a16="http://schemas.microsoft.com/office/drawing/2014/main" id="{A70F5089-CA32-497D-91E1-1E1F90E8A915}"/>
               </a:ext>
             </a:extLst>
           </p:cNvPr>
@@ -6794,7 +6794,7 @@
           <p:cNvPr id="2" name="">
             <a:extLst xmlns:a="http://schemas.openxmlformats.org/drawingml/2006/main">
               <a:ext uri="{FF2B5EF4-FFF2-40B4-BE49-F238E27FC236}">
-                <a16:creationId xmlns:a16="http://schemas.microsoft.com/office/drawing/2014/main" id="{69C1ADF2-05F8-489E-973F-5B459A56D93B}"/>
+                <a16:creationId xmlns:a16="http://schemas.microsoft.com/office/drawing/2014/main" id="{8A64A8A2-5D38-4648-AF1F-4598F63E8A32}"/>
               </a:ext>
             </a:extLst>
           </p:cNvPr>
@@ -6851,7 +6851,7 @@
           <p:cNvPr id="3" name="">
             <a:extLst xmlns:a="http://schemas.openxmlformats.org/drawingml/2006/main">
               <a:ext uri="{FF2B5EF4-FFF2-40B4-BE49-F238E27FC236}">
-                <a16:creationId xmlns:a16="http://schemas.microsoft.com/office/drawing/2014/main" id="{AC44D693-C347-4748-B6B6-3411F05EADF5}"/>
+                <a16:creationId xmlns:a16="http://schemas.microsoft.com/office/drawing/2014/main" id="{4908BF2B-6F40-496D-A8BA-67D88DB6CDF3}"/>
               </a:ext>
             </a:extLst>
           </p:cNvPr>
@@ -6881,7 +6881,7 @@
           <p:cNvPr id="4" name="">
             <a:extLst xmlns:a="http://schemas.openxmlformats.org/drawingml/2006/main">
               <a:ext uri="{FF2B5EF4-FFF2-40B4-BE49-F238E27FC236}">
-                <a16:creationId xmlns:a16="http://schemas.microsoft.com/office/drawing/2014/main" id="{2076E79C-1279-48AE-8E10-F86F21D472E1}"/>
+                <a16:creationId xmlns:a16="http://schemas.microsoft.com/office/drawing/2014/main" id="{2EC85170-ED98-4282-8942-15F563533693}"/>
               </a:ext>
             </a:extLst>
           </p:cNvPr>
@@ -6938,7 +6938,7 @@
           <p:cNvPr id="5" name="">
             <a:extLst xmlns:a="http://schemas.openxmlformats.org/drawingml/2006/main">
               <a:ext uri="{FF2B5EF4-FFF2-40B4-BE49-F238E27FC236}">
-                <a16:creationId xmlns:a16="http://schemas.microsoft.com/office/drawing/2014/main" id="{B57B200F-8BA7-4C3E-AB37-5C8DD8963379}"/>
+                <a16:creationId xmlns:a16="http://schemas.microsoft.com/office/drawing/2014/main" id="{2486D707-4B99-43B6-9E0D-8779E9E11605}"/>
               </a:ext>
             </a:extLst>
           </p:cNvPr>
@@ -6995,7 +6995,7 @@
           <p:cNvPr id="6" name="">
             <a:extLst xmlns:a="http://schemas.openxmlformats.org/drawingml/2006/main">
               <a:ext uri="{FF2B5EF4-FFF2-40B4-BE49-F238E27FC236}">
-                <a16:creationId xmlns:a16="http://schemas.microsoft.com/office/drawing/2014/main" id="{DC1109BD-204D-4687-9F42-78001271D375}"/>
+                <a16:creationId xmlns:a16="http://schemas.microsoft.com/office/drawing/2014/main" id="{1EC8ECD1-5CF0-469C-A00E-AE8E457277AA}"/>
               </a:ext>
             </a:extLst>
           </p:cNvPr>
@@ -7052,7 +7052,7 @@
           <p:cNvPr id="7" name="">
             <a:extLst xmlns:a="http://schemas.openxmlformats.org/drawingml/2006/main">
               <a:ext uri="{FF2B5EF4-FFF2-40B4-BE49-F238E27FC236}">
-                <a16:creationId xmlns:a16="http://schemas.microsoft.com/office/drawing/2014/main" id="{38F255F3-3A40-4309-B84F-CD5E94F1EC98}"/>
+                <a16:creationId xmlns:a16="http://schemas.microsoft.com/office/drawing/2014/main" id="{7612F32E-E1F0-4BB6-8419-E59FFE47F718}"/>
               </a:ext>
             </a:extLst>
           </p:cNvPr>
@@ -7109,7 +7109,7 @@
           <p:cNvPr id="8" name="">
             <a:extLst xmlns:a="http://schemas.openxmlformats.org/drawingml/2006/main">
               <a:ext uri="{FF2B5EF4-FFF2-40B4-BE49-F238E27FC236}">
-                <a16:creationId xmlns:a16="http://schemas.microsoft.com/office/drawing/2014/main" id="{376D2C89-7F50-467E-A8B3-C5E7002B8365}"/>
+                <a16:creationId xmlns:a16="http://schemas.microsoft.com/office/drawing/2014/main" id="{AB240249-4627-490F-B147-A04D441C9000}"/>
               </a:ext>
             </a:extLst>
           </p:cNvPr>
@@ -7166,7 +7166,7 @@
           <p:cNvPr id="9" name="">
             <a:extLst xmlns:a="http://schemas.openxmlformats.org/drawingml/2006/main">
               <a:ext uri="{FF2B5EF4-FFF2-40B4-BE49-F238E27FC236}">
-                <a16:creationId xmlns:a16="http://schemas.microsoft.com/office/drawing/2014/main" id="{08266346-4534-4DDF-9225-0B5436629553}"/>
+                <a16:creationId xmlns:a16="http://schemas.microsoft.com/office/drawing/2014/main" id="{4D9D4680-B2A9-43AF-8123-3A4DADE513C4}"/>
               </a:ext>
             </a:extLst>
           </p:cNvPr>
@@ -7196,7 +7196,7 @@
           <p:cNvPr id="10" name="">
             <a:extLst xmlns:a="http://schemas.openxmlformats.org/drawingml/2006/main">
               <a:ext uri="{FF2B5EF4-FFF2-40B4-BE49-F238E27FC236}">
-                <a16:creationId xmlns:a16="http://schemas.microsoft.com/office/drawing/2014/main" id="{092BA08B-458B-4C20-A169-C871BE597885}"/>
+                <a16:creationId xmlns:a16="http://schemas.microsoft.com/office/drawing/2014/main" id="{AEA3A379-84C1-4681-97D9-1B0942B590B7}"/>
               </a:ext>
             </a:extLst>
           </p:cNvPr>
@@ -7253,7 +7253,7 @@
           <p:cNvPr id="11" name="">
             <a:extLst xmlns:a="http://schemas.openxmlformats.org/drawingml/2006/main">
               <a:ext uri="{FF2B5EF4-FFF2-40B4-BE49-F238E27FC236}">
-                <a16:creationId xmlns:a16="http://schemas.microsoft.com/office/drawing/2014/main" id="{0B371E5D-6C86-4AEB-8CCB-1BD66E6F8099}"/>
+                <a16:creationId xmlns:a16="http://schemas.microsoft.com/office/drawing/2014/main" id="{01AA4DE8-2BE9-4A7E-9FBD-07849BE2E8D8}"/>
               </a:ext>
             </a:extLst>
           </p:cNvPr>
@@ -7310,7 +7310,7 @@
           <p:cNvPr id="12" name="">
             <a:extLst xmlns:a="http://schemas.openxmlformats.org/drawingml/2006/main">
               <a:ext uri="{FF2B5EF4-FFF2-40B4-BE49-F238E27FC236}">
-                <a16:creationId xmlns:a16="http://schemas.microsoft.com/office/drawing/2014/main" id="{AFD71A96-A9FF-482D-899C-1BF2E951FEF1}"/>
+                <a16:creationId xmlns:a16="http://schemas.microsoft.com/office/drawing/2014/main" id="{058F3D37-1BD0-4227-8EBB-DF2C949B963B}"/>
               </a:ext>
             </a:extLst>
           </p:cNvPr>
@@ -7357,7 +7357,7 @@
                 <a:ea typeface="Noto Sans KR"/>
                 <a:cs typeface="Noto Sans KR"/>
               </a:rPr>
-              <a:t>3명 관찰과 5명 시험으로 막히는 위치와 시간 단축을 확인</a:t>
+              <a:t>자료를 정리하고 결과물로 만드는 시간이 실제로 줄어드는지 확인</a:t>
             </a:r>
           </a:p>
         </p:txBody>
@@ -7367,7 +7367,7 @@
           <p:cNvPr id="13" name="">
             <a:extLst xmlns:a="http://schemas.openxmlformats.org/drawingml/2006/main">
               <a:ext uri="{FF2B5EF4-FFF2-40B4-BE49-F238E27FC236}">
-                <a16:creationId xmlns:a16="http://schemas.microsoft.com/office/drawing/2014/main" id="{B9AB395D-0E1A-4037-9FFD-4960804D5BC0}"/>
+                <a16:creationId xmlns:a16="http://schemas.microsoft.com/office/drawing/2014/main" id="{E7BDDF81-674A-4E82-8DA7-6BFDCB07110C}"/>
               </a:ext>
             </a:extLst>
           </p:cNvPr>
@@ -7424,7 +7424,7 @@
           <p:cNvPr id="14" name="">
             <a:extLst xmlns:a="http://schemas.openxmlformats.org/drawingml/2006/main">
               <a:ext uri="{FF2B5EF4-FFF2-40B4-BE49-F238E27FC236}">
-                <a16:creationId xmlns:a16="http://schemas.microsoft.com/office/drawing/2014/main" id="{A7EB0065-F287-4ED0-B6D7-D3E8555FB980}"/>
+                <a16:creationId xmlns:a16="http://schemas.microsoft.com/office/drawing/2014/main" id="{7CA446A1-E607-4C36-BA9A-A66C452B2F51}"/>
               </a:ext>
             </a:extLst>
           </p:cNvPr>
@@ -7471,7 +7471,7 @@
                 <a:ea typeface="Noto Sans KR"/>
                 <a:cs typeface="Noto Sans KR"/>
               </a:rPr>
-              <a:t>여러 사용자가 쓰는 단계에서 계정 로그인과 사용자별 기록 권한 구현</a:t>
+              <a:t>나만 쓰는 서비스에서 다양한 사람이 쓰는 범용 서비스로 확장</a:t>
             </a:r>
           </a:p>
         </p:txBody>
@@ -7481,7 +7481,7 @@
           <p:cNvPr id="15" name="">
             <a:extLst xmlns:a="http://schemas.openxmlformats.org/drawingml/2006/main">
               <a:ext uri="{FF2B5EF4-FFF2-40B4-BE49-F238E27FC236}">
-                <a16:creationId xmlns:a16="http://schemas.microsoft.com/office/drawing/2014/main" id="{A5D3229B-A237-459D-A718-622F4BB75A49}"/>
+                <a16:creationId xmlns:a16="http://schemas.microsoft.com/office/drawing/2014/main" id="{8188788F-0EA2-448F-9754-378DA2837E9A}"/>
               </a:ext>
             </a:extLst>
           </p:cNvPr>
@@ -7538,7 +7538,7 @@
           <p:cNvPr id="16" name="">
             <a:extLst xmlns:a="http://schemas.openxmlformats.org/drawingml/2006/main">
               <a:ext uri="{FF2B5EF4-FFF2-40B4-BE49-F238E27FC236}">
-                <a16:creationId xmlns:a16="http://schemas.microsoft.com/office/drawing/2014/main" id="{AB1EC055-43D2-4035-9351-DF340169FD17}"/>
+                <a16:creationId xmlns:a16="http://schemas.microsoft.com/office/drawing/2014/main" id="{831A4C84-0460-408E-B126-9278B048F528}"/>
               </a:ext>
             </a:extLst>
           </p:cNvPr>
@@ -7595,7 +7595,7 @@
           <p:cNvPr id="17" name="">
             <a:extLst xmlns:a="http://schemas.openxmlformats.org/drawingml/2006/main">
               <a:ext uri="{FF2B5EF4-FFF2-40B4-BE49-F238E27FC236}">
-                <a16:creationId xmlns:a16="http://schemas.microsoft.com/office/drawing/2014/main" id="{55906AF3-856A-4A47-B98B-340DD49C1CBC}"/>
+                <a16:creationId xmlns:a16="http://schemas.microsoft.com/office/drawing/2014/main" id="{6D1113F1-EB1F-46B9-A66E-C99548B3D2ED}"/>
               </a:ext>
             </a:extLst>
           </p:cNvPr>
@@ -7642,7 +7642,7 @@
                 <a:ea typeface="Noto Sans KR"/>
                 <a:cs typeface="Noto Sans KR"/>
               </a:rPr>
-              <a:t>검증 결과를 확인한 뒤 필요한 기능부터 구현하겠습니다</a:t>
+              <a:t>시간 단축을 확인하고, 다양한 사람이 쓸 수 있는 서비스로 확장하겠습니다</a:t>
             </a:r>
           </a:p>
         </p:txBody>
@@ -7650,7 +7650,7 @@
     </p:spTree>
     <p:extLst>
       <p:ext uri="{BB962C8B-B14F-4D97-AF65-F5344CB8AC3E}">
-        <p14:creationId xmlns:p14="http://schemas.microsoft.com/office/powerpoint/2010/main" val="622870741"/>
+        <p14:creationId xmlns:p14="http://schemas.microsoft.com/office/powerpoint/2010/main" val="1507994638"/>
       </p:ext>
     </p:extLst>
   </p:cSld>
@@ -7681,7 +7681,7 @@
           <p:cNvPr id="19" name="">
             <a:extLst xmlns:a="http://schemas.openxmlformats.org/drawingml/2006/main">
               <a:ext uri="{FF2B5EF4-FFF2-40B4-BE49-F238E27FC236}">
-                <a16:creationId xmlns:a16="http://schemas.microsoft.com/office/drawing/2014/main" id="{0D809E80-7F4B-4A9B-9C28-5865EBBB4796}"/>
+                <a16:creationId xmlns:a16="http://schemas.microsoft.com/office/drawing/2014/main" id="{26E321D3-56F0-495E-93CB-BAC82FEB5598}"/>
               </a:ext>
             </a:extLst>
           </p:cNvPr>
@@ -7711,7 +7711,7 @@
           <p:cNvPr id="2" name="">
             <a:extLst xmlns:a="http://schemas.openxmlformats.org/drawingml/2006/main">
               <a:ext uri="{FF2B5EF4-FFF2-40B4-BE49-F238E27FC236}">
-                <a16:creationId xmlns:a16="http://schemas.microsoft.com/office/drawing/2014/main" id="{76517AC6-201A-4D9A-9AA1-8EA2BCB86660}"/>
+                <a16:creationId xmlns:a16="http://schemas.microsoft.com/office/drawing/2014/main" id="{2B1F6AF4-AB14-49E5-B903-2308F9695C5D}"/>
               </a:ext>
             </a:extLst>
           </p:cNvPr>
@@ -7768,7 +7768,7 @@
           <p:cNvPr id="3" name="">
             <a:extLst xmlns:a="http://schemas.openxmlformats.org/drawingml/2006/main">
               <a:ext uri="{FF2B5EF4-FFF2-40B4-BE49-F238E27FC236}">
-                <a16:creationId xmlns:a16="http://schemas.microsoft.com/office/drawing/2014/main" id="{60FF1A6D-AE90-4522-A5A3-FCF996261809}"/>
+                <a16:creationId xmlns:a16="http://schemas.microsoft.com/office/drawing/2014/main" id="{82B5B03D-2D66-4869-8444-E9C83EBE9AEA}"/>
               </a:ext>
             </a:extLst>
           </p:cNvPr>
@@ -7798,7 +7798,7 @@
           <p:cNvPr id="4" name="">
             <a:extLst xmlns:a="http://schemas.openxmlformats.org/drawingml/2006/main">
               <a:ext uri="{FF2B5EF4-FFF2-40B4-BE49-F238E27FC236}">
-                <a16:creationId xmlns:a16="http://schemas.microsoft.com/office/drawing/2014/main" id="{1E25333D-3CD6-4F00-99EF-5364605BF191}"/>
+                <a16:creationId xmlns:a16="http://schemas.microsoft.com/office/drawing/2014/main" id="{E1585D15-E90B-4A18-A5F8-FD479937A73F}"/>
               </a:ext>
             </a:extLst>
           </p:cNvPr>
@@ -7855,7 +7855,7 @@
           <p:cNvPr id="5" name="">
             <a:extLst xmlns:a="http://schemas.openxmlformats.org/drawingml/2006/main">
               <a:ext uri="{FF2B5EF4-FFF2-40B4-BE49-F238E27FC236}">
-                <a16:creationId xmlns:a16="http://schemas.microsoft.com/office/drawing/2014/main" id="{80EFDD51-9818-4778-B290-8219CEB081B7}"/>
+                <a16:creationId xmlns:a16="http://schemas.microsoft.com/office/drawing/2014/main" id="{42725042-B53E-4987-BB34-72CF0B442E83}"/>
               </a:ext>
             </a:extLst>
           </p:cNvPr>
@@ -7912,7 +7912,7 @@
           <p:cNvPr id="6" name="">
             <a:extLst xmlns:a="http://schemas.openxmlformats.org/drawingml/2006/main">
               <a:ext uri="{FF2B5EF4-FFF2-40B4-BE49-F238E27FC236}">
-                <a16:creationId xmlns:a16="http://schemas.microsoft.com/office/drawing/2014/main" id="{C5681EAB-1E9A-4569-8B1E-1A68850D40F2}"/>
+                <a16:creationId xmlns:a16="http://schemas.microsoft.com/office/drawing/2014/main" id="{07D1E8CD-850B-4530-810E-5C54C8168A66}"/>
               </a:ext>
             </a:extLst>
           </p:cNvPr>
@@ -7992,7 +7992,7 @@
           <p:cNvPr id="7" name="">
             <a:extLst xmlns:a="http://schemas.openxmlformats.org/drawingml/2006/main">
               <a:ext uri="{FF2B5EF4-FFF2-40B4-BE49-F238E27FC236}">
-                <a16:creationId xmlns:a16="http://schemas.microsoft.com/office/drawing/2014/main" id="{BE56AC31-8223-4DE0-B173-48C39FCB1FF8}"/>
+                <a16:creationId xmlns:a16="http://schemas.microsoft.com/office/drawing/2014/main" id="{83F92DBC-00FC-44F5-B362-350B8C1B3529}"/>
               </a:ext>
             </a:extLst>
           </p:cNvPr>
@@ -8049,7 +8049,7 @@
           <p:cNvPr id="8" name="">
             <a:extLst xmlns:a="http://schemas.openxmlformats.org/drawingml/2006/main">
               <a:ext uri="{FF2B5EF4-FFF2-40B4-BE49-F238E27FC236}">
-                <a16:creationId xmlns:a16="http://schemas.microsoft.com/office/drawing/2014/main" id="{DE91129E-9046-460E-9D15-771742A51737}"/>
+                <a16:creationId xmlns:a16="http://schemas.microsoft.com/office/drawing/2014/main" id="{DE052FAA-C136-4D94-B74B-2A8738799D28}"/>
               </a:ext>
             </a:extLst>
           </p:cNvPr>
@@ -8129,7 +8129,7 @@
           <p:cNvPr id="9" name="">
             <a:extLst xmlns:a="http://schemas.openxmlformats.org/drawingml/2006/main">
               <a:ext uri="{FF2B5EF4-FFF2-40B4-BE49-F238E27FC236}">
-                <a16:creationId xmlns:a16="http://schemas.microsoft.com/office/drawing/2014/main" id="{4C91B3F4-BFC5-4579-8D4D-8A4368886A22}"/>
+                <a16:creationId xmlns:a16="http://schemas.microsoft.com/office/drawing/2014/main" id="{3DE10CAF-7E3E-44FA-9B8F-C73BB4E032F7}"/>
               </a:ext>
             </a:extLst>
           </p:cNvPr>
@@ -8186,7 +8186,7 @@
           <p:cNvPr id="10" name="">
             <a:extLst xmlns:a="http://schemas.openxmlformats.org/drawingml/2006/main">
               <a:ext uri="{FF2B5EF4-FFF2-40B4-BE49-F238E27FC236}">
-                <a16:creationId xmlns:a16="http://schemas.microsoft.com/office/drawing/2014/main" id="{876DED59-8F44-4D12-BFB8-3F54E58F6371}"/>
+                <a16:creationId xmlns:a16="http://schemas.microsoft.com/office/drawing/2014/main" id="{B185D1BB-7756-4179-B3CF-E9CCB875CE96}"/>
               </a:ext>
             </a:extLst>
           </p:cNvPr>
@@ -8289,7 +8289,7 @@
           <p:cNvPr id="11" name="">
             <a:extLst xmlns:a="http://schemas.openxmlformats.org/drawingml/2006/main">
               <a:ext uri="{FF2B5EF4-FFF2-40B4-BE49-F238E27FC236}">
-                <a16:creationId xmlns:a16="http://schemas.microsoft.com/office/drawing/2014/main" id="{F08FF74B-C0DA-43BF-B18B-69A52B789BF2}"/>
+                <a16:creationId xmlns:a16="http://schemas.microsoft.com/office/drawing/2014/main" id="{FF58728B-17B6-4D8D-BAE8-A82CDA1C872F}"/>
               </a:ext>
             </a:extLst>
           </p:cNvPr>
@@ -8346,7 +8346,7 @@
           <p:cNvPr id="12" name="">
             <a:extLst xmlns:a="http://schemas.openxmlformats.org/drawingml/2006/main">
               <a:ext uri="{FF2B5EF4-FFF2-40B4-BE49-F238E27FC236}">
-                <a16:creationId xmlns:a16="http://schemas.microsoft.com/office/drawing/2014/main" id="{07E2AEBE-9DE1-4D87-B338-2EF35ACEB959}"/>
+                <a16:creationId xmlns:a16="http://schemas.microsoft.com/office/drawing/2014/main" id="{AB5AC6DE-3003-417A-A955-4434BD26B4F8}"/>
               </a:ext>
             </a:extLst>
           </p:cNvPr>
@@ -8449,7 +8449,7 @@
           <p:cNvPr id="13" name="">
             <a:extLst xmlns:a="http://schemas.openxmlformats.org/drawingml/2006/main">
               <a:ext uri="{FF2B5EF4-FFF2-40B4-BE49-F238E27FC236}">
-                <a16:creationId xmlns:a16="http://schemas.microsoft.com/office/drawing/2014/main" id="{5A0F4B83-8E4A-425D-925E-B32B02CF25CB}"/>
+                <a16:creationId xmlns:a16="http://schemas.microsoft.com/office/drawing/2014/main" id="{E368CF16-165D-435B-BA37-95D9C4E94841}"/>
               </a:ext>
             </a:extLst>
           </p:cNvPr>
@@ -8506,7 +8506,7 @@
           <p:cNvPr id="14" name="">
             <a:extLst xmlns:a="http://schemas.openxmlformats.org/drawingml/2006/main">
               <a:ext uri="{FF2B5EF4-FFF2-40B4-BE49-F238E27FC236}">
-                <a16:creationId xmlns:a16="http://schemas.microsoft.com/office/drawing/2014/main" id="{1D6FC5DF-D4CE-4F00-89C4-7B7CAF6BCB57}"/>
+                <a16:creationId xmlns:a16="http://schemas.microsoft.com/office/drawing/2014/main" id="{450FC0BA-C92D-446A-9530-EF2FD2228257}"/>
               </a:ext>
             </a:extLst>
           </p:cNvPr>
@@ -8563,7 +8563,7 @@
           <p:cNvPr id="15" name="">
             <a:extLst xmlns:a="http://schemas.openxmlformats.org/drawingml/2006/main">
               <a:ext uri="{FF2B5EF4-FFF2-40B4-BE49-F238E27FC236}">
-                <a16:creationId xmlns:a16="http://schemas.microsoft.com/office/drawing/2014/main" id="{8E8FE15D-E32C-405E-9023-A9259F88A469}"/>
+                <a16:creationId xmlns:a16="http://schemas.microsoft.com/office/drawing/2014/main" id="{F9DA20A1-65C4-4922-81EF-6D7A1F828C21}"/>
               </a:ext>
             </a:extLst>
           </p:cNvPr>
@@ -8620,7 +8620,7 @@
           <p:cNvPr id="16" name="">
             <a:extLst xmlns:a="http://schemas.openxmlformats.org/drawingml/2006/main">
               <a:ext uri="{FF2B5EF4-FFF2-40B4-BE49-F238E27FC236}">
-                <a16:creationId xmlns:a16="http://schemas.microsoft.com/office/drawing/2014/main" id="{2502DF1B-AA10-4663-8519-B9796973A113}"/>
+                <a16:creationId xmlns:a16="http://schemas.microsoft.com/office/drawing/2014/main" id="{2DFD441E-9931-4D1F-8B7A-75C6B93A2437}"/>
               </a:ext>
             </a:extLst>
           </p:cNvPr>
@@ -8650,7 +8650,7 @@
           <p:cNvPr id="17" name="">
             <a:extLst xmlns:a="http://schemas.openxmlformats.org/drawingml/2006/main">
               <a:ext uri="{FF2B5EF4-FFF2-40B4-BE49-F238E27FC236}">
-                <a16:creationId xmlns:a16="http://schemas.microsoft.com/office/drawing/2014/main" id="{64FC5DD0-E4B7-47D7-A69F-A5B55E9BE235}"/>
+                <a16:creationId xmlns:a16="http://schemas.microsoft.com/office/drawing/2014/main" id="{11A56493-7CF8-4D9B-9A18-470E6547ED37}"/>
               </a:ext>
             </a:extLst>
           </p:cNvPr>
@@ -8707,7 +8707,7 @@
           <p:cNvPr id="18" name="">
             <a:extLst xmlns:a="http://schemas.openxmlformats.org/drawingml/2006/main">
               <a:ext uri="{FF2B5EF4-FFF2-40B4-BE49-F238E27FC236}">
-                <a16:creationId xmlns:a16="http://schemas.microsoft.com/office/drawing/2014/main" id="{EAC6106A-70DE-4CB6-87F8-D0D65F3FA019}"/>
+                <a16:creationId xmlns:a16="http://schemas.microsoft.com/office/drawing/2014/main" id="{DE0E13AA-8BE4-4F72-987B-47ADD65114A8}"/>
               </a:ext>
             </a:extLst>
           </p:cNvPr>
@@ -8785,7 +8785,7 @@
     </p:spTree>
     <p:extLst>
       <p:ext uri="{BB962C8B-B14F-4D97-AF65-F5344CB8AC3E}">
-        <p14:creationId xmlns:p14="http://schemas.microsoft.com/office/powerpoint/2010/main" val="1834696863"/>
+        <p14:creationId xmlns:p14="http://schemas.microsoft.com/office/powerpoint/2010/main" val="1728074684"/>
       </p:ext>
     </p:extLst>
   </p:cSld>
@@ -8816,7 +8816,7 @@
           <p:cNvPr id="19" name="">
             <a:extLst xmlns:a="http://schemas.openxmlformats.org/drawingml/2006/main">
               <a:ext uri="{FF2B5EF4-FFF2-40B4-BE49-F238E27FC236}">
-                <a16:creationId xmlns:a16="http://schemas.microsoft.com/office/drawing/2014/main" id="{DF0F2D52-B5C1-460D-8050-584B2939BCE9}"/>
+                <a16:creationId xmlns:a16="http://schemas.microsoft.com/office/drawing/2014/main" id="{7049B9E9-BA78-485D-9FDA-834199107F7A}"/>
               </a:ext>
             </a:extLst>
           </p:cNvPr>
@@ -8846,7 +8846,7 @@
           <p:cNvPr id="2" name="">
             <a:extLst xmlns:a="http://schemas.openxmlformats.org/drawingml/2006/main">
               <a:ext uri="{FF2B5EF4-FFF2-40B4-BE49-F238E27FC236}">
-                <a16:creationId xmlns:a16="http://schemas.microsoft.com/office/drawing/2014/main" id="{9F9B99EB-0490-4122-B67B-CFE66C5B87B0}"/>
+                <a16:creationId xmlns:a16="http://schemas.microsoft.com/office/drawing/2014/main" id="{1C0882BE-EDC0-4B63-8938-5874C79B4EDA}"/>
               </a:ext>
             </a:extLst>
           </p:cNvPr>
@@ -8903,7 +8903,7 @@
           <p:cNvPr id="3" name="">
             <a:extLst xmlns:a="http://schemas.openxmlformats.org/drawingml/2006/main">
               <a:ext uri="{FF2B5EF4-FFF2-40B4-BE49-F238E27FC236}">
-                <a16:creationId xmlns:a16="http://schemas.microsoft.com/office/drawing/2014/main" id="{FFA6EA54-2D3D-44EE-AEA4-64DC643C9E0F}"/>
+                <a16:creationId xmlns:a16="http://schemas.microsoft.com/office/drawing/2014/main" id="{FCCA2FEA-FF22-4AB2-8583-43815A83B687}"/>
               </a:ext>
             </a:extLst>
           </p:cNvPr>
@@ -8933,7 +8933,7 @@
           <p:cNvPr id="4" name="">
             <a:extLst xmlns:a="http://schemas.openxmlformats.org/drawingml/2006/main">
               <a:ext uri="{FF2B5EF4-FFF2-40B4-BE49-F238E27FC236}">
-                <a16:creationId xmlns:a16="http://schemas.microsoft.com/office/drawing/2014/main" id="{E0484149-FA7B-4A7E-A964-DF788392EDBD}"/>
+                <a16:creationId xmlns:a16="http://schemas.microsoft.com/office/drawing/2014/main" id="{09B0CF55-130F-4E81-A8B9-691C61F62DF7}"/>
               </a:ext>
             </a:extLst>
           </p:cNvPr>
@@ -8990,7 +8990,7 @@
           <p:cNvPr id="5" name="">
             <a:extLst xmlns:a="http://schemas.openxmlformats.org/drawingml/2006/main">
               <a:ext uri="{FF2B5EF4-FFF2-40B4-BE49-F238E27FC236}">
-                <a16:creationId xmlns:a16="http://schemas.microsoft.com/office/drawing/2014/main" id="{E4D7FA79-8EF2-480B-B3A2-5F4C18CC03A1}"/>
+                <a16:creationId xmlns:a16="http://schemas.microsoft.com/office/drawing/2014/main" id="{ECA7CAA1-45BB-4915-B282-9594832FC51D}"/>
               </a:ext>
             </a:extLst>
           </p:cNvPr>
@@ -9047,7 +9047,7 @@
           <p:cNvPr id="6" name="">
             <a:extLst xmlns:a="http://schemas.openxmlformats.org/drawingml/2006/main">
               <a:ext uri="{FF2B5EF4-FFF2-40B4-BE49-F238E27FC236}">
-                <a16:creationId xmlns:a16="http://schemas.microsoft.com/office/drawing/2014/main" id="{6CCEB68B-912A-4714-8A00-801D3179A5F7}"/>
+                <a16:creationId xmlns:a16="http://schemas.microsoft.com/office/drawing/2014/main" id="{568A602E-4FF5-43D9-8ABD-50A994A53B28}"/>
               </a:ext>
             </a:extLst>
           </p:cNvPr>
@@ -9104,7 +9104,7 @@
           <p:cNvPr id="7" name="">
             <a:extLst xmlns:a="http://schemas.openxmlformats.org/drawingml/2006/main">
               <a:ext uri="{FF2B5EF4-FFF2-40B4-BE49-F238E27FC236}">
-                <a16:creationId xmlns:a16="http://schemas.microsoft.com/office/drawing/2014/main" id="{D8E78EA0-9C1A-4B3E-BC30-CB30EAAAE552}"/>
+                <a16:creationId xmlns:a16="http://schemas.microsoft.com/office/drawing/2014/main" id="{83CE1E16-F227-40DC-A9C0-CE2EA1B14B9D}"/>
               </a:ext>
             </a:extLst>
           </p:cNvPr>
@@ -9184,7 +9184,7 @@
           <p:cNvPr id="8" name="">
             <a:extLst xmlns:a="http://schemas.openxmlformats.org/drawingml/2006/main">
               <a:ext uri="{FF2B5EF4-FFF2-40B4-BE49-F238E27FC236}">
-                <a16:creationId xmlns:a16="http://schemas.microsoft.com/office/drawing/2014/main" id="{7051A078-7F98-4A60-B7D7-6A4DDAE70CA7}"/>
+                <a16:creationId xmlns:a16="http://schemas.microsoft.com/office/drawing/2014/main" id="{207926FC-59FF-4477-AF86-F4D77714062A}"/>
               </a:ext>
             </a:extLst>
           </p:cNvPr>
@@ -9214,7 +9214,7 @@
           <p:cNvPr id="9" name="">
             <a:extLst xmlns:a="http://schemas.openxmlformats.org/drawingml/2006/main">
               <a:ext uri="{FF2B5EF4-FFF2-40B4-BE49-F238E27FC236}">
-                <a16:creationId xmlns:a16="http://schemas.microsoft.com/office/drawing/2014/main" id="{2E0299BB-00B5-4712-A3CE-2CBA94B65AEB}"/>
+                <a16:creationId xmlns:a16="http://schemas.microsoft.com/office/drawing/2014/main" id="{A4C38AAE-0D82-421F-9AD0-9402178D885A}"/>
               </a:ext>
             </a:extLst>
           </p:cNvPr>
@@ -9271,7 +9271,7 @@
           <p:cNvPr id="10" name="">
             <a:extLst xmlns:a="http://schemas.openxmlformats.org/drawingml/2006/main">
               <a:ext uri="{FF2B5EF4-FFF2-40B4-BE49-F238E27FC236}">
-                <a16:creationId xmlns:a16="http://schemas.microsoft.com/office/drawing/2014/main" id="{F67807EA-0857-4D6D-A005-510778772E54}"/>
+                <a16:creationId xmlns:a16="http://schemas.microsoft.com/office/drawing/2014/main" id="{8D81EDC0-89A9-4949-88BE-5420D754B9AA}"/>
               </a:ext>
             </a:extLst>
           </p:cNvPr>
@@ -9328,7 +9328,7 @@
           <p:cNvPr id="11" name="">
             <a:extLst xmlns:a="http://schemas.openxmlformats.org/drawingml/2006/main">
               <a:ext uri="{FF2B5EF4-FFF2-40B4-BE49-F238E27FC236}">
-                <a16:creationId xmlns:a16="http://schemas.microsoft.com/office/drawing/2014/main" id="{2D65D83E-3E23-433A-A53C-5B8B874F6EEB}"/>
+                <a16:creationId xmlns:a16="http://schemas.microsoft.com/office/drawing/2014/main" id="{A42A0894-C9AD-491E-BE9A-D033F7D3BF17}"/>
               </a:ext>
             </a:extLst>
           </p:cNvPr>
@@ -9408,7 +9408,7 @@
           <p:cNvPr id="12" name="">
             <a:extLst xmlns:a="http://schemas.openxmlformats.org/drawingml/2006/main">
               <a:ext uri="{FF2B5EF4-FFF2-40B4-BE49-F238E27FC236}">
-                <a16:creationId xmlns:a16="http://schemas.microsoft.com/office/drawing/2014/main" id="{E46766D3-FE94-4B0B-9A57-7D2964264BD5}"/>
+                <a16:creationId xmlns:a16="http://schemas.microsoft.com/office/drawing/2014/main" id="{44F44C85-5B24-4A77-8173-07515BAD987F}"/>
               </a:ext>
             </a:extLst>
           </p:cNvPr>
@@ -9438,7 +9438,7 @@
           <p:cNvPr id="13" name="">
             <a:extLst xmlns:a="http://schemas.openxmlformats.org/drawingml/2006/main">
               <a:ext uri="{FF2B5EF4-FFF2-40B4-BE49-F238E27FC236}">
-                <a16:creationId xmlns:a16="http://schemas.microsoft.com/office/drawing/2014/main" id="{36022420-C516-4005-AC58-27D1613A6ABE}"/>
+                <a16:creationId xmlns:a16="http://schemas.microsoft.com/office/drawing/2014/main" id="{3B98E212-D2FB-4D46-AD94-BDCAA16A6AB2}"/>
               </a:ext>
             </a:extLst>
           </p:cNvPr>
@@ -9495,7 +9495,7 @@
           <p:cNvPr id="14" name="">
             <a:extLst xmlns:a="http://schemas.openxmlformats.org/drawingml/2006/main">
               <a:ext uri="{FF2B5EF4-FFF2-40B4-BE49-F238E27FC236}">
-                <a16:creationId xmlns:a16="http://schemas.microsoft.com/office/drawing/2014/main" id="{E761C80C-C06C-4A1D-A09B-FD4DDB7C3429}"/>
+                <a16:creationId xmlns:a16="http://schemas.microsoft.com/office/drawing/2014/main" id="{B23935B5-DFE6-4496-AF01-64A1C80B3793}"/>
               </a:ext>
             </a:extLst>
           </p:cNvPr>
@@ -9552,7 +9552,7 @@
           <p:cNvPr id="15" name="">
             <a:extLst xmlns:a="http://schemas.openxmlformats.org/drawingml/2006/main">
               <a:ext uri="{FF2B5EF4-FFF2-40B4-BE49-F238E27FC236}">
-                <a16:creationId xmlns:a16="http://schemas.microsoft.com/office/drawing/2014/main" id="{F4ABB504-149D-4430-91F0-AD7699BEDF54}"/>
+                <a16:creationId xmlns:a16="http://schemas.microsoft.com/office/drawing/2014/main" id="{01226DE6-EA09-4006-9119-1058F28C3F64}"/>
               </a:ext>
             </a:extLst>
           </p:cNvPr>
@@ -9632,7 +9632,7 @@
           <p:cNvPr id="16" name="">
             <a:extLst xmlns:a="http://schemas.openxmlformats.org/drawingml/2006/main">
               <a:ext uri="{FF2B5EF4-FFF2-40B4-BE49-F238E27FC236}">
-                <a16:creationId xmlns:a16="http://schemas.microsoft.com/office/drawing/2014/main" id="{D32EAAAF-3D51-440E-82D9-450A699AE041}"/>
+                <a16:creationId xmlns:a16="http://schemas.microsoft.com/office/drawing/2014/main" id="{3CA0C6A5-04ED-4A91-ACC4-C7B57A943DAB}"/>
               </a:ext>
             </a:extLst>
           </p:cNvPr>
@@ -9689,7 +9689,7 @@
           <p:cNvPr id="17" name="">
             <a:extLst xmlns:a="http://schemas.openxmlformats.org/drawingml/2006/main">
               <a:ext uri="{FF2B5EF4-FFF2-40B4-BE49-F238E27FC236}">
-                <a16:creationId xmlns:a16="http://schemas.microsoft.com/office/drawing/2014/main" id="{2746FDCD-35A6-43F2-A831-6C95656D4B05}"/>
+                <a16:creationId xmlns:a16="http://schemas.microsoft.com/office/drawing/2014/main" id="{970B191C-C0AE-4603-AB71-968A85FA3344}"/>
               </a:ext>
             </a:extLst>
           </p:cNvPr>
@@ -9746,7 +9746,7 @@
           <p:cNvPr id="18" name="">
             <a:extLst xmlns:a="http://schemas.openxmlformats.org/drawingml/2006/main">
               <a:ext uri="{FF2B5EF4-FFF2-40B4-BE49-F238E27FC236}">
-                <a16:creationId xmlns:a16="http://schemas.microsoft.com/office/drawing/2014/main" id="{2BB1AD69-1121-4AB7-B0D5-8089F09071C3}"/>
+                <a16:creationId xmlns:a16="http://schemas.microsoft.com/office/drawing/2014/main" id="{C50DE119-3FD7-4E01-B5F8-965D715D76E7}"/>
               </a:ext>
             </a:extLst>
           </p:cNvPr>
@@ -9801,7 +9801,7 @@
     </p:spTree>
     <p:extLst>
       <p:ext uri="{BB962C8B-B14F-4D97-AF65-F5344CB8AC3E}">
-        <p14:creationId xmlns:p14="http://schemas.microsoft.com/office/powerpoint/2010/main" val="1467454721"/>
+        <p14:creationId xmlns:p14="http://schemas.microsoft.com/office/powerpoint/2010/main" val="1803741850"/>
       </p:ext>
     </p:extLst>
   </p:cSld>
@@ -9832,7 +9832,7 @@
           <p:cNvPr id="18" name="">
             <a:extLst xmlns:a="http://schemas.openxmlformats.org/drawingml/2006/main">
               <a:ext uri="{FF2B5EF4-FFF2-40B4-BE49-F238E27FC236}">
-                <a16:creationId xmlns:a16="http://schemas.microsoft.com/office/drawing/2014/main" id="{C23E73B6-DF69-4ED3-BE87-427B3A3E9642}"/>
+                <a16:creationId xmlns:a16="http://schemas.microsoft.com/office/drawing/2014/main" id="{2A0C4F07-7080-47C1-BE6E-9EC9AE0000CF}"/>
               </a:ext>
             </a:extLst>
           </p:cNvPr>
@@ -9862,7 +9862,7 @@
           <p:cNvPr id="2" name="">
             <a:extLst xmlns:a="http://schemas.openxmlformats.org/drawingml/2006/main">
               <a:ext uri="{FF2B5EF4-FFF2-40B4-BE49-F238E27FC236}">
-                <a16:creationId xmlns:a16="http://schemas.microsoft.com/office/drawing/2014/main" id="{FA2579AB-85F9-4594-9636-C0572C57AB8F}"/>
+                <a16:creationId xmlns:a16="http://schemas.microsoft.com/office/drawing/2014/main" id="{8A2E8129-4671-47C5-8166-5F24D71A83FA}"/>
               </a:ext>
             </a:extLst>
           </p:cNvPr>
@@ -9919,7 +9919,7 @@
           <p:cNvPr id="3" name="">
             <a:extLst xmlns:a="http://schemas.openxmlformats.org/drawingml/2006/main">
               <a:ext uri="{FF2B5EF4-FFF2-40B4-BE49-F238E27FC236}">
-                <a16:creationId xmlns:a16="http://schemas.microsoft.com/office/drawing/2014/main" id="{A9EF6490-5A73-47F5-972C-B65153D72012}"/>
+                <a16:creationId xmlns:a16="http://schemas.microsoft.com/office/drawing/2014/main" id="{0FAB1B8C-26C7-452E-814C-8613F63B59A7}"/>
               </a:ext>
             </a:extLst>
           </p:cNvPr>
@@ -9949,7 +9949,7 @@
           <p:cNvPr id="4" name="">
             <a:extLst xmlns:a="http://schemas.openxmlformats.org/drawingml/2006/main">
               <a:ext uri="{FF2B5EF4-FFF2-40B4-BE49-F238E27FC236}">
-                <a16:creationId xmlns:a16="http://schemas.microsoft.com/office/drawing/2014/main" id="{A04800F3-0980-4933-ACF8-4D03E07CB000}"/>
+                <a16:creationId xmlns:a16="http://schemas.microsoft.com/office/drawing/2014/main" id="{402BFB6C-D1C9-4CB6-87C6-B8C4C59FE53D}"/>
               </a:ext>
             </a:extLst>
           </p:cNvPr>
@@ -10006,7 +10006,7 @@
           <p:cNvPr id="5" name="">
             <a:extLst xmlns:a="http://schemas.openxmlformats.org/drawingml/2006/main">
               <a:ext uri="{FF2B5EF4-FFF2-40B4-BE49-F238E27FC236}">
-                <a16:creationId xmlns:a16="http://schemas.microsoft.com/office/drawing/2014/main" id="{5A4B0EEA-B0BA-4CD6-B8FF-8AFA18455707}"/>
+                <a16:creationId xmlns:a16="http://schemas.microsoft.com/office/drawing/2014/main" id="{F8081D26-B7B1-44A3-8116-930FFEAC3599}"/>
               </a:ext>
             </a:extLst>
           </p:cNvPr>
@@ -10036,7 +10036,7 @@
           <p:cNvPr id="6" name="">
             <a:extLst xmlns:a="http://schemas.openxmlformats.org/drawingml/2006/main">
               <a:ext uri="{FF2B5EF4-FFF2-40B4-BE49-F238E27FC236}">
-                <a16:creationId xmlns:a16="http://schemas.microsoft.com/office/drawing/2014/main" id="{705A9AD0-ABDA-4B9C-BA93-2DC0F5C85646}"/>
+                <a16:creationId xmlns:a16="http://schemas.microsoft.com/office/drawing/2014/main" id="{F4FA31A7-998B-4458-95C5-F28951EDC73D}"/>
               </a:ext>
             </a:extLst>
           </p:cNvPr>
@@ -10093,7 +10093,7 @@
           <p:cNvPr id="7" name="">
             <a:extLst xmlns:a="http://schemas.openxmlformats.org/drawingml/2006/main">
               <a:ext uri="{FF2B5EF4-FFF2-40B4-BE49-F238E27FC236}">
-                <a16:creationId xmlns:a16="http://schemas.microsoft.com/office/drawing/2014/main" id="{B3D048D9-D541-4797-8D25-E32862B7C11A}"/>
+                <a16:creationId xmlns:a16="http://schemas.microsoft.com/office/drawing/2014/main" id="{51C2A4DB-1C50-45D2-9E64-ABCC26C32D51}"/>
               </a:ext>
             </a:extLst>
           </p:cNvPr>
@@ -10173,7 +10173,7 @@
           <p:cNvPr id="8" name="">
             <a:extLst xmlns:a="http://schemas.openxmlformats.org/drawingml/2006/main">
               <a:ext uri="{FF2B5EF4-FFF2-40B4-BE49-F238E27FC236}">
-                <a16:creationId xmlns:a16="http://schemas.microsoft.com/office/drawing/2014/main" id="{76BB8D93-08AC-47FA-8F5F-25F3275A2662}"/>
+                <a16:creationId xmlns:a16="http://schemas.microsoft.com/office/drawing/2014/main" id="{A685A3B6-2641-411D-BF24-D86DC499516A}"/>
               </a:ext>
             </a:extLst>
           </p:cNvPr>
@@ -10203,7 +10203,7 @@
           <p:cNvPr id="9" name="">
             <a:extLst xmlns:a="http://schemas.openxmlformats.org/drawingml/2006/main">
               <a:ext uri="{FF2B5EF4-FFF2-40B4-BE49-F238E27FC236}">
-                <a16:creationId xmlns:a16="http://schemas.microsoft.com/office/drawing/2014/main" id="{DC32D34A-6858-455F-B516-522616877EC4}"/>
+                <a16:creationId xmlns:a16="http://schemas.microsoft.com/office/drawing/2014/main" id="{76575AF8-C3C8-4040-9586-449B4F99B1BA}"/>
               </a:ext>
             </a:extLst>
           </p:cNvPr>
@@ -10260,7 +10260,7 @@
           <p:cNvPr id="10" name="">
             <a:extLst xmlns:a="http://schemas.openxmlformats.org/drawingml/2006/main">
               <a:ext uri="{FF2B5EF4-FFF2-40B4-BE49-F238E27FC236}">
-                <a16:creationId xmlns:a16="http://schemas.microsoft.com/office/drawing/2014/main" id="{AF0DD99D-A94A-42FA-9E93-31D847BED536}"/>
+                <a16:creationId xmlns:a16="http://schemas.microsoft.com/office/drawing/2014/main" id="{79EFEDAA-4D47-48F4-A9D9-47B2DEFDD6E8}"/>
               </a:ext>
             </a:extLst>
           </p:cNvPr>
@@ -10340,7 +10340,7 @@
           <p:cNvPr id="11" name="">
             <a:extLst xmlns:a="http://schemas.openxmlformats.org/drawingml/2006/main">
               <a:ext uri="{FF2B5EF4-FFF2-40B4-BE49-F238E27FC236}">
-                <a16:creationId xmlns:a16="http://schemas.microsoft.com/office/drawing/2014/main" id="{D208321C-8DD1-4501-9698-D9234531827C}"/>
+                <a16:creationId xmlns:a16="http://schemas.microsoft.com/office/drawing/2014/main" id="{1DB7F900-9D93-477D-B309-2DA5440A6733}"/>
               </a:ext>
             </a:extLst>
           </p:cNvPr>
@@ -10370,7 +10370,7 @@
           <p:cNvPr id="12" name="">
             <a:extLst xmlns:a="http://schemas.openxmlformats.org/drawingml/2006/main">
               <a:ext uri="{FF2B5EF4-FFF2-40B4-BE49-F238E27FC236}">
-                <a16:creationId xmlns:a16="http://schemas.microsoft.com/office/drawing/2014/main" id="{52C023AC-6DAC-4BFA-8368-E8967EA8E863}"/>
+                <a16:creationId xmlns:a16="http://schemas.microsoft.com/office/drawing/2014/main" id="{6602AB6C-B986-48CB-A2A7-E3989A4D39F8}"/>
               </a:ext>
             </a:extLst>
           </p:cNvPr>
@@ -10427,7 +10427,7 @@
           <p:cNvPr id="13" name="">
             <a:extLst xmlns:a="http://schemas.openxmlformats.org/drawingml/2006/main">
               <a:ext uri="{FF2B5EF4-FFF2-40B4-BE49-F238E27FC236}">
-                <a16:creationId xmlns:a16="http://schemas.microsoft.com/office/drawing/2014/main" id="{A223634C-E262-4277-AD4D-309B7B53FABC}"/>
+                <a16:creationId xmlns:a16="http://schemas.microsoft.com/office/drawing/2014/main" id="{3361C133-124A-4E96-B250-36930E0DD62C}"/>
               </a:ext>
             </a:extLst>
           </p:cNvPr>
@@ -10507,7 +10507,7 @@
           <p:cNvPr id="14" name="">
             <a:extLst xmlns:a="http://schemas.openxmlformats.org/drawingml/2006/main">
               <a:ext uri="{FF2B5EF4-FFF2-40B4-BE49-F238E27FC236}">
-                <a16:creationId xmlns:a16="http://schemas.microsoft.com/office/drawing/2014/main" id="{1E53219A-F79E-428D-8607-1471A1702EE4}"/>
+                <a16:creationId xmlns:a16="http://schemas.microsoft.com/office/drawing/2014/main" id="{61DFB55D-63CA-438E-9975-732631C7530E}"/>
               </a:ext>
             </a:extLst>
           </p:cNvPr>
@@ -10537,7 +10537,7 @@
           <p:cNvPr id="15" name="">
             <a:extLst xmlns:a="http://schemas.openxmlformats.org/drawingml/2006/main">
               <a:ext uri="{FF2B5EF4-FFF2-40B4-BE49-F238E27FC236}">
-                <a16:creationId xmlns:a16="http://schemas.microsoft.com/office/drawing/2014/main" id="{BFCC9ABE-B741-45E0-A88B-FB7D88AA70BE}"/>
+                <a16:creationId xmlns:a16="http://schemas.microsoft.com/office/drawing/2014/main" id="{4C6F7059-4225-4128-9698-7B6ABAFF76DB}"/>
               </a:ext>
             </a:extLst>
           </p:cNvPr>
@@ -10594,7 +10594,7 @@
           <p:cNvPr id="16" name="">
             <a:extLst xmlns:a="http://schemas.openxmlformats.org/drawingml/2006/main">
               <a:ext uri="{FF2B5EF4-FFF2-40B4-BE49-F238E27FC236}">
-                <a16:creationId xmlns:a16="http://schemas.microsoft.com/office/drawing/2014/main" id="{630076FB-EE1F-419E-8B5D-8169F537D399}"/>
+                <a16:creationId xmlns:a16="http://schemas.microsoft.com/office/drawing/2014/main" id="{1EC755A4-C2A2-4898-9099-BEA9DC05C048}"/>
               </a:ext>
             </a:extLst>
           </p:cNvPr>
@@ -10674,7 +10674,7 @@
           <p:cNvPr id="17" name="">
             <a:extLst xmlns:a="http://schemas.openxmlformats.org/drawingml/2006/main">
               <a:ext uri="{FF2B5EF4-FFF2-40B4-BE49-F238E27FC236}">
-                <a16:creationId xmlns:a16="http://schemas.microsoft.com/office/drawing/2014/main" id="{095BBFAA-4D24-485F-A321-F4CD817081A4}"/>
+                <a16:creationId xmlns:a16="http://schemas.microsoft.com/office/drawing/2014/main" id="{CD5ACF9C-32B1-4713-88DA-FDAE9667FC91}"/>
               </a:ext>
             </a:extLst>
           </p:cNvPr>
@@ -10729,7 +10729,7 @@
     </p:spTree>
     <p:extLst>
       <p:ext uri="{BB962C8B-B14F-4D97-AF65-F5344CB8AC3E}">
-        <p14:creationId xmlns:p14="http://schemas.microsoft.com/office/powerpoint/2010/main" val="2019158915"/>
+        <p14:creationId xmlns:p14="http://schemas.microsoft.com/office/powerpoint/2010/main" val="34468637"/>
       </p:ext>
     </p:extLst>
   </p:cSld>
@@ -10760,7 +10760,7 @@
           <p:cNvPr id="30" name="">
             <a:extLst xmlns:a="http://schemas.openxmlformats.org/drawingml/2006/main">
               <a:ext uri="{FF2B5EF4-FFF2-40B4-BE49-F238E27FC236}">
-                <a16:creationId xmlns:a16="http://schemas.microsoft.com/office/drawing/2014/main" id="{66891B42-12F1-48DB-8764-8740054E6471}"/>
+                <a16:creationId xmlns:a16="http://schemas.microsoft.com/office/drawing/2014/main" id="{99FF510B-B2A1-4021-9AC7-513AA93504AA}"/>
               </a:ext>
             </a:extLst>
           </p:cNvPr>
@@ -10790,7 +10790,7 @@
           <p:cNvPr id="2" name="">
             <a:extLst xmlns:a="http://schemas.openxmlformats.org/drawingml/2006/main">
               <a:ext uri="{FF2B5EF4-FFF2-40B4-BE49-F238E27FC236}">
-                <a16:creationId xmlns:a16="http://schemas.microsoft.com/office/drawing/2014/main" id="{78ECB73E-BF0A-4637-9D8F-FDBDC20F3507}"/>
+                <a16:creationId xmlns:a16="http://schemas.microsoft.com/office/drawing/2014/main" id="{4C645120-8FD0-408B-B071-C48AE6118A91}"/>
               </a:ext>
             </a:extLst>
           </p:cNvPr>
@@ -10847,7 +10847,7 @@
           <p:cNvPr id="3" name="">
             <a:extLst xmlns:a="http://schemas.openxmlformats.org/drawingml/2006/main">
               <a:ext uri="{FF2B5EF4-FFF2-40B4-BE49-F238E27FC236}">
-                <a16:creationId xmlns:a16="http://schemas.microsoft.com/office/drawing/2014/main" id="{B0A9F970-5490-4ECC-8098-86CF96300582}"/>
+                <a16:creationId xmlns:a16="http://schemas.microsoft.com/office/drawing/2014/main" id="{4E33F3A5-9737-4827-8F9E-F8ADB0DA6FDF}"/>
               </a:ext>
             </a:extLst>
           </p:cNvPr>
@@ -10877,7 +10877,7 @@
           <p:cNvPr id="4" name="">
             <a:extLst xmlns:a="http://schemas.openxmlformats.org/drawingml/2006/main">
               <a:ext uri="{FF2B5EF4-FFF2-40B4-BE49-F238E27FC236}">
-                <a16:creationId xmlns:a16="http://schemas.microsoft.com/office/drawing/2014/main" id="{617BC351-568E-4BB6-9B9F-169F439C9B78}"/>
+                <a16:creationId xmlns:a16="http://schemas.microsoft.com/office/drawing/2014/main" id="{B76D0A75-B9CC-4EBF-9ACF-982D0631F3B4}"/>
               </a:ext>
             </a:extLst>
           </p:cNvPr>
@@ -10934,7 +10934,7 @@
           <p:cNvPr id="5" name="">
             <a:extLst xmlns:a="http://schemas.openxmlformats.org/drawingml/2006/main">
               <a:ext uri="{FF2B5EF4-FFF2-40B4-BE49-F238E27FC236}">
-                <a16:creationId xmlns:a16="http://schemas.microsoft.com/office/drawing/2014/main" id="{21CB5D8A-8EE4-4657-8EC9-1CAF499AA0EF}"/>
+                <a16:creationId xmlns:a16="http://schemas.microsoft.com/office/drawing/2014/main" id="{117341A1-05D5-4DB7-A8E1-3180F7A82B1D}"/>
               </a:ext>
             </a:extLst>
           </p:cNvPr>
@@ -10966,7 +10966,7 @@
           <p:cNvPr id="6" name="">
             <a:extLst xmlns:a="http://schemas.openxmlformats.org/drawingml/2006/main">
               <a:ext uri="{FF2B5EF4-FFF2-40B4-BE49-F238E27FC236}">
-                <a16:creationId xmlns:a16="http://schemas.microsoft.com/office/drawing/2014/main" id="{93223D4D-474C-4A68-A647-E0D05512F939}"/>
+                <a16:creationId xmlns:a16="http://schemas.microsoft.com/office/drawing/2014/main" id="{27359876-6EC3-4AA3-8A03-D3EF3B69C7FC}"/>
               </a:ext>
             </a:extLst>
           </p:cNvPr>
@@ -11023,7 +11023,7 @@
           <p:cNvPr id="7" name="">
             <a:extLst xmlns:a="http://schemas.openxmlformats.org/drawingml/2006/main">
               <a:ext uri="{FF2B5EF4-FFF2-40B4-BE49-F238E27FC236}">
-                <a16:creationId xmlns:a16="http://schemas.microsoft.com/office/drawing/2014/main" id="{062C5E53-32E8-40D8-A854-5C22DF59AC3E}"/>
+                <a16:creationId xmlns:a16="http://schemas.microsoft.com/office/drawing/2014/main" id="{FF14AD7A-7630-47D7-AF26-61542E74A16B}"/>
               </a:ext>
             </a:extLst>
           </p:cNvPr>
@@ -11080,7 +11080,7 @@
           <p:cNvPr id="8" name="">
             <a:extLst xmlns:a="http://schemas.openxmlformats.org/drawingml/2006/main">
               <a:ext uri="{FF2B5EF4-FFF2-40B4-BE49-F238E27FC236}">
-                <a16:creationId xmlns:a16="http://schemas.microsoft.com/office/drawing/2014/main" id="{F32A100D-2BF1-4654-8CF6-76C0C442E53F}"/>
+                <a16:creationId xmlns:a16="http://schemas.microsoft.com/office/drawing/2014/main" id="{127DF052-A931-4026-857C-78D14D83EBF8}"/>
               </a:ext>
             </a:extLst>
           </p:cNvPr>
@@ -11160,7 +11160,7 @@
           <p:cNvPr id="9" name="">
             <a:extLst xmlns:a="http://schemas.openxmlformats.org/drawingml/2006/main">
               <a:ext uri="{FF2B5EF4-FFF2-40B4-BE49-F238E27FC236}">
-                <a16:creationId xmlns:a16="http://schemas.microsoft.com/office/drawing/2014/main" id="{F15A5305-B942-4865-9F26-CA400E92E0EB}"/>
+                <a16:creationId xmlns:a16="http://schemas.microsoft.com/office/drawing/2014/main" id="{C39548F3-FDA0-4285-905B-707FEBE57A6E}"/>
               </a:ext>
             </a:extLst>
           </p:cNvPr>
@@ -11217,7 +11217,7 @@
           <p:cNvPr id="10" name="">
             <a:extLst xmlns:a="http://schemas.openxmlformats.org/drawingml/2006/main">
               <a:ext uri="{FF2B5EF4-FFF2-40B4-BE49-F238E27FC236}">
-                <a16:creationId xmlns:a16="http://schemas.microsoft.com/office/drawing/2014/main" id="{17C8FC9A-BFC7-4562-BB82-327EDF1A98FE}"/>
+                <a16:creationId xmlns:a16="http://schemas.microsoft.com/office/drawing/2014/main" id="{2920FC98-1492-4344-918D-B271A32B3C3D}"/>
               </a:ext>
             </a:extLst>
           </p:cNvPr>
@@ -11249,7 +11249,7 @@
           <p:cNvPr id="11" name="">
             <a:extLst xmlns:a="http://schemas.openxmlformats.org/drawingml/2006/main">
               <a:ext uri="{FF2B5EF4-FFF2-40B4-BE49-F238E27FC236}">
-                <a16:creationId xmlns:a16="http://schemas.microsoft.com/office/drawing/2014/main" id="{D2540578-3DBB-44AF-8E5D-1BA1DB5F35C8}"/>
+                <a16:creationId xmlns:a16="http://schemas.microsoft.com/office/drawing/2014/main" id="{83E23E97-6306-46EA-AB75-358DAFC79DBE}"/>
               </a:ext>
             </a:extLst>
           </p:cNvPr>
@@ -11306,7 +11306,7 @@
           <p:cNvPr id="12" name="">
             <a:extLst xmlns:a="http://schemas.openxmlformats.org/drawingml/2006/main">
               <a:ext uri="{FF2B5EF4-FFF2-40B4-BE49-F238E27FC236}">
-                <a16:creationId xmlns:a16="http://schemas.microsoft.com/office/drawing/2014/main" id="{1B08F686-3556-4318-81F0-8C59946FDB6E}"/>
+                <a16:creationId xmlns:a16="http://schemas.microsoft.com/office/drawing/2014/main" id="{6F921E00-71FF-48F5-9124-BBAB71674142}"/>
               </a:ext>
             </a:extLst>
           </p:cNvPr>
@@ -11363,7 +11363,7 @@
           <p:cNvPr id="13" name="">
             <a:extLst xmlns:a="http://schemas.openxmlformats.org/drawingml/2006/main">
               <a:ext uri="{FF2B5EF4-FFF2-40B4-BE49-F238E27FC236}">
-                <a16:creationId xmlns:a16="http://schemas.microsoft.com/office/drawing/2014/main" id="{49380B68-480F-4D14-8321-27546C3C3A90}"/>
+                <a16:creationId xmlns:a16="http://schemas.microsoft.com/office/drawing/2014/main" id="{82D2C569-3A96-43B8-83F4-A580D4832E16}"/>
               </a:ext>
             </a:extLst>
           </p:cNvPr>
@@ -11443,7 +11443,7 @@
           <p:cNvPr id="14" name="">
             <a:extLst xmlns:a="http://schemas.openxmlformats.org/drawingml/2006/main">
               <a:ext uri="{FF2B5EF4-FFF2-40B4-BE49-F238E27FC236}">
-                <a16:creationId xmlns:a16="http://schemas.microsoft.com/office/drawing/2014/main" id="{2C1A5386-2474-46B1-8717-842458C4B96C}"/>
+                <a16:creationId xmlns:a16="http://schemas.microsoft.com/office/drawing/2014/main" id="{FF404777-D485-4A86-8F44-4B1B571194A8}"/>
               </a:ext>
             </a:extLst>
           </p:cNvPr>
@@ -11500,7 +11500,7 @@
           <p:cNvPr id="15" name="">
             <a:extLst xmlns:a="http://schemas.openxmlformats.org/drawingml/2006/main">
               <a:ext uri="{FF2B5EF4-FFF2-40B4-BE49-F238E27FC236}">
-                <a16:creationId xmlns:a16="http://schemas.microsoft.com/office/drawing/2014/main" id="{0512B442-9EA7-4786-9A49-349A14F291D9}"/>
+                <a16:creationId xmlns:a16="http://schemas.microsoft.com/office/drawing/2014/main" id="{F49A6130-9D79-4A33-9A87-F6CD71103C80}"/>
               </a:ext>
             </a:extLst>
           </p:cNvPr>
@@ -11532,7 +11532,7 @@
           <p:cNvPr id="16" name="">
             <a:extLst xmlns:a="http://schemas.openxmlformats.org/drawingml/2006/main">
               <a:ext uri="{FF2B5EF4-FFF2-40B4-BE49-F238E27FC236}">
-                <a16:creationId xmlns:a16="http://schemas.microsoft.com/office/drawing/2014/main" id="{E486A962-AC9F-4711-BDEB-3C1AA1CF4E7B}"/>
+                <a16:creationId xmlns:a16="http://schemas.microsoft.com/office/drawing/2014/main" id="{E3E2B4F8-6CAD-41FA-9796-6CC510768C12}"/>
               </a:ext>
             </a:extLst>
           </p:cNvPr>
@@ -11589,7 +11589,7 @@
           <p:cNvPr id="17" name="">
             <a:extLst xmlns:a="http://schemas.openxmlformats.org/drawingml/2006/main">
               <a:ext uri="{FF2B5EF4-FFF2-40B4-BE49-F238E27FC236}">
-                <a16:creationId xmlns:a16="http://schemas.microsoft.com/office/drawing/2014/main" id="{B359265B-DDF2-44FC-80BF-F3442C00101F}"/>
+                <a16:creationId xmlns:a16="http://schemas.microsoft.com/office/drawing/2014/main" id="{1C2385DD-5380-480A-BF9A-EB3F616060A8}"/>
               </a:ext>
             </a:extLst>
           </p:cNvPr>
@@ -11646,7 +11646,7 @@
           <p:cNvPr id="18" name="">
             <a:extLst xmlns:a="http://schemas.openxmlformats.org/drawingml/2006/main">
               <a:ext uri="{FF2B5EF4-FFF2-40B4-BE49-F238E27FC236}">
-                <a16:creationId xmlns:a16="http://schemas.microsoft.com/office/drawing/2014/main" id="{14BAEA36-5D9B-4600-B134-ABEE2841A6AC}"/>
+                <a16:creationId xmlns:a16="http://schemas.microsoft.com/office/drawing/2014/main" id="{F4E52150-334F-43D9-8462-61953A812FF6}"/>
               </a:ext>
             </a:extLst>
           </p:cNvPr>
@@ -11726,7 +11726,7 @@
           <p:cNvPr id="19" name="">
             <a:extLst xmlns:a="http://schemas.openxmlformats.org/drawingml/2006/main">
               <a:ext uri="{FF2B5EF4-FFF2-40B4-BE49-F238E27FC236}">
-                <a16:creationId xmlns:a16="http://schemas.microsoft.com/office/drawing/2014/main" id="{83374031-8083-4F14-82DC-BB4FF4903F2F}"/>
+                <a16:creationId xmlns:a16="http://schemas.microsoft.com/office/drawing/2014/main" id="{A98B50D3-F651-40A1-B899-62E2CAB637EE}"/>
               </a:ext>
             </a:extLst>
           </p:cNvPr>
@@ -11783,7 +11783,7 @@
           <p:cNvPr id="20" name="">
             <a:extLst xmlns:a="http://schemas.openxmlformats.org/drawingml/2006/main">
               <a:ext uri="{FF2B5EF4-FFF2-40B4-BE49-F238E27FC236}">
-                <a16:creationId xmlns:a16="http://schemas.microsoft.com/office/drawing/2014/main" id="{FE965F7D-B000-4196-AED1-3FC2D8520262}"/>
+                <a16:creationId xmlns:a16="http://schemas.microsoft.com/office/drawing/2014/main" id="{7ECBF9F1-88F6-407C-94BF-288D0610E3BA}"/>
               </a:ext>
             </a:extLst>
           </p:cNvPr>
@@ -11815,7 +11815,7 @@
           <p:cNvPr id="21" name="">
             <a:extLst xmlns:a="http://schemas.openxmlformats.org/drawingml/2006/main">
               <a:ext uri="{FF2B5EF4-FFF2-40B4-BE49-F238E27FC236}">
-                <a16:creationId xmlns:a16="http://schemas.microsoft.com/office/drawing/2014/main" id="{9D73BFFC-DBB4-4B8A-83B4-787600E8D1DC}"/>
+                <a16:creationId xmlns:a16="http://schemas.microsoft.com/office/drawing/2014/main" id="{B05F8507-5253-479B-B516-19667BC44BCD}"/>
               </a:ext>
             </a:extLst>
           </p:cNvPr>
@@ -11872,7 +11872,7 @@
           <p:cNvPr id="22" name="">
             <a:extLst xmlns:a="http://schemas.openxmlformats.org/drawingml/2006/main">
               <a:ext uri="{FF2B5EF4-FFF2-40B4-BE49-F238E27FC236}">
-                <a16:creationId xmlns:a16="http://schemas.microsoft.com/office/drawing/2014/main" id="{D0AA117B-5338-4A98-A184-4A9A7040A398}"/>
+                <a16:creationId xmlns:a16="http://schemas.microsoft.com/office/drawing/2014/main" id="{A79D834F-4534-4E74-BD09-4C2AE90AD24A}"/>
               </a:ext>
             </a:extLst>
           </p:cNvPr>
@@ -11929,7 +11929,7 @@
           <p:cNvPr id="23" name="">
             <a:extLst xmlns:a="http://schemas.openxmlformats.org/drawingml/2006/main">
               <a:ext uri="{FF2B5EF4-FFF2-40B4-BE49-F238E27FC236}">
-                <a16:creationId xmlns:a16="http://schemas.microsoft.com/office/drawing/2014/main" id="{1604AF88-D7A5-49E2-B899-E4027606F773}"/>
+                <a16:creationId xmlns:a16="http://schemas.microsoft.com/office/drawing/2014/main" id="{2484CCA0-6445-4DCE-96AC-9C189D7A20D2}"/>
               </a:ext>
             </a:extLst>
           </p:cNvPr>
@@ -12009,7 +12009,7 @@
           <p:cNvPr id="24" name="">
             <a:extLst xmlns:a="http://schemas.openxmlformats.org/drawingml/2006/main">
               <a:ext uri="{FF2B5EF4-FFF2-40B4-BE49-F238E27FC236}">
-                <a16:creationId xmlns:a16="http://schemas.microsoft.com/office/drawing/2014/main" id="{C1863AF7-882D-416E-B844-6819DE958DAF}"/>
+                <a16:creationId xmlns:a16="http://schemas.microsoft.com/office/drawing/2014/main" id="{27B0BDFF-9148-4D6D-86E2-728656E69B4C}"/>
               </a:ext>
             </a:extLst>
           </p:cNvPr>
@@ -12066,7 +12066,7 @@
           <p:cNvPr id="25" name="">
             <a:extLst xmlns:a="http://schemas.openxmlformats.org/drawingml/2006/main">
               <a:ext uri="{FF2B5EF4-FFF2-40B4-BE49-F238E27FC236}">
-                <a16:creationId xmlns:a16="http://schemas.microsoft.com/office/drawing/2014/main" id="{C7D241A1-AAF9-453D-9149-A18A9C286B31}"/>
+                <a16:creationId xmlns:a16="http://schemas.microsoft.com/office/drawing/2014/main" id="{4160FF38-C14D-4CDA-A48B-343C485E9985}"/>
               </a:ext>
             </a:extLst>
           </p:cNvPr>
@@ -12096,7 +12096,7 @@
           <p:cNvPr id="26" name="">
             <a:extLst xmlns:a="http://schemas.openxmlformats.org/drawingml/2006/main">
               <a:ext uri="{FF2B5EF4-FFF2-40B4-BE49-F238E27FC236}">
-                <a16:creationId xmlns:a16="http://schemas.microsoft.com/office/drawing/2014/main" id="{2FB4F76B-2096-4B37-9FB7-AC7801DE2CB0}"/>
+                <a16:creationId xmlns:a16="http://schemas.microsoft.com/office/drawing/2014/main" id="{D58270F0-4D24-4E9A-9C03-57C3C6CFED0E}"/>
               </a:ext>
             </a:extLst>
           </p:cNvPr>
@@ -12153,7 +12153,7 @@
           <p:cNvPr id="27" name="">
             <a:extLst xmlns:a="http://schemas.openxmlformats.org/drawingml/2006/main">
               <a:ext uri="{FF2B5EF4-FFF2-40B4-BE49-F238E27FC236}">
-                <a16:creationId xmlns:a16="http://schemas.microsoft.com/office/drawing/2014/main" id="{7B16C8DF-13D0-4619-9D58-E9F7A3D2D22F}"/>
+                <a16:creationId xmlns:a16="http://schemas.microsoft.com/office/drawing/2014/main" id="{2251D62C-E4C4-441B-8AB9-2DE25BD68C1E}"/>
               </a:ext>
             </a:extLst>
           </p:cNvPr>
@@ -12210,7 +12210,7 @@
           <p:cNvPr id="28" name="">
             <a:extLst xmlns:a="http://schemas.openxmlformats.org/drawingml/2006/main">
               <a:ext uri="{FF2B5EF4-FFF2-40B4-BE49-F238E27FC236}">
-                <a16:creationId xmlns:a16="http://schemas.microsoft.com/office/drawing/2014/main" id="{E2941882-ECB4-49A6-B45E-5CD0A0409804}"/>
+                <a16:creationId xmlns:a16="http://schemas.microsoft.com/office/drawing/2014/main" id="{370E71C9-958C-459B-BD0C-4D0B2E16CBA7}"/>
               </a:ext>
             </a:extLst>
           </p:cNvPr>
@@ -12290,7 +12290,7 @@
           <p:cNvPr id="29" name="">
             <a:extLst xmlns:a="http://schemas.openxmlformats.org/drawingml/2006/main">
               <a:ext uri="{FF2B5EF4-FFF2-40B4-BE49-F238E27FC236}">
-                <a16:creationId xmlns:a16="http://schemas.microsoft.com/office/drawing/2014/main" id="{90DAF911-51FA-441B-BFBD-C4C639330040}"/>
+                <a16:creationId xmlns:a16="http://schemas.microsoft.com/office/drawing/2014/main" id="{BD02E04A-5132-41BF-811F-A03A46126FF1}"/>
               </a:ext>
             </a:extLst>
           </p:cNvPr>
@@ -12345,7 +12345,7 @@
     </p:spTree>
     <p:extLst>
       <p:ext uri="{BB962C8B-B14F-4D97-AF65-F5344CB8AC3E}">
-        <p14:creationId xmlns:p14="http://schemas.microsoft.com/office/powerpoint/2010/main" val="971713325"/>
+        <p14:creationId xmlns:p14="http://schemas.microsoft.com/office/powerpoint/2010/main" val="914399933"/>
       </p:ext>
     </p:extLst>
   </p:cSld>
@@ -12376,7 +12376,7 @@
           <p:cNvPr id="12" name="">
             <a:extLst xmlns:a="http://schemas.openxmlformats.org/drawingml/2006/main">
               <a:ext uri="{FF2B5EF4-FFF2-40B4-BE49-F238E27FC236}">
-                <a16:creationId xmlns:a16="http://schemas.microsoft.com/office/drawing/2014/main" id="{43E4F63B-DB51-4CC3-93E4-12BA1537F8B8}"/>
+                <a16:creationId xmlns:a16="http://schemas.microsoft.com/office/drawing/2014/main" id="{912A9869-E2F6-495F-B77A-F59B0439B2A2}"/>
               </a:ext>
             </a:extLst>
           </p:cNvPr>
@@ -12406,7 +12406,7 @@
           <p:cNvPr id="2" name="">
             <a:extLst xmlns:a="http://schemas.openxmlformats.org/drawingml/2006/main">
               <a:ext uri="{FF2B5EF4-FFF2-40B4-BE49-F238E27FC236}">
-                <a16:creationId xmlns:a16="http://schemas.microsoft.com/office/drawing/2014/main" id="{190B5F92-1593-4348-BCD7-715CAC727CF5}"/>
+                <a16:creationId xmlns:a16="http://schemas.microsoft.com/office/drawing/2014/main" id="{7684E40F-70A1-451A-98D0-0C9BFFC6BEDB}"/>
               </a:ext>
             </a:extLst>
           </p:cNvPr>
@@ -12463,7 +12463,7 @@
           <p:cNvPr id="3" name="">
             <a:extLst xmlns:a="http://schemas.openxmlformats.org/drawingml/2006/main">
               <a:ext uri="{FF2B5EF4-FFF2-40B4-BE49-F238E27FC236}">
-                <a16:creationId xmlns:a16="http://schemas.microsoft.com/office/drawing/2014/main" id="{ABA9FC49-0BB4-4433-8EA6-DF84109B0863}"/>
+                <a16:creationId xmlns:a16="http://schemas.microsoft.com/office/drawing/2014/main" id="{B9BA72C5-0550-48DB-A47A-1A877ACA8AD7}"/>
               </a:ext>
             </a:extLst>
           </p:cNvPr>
@@ -12493,7 +12493,7 @@
           <p:cNvPr id="4" name="">
             <a:extLst xmlns:a="http://schemas.openxmlformats.org/drawingml/2006/main">
               <a:ext uri="{FF2B5EF4-FFF2-40B4-BE49-F238E27FC236}">
-                <a16:creationId xmlns:a16="http://schemas.microsoft.com/office/drawing/2014/main" id="{8E098CEE-3FE0-4FF0-B063-72C5BB3D586E}"/>
+                <a16:creationId xmlns:a16="http://schemas.microsoft.com/office/drawing/2014/main" id="{145096C8-4725-428B-9C93-49C2362271CE}"/>
               </a:ext>
             </a:extLst>
           </p:cNvPr>
@@ -12550,7 +12550,7 @@
           <p:cNvPr id="5" name="">
             <a:extLst xmlns:a="http://schemas.openxmlformats.org/drawingml/2006/main">
               <a:ext uri="{FF2B5EF4-FFF2-40B4-BE49-F238E27FC236}">
-                <a16:creationId xmlns:a16="http://schemas.microsoft.com/office/drawing/2014/main" id="{9206223B-66D4-4258-9364-F25F76FBCBD6}"/>
+                <a16:creationId xmlns:a16="http://schemas.microsoft.com/office/drawing/2014/main" id="{86F1F572-754E-4453-808A-E2DE9ABDA5C4}"/>
               </a:ext>
             </a:extLst>
           </p:cNvPr>
@@ -12582,7 +12582,7 @@
           <p:cNvPr id="6" name="">
             <a:extLst xmlns:a="http://schemas.openxmlformats.org/drawingml/2006/main">
               <a:ext uri="{FF2B5EF4-FFF2-40B4-BE49-F238E27FC236}">
-                <a16:creationId xmlns:a16="http://schemas.microsoft.com/office/drawing/2014/main" id="{FB95A79A-2F30-4901-A40E-B90E37A9FB9B}"/>
+                <a16:creationId xmlns:a16="http://schemas.microsoft.com/office/drawing/2014/main" id="{552B5AE9-BC31-4E43-9F4D-8188936F0A11}"/>
               </a:ext>
             </a:extLst>
           </p:cNvPr>
@@ -12618,7 +12618,7 @@
           <p:nvPr/>
         </p:nvPicPr>
         <p:blipFill>
-          <a:blip xmlns:r="http://schemas.openxmlformats.org/officeDocument/2006/relationships" xmlns:a="http://schemas.openxmlformats.org/drawingml/2006/main" r:embed="R95ea58d4dc5847f8"/>
+          <a:blip xmlns:r="http://schemas.openxmlformats.org/officeDocument/2006/relationships" xmlns:a="http://schemas.openxmlformats.org/drawingml/2006/main" r:embed="Rd7572a77853d4af6"/>
           <a:stretch xmlns:a="http://schemas.openxmlformats.org/drawingml/2006/main"/>
         </p:blipFill>
         <p:spPr>
@@ -12640,7 +12640,7 @@
           <p:nvPr/>
         </p:nvPicPr>
         <p:blipFill>
-          <a:blip xmlns:r="http://schemas.openxmlformats.org/officeDocument/2006/relationships" xmlns:a="http://schemas.openxmlformats.org/drawingml/2006/main" r:embed="Rfe3fcd4557bc45ff"/>
+          <a:blip xmlns:r="http://schemas.openxmlformats.org/officeDocument/2006/relationships" xmlns:a="http://schemas.openxmlformats.org/drawingml/2006/main" r:embed="Rb301ca6f3ce846be"/>
           <a:stretch xmlns:a="http://schemas.openxmlformats.org/drawingml/2006/main"/>
         </p:blipFill>
         <p:spPr>
@@ -12658,7 +12658,7 @@
           <p:cNvPr id="9" name="">
             <a:extLst xmlns:a="http://schemas.openxmlformats.org/drawingml/2006/main">
               <a:ext uri="{FF2B5EF4-FFF2-40B4-BE49-F238E27FC236}">
-                <a16:creationId xmlns:a16="http://schemas.microsoft.com/office/drawing/2014/main" id="{333696A9-FDE6-4E6F-A924-EE4378D2D937}"/>
+                <a16:creationId xmlns:a16="http://schemas.microsoft.com/office/drawing/2014/main" id="{82E090F0-5000-4C41-815F-2001873CA86D}"/>
               </a:ext>
             </a:extLst>
           </p:cNvPr>
@@ -12715,7 +12715,7 @@
           <p:cNvPr id="10" name="">
             <a:extLst xmlns:a="http://schemas.openxmlformats.org/drawingml/2006/main">
               <a:ext uri="{FF2B5EF4-FFF2-40B4-BE49-F238E27FC236}">
-                <a16:creationId xmlns:a16="http://schemas.microsoft.com/office/drawing/2014/main" id="{451BFDF0-8FCE-44FF-B817-D9D2F5A071CD}"/>
+                <a16:creationId xmlns:a16="http://schemas.microsoft.com/office/drawing/2014/main" id="{D21D9592-1065-4BB6-B587-02ADE45850C0}"/>
               </a:ext>
             </a:extLst>
           </p:cNvPr>
@@ -12772,7 +12772,7 @@
           <p:cNvPr id="11" name="">
             <a:extLst xmlns:a="http://schemas.openxmlformats.org/drawingml/2006/main">
               <a:ext uri="{FF2B5EF4-FFF2-40B4-BE49-F238E27FC236}">
-                <a16:creationId xmlns:a16="http://schemas.microsoft.com/office/drawing/2014/main" id="{FAEBFA0E-6CD3-4428-A053-EE11944CEA29}"/>
+                <a16:creationId xmlns:a16="http://schemas.microsoft.com/office/drawing/2014/main" id="{4BB8E6B2-579D-4A63-8838-9256D09D3F3B}"/>
               </a:ext>
             </a:extLst>
           </p:cNvPr>
@@ -12827,7 +12827,7 @@
     </p:spTree>
     <p:extLst>
       <p:ext uri="{BB962C8B-B14F-4D97-AF65-F5344CB8AC3E}">
-        <p14:creationId xmlns:p14="http://schemas.microsoft.com/office/powerpoint/2010/main" val="45472646"/>
+        <p14:creationId xmlns:p14="http://schemas.microsoft.com/office/powerpoint/2010/main" val="610166305"/>
       </p:ext>
     </p:extLst>
   </p:cSld>
@@ -12858,7 +12858,7 @@
           <p:cNvPr id="12" name="">
             <a:extLst xmlns:a="http://schemas.openxmlformats.org/drawingml/2006/main">
               <a:ext uri="{FF2B5EF4-FFF2-40B4-BE49-F238E27FC236}">
-                <a16:creationId xmlns:a16="http://schemas.microsoft.com/office/drawing/2014/main" id="{03B6999E-DA3E-491F-9521-6B25ED8D4970}"/>
+                <a16:creationId xmlns:a16="http://schemas.microsoft.com/office/drawing/2014/main" id="{FC5DE705-BEF7-440A-A3D2-804AF30918FF}"/>
               </a:ext>
             </a:extLst>
           </p:cNvPr>
@@ -12888,7 +12888,7 @@
           <p:cNvPr id="2" name="">
             <a:extLst xmlns:a="http://schemas.openxmlformats.org/drawingml/2006/main">
               <a:ext uri="{FF2B5EF4-FFF2-40B4-BE49-F238E27FC236}">
-                <a16:creationId xmlns:a16="http://schemas.microsoft.com/office/drawing/2014/main" id="{C97E380B-246E-47BA-81B5-34B4F176F593}"/>
+                <a16:creationId xmlns:a16="http://schemas.microsoft.com/office/drawing/2014/main" id="{DCA3F050-36B6-422D-BC90-820EB93EED9E}"/>
               </a:ext>
             </a:extLst>
           </p:cNvPr>
@@ -12945,7 +12945,7 @@
           <p:cNvPr id="3" name="">
             <a:extLst xmlns:a="http://schemas.openxmlformats.org/drawingml/2006/main">
               <a:ext uri="{FF2B5EF4-FFF2-40B4-BE49-F238E27FC236}">
-                <a16:creationId xmlns:a16="http://schemas.microsoft.com/office/drawing/2014/main" id="{AB679FD2-5313-4263-A106-82C68A4F9109}"/>
+                <a16:creationId xmlns:a16="http://schemas.microsoft.com/office/drawing/2014/main" id="{84D67667-BC5E-4FCF-A8D8-A513E80A8280}"/>
               </a:ext>
             </a:extLst>
           </p:cNvPr>
@@ -12975,7 +12975,7 @@
           <p:cNvPr id="4" name="">
             <a:extLst xmlns:a="http://schemas.openxmlformats.org/drawingml/2006/main">
               <a:ext uri="{FF2B5EF4-FFF2-40B4-BE49-F238E27FC236}">
-                <a16:creationId xmlns:a16="http://schemas.microsoft.com/office/drawing/2014/main" id="{FFE17D1A-0134-4203-BA21-ADBFA40FCFF3}"/>
+                <a16:creationId xmlns:a16="http://schemas.microsoft.com/office/drawing/2014/main" id="{F7D469C2-F1C8-485C-8B3A-CC1B7D61A7EF}"/>
               </a:ext>
             </a:extLst>
           </p:cNvPr>
@@ -13032,7 +13032,7 @@
           <p:cNvPr id="5" name="">
             <a:extLst xmlns:a="http://schemas.openxmlformats.org/drawingml/2006/main">
               <a:ext uri="{FF2B5EF4-FFF2-40B4-BE49-F238E27FC236}">
-                <a16:creationId xmlns:a16="http://schemas.microsoft.com/office/drawing/2014/main" id="{C9E85DB1-785C-4761-85D0-98F459776989}"/>
+                <a16:creationId xmlns:a16="http://schemas.microsoft.com/office/drawing/2014/main" id="{AC8A612B-61FC-4D0A-B6EA-62D2B1C77631}"/>
               </a:ext>
             </a:extLst>
           </p:cNvPr>
@@ -13064,7 +13064,7 @@
           <p:cNvPr id="6" name="">
             <a:extLst xmlns:a="http://schemas.openxmlformats.org/drawingml/2006/main">
               <a:ext uri="{FF2B5EF4-FFF2-40B4-BE49-F238E27FC236}">
-                <a16:creationId xmlns:a16="http://schemas.microsoft.com/office/drawing/2014/main" id="{739953FA-3722-4874-8EDF-6AA2CCA118D1}"/>
+                <a16:creationId xmlns:a16="http://schemas.microsoft.com/office/drawing/2014/main" id="{7E9A293E-CE51-42BB-BB6A-212B3CF1F8A0}"/>
               </a:ext>
             </a:extLst>
           </p:cNvPr>
@@ -13100,7 +13100,7 @@
           <p:nvPr/>
         </p:nvPicPr>
         <p:blipFill>
-          <a:blip xmlns:r="http://schemas.openxmlformats.org/officeDocument/2006/relationships" xmlns:a="http://schemas.openxmlformats.org/drawingml/2006/main" r:embed="R6f8ec24e12bd4157"/>
+          <a:blip xmlns:r="http://schemas.openxmlformats.org/officeDocument/2006/relationships" xmlns:a="http://schemas.openxmlformats.org/drawingml/2006/main" r:embed="Rc43d8753dbc34187"/>
           <a:stretch xmlns:a="http://schemas.openxmlformats.org/drawingml/2006/main"/>
         </p:blipFill>
         <p:spPr>
@@ -13122,7 +13122,7 @@
           <p:nvPr/>
         </p:nvPicPr>
         <p:blipFill>
-          <a:blip xmlns:r="http://schemas.openxmlformats.org/officeDocument/2006/relationships" xmlns:a="http://schemas.openxmlformats.org/drawingml/2006/main" r:embed="Rc23c450f4c3f4615"/>
+          <a:blip xmlns:r="http://schemas.openxmlformats.org/officeDocument/2006/relationships" xmlns:a="http://schemas.openxmlformats.org/drawingml/2006/main" r:embed="R43a3e24caa9a48bc"/>
           <a:stretch xmlns:a="http://schemas.openxmlformats.org/drawingml/2006/main"/>
         </p:blipFill>
         <p:spPr>
@@ -13140,7 +13140,7 @@
           <p:cNvPr id="9" name="">
             <a:extLst xmlns:a="http://schemas.openxmlformats.org/drawingml/2006/main">
               <a:ext uri="{FF2B5EF4-FFF2-40B4-BE49-F238E27FC236}">
-                <a16:creationId xmlns:a16="http://schemas.microsoft.com/office/drawing/2014/main" id="{96BCF356-D273-412A-8BBD-07C9B59D0594}"/>
+                <a16:creationId xmlns:a16="http://schemas.microsoft.com/office/drawing/2014/main" id="{E2A2751F-0259-4CA6-A742-D859EF73D11D}"/>
               </a:ext>
             </a:extLst>
           </p:cNvPr>
@@ -13197,7 +13197,7 @@
           <p:cNvPr id="10" name="">
             <a:extLst xmlns:a="http://schemas.openxmlformats.org/drawingml/2006/main">
               <a:ext uri="{FF2B5EF4-FFF2-40B4-BE49-F238E27FC236}">
-                <a16:creationId xmlns:a16="http://schemas.microsoft.com/office/drawing/2014/main" id="{6023DDA6-D760-4B66-B62F-B5464092CF94}"/>
+                <a16:creationId xmlns:a16="http://schemas.microsoft.com/office/drawing/2014/main" id="{61599F00-89DB-46D8-A077-ACD1FEA16A91}"/>
               </a:ext>
             </a:extLst>
           </p:cNvPr>
@@ -13254,7 +13254,7 @@
           <p:cNvPr id="11" name="">
             <a:extLst xmlns:a="http://schemas.openxmlformats.org/drawingml/2006/main">
               <a:ext uri="{FF2B5EF4-FFF2-40B4-BE49-F238E27FC236}">
-                <a16:creationId xmlns:a16="http://schemas.microsoft.com/office/drawing/2014/main" id="{EF1CC71A-C229-41DB-BBAF-1E38061ABAE3}"/>
+                <a16:creationId xmlns:a16="http://schemas.microsoft.com/office/drawing/2014/main" id="{9D43D7C2-AB57-4B56-9717-043B30BAED47}"/>
               </a:ext>
             </a:extLst>
           </p:cNvPr>
@@ -13309,7 +13309,7 @@
     </p:spTree>
     <p:extLst>
       <p:ext uri="{BB962C8B-B14F-4D97-AF65-F5344CB8AC3E}">
-        <p14:creationId xmlns:p14="http://schemas.microsoft.com/office/powerpoint/2010/main" val="1740811960"/>
+        <p14:creationId xmlns:p14="http://schemas.microsoft.com/office/powerpoint/2010/main" val="774045049"/>
       </p:ext>
     </p:extLst>
   </p:cSld>
@@ -13340,7 +13340,7 @@
           <p:cNvPr id="12" name="">
             <a:extLst xmlns:a="http://schemas.openxmlformats.org/drawingml/2006/main">
               <a:ext uri="{FF2B5EF4-FFF2-40B4-BE49-F238E27FC236}">
-                <a16:creationId xmlns:a16="http://schemas.microsoft.com/office/drawing/2014/main" id="{BC114E8C-8101-44ED-A64D-B8481ED4C48A}"/>
+                <a16:creationId xmlns:a16="http://schemas.microsoft.com/office/drawing/2014/main" id="{AAAA1DAD-B68B-4C61-BD68-E460F0539ADE}"/>
               </a:ext>
             </a:extLst>
           </p:cNvPr>
@@ -13370,7 +13370,7 @@
           <p:cNvPr id="2" name="">
             <a:extLst xmlns:a="http://schemas.openxmlformats.org/drawingml/2006/main">
               <a:ext uri="{FF2B5EF4-FFF2-40B4-BE49-F238E27FC236}">
-                <a16:creationId xmlns:a16="http://schemas.microsoft.com/office/drawing/2014/main" id="{72DB6781-C24F-49CB-9087-C3A8C4F77A2E}"/>
+                <a16:creationId xmlns:a16="http://schemas.microsoft.com/office/drawing/2014/main" id="{FD2C9FEB-0713-4AED-931A-F6ACC2E75719}"/>
               </a:ext>
             </a:extLst>
           </p:cNvPr>
@@ -13427,7 +13427,7 @@
           <p:cNvPr id="3" name="">
             <a:extLst xmlns:a="http://schemas.openxmlformats.org/drawingml/2006/main">
               <a:ext uri="{FF2B5EF4-FFF2-40B4-BE49-F238E27FC236}">
-                <a16:creationId xmlns:a16="http://schemas.microsoft.com/office/drawing/2014/main" id="{257043BD-FC96-47C7-AA8F-E8AB27570460}"/>
+                <a16:creationId xmlns:a16="http://schemas.microsoft.com/office/drawing/2014/main" id="{984E29C0-C0E3-48DB-A669-5F896BDCA43C}"/>
               </a:ext>
             </a:extLst>
           </p:cNvPr>
@@ -13457,7 +13457,7 @@
           <p:cNvPr id="4" name="">
             <a:extLst xmlns:a="http://schemas.openxmlformats.org/drawingml/2006/main">
               <a:ext uri="{FF2B5EF4-FFF2-40B4-BE49-F238E27FC236}">
-                <a16:creationId xmlns:a16="http://schemas.microsoft.com/office/drawing/2014/main" id="{A6413FE1-E63A-4875-9C89-F8D5435E9C84}"/>
+                <a16:creationId xmlns:a16="http://schemas.microsoft.com/office/drawing/2014/main" id="{F5A1B8C2-530F-4C8C-89F6-B4E96C97E4F6}"/>
               </a:ext>
             </a:extLst>
           </p:cNvPr>
@@ -13514,7 +13514,7 @@
           <p:cNvPr id="5" name="">
             <a:extLst xmlns:a="http://schemas.openxmlformats.org/drawingml/2006/main">
               <a:ext uri="{FF2B5EF4-FFF2-40B4-BE49-F238E27FC236}">
-                <a16:creationId xmlns:a16="http://schemas.microsoft.com/office/drawing/2014/main" id="{E143FF19-D41E-432F-BDD0-8F87C2D3E94F}"/>
+                <a16:creationId xmlns:a16="http://schemas.microsoft.com/office/drawing/2014/main" id="{D778635B-5DAC-471A-A0E6-D21BAA7981FD}"/>
               </a:ext>
             </a:extLst>
           </p:cNvPr>
@@ -13546,7 +13546,7 @@
           <p:cNvPr id="6" name="">
             <a:extLst xmlns:a="http://schemas.openxmlformats.org/drawingml/2006/main">
               <a:ext uri="{FF2B5EF4-FFF2-40B4-BE49-F238E27FC236}">
-                <a16:creationId xmlns:a16="http://schemas.microsoft.com/office/drawing/2014/main" id="{A6E97CA5-A9F0-434C-A830-9090C6543549}"/>
+                <a16:creationId xmlns:a16="http://schemas.microsoft.com/office/drawing/2014/main" id="{AAE1CBD6-880F-4D8E-B52C-ECAAF6D9EBE1}"/>
               </a:ext>
             </a:extLst>
           </p:cNvPr>
@@ -13582,7 +13582,7 @@
           <p:nvPr/>
         </p:nvPicPr>
         <p:blipFill>
-          <a:blip xmlns:r="http://schemas.openxmlformats.org/officeDocument/2006/relationships" xmlns:a="http://schemas.openxmlformats.org/drawingml/2006/main" r:embed="Rf04cffc3e0504d48"/>
+          <a:blip xmlns:r="http://schemas.openxmlformats.org/officeDocument/2006/relationships" xmlns:a="http://schemas.openxmlformats.org/drawingml/2006/main" r:embed="R9a67a674c9404a9e"/>
           <a:stretch xmlns:a="http://schemas.openxmlformats.org/drawingml/2006/main"/>
         </p:blipFill>
         <p:spPr>
@@ -13604,7 +13604,7 @@
           <p:nvPr/>
         </p:nvPicPr>
         <p:blipFill>
-          <a:blip xmlns:r="http://schemas.openxmlformats.org/officeDocument/2006/relationships" xmlns:a="http://schemas.openxmlformats.org/drawingml/2006/main" r:embed="Re232f79b6c1746a2"/>
+          <a:blip xmlns:r="http://schemas.openxmlformats.org/officeDocument/2006/relationships" xmlns:a="http://schemas.openxmlformats.org/drawingml/2006/main" r:embed="R93e1876782264bf3"/>
           <a:stretch xmlns:a="http://schemas.openxmlformats.org/drawingml/2006/main"/>
         </p:blipFill>
         <p:spPr>
@@ -13622,7 +13622,7 @@
           <p:cNvPr id="9" name="">
             <a:extLst xmlns:a="http://schemas.openxmlformats.org/drawingml/2006/main">
               <a:ext uri="{FF2B5EF4-FFF2-40B4-BE49-F238E27FC236}">
-                <a16:creationId xmlns:a16="http://schemas.microsoft.com/office/drawing/2014/main" id="{2B62F258-BD70-4C80-A810-397EF4A28483}"/>
+                <a16:creationId xmlns:a16="http://schemas.microsoft.com/office/drawing/2014/main" id="{512B87EB-CE17-4FC8-9ED5-7170C966A054}"/>
               </a:ext>
             </a:extLst>
           </p:cNvPr>
@@ -13679,7 +13679,7 @@
           <p:cNvPr id="10" name="">
             <a:extLst xmlns:a="http://schemas.openxmlformats.org/drawingml/2006/main">
               <a:ext uri="{FF2B5EF4-FFF2-40B4-BE49-F238E27FC236}">
-                <a16:creationId xmlns:a16="http://schemas.microsoft.com/office/drawing/2014/main" id="{951AA9B9-CD49-4589-890D-E089A3074958}"/>
+                <a16:creationId xmlns:a16="http://schemas.microsoft.com/office/drawing/2014/main" id="{06A594C1-7AC0-4674-B411-1454CA8B1FFC}"/>
               </a:ext>
             </a:extLst>
           </p:cNvPr>
@@ -13736,7 +13736,7 @@
           <p:cNvPr id="11" name="">
             <a:extLst xmlns:a="http://schemas.openxmlformats.org/drawingml/2006/main">
               <a:ext uri="{FF2B5EF4-FFF2-40B4-BE49-F238E27FC236}">
-                <a16:creationId xmlns:a16="http://schemas.microsoft.com/office/drawing/2014/main" id="{35C3CD68-B5BC-4724-A60F-46DA886E3FB8}"/>
+                <a16:creationId xmlns:a16="http://schemas.microsoft.com/office/drawing/2014/main" id="{A50657A5-45C6-4AB8-B5CC-8A9AB21196E0}"/>
               </a:ext>
             </a:extLst>
           </p:cNvPr>
@@ -13791,7 +13791,7 @@
     </p:spTree>
     <p:extLst>
       <p:ext uri="{BB962C8B-B14F-4D97-AF65-F5344CB8AC3E}">
-        <p14:creationId xmlns:p14="http://schemas.microsoft.com/office/powerpoint/2010/main" val="1315261781"/>
+        <p14:creationId xmlns:p14="http://schemas.microsoft.com/office/powerpoint/2010/main" val="2094041068"/>
       </p:ext>
     </p:extLst>
   </p:cSld>
@@ -13822,7 +13822,7 @@
           <p:cNvPr id="27" name="">
             <a:extLst xmlns:a="http://schemas.openxmlformats.org/drawingml/2006/main">
               <a:ext uri="{FF2B5EF4-FFF2-40B4-BE49-F238E27FC236}">
-                <a16:creationId xmlns:a16="http://schemas.microsoft.com/office/drawing/2014/main" id="{66620607-C16B-4F49-83AC-AD06F4ADEDF5}"/>
+                <a16:creationId xmlns:a16="http://schemas.microsoft.com/office/drawing/2014/main" id="{1DD38E81-A94A-4458-A357-8F95E4005259}"/>
               </a:ext>
             </a:extLst>
           </p:cNvPr>
@@ -13852,7 +13852,7 @@
           <p:cNvPr id="2" name="">
             <a:extLst xmlns:a="http://schemas.openxmlformats.org/drawingml/2006/main">
               <a:ext uri="{FF2B5EF4-FFF2-40B4-BE49-F238E27FC236}">
-                <a16:creationId xmlns:a16="http://schemas.microsoft.com/office/drawing/2014/main" id="{8A339FC0-4078-456A-87BC-8D001F25EE23}"/>
+                <a16:creationId xmlns:a16="http://schemas.microsoft.com/office/drawing/2014/main" id="{33A83B2F-1D61-464E-B7B5-2D1A4D215A9E}"/>
               </a:ext>
             </a:extLst>
           </p:cNvPr>
@@ -13909,7 +13909,7 @@
           <p:cNvPr id="3" name="">
             <a:extLst xmlns:a="http://schemas.openxmlformats.org/drawingml/2006/main">
               <a:ext uri="{FF2B5EF4-FFF2-40B4-BE49-F238E27FC236}">
-                <a16:creationId xmlns:a16="http://schemas.microsoft.com/office/drawing/2014/main" id="{AAE1ADD2-A7F9-4090-A5C9-7D1A27D52BD4}"/>
+                <a16:creationId xmlns:a16="http://schemas.microsoft.com/office/drawing/2014/main" id="{E2A132B8-821D-4EF8-91B4-91533C8EBE0C}"/>
               </a:ext>
             </a:extLst>
           </p:cNvPr>
@@ -13939,7 +13939,7 @@
           <p:cNvPr id="4" name="">
             <a:extLst xmlns:a="http://schemas.openxmlformats.org/drawingml/2006/main">
               <a:ext uri="{FF2B5EF4-FFF2-40B4-BE49-F238E27FC236}">
-                <a16:creationId xmlns:a16="http://schemas.microsoft.com/office/drawing/2014/main" id="{90F7CD2E-A540-4707-AD50-B707010A9BC7}"/>
+                <a16:creationId xmlns:a16="http://schemas.microsoft.com/office/drawing/2014/main" id="{4573E0C3-27F4-48E0-98B1-5A71B04BAABB}"/>
               </a:ext>
             </a:extLst>
           </p:cNvPr>
@@ -13996,7 +13996,7 @@
           <p:cNvPr id="5" name="">
             <a:extLst xmlns:a="http://schemas.openxmlformats.org/drawingml/2006/main">
               <a:ext uri="{FF2B5EF4-FFF2-40B4-BE49-F238E27FC236}">
-                <a16:creationId xmlns:a16="http://schemas.microsoft.com/office/drawing/2014/main" id="{34F8B9FD-B94E-4D7E-8029-9040312E6B4B}"/>
+                <a16:creationId xmlns:a16="http://schemas.microsoft.com/office/drawing/2014/main" id="{FC6C54DF-754A-473C-85E8-618D04AECF37}"/>
               </a:ext>
             </a:extLst>
           </p:cNvPr>
@@ -14028,7 +14028,7 @@
           <p:cNvPr id="6" name="">
             <a:extLst xmlns:a="http://schemas.openxmlformats.org/drawingml/2006/main">
               <a:ext uri="{FF2B5EF4-FFF2-40B4-BE49-F238E27FC236}">
-                <a16:creationId xmlns:a16="http://schemas.microsoft.com/office/drawing/2014/main" id="{0F6630C8-ED14-4541-8908-216D45A97F0B}"/>
+                <a16:creationId xmlns:a16="http://schemas.microsoft.com/office/drawing/2014/main" id="{D88C1D0A-AADE-42C3-8B9D-E370377B612B}"/>
               </a:ext>
             </a:extLst>
           </p:cNvPr>
@@ -14085,7 +14085,7 @@
           <p:cNvPr id="7" name="">
             <a:extLst xmlns:a="http://schemas.openxmlformats.org/drawingml/2006/main">
               <a:ext uri="{FF2B5EF4-FFF2-40B4-BE49-F238E27FC236}">
-                <a16:creationId xmlns:a16="http://schemas.microsoft.com/office/drawing/2014/main" id="{EB864EDB-4485-4992-A782-CF4B80258B47}"/>
+                <a16:creationId xmlns:a16="http://schemas.microsoft.com/office/drawing/2014/main" id="{E3E4B704-91F6-4DBF-9E5A-14762915CE7B}"/>
               </a:ext>
             </a:extLst>
           </p:cNvPr>
@@ -14142,7 +14142,7 @@
           <p:cNvPr id="8" name="">
             <a:extLst xmlns:a="http://schemas.openxmlformats.org/drawingml/2006/main">
               <a:ext uri="{FF2B5EF4-FFF2-40B4-BE49-F238E27FC236}">
-                <a16:creationId xmlns:a16="http://schemas.microsoft.com/office/drawing/2014/main" id="{9E3494F2-5924-4BD5-AD9E-03951DF27760}"/>
+                <a16:creationId xmlns:a16="http://schemas.microsoft.com/office/drawing/2014/main" id="{42856105-61BC-43BF-B391-D4461B04CB50}"/>
               </a:ext>
             </a:extLst>
           </p:cNvPr>
@@ -14222,7 +14222,7 @@
           <p:cNvPr id="9" name="">
             <a:extLst xmlns:a="http://schemas.openxmlformats.org/drawingml/2006/main">
               <a:ext uri="{FF2B5EF4-FFF2-40B4-BE49-F238E27FC236}">
-                <a16:creationId xmlns:a16="http://schemas.microsoft.com/office/drawing/2014/main" id="{4ADF35E7-2CDD-4402-8FED-4F61A6B83E65}"/>
+                <a16:creationId xmlns:a16="http://schemas.microsoft.com/office/drawing/2014/main" id="{8BEE3044-050A-414D-AAD8-04A2162ACEDC}"/>
               </a:ext>
             </a:extLst>
           </p:cNvPr>
@@ -14254,7 +14254,7 @@
           <p:cNvPr id="10" name="">
             <a:extLst xmlns:a="http://schemas.openxmlformats.org/drawingml/2006/main">
               <a:ext uri="{FF2B5EF4-FFF2-40B4-BE49-F238E27FC236}">
-                <a16:creationId xmlns:a16="http://schemas.microsoft.com/office/drawing/2014/main" id="{570CB376-955E-43C1-8496-924E16FA7B67}"/>
+                <a16:creationId xmlns:a16="http://schemas.microsoft.com/office/drawing/2014/main" id="{0018FAA9-E69D-41C3-9DEC-853AFE9FCF61}"/>
               </a:ext>
             </a:extLst>
           </p:cNvPr>
@@ -14311,7 +14311,7 @@
           <p:cNvPr id="11" name="">
             <a:extLst xmlns:a="http://schemas.openxmlformats.org/drawingml/2006/main">
               <a:ext uri="{FF2B5EF4-FFF2-40B4-BE49-F238E27FC236}">
-                <a16:creationId xmlns:a16="http://schemas.microsoft.com/office/drawing/2014/main" id="{A612C935-46EA-470F-B19D-67AF21FFFDF2}"/>
+                <a16:creationId xmlns:a16="http://schemas.microsoft.com/office/drawing/2014/main" id="{3C8D35D3-5E35-47AB-A944-E4DA87342795}"/>
               </a:ext>
             </a:extLst>
           </p:cNvPr>
@@ -14368,7 +14368,7 @@
           <p:cNvPr id="12" name="">
             <a:extLst xmlns:a="http://schemas.openxmlformats.org/drawingml/2006/main">
               <a:ext uri="{FF2B5EF4-FFF2-40B4-BE49-F238E27FC236}">
-                <a16:creationId xmlns:a16="http://schemas.microsoft.com/office/drawing/2014/main" id="{5DA930FC-D04C-4246-86E5-FBCDD446A9A8}"/>
+                <a16:creationId xmlns:a16="http://schemas.microsoft.com/office/drawing/2014/main" id="{2DCCF991-195D-4DAC-8413-015A8A001BFF}"/>
               </a:ext>
             </a:extLst>
           </p:cNvPr>
@@ -14448,7 +14448,7 @@
           <p:cNvPr id="13" name="">
             <a:extLst xmlns:a="http://schemas.openxmlformats.org/drawingml/2006/main">
               <a:ext uri="{FF2B5EF4-FFF2-40B4-BE49-F238E27FC236}">
-                <a16:creationId xmlns:a16="http://schemas.microsoft.com/office/drawing/2014/main" id="{E369BDB6-5DB5-40C7-904F-1D2C77283963}"/>
+                <a16:creationId xmlns:a16="http://schemas.microsoft.com/office/drawing/2014/main" id="{1A359B9F-94F6-429E-AE6F-9630C96FE722}"/>
               </a:ext>
             </a:extLst>
           </p:cNvPr>
@@ -14480,7 +14480,7 @@
           <p:cNvPr id="14" name="">
             <a:extLst xmlns:a="http://schemas.openxmlformats.org/drawingml/2006/main">
               <a:ext uri="{FF2B5EF4-FFF2-40B4-BE49-F238E27FC236}">
-                <a16:creationId xmlns:a16="http://schemas.microsoft.com/office/drawing/2014/main" id="{F05FC300-37F1-4B36-A04F-0D94257830EF}"/>
+                <a16:creationId xmlns:a16="http://schemas.microsoft.com/office/drawing/2014/main" id="{82ED5AE3-E41B-4809-8F52-82CB4B5C372C}"/>
               </a:ext>
             </a:extLst>
           </p:cNvPr>
@@ -14537,7 +14537,7 @@
           <p:cNvPr id="15" name="">
             <a:extLst xmlns:a="http://schemas.openxmlformats.org/drawingml/2006/main">
               <a:ext uri="{FF2B5EF4-FFF2-40B4-BE49-F238E27FC236}">
-                <a16:creationId xmlns:a16="http://schemas.microsoft.com/office/drawing/2014/main" id="{C2898703-D961-4C3F-AEB0-0B712906F12F}"/>
+                <a16:creationId xmlns:a16="http://schemas.microsoft.com/office/drawing/2014/main" id="{069B6A9B-9042-453C-B618-249191C0EAC4}"/>
               </a:ext>
             </a:extLst>
           </p:cNvPr>
@@ -14594,7 +14594,7 @@
           <p:cNvPr id="16" name="">
             <a:extLst xmlns:a="http://schemas.openxmlformats.org/drawingml/2006/main">
               <a:ext uri="{FF2B5EF4-FFF2-40B4-BE49-F238E27FC236}">
-                <a16:creationId xmlns:a16="http://schemas.microsoft.com/office/drawing/2014/main" id="{7ED8CA61-D862-45A6-B189-904A3A02326E}"/>
+                <a16:creationId xmlns:a16="http://schemas.microsoft.com/office/drawing/2014/main" id="{BF065F0C-F8A8-4358-8083-0F68877870D8}"/>
               </a:ext>
             </a:extLst>
           </p:cNvPr>
@@ -14674,7 +14674,7 @@
           <p:cNvPr id="17" name="">
             <a:extLst xmlns:a="http://schemas.openxmlformats.org/drawingml/2006/main">
               <a:ext uri="{FF2B5EF4-FFF2-40B4-BE49-F238E27FC236}">
-                <a16:creationId xmlns:a16="http://schemas.microsoft.com/office/drawing/2014/main" id="{03EF750B-D497-4643-A4C8-7C1601626BF2}"/>
+                <a16:creationId xmlns:a16="http://schemas.microsoft.com/office/drawing/2014/main" id="{0AC39666-95C8-43C0-A387-270D8F8A7803}"/>
               </a:ext>
             </a:extLst>
           </p:cNvPr>
@@ -14706,7 +14706,7 @@
           <p:cNvPr id="18" name="">
             <a:extLst xmlns:a="http://schemas.openxmlformats.org/drawingml/2006/main">
               <a:ext uri="{FF2B5EF4-FFF2-40B4-BE49-F238E27FC236}">
-                <a16:creationId xmlns:a16="http://schemas.microsoft.com/office/drawing/2014/main" id="{01D8DA9D-5248-4972-9484-BC08961176E5}"/>
+                <a16:creationId xmlns:a16="http://schemas.microsoft.com/office/drawing/2014/main" id="{E49573B3-A39F-45CD-83B6-75705C3AF10B}"/>
               </a:ext>
             </a:extLst>
           </p:cNvPr>
@@ -14763,7 +14763,7 @@
           <p:cNvPr id="19" name="">
             <a:extLst xmlns:a="http://schemas.openxmlformats.org/drawingml/2006/main">
               <a:ext uri="{FF2B5EF4-FFF2-40B4-BE49-F238E27FC236}">
-                <a16:creationId xmlns:a16="http://schemas.microsoft.com/office/drawing/2014/main" id="{4FE5EEDC-AFF4-444B-A246-AD1BF5EA7200}"/>
+                <a16:creationId xmlns:a16="http://schemas.microsoft.com/office/drawing/2014/main" id="{A541FE01-496B-47C8-ACE3-1F2600EBABAE}"/>
               </a:ext>
             </a:extLst>
           </p:cNvPr>
@@ -14820,7 +14820,7 @@
           <p:cNvPr id="20" name="">
             <a:extLst xmlns:a="http://schemas.openxmlformats.org/drawingml/2006/main">
               <a:ext uri="{FF2B5EF4-FFF2-40B4-BE49-F238E27FC236}">
-                <a16:creationId xmlns:a16="http://schemas.microsoft.com/office/drawing/2014/main" id="{D9EA0EBA-46EA-4BD4-97A9-2157B9435683}"/>
+                <a16:creationId xmlns:a16="http://schemas.microsoft.com/office/drawing/2014/main" id="{44DE1061-15C7-4A0B-BEED-D941F2EF70C4}"/>
               </a:ext>
             </a:extLst>
           </p:cNvPr>
@@ -14900,7 +14900,7 @@
           <p:cNvPr id="21" name="">
             <a:extLst xmlns:a="http://schemas.openxmlformats.org/drawingml/2006/main">
               <a:ext uri="{FF2B5EF4-FFF2-40B4-BE49-F238E27FC236}">
-                <a16:creationId xmlns:a16="http://schemas.microsoft.com/office/drawing/2014/main" id="{2FDD2A37-AB97-4CAC-816C-F62C96E35B0C}"/>
+                <a16:creationId xmlns:a16="http://schemas.microsoft.com/office/drawing/2014/main" id="{FCF28743-F447-4D18-96EB-B0CAC6EAA9B0}"/>
               </a:ext>
             </a:extLst>
           </p:cNvPr>
@@ -14957,7 +14957,7 @@
           <p:cNvPr id="22" name="">
             <a:extLst xmlns:a="http://schemas.openxmlformats.org/drawingml/2006/main">
               <a:ext uri="{FF2B5EF4-FFF2-40B4-BE49-F238E27FC236}">
-                <a16:creationId xmlns:a16="http://schemas.microsoft.com/office/drawing/2014/main" id="{BC4009C3-0A07-4029-8396-2BA8FCE6501C}"/>
+                <a16:creationId xmlns:a16="http://schemas.microsoft.com/office/drawing/2014/main" id="{15606E55-7A72-4B31-8C60-78FBC1559B40}"/>
               </a:ext>
             </a:extLst>
           </p:cNvPr>
@@ -15014,7 +15014,7 @@
           <p:cNvPr id="23" name="">
             <a:extLst xmlns:a="http://schemas.openxmlformats.org/drawingml/2006/main">
               <a:ext uri="{FF2B5EF4-FFF2-40B4-BE49-F238E27FC236}">
-                <a16:creationId xmlns:a16="http://schemas.microsoft.com/office/drawing/2014/main" id="{6BD5B5BF-5A90-4C46-A437-D7D94060AEC2}"/>
+                <a16:creationId xmlns:a16="http://schemas.microsoft.com/office/drawing/2014/main" id="{138F50D4-DFBD-459B-BB15-51FE77705C72}"/>
               </a:ext>
             </a:extLst>
           </p:cNvPr>
@@ -15071,7 +15071,7 @@
           <p:cNvPr id="24" name="">
             <a:extLst xmlns:a="http://schemas.openxmlformats.org/drawingml/2006/main">
               <a:ext uri="{FF2B5EF4-FFF2-40B4-BE49-F238E27FC236}">
-                <a16:creationId xmlns:a16="http://schemas.microsoft.com/office/drawing/2014/main" id="{1627FAE8-6934-48E5-94AE-F772DCCA403B}"/>
+                <a16:creationId xmlns:a16="http://schemas.microsoft.com/office/drawing/2014/main" id="{DBF226B6-AB73-495A-A27F-59C0AC8CE264}"/>
               </a:ext>
             </a:extLst>
           </p:cNvPr>
@@ -15128,7 +15128,7 @@
           <p:cNvPr id="25" name="">
             <a:extLst xmlns:a="http://schemas.openxmlformats.org/drawingml/2006/main">
               <a:ext uri="{FF2B5EF4-FFF2-40B4-BE49-F238E27FC236}">
-                <a16:creationId xmlns:a16="http://schemas.microsoft.com/office/drawing/2014/main" id="{2EF215B9-8A57-4A60-80AE-701B6D9036EF}"/>
+                <a16:creationId xmlns:a16="http://schemas.microsoft.com/office/drawing/2014/main" id="{A2E6213C-0502-49CA-A48B-2617187A172B}"/>
               </a:ext>
             </a:extLst>
           </p:cNvPr>
@@ -15185,7 +15185,7 @@
           <p:cNvPr id="26" name="">
             <a:extLst xmlns:a="http://schemas.openxmlformats.org/drawingml/2006/main">
               <a:ext uri="{FF2B5EF4-FFF2-40B4-BE49-F238E27FC236}">
-                <a16:creationId xmlns:a16="http://schemas.microsoft.com/office/drawing/2014/main" id="{0D7C30DA-802D-4833-A661-2E01416ACFA4}"/>
+                <a16:creationId xmlns:a16="http://schemas.microsoft.com/office/drawing/2014/main" id="{AD294938-3E29-4954-990E-3E2837CC4B69}"/>
               </a:ext>
             </a:extLst>
           </p:cNvPr>
@@ -15240,7 +15240,7 @@
     </p:spTree>
     <p:extLst>
       <p:ext uri="{BB962C8B-B14F-4D97-AF65-F5344CB8AC3E}">
-        <p14:creationId xmlns:p14="http://schemas.microsoft.com/office/powerpoint/2010/main" val="1067670571"/>
+        <p14:creationId xmlns:p14="http://schemas.microsoft.com/office/powerpoint/2010/main" val="45135520"/>
       </p:ext>
     </p:extLst>
   </p:cSld>

</xml_diff>

<commit_message>
docs: refine final presentation plan (#10)
</commit_message>
<xml_diff>
--- a/docs/presentation/MEMOIVE-Presentation.pptx
+++ b/docs/presentation/MEMOIVE-Presentation.pptx
@@ -2,26 +2,26 @@
 <file path=ppt/presentation.xml><?xml version="1.0" encoding="utf-8"?>
 <p:presentation xmlns:p="http://schemas.openxmlformats.org/presentationml/2006/main">
   <p:sldMasterIdLst>
-    <p:sldMasterId xmlns:r="http://schemas.openxmlformats.org/officeDocument/2006/relationships" id="2147483648" r:id="R63389ff20b7d4eed"/>
+    <p:sldMasterId xmlns:r="http://schemas.openxmlformats.org/officeDocument/2006/relationships" id="2147483648" r:id="R1a60270e200f46ab"/>
   </p:sldMasterIdLst>
   <p:notesMasterIdLst>
-    <p:notesMasterId xmlns:r="http://schemas.openxmlformats.org/officeDocument/2006/relationships" r:id="Rb497f1323ac941dc"/>
+    <p:notesMasterId xmlns:r="http://schemas.openxmlformats.org/officeDocument/2006/relationships" r:id="R2d6d1e16300b4194"/>
   </p:notesMasterIdLst>
   <p:sldIdLst>
-    <p:sldId xmlns:r="http://schemas.openxmlformats.org/officeDocument/2006/relationships" id="256" r:id="R1739812baeb64f79"/>
-    <p:sldId xmlns:r="http://schemas.openxmlformats.org/officeDocument/2006/relationships" id="257" r:id="R6fbbc29ce7904e98"/>
-    <p:sldId xmlns:r="http://schemas.openxmlformats.org/officeDocument/2006/relationships" id="258" r:id="R0c7cba70407243af"/>
-    <p:sldId xmlns:r="http://schemas.openxmlformats.org/officeDocument/2006/relationships" id="259" r:id="R91735f8c03cb44c9"/>
-    <p:sldId xmlns:r="http://schemas.openxmlformats.org/officeDocument/2006/relationships" id="260" r:id="Rffe5c07723364782"/>
-    <p:sldId xmlns:r="http://schemas.openxmlformats.org/officeDocument/2006/relationships" id="261" r:id="R30324338e4d341b7"/>
-    <p:sldId xmlns:r="http://schemas.openxmlformats.org/officeDocument/2006/relationships" id="262" r:id="R804a309e3c97409e"/>
-    <p:sldId xmlns:r="http://schemas.openxmlformats.org/officeDocument/2006/relationships" id="263" r:id="Rcdf0f5579d3a493e"/>
-    <p:sldId xmlns:r="http://schemas.openxmlformats.org/officeDocument/2006/relationships" id="264" r:id="R5136b9a09f634f70"/>
-    <p:sldId xmlns:r="http://schemas.openxmlformats.org/officeDocument/2006/relationships" id="265" r:id="R5d1a575e057844b7"/>
-    <p:sldId xmlns:r="http://schemas.openxmlformats.org/officeDocument/2006/relationships" id="266" r:id="R870ab957b1ec4876"/>
-    <p:sldId xmlns:r="http://schemas.openxmlformats.org/officeDocument/2006/relationships" id="267" r:id="R4b9d3561e23c4b63"/>
-    <p:sldId xmlns:r="http://schemas.openxmlformats.org/officeDocument/2006/relationships" id="268" r:id="R7187c620ce2542d2"/>
-    <p:sldId xmlns:r="http://schemas.openxmlformats.org/officeDocument/2006/relationships" id="269" r:id="Raeac6acf29b14569"/>
+    <p:sldId xmlns:r="http://schemas.openxmlformats.org/officeDocument/2006/relationships" id="256" r:id="R0a738db1ca9b483f"/>
+    <p:sldId xmlns:r="http://schemas.openxmlformats.org/officeDocument/2006/relationships" id="257" r:id="R069f10033e1944a8"/>
+    <p:sldId xmlns:r="http://schemas.openxmlformats.org/officeDocument/2006/relationships" id="258" r:id="R1dd8a136fc114d6a"/>
+    <p:sldId xmlns:r="http://schemas.openxmlformats.org/officeDocument/2006/relationships" id="259" r:id="Raf8442e921a643be"/>
+    <p:sldId xmlns:r="http://schemas.openxmlformats.org/officeDocument/2006/relationships" id="260" r:id="Rf257e9cae60a48d8"/>
+    <p:sldId xmlns:r="http://schemas.openxmlformats.org/officeDocument/2006/relationships" id="261" r:id="R86202cd60a874593"/>
+    <p:sldId xmlns:r="http://schemas.openxmlformats.org/officeDocument/2006/relationships" id="262" r:id="R9bb53f23bc194338"/>
+    <p:sldId xmlns:r="http://schemas.openxmlformats.org/officeDocument/2006/relationships" id="263" r:id="Rd67e6dd9b8a74713"/>
+    <p:sldId xmlns:r="http://schemas.openxmlformats.org/officeDocument/2006/relationships" id="264" r:id="R32f3e467ee5b4a33"/>
+    <p:sldId xmlns:r="http://schemas.openxmlformats.org/officeDocument/2006/relationships" id="265" r:id="Ra548dd90f7a54d25"/>
+    <p:sldId xmlns:r="http://schemas.openxmlformats.org/officeDocument/2006/relationships" id="266" r:id="R98cdc3cd49eb47c1"/>
+    <p:sldId xmlns:r="http://schemas.openxmlformats.org/officeDocument/2006/relationships" id="267" r:id="R283830d15b5c40be"/>
+    <p:sldId xmlns:r="http://schemas.openxmlformats.org/officeDocument/2006/relationships" id="268" r:id="R6e7e07575f29464b"/>
+    <p:sldId xmlns:r="http://schemas.openxmlformats.org/officeDocument/2006/relationships" id="269" r:id="R45b695db13b04bff"/>
   </p:sldIdLst>
   <p:sldSz cx="12192000" cy="6858000"/>
   <p:notesSz cx="6858000" cy="9144000"/>
@@ -935,7 +935,7 @@
           </a:p>
           <a:p xmlns:a="http://schemas.openxmlformats.org/drawingml/2006/main">
             <a:r>
-              <a:t>메모이브는 memoive.vercel.app에서 확인할 수 있습니다. 다음 단계에서는 먼저 3명을 관찰하고 5명 시험으로 막히는 위치와 시간 단축을 확인하겠습니다. 여러 사용자가 쓰는 단계에 도달하면 계정 로그인과 사용자별 기록 권한을 구현하고, 반복 사용이 확인되면 검색 필터와 결과물 버전 관리를 개선하겠습니다. 검증 결과에 따라 필요한 기능부터 구현하겠습니다. 감사합니다.</a:t>
+              <a:t>메모이브는 memoive.vercel.app에서 확인할 수 있습니다. 다음 단계의 첫 번째 초점은 시간 단축입니다. 자료를 정리하고 결과물로 만드는 데 걸리는 시간이 실제로 줄어드는지 확인하겠습니다. 지금은 제가 혼자 쓰는 서비스이므로, 두 번째는 다양한 사람이 사용할 수 있는 범용 서비스로 확장하는 것입니다. 반복 사용이 확인되면 검색 필터와 결과물 버전 관리도 개선하겠습니다. 감사합니다.</a:t>
             </a:r>
           </a:p>
           <a:p xmlns:a="http://schemas.openxmlformats.org/drawingml/2006/main">
@@ -1783,7 +1783,7 @@
   </p:cSld>
   <p:clrMap bg1="lt1" tx1="dk1" bg2="lt2" tx2="dk2" accent1="accent1" accent2="accent2" accent3="accent3" accent4="accent4" accent5="accent5" accent6="accent6" hlink="hlink" folHlink="folHlink"/>
   <p:sldLayoutIdLst>
-    <p:sldLayoutId xmlns:r="http://schemas.openxmlformats.org/officeDocument/2006/relationships" id="2147483649" r:id="Red940412a11a41a4"/>
+    <p:sldLayoutId xmlns:r="http://schemas.openxmlformats.org/officeDocument/2006/relationships" id="2147483649" r:id="R7de44020cc874305"/>
   </p:sldLayoutIdLst>
   <p:txStyles>
     <p:titleStyle>
@@ -2334,7 +2334,7 @@
           <p:cNvPr id="9" name="">
             <a:extLst xmlns:a="http://schemas.openxmlformats.org/drawingml/2006/main">
               <a:ext uri="{FF2B5EF4-FFF2-40B4-BE49-F238E27FC236}">
-                <a16:creationId xmlns:a16="http://schemas.microsoft.com/office/drawing/2014/main" id="{E30A8B98-532C-4E10-A8E4-C4239BBB3436}"/>
+                <a16:creationId xmlns:a16="http://schemas.microsoft.com/office/drawing/2014/main" id="{BA47CF77-DD35-45CC-8A5B-996D2707CB49}"/>
               </a:ext>
             </a:extLst>
           </p:cNvPr>
@@ -2391,7 +2391,7 @@
           <p:cNvPr id="2" name="">
             <a:extLst xmlns:a="http://schemas.openxmlformats.org/drawingml/2006/main">
               <a:ext uri="{FF2B5EF4-FFF2-40B4-BE49-F238E27FC236}">
-                <a16:creationId xmlns:a16="http://schemas.microsoft.com/office/drawing/2014/main" id="{F8AD504B-8E3B-4222-9985-CDE3310167DA}"/>
+                <a16:creationId xmlns:a16="http://schemas.microsoft.com/office/drawing/2014/main" id="{F0A7A424-5A8E-4ADA-B071-31E9DE023B5F}"/>
               </a:ext>
             </a:extLst>
           </p:cNvPr>
@@ -2448,7 +2448,7 @@
           <p:cNvPr id="3" name="">
             <a:extLst xmlns:a="http://schemas.openxmlformats.org/drawingml/2006/main">
               <a:ext uri="{FF2B5EF4-FFF2-40B4-BE49-F238E27FC236}">
-                <a16:creationId xmlns:a16="http://schemas.microsoft.com/office/drawing/2014/main" id="{727D0573-4949-4544-8260-B53885A23628}"/>
+                <a16:creationId xmlns:a16="http://schemas.microsoft.com/office/drawing/2014/main" id="{C6F2C2F2-E52A-4898-9F74-452AE3660013}"/>
               </a:ext>
             </a:extLst>
           </p:cNvPr>
@@ -2505,7 +2505,7 @@
           <p:cNvPr id="4" name="">
             <a:extLst xmlns:a="http://schemas.openxmlformats.org/drawingml/2006/main">
               <a:ext uri="{FF2B5EF4-FFF2-40B4-BE49-F238E27FC236}">
-                <a16:creationId xmlns:a16="http://schemas.microsoft.com/office/drawing/2014/main" id="{6DA83F83-52C8-4A51-9FBA-402F5784B3B4}"/>
+                <a16:creationId xmlns:a16="http://schemas.microsoft.com/office/drawing/2014/main" id="{6AD68458-581E-4CC4-8A7B-EC3A45F8F87B}"/>
               </a:ext>
             </a:extLst>
           </p:cNvPr>
@@ -2562,7 +2562,7 @@
           <p:cNvPr id="5" name="">
             <a:extLst xmlns:a="http://schemas.openxmlformats.org/drawingml/2006/main">
               <a:ext uri="{FF2B5EF4-FFF2-40B4-BE49-F238E27FC236}">
-                <a16:creationId xmlns:a16="http://schemas.microsoft.com/office/drawing/2014/main" id="{53E7D1E3-5324-46A0-8B61-A194B0966D70}"/>
+                <a16:creationId xmlns:a16="http://schemas.microsoft.com/office/drawing/2014/main" id="{36FCF40C-3444-4861-B380-2291F9C59D82}"/>
               </a:ext>
             </a:extLst>
           </p:cNvPr>
@@ -2642,7 +2642,7 @@
           <p:cNvPr id="6" name="">
             <a:extLst xmlns:a="http://schemas.openxmlformats.org/drawingml/2006/main">
               <a:ext uri="{FF2B5EF4-FFF2-40B4-BE49-F238E27FC236}">
-                <a16:creationId xmlns:a16="http://schemas.microsoft.com/office/drawing/2014/main" id="{AADB7CA3-BCB2-475C-AD97-D23828F5301B}"/>
+                <a16:creationId xmlns:a16="http://schemas.microsoft.com/office/drawing/2014/main" id="{818E2DB3-D02A-4D5A-A692-183499EBFA70}"/>
               </a:ext>
             </a:extLst>
           </p:cNvPr>
@@ -2672,7 +2672,7 @@
           <p:cNvPr id="7" name="">
             <a:extLst xmlns:a="http://schemas.openxmlformats.org/drawingml/2006/main">
               <a:ext uri="{FF2B5EF4-FFF2-40B4-BE49-F238E27FC236}">
-                <a16:creationId xmlns:a16="http://schemas.microsoft.com/office/drawing/2014/main" id="{CC35385D-6F54-44F2-B2A2-02778FD8C605}"/>
+                <a16:creationId xmlns:a16="http://schemas.microsoft.com/office/drawing/2014/main" id="{6B3784B3-5303-4820-8B0A-0C067E818EF7}"/>
               </a:ext>
             </a:extLst>
           </p:cNvPr>
@@ -2729,7 +2729,7 @@
           <p:cNvPr id="8" name="">
             <a:extLst xmlns:a="http://schemas.openxmlformats.org/drawingml/2006/main">
               <a:ext uri="{FF2B5EF4-FFF2-40B4-BE49-F238E27FC236}">
-                <a16:creationId xmlns:a16="http://schemas.microsoft.com/office/drawing/2014/main" id="{9D26C232-9378-45F7-8E13-D8C1EE586A12}"/>
+                <a16:creationId xmlns:a16="http://schemas.microsoft.com/office/drawing/2014/main" id="{59F4E7E8-FA01-4FCE-8285-516398B6BA07}"/>
               </a:ext>
             </a:extLst>
           </p:cNvPr>
@@ -2784,7 +2784,7 @@
     </p:spTree>
     <p:extLst>
       <p:ext uri="{BB962C8B-B14F-4D97-AF65-F5344CB8AC3E}">
-        <p14:creationId xmlns:p14="http://schemas.microsoft.com/office/powerpoint/2010/main" val="990642439"/>
+        <p14:creationId xmlns:p14="http://schemas.microsoft.com/office/powerpoint/2010/main" val="1096804224"/>
       </p:ext>
     </p:extLst>
   </p:cSld>
@@ -2815,7 +2815,7 @@
           <p:cNvPr id="22" name="">
             <a:extLst xmlns:a="http://schemas.openxmlformats.org/drawingml/2006/main">
               <a:ext uri="{FF2B5EF4-FFF2-40B4-BE49-F238E27FC236}">
-                <a16:creationId xmlns:a16="http://schemas.microsoft.com/office/drawing/2014/main" id="{8491E527-47DD-4872-888F-88F6E6EC2EB5}"/>
+                <a16:creationId xmlns:a16="http://schemas.microsoft.com/office/drawing/2014/main" id="{99117364-111C-451F-99D6-30F79B1E135E}"/>
               </a:ext>
             </a:extLst>
           </p:cNvPr>
@@ -2845,7 +2845,7 @@
           <p:cNvPr id="2" name="">
             <a:extLst xmlns:a="http://schemas.openxmlformats.org/drawingml/2006/main">
               <a:ext uri="{FF2B5EF4-FFF2-40B4-BE49-F238E27FC236}">
-                <a16:creationId xmlns:a16="http://schemas.microsoft.com/office/drawing/2014/main" id="{C16C7589-8BBA-4BB8-B909-9F7122EAB3D3}"/>
+                <a16:creationId xmlns:a16="http://schemas.microsoft.com/office/drawing/2014/main" id="{ACBF4D66-EEF5-4EAF-AFED-C997B835820F}"/>
               </a:ext>
             </a:extLst>
           </p:cNvPr>
@@ -2902,7 +2902,7 @@
           <p:cNvPr id="3" name="">
             <a:extLst xmlns:a="http://schemas.openxmlformats.org/drawingml/2006/main">
               <a:ext uri="{FF2B5EF4-FFF2-40B4-BE49-F238E27FC236}">
-                <a16:creationId xmlns:a16="http://schemas.microsoft.com/office/drawing/2014/main" id="{FEB7C680-79C1-4C29-82B3-87CAA8536C8B}"/>
+                <a16:creationId xmlns:a16="http://schemas.microsoft.com/office/drawing/2014/main" id="{1840ED12-5FB5-4BA9-A21C-7CC773824348}"/>
               </a:ext>
             </a:extLst>
           </p:cNvPr>
@@ -2932,7 +2932,7 @@
           <p:cNvPr id="4" name="">
             <a:extLst xmlns:a="http://schemas.openxmlformats.org/drawingml/2006/main">
               <a:ext uri="{FF2B5EF4-FFF2-40B4-BE49-F238E27FC236}">
-                <a16:creationId xmlns:a16="http://schemas.microsoft.com/office/drawing/2014/main" id="{A858A319-11F4-413F-86AA-71CF3DEA6F63}"/>
+                <a16:creationId xmlns:a16="http://schemas.microsoft.com/office/drawing/2014/main" id="{6677304B-778C-4422-BE08-44687CBA3582}"/>
               </a:ext>
             </a:extLst>
           </p:cNvPr>
@@ -2989,7 +2989,7 @@
           <p:cNvPr id="5" name="">
             <a:extLst xmlns:a="http://schemas.openxmlformats.org/drawingml/2006/main">
               <a:ext uri="{FF2B5EF4-FFF2-40B4-BE49-F238E27FC236}">
-                <a16:creationId xmlns:a16="http://schemas.microsoft.com/office/drawing/2014/main" id="{BFE459AB-9EDE-416F-BB49-50285036E1A1}"/>
+                <a16:creationId xmlns:a16="http://schemas.microsoft.com/office/drawing/2014/main" id="{1F65DD82-7864-4B20-BB84-CEBCF3831393}"/>
               </a:ext>
             </a:extLst>
           </p:cNvPr>
@@ -3019,7 +3019,7 @@
           <p:cNvPr id="6" name="">
             <a:extLst xmlns:a="http://schemas.openxmlformats.org/drawingml/2006/main">
               <a:ext uri="{FF2B5EF4-FFF2-40B4-BE49-F238E27FC236}">
-                <a16:creationId xmlns:a16="http://schemas.microsoft.com/office/drawing/2014/main" id="{8EE6BF0A-B664-417A-8985-C19C952633EC}"/>
+                <a16:creationId xmlns:a16="http://schemas.microsoft.com/office/drawing/2014/main" id="{C61F2986-F81B-4946-969B-3D9F1E9AA767}"/>
               </a:ext>
             </a:extLst>
           </p:cNvPr>
@@ -3076,7 +3076,7 @@
           <p:cNvPr id="7" name="">
             <a:extLst xmlns:a="http://schemas.openxmlformats.org/drawingml/2006/main">
               <a:ext uri="{FF2B5EF4-FFF2-40B4-BE49-F238E27FC236}">
-                <a16:creationId xmlns:a16="http://schemas.microsoft.com/office/drawing/2014/main" id="{F59E74FB-1A8D-4F6C-B32F-6AB061591AB6}"/>
+                <a16:creationId xmlns:a16="http://schemas.microsoft.com/office/drawing/2014/main" id="{6EEB67F9-010D-4040-A029-FB7DFB32C8C4}"/>
               </a:ext>
             </a:extLst>
           </p:cNvPr>
@@ -3133,7 +3133,7 @@
           <p:cNvPr id="8" name="">
             <a:extLst xmlns:a="http://schemas.openxmlformats.org/drawingml/2006/main">
               <a:ext uri="{FF2B5EF4-FFF2-40B4-BE49-F238E27FC236}">
-                <a16:creationId xmlns:a16="http://schemas.microsoft.com/office/drawing/2014/main" id="{BC4F7032-714D-4E56-AF6C-2466B7542BC3}"/>
+                <a16:creationId xmlns:a16="http://schemas.microsoft.com/office/drawing/2014/main" id="{19617924-D352-4BEC-A923-2D3FE1B283C9}"/>
               </a:ext>
             </a:extLst>
           </p:cNvPr>
@@ -3190,7 +3190,7 @@
           <p:cNvPr id="9" name="">
             <a:extLst xmlns:a="http://schemas.openxmlformats.org/drawingml/2006/main">
               <a:ext uri="{FF2B5EF4-FFF2-40B4-BE49-F238E27FC236}">
-                <a16:creationId xmlns:a16="http://schemas.microsoft.com/office/drawing/2014/main" id="{5491F373-979C-42BA-854C-CB93644BF15A}"/>
+                <a16:creationId xmlns:a16="http://schemas.microsoft.com/office/drawing/2014/main" id="{EB3A59A6-1072-4C6A-AC53-095DFFB19BB9}"/>
               </a:ext>
             </a:extLst>
           </p:cNvPr>
@@ -3222,7 +3222,7 @@
           <p:cNvPr id="10" name="">
             <a:extLst xmlns:a="http://schemas.openxmlformats.org/drawingml/2006/main">
               <a:ext uri="{FF2B5EF4-FFF2-40B4-BE49-F238E27FC236}">
-                <a16:creationId xmlns:a16="http://schemas.microsoft.com/office/drawing/2014/main" id="{717B23FD-D0CE-4597-8AB6-D164AAD5999F}"/>
+                <a16:creationId xmlns:a16="http://schemas.microsoft.com/office/drawing/2014/main" id="{79E73B54-F5BB-4D3D-8E90-8EEA4181997F}"/>
               </a:ext>
             </a:extLst>
           </p:cNvPr>
@@ -3279,7 +3279,7 @@
           <p:cNvPr id="11" name="">
             <a:extLst xmlns:a="http://schemas.openxmlformats.org/drawingml/2006/main">
               <a:ext uri="{FF2B5EF4-FFF2-40B4-BE49-F238E27FC236}">
-                <a16:creationId xmlns:a16="http://schemas.microsoft.com/office/drawing/2014/main" id="{8ABE7ECD-259F-4386-8102-63B00E79B29E}"/>
+                <a16:creationId xmlns:a16="http://schemas.microsoft.com/office/drawing/2014/main" id="{F9C678DD-1584-4919-AA37-59FBCA1585CC}"/>
               </a:ext>
             </a:extLst>
           </p:cNvPr>
@@ -3336,7 +3336,7 @@
           <p:cNvPr id="12" name="">
             <a:extLst xmlns:a="http://schemas.openxmlformats.org/drawingml/2006/main">
               <a:ext uri="{FF2B5EF4-FFF2-40B4-BE49-F238E27FC236}">
-                <a16:creationId xmlns:a16="http://schemas.microsoft.com/office/drawing/2014/main" id="{7E072BF7-35D7-484F-A0A0-0DDA00FE3B6E}"/>
+                <a16:creationId xmlns:a16="http://schemas.microsoft.com/office/drawing/2014/main" id="{CB674C74-7E3D-4A6C-910A-DD3AF20DD4DC}"/>
               </a:ext>
             </a:extLst>
           </p:cNvPr>
@@ -3393,7 +3393,7 @@
           <p:cNvPr id="13" name="">
             <a:extLst xmlns:a="http://schemas.openxmlformats.org/drawingml/2006/main">
               <a:ext uri="{FF2B5EF4-FFF2-40B4-BE49-F238E27FC236}">
-                <a16:creationId xmlns:a16="http://schemas.microsoft.com/office/drawing/2014/main" id="{DF475A30-5B4C-46B0-B102-361C9DAD63FA}"/>
+                <a16:creationId xmlns:a16="http://schemas.microsoft.com/office/drawing/2014/main" id="{6BE5B791-8610-489F-B26E-9FE936D9E4EA}"/>
               </a:ext>
             </a:extLst>
           </p:cNvPr>
@@ -3425,7 +3425,7 @@
           <p:cNvPr id="14" name="">
             <a:extLst xmlns:a="http://schemas.openxmlformats.org/drawingml/2006/main">
               <a:ext uri="{FF2B5EF4-FFF2-40B4-BE49-F238E27FC236}">
-                <a16:creationId xmlns:a16="http://schemas.microsoft.com/office/drawing/2014/main" id="{02673EFE-9888-4CCC-973F-D98BC19FF844}"/>
+                <a16:creationId xmlns:a16="http://schemas.microsoft.com/office/drawing/2014/main" id="{2105434F-76C4-4C97-9AF7-6DBD08BCBAAD}"/>
               </a:ext>
             </a:extLst>
           </p:cNvPr>
@@ -3482,7 +3482,7 @@
           <p:cNvPr id="15" name="">
             <a:extLst xmlns:a="http://schemas.openxmlformats.org/drawingml/2006/main">
               <a:ext uri="{FF2B5EF4-FFF2-40B4-BE49-F238E27FC236}">
-                <a16:creationId xmlns:a16="http://schemas.microsoft.com/office/drawing/2014/main" id="{E38DAAC5-0D37-470E-A0B6-2F7A3D1DA7D4}"/>
+                <a16:creationId xmlns:a16="http://schemas.microsoft.com/office/drawing/2014/main" id="{EF941CC3-7861-4F1A-BA9D-277D89454C23}"/>
               </a:ext>
             </a:extLst>
           </p:cNvPr>
@@ -3539,7 +3539,7 @@
           <p:cNvPr id="16" name="">
             <a:extLst xmlns:a="http://schemas.openxmlformats.org/drawingml/2006/main">
               <a:ext uri="{FF2B5EF4-FFF2-40B4-BE49-F238E27FC236}">
-                <a16:creationId xmlns:a16="http://schemas.microsoft.com/office/drawing/2014/main" id="{DCFBA9B6-6397-4642-A5C2-C22755D1C26C}"/>
+                <a16:creationId xmlns:a16="http://schemas.microsoft.com/office/drawing/2014/main" id="{A48D0C0B-5794-4A22-AC5D-13C6F717E195}"/>
               </a:ext>
             </a:extLst>
           </p:cNvPr>
@@ -3596,7 +3596,7 @@
           <p:cNvPr id="17" name="">
             <a:extLst xmlns:a="http://schemas.openxmlformats.org/drawingml/2006/main">
               <a:ext uri="{FF2B5EF4-FFF2-40B4-BE49-F238E27FC236}">
-                <a16:creationId xmlns:a16="http://schemas.microsoft.com/office/drawing/2014/main" id="{18FC7B87-5DEB-4544-9C65-9953FF951BF4}"/>
+                <a16:creationId xmlns:a16="http://schemas.microsoft.com/office/drawing/2014/main" id="{824A5395-1776-4A08-A355-1294C34EE8BF}"/>
               </a:ext>
             </a:extLst>
           </p:cNvPr>
@@ -3628,7 +3628,7 @@
           <p:cNvPr id="18" name="">
             <a:extLst xmlns:a="http://schemas.openxmlformats.org/drawingml/2006/main">
               <a:ext uri="{FF2B5EF4-FFF2-40B4-BE49-F238E27FC236}">
-                <a16:creationId xmlns:a16="http://schemas.microsoft.com/office/drawing/2014/main" id="{4E2CFE37-D44E-4EE8-9C56-DEEEF7EBDDA3}"/>
+                <a16:creationId xmlns:a16="http://schemas.microsoft.com/office/drawing/2014/main" id="{E9AE2D57-B3CC-4CEA-BD6A-6A00FE900C9D}"/>
               </a:ext>
             </a:extLst>
           </p:cNvPr>
@@ -3685,7 +3685,7 @@
           <p:cNvPr id="19" name="">
             <a:extLst xmlns:a="http://schemas.openxmlformats.org/drawingml/2006/main">
               <a:ext uri="{FF2B5EF4-FFF2-40B4-BE49-F238E27FC236}">
-                <a16:creationId xmlns:a16="http://schemas.microsoft.com/office/drawing/2014/main" id="{19F8EDAC-D542-4DD7-AF00-874869DC2CF6}"/>
+                <a16:creationId xmlns:a16="http://schemas.microsoft.com/office/drawing/2014/main" id="{965EB956-4594-46CB-989F-C06BE864753A}"/>
               </a:ext>
             </a:extLst>
           </p:cNvPr>
@@ -3742,7 +3742,7 @@
           <p:cNvPr id="20" name="">
             <a:extLst xmlns:a="http://schemas.openxmlformats.org/drawingml/2006/main">
               <a:ext uri="{FF2B5EF4-FFF2-40B4-BE49-F238E27FC236}">
-                <a16:creationId xmlns:a16="http://schemas.microsoft.com/office/drawing/2014/main" id="{0C365874-C70E-4345-9DF9-DBFE6B8730FF}"/>
+                <a16:creationId xmlns:a16="http://schemas.microsoft.com/office/drawing/2014/main" id="{E7E5F287-750B-417E-82E9-014A6C29286A}"/>
               </a:ext>
             </a:extLst>
           </p:cNvPr>
@@ -3799,7 +3799,7 @@
           <p:cNvPr id="21" name="">
             <a:extLst xmlns:a="http://schemas.openxmlformats.org/drawingml/2006/main">
               <a:ext uri="{FF2B5EF4-FFF2-40B4-BE49-F238E27FC236}">
-                <a16:creationId xmlns:a16="http://schemas.microsoft.com/office/drawing/2014/main" id="{79684C62-2FE7-4F59-8DBD-72B096091CF7}"/>
+                <a16:creationId xmlns:a16="http://schemas.microsoft.com/office/drawing/2014/main" id="{B9C9B35C-4E36-4652-91A9-B89FEF5F2A93}"/>
               </a:ext>
             </a:extLst>
           </p:cNvPr>
@@ -3854,7 +3854,7 @@
     </p:spTree>
     <p:extLst>
       <p:ext uri="{BB962C8B-B14F-4D97-AF65-F5344CB8AC3E}">
-        <p14:creationId xmlns:p14="http://schemas.microsoft.com/office/powerpoint/2010/main" val="1180608110"/>
+        <p14:creationId xmlns:p14="http://schemas.microsoft.com/office/powerpoint/2010/main" val="1836227365"/>
       </p:ext>
     </p:extLst>
   </p:cSld>
@@ -3885,7 +3885,7 @@
           <p:cNvPr id="21" name="">
             <a:extLst xmlns:a="http://schemas.openxmlformats.org/drawingml/2006/main">
               <a:ext uri="{FF2B5EF4-FFF2-40B4-BE49-F238E27FC236}">
-                <a16:creationId xmlns:a16="http://schemas.microsoft.com/office/drawing/2014/main" id="{0395ED75-C40E-476E-861F-5B61BAB86735}"/>
+                <a16:creationId xmlns:a16="http://schemas.microsoft.com/office/drawing/2014/main" id="{5B72C287-F3CB-4EDC-8021-EACEB2C66745}"/>
               </a:ext>
             </a:extLst>
           </p:cNvPr>
@@ -3915,7 +3915,7 @@
           <p:cNvPr id="2" name="">
             <a:extLst xmlns:a="http://schemas.openxmlformats.org/drawingml/2006/main">
               <a:ext uri="{FF2B5EF4-FFF2-40B4-BE49-F238E27FC236}">
-                <a16:creationId xmlns:a16="http://schemas.microsoft.com/office/drawing/2014/main" id="{2C6C43F2-234A-4195-A0F7-7A7E21DA64FE}"/>
+                <a16:creationId xmlns:a16="http://schemas.microsoft.com/office/drawing/2014/main" id="{917060AE-BFCD-41F5-ACA2-4B6A1407E961}"/>
               </a:ext>
             </a:extLst>
           </p:cNvPr>
@@ -3972,7 +3972,7 @@
           <p:cNvPr id="3" name="">
             <a:extLst xmlns:a="http://schemas.openxmlformats.org/drawingml/2006/main">
               <a:ext uri="{FF2B5EF4-FFF2-40B4-BE49-F238E27FC236}">
-                <a16:creationId xmlns:a16="http://schemas.microsoft.com/office/drawing/2014/main" id="{07A81E01-E916-4F19-B2DB-A9269DD7C2E9}"/>
+                <a16:creationId xmlns:a16="http://schemas.microsoft.com/office/drawing/2014/main" id="{82DECDB4-D767-4823-94DF-71DC665F5F79}"/>
               </a:ext>
             </a:extLst>
           </p:cNvPr>
@@ -4002,7 +4002,7 @@
           <p:cNvPr id="4" name="">
             <a:extLst xmlns:a="http://schemas.openxmlformats.org/drawingml/2006/main">
               <a:ext uri="{FF2B5EF4-FFF2-40B4-BE49-F238E27FC236}">
-                <a16:creationId xmlns:a16="http://schemas.microsoft.com/office/drawing/2014/main" id="{14EEE9A4-587F-4285-816C-E9E72ADECFC7}"/>
+                <a16:creationId xmlns:a16="http://schemas.microsoft.com/office/drawing/2014/main" id="{67B154E6-DA4F-42F5-9DD0-6515031A126B}"/>
               </a:ext>
             </a:extLst>
           </p:cNvPr>
@@ -4059,7 +4059,7 @@
           <p:cNvPr id="5" name="">
             <a:extLst xmlns:a="http://schemas.openxmlformats.org/drawingml/2006/main">
               <a:ext uri="{FF2B5EF4-FFF2-40B4-BE49-F238E27FC236}">
-                <a16:creationId xmlns:a16="http://schemas.microsoft.com/office/drawing/2014/main" id="{937CE83C-EC58-4DC2-81B5-28D4AE4CD21B}"/>
+                <a16:creationId xmlns:a16="http://schemas.microsoft.com/office/drawing/2014/main" id="{6AA338CB-1AA0-4E0A-80BD-BBFFD2FED974}"/>
               </a:ext>
             </a:extLst>
           </p:cNvPr>
@@ -4116,7 +4116,7 @@
           <p:cNvPr id="6" name="">
             <a:extLst xmlns:a="http://schemas.openxmlformats.org/drawingml/2006/main">
               <a:ext uri="{FF2B5EF4-FFF2-40B4-BE49-F238E27FC236}">
-                <a16:creationId xmlns:a16="http://schemas.microsoft.com/office/drawing/2014/main" id="{70F553C5-E0BE-4D99-865E-16AF8A55CFF6}"/>
+                <a16:creationId xmlns:a16="http://schemas.microsoft.com/office/drawing/2014/main" id="{EF94D952-9EB6-4207-9546-925BAC94DC4A}"/>
               </a:ext>
             </a:extLst>
           </p:cNvPr>
@@ -4173,7 +4173,7 @@
           <p:cNvPr id="7" name="">
             <a:extLst xmlns:a="http://schemas.openxmlformats.org/drawingml/2006/main">
               <a:ext uri="{FF2B5EF4-FFF2-40B4-BE49-F238E27FC236}">
-                <a16:creationId xmlns:a16="http://schemas.microsoft.com/office/drawing/2014/main" id="{3D767B04-2F74-4D2B-A535-7EDA945B5844}"/>
+                <a16:creationId xmlns:a16="http://schemas.microsoft.com/office/drawing/2014/main" id="{BC528BD6-99C4-4729-8676-9637C0B127CF}"/>
               </a:ext>
             </a:extLst>
           </p:cNvPr>
@@ -4230,7 +4230,7 @@
           <p:cNvPr id="8" name="">
             <a:extLst xmlns:a="http://schemas.openxmlformats.org/drawingml/2006/main">
               <a:ext uri="{FF2B5EF4-FFF2-40B4-BE49-F238E27FC236}">
-                <a16:creationId xmlns:a16="http://schemas.microsoft.com/office/drawing/2014/main" id="{01CF3C6A-0BBB-4D7F-AC6E-3FC14A026F9C}"/>
+                <a16:creationId xmlns:a16="http://schemas.microsoft.com/office/drawing/2014/main" id="{CE7FBFC5-8D43-42CD-B129-C86E302DDB8E}"/>
               </a:ext>
             </a:extLst>
           </p:cNvPr>
@@ -4260,7 +4260,7 @@
           <p:cNvPr id="9" name="">
             <a:extLst xmlns:a="http://schemas.openxmlformats.org/drawingml/2006/main">
               <a:ext uri="{FF2B5EF4-FFF2-40B4-BE49-F238E27FC236}">
-                <a16:creationId xmlns:a16="http://schemas.microsoft.com/office/drawing/2014/main" id="{4F686899-A1F6-434B-A8C2-E014434DE095}"/>
+                <a16:creationId xmlns:a16="http://schemas.microsoft.com/office/drawing/2014/main" id="{8BD18F68-8E35-4382-8BA0-8327D1EFF029}"/>
               </a:ext>
             </a:extLst>
           </p:cNvPr>
@@ -4317,7 +4317,7 @@
           <p:cNvPr id="10" name="">
             <a:extLst xmlns:a="http://schemas.openxmlformats.org/drawingml/2006/main">
               <a:ext uri="{FF2B5EF4-FFF2-40B4-BE49-F238E27FC236}">
-                <a16:creationId xmlns:a16="http://schemas.microsoft.com/office/drawing/2014/main" id="{ABACDF65-87B9-4A4F-874F-C6D3FFDCFE3C}"/>
+                <a16:creationId xmlns:a16="http://schemas.microsoft.com/office/drawing/2014/main" id="{F3247C53-0EC3-4357-829A-F47A33F80E71}"/>
               </a:ext>
             </a:extLst>
           </p:cNvPr>
@@ -4374,7 +4374,7 @@
           <p:cNvPr id="11" name="">
             <a:extLst xmlns:a="http://schemas.openxmlformats.org/drawingml/2006/main">
               <a:ext uri="{FF2B5EF4-FFF2-40B4-BE49-F238E27FC236}">
-                <a16:creationId xmlns:a16="http://schemas.microsoft.com/office/drawing/2014/main" id="{41E78910-60AC-4EE1-B27B-99E5718383F7}"/>
+                <a16:creationId xmlns:a16="http://schemas.microsoft.com/office/drawing/2014/main" id="{E3ED147B-1366-49BB-9DBD-12D096DA409D}"/>
               </a:ext>
             </a:extLst>
           </p:cNvPr>
@@ -4431,7 +4431,7 @@
           <p:cNvPr id="12" name="">
             <a:extLst xmlns:a="http://schemas.openxmlformats.org/drawingml/2006/main">
               <a:ext uri="{FF2B5EF4-FFF2-40B4-BE49-F238E27FC236}">
-                <a16:creationId xmlns:a16="http://schemas.microsoft.com/office/drawing/2014/main" id="{8CA6DC50-4ABB-4AF5-8963-A39ADDB75E3D}"/>
+                <a16:creationId xmlns:a16="http://schemas.microsoft.com/office/drawing/2014/main" id="{6C221BFF-83F2-4FD1-B41F-83FAE171B570}"/>
               </a:ext>
             </a:extLst>
           </p:cNvPr>
@@ -4461,7 +4461,7 @@
           <p:cNvPr id="13" name="">
             <a:extLst xmlns:a="http://schemas.openxmlformats.org/drawingml/2006/main">
               <a:ext uri="{FF2B5EF4-FFF2-40B4-BE49-F238E27FC236}">
-                <a16:creationId xmlns:a16="http://schemas.microsoft.com/office/drawing/2014/main" id="{F2853B5B-6EC8-4FB1-968F-6CB337856212}"/>
+                <a16:creationId xmlns:a16="http://schemas.microsoft.com/office/drawing/2014/main" id="{E806BF57-5F79-4A83-A8C7-21478AA601D8}"/>
               </a:ext>
             </a:extLst>
           </p:cNvPr>
@@ -4518,7 +4518,7 @@
           <p:cNvPr id="14" name="">
             <a:extLst xmlns:a="http://schemas.openxmlformats.org/drawingml/2006/main">
               <a:ext uri="{FF2B5EF4-FFF2-40B4-BE49-F238E27FC236}">
-                <a16:creationId xmlns:a16="http://schemas.microsoft.com/office/drawing/2014/main" id="{9A292D65-907C-4F85-A3D8-C19969AC683B}"/>
+                <a16:creationId xmlns:a16="http://schemas.microsoft.com/office/drawing/2014/main" id="{18999AAD-3C9F-406F-AD29-9B97BD39247F}"/>
               </a:ext>
             </a:extLst>
           </p:cNvPr>
@@ -4575,7 +4575,7 @@
           <p:cNvPr id="15" name="">
             <a:extLst xmlns:a="http://schemas.openxmlformats.org/drawingml/2006/main">
               <a:ext uri="{FF2B5EF4-FFF2-40B4-BE49-F238E27FC236}">
-                <a16:creationId xmlns:a16="http://schemas.microsoft.com/office/drawing/2014/main" id="{8DF8D7C7-B095-442C-AEAE-338479644FB0}"/>
+                <a16:creationId xmlns:a16="http://schemas.microsoft.com/office/drawing/2014/main" id="{73E78BD2-E47D-4664-8AD2-7925E71E0ABE}"/>
               </a:ext>
             </a:extLst>
           </p:cNvPr>
@@ -4632,7 +4632,7 @@
           <p:cNvPr id="16" name="">
             <a:extLst xmlns:a="http://schemas.openxmlformats.org/drawingml/2006/main">
               <a:ext uri="{FF2B5EF4-FFF2-40B4-BE49-F238E27FC236}">
-                <a16:creationId xmlns:a16="http://schemas.microsoft.com/office/drawing/2014/main" id="{0D057AC4-4C42-4F9A-A06F-D3B06178BD38}"/>
+                <a16:creationId xmlns:a16="http://schemas.microsoft.com/office/drawing/2014/main" id="{AF5FEE80-56AA-47F8-A29A-5E8201B26017}"/>
               </a:ext>
             </a:extLst>
           </p:cNvPr>
@@ -4662,7 +4662,7 @@
           <p:cNvPr id="17" name="">
             <a:extLst xmlns:a="http://schemas.openxmlformats.org/drawingml/2006/main">
               <a:ext uri="{FF2B5EF4-FFF2-40B4-BE49-F238E27FC236}">
-                <a16:creationId xmlns:a16="http://schemas.microsoft.com/office/drawing/2014/main" id="{C3D32F45-186D-4DF8-97D8-0F41168724E1}"/>
+                <a16:creationId xmlns:a16="http://schemas.microsoft.com/office/drawing/2014/main" id="{9691673B-E6F8-40E0-B2F3-F94D340CD1E0}"/>
               </a:ext>
             </a:extLst>
           </p:cNvPr>
@@ -4719,7 +4719,7 @@
           <p:cNvPr id="18" name="">
             <a:extLst xmlns:a="http://schemas.openxmlformats.org/drawingml/2006/main">
               <a:ext uri="{FF2B5EF4-FFF2-40B4-BE49-F238E27FC236}">
-                <a16:creationId xmlns:a16="http://schemas.microsoft.com/office/drawing/2014/main" id="{37384C16-F666-4F24-9639-FF8A5D954E82}"/>
+                <a16:creationId xmlns:a16="http://schemas.microsoft.com/office/drawing/2014/main" id="{3C9EB00F-6DEF-4F0D-999A-B831D087286C}"/>
               </a:ext>
             </a:extLst>
           </p:cNvPr>
@@ -4776,7 +4776,7 @@
           <p:cNvPr id="19" name="">
             <a:extLst xmlns:a="http://schemas.openxmlformats.org/drawingml/2006/main">
               <a:ext uri="{FF2B5EF4-FFF2-40B4-BE49-F238E27FC236}">
-                <a16:creationId xmlns:a16="http://schemas.microsoft.com/office/drawing/2014/main" id="{B356BF4E-86B2-4AAE-85C3-D50E821863EC}"/>
+                <a16:creationId xmlns:a16="http://schemas.microsoft.com/office/drawing/2014/main" id="{C08EEC7B-E7AB-4061-B9D1-A294C5358067}"/>
               </a:ext>
             </a:extLst>
           </p:cNvPr>
@@ -4833,7 +4833,7 @@
           <p:cNvPr id="20" name="">
             <a:extLst xmlns:a="http://schemas.openxmlformats.org/drawingml/2006/main">
               <a:ext uri="{FF2B5EF4-FFF2-40B4-BE49-F238E27FC236}">
-                <a16:creationId xmlns:a16="http://schemas.microsoft.com/office/drawing/2014/main" id="{159FB153-8474-4901-820C-32CC7013D838}"/>
+                <a16:creationId xmlns:a16="http://schemas.microsoft.com/office/drawing/2014/main" id="{9753F51E-7E4F-40FE-B73F-D9BCCE19E78A}"/>
               </a:ext>
             </a:extLst>
           </p:cNvPr>
@@ -4888,7 +4888,7 @@
     </p:spTree>
     <p:extLst>
       <p:ext uri="{BB962C8B-B14F-4D97-AF65-F5344CB8AC3E}">
-        <p14:creationId xmlns:p14="http://schemas.microsoft.com/office/powerpoint/2010/main" val="1039531399"/>
+        <p14:creationId xmlns:p14="http://schemas.microsoft.com/office/powerpoint/2010/main" val="2034378284"/>
       </p:ext>
     </p:extLst>
   </p:cSld>
@@ -4919,7 +4919,7 @@
           <p:cNvPr id="21" name="">
             <a:extLst xmlns:a="http://schemas.openxmlformats.org/drawingml/2006/main">
               <a:ext uri="{FF2B5EF4-FFF2-40B4-BE49-F238E27FC236}">
-                <a16:creationId xmlns:a16="http://schemas.microsoft.com/office/drawing/2014/main" id="{93B30118-89CE-457E-95AF-DB2C9C0B0714}"/>
+                <a16:creationId xmlns:a16="http://schemas.microsoft.com/office/drawing/2014/main" id="{AF3313A8-37A5-444B-8FF1-C4486E0528D3}"/>
               </a:ext>
             </a:extLst>
           </p:cNvPr>
@@ -4949,7 +4949,7 @@
           <p:cNvPr id="2" name="">
             <a:extLst xmlns:a="http://schemas.openxmlformats.org/drawingml/2006/main">
               <a:ext uri="{FF2B5EF4-FFF2-40B4-BE49-F238E27FC236}">
-                <a16:creationId xmlns:a16="http://schemas.microsoft.com/office/drawing/2014/main" id="{701FDF30-B5B6-4773-95C4-D38400206646}"/>
+                <a16:creationId xmlns:a16="http://schemas.microsoft.com/office/drawing/2014/main" id="{AA291B3B-6EEE-421A-A7B5-27E0831F5FC4}"/>
               </a:ext>
             </a:extLst>
           </p:cNvPr>
@@ -5006,7 +5006,7 @@
           <p:cNvPr id="3" name="">
             <a:extLst xmlns:a="http://schemas.openxmlformats.org/drawingml/2006/main">
               <a:ext uri="{FF2B5EF4-FFF2-40B4-BE49-F238E27FC236}">
-                <a16:creationId xmlns:a16="http://schemas.microsoft.com/office/drawing/2014/main" id="{9731ED50-B118-49AA-9A33-338148952CEF}"/>
+                <a16:creationId xmlns:a16="http://schemas.microsoft.com/office/drawing/2014/main" id="{304C9ABD-06F3-4AF3-A50E-A877CD0CE24B}"/>
               </a:ext>
             </a:extLst>
           </p:cNvPr>
@@ -5036,7 +5036,7 @@
           <p:cNvPr id="4" name="">
             <a:extLst xmlns:a="http://schemas.openxmlformats.org/drawingml/2006/main">
               <a:ext uri="{FF2B5EF4-FFF2-40B4-BE49-F238E27FC236}">
-                <a16:creationId xmlns:a16="http://schemas.microsoft.com/office/drawing/2014/main" id="{02EC0114-B656-43B3-A04C-BCBB018EB107}"/>
+                <a16:creationId xmlns:a16="http://schemas.microsoft.com/office/drawing/2014/main" id="{CB4542AD-2D9C-4E3A-ADD6-4B3EEF967494}"/>
               </a:ext>
             </a:extLst>
           </p:cNvPr>
@@ -5093,7 +5093,7 @@
           <p:cNvPr id="5" name="">
             <a:extLst xmlns:a="http://schemas.openxmlformats.org/drawingml/2006/main">
               <a:ext uri="{FF2B5EF4-FFF2-40B4-BE49-F238E27FC236}">
-                <a16:creationId xmlns:a16="http://schemas.microsoft.com/office/drawing/2014/main" id="{00C110BD-525C-4F18-A2D9-F7A074824586}"/>
+                <a16:creationId xmlns:a16="http://schemas.microsoft.com/office/drawing/2014/main" id="{F293ED72-7404-476B-968B-024F3669BA0A}"/>
               </a:ext>
             </a:extLst>
           </p:cNvPr>
@@ -5125,7 +5125,7 @@
           <p:cNvPr id="6" name="">
             <a:extLst xmlns:a="http://schemas.openxmlformats.org/drawingml/2006/main">
               <a:ext uri="{FF2B5EF4-FFF2-40B4-BE49-F238E27FC236}">
-                <a16:creationId xmlns:a16="http://schemas.microsoft.com/office/drawing/2014/main" id="{4BD3C4E8-D838-4ADB-ADB3-70FA74BC4091}"/>
+                <a16:creationId xmlns:a16="http://schemas.microsoft.com/office/drawing/2014/main" id="{E7FB83FF-9632-48FB-8E41-BDE9394A1C98}"/>
               </a:ext>
             </a:extLst>
           </p:cNvPr>
@@ -5182,7 +5182,7 @@
           <p:cNvPr id="7" name="">
             <a:extLst xmlns:a="http://schemas.openxmlformats.org/drawingml/2006/main">
               <a:ext uri="{FF2B5EF4-FFF2-40B4-BE49-F238E27FC236}">
-                <a16:creationId xmlns:a16="http://schemas.microsoft.com/office/drawing/2014/main" id="{5BDFB574-F739-4D2D-9EFF-62A7AF116644}"/>
+                <a16:creationId xmlns:a16="http://schemas.microsoft.com/office/drawing/2014/main" id="{2B08E7A1-FB5E-41C7-9D96-A92E84DA0A26}"/>
               </a:ext>
             </a:extLst>
           </p:cNvPr>
@@ -5262,7 +5262,7 @@
           <p:cNvPr id="8" name="">
             <a:extLst xmlns:a="http://schemas.openxmlformats.org/drawingml/2006/main">
               <a:ext uri="{FF2B5EF4-FFF2-40B4-BE49-F238E27FC236}">
-                <a16:creationId xmlns:a16="http://schemas.microsoft.com/office/drawing/2014/main" id="{FD4F4B41-A211-4FF8-A9D7-094AFED8B41C}"/>
+                <a16:creationId xmlns:a16="http://schemas.microsoft.com/office/drawing/2014/main" id="{88C276D1-105C-408B-A44A-7B8DEE855050}"/>
               </a:ext>
             </a:extLst>
           </p:cNvPr>
@@ -5342,7 +5342,7 @@
           <p:cNvPr id="9" name="">
             <a:extLst xmlns:a="http://schemas.openxmlformats.org/drawingml/2006/main">
               <a:ext uri="{FF2B5EF4-FFF2-40B4-BE49-F238E27FC236}">
-                <a16:creationId xmlns:a16="http://schemas.microsoft.com/office/drawing/2014/main" id="{7A97AAB2-A0E4-49B8-9069-8F02E233D0A8}"/>
+                <a16:creationId xmlns:a16="http://schemas.microsoft.com/office/drawing/2014/main" id="{9C26DBE4-F7B8-4E7F-8B56-26C74DEF54AE}"/>
               </a:ext>
             </a:extLst>
           </p:cNvPr>
@@ -5372,7 +5372,7 @@
           <p:cNvPr id="10" name="">
             <a:extLst xmlns:a="http://schemas.openxmlformats.org/drawingml/2006/main">
               <a:ext uri="{FF2B5EF4-FFF2-40B4-BE49-F238E27FC236}">
-                <a16:creationId xmlns:a16="http://schemas.microsoft.com/office/drawing/2014/main" id="{5646C22A-A951-485E-AAA7-06D74A5C0056}"/>
+                <a16:creationId xmlns:a16="http://schemas.microsoft.com/office/drawing/2014/main" id="{72AEEBAA-47DE-4F3E-9CCF-7CBAD2F973B9}"/>
               </a:ext>
             </a:extLst>
           </p:cNvPr>
@@ -5429,7 +5429,7 @@
           <p:cNvPr id="11" name="">
             <a:extLst xmlns:a="http://schemas.openxmlformats.org/drawingml/2006/main">
               <a:ext uri="{FF2B5EF4-FFF2-40B4-BE49-F238E27FC236}">
-                <a16:creationId xmlns:a16="http://schemas.microsoft.com/office/drawing/2014/main" id="{CC5C84B8-7EE4-4692-82D3-14055F5EF926}"/>
+                <a16:creationId xmlns:a16="http://schemas.microsoft.com/office/drawing/2014/main" id="{EE5F40FD-3768-426D-ABF8-8FA607EAF94D}"/>
               </a:ext>
             </a:extLst>
           </p:cNvPr>
@@ -5486,7 +5486,7 @@
           <p:cNvPr id="12" name="">
             <a:extLst xmlns:a="http://schemas.openxmlformats.org/drawingml/2006/main">
               <a:ext uri="{FF2B5EF4-FFF2-40B4-BE49-F238E27FC236}">
-                <a16:creationId xmlns:a16="http://schemas.microsoft.com/office/drawing/2014/main" id="{0C2FB5EC-7DA2-4FF6-AF89-890E14E8C9BE}"/>
+                <a16:creationId xmlns:a16="http://schemas.microsoft.com/office/drawing/2014/main" id="{9A4DE62A-8112-489A-9E1F-EBBAF91F4548}"/>
               </a:ext>
             </a:extLst>
           </p:cNvPr>
@@ -5543,7 +5543,7 @@
           <p:cNvPr id="13" name="">
             <a:extLst xmlns:a="http://schemas.openxmlformats.org/drawingml/2006/main">
               <a:ext uri="{FF2B5EF4-FFF2-40B4-BE49-F238E27FC236}">
-                <a16:creationId xmlns:a16="http://schemas.microsoft.com/office/drawing/2014/main" id="{907D0C83-34E4-4939-A661-9C721CF23B3A}"/>
+                <a16:creationId xmlns:a16="http://schemas.microsoft.com/office/drawing/2014/main" id="{C7E6E399-B7B1-4098-B063-0EDDF56BF784}"/>
               </a:ext>
             </a:extLst>
           </p:cNvPr>
@@ -5623,7 +5623,7 @@
           <p:cNvPr id="14" name="">
             <a:extLst xmlns:a="http://schemas.openxmlformats.org/drawingml/2006/main">
               <a:ext uri="{FF2B5EF4-FFF2-40B4-BE49-F238E27FC236}">
-                <a16:creationId xmlns:a16="http://schemas.microsoft.com/office/drawing/2014/main" id="{482F47EF-9B87-4124-9ED0-6CFE2F68290A}"/>
+                <a16:creationId xmlns:a16="http://schemas.microsoft.com/office/drawing/2014/main" id="{53A06009-01D6-4541-B95C-E46A4995B18F}"/>
               </a:ext>
             </a:extLst>
           </p:cNvPr>
@@ -5680,7 +5680,7 @@
           <p:cNvPr id="15" name="">
             <a:extLst xmlns:a="http://schemas.openxmlformats.org/drawingml/2006/main">
               <a:ext uri="{FF2B5EF4-FFF2-40B4-BE49-F238E27FC236}">
-                <a16:creationId xmlns:a16="http://schemas.microsoft.com/office/drawing/2014/main" id="{6933FDCA-CB80-49C4-B458-5F4C1DC3B92A}"/>
+                <a16:creationId xmlns:a16="http://schemas.microsoft.com/office/drawing/2014/main" id="{3E63DF0A-7188-48A4-A9C5-4D8155EF2AEE}"/>
               </a:ext>
             </a:extLst>
           </p:cNvPr>
@@ -5712,7 +5712,7 @@
           <p:cNvPr id="16" name="">
             <a:extLst xmlns:a="http://schemas.openxmlformats.org/drawingml/2006/main">
               <a:ext uri="{FF2B5EF4-FFF2-40B4-BE49-F238E27FC236}">
-                <a16:creationId xmlns:a16="http://schemas.microsoft.com/office/drawing/2014/main" id="{15986DA8-2CFE-4FC9-9D85-7656265C77D8}"/>
+                <a16:creationId xmlns:a16="http://schemas.microsoft.com/office/drawing/2014/main" id="{C5C054BD-17BB-4FB2-A682-EA71C894CBE9}"/>
               </a:ext>
             </a:extLst>
           </p:cNvPr>
@@ -5769,7 +5769,7 @@
           <p:cNvPr id="17" name="">
             <a:extLst xmlns:a="http://schemas.openxmlformats.org/drawingml/2006/main">
               <a:ext uri="{FF2B5EF4-FFF2-40B4-BE49-F238E27FC236}">
-                <a16:creationId xmlns:a16="http://schemas.microsoft.com/office/drawing/2014/main" id="{358B2A26-1668-49A6-9F5C-3AE11CAB4205}"/>
+                <a16:creationId xmlns:a16="http://schemas.microsoft.com/office/drawing/2014/main" id="{DE26B6B4-7271-4797-9260-024F819C0592}"/>
               </a:ext>
             </a:extLst>
           </p:cNvPr>
@@ -5849,7 +5849,7 @@
           <p:cNvPr id="18" name="">
             <a:extLst xmlns:a="http://schemas.openxmlformats.org/drawingml/2006/main">
               <a:ext uri="{FF2B5EF4-FFF2-40B4-BE49-F238E27FC236}">
-                <a16:creationId xmlns:a16="http://schemas.microsoft.com/office/drawing/2014/main" id="{38FE4C0C-1393-4295-94BB-0AB0B4EE2820}"/>
+                <a16:creationId xmlns:a16="http://schemas.microsoft.com/office/drawing/2014/main" id="{E405314F-1037-4653-9215-08EEF7D6E970}"/>
               </a:ext>
             </a:extLst>
           </p:cNvPr>
@@ -5929,7 +5929,7 @@
           <p:cNvPr id="19" name="">
             <a:extLst xmlns:a="http://schemas.openxmlformats.org/drawingml/2006/main">
               <a:ext uri="{FF2B5EF4-FFF2-40B4-BE49-F238E27FC236}">
-                <a16:creationId xmlns:a16="http://schemas.microsoft.com/office/drawing/2014/main" id="{F2467CEF-5655-43C6-8E23-2ECA3AA684E4}"/>
+                <a16:creationId xmlns:a16="http://schemas.microsoft.com/office/drawing/2014/main" id="{42377FD6-46FC-4E3B-839E-8553C04508F0}"/>
               </a:ext>
             </a:extLst>
           </p:cNvPr>
@@ -5986,7 +5986,7 @@
           <p:cNvPr id="20" name="">
             <a:extLst xmlns:a="http://schemas.openxmlformats.org/drawingml/2006/main">
               <a:ext uri="{FF2B5EF4-FFF2-40B4-BE49-F238E27FC236}">
-                <a16:creationId xmlns:a16="http://schemas.microsoft.com/office/drawing/2014/main" id="{4C08B5B3-6DF9-4FFA-8925-F56A6F4C0C32}"/>
+                <a16:creationId xmlns:a16="http://schemas.microsoft.com/office/drawing/2014/main" id="{BA04CAED-2671-4189-A9E8-3DBC64656046}"/>
               </a:ext>
             </a:extLst>
           </p:cNvPr>
@@ -6041,7 +6041,7 @@
     </p:spTree>
     <p:extLst>
       <p:ext uri="{BB962C8B-B14F-4D97-AF65-F5344CB8AC3E}">
-        <p14:creationId xmlns:p14="http://schemas.microsoft.com/office/powerpoint/2010/main" val="1860346409"/>
+        <p14:creationId xmlns:p14="http://schemas.microsoft.com/office/powerpoint/2010/main" val="1357732233"/>
       </p:ext>
     </p:extLst>
   </p:cSld>
@@ -6072,7 +6072,7 @@
           <p:cNvPr id="15" name="">
             <a:extLst xmlns:a="http://schemas.openxmlformats.org/drawingml/2006/main">
               <a:ext uri="{FF2B5EF4-FFF2-40B4-BE49-F238E27FC236}">
-                <a16:creationId xmlns:a16="http://schemas.microsoft.com/office/drawing/2014/main" id="{0E8F5009-5A16-4957-BF5C-B9FD9E3BF0FF}"/>
+                <a16:creationId xmlns:a16="http://schemas.microsoft.com/office/drawing/2014/main" id="{C4F0ACEF-6D21-4BE2-B024-4B0AE48DBFD5}"/>
               </a:ext>
             </a:extLst>
           </p:cNvPr>
@@ -6102,7 +6102,7 @@
           <p:cNvPr id="2" name="">
             <a:extLst xmlns:a="http://schemas.openxmlformats.org/drawingml/2006/main">
               <a:ext uri="{FF2B5EF4-FFF2-40B4-BE49-F238E27FC236}">
-                <a16:creationId xmlns:a16="http://schemas.microsoft.com/office/drawing/2014/main" id="{3317EA2D-5A85-4DC3-93ED-9DAB6AFD286C}"/>
+                <a16:creationId xmlns:a16="http://schemas.microsoft.com/office/drawing/2014/main" id="{C11A3BA0-E43A-430B-9C1A-8193C36F9721}"/>
               </a:ext>
             </a:extLst>
           </p:cNvPr>
@@ -6159,7 +6159,7 @@
           <p:cNvPr id="3" name="">
             <a:extLst xmlns:a="http://schemas.openxmlformats.org/drawingml/2006/main">
               <a:ext uri="{FF2B5EF4-FFF2-40B4-BE49-F238E27FC236}">
-                <a16:creationId xmlns:a16="http://schemas.microsoft.com/office/drawing/2014/main" id="{309C84BA-9695-4420-BDB1-C24953542178}"/>
+                <a16:creationId xmlns:a16="http://schemas.microsoft.com/office/drawing/2014/main" id="{F0F8BBF3-A8F9-41D8-B4C8-234920051A92}"/>
               </a:ext>
             </a:extLst>
           </p:cNvPr>
@@ -6189,7 +6189,7 @@
           <p:cNvPr id="4" name="">
             <a:extLst xmlns:a="http://schemas.openxmlformats.org/drawingml/2006/main">
               <a:ext uri="{FF2B5EF4-FFF2-40B4-BE49-F238E27FC236}">
-                <a16:creationId xmlns:a16="http://schemas.microsoft.com/office/drawing/2014/main" id="{42A006F3-DA56-4606-AC11-52B38034BE70}"/>
+                <a16:creationId xmlns:a16="http://schemas.microsoft.com/office/drawing/2014/main" id="{66A3DF12-C679-4A88-BB28-D7603F76F89B}"/>
               </a:ext>
             </a:extLst>
           </p:cNvPr>
@@ -6246,7 +6246,7 @@
           <p:cNvPr id="5" name="">
             <a:extLst xmlns:a="http://schemas.openxmlformats.org/drawingml/2006/main">
               <a:ext uri="{FF2B5EF4-FFF2-40B4-BE49-F238E27FC236}">
-                <a16:creationId xmlns:a16="http://schemas.microsoft.com/office/drawing/2014/main" id="{26C989E3-7ED9-4E99-9A2F-1F475315D1D3}"/>
+                <a16:creationId xmlns:a16="http://schemas.microsoft.com/office/drawing/2014/main" id="{F44BC889-51D9-425B-BA25-988BDD38A310}"/>
               </a:ext>
             </a:extLst>
           </p:cNvPr>
@@ -6303,7 +6303,7 @@
           <p:cNvPr id="6" name="">
             <a:extLst xmlns:a="http://schemas.openxmlformats.org/drawingml/2006/main">
               <a:ext uri="{FF2B5EF4-FFF2-40B4-BE49-F238E27FC236}">
-                <a16:creationId xmlns:a16="http://schemas.microsoft.com/office/drawing/2014/main" id="{12271541-4D43-4752-9963-A0231C4290E6}"/>
+                <a16:creationId xmlns:a16="http://schemas.microsoft.com/office/drawing/2014/main" id="{8410A549-A2F5-4F13-98FE-46D3FF1B6DB5}"/>
               </a:ext>
             </a:extLst>
           </p:cNvPr>
@@ -6360,7 +6360,7 @@
           <p:cNvPr id="7" name="">
             <a:extLst xmlns:a="http://schemas.openxmlformats.org/drawingml/2006/main">
               <a:ext uri="{FF2B5EF4-FFF2-40B4-BE49-F238E27FC236}">
-                <a16:creationId xmlns:a16="http://schemas.microsoft.com/office/drawing/2014/main" id="{8587A9A3-9E2C-4149-ACE7-F1CA7FE44DF5}"/>
+                <a16:creationId xmlns:a16="http://schemas.microsoft.com/office/drawing/2014/main" id="{F2A01730-BACB-461D-9403-8B7D45DCB2BB}"/>
               </a:ext>
             </a:extLst>
           </p:cNvPr>
@@ -6390,7 +6390,7 @@
           <p:cNvPr id="8" name="">
             <a:extLst xmlns:a="http://schemas.openxmlformats.org/drawingml/2006/main">
               <a:ext uri="{FF2B5EF4-FFF2-40B4-BE49-F238E27FC236}">
-                <a16:creationId xmlns:a16="http://schemas.microsoft.com/office/drawing/2014/main" id="{06E0E123-5A28-4869-AFD5-07A0DDBCB142}"/>
+                <a16:creationId xmlns:a16="http://schemas.microsoft.com/office/drawing/2014/main" id="{F6A3DD55-DA96-43FF-ACF4-A34869663424}"/>
               </a:ext>
             </a:extLst>
           </p:cNvPr>
@@ -6447,7 +6447,7 @@
           <p:cNvPr id="9" name="">
             <a:extLst xmlns:a="http://schemas.openxmlformats.org/drawingml/2006/main">
               <a:ext uri="{FF2B5EF4-FFF2-40B4-BE49-F238E27FC236}">
-                <a16:creationId xmlns:a16="http://schemas.microsoft.com/office/drawing/2014/main" id="{C9584CBC-DA4E-41CD-99D1-F56D5D424615}"/>
+                <a16:creationId xmlns:a16="http://schemas.microsoft.com/office/drawing/2014/main" id="{7173481D-B406-4BDF-BAF3-02700B5F92EE}"/>
               </a:ext>
             </a:extLst>
           </p:cNvPr>
@@ -6504,7 +6504,7 @@
           <p:cNvPr id="10" name="">
             <a:extLst xmlns:a="http://schemas.openxmlformats.org/drawingml/2006/main">
               <a:ext uri="{FF2B5EF4-FFF2-40B4-BE49-F238E27FC236}">
-                <a16:creationId xmlns:a16="http://schemas.microsoft.com/office/drawing/2014/main" id="{6E4F8F82-752D-453A-85EE-A6B8E8CF2898}"/>
+                <a16:creationId xmlns:a16="http://schemas.microsoft.com/office/drawing/2014/main" id="{D20EB127-8223-4C05-849F-D35DBB068FF1}"/>
               </a:ext>
             </a:extLst>
           </p:cNvPr>
@@ -6534,7 +6534,7 @@
           <p:cNvPr id="11" name="">
             <a:extLst xmlns:a="http://schemas.openxmlformats.org/drawingml/2006/main">
               <a:ext uri="{FF2B5EF4-FFF2-40B4-BE49-F238E27FC236}">
-                <a16:creationId xmlns:a16="http://schemas.microsoft.com/office/drawing/2014/main" id="{26911DE6-0C2C-4830-99BC-631A6AD5A41A}"/>
+                <a16:creationId xmlns:a16="http://schemas.microsoft.com/office/drawing/2014/main" id="{F4038418-9FE4-48E6-8A1D-5D15E1703B69}"/>
               </a:ext>
             </a:extLst>
           </p:cNvPr>
@@ -6591,7 +6591,7 @@
           <p:cNvPr id="12" name="">
             <a:extLst xmlns:a="http://schemas.openxmlformats.org/drawingml/2006/main">
               <a:ext uri="{FF2B5EF4-FFF2-40B4-BE49-F238E27FC236}">
-                <a16:creationId xmlns:a16="http://schemas.microsoft.com/office/drawing/2014/main" id="{0DB03915-0A27-4EED-A0C7-160336D66933}"/>
+                <a16:creationId xmlns:a16="http://schemas.microsoft.com/office/drawing/2014/main" id="{D70DE86A-2558-42DE-9307-77FC80D6B7CE}"/>
               </a:ext>
             </a:extLst>
           </p:cNvPr>
@@ -6648,7 +6648,7 @@
           <p:cNvPr id="13" name="">
             <a:extLst xmlns:a="http://schemas.openxmlformats.org/drawingml/2006/main">
               <a:ext uri="{FF2B5EF4-FFF2-40B4-BE49-F238E27FC236}">
-                <a16:creationId xmlns:a16="http://schemas.microsoft.com/office/drawing/2014/main" id="{FD90B609-437D-48F8-8862-9700DC598E51}"/>
+                <a16:creationId xmlns:a16="http://schemas.microsoft.com/office/drawing/2014/main" id="{D616B5CD-31B7-40F3-A077-1B48785D509B}"/>
               </a:ext>
             </a:extLst>
           </p:cNvPr>
@@ -6678,7 +6678,7 @@
           <p:cNvPr id="14" name="">
             <a:extLst xmlns:a="http://schemas.openxmlformats.org/drawingml/2006/main">
               <a:ext uri="{FF2B5EF4-FFF2-40B4-BE49-F238E27FC236}">
-                <a16:creationId xmlns:a16="http://schemas.microsoft.com/office/drawing/2014/main" id="{45245DC4-E45F-48E6-9080-7361A0392CC5}"/>
+                <a16:creationId xmlns:a16="http://schemas.microsoft.com/office/drawing/2014/main" id="{0E9C092A-E26C-4EA7-8B6B-F3E4BC15FCC4}"/>
               </a:ext>
             </a:extLst>
           </p:cNvPr>
@@ -6733,7 +6733,7 @@
     </p:spTree>
     <p:extLst>
       <p:ext uri="{BB962C8B-B14F-4D97-AF65-F5344CB8AC3E}">
-        <p14:creationId xmlns:p14="http://schemas.microsoft.com/office/powerpoint/2010/main" val="560443876"/>
+        <p14:creationId xmlns:p14="http://schemas.microsoft.com/office/powerpoint/2010/main" val="246688590"/>
       </p:ext>
     </p:extLst>
   </p:cSld>
@@ -6764,7 +6764,7 @@
           <p:cNvPr id="18" name="">
             <a:extLst xmlns:a="http://schemas.openxmlformats.org/drawingml/2006/main">
               <a:ext uri="{FF2B5EF4-FFF2-40B4-BE49-F238E27FC236}">
-                <a16:creationId xmlns:a16="http://schemas.microsoft.com/office/drawing/2014/main" id="{7E5A0BF4-9DC1-4B03-9B46-C22D99F90658}"/>
+                <a16:creationId xmlns:a16="http://schemas.microsoft.com/office/drawing/2014/main" id="{A70F5089-CA32-497D-91E1-1E1F90E8A915}"/>
               </a:ext>
             </a:extLst>
           </p:cNvPr>
@@ -6794,7 +6794,7 @@
           <p:cNvPr id="2" name="">
             <a:extLst xmlns:a="http://schemas.openxmlformats.org/drawingml/2006/main">
               <a:ext uri="{FF2B5EF4-FFF2-40B4-BE49-F238E27FC236}">
-                <a16:creationId xmlns:a16="http://schemas.microsoft.com/office/drawing/2014/main" id="{69C1ADF2-05F8-489E-973F-5B459A56D93B}"/>
+                <a16:creationId xmlns:a16="http://schemas.microsoft.com/office/drawing/2014/main" id="{8A64A8A2-5D38-4648-AF1F-4598F63E8A32}"/>
               </a:ext>
             </a:extLst>
           </p:cNvPr>
@@ -6851,7 +6851,7 @@
           <p:cNvPr id="3" name="">
             <a:extLst xmlns:a="http://schemas.openxmlformats.org/drawingml/2006/main">
               <a:ext uri="{FF2B5EF4-FFF2-40B4-BE49-F238E27FC236}">
-                <a16:creationId xmlns:a16="http://schemas.microsoft.com/office/drawing/2014/main" id="{AC44D693-C347-4748-B6B6-3411F05EADF5}"/>
+                <a16:creationId xmlns:a16="http://schemas.microsoft.com/office/drawing/2014/main" id="{4908BF2B-6F40-496D-A8BA-67D88DB6CDF3}"/>
               </a:ext>
             </a:extLst>
           </p:cNvPr>
@@ -6881,7 +6881,7 @@
           <p:cNvPr id="4" name="">
             <a:extLst xmlns:a="http://schemas.openxmlformats.org/drawingml/2006/main">
               <a:ext uri="{FF2B5EF4-FFF2-40B4-BE49-F238E27FC236}">
-                <a16:creationId xmlns:a16="http://schemas.microsoft.com/office/drawing/2014/main" id="{2076E79C-1279-48AE-8E10-F86F21D472E1}"/>
+                <a16:creationId xmlns:a16="http://schemas.microsoft.com/office/drawing/2014/main" id="{2EC85170-ED98-4282-8942-15F563533693}"/>
               </a:ext>
             </a:extLst>
           </p:cNvPr>
@@ -6938,7 +6938,7 @@
           <p:cNvPr id="5" name="">
             <a:extLst xmlns:a="http://schemas.openxmlformats.org/drawingml/2006/main">
               <a:ext uri="{FF2B5EF4-FFF2-40B4-BE49-F238E27FC236}">
-                <a16:creationId xmlns:a16="http://schemas.microsoft.com/office/drawing/2014/main" id="{B57B200F-8BA7-4C3E-AB37-5C8DD8963379}"/>
+                <a16:creationId xmlns:a16="http://schemas.microsoft.com/office/drawing/2014/main" id="{2486D707-4B99-43B6-9E0D-8779E9E11605}"/>
               </a:ext>
             </a:extLst>
           </p:cNvPr>
@@ -6995,7 +6995,7 @@
           <p:cNvPr id="6" name="">
             <a:extLst xmlns:a="http://schemas.openxmlformats.org/drawingml/2006/main">
               <a:ext uri="{FF2B5EF4-FFF2-40B4-BE49-F238E27FC236}">
-                <a16:creationId xmlns:a16="http://schemas.microsoft.com/office/drawing/2014/main" id="{DC1109BD-204D-4687-9F42-78001271D375}"/>
+                <a16:creationId xmlns:a16="http://schemas.microsoft.com/office/drawing/2014/main" id="{1EC8ECD1-5CF0-469C-A00E-AE8E457277AA}"/>
               </a:ext>
             </a:extLst>
           </p:cNvPr>
@@ -7052,7 +7052,7 @@
           <p:cNvPr id="7" name="">
             <a:extLst xmlns:a="http://schemas.openxmlformats.org/drawingml/2006/main">
               <a:ext uri="{FF2B5EF4-FFF2-40B4-BE49-F238E27FC236}">
-                <a16:creationId xmlns:a16="http://schemas.microsoft.com/office/drawing/2014/main" id="{38F255F3-3A40-4309-B84F-CD5E94F1EC98}"/>
+                <a16:creationId xmlns:a16="http://schemas.microsoft.com/office/drawing/2014/main" id="{7612F32E-E1F0-4BB6-8419-E59FFE47F718}"/>
               </a:ext>
             </a:extLst>
           </p:cNvPr>
@@ -7109,7 +7109,7 @@
           <p:cNvPr id="8" name="">
             <a:extLst xmlns:a="http://schemas.openxmlformats.org/drawingml/2006/main">
               <a:ext uri="{FF2B5EF4-FFF2-40B4-BE49-F238E27FC236}">
-                <a16:creationId xmlns:a16="http://schemas.microsoft.com/office/drawing/2014/main" id="{376D2C89-7F50-467E-A8B3-C5E7002B8365}"/>
+                <a16:creationId xmlns:a16="http://schemas.microsoft.com/office/drawing/2014/main" id="{AB240249-4627-490F-B147-A04D441C9000}"/>
               </a:ext>
             </a:extLst>
           </p:cNvPr>
@@ -7166,7 +7166,7 @@
           <p:cNvPr id="9" name="">
             <a:extLst xmlns:a="http://schemas.openxmlformats.org/drawingml/2006/main">
               <a:ext uri="{FF2B5EF4-FFF2-40B4-BE49-F238E27FC236}">
-                <a16:creationId xmlns:a16="http://schemas.microsoft.com/office/drawing/2014/main" id="{08266346-4534-4DDF-9225-0B5436629553}"/>
+                <a16:creationId xmlns:a16="http://schemas.microsoft.com/office/drawing/2014/main" id="{4D9D4680-B2A9-43AF-8123-3A4DADE513C4}"/>
               </a:ext>
             </a:extLst>
           </p:cNvPr>
@@ -7196,7 +7196,7 @@
           <p:cNvPr id="10" name="">
             <a:extLst xmlns:a="http://schemas.openxmlformats.org/drawingml/2006/main">
               <a:ext uri="{FF2B5EF4-FFF2-40B4-BE49-F238E27FC236}">
-                <a16:creationId xmlns:a16="http://schemas.microsoft.com/office/drawing/2014/main" id="{092BA08B-458B-4C20-A169-C871BE597885}"/>
+                <a16:creationId xmlns:a16="http://schemas.microsoft.com/office/drawing/2014/main" id="{AEA3A379-84C1-4681-97D9-1B0942B590B7}"/>
               </a:ext>
             </a:extLst>
           </p:cNvPr>
@@ -7253,7 +7253,7 @@
           <p:cNvPr id="11" name="">
             <a:extLst xmlns:a="http://schemas.openxmlformats.org/drawingml/2006/main">
               <a:ext uri="{FF2B5EF4-FFF2-40B4-BE49-F238E27FC236}">
-                <a16:creationId xmlns:a16="http://schemas.microsoft.com/office/drawing/2014/main" id="{0B371E5D-6C86-4AEB-8CCB-1BD66E6F8099}"/>
+                <a16:creationId xmlns:a16="http://schemas.microsoft.com/office/drawing/2014/main" id="{01AA4DE8-2BE9-4A7E-9FBD-07849BE2E8D8}"/>
               </a:ext>
             </a:extLst>
           </p:cNvPr>
@@ -7310,7 +7310,7 @@
           <p:cNvPr id="12" name="">
             <a:extLst xmlns:a="http://schemas.openxmlformats.org/drawingml/2006/main">
               <a:ext uri="{FF2B5EF4-FFF2-40B4-BE49-F238E27FC236}">
-                <a16:creationId xmlns:a16="http://schemas.microsoft.com/office/drawing/2014/main" id="{AFD71A96-A9FF-482D-899C-1BF2E951FEF1}"/>
+                <a16:creationId xmlns:a16="http://schemas.microsoft.com/office/drawing/2014/main" id="{058F3D37-1BD0-4227-8EBB-DF2C949B963B}"/>
               </a:ext>
             </a:extLst>
           </p:cNvPr>
@@ -7357,7 +7357,7 @@
                 <a:ea typeface="Noto Sans KR"/>
                 <a:cs typeface="Noto Sans KR"/>
               </a:rPr>
-              <a:t>3명 관찰과 5명 시험으로 막히는 위치와 시간 단축을 확인</a:t>
+              <a:t>자료를 정리하고 결과물로 만드는 시간이 실제로 줄어드는지 확인</a:t>
             </a:r>
           </a:p>
         </p:txBody>
@@ -7367,7 +7367,7 @@
           <p:cNvPr id="13" name="">
             <a:extLst xmlns:a="http://schemas.openxmlformats.org/drawingml/2006/main">
               <a:ext uri="{FF2B5EF4-FFF2-40B4-BE49-F238E27FC236}">
-                <a16:creationId xmlns:a16="http://schemas.microsoft.com/office/drawing/2014/main" id="{B9AB395D-0E1A-4037-9FFD-4960804D5BC0}"/>
+                <a16:creationId xmlns:a16="http://schemas.microsoft.com/office/drawing/2014/main" id="{E7BDDF81-674A-4E82-8DA7-6BFDCB07110C}"/>
               </a:ext>
             </a:extLst>
           </p:cNvPr>
@@ -7424,7 +7424,7 @@
           <p:cNvPr id="14" name="">
             <a:extLst xmlns:a="http://schemas.openxmlformats.org/drawingml/2006/main">
               <a:ext uri="{FF2B5EF4-FFF2-40B4-BE49-F238E27FC236}">
-                <a16:creationId xmlns:a16="http://schemas.microsoft.com/office/drawing/2014/main" id="{A7EB0065-F287-4ED0-B6D7-D3E8555FB980}"/>
+                <a16:creationId xmlns:a16="http://schemas.microsoft.com/office/drawing/2014/main" id="{7CA446A1-E607-4C36-BA9A-A66C452B2F51}"/>
               </a:ext>
             </a:extLst>
           </p:cNvPr>
@@ -7471,7 +7471,7 @@
                 <a:ea typeface="Noto Sans KR"/>
                 <a:cs typeface="Noto Sans KR"/>
               </a:rPr>
-              <a:t>여러 사용자가 쓰는 단계에서 계정 로그인과 사용자별 기록 권한 구현</a:t>
+              <a:t>나만 쓰는 서비스에서 다양한 사람이 쓰는 범용 서비스로 확장</a:t>
             </a:r>
           </a:p>
         </p:txBody>
@@ -7481,7 +7481,7 @@
           <p:cNvPr id="15" name="">
             <a:extLst xmlns:a="http://schemas.openxmlformats.org/drawingml/2006/main">
               <a:ext uri="{FF2B5EF4-FFF2-40B4-BE49-F238E27FC236}">
-                <a16:creationId xmlns:a16="http://schemas.microsoft.com/office/drawing/2014/main" id="{A5D3229B-A237-459D-A718-622F4BB75A49}"/>
+                <a16:creationId xmlns:a16="http://schemas.microsoft.com/office/drawing/2014/main" id="{8188788F-0EA2-448F-9754-378DA2837E9A}"/>
               </a:ext>
             </a:extLst>
           </p:cNvPr>
@@ -7538,7 +7538,7 @@
           <p:cNvPr id="16" name="">
             <a:extLst xmlns:a="http://schemas.openxmlformats.org/drawingml/2006/main">
               <a:ext uri="{FF2B5EF4-FFF2-40B4-BE49-F238E27FC236}">
-                <a16:creationId xmlns:a16="http://schemas.microsoft.com/office/drawing/2014/main" id="{AB1EC055-43D2-4035-9351-DF340169FD17}"/>
+                <a16:creationId xmlns:a16="http://schemas.microsoft.com/office/drawing/2014/main" id="{831A4C84-0460-408E-B126-9278B048F528}"/>
               </a:ext>
             </a:extLst>
           </p:cNvPr>
@@ -7595,7 +7595,7 @@
           <p:cNvPr id="17" name="">
             <a:extLst xmlns:a="http://schemas.openxmlformats.org/drawingml/2006/main">
               <a:ext uri="{FF2B5EF4-FFF2-40B4-BE49-F238E27FC236}">
-                <a16:creationId xmlns:a16="http://schemas.microsoft.com/office/drawing/2014/main" id="{55906AF3-856A-4A47-B98B-340DD49C1CBC}"/>
+                <a16:creationId xmlns:a16="http://schemas.microsoft.com/office/drawing/2014/main" id="{6D1113F1-EB1F-46B9-A66E-C99548B3D2ED}"/>
               </a:ext>
             </a:extLst>
           </p:cNvPr>
@@ -7642,7 +7642,7 @@
                 <a:ea typeface="Noto Sans KR"/>
                 <a:cs typeface="Noto Sans KR"/>
               </a:rPr>
-              <a:t>검증 결과를 확인한 뒤 필요한 기능부터 구현하겠습니다</a:t>
+              <a:t>시간 단축을 확인하고, 다양한 사람이 쓸 수 있는 서비스로 확장하겠습니다</a:t>
             </a:r>
           </a:p>
         </p:txBody>
@@ -7650,7 +7650,7 @@
     </p:spTree>
     <p:extLst>
       <p:ext uri="{BB962C8B-B14F-4D97-AF65-F5344CB8AC3E}">
-        <p14:creationId xmlns:p14="http://schemas.microsoft.com/office/powerpoint/2010/main" val="622870741"/>
+        <p14:creationId xmlns:p14="http://schemas.microsoft.com/office/powerpoint/2010/main" val="1507994638"/>
       </p:ext>
     </p:extLst>
   </p:cSld>
@@ -7681,7 +7681,7 @@
           <p:cNvPr id="19" name="">
             <a:extLst xmlns:a="http://schemas.openxmlformats.org/drawingml/2006/main">
               <a:ext uri="{FF2B5EF4-FFF2-40B4-BE49-F238E27FC236}">
-                <a16:creationId xmlns:a16="http://schemas.microsoft.com/office/drawing/2014/main" id="{0D809E80-7F4B-4A9B-9C28-5865EBBB4796}"/>
+                <a16:creationId xmlns:a16="http://schemas.microsoft.com/office/drawing/2014/main" id="{26E321D3-56F0-495E-93CB-BAC82FEB5598}"/>
               </a:ext>
             </a:extLst>
           </p:cNvPr>
@@ -7711,7 +7711,7 @@
           <p:cNvPr id="2" name="">
             <a:extLst xmlns:a="http://schemas.openxmlformats.org/drawingml/2006/main">
               <a:ext uri="{FF2B5EF4-FFF2-40B4-BE49-F238E27FC236}">
-                <a16:creationId xmlns:a16="http://schemas.microsoft.com/office/drawing/2014/main" id="{76517AC6-201A-4D9A-9AA1-8EA2BCB86660}"/>
+                <a16:creationId xmlns:a16="http://schemas.microsoft.com/office/drawing/2014/main" id="{2B1F6AF4-AB14-49E5-B903-2308F9695C5D}"/>
               </a:ext>
             </a:extLst>
           </p:cNvPr>
@@ -7768,7 +7768,7 @@
           <p:cNvPr id="3" name="">
             <a:extLst xmlns:a="http://schemas.openxmlformats.org/drawingml/2006/main">
               <a:ext uri="{FF2B5EF4-FFF2-40B4-BE49-F238E27FC236}">
-                <a16:creationId xmlns:a16="http://schemas.microsoft.com/office/drawing/2014/main" id="{60FF1A6D-AE90-4522-A5A3-FCF996261809}"/>
+                <a16:creationId xmlns:a16="http://schemas.microsoft.com/office/drawing/2014/main" id="{82B5B03D-2D66-4869-8444-E9C83EBE9AEA}"/>
               </a:ext>
             </a:extLst>
           </p:cNvPr>
@@ -7798,7 +7798,7 @@
           <p:cNvPr id="4" name="">
             <a:extLst xmlns:a="http://schemas.openxmlformats.org/drawingml/2006/main">
               <a:ext uri="{FF2B5EF4-FFF2-40B4-BE49-F238E27FC236}">
-                <a16:creationId xmlns:a16="http://schemas.microsoft.com/office/drawing/2014/main" id="{1E25333D-3CD6-4F00-99EF-5364605BF191}"/>
+                <a16:creationId xmlns:a16="http://schemas.microsoft.com/office/drawing/2014/main" id="{E1585D15-E90B-4A18-A5F8-FD479937A73F}"/>
               </a:ext>
             </a:extLst>
           </p:cNvPr>
@@ -7855,7 +7855,7 @@
           <p:cNvPr id="5" name="">
             <a:extLst xmlns:a="http://schemas.openxmlformats.org/drawingml/2006/main">
               <a:ext uri="{FF2B5EF4-FFF2-40B4-BE49-F238E27FC236}">
-                <a16:creationId xmlns:a16="http://schemas.microsoft.com/office/drawing/2014/main" id="{80EFDD51-9818-4778-B290-8219CEB081B7}"/>
+                <a16:creationId xmlns:a16="http://schemas.microsoft.com/office/drawing/2014/main" id="{42725042-B53E-4987-BB34-72CF0B442E83}"/>
               </a:ext>
             </a:extLst>
           </p:cNvPr>
@@ -7912,7 +7912,7 @@
           <p:cNvPr id="6" name="">
             <a:extLst xmlns:a="http://schemas.openxmlformats.org/drawingml/2006/main">
               <a:ext uri="{FF2B5EF4-FFF2-40B4-BE49-F238E27FC236}">
-                <a16:creationId xmlns:a16="http://schemas.microsoft.com/office/drawing/2014/main" id="{C5681EAB-1E9A-4569-8B1E-1A68850D40F2}"/>
+                <a16:creationId xmlns:a16="http://schemas.microsoft.com/office/drawing/2014/main" id="{07D1E8CD-850B-4530-810E-5C54C8168A66}"/>
               </a:ext>
             </a:extLst>
           </p:cNvPr>
@@ -7992,7 +7992,7 @@
           <p:cNvPr id="7" name="">
             <a:extLst xmlns:a="http://schemas.openxmlformats.org/drawingml/2006/main">
               <a:ext uri="{FF2B5EF4-FFF2-40B4-BE49-F238E27FC236}">
-                <a16:creationId xmlns:a16="http://schemas.microsoft.com/office/drawing/2014/main" id="{BE56AC31-8223-4DE0-B173-48C39FCB1FF8}"/>
+                <a16:creationId xmlns:a16="http://schemas.microsoft.com/office/drawing/2014/main" id="{83F92DBC-00FC-44F5-B362-350B8C1B3529}"/>
               </a:ext>
             </a:extLst>
           </p:cNvPr>
@@ -8049,7 +8049,7 @@
           <p:cNvPr id="8" name="">
             <a:extLst xmlns:a="http://schemas.openxmlformats.org/drawingml/2006/main">
               <a:ext uri="{FF2B5EF4-FFF2-40B4-BE49-F238E27FC236}">
-                <a16:creationId xmlns:a16="http://schemas.microsoft.com/office/drawing/2014/main" id="{DE91129E-9046-460E-9D15-771742A51737}"/>
+                <a16:creationId xmlns:a16="http://schemas.microsoft.com/office/drawing/2014/main" id="{DE052FAA-C136-4D94-B74B-2A8738799D28}"/>
               </a:ext>
             </a:extLst>
           </p:cNvPr>
@@ -8129,7 +8129,7 @@
           <p:cNvPr id="9" name="">
             <a:extLst xmlns:a="http://schemas.openxmlformats.org/drawingml/2006/main">
               <a:ext uri="{FF2B5EF4-FFF2-40B4-BE49-F238E27FC236}">
-                <a16:creationId xmlns:a16="http://schemas.microsoft.com/office/drawing/2014/main" id="{4C91B3F4-BFC5-4579-8D4D-8A4368886A22}"/>
+                <a16:creationId xmlns:a16="http://schemas.microsoft.com/office/drawing/2014/main" id="{3DE10CAF-7E3E-44FA-9B8F-C73BB4E032F7}"/>
               </a:ext>
             </a:extLst>
           </p:cNvPr>
@@ -8186,7 +8186,7 @@
           <p:cNvPr id="10" name="">
             <a:extLst xmlns:a="http://schemas.openxmlformats.org/drawingml/2006/main">
               <a:ext uri="{FF2B5EF4-FFF2-40B4-BE49-F238E27FC236}">
-                <a16:creationId xmlns:a16="http://schemas.microsoft.com/office/drawing/2014/main" id="{876DED59-8F44-4D12-BFB8-3F54E58F6371}"/>
+                <a16:creationId xmlns:a16="http://schemas.microsoft.com/office/drawing/2014/main" id="{B185D1BB-7756-4179-B3CF-E9CCB875CE96}"/>
               </a:ext>
             </a:extLst>
           </p:cNvPr>
@@ -8289,7 +8289,7 @@
           <p:cNvPr id="11" name="">
             <a:extLst xmlns:a="http://schemas.openxmlformats.org/drawingml/2006/main">
               <a:ext uri="{FF2B5EF4-FFF2-40B4-BE49-F238E27FC236}">
-                <a16:creationId xmlns:a16="http://schemas.microsoft.com/office/drawing/2014/main" id="{F08FF74B-C0DA-43BF-B18B-69A52B789BF2}"/>
+                <a16:creationId xmlns:a16="http://schemas.microsoft.com/office/drawing/2014/main" id="{FF58728B-17B6-4D8D-BAE8-A82CDA1C872F}"/>
               </a:ext>
             </a:extLst>
           </p:cNvPr>
@@ -8346,7 +8346,7 @@
           <p:cNvPr id="12" name="">
             <a:extLst xmlns:a="http://schemas.openxmlformats.org/drawingml/2006/main">
               <a:ext uri="{FF2B5EF4-FFF2-40B4-BE49-F238E27FC236}">
-                <a16:creationId xmlns:a16="http://schemas.microsoft.com/office/drawing/2014/main" id="{07E2AEBE-9DE1-4D87-B338-2EF35ACEB959}"/>
+                <a16:creationId xmlns:a16="http://schemas.microsoft.com/office/drawing/2014/main" id="{AB5AC6DE-3003-417A-A955-4434BD26B4F8}"/>
               </a:ext>
             </a:extLst>
           </p:cNvPr>
@@ -8449,7 +8449,7 @@
           <p:cNvPr id="13" name="">
             <a:extLst xmlns:a="http://schemas.openxmlformats.org/drawingml/2006/main">
               <a:ext uri="{FF2B5EF4-FFF2-40B4-BE49-F238E27FC236}">
-                <a16:creationId xmlns:a16="http://schemas.microsoft.com/office/drawing/2014/main" id="{5A0F4B83-8E4A-425D-925E-B32B02CF25CB}"/>
+                <a16:creationId xmlns:a16="http://schemas.microsoft.com/office/drawing/2014/main" id="{E368CF16-165D-435B-BA37-95D9C4E94841}"/>
               </a:ext>
             </a:extLst>
           </p:cNvPr>
@@ -8506,7 +8506,7 @@
           <p:cNvPr id="14" name="">
             <a:extLst xmlns:a="http://schemas.openxmlformats.org/drawingml/2006/main">
               <a:ext uri="{FF2B5EF4-FFF2-40B4-BE49-F238E27FC236}">
-                <a16:creationId xmlns:a16="http://schemas.microsoft.com/office/drawing/2014/main" id="{1D6FC5DF-D4CE-4F00-89C4-7B7CAF6BCB57}"/>
+                <a16:creationId xmlns:a16="http://schemas.microsoft.com/office/drawing/2014/main" id="{450FC0BA-C92D-446A-9530-EF2FD2228257}"/>
               </a:ext>
             </a:extLst>
           </p:cNvPr>
@@ -8563,7 +8563,7 @@
           <p:cNvPr id="15" name="">
             <a:extLst xmlns:a="http://schemas.openxmlformats.org/drawingml/2006/main">
               <a:ext uri="{FF2B5EF4-FFF2-40B4-BE49-F238E27FC236}">
-                <a16:creationId xmlns:a16="http://schemas.microsoft.com/office/drawing/2014/main" id="{8E8FE15D-E32C-405E-9023-A9259F88A469}"/>
+                <a16:creationId xmlns:a16="http://schemas.microsoft.com/office/drawing/2014/main" id="{F9DA20A1-65C4-4922-81EF-6D7A1F828C21}"/>
               </a:ext>
             </a:extLst>
           </p:cNvPr>
@@ -8620,7 +8620,7 @@
           <p:cNvPr id="16" name="">
             <a:extLst xmlns:a="http://schemas.openxmlformats.org/drawingml/2006/main">
               <a:ext uri="{FF2B5EF4-FFF2-40B4-BE49-F238E27FC236}">
-                <a16:creationId xmlns:a16="http://schemas.microsoft.com/office/drawing/2014/main" id="{2502DF1B-AA10-4663-8519-B9796973A113}"/>
+                <a16:creationId xmlns:a16="http://schemas.microsoft.com/office/drawing/2014/main" id="{2DFD441E-9931-4D1F-8B7A-75C6B93A2437}"/>
               </a:ext>
             </a:extLst>
           </p:cNvPr>
@@ -8650,7 +8650,7 @@
           <p:cNvPr id="17" name="">
             <a:extLst xmlns:a="http://schemas.openxmlformats.org/drawingml/2006/main">
               <a:ext uri="{FF2B5EF4-FFF2-40B4-BE49-F238E27FC236}">
-                <a16:creationId xmlns:a16="http://schemas.microsoft.com/office/drawing/2014/main" id="{64FC5DD0-E4B7-47D7-A69F-A5B55E9BE235}"/>
+                <a16:creationId xmlns:a16="http://schemas.microsoft.com/office/drawing/2014/main" id="{11A56493-7CF8-4D9B-9A18-470E6547ED37}"/>
               </a:ext>
             </a:extLst>
           </p:cNvPr>
@@ -8707,7 +8707,7 @@
           <p:cNvPr id="18" name="">
             <a:extLst xmlns:a="http://schemas.openxmlformats.org/drawingml/2006/main">
               <a:ext uri="{FF2B5EF4-FFF2-40B4-BE49-F238E27FC236}">
-                <a16:creationId xmlns:a16="http://schemas.microsoft.com/office/drawing/2014/main" id="{EAC6106A-70DE-4CB6-87F8-D0D65F3FA019}"/>
+                <a16:creationId xmlns:a16="http://schemas.microsoft.com/office/drawing/2014/main" id="{DE0E13AA-8BE4-4F72-987B-47ADD65114A8}"/>
               </a:ext>
             </a:extLst>
           </p:cNvPr>
@@ -8785,7 +8785,7 @@
     </p:spTree>
     <p:extLst>
       <p:ext uri="{BB962C8B-B14F-4D97-AF65-F5344CB8AC3E}">
-        <p14:creationId xmlns:p14="http://schemas.microsoft.com/office/powerpoint/2010/main" val="1834696863"/>
+        <p14:creationId xmlns:p14="http://schemas.microsoft.com/office/powerpoint/2010/main" val="1728074684"/>
       </p:ext>
     </p:extLst>
   </p:cSld>
@@ -8816,7 +8816,7 @@
           <p:cNvPr id="19" name="">
             <a:extLst xmlns:a="http://schemas.openxmlformats.org/drawingml/2006/main">
               <a:ext uri="{FF2B5EF4-FFF2-40B4-BE49-F238E27FC236}">
-                <a16:creationId xmlns:a16="http://schemas.microsoft.com/office/drawing/2014/main" id="{DF0F2D52-B5C1-460D-8050-584B2939BCE9}"/>
+                <a16:creationId xmlns:a16="http://schemas.microsoft.com/office/drawing/2014/main" id="{7049B9E9-BA78-485D-9FDA-834199107F7A}"/>
               </a:ext>
             </a:extLst>
           </p:cNvPr>
@@ -8846,7 +8846,7 @@
           <p:cNvPr id="2" name="">
             <a:extLst xmlns:a="http://schemas.openxmlformats.org/drawingml/2006/main">
               <a:ext uri="{FF2B5EF4-FFF2-40B4-BE49-F238E27FC236}">
-                <a16:creationId xmlns:a16="http://schemas.microsoft.com/office/drawing/2014/main" id="{9F9B99EB-0490-4122-B67B-CFE66C5B87B0}"/>
+                <a16:creationId xmlns:a16="http://schemas.microsoft.com/office/drawing/2014/main" id="{1C0882BE-EDC0-4B63-8938-5874C79B4EDA}"/>
               </a:ext>
             </a:extLst>
           </p:cNvPr>
@@ -8903,7 +8903,7 @@
           <p:cNvPr id="3" name="">
             <a:extLst xmlns:a="http://schemas.openxmlformats.org/drawingml/2006/main">
               <a:ext uri="{FF2B5EF4-FFF2-40B4-BE49-F238E27FC236}">
-                <a16:creationId xmlns:a16="http://schemas.microsoft.com/office/drawing/2014/main" id="{FFA6EA54-2D3D-44EE-AEA4-64DC643C9E0F}"/>
+                <a16:creationId xmlns:a16="http://schemas.microsoft.com/office/drawing/2014/main" id="{FCCA2FEA-FF22-4AB2-8583-43815A83B687}"/>
               </a:ext>
             </a:extLst>
           </p:cNvPr>
@@ -8933,7 +8933,7 @@
           <p:cNvPr id="4" name="">
             <a:extLst xmlns:a="http://schemas.openxmlformats.org/drawingml/2006/main">
               <a:ext uri="{FF2B5EF4-FFF2-40B4-BE49-F238E27FC236}">
-                <a16:creationId xmlns:a16="http://schemas.microsoft.com/office/drawing/2014/main" id="{E0484149-FA7B-4A7E-A964-DF788392EDBD}"/>
+                <a16:creationId xmlns:a16="http://schemas.microsoft.com/office/drawing/2014/main" id="{09B0CF55-130F-4E81-A8B9-691C61F62DF7}"/>
               </a:ext>
             </a:extLst>
           </p:cNvPr>
@@ -8990,7 +8990,7 @@
           <p:cNvPr id="5" name="">
             <a:extLst xmlns:a="http://schemas.openxmlformats.org/drawingml/2006/main">
               <a:ext uri="{FF2B5EF4-FFF2-40B4-BE49-F238E27FC236}">
-                <a16:creationId xmlns:a16="http://schemas.microsoft.com/office/drawing/2014/main" id="{E4D7FA79-8EF2-480B-B3A2-5F4C18CC03A1}"/>
+                <a16:creationId xmlns:a16="http://schemas.microsoft.com/office/drawing/2014/main" id="{ECA7CAA1-45BB-4915-B282-9594832FC51D}"/>
               </a:ext>
             </a:extLst>
           </p:cNvPr>
@@ -9047,7 +9047,7 @@
           <p:cNvPr id="6" name="">
             <a:extLst xmlns:a="http://schemas.openxmlformats.org/drawingml/2006/main">
               <a:ext uri="{FF2B5EF4-FFF2-40B4-BE49-F238E27FC236}">
-                <a16:creationId xmlns:a16="http://schemas.microsoft.com/office/drawing/2014/main" id="{6CCEB68B-912A-4714-8A00-801D3179A5F7}"/>
+                <a16:creationId xmlns:a16="http://schemas.microsoft.com/office/drawing/2014/main" id="{568A602E-4FF5-43D9-8ABD-50A994A53B28}"/>
               </a:ext>
             </a:extLst>
           </p:cNvPr>
@@ -9104,7 +9104,7 @@
           <p:cNvPr id="7" name="">
             <a:extLst xmlns:a="http://schemas.openxmlformats.org/drawingml/2006/main">
               <a:ext uri="{FF2B5EF4-FFF2-40B4-BE49-F238E27FC236}">
-                <a16:creationId xmlns:a16="http://schemas.microsoft.com/office/drawing/2014/main" id="{D8E78EA0-9C1A-4B3E-BC30-CB30EAAAE552}"/>
+                <a16:creationId xmlns:a16="http://schemas.microsoft.com/office/drawing/2014/main" id="{83CE1E16-F227-40DC-A9C0-CE2EA1B14B9D}"/>
               </a:ext>
             </a:extLst>
           </p:cNvPr>
@@ -9184,7 +9184,7 @@
           <p:cNvPr id="8" name="">
             <a:extLst xmlns:a="http://schemas.openxmlformats.org/drawingml/2006/main">
               <a:ext uri="{FF2B5EF4-FFF2-40B4-BE49-F238E27FC236}">
-                <a16:creationId xmlns:a16="http://schemas.microsoft.com/office/drawing/2014/main" id="{7051A078-7F98-4A60-B7D7-6A4DDAE70CA7}"/>
+                <a16:creationId xmlns:a16="http://schemas.microsoft.com/office/drawing/2014/main" id="{207926FC-59FF-4477-AF86-F4D77714062A}"/>
               </a:ext>
             </a:extLst>
           </p:cNvPr>
@@ -9214,7 +9214,7 @@
           <p:cNvPr id="9" name="">
             <a:extLst xmlns:a="http://schemas.openxmlformats.org/drawingml/2006/main">
               <a:ext uri="{FF2B5EF4-FFF2-40B4-BE49-F238E27FC236}">
-                <a16:creationId xmlns:a16="http://schemas.microsoft.com/office/drawing/2014/main" id="{2E0299BB-00B5-4712-A3CE-2CBA94B65AEB}"/>
+                <a16:creationId xmlns:a16="http://schemas.microsoft.com/office/drawing/2014/main" id="{A4C38AAE-0D82-421F-9AD0-9402178D885A}"/>
               </a:ext>
             </a:extLst>
           </p:cNvPr>
@@ -9271,7 +9271,7 @@
           <p:cNvPr id="10" name="">
             <a:extLst xmlns:a="http://schemas.openxmlformats.org/drawingml/2006/main">
               <a:ext uri="{FF2B5EF4-FFF2-40B4-BE49-F238E27FC236}">
-                <a16:creationId xmlns:a16="http://schemas.microsoft.com/office/drawing/2014/main" id="{F67807EA-0857-4D6D-A005-510778772E54}"/>
+                <a16:creationId xmlns:a16="http://schemas.microsoft.com/office/drawing/2014/main" id="{8D81EDC0-89A9-4949-88BE-5420D754B9AA}"/>
               </a:ext>
             </a:extLst>
           </p:cNvPr>
@@ -9328,7 +9328,7 @@
           <p:cNvPr id="11" name="">
             <a:extLst xmlns:a="http://schemas.openxmlformats.org/drawingml/2006/main">
               <a:ext uri="{FF2B5EF4-FFF2-40B4-BE49-F238E27FC236}">
-                <a16:creationId xmlns:a16="http://schemas.microsoft.com/office/drawing/2014/main" id="{2D65D83E-3E23-433A-A53C-5B8B874F6EEB}"/>
+                <a16:creationId xmlns:a16="http://schemas.microsoft.com/office/drawing/2014/main" id="{A42A0894-C9AD-491E-BE9A-D033F7D3BF17}"/>
               </a:ext>
             </a:extLst>
           </p:cNvPr>
@@ -9408,7 +9408,7 @@
           <p:cNvPr id="12" name="">
             <a:extLst xmlns:a="http://schemas.openxmlformats.org/drawingml/2006/main">
               <a:ext uri="{FF2B5EF4-FFF2-40B4-BE49-F238E27FC236}">
-                <a16:creationId xmlns:a16="http://schemas.microsoft.com/office/drawing/2014/main" id="{E46766D3-FE94-4B0B-9A57-7D2964264BD5}"/>
+                <a16:creationId xmlns:a16="http://schemas.microsoft.com/office/drawing/2014/main" id="{44F44C85-5B24-4A77-8173-07515BAD987F}"/>
               </a:ext>
             </a:extLst>
           </p:cNvPr>
@@ -9438,7 +9438,7 @@
           <p:cNvPr id="13" name="">
             <a:extLst xmlns:a="http://schemas.openxmlformats.org/drawingml/2006/main">
               <a:ext uri="{FF2B5EF4-FFF2-40B4-BE49-F238E27FC236}">
-                <a16:creationId xmlns:a16="http://schemas.microsoft.com/office/drawing/2014/main" id="{36022420-C516-4005-AC58-27D1613A6ABE}"/>
+                <a16:creationId xmlns:a16="http://schemas.microsoft.com/office/drawing/2014/main" id="{3B98E212-D2FB-4D46-AD94-BDCAA16A6AB2}"/>
               </a:ext>
             </a:extLst>
           </p:cNvPr>
@@ -9495,7 +9495,7 @@
           <p:cNvPr id="14" name="">
             <a:extLst xmlns:a="http://schemas.openxmlformats.org/drawingml/2006/main">
               <a:ext uri="{FF2B5EF4-FFF2-40B4-BE49-F238E27FC236}">
-                <a16:creationId xmlns:a16="http://schemas.microsoft.com/office/drawing/2014/main" id="{E761C80C-C06C-4A1D-A09B-FD4DDB7C3429}"/>
+                <a16:creationId xmlns:a16="http://schemas.microsoft.com/office/drawing/2014/main" id="{B23935B5-DFE6-4496-AF01-64A1C80B3793}"/>
               </a:ext>
             </a:extLst>
           </p:cNvPr>
@@ -9552,7 +9552,7 @@
           <p:cNvPr id="15" name="">
             <a:extLst xmlns:a="http://schemas.openxmlformats.org/drawingml/2006/main">
               <a:ext uri="{FF2B5EF4-FFF2-40B4-BE49-F238E27FC236}">
-                <a16:creationId xmlns:a16="http://schemas.microsoft.com/office/drawing/2014/main" id="{F4ABB504-149D-4430-91F0-AD7699BEDF54}"/>
+                <a16:creationId xmlns:a16="http://schemas.microsoft.com/office/drawing/2014/main" id="{01226DE6-EA09-4006-9119-1058F28C3F64}"/>
               </a:ext>
             </a:extLst>
           </p:cNvPr>
@@ -9632,7 +9632,7 @@
           <p:cNvPr id="16" name="">
             <a:extLst xmlns:a="http://schemas.openxmlformats.org/drawingml/2006/main">
               <a:ext uri="{FF2B5EF4-FFF2-40B4-BE49-F238E27FC236}">
-                <a16:creationId xmlns:a16="http://schemas.microsoft.com/office/drawing/2014/main" id="{D32EAAAF-3D51-440E-82D9-450A699AE041}"/>
+                <a16:creationId xmlns:a16="http://schemas.microsoft.com/office/drawing/2014/main" id="{3CA0C6A5-04ED-4A91-ACC4-C7B57A943DAB}"/>
               </a:ext>
             </a:extLst>
           </p:cNvPr>
@@ -9689,7 +9689,7 @@
           <p:cNvPr id="17" name="">
             <a:extLst xmlns:a="http://schemas.openxmlformats.org/drawingml/2006/main">
               <a:ext uri="{FF2B5EF4-FFF2-40B4-BE49-F238E27FC236}">
-                <a16:creationId xmlns:a16="http://schemas.microsoft.com/office/drawing/2014/main" id="{2746FDCD-35A6-43F2-A831-6C95656D4B05}"/>
+                <a16:creationId xmlns:a16="http://schemas.microsoft.com/office/drawing/2014/main" id="{970B191C-C0AE-4603-AB71-968A85FA3344}"/>
               </a:ext>
             </a:extLst>
           </p:cNvPr>
@@ -9746,7 +9746,7 @@
           <p:cNvPr id="18" name="">
             <a:extLst xmlns:a="http://schemas.openxmlformats.org/drawingml/2006/main">
               <a:ext uri="{FF2B5EF4-FFF2-40B4-BE49-F238E27FC236}">
-                <a16:creationId xmlns:a16="http://schemas.microsoft.com/office/drawing/2014/main" id="{2BB1AD69-1121-4AB7-B0D5-8089F09071C3}"/>
+                <a16:creationId xmlns:a16="http://schemas.microsoft.com/office/drawing/2014/main" id="{C50DE119-3FD7-4E01-B5F8-965D715D76E7}"/>
               </a:ext>
             </a:extLst>
           </p:cNvPr>
@@ -9801,7 +9801,7 @@
     </p:spTree>
     <p:extLst>
       <p:ext uri="{BB962C8B-B14F-4D97-AF65-F5344CB8AC3E}">
-        <p14:creationId xmlns:p14="http://schemas.microsoft.com/office/powerpoint/2010/main" val="1467454721"/>
+        <p14:creationId xmlns:p14="http://schemas.microsoft.com/office/powerpoint/2010/main" val="1803741850"/>
       </p:ext>
     </p:extLst>
   </p:cSld>
@@ -9832,7 +9832,7 @@
           <p:cNvPr id="18" name="">
             <a:extLst xmlns:a="http://schemas.openxmlformats.org/drawingml/2006/main">
               <a:ext uri="{FF2B5EF4-FFF2-40B4-BE49-F238E27FC236}">
-                <a16:creationId xmlns:a16="http://schemas.microsoft.com/office/drawing/2014/main" id="{C23E73B6-DF69-4ED3-BE87-427B3A3E9642}"/>
+                <a16:creationId xmlns:a16="http://schemas.microsoft.com/office/drawing/2014/main" id="{2A0C4F07-7080-47C1-BE6E-9EC9AE0000CF}"/>
               </a:ext>
             </a:extLst>
           </p:cNvPr>
@@ -9862,7 +9862,7 @@
           <p:cNvPr id="2" name="">
             <a:extLst xmlns:a="http://schemas.openxmlformats.org/drawingml/2006/main">
               <a:ext uri="{FF2B5EF4-FFF2-40B4-BE49-F238E27FC236}">
-                <a16:creationId xmlns:a16="http://schemas.microsoft.com/office/drawing/2014/main" id="{FA2579AB-85F9-4594-9636-C0572C57AB8F}"/>
+                <a16:creationId xmlns:a16="http://schemas.microsoft.com/office/drawing/2014/main" id="{8A2E8129-4671-47C5-8166-5F24D71A83FA}"/>
               </a:ext>
             </a:extLst>
           </p:cNvPr>
@@ -9919,7 +9919,7 @@
           <p:cNvPr id="3" name="">
             <a:extLst xmlns:a="http://schemas.openxmlformats.org/drawingml/2006/main">
               <a:ext uri="{FF2B5EF4-FFF2-40B4-BE49-F238E27FC236}">
-                <a16:creationId xmlns:a16="http://schemas.microsoft.com/office/drawing/2014/main" id="{A9EF6490-5A73-47F5-972C-B65153D72012}"/>
+                <a16:creationId xmlns:a16="http://schemas.microsoft.com/office/drawing/2014/main" id="{0FAB1B8C-26C7-452E-814C-8613F63B59A7}"/>
               </a:ext>
             </a:extLst>
           </p:cNvPr>
@@ -9949,7 +9949,7 @@
           <p:cNvPr id="4" name="">
             <a:extLst xmlns:a="http://schemas.openxmlformats.org/drawingml/2006/main">
               <a:ext uri="{FF2B5EF4-FFF2-40B4-BE49-F238E27FC236}">
-                <a16:creationId xmlns:a16="http://schemas.microsoft.com/office/drawing/2014/main" id="{A04800F3-0980-4933-ACF8-4D03E07CB000}"/>
+                <a16:creationId xmlns:a16="http://schemas.microsoft.com/office/drawing/2014/main" id="{402BFB6C-D1C9-4CB6-87C6-B8C4C59FE53D}"/>
               </a:ext>
             </a:extLst>
           </p:cNvPr>
@@ -10006,7 +10006,7 @@
           <p:cNvPr id="5" name="">
             <a:extLst xmlns:a="http://schemas.openxmlformats.org/drawingml/2006/main">
               <a:ext uri="{FF2B5EF4-FFF2-40B4-BE49-F238E27FC236}">
-                <a16:creationId xmlns:a16="http://schemas.microsoft.com/office/drawing/2014/main" id="{5A4B0EEA-B0BA-4CD6-B8FF-8AFA18455707}"/>
+                <a16:creationId xmlns:a16="http://schemas.microsoft.com/office/drawing/2014/main" id="{F8081D26-B7B1-44A3-8116-930FFEAC3599}"/>
               </a:ext>
             </a:extLst>
           </p:cNvPr>
@@ -10036,7 +10036,7 @@
           <p:cNvPr id="6" name="">
             <a:extLst xmlns:a="http://schemas.openxmlformats.org/drawingml/2006/main">
               <a:ext uri="{FF2B5EF4-FFF2-40B4-BE49-F238E27FC236}">
-                <a16:creationId xmlns:a16="http://schemas.microsoft.com/office/drawing/2014/main" id="{705A9AD0-ABDA-4B9C-BA93-2DC0F5C85646}"/>
+                <a16:creationId xmlns:a16="http://schemas.microsoft.com/office/drawing/2014/main" id="{F4FA31A7-998B-4458-95C5-F28951EDC73D}"/>
               </a:ext>
             </a:extLst>
           </p:cNvPr>
@@ -10093,7 +10093,7 @@
           <p:cNvPr id="7" name="">
             <a:extLst xmlns:a="http://schemas.openxmlformats.org/drawingml/2006/main">
               <a:ext uri="{FF2B5EF4-FFF2-40B4-BE49-F238E27FC236}">
-                <a16:creationId xmlns:a16="http://schemas.microsoft.com/office/drawing/2014/main" id="{B3D048D9-D541-4797-8D25-E32862B7C11A}"/>
+                <a16:creationId xmlns:a16="http://schemas.microsoft.com/office/drawing/2014/main" id="{51C2A4DB-1C50-45D2-9E64-ABCC26C32D51}"/>
               </a:ext>
             </a:extLst>
           </p:cNvPr>
@@ -10173,7 +10173,7 @@
           <p:cNvPr id="8" name="">
             <a:extLst xmlns:a="http://schemas.openxmlformats.org/drawingml/2006/main">
               <a:ext uri="{FF2B5EF4-FFF2-40B4-BE49-F238E27FC236}">
-                <a16:creationId xmlns:a16="http://schemas.microsoft.com/office/drawing/2014/main" id="{76BB8D93-08AC-47FA-8F5F-25F3275A2662}"/>
+                <a16:creationId xmlns:a16="http://schemas.microsoft.com/office/drawing/2014/main" id="{A685A3B6-2641-411D-BF24-D86DC499516A}"/>
               </a:ext>
             </a:extLst>
           </p:cNvPr>
@@ -10203,7 +10203,7 @@
           <p:cNvPr id="9" name="">
             <a:extLst xmlns:a="http://schemas.openxmlformats.org/drawingml/2006/main">
               <a:ext uri="{FF2B5EF4-FFF2-40B4-BE49-F238E27FC236}">
-                <a16:creationId xmlns:a16="http://schemas.microsoft.com/office/drawing/2014/main" id="{DC32D34A-6858-455F-B516-522616877EC4}"/>
+                <a16:creationId xmlns:a16="http://schemas.microsoft.com/office/drawing/2014/main" id="{76575AF8-C3C8-4040-9586-449B4F99B1BA}"/>
               </a:ext>
             </a:extLst>
           </p:cNvPr>
@@ -10260,7 +10260,7 @@
           <p:cNvPr id="10" name="">
             <a:extLst xmlns:a="http://schemas.openxmlformats.org/drawingml/2006/main">
               <a:ext uri="{FF2B5EF4-FFF2-40B4-BE49-F238E27FC236}">
-                <a16:creationId xmlns:a16="http://schemas.microsoft.com/office/drawing/2014/main" id="{AF0DD99D-A94A-42FA-9E93-31D847BED536}"/>
+                <a16:creationId xmlns:a16="http://schemas.microsoft.com/office/drawing/2014/main" id="{79EFEDAA-4D47-48F4-A9D9-47B2DEFDD6E8}"/>
               </a:ext>
             </a:extLst>
           </p:cNvPr>
@@ -10340,7 +10340,7 @@
           <p:cNvPr id="11" name="">
             <a:extLst xmlns:a="http://schemas.openxmlformats.org/drawingml/2006/main">
               <a:ext uri="{FF2B5EF4-FFF2-40B4-BE49-F238E27FC236}">
-                <a16:creationId xmlns:a16="http://schemas.microsoft.com/office/drawing/2014/main" id="{D208321C-8DD1-4501-9698-D9234531827C}"/>
+                <a16:creationId xmlns:a16="http://schemas.microsoft.com/office/drawing/2014/main" id="{1DB7F900-9D93-477D-B309-2DA5440A6733}"/>
               </a:ext>
             </a:extLst>
           </p:cNvPr>
@@ -10370,7 +10370,7 @@
           <p:cNvPr id="12" name="">
             <a:extLst xmlns:a="http://schemas.openxmlformats.org/drawingml/2006/main">
               <a:ext uri="{FF2B5EF4-FFF2-40B4-BE49-F238E27FC236}">
-                <a16:creationId xmlns:a16="http://schemas.microsoft.com/office/drawing/2014/main" id="{52C023AC-6DAC-4BFA-8368-E8967EA8E863}"/>
+                <a16:creationId xmlns:a16="http://schemas.microsoft.com/office/drawing/2014/main" id="{6602AB6C-B986-48CB-A2A7-E3989A4D39F8}"/>
               </a:ext>
             </a:extLst>
           </p:cNvPr>
@@ -10427,7 +10427,7 @@
           <p:cNvPr id="13" name="">
             <a:extLst xmlns:a="http://schemas.openxmlformats.org/drawingml/2006/main">
               <a:ext uri="{FF2B5EF4-FFF2-40B4-BE49-F238E27FC236}">
-                <a16:creationId xmlns:a16="http://schemas.microsoft.com/office/drawing/2014/main" id="{A223634C-E262-4277-AD4D-309B7B53FABC}"/>
+                <a16:creationId xmlns:a16="http://schemas.microsoft.com/office/drawing/2014/main" id="{3361C133-124A-4E96-B250-36930E0DD62C}"/>
               </a:ext>
             </a:extLst>
           </p:cNvPr>
@@ -10507,7 +10507,7 @@
           <p:cNvPr id="14" name="">
             <a:extLst xmlns:a="http://schemas.openxmlformats.org/drawingml/2006/main">
               <a:ext uri="{FF2B5EF4-FFF2-40B4-BE49-F238E27FC236}">
-                <a16:creationId xmlns:a16="http://schemas.microsoft.com/office/drawing/2014/main" id="{1E53219A-F79E-428D-8607-1471A1702EE4}"/>
+                <a16:creationId xmlns:a16="http://schemas.microsoft.com/office/drawing/2014/main" id="{61DFB55D-63CA-438E-9975-732631C7530E}"/>
               </a:ext>
             </a:extLst>
           </p:cNvPr>
@@ -10537,7 +10537,7 @@
           <p:cNvPr id="15" name="">
             <a:extLst xmlns:a="http://schemas.openxmlformats.org/drawingml/2006/main">
               <a:ext uri="{FF2B5EF4-FFF2-40B4-BE49-F238E27FC236}">
-                <a16:creationId xmlns:a16="http://schemas.microsoft.com/office/drawing/2014/main" id="{BFCC9ABE-B741-45E0-A88B-FB7D88AA70BE}"/>
+                <a16:creationId xmlns:a16="http://schemas.microsoft.com/office/drawing/2014/main" id="{4C6F7059-4225-4128-9698-7B6ABAFF76DB}"/>
               </a:ext>
             </a:extLst>
           </p:cNvPr>
@@ -10594,7 +10594,7 @@
           <p:cNvPr id="16" name="">
             <a:extLst xmlns:a="http://schemas.openxmlformats.org/drawingml/2006/main">
               <a:ext uri="{FF2B5EF4-FFF2-40B4-BE49-F238E27FC236}">
-                <a16:creationId xmlns:a16="http://schemas.microsoft.com/office/drawing/2014/main" id="{630076FB-EE1F-419E-8B5D-8169F537D399}"/>
+                <a16:creationId xmlns:a16="http://schemas.microsoft.com/office/drawing/2014/main" id="{1EC755A4-C2A2-4898-9099-BEA9DC05C048}"/>
               </a:ext>
             </a:extLst>
           </p:cNvPr>
@@ -10674,7 +10674,7 @@
           <p:cNvPr id="17" name="">
             <a:extLst xmlns:a="http://schemas.openxmlformats.org/drawingml/2006/main">
               <a:ext uri="{FF2B5EF4-FFF2-40B4-BE49-F238E27FC236}">
-                <a16:creationId xmlns:a16="http://schemas.microsoft.com/office/drawing/2014/main" id="{095BBFAA-4D24-485F-A321-F4CD817081A4}"/>
+                <a16:creationId xmlns:a16="http://schemas.microsoft.com/office/drawing/2014/main" id="{CD5ACF9C-32B1-4713-88DA-FDAE9667FC91}"/>
               </a:ext>
             </a:extLst>
           </p:cNvPr>
@@ -10729,7 +10729,7 @@
     </p:spTree>
     <p:extLst>
       <p:ext uri="{BB962C8B-B14F-4D97-AF65-F5344CB8AC3E}">
-        <p14:creationId xmlns:p14="http://schemas.microsoft.com/office/powerpoint/2010/main" val="2019158915"/>
+        <p14:creationId xmlns:p14="http://schemas.microsoft.com/office/powerpoint/2010/main" val="34468637"/>
       </p:ext>
     </p:extLst>
   </p:cSld>
@@ -10760,7 +10760,7 @@
           <p:cNvPr id="30" name="">
             <a:extLst xmlns:a="http://schemas.openxmlformats.org/drawingml/2006/main">
               <a:ext uri="{FF2B5EF4-FFF2-40B4-BE49-F238E27FC236}">
-                <a16:creationId xmlns:a16="http://schemas.microsoft.com/office/drawing/2014/main" id="{66891B42-12F1-48DB-8764-8740054E6471}"/>
+                <a16:creationId xmlns:a16="http://schemas.microsoft.com/office/drawing/2014/main" id="{99FF510B-B2A1-4021-9AC7-513AA93504AA}"/>
               </a:ext>
             </a:extLst>
           </p:cNvPr>
@@ -10790,7 +10790,7 @@
           <p:cNvPr id="2" name="">
             <a:extLst xmlns:a="http://schemas.openxmlformats.org/drawingml/2006/main">
               <a:ext uri="{FF2B5EF4-FFF2-40B4-BE49-F238E27FC236}">
-                <a16:creationId xmlns:a16="http://schemas.microsoft.com/office/drawing/2014/main" id="{78ECB73E-BF0A-4637-9D8F-FDBDC20F3507}"/>
+                <a16:creationId xmlns:a16="http://schemas.microsoft.com/office/drawing/2014/main" id="{4C645120-8FD0-408B-B071-C48AE6118A91}"/>
               </a:ext>
             </a:extLst>
           </p:cNvPr>
@@ -10847,7 +10847,7 @@
           <p:cNvPr id="3" name="">
             <a:extLst xmlns:a="http://schemas.openxmlformats.org/drawingml/2006/main">
               <a:ext uri="{FF2B5EF4-FFF2-40B4-BE49-F238E27FC236}">
-                <a16:creationId xmlns:a16="http://schemas.microsoft.com/office/drawing/2014/main" id="{B0A9F970-5490-4ECC-8098-86CF96300582}"/>
+                <a16:creationId xmlns:a16="http://schemas.microsoft.com/office/drawing/2014/main" id="{4E33F3A5-9737-4827-8F9E-F8ADB0DA6FDF}"/>
               </a:ext>
             </a:extLst>
           </p:cNvPr>
@@ -10877,7 +10877,7 @@
           <p:cNvPr id="4" name="">
             <a:extLst xmlns:a="http://schemas.openxmlformats.org/drawingml/2006/main">
               <a:ext uri="{FF2B5EF4-FFF2-40B4-BE49-F238E27FC236}">
-                <a16:creationId xmlns:a16="http://schemas.microsoft.com/office/drawing/2014/main" id="{617BC351-568E-4BB6-9B9F-169F439C9B78}"/>
+                <a16:creationId xmlns:a16="http://schemas.microsoft.com/office/drawing/2014/main" id="{B76D0A75-B9CC-4EBF-9ACF-982D0631F3B4}"/>
               </a:ext>
             </a:extLst>
           </p:cNvPr>
@@ -10934,7 +10934,7 @@
           <p:cNvPr id="5" name="">
             <a:extLst xmlns:a="http://schemas.openxmlformats.org/drawingml/2006/main">
               <a:ext uri="{FF2B5EF4-FFF2-40B4-BE49-F238E27FC236}">
-                <a16:creationId xmlns:a16="http://schemas.microsoft.com/office/drawing/2014/main" id="{21CB5D8A-8EE4-4657-8EC9-1CAF499AA0EF}"/>
+                <a16:creationId xmlns:a16="http://schemas.microsoft.com/office/drawing/2014/main" id="{117341A1-05D5-4DB7-A8E1-3180F7A82B1D}"/>
               </a:ext>
             </a:extLst>
           </p:cNvPr>
@@ -10966,7 +10966,7 @@
           <p:cNvPr id="6" name="">
             <a:extLst xmlns:a="http://schemas.openxmlformats.org/drawingml/2006/main">
               <a:ext uri="{FF2B5EF4-FFF2-40B4-BE49-F238E27FC236}">
-                <a16:creationId xmlns:a16="http://schemas.microsoft.com/office/drawing/2014/main" id="{93223D4D-474C-4A68-A647-E0D05512F939}"/>
+                <a16:creationId xmlns:a16="http://schemas.microsoft.com/office/drawing/2014/main" id="{27359876-6EC3-4AA3-8A03-D3EF3B69C7FC}"/>
               </a:ext>
             </a:extLst>
           </p:cNvPr>
@@ -11023,7 +11023,7 @@
           <p:cNvPr id="7" name="">
             <a:extLst xmlns:a="http://schemas.openxmlformats.org/drawingml/2006/main">
               <a:ext uri="{FF2B5EF4-FFF2-40B4-BE49-F238E27FC236}">
-                <a16:creationId xmlns:a16="http://schemas.microsoft.com/office/drawing/2014/main" id="{062C5E53-32E8-40D8-A854-5C22DF59AC3E}"/>
+                <a16:creationId xmlns:a16="http://schemas.microsoft.com/office/drawing/2014/main" id="{FF14AD7A-7630-47D7-AF26-61542E74A16B}"/>
               </a:ext>
             </a:extLst>
           </p:cNvPr>
@@ -11080,7 +11080,7 @@
           <p:cNvPr id="8" name="">
             <a:extLst xmlns:a="http://schemas.openxmlformats.org/drawingml/2006/main">
               <a:ext uri="{FF2B5EF4-FFF2-40B4-BE49-F238E27FC236}">
-                <a16:creationId xmlns:a16="http://schemas.microsoft.com/office/drawing/2014/main" id="{F32A100D-2BF1-4654-8CF6-76C0C442E53F}"/>
+                <a16:creationId xmlns:a16="http://schemas.microsoft.com/office/drawing/2014/main" id="{127DF052-A931-4026-857C-78D14D83EBF8}"/>
               </a:ext>
             </a:extLst>
           </p:cNvPr>
@@ -11160,7 +11160,7 @@
           <p:cNvPr id="9" name="">
             <a:extLst xmlns:a="http://schemas.openxmlformats.org/drawingml/2006/main">
               <a:ext uri="{FF2B5EF4-FFF2-40B4-BE49-F238E27FC236}">
-                <a16:creationId xmlns:a16="http://schemas.microsoft.com/office/drawing/2014/main" id="{F15A5305-B942-4865-9F26-CA400E92E0EB}"/>
+                <a16:creationId xmlns:a16="http://schemas.microsoft.com/office/drawing/2014/main" id="{C39548F3-FDA0-4285-905B-707FEBE57A6E}"/>
               </a:ext>
             </a:extLst>
           </p:cNvPr>
@@ -11217,7 +11217,7 @@
           <p:cNvPr id="10" name="">
             <a:extLst xmlns:a="http://schemas.openxmlformats.org/drawingml/2006/main">
               <a:ext uri="{FF2B5EF4-FFF2-40B4-BE49-F238E27FC236}">
-                <a16:creationId xmlns:a16="http://schemas.microsoft.com/office/drawing/2014/main" id="{17C8FC9A-BFC7-4562-BB82-327EDF1A98FE}"/>
+                <a16:creationId xmlns:a16="http://schemas.microsoft.com/office/drawing/2014/main" id="{2920FC98-1492-4344-918D-B271A32B3C3D}"/>
               </a:ext>
             </a:extLst>
           </p:cNvPr>
@@ -11249,7 +11249,7 @@
           <p:cNvPr id="11" name="">
             <a:extLst xmlns:a="http://schemas.openxmlformats.org/drawingml/2006/main">
               <a:ext uri="{FF2B5EF4-FFF2-40B4-BE49-F238E27FC236}">
-                <a16:creationId xmlns:a16="http://schemas.microsoft.com/office/drawing/2014/main" id="{D2540578-3DBB-44AF-8E5D-1BA1DB5F35C8}"/>
+                <a16:creationId xmlns:a16="http://schemas.microsoft.com/office/drawing/2014/main" id="{83E23E97-6306-46EA-AB75-358DAFC79DBE}"/>
               </a:ext>
             </a:extLst>
           </p:cNvPr>
@@ -11306,7 +11306,7 @@
           <p:cNvPr id="12" name="">
             <a:extLst xmlns:a="http://schemas.openxmlformats.org/drawingml/2006/main">
               <a:ext uri="{FF2B5EF4-FFF2-40B4-BE49-F238E27FC236}">
-                <a16:creationId xmlns:a16="http://schemas.microsoft.com/office/drawing/2014/main" id="{1B08F686-3556-4318-81F0-8C59946FDB6E}"/>
+                <a16:creationId xmlns:a16="http://schemas.microsoft.com/office/drawing/2014/main" id="{6F921E00-71FF-48F5-9124-BBAB71674142}"/>
               </a:ext>
             </a:extLst>
           </p:cNvPr>
@@ -11363,7 +11363,7 @@
           <p:cNvPr id="13" name="">
             <a:extLst xmlns:a="http://schemas.openxmlformats.org/drawingml/2006/main">
               <a:ext uri="{FF2B5EF4-FFF2-40B4-BE49-F238E27FC236}">
-                <a16:creationId xmlns:a16="http://schemas.microsoft.com/office/drawing/2014/main" id="{49380B68-480F-4D14-8321-27546C3C3A90}"/>
+                <a16:creationId xmlns:a16="http://schemas.microsoft.com/office/drawing/2014/main" id="{82D2C569-3A96-43B8-83F4-A580D4832E16}"/>
               </a:ext>
             </a:extLst>
           </p:cNvPr>
@@ -11443,7 +11443,7 @@
           <p:cNvPr id="14" name="">
             <a:extLst xmlns:a="http://schemas.openxmlformats.org/drawingml/2006/main">
               <a:ext uri="{FF2B5EF4-FFF2-40B4-BE49-F238E27FC236}">
-                <a16:creationId xmlns:a16="http://schemas.microsoft.com/office/drawing/2014/main" id="{2C1A5386-2474-46B1-8717-842458C4B96C}"/>
+                <a16:creationId xmlns:a16="http://schemas.microsoft.com/office/drawing/2014/main" id="{FF404777-D485-4A86-8F44-4B1B571194A8}"/>
               </a:ext>
             </a:extLst>
           </p:cNvPr>
@@ -11500,7 +11500,7 @@
           <p:cNvPr id="15" name="">
             <a:extLst xmlns:a="http://schemas.openxmlformats.org/drawingml/2006/main">
               <a:ext uri="{FF2B5EF4-FFF2-40B4-BE49-F238E27FC236}">
-                <a16:creationId xmlns:a16="http://schemas.microsoft.com/office/drawing/2014/main" id="{0512B442-9EA7-4786-9A49-349A14F291D9}"/>
+                <a16:creationId xmlns:a16="http://schemas.microsoft.com/office/drawing/2014/main" id="{F49A6130-9D79-4A33-9A87-F6CD71103C80}"/>
               </a:ext>
             </a:extLst>
           </p:cNvPr>
@@ -11532,7 +11532,7 @@
           <p:cNvPr id="16" name="">
             <a:extLst xmlns:a="http://schemas.openxmlformats.org/drawingml/2006/main">
               <a:ext uri="{FF2B5EF4-FFF2-40B4-BE49-F238E27FC236}">
-                <a16:creationId xmlns:a16="http://schemas.microsoft.com/office/drawing/2014/main" id="{E486A962-AC9F-4711-BDEB-3C1AA1CF4E7B}"/>
+                <a16:creationId xmlns:a16="http://schemas.microsoft.com/office/drawing/2014/main" id="{E3E2B4F8-6CAD-41FA-9796-6CC510768C12}"/>
               </a:ext>
             </a:extLst>
           </p:cNvPr>
@@ -11589,7 +11589,7 @@
           <p:cNvPr id="17" name="">
             <a:extLst xmlns:a="http://schemas.openxmlformats.org/drawingml/2006/main">
               <a:ext uri="{FF2B5EF4-FFF2-40B4-BE49-F238E27FC236}">
-                <a16:creationId xmlns:a16="http://schemas.microsoft.com/office/drawing/2014/main" id="{B359265B-DDF2-44FC-80BF-F3442C00101F}"/>
+                <a16:creationId xmlns:a16="http://schemas.microsoft.com/office/drawing/2014/main" id="{1C2385DD-5380-480A-BF9A-EB3F616060A8}"/>
               </a:ext>
             </a:extLst>
           </p:cNvPr>
@@ -11646,7 +11646,7 @@
           <p:cNvPr id="18" name="">
             <a:extLst xmlns:a="http://schemas.openxmlformats.org/drawingml/2006/main">
               <a:ext uri="{FF2B5EF4-FFF2-40B4-BE49-F238E27FC236}">
-                <a16:creationId xmlns:a16="http://schemas.microsoft.com/office/drawing/2014/main" id="{14BAEA36-5D9B-4600-B134-ABEE2841A6AC}"/>
+                <a16:creationId xmlns:a16="http://schemas.microsoft.com/office/drawing/2014/main" id="{F4E52150-334F-43D9-8462-61953A812FF6}"/>
               </a:ext>
             </a:extLst>
           </p:cNvPr>
@@ -11726,7 +11726,7 @@
           <p:cNvPr id="19" name="">
             <a:extLst xmlns:a="http://schemas.openxmlformats.org/drawingml/2006/main">
               <a:ext uri="{FF2B5EF4-FFF2-40B4-BE49-F238E27FC236}">
-                <a16:creationId xmlns:a16="http://schemas.microsoft.com/office/drawing/2014/main" id="{83374031-8083-4F14-82DC-BB4FF4903F2F}"/>
+                <a16:creationId xmlns:a16="http://schemas.microsoft.com/office/drawing/2014/main" id="{A98B50D3-F651-40A1-B899-62E2CAB637EE}"/>
               </a:ext>
             </a:extLst>
           </p:cNvPr>
@@ -11783,7 +11783,7 @@
           <p:cNvPr id="20" name="">
             <a:extLst xmlns:a="http://schemas.openxmlformats.org/drawingml/2006/main">
               <a:ext uri="{FF2B5EF4-FFF2-40B4-BE49-F238E27FC236}">
-                <a16:creationId xmlns:a16="http://schemas.microsoft.com/office/drawing/2014/main" id="{FE965F7D-B000-4196-AED1-3FC2D8520262}"/>
+                <a16:creationId xmlns:a16="http://schemas.microsoft.com/office/drawing/2014/main" id="{7ECBF9F1-88F6-407C-94BF-288D0610E3BA}"/>
               </a:ext>
             </a:extLst>
           </p:cNvPr>
@@ -11815,7 +11815,7 @@
           <p:cNvPr id="21" name="">
             <a:extLst xmlns:a="http://schemas.openxmlformats.org/drawingml/2006/main">
               <a:ext uri="{FF2B5EF4-FFF2-40B4-BE49-F238E27FC236}">
-                <a16:creationId xmlns:a16="http://schemas.microsoft.com/office/drawing/2014/main" id="{9D73BFFC-DBB4-4B8A-83B4-787600E8D1DC}"/>
+                <a16:creationId xmlns:a16="http://schemas.microsoft.com/office/drawing/2014/main" id="{B05F8507-5253-479B-B516-19667BC44BCD}"/>
               </a:ext>
             </a:extLst>
           </p:cNvPr>
@@ -11872,7 +11872,7 @@
           <p:cNvPr id="22" name="">
             <a:extLst xmlns:a="http://schemas.openxmlformats.org/drawingml/2006/main">
               <a:ext uri="{FF2B5EF4-FFF2-40B4-BE49-F238E27FC236}">
-                <a16:creationId xmlns:a16="http://schemas.microsoft.com/office/drawing/2014/main" id="{D0AA117B-5338-4A98-A184-4A9A7040A398}"/>
+                <a16:creationId xmlns:a16="http://schemas.microsoft.com/office/drawing/2014/main" id="{A79D834F-4534-4E74-BD09-4C2AE90AD24A}"/>
               </a:ext>
             </a:extLst>
           </p:cNvPr>
@@ -11929,7 +11929,7 @@
           <p:cNvPr id="23" name="">
             <a:extLst xmlns:a="http://schemas.openxmlformats.org/drawingml/2006/main">
               <a:ext uri="{FF2B5EF4-FFF2-40B4-BE49-F238E27FC236}">
-                <a16:creationId xmlns:a16="http://schemas.microsoft.com/office/drawing/2014/main" id="{1604AF88-D7A5-49E2-B899-E4027606F773}"/>
+                <a16:creationId xmlns:a16="http://schemas.microsoft.com/office/drawing/2014/main" id="{2484CCA0-6445-4DCE-96AC-9C189D7A20D2}"/>
               </a:ext>
             </a:extLst>
           </p:cNvPr>
@@ -12009,7 +12009,7 @@
           <p:cNvPr id="24" name="">
             <a:extLst xmlns:a="http://schemas.openxmlformats.org/drawingml/2006/main">
               <a:ext uri="{FF2B5EF4-FFF2-40B4-BE49-F238E27FC236}">
-                <a16:creationId xmlns:a16="http://schemas.microsoft.com/office/drawing/2014/main" id="{C1863AF7-882D-416E-B844-6819DE958DAF}"/>
+                <a16:creationId xmlns:a16="http://schemas.microsoft.com/office/drawing/2014/main" id="{27B0BDFF-9148-4D6D-86E2-728656E69B4C}"/>
               </a:ext>
             </a:extLst>
           </p:cNvPr>
@@ -12066,7 +12066,7 @@
           <p:cNvPr id="25" name="">
             <a:extLst xmlns:a="http://schemas.openxmlformats.org/drawingml/2006/main">
               <a:ext uri="{FF2B5EF4-FFF2-40B4-BE49-F238E27FC236}">
-                <a16:creationId xmlns:a16="http://schemas.microsoft.com/office/drawing/2014/main" id="{C7D241A1-AAF9-453D-9149-A18A9C286B31}"/>
+                <a16:creationId xmlns:a16="http://schemas.microsoft.com/office/drawing/2014/main" id="{4160FF38-C14D-4CDA-A48B-343C485E9985}"/>
               </a:ext>
             </a:extLst>
           </p:cNvPr>
@@ -12096,7 +12096,7 @@
           <p:cNvPr id="26" name="">
             <a:extLst xmlns:a="http://schemas.openxmlformats.org/drawingml/2006/main">
               <a:ext uri="{FF2B5EF4-FFF2-40B4-BE49-F238E27FC236}">
-                <a16:creationId xmlns:a16="http://schemas.microsoft.com/office/drawing/2014/main" id="{2FB4F76B-2096-4B37-9FB7-AC7801DE2CB0}"/>
+                <a16:creationId xmlns:a16="http://schemas.microsoft.com/office/drawing/2014/main" id="{D58270F0-4D24-4E9A-9C03-57C3C6CFED0E}"/>
               </a:ext>
             </a:extLst>
           </p:cNvPr>
@@ -12153,7 +12153,7 @@
           <p:cNvPr id="27" name="">
             <a:extLst xmlns:a="http://schemas.openxmlformats.org/drawingml/2006/main">
               <a:ext uri="{FF2B5EF4-FFF2-40B4-BE49-F238E27FC236}">
-                <a16:creationId xmlns:a16="http://schemas.microsoft.com/office/drawing/2014/main" id="{7B16C8DF-13D0-4619-9D58-E9F7A3D2D22F}"/>
+                <a16:creationId xmlns:a16="http://schemas.microsoft.com/office/drawing/2014/main" id="{2251D62C-E4C4-441B-8AB9-2DE25BD68C1E}"/>
               </a:ext>
             </a:extLst>
           </p:cNvPr>
@@ -12210,7 +12210,7 @@
           <p:cNvPr id="28" name="">
             <a:extLst xmlns:a="http://schemas.openxmlformats.org/drawingml/2006/main">
               <a:ext uri="{FF2B5EF4-FFF2-40B4-BE49-F238E27FC236}">
-                <a16:creationId xmlns:a16="http://schemas.microsoft.com/office/drawing/2014/main" id="{E2941882-ECB4-49A6-B45E-5CD0A0409804}"/>
+                <a16:creationId xmlns:a16="http://schemas.microsoft.com/office/drawing/2014/main" id="{370E71C9-958C-459B-BD0C-4D0B2E16CBA7}"/>
               </a:ext>
             </a:extLst>
           </p:cNvPr>
@@ -12290,7 +12290,7 @@
           <p:cNvPr id="29" name="">
             <a:extLst xmlns:a="http://schemas.openxmlformats.org/drawingml/2006/main">
               <a:ext uri="{FF2B5EF4-FFF2-40B4-BE49-F238E27FC236}">
-                <a16:creationId xmlns:a16="http://schemas.microsoft.com/office/drawing/2014/main" id="{90DAF911-51FA-441B-BFBD-C4C639330040}"/>
+                <a16:creationId xmlns:a16="http://schemas.microsoft.com/office/drawing/2014/main" id="{BD02E04A-5132-41BF-811F-A03A46126FF1}"/>
               </a:ext>
             </a:extLst>
           </p:cNvPr>
@@ -12345,7 +12345,7 @@
     </p:spTree>
     <p:extLst>
       <p:ext uri="{BB962C8B-B14F-4D97-AF65-F5344CB8AC3E}">
-        <p14:creationId xmlns:p14="http://schemas.microsoft.com/office/powerpoint/2010/main" val="971713325"/>
+        <p14:creationId xmlns:p14="http://schemas.microsoft.com/office/powerpoint/2010/main" val="914399933"/>
       </p:ext>
     </p:extLst>
   </p:cSld>
@@ -12376,7 +12376,7 @@
           <p:cNvPr id="12" name="">
             <a:extLst xmlns:a="http://schemas.openxmlformats.org/drawingml/2006/main">
               <a:ext uri="{FF2B5EF4-FFF2-40B4-BE49-F238E27FC236}">
-                <a16:creationId xmlns:a16="http://schemas.microsoft.com/office/drawing/2014/main" id="{43E4F63B-DB51-4CC3-93E4-12BA1537F8B8}"/>
+                <a16:creationId xmlns:a16="http://schemas.microsoft.com/office/drawing/2014/main" id="{912A9869-E2F6-495F-B77A-F59B0439B2A2}"/>
               </a:ext>
             </a:extLst>
           </p:cNvPr>
@@ -12406,7 +12406,7 @@
           <p:cNvPr id="2" name="">
             <a:extLst xmlns:a="http://schemas.openxmlformats.org/drawingml/2006/main">
               <a:ext uri="{FF2B5EF4-FFF2-40B4-BE49-F238E27FC236}">
-                <a16:creationId xmlns:a16="http://schemas.microsoft.com/office/drawing/2014/main" id="{190B5F92-1593-4348-BCD7-715CAC727CF5}"/>
+                <a16:creationId xmlns:a16="http://schemas.microsoft.com/office/drawing/2014/main" id="{7684E40F-70A1-451A-98D0-0C9BFFC6BEDB}"/>
               </a:ext>
             </a:extLst>
           </p:cNvPr>
@@ -12463,7 +12463,7 @@
           <p:cNvPr id="3" name="">
             <a:extLst xmlns:a="http://schemas.openxmlformats.org/drawingml/2006/main">
               <a:ext uri="{FF2B5EF4-FFF2-40B4-BE49-F238E27FC236}">
-                <a16:creationId xmlns:a16="http://schemas.microsoft.com/office/drawing/2014/main" id="{ABA9FC49-0BB4-4433-8EA6-DF84109B0863}"/>
+                <a16:creationId xmlns:a16="http://schemas.microsoft.com/office/drawing/2014/main" id="{B9BA72C5-0550-48DB-A47A-1A877ACA8AD7}"/>
               </a:ext>
             </a:extLst>
           </p:cNvPr>
@@ -12493,7 +12493,7 @@
           <p:cNvPr id="4" name="">
             <a:extLst xmlns:a="http://schemas.openxmlformats.org/drawingml/2006/main">
               <a:ext uri="{FF2B5EF4-FFF2-40B4-BE49-F238E27FC236}">
-                <a16:creationId xmlns:a16="http://schemas.microsoft.com/office/drawing/2014/main" id="{8E098CEE-3FE0-4FF0-B063-72C5BB3D586E}"/>
+                <a16:creationId xmlns:a16="http://schemas.microsoft.com/office/drawing/2014/main" id="{145096C8-4725-428B-9C93-49C2362271CE}"/>
               </a:ext>
             </a:extLst>
           </p:cNvPr>
@@ -12550,7 +12550,7 @@
           <p:cNvPr id="5" name="">
             <a:extLst xmlns:a="http://schemas.openxmlformats.org/drawingml/2006/main">
               <a:ext uri="{FF2B5EF4-FFF2-40B4-BE49-F238E27FC236}">
-                <a16:creationId xmlns:a16="http://schemas.microsoft.com/office/drawing/2014/main" id="{9206223B-66D4-4258-9364-F25F76FBCBD6}"/>
+                <a16:creationId xmlns:a16="http://schemas.microsoft.com/office/drawing/2014/main" id="{86F1F572-754E-4453-808A-E2DE9ABDA5C4}"/>
               </a:ext>
             </a:extLst>
           </p:cNvPr>
@@ -12582,7 +12582,7 @@
           <p:cNvPr id="6" name="">
             <a:extLst xmlns:a="http://schemas.openxmlformats.org/drawingml/2006/main">
               <a:ext uri="{FF2B5EF4-FFF2-40B4-BE49-F238E27FC236}">
-                <a16:creationId xmlns:a16="http://schemas.microsoft.com/office/drawing/2014/main" id="{FB95A79A-2F30-4901-A40E-B90E37A9FB9B}"/>
+                <a16:creationId xmlns:a16="http://schemas.microsoft.com/office/drawing/2014/main" id="{552B5AE9-BC31-4E43-9F4D-8188936F0A11}"/>
               </a:ext>
             </a:extLst>
           </p:cNvPr>
@@ -12618,7 +12618,7 @@
           <p:nvPr/>
         </p:nvPicPr>
         <p:blipFill>
-          <a:blip xmlns:r="http://schemas.openxmlformats.org/officeDocument/2006/relationships" xmlns:a="http://schemas.openxmlformats.org/drawingml/2006/main" r:embed="R95ea58d4dc5847f8"/>
+          <a:blip xmlns:r="http://schemas.openxmlformats.org/officeDocument/2006/relationships" xmlns:a="http://schemas.openxmlformats.org/drawingml/2006/main" r:embed="Rd7572a77853d4af6"/>
           <a:stretch xmlns:a="http://schemas.openxmlformats.org/drawingml/2006/main"/>
         </p:blipFill>
         <p:spPr>
@@ -12640,7 +12640,7 @@
           <p:nvPr/>
         </p:nvPicPr>
         <p:blipFill>
-          <a:blip xmlns:r="http://schemas.openxmlformats.org/officeDocument/2006/relationships" xmlns:a="http://schemas.openxmlformats.org/drawingml/2006/main" r:embed="Rfe3fcd4557bc45ff"/>
+          <a:blip xmlns:r="http://schemas.openxmlformats.org/officeDocument/2006/relationships" xmlns:a="http://schemas.openxmlformats.org/drawingml/2006/main" r:embed="Rb301ca6f3ce846be"/>
           <a:stretch xmlns:a="http://schemas.openxmlformats.org/drawingml/2006/main"/>
         </p:blipFill>
         <p:spPr>
@@ -12658,7 +12658,7 @@
           <p:cNvPr id="9" name="">
             <a:extLst xmlns:a="http://schemas.openxmlformats.org/drawingml/2006/main">
               <a:ext uri="{FF2B5EF4-FFF2-40B4-BE49-F238E27FC236}">
-                <a16:creationId xmlns:a16="http://schemas.microsoft.com/office/drawing/2014/main" id="{333696A9-FDE6-4E6F-A924-EE4378D2D937}"/>
+                <a16:creationId xmlns:a16="http://schemas.microsoft.com/office/drawing/2014/main" id="{82E090F0-5000-4C41-815F-2001873CA86D}"/>
               </a:ext>
             </a:extLst>
           </p:cNvPr>
@@ -12715,7 +12715,7 @@
           <p:cNvPr id="10" name="">
             <a:extLst xmlns:a="http://schemas.openxmlformats.org/drawingml/2006/main">
               <a:ext uri="{FF2B5EF4-FFF2-40B4-BE49-F238E27FC236}">
-                <a16:creationId xmlns:a16="http://schemas.microsoft.com/office/drawing/2014/main" id="{451BFDF0-8FCE-44FF-B817-D9D2F5A071CD}"/>
+                <a16:creationId xmlns:a16="http://schemas.microsoft.com/office/drawing/2014/main" id="{D21D9592-1065-4BB6-B587-02ADE45850C0}"/>
               </a:ext>
             </a:extLst>
           </p:cNvPr>
@@ -12772,7 +12772,7 @@
           <p:cNvPr id="11" name="">
             <a:extLst xmlns:a="http://schemas.openxmlformats.org/drawingml/2006/main">
               <a:ext uri="{FF2B5EF4-FFF2-40B4-BE49-F238E27FC236}">
-                <a16:creationId xmlns:a16="http://schemas.microsoft.com/office/drawing/2014/main" id="{FAEBFA0E-6CD3-4428-A053-EE11944CEA29}"/>
+                <a16:creationId xmlns:a16="http://schemas.microsoft.com/office/drawing/2014/main" id="{4BB8E6B2-579D-4A63-8838-9256D09D3F3B}"/>
               </a:ext>
             </a:extLst>
           </p:cNvPr>
@@ -12827,7 +12827,7 @@
     </p:spTree>
     <p:extLst>
       <p:ext uri="{BB962C8B-B14F-4D97-AF65-F5344CB8AC3E}">
-        <p14:creationId xmlns:p14="http://schemas.microsoft.com/office/powerpoint/2010/main" val="45472646"/>
+        <p14:creationId xmlns:p14="http://schemas.microsoft.com/office/powerpoint/2010/main" val="610166305"/>
       </p:ext>
     </p:extLst>
   </p:cSld>
@@ -12858,7 +12858,7 @@
           <p:cNvPr id="12" name="">
             <a:extLst xmlns:a="http://schemas.openxmlformats.org/drawingml/2006/main">
               <a:ext uri="{FF2B5EF4-FFF2-40B4-BE49-F238E27FC236}">
-                <a16:creationId xmlns:a16="http://schemas.microsoft.com/office/drawing/2014/main" id="{03B6999E-DA3E-491F-9521-6B25ED8D4970}"/>
+                <a16:creationId xmlns:a16="http://schemas.microsoft.com/office/drawing/2014/main" id="{FC5DE705-BEF7-440A-A3D2-804AF30918FF}"/>
               </a:ext>
             </a:extLst>
           </p:cNvPr>
@@ -12888,7 +12888,7 @@
           <p:cNvPr id="2" name="">
             <a:extLst xmlns:a="http://schemas.openxmlformats.org/drawingml/2006/main">
               <a:ext uri="{FF2B5EF4-FFF2-40B4-BE49-F238E27FC236}">
-                <a16:creationId xmlns:a16="http://schemas.microsoft.com/office/drawing/2014/main" id="{C97E380B-246E-47BA-81B5-34B4F176F593}"/>
+                <a16:creationId xmlns:a16="http://schemas.microsoft.com/office/drawing/2014/main" id="{DCA3F050-36B6-422D-BC90-820EB93EED9E}"/>
               </a:ext>
             </a:extLst>
           </p:cNvPr>
@@ -12945,7 +12945,7 @@
           <p:cNvPr id="3" name="">
             <a:extLst xmlns:a="http://schemas.openxmlformats.org/drawingml/2006/main">
               <a:ext uri="{FF2B5EF4-FFF2-40B4-BE49-F238E27FC236}">
-                <a16:creationId xmlns:a16="http://schemas.microsoft.com/office/drawing/2014/main" id="{AB679FD2-5313-4263-A106-82C68A4F9109}"/>
+                <a16:creationId xmlns:a16="http://schemas.microsoft.com/office/drawing/2014/main" id="{84D67667-BC5E-4FCF-A8D8-A513E80A8280}"/>
               </a:ext>
             </a:extLst>
           </p:cNvPr>
@@ -12975,7 +12975,7 @@
           <p:cNvPr id="4" name="">
             <a:extLst xmlns:a="http://schemas.openxmlformats.org/drawingml/2006/main">
               <a:ext uri="{FF2B5EF4-FFF2-40B4-BE49-F238E27FC236}">
-                <a16:creationId xmlns:a16="http://schemas.microsoft.com/office/drawing/2014/main" id="{FFE17D1A-0134-4203-BA21-ADBFA40FCFF3}"/>
+                <a16:creationId xmlns:a16="http://schemas.microsoft.com/office/drawing/2014/main" id="{F7D469C2-F1C8-485C-8B3A-CC1B7D61A7EF}"/>
               </a:ext>
             </a:extLst>
           </p:cNvPr>
@@ -13032,7 +13032,7 @@
           <p:cNvPr id="5" name="">
             <a:extLst xmlns:a="http://schemas.openxmlformats.org/drawingml/2006/main">
               <a:ext uri="{FF2B5EF4-FFF2-40B4-BE49-F238E27FC236}">
-                <a16:creationId xmlns:a16="http://schemas.microsoft.com/office/drawing/2014/main" id="{C9E85DB1-785C-4761-85D0-98F459776989}"/>
+                <a16:creationId xmlns:a16="http://schemas.microsoft.com/office/drawing/2014/main" id="{AC8A612B-61FC-4D0A-B6EA-62D2B1C77631}"/>
               </a:ext>
             </a:extLst>
           </p:cNvPr>
@@ -13064,7 +13064,7 @@
           <p:cNvPr id="6" name="">
             <a:extLst xmlns:a="http://schemas.openxmlformats.org/drawingml/2006/main">
               <a:ext uri="{FF2B5EF4-FFF2-40B4-BE49-F238E27FC236}">
-                <a16:creationId xmlns:a16="http://schemas.microsoft.com/office/drawing/2014/main" id="{739953FA-3722-4874-8EDF-6AA2CCA118D1}"/>
+                <a16:creationId xmlns:a16="http://schemas.microsoft.com/office/drawing/2014/main" id="{7E9A293E-CE51-42BB-BB6A-212B3CF1F8A0}"/>
               </a:ext>
             </a:extLst>
           </p:cNvPr>
@@ -13100,7 +13100,7 @@
           <p:nvPr/>
         </p:nvPicPr>
         <p:blipFill>
-          <a:blip xmlns:r="http://schemas.openxmlformats.org/officeDocument/2006/relationships" xmlns:a="http://schemas.openxmlformats.org/drawingml/2006/main" r:embed="R6f8ec24e12bd4157"/>
+          <a:blip xmlns:r="http://schemas.openxmlformats.org/officeDocument/2006/relationships" xmlns:a="http://schemas.openxmlformats.org/drawingml/2006/main" r:embed="Rc43d8753dbc34187"/>
           <a:stretch xmlns:a="http://schemas.openxmlformats.org/drawingml/2006/main"/>
         </p:blipFill>
         <p:spPr>
@@ -13122,7 +13122,7 @@
           <p:nvPr/>
         </p:nvPicPr>
         <p:blipFill>
-          <a:blip xmlns:r="http://schemas.openxmlformats.org/officeDocument/2006/relationships" xmlns:a="http://schemas.openxmlformats.org/drawingml/2006/main" r:embed="Rc23c450f4c3f4615"/>
+          <a:blip xmlns:r="http://schemas.openxmlformats.org/officeDocument/2006/relationships" xmlns:a="http://schemas.openxmlformats.org/drawingml/2006/main" r:embed="R43a3e24caa9a48bc"/>
           <a:stretch xmlns:a="http://schemas.openxmlformats.org/drawingml/2006/main"/>
         </p:blipFill>
         <p:spPr>
@@ -13140,7 +13140,7 @@
           <p:cNvPr id="9" name="">
             <a:extLst xmlns:a="http://schemas.openxmlformats.org/drawingml/2006/main">
               <a:ext uri="{FF2B5EF4-FFF2-40B4-BE49-F238E27FC236}">
-                <a16:creationId xmlns:a16="http://schemas.microsoft.com/office/drawing/2014/main" id="{96BCF356-D273-412A-8BBD-07C9B59D0594}"/>
+                <a16:creationId xmlns:a16="http://schemas.microsoft.com/office/drawing/2014/main" id="{E2A2751F-0259-4CA6-A742-D859EF73D11D}"/>
               </a:ext>
             </a:extLst>
           </p:cNvPr>
@@ -13197,7 +13197,7 @@
           <p:cNvPr id="10" name="">
             <a:extLst xmlns:a="http://schemas.openxmlformats.org/drawingml/2006/main">
               <a:ext uri="{FF2B5EF4-FFF2-40B4-BE49-F238E27FC236}">
-                <a16:creationId xmlns:a16="http://schemas.microsoft.com/office/drawing/2014/main" id="{6023DDA6-D760-4B66-B62F-B5464092CF94}"/>
+                <a16:creationId xmlns:a16="http://schemas.microsoft.com/office/drawing/2014/main" id="{61599F00-89DB-46D8-A077-ACD1FEA16A91}"/>
               </a:ext>
             </a:extLst>
           </p:cNvPr>
@@ -13254,7 +13254,7 @@
           <p:cNvPr id="11" name="">
             <a:extLst xmlns:a="http://schemas.openxmlformats.org/drawingml/2006/main">
               <a:ext uri="{FF2B5EF4-FFF2-40B4-BE49-F238E27FC236}">
-                <a16:creationId xmlns:a16="http://schemas.microsoft.com/office/drawing/2014/main" id="{EF1CC71A-C229-41DB-BBAF-1E38061ABAE3}"/>
+                <a16:creationId xmlns:a16="http://schemas.microsoft.com/office/drawing/2014/main" id="{9D43D7C2-AB57-4B56-9717-043B30BAED47}"/>
               </a:ext>
             </a:extLst>
           </p:cNvPr>
@@ -13309,7 +13309,7 @@
     </p:spTree>
     <p:extLst>
       <p:ext uri="{BB962C8B-B14F-4D97-AF65-F5344CB8AC3E}">
-        <p14:creationId xmlns:p14="http://schemas.microsoft.com/office/powerpoint/2010/main" val="1740811960"/>
+        <p14:creationId xmlns:p14="http://schemas.microsoft.com/office/powerpoint/2010/main" val="774045049"/>
       </p:ext>
     </p:extLst>
   </p:cSld>
@@ -13340,7 +13340,7 @@
           <p:cNvPr id="12" name="">
             <a:extLst xmlns:a="http://schemas.openxmlformats.org/drawingml/2006/main">
               <a:ext uri="{FF2B5EF4-FFF2-40B4-BE49-F238E27FC236}">
-                <a16:creationId xmlns:a16="http://schemas.microsoft.com/office/drawing/2014/main" id="{BC114E8C-8101-44ED-A64D-B8481ED4C48A}"/>
+                <a16:creationId xmlns:a16="http://schemas.microsoft.com/office/drawing/2014/main" id="{AAAA1DAD-B68B-4C61-BD68-E460F0539ADE}"/>
               </a:ext>
             </a:extLst>
           </p:cNvPr>
@@ -13370,7 +13370,7 @@
           <p:cNvPr id="2" name="">
             <a:extLst xmlns:a="http://schemas.openxmlformats.org/drawingml/2006/main">
               <a:ext uri="{FF2B5EF4-FFF2-40B4-BE49-F238E27FC236}">
-                <a16:creationId xmlns:a16="http://schemas.microsoft.com/office/drawing/2014/main" id="{72DB6781-C24F-49CB-9087-C3A8C4F77A2E}"/>
+                <a16:creationId xmlns:a16="http://schemas.microsoft.com/office/drawing/2014/main" id="{FD2C9FEB-0713-4AED-931A-F6ACC2E75719}"/>
               </a:ext>
             </a:extLst>
           </p:cNvPr>
@@ -13427,7 +13427,7 @@
           <p:cNvPr id="3" name="">
             <a:extLst xmlns:a="http://schemas.openxmlformats.org/drawingml/2006/main">
               <a:ext uri="{FF2B5EF4-FFF2-40B4-BE49-F238E27FC236}">
-                <a16:creationId xmlns:a16="http://schemas.microsoft.com/office/drawing/2014/main" id="{257043BD-FC96-47C7-AA8F-E8AB27570460}"/>
+                <a16:creationId xmlns:a16="http://schemas.microsoft.com/office/drawing/2014/main" id="{984E29C0-C0E3-48DB-A669-5F896BDCA43C}"/>
               </a:ext>
             </a:extLst>
           </p:cNvPr>
@@ -13457,7 +13457,7 @@
           <p:cNvPr id="4" name="">
             <a:extLst xmlns:a="http://schemas.openxmlformats.org/drawingml/2006/main">
               <a:ext uri="{FF2B5EF4-FFF2-40B4-BE49-F238E27FC236}">
-                <a16:creationId xmlns:a16="http://schemas.microsoft.com/office/drawing/2014/main" id="{A6413FE1-E63A-4875-9C89-F8D5435E9C84}"/>
+                <a16:creationId xmlns:a16="http://schemas.microsoft.com/office/drawing/2014/main" id="{F5A1B8C2-530F-4C8C-89F6-B4E96C97E4F6}"/>
               </a:ext>
             </a:extLst>
           </p:cNvPr>
@@ -13514,7 +13514,7 @@
           <p:cNvPr id="5" name="">
             <a:extLst xmlns:a="http://schemas.openxmlformats.org/drawingml/2006/main">
               <a:ext uri="{FF2B5EF4-FFF2-40B4-BE49-F238E27FC236}">
-                <a16:creationId xmlns:a16="http://schemas.microsoft.com/office/drawing/2014/main" id="{E143FF19-D41E-432F-BDD0-8F87C2D3E94F}"/>
+                <a16:creationId xmlns:a16="http://schemas.microsoft.com/office/drawing/2014/main" id="{D778635B-5DAC-471A-A0E6-D21BAA7981FD}"/>
               </a:ext>
             </a:extLst>
           </p:cNvPr>
@@ -13546,7 +13546,7 @@
           <p:cNvPr id="6" name="">
             <a:extLst xmlns:a="http://schemas.openxmlformats.org/drawingml/2006/main">
               <a:ext uri="{FF2B5EF4-FFF2-40B4-BE49-F238E27FC236}">
-                <a16:creationId xmlns:a16="http://schemas.microsoft.com/office/drawing/2014/main" id="{A6E97CA5-A9F0-434C-A830-9090C6543549}"/>
+                <a16:creationId xmlns:a16="http://schemas.microsoft.com/office/drawing/2014/main" id="{AAE1CBD6-880F-4D8E-B52C-ECAAF6D9EBE1}"/>
               </a:ext>
             </a:extLst>
           </p:cNvPr>
@@ -13582,7 +13582,7 @@
           <p:nvPr/>
         </p:nvPicPr>
         <p:blipFill>
-          <a:blip xmlns:r="http://schemas.openxmlformats.org/officeDocument/2006/relationships" xmlns:a="http://schemas.openxmlformats.org/drawingml/2006/main" r:embed="Rf04cffc3e0504d48"/>
+          <a:blip xmlns:r="http://schemas.openxmlformats.org/officeDocument/2006/relationships" xmlns:a="http://schemas.openxmlformats.org/drawingml/2006/main" r:embed="R9a67a674c9404a9e"/>
           <a:stretch xmlns:a="http://schemas.openxmlformats.org/drawingml/2006/main"/>
         </p:blipFill>
         <p:spPr>
@@ -13604,7 +13604,7 @@
           <p:nvPr/>
         </p:nvPicPr>
         <p:blipFill>
-          <a:blip xmlns:r="http://schemas.openxmlformats.org/officeDocument/2006/relationships" xmlns:a="http://schemas.openxmlformats.org/drawingml/2006/main" r:embed="Re232f79b6c1746a2"/>
+          <a:blip xmlns:r="http://schemas.openxmlformats.org/officeDocument/2006/relationships" xmlns:a="http://schemas.openxmlformats.org/drawingml/2006/main" r:embed="R93e1876782264bf3"/>
           <a:stretch xmlns:a="http://schemas.openxmlformats.org/drawingml/2006/main"/>
         </p:blipFill>
         <p:spPr>
@@ -13622,7 +13622,7 @@
           <p:cNvPr id="9" name="">
             <a:extLst xmlns:a="http://schemas.openxmlformats.org/drawingml/2006/main">
               <a:ext uri="{FF2B5EF4-FFF2-40B4-BE49-F238E27FC236}">
-                <a16:creationId xmlns:a16="http://schemas.microsoft.com/office/drawing/2014/main" id="{2B62F258-BD70-4C80-A810-397EF4A28483}"/>
+                <a16:creationId xmlns:a16="http://schemas.microsoft.com/office/drawing/2014/main" id="{512B87EB-CE17-4FC8-9ED5-7170C966A054}"/>
               </a:ext>
             </a:extLst>
           </p:cNvPr>
@@ -13679,7 +13679,7 @@
           <p:cNvPr id="10" name="">
             <a:extLst xmlns:a="http://schemas.openxmlformats.org/drawingml/2006/main">
               <a:ext uri="{FF2B5EF4-FFF2-40B4-BE49-F238E27FC236}">
-                <a16:creationId xmlns:a16="http://schemas.microsoft.com/office/drawing/2014/main" id="{951AA9B9-CD49-4589-890D-E089A3074958}"/>
+                <a16:creationId xmlns:a16="http://schemas.microsoft.com/office/drawing/2014/main" id="{06A594C1-7AC0-4674-B411-1454CA8B1FFC}"/>
               </a:ext>
             </a:extLst>
           </p:cNvPr>
@@ -13736,7 +13736,7 @@
           <p:cNvPr id="11" name="">
             <a:extLst xmlns:a="http://schemas.openxmlformats.org/drawingml/2006/main">
               <a:ext uri="{FF2B5EF4-FFF2-40B4-BE49-F238E27FC236}">
-                <a16:creationId xmlns:a16="http://schemas.microsoft.com/office/drawing/2014/main" id="{35C3CD68-B5BC-4724-A60F-46DA886E3FB8}"/>
+                <a16:creationId xmlns:a16="http://schemas.microsoft.com/office/drawing/2014/main" id="{A50657A5-45C6-4AB8-B5CC-8A9AB21196E0}"/>
               </a:ext>
             </a:extLst>
           </p:cNvPr>
@@ -13791,7 +13791,7 @@
     </p:spTree>
     <p:extLst>
       <p:ext uri="{BB962C8B-B14F-4D97-AF65-F5344CB8AC3E}">
-        <p14:creationId xmlns:p14="http://schemas.microsoft.com/office/powerpoint/2010/main" val="1315261781"/>
+        <p14:creationId xmlns:p14="http://schemas.microsoft.com/office/powerpoint/2010/main" val="2094041068"/>
       </p:ext>
     </p:extLst>
   </p:cSld>
@@ -13822,7 +13822,7 @@
           <p:cNvPr id="27" name="">
             <a:extLst xmlns:a="http://schemas.openxmlformats.org/drawingml/2006/main">
               <a:ext uri="{FF2B5EF4-FFF2-40B4-BE49-F238E27FC236}">
-                <a16:creationId xmlns:a16="http://schemas.microsoft.com/office/drawing/2014/main" id="{66620607-C16B-4F49-83AC-AD06F4ADEDF5}"/>
+                <a16:creationId xmlns:a16="http://schemas.microsoft.com/office/drawing/2014/main" id="{1DD38E81-A94A-4458-A357-8F95E4005259}"/>
               </a:ext>
             </a:extLst>
           </p:cNvPr>
@@ -13852,7 +13852,7 @@
           <p:cNvPr id="2" name="">
             <a:extLst xmlns:a="http://schemas.openxmlformats.org/drawingml/2006/main">
               <a:ext uri="{FF2B5EF4-FFF2-40B4-BE49-F238E27FC236}">
-                <a16:creationId xmlns:a16="http://schemas.microsoft.com/office/drawing/2014/main" id="{8A339FC0-4078-456A-87BC-8D001F25EE23}"/>
+                <a16:creationId xmlns:a16="http://schemas.microsoft.com/office/drawing/2014/main" id="{33A83B2F-1D61-464E-B7B5-2D1A4D215A9E}"/>
               </a:ext>
             </a:extLst>
           </p:cNvPr>
@@ -13909,7 +13909,7 @@
           <p:cNvPr id="3" name="">
             <a:extLst xmlns:a="http://schemas.openxmlformats.org/drawingml/2006/main">
               <a:ext uri="{FF2B5EF4-FFF2-40B4-BE49-F238E27FC236}">
-                <a16:creationId xmlns:a16="http://schemas.microsoft.com/office/drawing/2014/main" id="{AAE1ADD2-A7F9-4090-A5C9-7D1A27D52BD4}"/>
+                <a16:creationId xmlns:a16="http://schemas.microsoft.com/office/drawing/2014/main" id="{E2A132B8-821D-4EF8-91B4-91533C8EBE0C}"/>
               </a:ext>
             </a:extLst>
           </p:cNvPr>
@@ -13939,7 +13939,7 @@
           <p:cNvPr id="4" name="">
             <a:extLst xmlns:a="http://schemas.openxmlformats.org/drawingml/2006/main">
               <a:ext uri="{FF2B5EF4-FFF2-40B4-BE49-F238E27FC236}">
-                <a16:creationId xmlns:a16="http://schemas.microsoft.com/office/drawing/2014/main" id="{90F7CD2E-A540-4707-AD50-B707010A9BC7}"/>
+                <a16:creationId xmlns:a16="http://schemas.microsoft.com/office/drawing/2014/main" id="{4573E0C3-27F4-48E0-98B1-5A71B04BAABB}"/>
               </a:ext>
             </a:extLst>
           </p:cNvPr>
@@ -13996,7 +13996,7 @@
           <p:cNvPr id="5" name="">
             <a:extLst xmlns:a="http://schemas.openxmlformats.org/drawingml/2006/main">
               <a:ext uri="{FF2B5EF4-FFF2-40B4-BE49-F238E27FC236}">
-                <a16:creationId xmlns:a16="http://schemas.microsoft.com/office/drawing/2014/main" id="{34F8B9FD-B94E-4D7E-8029-9040312E6B4B}"/>
+                <a16:creationId xmlns:a16="http://schemas.microsoft.com/office/drawing/2014/main" id="{FC6C54DF-754A-473C-85E8-618D04AECF37}"/>
               </a:ext>
             </a:extLst>
           </p:cNvPr>
@@ -14028,7 +14028,7 @@
           <p:cNvPr id="6" name="">
             <a:extLst xmlns:a="http://schemas.openxmlformats.org/drawingml/2006/main">
               <a:ext uri="{FF2B5EF4-FFF2-40B4-BE49-F238E27FC236}">
-                <a16:creationId xmlns:a16="http://schemas.microsoft.com/office/drawing/2014/main" id="{0F6630C8-ED14-4541-8908-216D45A97F0B}"/>
+                <a16:creationId xmlns:a16="http://schemas.microsoft.com/office/drawing/2014/main" id="{D88C1D0A-AADE-42C3-8B9D-E370377B612B}"/>
               </a:ext>
             </a:extLst>
           </p:cNvPr>
@@ -14085,7 +14085,7 @@
           <p:cNvPr id="7" name="">
             <a:extLst xmlns:a="http://schemas.openxmlformats.org/drawingml/2006/main">
               <a:ext uri="{FF2B5EF4-FFF2-40B4-BE49-F238E27FC236}">
-                <a16:creationId xmlns:a16="http://schemas.microsoft.com/office/drawing/2014/main" id="{EB864EDB-4485-4992-A782-CF4B80258B47}"/>
+                <a16:creationId xmlns:a16="http://schemas.microsoft.com/office/drawing/2014/main" id="{E3E4B704-91F6-4DBF-9E5A-14762915CE7B}"/>
               </a:ext>
             </a:extLst>
           </p:cNvPr>
@@ -14142,7 +14142,7 @@
           <p:cNvPr id="8" name="">
             <a:extLst xmlns:a="http://schemas.openxmlformats.org/drawingml/2006/main">
               <a:ext uri="{FF2B5EF4-FFF2-40B4-BE49-F238E27FC236}">
-                <a16:creationId xmlns:a16="http://schemas.microsoft.com/office/drawing/2014/main" id="{9E3494F2-5924-4BD5-AD9E-03951DF27760}"/>
+                <a16:creationId xmlns:a16="http://schemas.microsoft.com/office/drawing/2014/main" id="{42856105-61BC-43BF-B391-D4461B04CB50}"/>
               </a:ext>
             </a:extLst>
           </p:cNvPr>
@@ -14222,7 +14222,7 @@
           <p:cNvPr id="9" name="">
             <a:extLst xmlns:a="http://schemas.openxmlformats.org/drawingml/2006/main">
               <a:ext uri="{FF2B5EF4-FFF2-40B4-BE49-F238E27FC236}">
-                <a16:creationId xmlns:a16="http://schemas.microsoft.com/office/drawing/2014/main" id="{4ADF35E7-2CDD-4402-8FED-4F61A6B83E65}"/>
+                <a16:creationId xmlns:a16="http://schemas.microsoft.com/office/drawing/2014/main" id="{8BEE3044-050A-414D-AAD8-04A2162ACEDC}"/>
               </a:ext>
             </a:extLst>
           </p:cNvPr>
@@ -14254,7 +14254,7 @@
           <p:cNvPr id="10" name="">
             <a:extLst xmlns:a="http://schemas.openxmlformats.org/drawingml/2006/main">
               <a:ext uri="{FF2B5EF4-FFF2-40B4-BE49-F238E27FC236}">
-                <a16:creationId xmlns:a16="http://schemas.microsoft.com/office/drawing/2014/main" id="{570CB376-955E-43C1-8496-924E16FA7B67}"/>
+                <a16:creationId xmlns:a16="http://schemas.microsoft.com/office/drawing/2014/main" id="{0018FAA9-E69D-41C3-9DEC-853AFE9FCF61}"/>
               </a:ext>
             </a:extLst>
           </p:cNvPr>
@@ -14311,7 +14311,7 @@
           <p:cNvPr id="11" name="">
             <a:extLst xmlns:a="http://schemas.openxmlformats.org/drawingml/2006/main">
               <a:ext uri="{FF2B5EF4-FFF2-40B4-BE49-F238E27FC236}">
-                <a16:creationId xmlns:a16="http://schemas.microsoft.com/office/drawing/2014/main" id="{A612C935-46EA-470F-B19D-67AF21FFFDF2}"/>
+                <a16:creationId xmlns:a16="http://schemas.microsoft.com/office/drawing/2014/main" id="{3C8D35D3-5E35-47AB-A944-E4DA87342795}"/>
               </a:ext>
             </a:extLst>
           </p:cNvPr>
@@ -14368,7 +14368,7 @@
           <p:cNvPr id="12" name="">
             <a:extLst xmlns:a="http://schemas.openxmlformats.org/drawingml/2006/main">
               <a:ext uri="{FF2B5EF4-FFF2-40B4-BE49-F238E27FC236}">
-                <a16:creationId xmlns:a16="http://schemas.microsoft.com/office/drawing/2014/main" id="{5DA930FC-D04C-4246-86E5-FBCDD446A9A8}"/>
+                <a16:creationId xmlns:a16="http://schemas.microsoft.com/office/drawing/2014/main" id="{2DCCF991-195D-4DAC-8413-015A8A001BFF}"/>
               </a:ext>
             </a:extLst>
           </p:cNvPr>
@@ -14448,7 +14448,7 @@
           <p:cNvPr id="13" name="">
             <a:extLst xmlns:a="http://schemas.openxmlformats.org/drawingml/2006/main">
               <a:ext uri="{FF2B5EF4-FFF2-40B4-BE49-F238E27FC236}">
-                <a16:creationId xmlns:a16="http://schemas.microsoft.com/office/drawing/2014/main" id="{E369BDB6-5DB5-40C7-904F-1D2C77283963}"/>
+                <a16:creationId xmlns:a16="http://schemas.microsoft.com/office/drawing/2014/main" id="{1A359B9F-94F6-429E-AE6F-9630C96FE722}"/>
               </a:ext>
             </a:extLst>
           </p:cNvPr>
@@ -14480,7 +14480,7 @@
           <p:cNvPr id="14" name="">
             <a:extLst xmlns:a="http://schemas.openxmlformats.org/drawingml/2006/main">
               <a:ext uri="{FF2B5EF4-FFF2-40B4-BE49-F238E27FC236}">
-                <a16:creationId xmlns:a16="http://schemas.microsoft.com/office/drawing/2014/main" id="{F05FC300-37F1-4B36-A04F-0D94257830EF}"/>
+                <a16:creationId xmlns:a16="http://schemas.microsoft.com/office/drawing/2014/main" id="{82ED5AE3-E41B-4809-8F52-82CB4B5C372C}"/>
               </a:ext>
             </a:extLst>
           </p:cNvPr>
@@ -14537,7 +14537,7 @@
           <p:cNvPr id="15" name="">
             <a:extLst xmlns:a="http://schemas.openxmlformats.org/drawingml/2006/main">
               <a:ext uri="{FF2B5EF4-FFF2-40B4-BE49-F238E27FC236}">
-                <a16:creationId xmlns:a16="http://schemas.microsoft.com/office/drawing/2014/main" id="{C2898703-D961-4C3F-AEB0-0B712906F12F}"/>
+                <a16:creationId xmlns:a16="http://schemas.microsoft.com/office/drawing/2014/main" id="{069B6A9B-9042-453C-B618-249191C0EAC4}"/>
               </a:ext>
             </a:extLst>
           </p:cNvPr>
@@ -14594,7 +14594,7 @@
           <p:cNvPr id="16" name="">
             <a:extLst xmlns:a="http://schemas.openxmlformats.org/drawingml/2006/main">
               <a:ext uri="{FF2B5EF4-FFF2-40B4-BE49-F238E27FC236}">
-                <a16:creationId xmlns:a16="http://schemas.microsoft.com/office/drawing/2014/main" id="{7ED8CA61-D862-45A6-B189-904A3A02326E}"/>
+                <a16:creationId xmlns:a16="http://schemas.microsoft.com/office/drawing/2014/main" id="{BF065F0C-F8A8-4358-8083-0F68877870D8}"/>
               </a:ext>
             </a:extLst>
           </p:cNvPr>
@@ -14674,7 +14674,7 @@
           <p:cNvPr id="17" name="">
             <a:extLst xmlns:a="http://schemas.openxmlformats.org/drawingml/2006/main">
               <a:ext uri="{FF2B5EF4-FFF2-40B4-BE49-F238E27FC236}">
-                <a16:creationId xmlns:a16="http://schemas.microsoft.com/office/drawing/2014/main" id="{03EF750B-D497-4643-A4C8-7C1601626BF2}"/>
+                <a16:creationId xmlns:a16="http://schemas.microsoft.com/office/drawing/2014/main" id="{0AC39666-95C8-43C0-A387-270D8F8A7803}"/>
               </a:ext>
             </a:extLst>
           </p:cNvPr>
@@ -14706,7 +14706,7 @@
           <p:cNvPr id="18" name="">
             <a:extLst xmlns:a="http://schemas.openxmlformats.org/drawingml/2006/main">
               <a:ext uri="{FF2B5EF4-FFF2-40B4-BE49-F238E27FC236}">
-                <a16:creationId xmlns:a16="http://schemas.microsoft.com/office/drawing/2014/main" id="{01D8DA9D-5248-4972-9484-BC08961176E5}"/>
+                <a16:creationId xmlns:a16="http://schemas.microsoft.com/office/drawing/2014/main" id="{E49573B3-A39F-45CD-83B6-75705C3AF10B}"/>
               </a:ext>
             </a:extLst>
           </p:cNvPr>
@@ -14763,7 +14763,7 @@
           <p:cNvPr id="19" name="">
             <a:extLst xmlns:a="http://schemas.openxmlformats.org/drawingml/2006/main">
               <a:ext uri="{FF2B5EF4-FFF2-40B4-BE49-F238E27FC236}">
-                <a16:creationId xmlns:a16="http://schemas.microsoft.com/office/drawing/2014/main" id="{4FE5EEDC-AFF4-444B-A246-AD1BF5EA7200}"/>
+                <a16:creationId xmlns:a16="http://schemas.microsoft.com/office/drawing/2014/main" id="{A541FE01-496B-47C8-ACE3-1F2600EBABAE}"/>
               </a:ext>
             </a:extLst>
           </p:cNvPr>
@@ -14820,7 +14820,7 @@
           <p:cNvPr id="20" name="">
             <a:extLst xmlns:a="http://schemas.openxmlformats.org/drawingml/2006/main">
               <a:ext uri="{FF2B5EF4-FFF2-40B4-BE49-F238E27FC236}">
-                <a16:creationId xmlns:a16="http://schemas.microsoft.com/office/drawing/2014/main" id="{D9EA0EBA-46EA-4BD4-97A9-2157B9435683}"/>
+                <a16:creationId xmlns:a16="http://schemas.microsoft.com/office/drawing/2014/main" id="{44DE1061-15C7-4A0B-BEED-D941F2EF70C4}"/>
               </a:ext>
             </a:extLst>
           </p:cNvPr>
@@ -14900,7 +14900,7 @@
           <p:cNvPr id="21" name="">
             <a:extLst xmlns:a="http://schemas.openxmlformats.org/drawingml/2006/main">
               <a:ext uri="{FF2B5EF4-FFF2-40B4-BE49-F238E27FC236}">
-                <a16:creationId xmlns:a16="http://schemas.microsoft.com/office/drawing/2014/main" id="{2FDD2A37-AB97-4CAC-816C-F62C96E35B0C}"/>
+                <a16:creationId xmlns:a16="http://schemas.microsoft.com/office/drawing/2014/main" id="{FCF28743-F447-4D18-96EB-B0CAC6EAA9B0}"/>
               </a:ext>
             </a:extLst>
           </p:cNvPr>
@@ -14957,7 +14957,7 @@
           <p:cNvPr id="22" name="">
             <a:extLst xmlns:a="http://schemas.openxmlformats.org/drawingml/2006/main">
               <a:ext uri="{FF2B5EF4-FFF2-40B4-BE49-F238E27FC236}">
-                <a16:creationId xmlns:a16="http://schemas.microsoft.com/office/drawing/2014/main" id="{BC4009C3-0A07-4029-8396-2BA8FCE6501C}"/>
+                <a16:creationId xmlns:a16="http://schemas.microsoft.com/office/drawing/2014/main" id="{15606E55-7A72-4B31-8C60-78FBC1559B40}"/>
               </a:ext>
             </a:extLst>
           </p:cNvPr>
@@ -15014,7 +15014,7 @@
           <p:cNvPr id="23" name="">
             <a:extLst xmlns:a="http://schemas.openxmlformats.org/drawingml/2006/main">
               <a:ext uri="{FF2B5EF4-FFF2-40B4-BE49-F238E27FC236}">
-                <a16:creationId xmlns:a16="http://schemas.microsoft.com/office/drawing/2014/main" id="{6BD5B5BF-5A90-4C46-A437-D7D94060AEC2}"/>
+                <a16:creationId xmlns:a16="http://schemas.microsoft.com/office/drawing/2014/main" id="{138F50D4-DFBD-459B-BB15-51FE77705C72}"/>
               </a:ext>
             </a:extLst>
           </p:cNvPr>
@@ -15071,7 +15071,7 @@
           <p:cNvPr id="24" name="">
             <a:extLst xmlns:a="http://schemas.openxmlformats.org/drawingml/2006/main">
               <a:ext uri="{FF2B5EF4-FFF2-40B4-BE49-F238E27FC236}">
-                <a16:creationId xmlns:a16="http://schemas.microsoft.com/office/drawing/2014/main" id="{1627FAE8-6934-48E5-94AE-F772DCCA403B}"/>
+                <a16:creationId xmlns:a16="http://schemas.microsoft.com/office/drawing/2014/main" id="{DBF226B6-AB73-495A-A27F-59C0AC8CE264}"/>
               </a:ext>
             </a:extLst>
           </p:cNvPr>
@@ -15128,7 +15128,7 @@
           <p:cNvPr id="25" name="">
             <a:extLst xmlns:a="http://schemas.openxmlformats.org/drawingml/2006/main">
               <a:ext uri="{FF2B5EF4-FFF2-40B4-BE49-F238E27FC236}">
-                <a16:creationId xmlns:a16="http://schemas.microsoft.com/office/drawing/2014/main" id="{2EF215B9-8A57-4A60-80AE-701B6D9036EF}"/>
+                <a16:creationId xmlns:a16="http://schemas.microsoft.com/office/drawing/2014/main" id="{A2E6213C-0502-49CA-A48B-2617187A172B}"/>
               </a:ext>
             </a:extLst>
           </p:cNvPr>
@@ -15185,7 +15185,7 @@
           <p:cNvPr id="26" name="">
             <a:extLst xmlns:a="http://schemas.openxmlformats.org/drawingml/2006/main">
               <a:ext uri="{FF2B5EF4-FFF2-40B4-BE49-F238E27FC236}">
-                <a16:creationId xmlns:a16="http://schemas.microsoft.com/office/drawing/2014/main" id="{0D7C30DA-802D-4833-A661-2E01416ACFA4}"/>
+                <a16:creationId xmlns:a16="http://schemas.microsoft.com/office/drawing/2014/main" id="{AD294938-3E29-4954-990E-3E2837CC4B69}"/>
               </a:ext>
             </a:extLst>
           </p:cNvPr>
@@ -15240,7 +15240,7 @@
     </p:spTree>
     <p:extLst>
       <p:ext uri="{BB962C8B-B14F-4D97-AF65-F5344CB8AC3E}">
-        <p14:creationId xmlns:p14="http://schemas.microsoft.com/office/powerpoint/2010/main" val="1067670571"/>
+        <p14:creationId xmlns:p14="http://schemas.microsoft.com/office/powerpoint/2010/main" val="45135520"/>
       </p:ext>
     </p:extLst>
   </p:cSld>

</xml_diff>

<commit_message>
docs: clarify MEMOIVE strengths in presentation
</commit_message>
<xml_diff>
--- a/docs/presentation/MEMOIVE-Presentation.pptx
+++ b/docs/presentation/MEMOIVE-Presentation.pptx
@@ -1025,29 +1025,169 @@
           <a:lstStyle/>
           <a:p>
             <a:r>
-              <a:t>시간 배분 25초</a:t>
-            </a:r>
-          </a:p>
-          <a:p>
-            <a:r>
-              <a:t>생성형 AI는 지금 받은 질문에 답하고, 일반적인 자료 보관 도구는 저장과 검색을 돕습니다. 메모이브는 원문과 저장 이유, 내 생각, 작성 중인 결과물을 연결해 다음 작업에서 같은 설명을 반복하지 않게 설계했습니다. 더 우수하다고 주장하기보다, 맥락 재사용이라는 다른 역할이 실제로 유용한지 검증하려는 단계입니다.</a:t>
-            </a:r>
-          </a:p>
-          <a:p>
+              <a:rPr lang="ko-KR" altLang="en-US"/>
+              <a:t>시간 배분 </a:t>
+            </a:r>
+            <a:r>
+              <a:rPr lang="en-US" altLang="ko-KR"/>
+              <a:t>25</a:t>
+            </a:r>
+            <a:r>
+              <a:rPr lang="ko-KR" altLang="en-US"/>
+              <a:t>초
+</a:t>
+            </a:r>
+            <a:r>
+              <a:rPr lang="en-US" altLang="ko-KR"/>
+              <a:t>Codex</a:t>
+            </a:r>
+            <a:r>
+              <a:rPr lang="ko-KR" altLang="en-US"/>
+              <a:t>는 현재 대화와 프로젝트를 바탕으로 코드</a:t>
+            </a:r>
+            <a:r>
+              <a:rPr lang="en-US" altLang="ko-KR"/>
+              <a:t>, </a:t>
+            </a:r>
+            <a:r>
+              <a:rPr lang="ko-KR" altLang="en-US"/>
+              <a:t>문서</a:t>
+            </a:r>
+            <a:r>
+              <a:rPr lang="en-US" altLang="ko-KR"/>
+              <a:t>, </a:t>
+            </a:r>
+            <a:r>
+              <a:rPr lang="ko-KR" altLang="en-US"/>
+              <a:t>파일을 만들고 수정하는 실행 도구입니다</a:t>
+            </a:r>
+            <a:r>
+              <a:rPr lang="en-US" altLang="ko-KR"/>
+              <a:t>. MEMOIVE</a:t>
+            </a:r>
+            <a:r>
+              <a:rPr lang="ko-KR" altLang="en-US"/>
+              <a:t>는 그 앞단에서 원문</a:t>
+            </a:r>
+            <a:r>
+              <a:rPr lang="en-US" altLang="ko-KR"/>
+              <a:t>, </a:t>
+            </a:r>
+            <a:r>
+              <a:rPr lang="ko-KR" altLang="en-US"/>
+              <a:t>저장 이유</a:t>
+            </a:r>
+            <a:r>
+              <a:rPr lang="en-US" altLang="ko-KR"/>
+              <a:t>, </a:t>
+            </a:r>
+            <a:r>
+              <a:rPr lang="ko-KR" altLang="en-US"/>
+              <a:t>제 생각을 장기 기록으로 남기고 다음 글이나 기획에서 다시 불러옵니다</a:t>
+            </a:r>
+            <a:r>
+              <a:rPr lang="en-US" altLang="ko-KR"/>
+              <a:t>. MEMOIVE</a:t>
+            </a:r>
+            <a:r>
+              <a:rPr lang="ko-KR" altLang="en-US"/>
+              <a:t>의 강점은 작업할 때마다 맥락을 처음부터 설명하는 수고를 줄이는 데 있습니다</a:t>
+            </a:r>
+            <a:r>
+              <a:rPr lang="en-US" altLang="ko-KR"/>
+              <a:t>. MEMOIVE</a:t>
+            </a:r>
+            <a:r>
+              <a:rPr lang="ko-KR" altLang="en-US"/>
+              <a:t>가 맥락을 준비하고 </a:t>
+            </a:r>
+            <a:r>
+              <a:rPr lang="en-US" altLang="ko-KR"/>
+              <a:t>Codex</a:t>
+            </a:r>
+            <a:r>
+              <a:rPr lang="ko-KR" altLang="en-US"/>
+              <a:t>가 결과물을 만드는 방식으로 함께 사용할 수 있습니다</a:t>
+            </a:r>
+            <a:r>
+              <a:rPr lang="en-US" altLang="ko-KR"/>
+              <a:t>.
+</a:t>
+            </a:r>
+            <a:r>
+              <a:rPr lang="ko-KR" altLang="en-US"/>
+              <a:t>진행 메모</a:t>
+            </a:r>
+            <a:r>
+              <a:rPr lang="en-US" altLang="ko-KR"/>
+              <a:t>: Codex</a:t>
+            </a:r>
+            <a:r>
+              <a:rPr lang="ko-KR" altLang="en-US"/>
+              <a:t>의 작업 실행과 </a:t>
+            </a:r>
+            <a:r>
+              <a:rPr lang="en-US" altLang="ko-KR"/>
+              <a:t>MEMOIVE</a:t>
+            </a:r>
+            <a:r>
+              <a:rPr lang="ko-KR" altLang="en-US"/>
+              <a:t>의 개인 맥락 축적을 구분한 뒤 함께 쓰는 방식을 설명합니다</a:t>
+            </a:r>
+            <a:r>
+              <a:rPr lang="en-US" altLang="ko-KR"/>
+              <a:t>.
+</a:t>
+            </a:r>
+            <a:r>
+              <a:rPr lang="ko-KR" altLang="en-US"/>
+              <a:t>근거</a:t>
+            </a:r>
+            <a:r>
+              <a:rPr lang="en-US" altLang="ko-KR"/>
+              <a:t>: OpenAI </a:t>
+            </a:r>
+            <a:r>
+              <a:rPr lang="ko-KR" altLang="en-US"/>
+              <a:t>공식 문서에서 </a:t>
+            </a:r>
+            <a:r>
+              <a:rPr lang="en-US" altLang="ko-KR"/>
+              <a:t>Codex</a:t>
+            </a:r>
+            <a:r>
+              <a:rPr lang="ko-KR" altLang="en-US"/>
+              <a:t>는 저장소 점검</a:t>
+            </a:r>
+            <a:r>
+              <a:rPr lang="en-US" altLang="ko-KR"/>
+              <a:t>, </a:t>
+            </a:r>
+            <a:r>
+              <a:rPr lang="ko-KR" altLang="en-US"/>
+              <a:t>버그 수정</a:t>
+            </a:r>
+            <a:r>
+              <a:rPr lang="en-US" altLang="ko-KR"/>
+              <a:t>, </a:t>
+            </a:r>
+            <a:r>
+              <a:rPr lang="ko-KR" altLang="en-US"/>
+              <a:t>테스트</a:t>
+            </a:r>
+            <a:r>
+              <a:rPr lang="en-US" altLang="ko-KR"/>
+              <a:t>, </a:t>
+            </a:r>
+            <a:r>
+              <a:rPr lang="ko-KR" altLang="en-US"/>
+              <a:t>파일 변경 같은 범위가 정해진 작업에 적합하다고 설명합니다</a:t>
+            </a:r>
+            <a:r>
+              <a:rPr lang="en-US" altLang="ko-KR"/>
+              <a:t>. https://developers.openai.com/cookbook/examples/codex/using_goals_in_codex</a:t>
+            </a:r>
             <a:endParaRPr/>
-          </a:p>
-          <a:p>
-            <a:r>
-              <a:t>진행 메모: 비교 우위가 아니라 역할의 차이를 설명합니다.</a:t>
-            </a:r>
-          </a:p>
-          <a:p>
-            <a:endParaRPr/>
-          </a:p>
-          <a:p>
-            <a:r>
-              <a:t>근거: MEMOIVE 운영 코드와 2026-10-07~08 확인 내용. https://memoive.vercel.app/ 및 https://github.com/jhheo51-arch/memoive</a:t>
-            </a:r>
           </a:p>
         </p:txBody>
       </p:sp>
@@ -5872,7 +6012,7 @@
               </a:defRPr>
             </a:pPr>
             <a:r>
-              <a:rPr sz="3000" b="1">
+              <a:rPr lang="ko-KR" altLang="en-US" sz="3000" b="1">
                 <a:solidFill>
                   <a:srgbClr val="2C1D18"/>
                 </a:solidFill>
@@ -5880,8 +6020,16 @@
                 <a:ea typeface="Noto Sans KR"/>
                 <a:cs typeface="Noto Sans KR"/>
               </a:rPr>
-              <a:t>제품 기획자로서 배운 점</a:t>
-            </a:r>
+              <a:t>제품 기획자로서 배운 세 가지</a:t>
+            </a:r>
+            <a:endParaRPr sz="3000" b="1">
+              <a:solidFill>
+                <a:srgbClr val="2C1D18"/>
+              </a:solidFill>
+              <a:latin typeface="Noto Sans KR"/>
+              <a:ea typeface="Noto Sans KR"/>
+              <a:cs typeface="Noto Sans KR"/>
+            </a:endParaRPr>
           </a:p>
         </p:txBody>
       </p:sp>
@@ -6073,7 +6221,7 @@
               </a:defRPr>
             </a:pPr>
             <a:r>
-              <a:rPr sz="2325" b="1">
+              <a:rPr lang="en-US" altLang="ko-KR" sz="2325" b="1">
                 <a:solidFill>
                   <a:srgbClr val="2C1D18"/>
                 </a:solidFill>
@@ -6081,8 +6229,49 @@
                 <a:ea typeface="Noto Sans KR"/>
                 <a:cs typeface="Noto Sans KR"/>
               </a:rPr>
-              <a:t>AI 답변 품질만 높여도 반복 사용 이유는 생기지 않았다</a:t>
-            </a:r>
+              <a:t>AI </a:t>
+            </a:r>
+            <a:r>
+              <a:rPr lang="ko-KR" altLang="en-US" sz="2325" b="1">
+                <a:solidFill>
+                  <a:srgbClr val="2C1D18"/>
+                </a:solidFill>
+                <a:latin typeface="Noto Sans KR"/>
+                <a:ea typeface="Noto Sans KR"/>
+                <a:cs typeface="Noto Sans KR"/>
+              </a:rPr>
+              <a:t>요약은 출발점이었다</a:t>
+            </a:r>
+            <a:r>
+              <a:rPr lang="en-US" altLang="ko-KR" sz="2325" b="1">
+                <a:solidFill>
+                  <a:srgbClr val="2C1D18"/>
+                </a:solidFill>
+                <a:latin typeface="Noto Sans KR"/>
+                <a:ea typeface="Noto Sans KR"/>
+                <a:cs typeface="Noto Sans KR"/>
+              </a:rPr>
+              <a:t>. </a:t>
+            </a:r>
+            <a:r>
+              <a:rPr lang="ko-KR" altLang="en-US" sz="2325" b="1">
+                <a:solidFill>
+                  <a:srgbClr val="2C1D18"/>
+                </a:solidFill>
+                <a:latin typeface="Noto Sans KR"/>
+                <a:ea typeface="Noto Sans KR"/>
+                <a:cs typeface="Noto Sans KR"/>
+              </a:rPr>
+              <a:t>기록이 생각과 창작으로 이어져야 다시 쓰게 된다</a:t>
+            </a:r>
+            <a:endParaRPr sz="2325" b="1">
+              <a:solidFill>
+                <a:srgbClr val="2C1D18"/>
+              </a:solidFill>
+              <a:latin typeface="Noto Sans KR"/>
+              <a:ea typeface="Noto Sans KR"/>
+              <a:cs typeface="Noto Sans KR"/>
+            </a:endParaRPr>
           </a:p>
         </p:txBody>
       </p:sp>
@@ -6217,7 +6406,7 @@
               </a:defRPr>
             </a:pPr>
             <a:r>
-              <a:rPr sz="2325" b="1">
+              <a:rPr lang="ko-KR" altLang="en-US" sz="2325" b="1">
                 <a:solidFill>
                   <a:srgbClr val="2C1D18"/>
                 </a:solidFill>
@@ -6225,8 +6414,16 @@
                 <a:ea typeface="Noto Sans KR"/>
                 <a:cs typeface="Noto Sans KR"/>
               </a:rPr>
-              <a:t>새 기능보다 저장 실패와 충돌, 복구 같은 신뢰 문제를 먼저 다뤘다</a:t>
-            </a:r>
+              <a:t>기록의 신뢰를 위해 기능 추가보다 저장 오류와 데이터 충돌을 먼저 해결했다</a:t>
+            </a:r>
+            <a:endParaRPr sz="2325" b="1">
+              <a:solidFill>
+                <a:srgbClr val="2C1D18"/>
+              </a:solidFill>
+              <a:latin typeface="Noto Sans KR"/>
+              <a:ea typeface="Noto Sans KR"/>
+              <a:cs typeface="Noto Sans KR"/>
+            </a:endParaRPr>
           </a:p>
         </p:txBody>
       </p:sp>
@@ -6361,7 +6558,7 @@
               </a:defRPr>
             </a:pPr>
             <a:r>
-              <a:rPr sz="2325" b="1">
+              <a:rPr lang="ko-KR" altLang="en-US" sz="2325" b="1">
                 <a:solidFill>
                   <a:srgbClr val="2C1D18"/>
                 </a:solidFill>
@@ -6369,8 +6566,16 @@
                 <a:ea typeface="Noto Sans KR"/>
                 <a:cs typeface="Noto Sans KR"/>
               </a:rPr>
-              <a:t>데이터가 있다는 사실과 사용자 문제가 해결됐다는 주장을 구분했다</a:t>
-            </a:r>
+              <a:t>저장 성공 뒤에도 사용자가 다시 찾고 활용하는지 확인해야 한다</a:t>
+            </a:r>
+            <a:endParaRPr sz="2325" b="1">
+              <a:solidFill>
+                <a:srgbClr val="2C1D18"/>
+              </a:solidFill>
+              <a:latin typeface="Noto Sans KR"/>
+              <a:ea typeface="Noto Sans KR"/>
+              <a:cs typeface="Noto Sans KR"/>
+            </a:endParaRPr>
           </a:p>
         </p:txBody>
       </p:sp>
@@ -6448,7 +6653,7 @@
               </a:defRPr>
             </a:pPr>
             <a:r>
-              <a:rPr sz="2175" b="1">
+              <a:rPr lang="ko-KR" altLang="en-US" sz="2175" b="1">
                 <a:solidFill>
                   <a:srgbClr val="F7F2EA"/>
                 </a:solidFill>
@@ -6456,8 +6661,16 @@
                 <a:ea typeface="Noto Sans KR"/>
                 <a:cs typeface="Noto Sans KR"/>
               </a:rPr>
-              <a:t>제품 기획에서 기능, 데이터, 사용자 행동을 함께 봐야 했습니다</a:t>
-            </a:r>
+              <a:t>저장한 기록을 다시 활용했는가를 제품의 최종 기준으로 삼았습니다</a:t>
+            </a:r>
+            <a:endParaRPr sz="2175" b="1">
+              <a:solidFill>
+                <a:srgbClr val="F7F2EA"/>
+              </a:solidFill>
+              <a:latin typeface="Noto Sans KR"/>
+              <a:ea typeface="Noto Sans KR"/>
+              <a:cs typeface="Noto Sans KR"/>
+            </a:endParaRPr>
           </a:p>
         </p:txBody>
       </p:sp>
@@ -8643,7 +8856,7 @@
               </a:defRPr>
             </a:pPr>
             <a:r>
-              <a:rPr sz="3000" b="1">
+              <a:rPr lang="en-US" altLang="ko-KR" sz="3000" b="1">
                 <a:solidFill>
                   <a:srgbClr val="2C1D18"/>
                 </a:solidFill>
@@ -8651,8 +8864,49 @@
                 <a:ea typeface="Noto Sans KR"/>
                 <a:cs typeface="Noto Sans KR"/>
               </a:rPr>
-              <a:t>기존 도구 사이에서 MEMOIVE가 맡는 역할</a:t>
-            </a:r>
+              <a:t>Codex</a:t>
+            </a:r>
+            <a:r>
+              <a:rPr lang="ko-KR" altLang="en-US" sz="3000" b="1">
+                <a:solidFill>
+                  <a:srgbClr val="2C1D18"/>
+                </a:solidFill>
+                <a:latin typeface="Noto Sans KR"/>
+                <a:ea typeface="Noto Sans KR"/>
+                <a:cs typeface="Noto Sans KR"/>
+              </a:rPr>
+              <a:t>와 </a:t>
+            </a:r>
+            <a:r>
+              <a:rPr lang="en-US" altLang="ko-KR" sz="3000" b="1">
+                <a:solidFill>
+                  <a:srgbClr val="2C1D18"/>
+                </a:solidFill>
+                <a:latin typeface="Noto Sans KR"/>
+                <a:ea typeface="Noto Sans KR"/>
+                <a:cs typeface="Noto Sans KR"/>
+              </a:rPr>
+              <a:t>MEMOIVE</a:t>
+            </a:r>
+            <a:r>
+              <a:rPr lang="ko-KR" altLang="en-US" sz="3000" b="1">
+                <a:solidFill>
+                  <a:srgbClr val="2C1D18"/>
+                </a:solidFill>
+                <a:latin typeface="Noto Sans KR"/>
+                <a:ea typeface="Noto Sans KR"/>
+                <a:cs typeface="Noto Sans KR"/>
+              </a:rPr>
+              <a:t>의 역할 차이</a:t>
+            </a:r>
+            <a:endParaRPr sz="3000" b="1">
+              <a:solidFill>
+                <a:srgbClr val="2C1D18"/>
+              </a:solidFill>
+              <a:latin typeface="Noto Sans KR"/>
+              <a:ea typeface="Noto Sans KR"/>
+              <a:cs typeface="Noto Sans KR"/>
+            </a:endParaRPr>
           </a:p>
         </p:txBody>
       </p:sp>
@@ -8787,7 +9041,7 @@
               </a:defRPr>
             </a:pPr>
             <a:r>
-              <a:rPr sz="2175" b="1">
+              <a:rPr lang="en-US" sz="2175" b="1">
                 <a:solidFill>
                   <a:srgbClr val="5F534C"/>
                 </a:solidFill>
@@ -8795,8 +9049,16 @@
                 <a:ea typeface="Noto Sans KR"/>
                 <a:cs typeface="Noto Sans KR"/>
               </a:rPr>
-              <a:t>생성형 AI</a:t>
-            </a:r>
+              <a:t>CODEX</a:t>
+            </a:r>
+            <a:endParaRPr sz="2175" b="1">
+              <a:solidFill>
+                <a:srgbClr val="5F534C"/>
+              </a:solidFill>
+              <a:latin typeface="Noto Sans KR"/>
+              <a:ea typeface="Noto Sans KR"/>
+              <a:cs typeface="Noto Sans KR"/>
+            </a:endParaRPr>
           </a:p>
         </p:txBody>
       </p:sp>
@@ -8844,7 +9106,7 @@
               </a:defRPr>
             </a:pPr>
             <a:r>
-              <a:rPr sz="1950" b="1">
+              <a:rPr lang="ko-KR" altLang="en-US" sz="1950" b="1">
                 <a:solidFill>
                   <a:srgbClr val="2C1D18"/>
                 </a:solidFill>
@@ -8852,8 +9114,16 @@
                 <a:ea typeface="Noto Sans KR"/>
                 <a:cs typeface="Noto Sans KR"/>
               </a:rPr>
-              <a:t>답변 생성</a:t>
-            </a:r>
+              <a:t>작업 실행</a:t>
+            </a:r>
+            <a:endParaRPr sz="1950" b="1">
+              <a:solidFill>
+                <a:srgbClr val="2C1D18"/>
+              </a:solidFill>
+              <a:latin typeface="Noto Sans KR"/>
+              <a:ea typeface="Noto Sans KR"/>
+              <a:cs typeface="Noto Sans KR"/>
+            </a:endParaRPr>
           </a:p>
         </p:txBody>
       </p:sp>
@@ -8901,7 +9171,7 @@
               </a:defRPr>
             </a:pPr>
             <a:r>
-              <a:rPr sz="1800" b="0">
+              <a:rPr lang="ko-KR" altLang="en-US" sz="1800" b="0">
                 <a:solidFill>
                   <a:srgbClr val="5F534C"/>
                 </a:solidFill>
@@ -8909,7 +9179,7 @@
                 <a:ea typeface="Noto Sans KR"/>
                 <a:cs typeface="Noto Sans KR"/>
               </a:rPr>
-              <a:t>다음 작업에서는 자료와</a:t>
+              <a:t>현재 대화와 프로젝트에서</a:t>
             </a:r>
           </a:p>
           <a:p>
@@ -8924,7 +9194,7 @@
               </a:defRPr>
             </a:pPr>
             <a:r>
-              <a:rPr sz="1800" b="0">
+              <a:rPr lang="ko-KR" altLang="en-US" sz="1800" b="0">
                 <a:solidFill>
                   <a:srgbClr val="5F534C"/>
                 </a:solidFill>
@@ -8932,8 +9202,60 @@
                 <a:ea typeface="Noto Sans KR"/>
                 <a:cs typeface="Noto Sans KR"/>
               </a:rPr>
-              <a:t>맥락을 다시 넣어야 함</a:t>
-            </a:r>
+              <a:t>코드 </a:t>
+            </a:r>
+            <a:r>
+              <a:rPr lang="en-US" altLang="ko-KR" sz="1800" b="0">
+                <a:solidFill>
+                  <a:srgbClr val="5F534C"/>
+                </a:solidFill>
+                <a:latin typeface="Noto Sans KR"/>
+                <a:ea typeface="Noto Sans KR"/>
+                <a:cs typeface="Noto Sans KR"/>
+              </a:rPr>
+              <a:t>· </a:t>
+            </a:r>
+            <a:r>
+              <a:rPr lang="ko-KR" altLang="en-US" sz="1800" b="0">
+                <a:solidFill>
+                  <a:srgbClr val="5F534C"/>
+                </a:solidFill>
+                <a:latin typeface="Noto Sans KR"/>
+                <a:ea typeface="Noto Sans KR"/>
+                <a:cs typeface="Noto Sans KR"/>
+              </a:rPr>
+              <a:t>문서 </a:t>
+            </a:r>
+            <a:r>
+              <a:rPr lang="en-US" altLang="ko-KR" sz="1800" b="0">
+                <a:solidFill>
+                  <a:srgbClr val="5F534C"/>
+                </a:solidFill>
+                <a:latin typeface="Noto Sans KR"/>
+                <a:ea typeface="Noto Sans KR"/>
+                <a:cs typeface="Noto Sans KR"/>
+              </a:rPr>
+              <a:t>· </a:t>
+            </a:r>
+            <a:r>
+              <a:rPr lang="ko-KR" altLang="en-US" sz="1800" b="0">
+                <a:solidFill>
+                  <a:srgbClr val="5F534C"/>
+                </a:solidFill>
+                <a:latin typeface="Noto Sans KR"/>
+                <a:ea typeface="Noto Sans KR"/>
+                <a:cs typeface="Noto Sans KR"/>
+              </a:rPr>
+              <a:t>파일을 만들고 수정</a:t>
+            </a:r>
+            <a:endParaRPr sz="1800" b="0">
+              <a:solidFill>
+                <a:srgbClr val="5F534C"/>
+              </a:solidFill>
+              <a:latin typeface="Noto Sans KR"/>
+              <a:ea typeface="Noto Sans KR"/>
+              <a:cs typeface="Noto Sans KR"/>
+            </a:endParaRPr>
           </a:p>
         </p:txBody>
       </p:sp>
@@ -9011,7 +9333,7 @@
               </a:defRPr>
             </a:pPr>
             <a:r>
-              <a:rPr sz="2175" b="1">
+              <a:rPr lang="en-US" sz="2175" b="1">
                 <a:solidFill>
                   <a:srgbClr val="5F534C"/>
                 </a:solidFill>
@@ -9019,8 +9341,16 @@
                 <a:ea typeface="Noto Sans KR"/>
                 <a:cs typeface="Noto Sans KR"/>
               </a:rPr>
-              <a:t>자료 보관 도구</a:t>
-            </a:r>
+              <a:t>MEMOIVE</a:t>
+            </a:r>
+            <a:endParaRPr sz="2175" b="1">
+              <a:solidFill>
+                <a:srgbClr val="5F534C"/>
+              </a:solidFill>
+              <a:latin typeface="Noto Sans KR"/>
+              <a:ea typeface="Noto Sans KR"/>
+              <a:cs typeface="Noto Sans KR"/>
+            </a:endParaRPr>
           </a:p>
         </p:txBody>
       </p:sp>
@@ -9068,7 +9398,7 @@
               </a:defRPr>
             </a:pPr>
             <a:r>
-              <a:rPr sz="1950" b="1">
+              <a:rPr lang="ko-KR" altLang="en-US" sz="1950" b="1">
                 <a:solidFill>
                   <a:srgbClr val="2C1D18"/>
                 </a:solidFill>
@@ -9076,8 +9406,16 @@
                 <a:ea typeface="Noto Sans KR"/>
                 <a:cs typeface="Noto Sans KR"/>
               </a:rPr>
-              <a:t>저장과 검색</a:t>
-            </a:r>
+              <a:t>맥락 축적</a:t>
+            </a:r>
+            <a:endParaRPr sz="1950" b="1">
+              <a:solidFill>
+                <a:srgbClr val="2C1D18"/>
+              </a:solidFill>
+              <a:latin typeface="Noto Sans KR"/>
+              <a:ea typeface="Noto Sans KR"/>
+              <a:cs typeface="Noto Sans KR"/>
+            </a:endParaRPr>
           </a:p>
         </p:txBody>
       </p:sp>
@@ -9125,7 +9463,7 @@
               </a:defRPr>
             </a:pPr>
             <a:r>
-              <a:rPr sz="1800" b="0">
+              <a:rPr lang="ko-KR" altLang="en-US" sz="1800" b="0">
                 <a:solidFill>
                   <a:srgbClr val="5F534C"/>
                 </a:solidFill>
@@ -9133,7 +9471,51 @@
                 <a:ea typeface="Noto Sans KR"/>
                 <a:cs typeface="Noto Sans KR"/>
               </a:rPr>
-              <a:t>저장 이유와 내 생각을</a:t>
+              <a:t>원문 </a:t>
+            </a:r>
+            <a:r>
+              <a:rPr lang="en-US" altLang="ko-KR" sz="1800" b="0">
+                <a:solidFill>
+                  <a:srgbClr val="5F534C"/>
+                </a:solidFill>
+                <a:latin typeface="Noto Sans KR"/>
+                <a:ea typeface="Noto Sans KR"/>
+                <a:cs typeface="Noto Sans KR"/>
+              </a:rPr>
+              <a:t>· </a:t>
+            </a:r>
+            <a:r>
+              <a:rPr lang="ko-KR" altLang="en-US" sz="1800" b="0">
+                <a:solidFill>
+                  <a:srgbClr val="5F534C"/>
+                </a:solidFill>
+                <a:latin typeface="Noto Sans KR"/>
+                <a:ea typeface="Noto Sans KR"/>
+                <a:cs typeface="Noto Sans KR"/>
+              </a:rPr>
+              <a:t>저장 이유 </a:t>
+            </a:r>
+            <a:r>
+              <a:rPr lang="en-US" altLang="ko-KR" sz="1800" b="0">
+                <a:solidFill>
+                  <a:srgbClr val="5F534C"/>
+                </a:solidFill>
+                <a:latin typeface="Noto Sans KR"/>
+                <a:ea typeface="Noto Sans KR"/>
+                <a:cs typeface="Noto Sans KR"/>
+              </a:rPr>
+              <a:t>· </a:t>
+            </a:r>
+            <a:r>
+              <a:rPr lang="ko-KR" altLang="en-US" sz="1800" b="0">
+                <a:solidFill>
+                  <a:srgbClr val="5F534C"/>
+                </a:solidFill>
+                <a:latin typeface="Noto Sans KR"/>
+                <a:ea typeface="Noto Sans KR"/>
+                <a:cs typeface="Noto Sans KR"/>
+              </a:rPr>
+              <a:t>내 생각을</a:t>
             </a:r>
           </a:p>
           <a:p>
@@ -9148,7 +9530,7 @@
               </a:defRPr>
             </a:pPr>
             <a:r>
-              <a:rPr sz="1800" b="0">
+              <a:rPr lang="ko-KR" altLang="en-US" sz="1800" b="0">
                 <a:solidFill>
                   <a:srgbClr val="5F534C"/>
                 </a:solidFill>
@@ -9156,8 +9538,16 @@
                 <a:ea typeface="Noto Sans KR"/>
                 <a:cs typeface="Noto Sans KR"/>
               </a:rPr>
-              <a:t>초안까지 연결하는 일은 직접 구성</a:t>
-            </a:r>
+              <a:t>장기 기록으로 보관하고 다시 불러옴</a:t>
+            </a:r>
+            <a:endParaRPr sz="1800" b="0">
+              <a:solidFill>
+                <a:srgbClr val="5F534C"/>
+              </a:solidFill>
+              <a:latin typeface="Noto Sans KR"/>
+              <a:ea typeface="Noto Sans KR"/>
+              <a:cs typeface="Noto Sans KR"/>
+            </a:endParaRPr>
           </a:p>
         </p:txBody>
       </p:sp>
@@ -9235,7 +9625,7 @@
               </a:defRPr>
             </a:pPr>
             <a:r>
-              <a:rPr sz="2175" b="1">
+              <a:rPr lang="en-US" sz="2175" b="1">
                 <a:solidFill>
                   <a:srgbClr val="E8D9CB"/>
                 </a:solidFill>
@@ -9245,6 +9635,25 @@
               </a:rPr>
               <a:t>MEMOIVE</a:t>
             </a:r>
+            <a:r>
+              <a:rPr lang="ko-KR" altLang="en-US" sz="2175" b="1">
+                <a:solidFill>
+                  <a:srgbClr val="E8D9CB"/>
+                </a:solidFill>
+                <a:latin typeface="Noto Sans KR"/>
+                <a:ea typeface="Noto Sans KR"/>
+                <a:cs typeface="Noto Sans KR"/>
+              </a:rPr>
+              <a:t>의 강점</a:t>
+            </a:r>
+            <a:endParaRPr sz="2175" b="1">
+              <a:solidFill>
+                <a:srgbClr val="E8D9CB"/>
+              </a:solidFill>
+              <a:latin typeface="Noto Sans KR"/>
+              <a:ea typeface="Noto Sans KR"/>
+              <a:cs typeface="Noto Sans KR"/>
+            </a:endParaRPr>
           </a:p>
         </p:txBody>
       </p:sp>
@@ -9292,7 +9701,7 @@
               </a:defRPr>
             </a:pPr>
             <a:r>
-              <a:rPr sz="1950" b="1">
+              <a:rPr lang="ko-KR" altLang="en-US" sz="1950" b="1">
                 <a:solidFill>
                   <a:srgbClr val="F7F2EA"/>
                 </a:solidFill>
@@ -9300,8 +9709,16 @@
                 <a:ea typeface="Noto Sans KR"/>
                 <a:cs typeface="Noto Sans KR"/>
               </a:rPr>
-              <a:t>맥락을 함께 보관</a:t>
-            </a:r>
+              <a:t>반복 설명을 줄임</a:t>
+            </a:r>
+            <a:endParaRPr sz="1950" b="1">
+              <a:solidFill>
+                <a:srgbClr val="F7F2EA"/>
+              </a:solidFill>
+              <a:latin typeface="Noto Sans KR"/>
+              <a:ea typeface="Noto Sans KR"/>
+              <a:cs typeface="Noto Sans KR"/>
+            </a:endParaRPr>
           </a:p>
         </p:txBody>
       </p:sp>
@@ -9349,7 +9766,7 @@
               </a:defRPr>
             </a:pPr>
             <a:r>
-              <a:rPr sz="1800" b="0">
+              <a:rPr lang="ko-KR" altLang="en-US" sz="1800" b="0">
                 <a:solidFill>
                   <a:srgbClr val="E8D9CB"/>
                 </a:solidFill>
@@ -9357,7 +9774,7 @@
                 <a:ea typeface="Noto Sans KR"/>
                 <a:cs typeface="Noto Sans KR"/>
               </a:rPr>
-              <a:t>원문 · 저장 이유 · 내 생각</a:t>
+              <a:t>저장한 자료와 생각을</a:t>
             </a:r>
           </a:p>
           <a:p>
@@ -9372,7 +9789,7 @@
               </a:defRPr>
             </a:pPr>
             <a:r>
-              <a:rPr sz="1800" b="0">
+              <a:rPr lang="ko-KR" altLang="en-US" sz="1800" b="0">
                 <a:solidFill>
                   <a:srgbClr val="E8D9CB"/>
                 </a:solidFill>
@@ -9380,8 +9797,16 @@
                 <a:ea typeface="Noto Sans KR"/>
                 <a:cs typeface="Noto Sans KR"/>
               </a:rPr>
-              <a:t>진행 중인 글을 한 흐름에 연결</a:t>
-            </a:r>
+              <a:t>다음 작업과 창작에 바로 연결</a:t>
+            </a:r>
+            <a:endParaRPr sz="1800" b="0">
+              <a:solidFill>
+                <a:srgbClr val="E8D9CB"/>
+              </a:solidFill>
+              <a:latin typeface="Noto Sans KR"/>
+              <a:ea typeface="Noto Sans KR"/>
+              <a:cs typeface="Noto Sans KR"/>
+            </a:endParaRPr>
           </a:p>
         </p:txBody>
       </p:sp>
@@ -9429,7 +9854,7 @@
               </a:defRPr>
             </a:pPr>
             <a:r>
-              <a:rPr sz="1650" b="1">
+              <a:rPr lang="ko-KR" altLang="en-US" sz="1650" b="1">
                 <a:solidFill>
                   <a:srgbClr val="865C46"/>
                 </a:solidFill>
@@ -9437,8 +9862,16 @@
                 <a:ea typeface="Noto Sans KR"/>
                 <a:cs typeface="Noto Sans KR"/>
               </a:rPr>
-              <a:t>검증할 가설</a:t>
-            </a:r>
+              <a:t>함께 쓰는 방식</a:t>
+            </a:r>
+            <a:endParaRPr sz="1650" b="1">
+              <a:solidFill>
+                <a:srgbClr val="865C46"/>
+              </a:solidFill>
+              <a:latin typeface="Noto Sans KR"/>
+              <a:ea typeface="Noto Sans KR"/>
+              <a:cs typeface="Noto Sans KR"/>
+            </a:endParaRPr>
           </a:p>
         </p:txBody>
       </p:sp>
@@ -9486,7 +9919,7 @@
               </a:defRPr>
             </a:pPr>
             <a:r>
-              <a:rPr sz="2250" b="1">
+              <a:rPr lang="en-US" altLang="ko-KR" sz="2250" b="1">
                 <a:solidFill>
                   <a:srgbClr val="2C1D18"/>
                 </a:solidFill>
@@ -9494,8 +9927,49 @@
                 <a:ea typeface="Noto Sans KR"/>
                 <a:cs typeface="Noto Sans KR"/>
               </a:rPr>
-              <a:t>이 연결이 자료를 다시 찾고 설명하는 수고를 실제로 줄이는가</a:t>
-            </a:r>
+              <a:t>MEMOIVE</a:t>
+            </a:r>
+            <a:r>
+              <a:rPr lang="ko-KR" altLang="en-US" sz="2250" b="1">
+                <a:solidFill>
+                  <a:srgbClr val="2C1D18"/>
+                </a:solidFill>
+                <a:latin typeface="Noto Sans KR"/>
+                <a:ea typeface="Noto Sans KR"/>
+                <a:cs typeface="Noto Sans KR"/>
+              </a:rPr>
+              <a:t>가 개인 맥락을 준비하고</a:t>
+            </a:r>
+            <a:r>
+              <a:rPr lang="en-US" altLang="ko-KR" sz="2250" b="1">
+                <a:solidFill>
+                  <a:srgbClr val="2C1D18"/>
+                </a:solidFill>
+                <a:latin typeface="Noto Sans KR"/>
+                <a:ea typeface="Noto Sans KR"/>
+                <a:cs typeface="Noto Sans KR"/>
+              </a:rPr>
+              <a:t>, Codex</a:t>
+            </a:r>
+            <a:r>
+              <a:rPr lang="ko-KR" altLang="en-US" sz="2250" b="1">
+                <a:solidFill>
+                  <a:srgbClr val="2C1D18"/>
+                </a:solidFill>
+                <a:latin typeface="Noto Sans KR"/>
+                <a:ea typeface="Noto Sans KR"/>
+                <a:cs typeface="Noto Sans KR"/>
+              </a:rPr>
+              <a:t>가 그 맥락으로 결과물을 만든다</a:t>
+            </a:r>
+            <a:endParaRPr sz="2250" b="1">
+              <a:solidFill>
+                <a:srgbClr val="2C1D18"/>
+              </a:solidFill>
+              <a:latin typeface="Noto Sans KR"/>
+              <a:ea typeface="Noto Sans KR"/>
+              <a:cs typeface="Noto Sans KR"/>
+            </a:endParaRPr>
           </a:p>
         </p:txBody>
       </p:sp>
@@ -9543,7 +10017,7 @@
               </a:defRPr>
             </a:pPr>
             <a:r>
-              <a:rPr sz="1500" b="0">
+              <a:rPr lang="ko-KR" altLang="en-US" sz="1500" b="0">
                 <a:solidFill>
                   <a:srgbClr val="5F534C"/>
                 </a:solidFill>
@@ -9551,8 +10025,16 @@
                 <a:ea typeface="Noto Sans KR"/>
                 <a:cs typeface="Noto Sans KR"/>
               </a:rPr>
-              <a:t>기존 도구보다 더 낫다고 확정한 것이 아니라, 다른 역할을 검증하는 단계입니다</a:t>
-            </a:r>
+              <a:t>기록 관리와 작업 실행을 나누면 같은 자료를 다시 설명하는 수고를 줄일 수 있습니다</a:t>
+            </a:r>
+            <a:endParaRPr sz="1500" b="0">
+              <a:solidFill>
+                <a:srgbClr val="5F534C"/>
+              </a:solidFill>
+              <a:latin typeface="Noto Sans KR"/>
+              <a:ea typeface="Noto Sans KR"/>
+              <a:cs typeface="Noto Sans KR"/>
+            </a:endParaRPr>
           </a:p>
         </p:txBody>
       </p:sp>

</xml_diff>

<commit_message>
docs: clarify MEMOIVE strengths in presentation (#12)
</commit_message>
<xml_diff>
--- a/docs/presentation/MEMOIVE-Presentation.pptx
+++ b/docs/presentation/MEMOIVE-Presentation.pptx
@@ -1025,29 +1025,169 @@
           <a:lstStyle/>
           <a:p>
             <a:r>
-              <a:t>시간 배분 25초</a:t>
-            </a:r>
-          </a:p>
-          <a:p>
-            <a:r>
-              <a:t>생성형 AI는 지금 받은 질문에 답하고, 일반적인 자료 보관 도구는 저장과 검색을 돕습니다. 메모이브는 원문과 저장 이유, 내 생각, 작성 중인 결과물을 연결해 다음 작업에서 같은 설명을 반복하지 않게 설계했습니다. 더 우수하다고 주장하기보다, 맥락 재사용이라는 다른 역할이 실제로 유용한지 검증하려는 단계입니다.</a:t>
-            </a:r>
-          </a:p>
-          <a:p>
+              <a:rPr lang="ko-KR" altLang="en-US"/>
+              <a:t>시간 배분 </a:t>
+            </a:r>
+            <a:r>
+              <a:rPr lang="en-US" altLang="ko-KR"/>
+              <a:t>25</a:t>
+            </a:r>
+            <a:r>
+              <a:rPr lang="ko-KR" altLang="en-US"/>
+              <a:t>초
+</a:t>
+            </a:r>
+            <a:r>
+              <a:rPr lang="en-US" altLang="ko-KR"/>
+              <a:t>Codex</a:t>
+            </a:r>
+            <a:r>
+              <a:rPr lang="ko-KR" altLang="en-US"/>
+              <a:t>는 현재 대화와 프로젝트를 바탕으로 코드</a:t>
+            </a:r>
+            <a:r>
+              <a:rPr lang="en-US" altLang="ko-KR"/>
+              <a:t>, </a:t>
+            </a:r>
+            <a:r>
+              <a:rPr lang="ko-KR" altLang="en-US"/>
+              <a:t>문서</a:t>
+            </a:r>
+            <a:r>
+              <a:rPr lang="en-US" altLang="ko-KR"/>
+              <a:t>, </a:t>
+            </a:r>
+            <a:r>
+              <a:rPr lang="ko-KR" altLang="en-US"/>
+              <a:t>파일을 만들고 수정하는 실행 도구입니다</a:t>
+            </a:r>
+            <a:r>
+              <a:rPr lang="en-US" altLang="ko-KR"/>
+              <a:t>. MEMOIVE</a:t>
+            </a:r>
+            <a:r>
+              <a:rPr lang="ko-KR" altLang="en-US"/>
+              <a:t>는 그 앞단에서 원문</a:t>
+            </a:r>
+            <a:r>
+              <a:rPr lang="en-US" altLang="ko-KR"/>
+              <a:t>, </a:t>
+            </a:r>
+            <a:r>
+              <a:rPr lang="ko-KR" altLang="en-US"/>
+              <a:t>저장 이유</a:t>
+            </a:r>
+            <a:r>
+              <a:rPr lang="en-US" altLang="ko-KR"/>
+              <a:t>, </a:t>
+            </a:r>
+            <a:r>
+              <a:rPr lang="ko-KR" altLang="en-US"/>
+              <a:t>제 생각을 장기 기록으로 남기고 다음 글이나 기획에서 다시 불러옵니다</a:t>
+            </a:r>
+            <a:r>
+              <a:rPr lang="en-US" altLang="ko-KR"/>
+              <a:t>. MEMOIVE</a:t>
+            </a:r>
+            <a:r>
+              <a:rPr lang="ko-KR" altLang="en-US"/>
+              <a:t>의 강점은 작업할 때마다 맥락을 처음부터 설명하는 수고를 줄이는 데 있습니다</a:t>
+            </a:r>
+            <a:r>
+              <a:rPr lang="en-US" altLang="ko-KR"/>
+              <a:t>. MEMOIVE</a:t>
+            </a:r>
+            <a:r>
+              <a:rPr lang="ko-KR" altLang="en-US"/>
+              <a:t>가 맥락을 준비하고 </a:t>
+            </a:r>
+            <a:r>
+              <a:rPr lang="en-US" altLang="ko-KR"/>
+              <a:t>Codex</a:t>
+            </a:r>
+            <a:r>
+              <a:rPr lang="ko-KR" altLang="en-US"/>
+              <a:t>가 결과물을 만드는 방식으로 함께 사용할 수 있습니다</a:t>
+            </a:r>
+            <a:r>
+              <a:rPr lang="en-US" altLang="ko-KR"/>
+              <a:t>.
+</a:t>
+            </a:r>
+            <a:r>
+              <a:rPr lang="ko-KR" altLang="en-US"/>
+              <a:t>진행 메모</a:t>
+            </a:r>
+            <a:r>
+              <a:rPr lang="en-US" altLang="ko-KR"/>
+              <a:t>: Codex</a:t>
+            </a:r>
+            <a:r>
+              <a:rPr lang="ko-KR" altLang="en-US"/>
+              <a:t>의 작업 실행과 </a:t>
+            </a:r>
+            <a:r>
+              <a:rPr lang="en-US" altLang="ko-KR"/>
+              <a:t>MEMOIVE</a:t>
+            </a:r>
+            <a:r>
+              <a:rPr lang="ko-KR" altLang="en-US"/>
+              <a:t>의 개인 맥락 축적을 구분한 뒤 함께 쓰는 방식을 설명합니다</a:t>
+            </a:r>
+            <a:r>
+              <a:rPr lang="en-US" altLang="ko-KR"/>
+              <a:t>.
+</a:t>
+            </a:r>
+            <a:r>
+              <a:rPr lang="ko-KR" altLang="en-US"/>
+              <a:t>근거</a:t>
+            </a:r>
+            <a:r>
+              <a:rPr lang="en-US" altLang="ko-KR"/>
+              <a:t>: OpenAI </a:t>
+            </a:r>
+            <a:r>
+              <a:rPr lang="ko-KR" altLang="en-US"/>
+              <a:t>공식 문서에서 </a:t>
+            </a:r>
+            <a:r>
+              <a:rPr lang="en-US" altLang="ko-KR"/>
+              <a:t>Codex</a:t>
+            </a:r>
+            <a:r>
+              <a:rPr lang="ko-KR" altLang="en-US"/>
+              <a:t>는 저장소 점검</a:t>
+            </a:r>
+            <a:r>
+              <a:rPr lang="en-US" altLang="ko-KR"/>
+              <a:t>, </a:t>
+            </a:r>
+            <a:r>
+              <a:rPr lang="ko-KR" altLang="en-US"/>
+              <a:t>버그 수정</a:t>
+            </a:r>
+            <a:r>
+              <a:rPr lang="en-US" altLang="ko-KR"/>
+              <a:t>, </a:t>
+            </a:r>
+            <a:r>
+              <a:rPr lang="ko-KR" altLang="en-US"/>
+              <a:t>테스트</a:t>
+            </a:r>
+            <a:r>
+              <a:rPr lang="en-US" altLang="ko-KR"/>
+              <a:t>, </a:t>
+            </a:r>
+            <a:r>
+              <a:rPr lang="ko-KR" altLang="en-US"/>
+              <a:t>파일 변경 같은 범위가 정해진 작업에 적합하다고 설명합니다</a:t>
+            </a:r>
+            <a:r>
+              <a:rPr lang="en-US" altLang="ko-KR"/>
+              <a:t>. https://developers.openai.com/cookbook/examples/codex/using_goals_in_codex</a:t>
+            </a:r>
             <a:endParaRPr/>
-          </a:p>
-          <a:p>
-            <a:r>
-              <a:t>진행 메모: 비교 우위가 아니라 역할의 차이를 설명합니다.</a:t>
-            </a:r>
-          </a:p>
-          <a:p>
-            <a:endParaRPr/>
-          </a:p>
-          <a:p>
-            <a:r>
-              <a:t>근거: MEMOIVE 운영 코드와 2026-10-07~08 확인 내용. https://memoive.vercel.app/ 및 https://github.com/jhheo51-arch/memoive</a:t>
-            </a:r>
           </a:p>
         </p:txBody>
       </p:sp>
@@ -5872,7 +6012,7 @@
               </a:defRPr>
             </a:pPr>
             <a:r>
-              <a:rPr sz="3000" b="1">
+              <a:rPr lang="ko-KR" altLang="en-US" sz="3000" b="1">
                 <a:solidFill>
                   <a:srgbClr val="2C1D18"/>
                 </a:solidFill>
@@ -5880,8 +6020,16 @@
                 <a:ea typeface="Noto Sans KR"/>
                 <a:cs typeface="Noto Sans KR"/>
               </a:rPr>
-              <a:t>제품 기획자로서 배운 점</a:t>
-            </a:r>
+              <a:t>제품 기획자로서 배운 세 가지</a:t>
+            </a:r>
+            <a:endParaRPr sz="3000" b="1">
+              <a:solidFill>
+                <a:srgbClr val="2C1D18"/>
+              </a:solidFill>
+              <a:latin typeface="Noto Sans KR"/>
+              <a:ea typeface="Noto Sans KR"/>
+              <a:cs typeface="Noto Sans KR"/>
+            </a:endParaRPr>
           </a:p>
         </p:txBody>
       </p:sp>
@@ -6073,7 +6221,7 @@
               </a:defRPr>
             </a:pPr>
             <a:r>
-              <a:rPr sz="2325" b="1">
+              <a:rPr lang="en-US" altLang="ko-KR" sz="2325" b="1">
                 <a:solidFill>
                   <a:srgbClr val="2C1D18"/>
                 </a:solidFill>
@@ -6081,8 +6229,49 @@
                 <a:ea typeface="Noto Sans KR"/>
                 <a:cs typeface="Noto Sans KR"/>
               </a:rPr>
-              <a:t>AI 답변 품질만 높여도 반복 사용 이유는 생기지 않았다</a:t>
-            </a:r>
+              <a:t>AI </a:t>
+            </a:r>
+            <a:r>
+              <a:rPr lang="ko-KR" altLang="en-US" sz="2325" b="1">
+                <a:solidFill>
+                  <a:srgbClr val="2C1D18"/>
+                </a:solidFill>
+                <a:latin typeface="Noto Sans KR"/>
+                <a:ea typeface="Noto Sans KR"/>
+                <a:cs typeface="Noto Sans KR"/>
+              </a:rPr>
+              <a:t>요약은 출발점이었다</a:t>
+            </a:r>
+            <a:r>
+              <a:rPr lang="en-US" altLang="ko-KR" sz="2325" b="1">
+                <a:solidFill>
+                  <a:srgbClr val="2C1D18"/>
+                </a:solidFill>
+                <a:latin typeface="Noto Sans KR"/>
+                <a:ea typeface="Noto Sans KR"/>
+                <a:cs typeface="Noto Sans KR"/>
+              </a:rPr>
+              <a:t>. </a:t>
+            </a:r>
+            <a:r>
+              <a:rPr lang="ko-KR" altLang="en-US" sz="2325" b="1">
+                <a:solidFill>
+                  <a:srgbClr val="2C1D18"/>
+                </a:solidFill>
+                <a:latin typeface="Noto Sans KR"/>
+                <a:ea typeface="Noto Sans KR"/>
+                <a:cs typeface="Noto Sans KR"/>
+              </a:rPr>
+              <a:t>기록이 생각과 창작으로 이어져야 다시 쓰게 된다</a:t>
+            </a:r>
+            <a:endParaRPr sz="2325" b="1">
+              <a:solidFill>
+                <a:srgbClr val="2C1D18"/>
+              </a:solidFill>
+              <a:latin typeface="Noto Sans KR"/>
+              <a:ea typeface="Noto Sans KR"/>
+              <a:cs typeface="Noto Sans KR"/>
+            </a:endParaRPr>
           </a:p>
         </p:txBody>
       </p:sp>
@@ -6217,7 +6406,7 @@
               </a:defRPr>
             </a:pPr>
             <a:r>
-              <a:rPr sz="2325" b="1">
+              <a:rPr lang="ko-KR" altLang="en-US" sz="2325" b="1">
                 <a:solidFill>
                   <a:srgbClr val="2C1D18"/>
                 </a:solidFill>
@@ -6225,8 +6414,16 @@
                 <a:ea typeface="Noto Sans KR"/>
                 <a:cs typeface="Noto Sans KR"/>
               </a:rPr>
-              <a:t>새 기능보다 저장 실패와 충돌, 복구 같은 신뢰 문제를 먼저 다뤘다</a:t>
-            </a:r>
+              <a:t>기록의 신뢰를 위해 기능 추가보다 저장 오류와 데이터 충돌을 먼저 해결했다</a:t>
+            </a:r>
+            <a:endParaRPr sz="2325" b="1">
+              <a:solidFill>
+                <a:srgbClr val="2C1D18"/>
+              </a:solidFill>
+              <a:latin typeface="Noto Sans KR"/>
+              <a:ea typeface="Noto Sans KR"/>
+              <a:cs typeface="Noto Sans KR"/>
+            </a:endParaRPr>
           </a:p>
         </p:txBody>
       </p:sp>
@@ -6361,7 +6558,7 @@
               </a:defRPr>
             </a:pPr>
             <a:r>
-              <a:rPr sz="2325" b="1">
+              <a:rPr lang="ko-KR" altLang="en-US" sz="2325" b="1">
                 <a:solidFill>
                   <a:srgbClr val="2C1D18"/>
                 </a:solidFill>
@@ -6369,8 +6566,16 @@
                 <a:ea typeface="Noto Sans KR"/>
                 <a:cs typeface="Noto Sans KR"/>
               </a:rPr>
-              <a:t>데이터가 있다는 사실과 사용자 문제가 해결됐다는 주장을 구분했다</a:t>
-            </a:r>
+              <a:t>저장 성공 뒤에도 사용자가 다시 찾고 활용하는지 확인해야 한다</a:t>
+            </a:r>
+            <a:endParaRPr sz="2325" b="1">
+              <a:solidFill>
+                <a:srgbClr val="2C1D18"/>
+              </a:solidFill>
+              <a:latin typeface="Noto Sans KR"/>
+              <a:ea typeface="Noto Sans KR"/>
+              <a:cs typeface="Noto Sans KR"/>
+            </a:endParaRPr>
           </a:p>
         </p:txBody>
       </p:sp>
@@ -6448,7 +6653,7 @@
               </a:defRPr>
             </a:pPr>
             <a:r>
-              <a:rPr sz="2175" b="1">
+              <a:rPr lang="ko-KR" altLang="en-US" sz="2175" b="1">
                 <a:solidFill>
                   <a:srgbClr val="F7F2EA"/>
                 </a:solidFill>
@@ -6456,8 +6661,16 @@
                 <a:ea typeface="Noto Sans KR"/>
                 <a:cs typeface="Noto Sans KR"/>
               </a:rPr>
-              <a:t>제품 기획에서 기능, 데이터, 사용자 행동을 함께 봐야 했습니다</a:t>
-            </a:r>
+              <a:t>저장한 기록을 다시 활용했는가를 제품의 최종 기준으로 삼았습니다</a:t>
+            </a:r>
+            <a:endParaRPr sz="2175" b="1">
+              <a:solidFill>
+                <a:srgbClr val="F7F2EA"/>
+              </a:solidFill>
+              <a:latin typeface="Noto Sans KR"/>
+              <a:ea typeface="Noto Sans KR"/>
+              <a:cs typeface="Noto Sans KR"/>
+            </a:endParaRPr>
           </a:p>
         </p:txBody>
       </p:sp>
@@ -8643,7 +8856,7 @@
               </a:defRPr>
             </a:pPr>
             <a:r>
-              <a:rPr sz="3000" b="1">
+              <a:rPr lang="en-US" altLang="ko-KR" sz="3000" b="1">
                 <a:solidFill>
                   <a:srgbClr val="2C1D18"/>
                 </a:solidFill>
@@ -8651,8 +8864,49 @@
                 <a:ea typeface="Noto Sans KR"/>
                 <a:cs typeface="Noto Sans KR"/>
               </a:rPr>
-              <a:t>기존 도구 사이에서 MEMOIVE가 맡는 역할</a:t>
-            </a:r>
+              <a:t>Codex</a:t>
+            </a:r>
+            <a:r>
+              <a:rPr lang="ko-KR" altLang="en-US" sz="3000" b="1">
+                <a:solidFill>
+                  <a:srgbClr val="2C1D18"/>
+                </a:solidFill>
+                <a:latin typeface="Noto Sans KR"/>
+                <a:ea typeface="Noto Sans KR"/>
+                <a:cs typeface="Noto Sans KR"/>
+              </a:rPr>
+              <a:t>와 </a:t>
+            </a:r>
+            <a:r>
+              <a:rPr lang="en-US" altLang="ko-KR" sz="3000" b="1">
+                <a:solidFill>
+                  <a:srgbClr val="2C1D18"/>
+                </a:solidFill>
+                <a:latin typeface="Noto Sans KR"/>
+                <a:ea typeface="Noto Sans KR"/>
+                <a:cs typeface="Noto Sans KR"/>
+              </a:rPr>
+              <a:t>MEMOIVE</a:t>
+            </a:r>
+            <a:r>
+              <a:rPr lang="ko-KR" altLang="en-US" sz="3000" b="1">
+                <a:solidFill>
+                  <a:srgbClr val="2C1D18"/>
+                </a:solidFill>
+                <a:latin typeface="Noto Sans KR"/>
+                <a:ea typeface="Noto Sans KR"/>
+                <a:cs typeface="Noto Sans KR"/>
+              </a:rPr>
+              <a:t>의 역할 차이</a:t>
+            </a:r>
+            <a:endParaRPr sz="3000" b="1">
+              <a:solidFill>
+                <a:srgbClr val="2C1D18"/>
+              </a:solidFill>
+              <a:latin typeface="Noto Sans KR"/>
+              <a:ea typeface="Noto Sans KR"/>
+              <a:cs typeface="Noto Sans KR"/>
+            </a:endParaRPr>
           </a:p>
         </p:txBody>
       </p:sp>
@@ -8787,7 +9041,7 @@
               </a:defRPr>
             </a:pPr>
             <a:r>
-              <a:rPr sz="2175" b="1">
+              <a:rPr lang="en-US" sz="2175" b="1">
                 <a:solidFill>
                   <a:srgbClr val="5F534C"/>
                 </a:solidFill>
@@ -8795,8 +9049,16 @@
                 <a:ea typeface="Noto Sans KR"/>
                 <a:cs typeface="Noto Sans KR"/>
               </a:rPr>
-              <a:t>생성형 AI</a:t>
-            </a:r>
+              <a:t>CODEX</a:t>
+            </a:r>
+            <a:endParaRPr sz="2175" b="1">
+              <a:solidFill>
+                <a:srgbClr val="5F534C"/>
+              </a:solidFill>
+              <a:latin typeface="Noto Sans KR"/>
+              <a:ea typeface="Noto Sans KR"/>
+              <a:cs typeface="Noto Sans KR"/>
+            </a:endParaRPr>
           </a:p>
         </p:txBody>
       </p:sp>
@@ -8844,7 +9106,7 @@
               </a:defRPr>
             </a:pPr>
             <a:r>
-              <a:rPr sz="1950" b="1">
+              <a:rPr lang="ko-KR" altLang="en-US" sz="1950" b="1">
                 <a:solidFill>
                   <a:srgbClr val="2C1D18"/>
                 </a:solidFill>
@@ -8852,8 +9114,16 @@
                 <a:ea typeface="Noto Sans KR"/>
                 <a:cs typeface="Noto Sans KR"/>
               </a:rPr>
-              <a:t>답변 생성</a:t>
-            </a:r>
+              <a:t>작업 실행</a:t>
+            </a:r>
+            <a:endParaRPr sz="1950" b="1">
+              <a:solidFill>
+                <a:srgbClr val="2C1D18"/>
+              </a:solidFill>
+              <a:latin typeface="Noto Sans KR"/>
+              <a:ea typeface="Noto Sans KR"/>
+              <a:cs typeface="Noto Sans KR"/>
+            </a:endParaRPr>
           </a:p>
         </p:txBody>
       </p:sp>
@@ -8901,7 +9171,7 @@
               </a:defRPr>
             </a:pPr>
             <a:r>
-              <a:rPr sz="1800" b="0">
+              <a:rPr lang="ko-KR" altLang="en-US" sz="1800" b="0">
                 <a:solidFill>
                   <a:srgbClr val="5F534C"/>
                 </a:solidFill>
@@ -8909,7 +9179,7 @@
                 <a:ea typeface="Noto Sans KR"/>
                 <a:cs typeface="Noto Sans KR"/>
               </a:rPr>
-              <a:t>다음 작업에서는 자료와</a:t>
+              <a:t>현재 대화와 프로젝트에서</a:t>
             </a:r>
           </a:p>
           <a:p>
@@ -8924,7 +9194,7 @@
               </a:defRPr>
             </a:pPr>
             <a:r>
-              <a:rPr sz="1800" b="0">
+              <a:rPr lang="ko-KR" altLang="en-US" sz="1800" b="0">
                 <a:solidFill>
                   <a:srgbClr val="5F534C"/>
                 </a:solidFill>
@@ -8932,8 +9202,60 @@
                 <a:ea typeface="Noto Sans KR"/>
                 <a:cs typeface="Noto Sans KR"/>
               </a:rPr>
-              <a:t>맥락을 다시 넣어야 함</a:t>
-            </a:r>
+              <a:t>코드 </a:t>
+            </a:r>
+            <a:r>
+              <a:rPr lang="en-US" altLang="ko-KR" sz="1800" b="0">
+                <a:solidFill>
+                  <a:srgbClr val="5F534C"/>
+                </a:solidFill>
+                <a:latin typeface="Noto Sans KR"/>
+                <a:ea typeface="Noto Sans KR"/>
+                <a:cs typeface="Noto Sans KR"/>
+              </a:rPr>
+              <a:t>· </a:t>
+            </a:r>
+            <a:r>
+              <a:rPr lang="ko-KR" altLang="en-US" sz="1800" b="0">
+                <a:solidFill>
+                  <a:srgbClr val="5F534C"/>
+                </a:solidFill>
+                <a:latin typeface="Noto Sans KR"/>
+                <a:ea typeface="Noto Sans KR"/>
+                <a:cs typeface="Noto Sans KR"/>
+              </a:rPr>
+              <a:t>문서 </a:t>
+            </a:r>
+            <a:r>
+              <a:rPr lang="en-US" altLang="ko-KR" sz="1800" b="0">
+                <a:solidFill>
+                  <a:srgbClr val="5F534C"/>
+                </a:solidFill>
+                <a:latin typeface="Noto Sans KR"/>
+                <a:ea typeface="Noto Sans KR"/>
+                <a:cs typeface="Noto Sans KR"/>
+              </a:rPr>
+              <a:t>· </a:t>
+            </a:r>
+            <a:r>
+              <a:rPr lang="ko-KR" altLang="en-US" sz="1800" b="0">
+                <a:solidFill>
+                  <a:srgbClr val="5F534C"/>
+                </a:solidFill>
+                <a:latin typeface="Noto Sans KR"/>
+                <a:ea typeface="Noto Sans KR"/>
+                <a:cs typeface="Noto Sans KR"/>
+              </a:rPr>
+              <a:t>파일을 만들고 수정</a:t>
+            </a:r>
+            <a:endParaRPr sz="1800" b="0">
+              <a:solidFill>
+                <a:srgbClr val="5F534C"/>
+              </a:solidFill>
+              <a:latin typeface="Noto Sans KR"/>
+              <a:ea typeface="Noto Sans KR"/>
+              <a:cs typeface="Noto Sans KR"/>
+            </a:endParaRPr>
           </a:p>
         </p:txBody>
       </p:sp>
@@ -9011,7 +9333,7 @@
               </a:defRPr>
             </a:pPr>
             <a:r>
-              <a:rPr sz="2175" b="1">
+              <a:rPr lang="en-US" sz="2175" b="1">
                 <a:solidFill>
                   <a:srgbClr val="5F534C"/>
                 </a:solidFill>
@@ -9019,8 +9341,16 @@
                 <a:ea typeface="Noto Sans KR"/>
                 <a:cs typeface="Noto Sans KR"/>
               </a:rPr>
-              <a:t>자료 보관 도구</a:t>
-            </a:r>
+              <a:t>MEMOIVE</a:t>
+            </a:r>
+            <a:endParaRPr sz="2175" b="1">
+              <a:solidFill>
+                <a:srgbClr val="5F534C"/>
+              </a:solidFill>
+              <a:latin typeface="Noto Sans KR"/>
+              <a:ea typeface="Noto Sans KR"/>
+              <a:cs typeface="Noto Sans KR"/>
+            </a:endParaRPr>
           </a:p>
         </p:txBody>
       </p:sp>
@@ -9068,7 +9398,7 @@
               </a:defRPr>
             </a:pPr>
             <a:r>
-              <a:rPr sz="1950" b="1">
+              <a:rPr lang="ko-KR" altLang="en-US" sz="1950" b="1">
                 <a:solidFill>
                   <a:srgbClr val="2C1D18"/>
                 </a:solidFill>
@@ -9076,8 +9406,16 @@
                 <a:ea typeface="Noto Sans KR"/>
                 <a:cs typeface="Noto Sans KR"/>
               </a:rPr>
-              <a:t>저장과 검색</a:t>
-            </a:r>
+              <a:t>맥락 축적</a:t>
+            </a:r>
+            <a:endParaRPr sz="1950" b="1">
+              <a:solidFill>
+                <a:srgbClr val="2C1D18"/>
+              </a:solidFill>
+              <a:latin typeface="Noto Sans KR"/>
+              <a:ea typeface="Noto Sans KR"/>
+              <a:cs typeface="Noto Sans KR"/>
+            </a:endParaRPr>
           </a:p>
         </p:txBody>
       </p:sp>
@@ -9125,7 +9463,7 @@
               </a:defRPr>
             </a:pPr>
             <a:r>
-              <a:rPr sz="1800" b="0">
+              <a:rPr lang="ko-KR" altLang="en-US" sz="1800" b="0">
                 <a:solidFill>
                   <a:srgbClr val="5F534C"/>
                 </a:solidFill>
@@ -9133,7 +9471,51 @@
                 <a:ea typeface="Noto Sans KR"/>
                 <a:cs typeface="Noto Sans KR"/>
               </a:rPr>
-              <a:t>저장 이유와 내 생각을</a:t>
+              <a:t>원문 </a:t>
+            </a:r>
+            <a:r>
+              <a:rPr lang="en-US" altLang="ko-KR" sz="1800" b="0">
+                <a:solidFill>
+                  <a:srgbClr val="5F534C"/>
+                </a:solidFill>
+                <a:latin typeface="Noto Sans KR"/>
+                <a:ea typeface="Noto Sans KR"/>
+                <a:cs typeface="Noto Sans KR"/>
+              </a:rPr>
+              <a:t>· </a:t>
+            </a:r>
+            <a:r>
+              <a:rPr lang="ko-KR" altLang="en-US" sz="1800" b="0">
+                <a:solidFill>
+                  <a:srgbClr val="5F534C"/>
+                </a:solidFill>
+                <a:latin typeface="Noto Sans KR"/>
+                <a:ea typeface="Noto Sans KR"/>
+                <a:cs typeface="Noto Sans KR"/>
+              </a:rPr>
+              <a:t>저장 이유 </a:t>
+            </a:r>
+            <a:r>
+              <a:rPr lang="en-US" altLang="ko-KR" sz="1800" b="0">
+                <a:solidFill>
+                  <a:srgbClr val="5F534C"/>
+                </a:solidFill>
+                <a:latin typeface="Noto Sans KR"/>
+                <a:ea typeface="Noto Sans KR"/>
+                <a:cs typeface="Noto Sans KR"/>
+              </a:rPr>
+              <a:t>· </a:t>
+            </a:r>
+            <a:r>
+              <a:rPr lang="ko-KR" altLang="en-US" sz="1800" b="0">
+                <a:solidFill>
+                  <a:srgbClr val="5F534C"/>
+                </a:solidFill>
+                <a:latin typeface="Noto Sans KR"/>
+                <a:ea typeface="Noto Sans KR"/>
+                <a:cs typeface="Noto Sans KR"/>
+              </a:rPr>
+              <a:t>내 생각을</a:t>
             </a:r>
           </a:p>
           <a:p>
@@ -9148,7 +9530,7 @@
               </a:defRPr>
             </a:pPr>
             <a:r>
-              <a:rPr sz="1800" b="0">
+              <a:rPr lang="ko-KR" altLang="en-US" sz="1800" b="0">
                 <a:solidFill>
                   <a:srgbClr val="5F534C"/>
                 </a:solidFill>
@@ -9156,8 +9538,16 @@
                 <a:ea typeface="Noto Sans KR"/>
                 <a:cs typeface="Noto Sans KR"/>
               </a:rPr>
-              <a:t>초안까지 연결하는 일은 직접 구성</a:t>
-            </a:r>
+              <a:t>장기 기록으로 보관하고 다시 불러옴</a:t>
+            </a:r>
+            <a:endParaRPr sz="1800" b="0">
+              <a:solidFill>
+                <a:srgbClr val="5F534C"/>
+              </a:solidFill>
+              <a:latin typeface="Noto Sans KR"/>
+              <a:ea typeface="Noto Sans KR"/>
+              <a:cs typeface="Noto Sans KR"/>
+            </a:endParaRPr>
           </a:p>
         </p:txBody>
       </p:sp>
@@ -9235,7 +9625,7 @@
               </a:defRPr>
             </a:pPr>
             <a:r>
-              <a:rPr sz="2175" b="1">
+              <a:rPr lang="en-US" sz="2175" b="1">
                 <a:solidFill>
                   <a:srgbClr val="E8D9CB"/>
                 </a:solidFill>
@@ -9245,6 +9635,25 @@
               </a:rPr>
               <a:t>MEMOIVE</a:t>
             </a:r>
+            <a:r>
+              <a:rPr lang="ko-KR" altLang="en-US" sz="2175" b="1">
+                <a:solidFill>
+                  <a:srgbClr val="E8D9CB"/>
+                </a:solidFill>
+                <a:latin typeface="Noto Sans KR"/>
+                <a:ea typeface="Noto Sans KR"/>
+                <a:cs typeface="Noto Sans KR"/>
+              </a:rPr>
+              <a:t>의 강점</a:t>
+            </a:r>
+            <a:endParaRPr sz="2175" b="1">
+              <a:solidFill>
+                <a:srgbClr val="E8D9CB"/>
+              </a:solidFill>
+              <a:latin typeface="Noto Sans KR"/>
+              <a:ea typeface="Noto Sans KR"/>
+              <a:cs typeface="Noto Sans KR"/>
+            </a:endParaRPr>
           </a:p>
         </p:txBody>
       </p:sp>
@@ -9292,7 +9701,7 @@
               </a:defRPr>
             </a:pPr>
             <a:r>
-              <a:rPr sz="1950" b="1">
+              <a:rPr lang="ko-KR" altLang="en-US" sz="1950" b="1">
                 <a:solidFill>
                   <a:srgbClr val="F7F2EA"/>
                 </a:solidFill>
@@ -9300,8 +9709,16 @@
                 <a:ea typeface="Noto Sans KR"/>
                 <a:cs typeface="Noto Sans KR"/>
               </a:rPr>
-              <a:t>맥락을 함께 보관</a:t>
-            </a:r>
+              <a:t>반복 설명을 줄임</a:t>
+            </a:r>
+            <a:endParaRPr sz="1950" b="1">
+              <a:solidFill>
+                <a:srgbClr val="F7F2EA"/>
+              </a:solidFill>
+              <a:latin typeface="Noto Sans KR"/>
+              <a:ea typeface="Noto Sans KR"/>
+              <a:cs typeface="Noto Sans KR"/>
+            </a:endParaRPr>
           </a:p>
         </p:txBody>
       </p:sp>
@@ -9349,7 +9766,7 @@
               </a:defRPr>
             </a:pPr>
             <a:r>
-              <a:rPr sz="1800" b="0">
+              <a:rPr lang="ko-KR" altLang="en-US" sz="1800" b="0">
                 <a:solidFill>
                   <a:srgbClr val="E8D9CB"/>
                 </a:solidFill>
@@ -9357,7 +9774,7 @@
                 <a:ea typeface="Noto Sans KR"/>
                 <a:cs typeface="Noto Sans KR"/>
               </a:rPr>
-              <a:t>원문 · 저장 이유 · 내 생각</a:t>
+              <a:t>저장한 자료와 생각을</a:t>
             </a:r>
           </a:p>
           <a:p>
@@ -9372,7 +9789,7 @@
               </a:defRPr>
             </a:pPr>
             <a:r>
-              <a:rPr sz="1800" b="0">
+              <a:rPr lang="ko-KR" altLang="en-US" sz="1800" b="0">
                 <a:solidFill>
                   <a:srgbClr val="E8D9CB"/>
                 </a:solidFill>
@@ -9380,8 +9797,16 @@
                 <a:ea typeface="Noto Sans KR"/>
                 <a:cs typeface="Noto Sans KR"/>
               </a:rPr>
-              <a:t>진행 중인 글을 한 흐름에 연결</a:t>
-            </a:r>
+              <a:t>다음 작업과 창작에 바로 연결</a:t>
+            </a:r>
+            <a:endParaRPr sz="1800" b="0">
+              <a:solidFill>
+                <a:srgbClr val="E8D9CB"/>
+              </a:solidFill>
+              <a:latin typeface="Noto Sans KR"/>
+              <a:ea typeface="Noto Sans KR"/>
+              <a:cs typeface="Noto Sans KR"/>
+            </a:endParaRPr>
           </a:p>
         </p:txBody>
       </p:sp>
@@ -9429,7 +9854,7 @@
               </a:defRPr>
             </a:pPr>
             <a:r>
-              <a:rPr sz="1650" b="1">
+              <a:rPr lang="ko-KR" altLang="en-US" sz="1650" b="1">
                 <a:solidFill>
                   <a:srgbClr val="865C46"/>
                 </a:solidFill>
@@ -9437,8 +9862,16 @@
                 <a:ea typeface="Noto Sans KR"/>
                 <a:cs typeface="Noto Sans KR"/>
               </a:rPr>
-              <a:t>검증할 가설</a:t>
-            </a:r>
+              <a:t>함께 쓰는 방식</a:t>
+            </a:r>
+            <a:endParaRPr sz="1650" b="1">
+              <a:solidFill>
+                <a:srgbClr val="865C46"/>
+              </a:solidFill>
+              <a:latin typeface="Noto Sans KR"/>
+              <a:ea typeface="Noto Sans KR"/>
+              <a:cs typeface="Noto Sans KR"/>
+            </a:endParaRPr>
           </a:p>
         </p:txBody>
       </p:sp>
@@ -9486,7 +9919,7 @@
               </a:defRPr>
             </a:pPr>
             <a:r>
-              <a:rPr sz="2250" b="1">
+              <a:rPr lang="en-US" altLang="ko-KR" sz="2250" b="1">
                 <a:solidFill>
                   <a:srgbClr val="2C1D18"/>
                 </a:solidFill>
@@ -9494,8 +9927,49 @@
                 <a:ea typeface="Noto Sans KR"/>
                 <a:cs typeface="Noto Sans KR"/>
               </a:rPr>
-              <a:t>이 연결이 자료를 다시 찾고 설명하는 수고를 실제로 줄이는가</a:t>
-            </a:r>
+              <a:t>MEMOIVE</a:t>
+            </a:r>
+            <a:r>
+              <a:rPr lang="ko-KR" altLang="en-US" sz="2250" b="1">
+                <a:solidFill>
+                  <a:srgbClr val="2C1D18"/>
+                </a:solidFill>
+                <a:latin typeface="Noto Sans KR"/>
+                <a:ea typeface="Noto Sans KR"/>
+                <a:cs typeface="Noto Sans KR"/>
+              </a:rPr>
+              <a:t>가 개인 맥락을 준비하고</a:t>
+            </a:r>
+            <a:r>
+              <a:rPr lang="en-US" altLang="ko-KR" sz="2250" b="1">
+                <a:solidFill>
+                  <a:srgbClr val="2C1D18"/>
+                </a:solidFill>
+                <a:latin typeface="Noto Sans KR"/>
+                <a:ea typeface="Noto Sans KR"/>
+                <a:cs typeface="Noto Sans KR"/>
+              </a:rPr>
+              <a:t>, Codex</a:t>
+            </a:r>
+            <a:r>
+              <a:rPr lang="ko-KR" altLang="en-US" sz="2250" b="1">
+                <a:solidFill>
+                  <a:srgbClr val="2C1D18"/>
+                </a:solidFill>
+                <a:latin typeface="Noto Sans KR"/>
+                <a:ea typeface="Noto Sans KR"/>
+                <a:cs typeface="Noto Sans KR"/>
+              </a:rPr>
+              <a:t>가 그 맥락으로 결과물을 만든다</a:t>
+            </a:r>
+            <a:endParaRPr sz="2250" b="1">
+              <a:solidFill>
+                <a:srgbClr val="2C1D18"/>
+              </a:solidFill>
+              <a:latin typeface="Noto Sans KR"/>
+              <a:ea typeface="Noto Sans KR"/>
+              <a:cs typeface="Noto Sans KR"/>
+            </a:endParaRPr>
           </a:p>
         </p:txBody>
       </p:sp>
@@ -9543,7 +10017,7 @@
               </a:defRPr>
             </a:pPr>
             <a:r>
-              <a:rPr sz="1500" b="0">
+              <a:rPr lang="ko-KR" altLang="en-US" sz="1500" b="0">
                 <a:solidFill>
                   <a:srgbClr val="5F534C"/>
                 </a:solidFill>
@@ -9551,8 +10025,16 @@
                 <a:ea typeface="Noto Sans KR"/>
                 <a:cs typeface="Noto Sans KR"/>
               </a:rPr>
-              <a:t>기존 도구보다 더 낫다고 확정한 것이 아니라, 다른 역할을 검증하는 단계입니다</a:t>
-            </a:r>
+              <a:t>기록 관리와 작업 실행을 나누면 같은 자료를 다시 설명하는 수고를 줄일 수 있습니다</a:t>
+            </a:r>
+            <a:endParaRPr sz="1500" b="0">
+              <a:solidFill>
+                <a:srgbClr val="5F534C"/>
+              </a:solidFill>
+              <a:latin typeface="Noto Sans KR"/>
+              <a:ea typeface="Noto Sans KR"/>
+              <a:cs typeface="Noto Sans KR"/>
+            </a:endParaRPr>
           </a:p>
         </p:txBody>
       </p:sp>

</xml_diff>